<commit_message>
Add post-maturity validation slides for the Save Max cohort
Two slides built from data/savemax_maturity.tsv, the first outcome data
in the deck rather than a pre-maturity heuristic.

Slide 10 sets the headline: 6,781 of 72,874 Save Max holders emptied the
pocket, Save Max fell THB 209m, yet total deposit balance rose THB 155m.
Move rate by rate-sensitivity segment shows the ranking is not monotonic
- the High band moves at 49.5% against 12.8% for Very High - which is a
direct argument for recalibrating the cut-offs on observed outcomes.

Slide 11 isolates the discriminator: among movers, those holding Save
More retained 108.9% of balance while those without retained 26.4%. The
2x2 of Save Max behaviour against Save More holding carries counts and
balance change, and the notes record the composition caveat.

Co-Authored-By: Claude Opus 5 <noreply@anthropic.com>
Claude-Session: https://claude.ai/code/session_01VKpfo226Go9vQJYa4eoC1d
</commit_message>
<xml_diff>
--- a/Deposit_Stickiness_Framework.pptx
+++ b/Deposit_Stickiness_Framework.pptx
@@ -14,9 +14,11 @@
     <p:sldId id="262" r:id="rId8"/>
     <p:sldId id="263" r:id="rId9"/>
     <p:sldId id="264" r:id="rId10"/>
+    <p:sldId id="265" r:id="rId11"/>
+    <p:sldId id="266" r:id="rId12"/>
   </p:sldIdLst>
   <p:notesMasterIdLst>
-    <p:notesMasterId r:id="rId11"/>
+    <p:notesMasterId r:id="rId13"/>
   </p:notesMasterIdLst>
   <p:sldSz cx="12192000" cy="6858000"/>
   <p:notesSz cx="6858000" cy="12192000"/>
@@ -534,6 +536,182 @@
             <a:fld id="{F7021451-1387-4CA6-816F-3879F97B5CBC}" type="slidenum">
               <a:rPr lang="en-US"/>
               <a:t>1</a:t>
+            </a:fld>
+            <a:endParaRPr lang="en-US"/>
+          </a:p>
+        </p:txBody>
+      </p:sp>
+    </p:spTree>
+    <p:extLst>
+      <p:ext uri="{BB962C8B-B14F-4D97-AF65-F5344CB8AC3E}">
+        <p14:creationId xmlns:p14="http://schemas.microsoft.com/office/powerpoint/2010/main" val="1024086991"/>
+      </p:ext>
+    </p:extLst>
+  </p:cSld>
+  <p:clrMapOvr>
+    <a:masterClrMapping/>
+  </p:clrMapOvr>
+</p:notes>
+</file>
+
+<file path=ppt/notesSlides/notesSlide10.xml><?xml version="1.0" encoding="utf-8"?>
+<p:notes xmlns:a="http://schemas.openxmlformats.org/drawingml/2006/main" xmlns:r="http://schemas.openxmlformats.org/officeDocument/2006/relationships" xmlns:p="http://schemas.openxmlformats.org/presentationml/2006/main">
+  <p:cSld>
+    <p:spTree>
+      <p:nvGrpSpPr>
+        <p:cNvPr id="1" name=""/>
+        <p:cNvGrpSpPr/>
+        <p:nvPr/>
+      </p:nvGrpSpPr>
+      <p:grpSpPr>
+        <a:xfrm>
+          <a:off x="0" y="0"/>
+          <a:ext cx="0" cy="0"/>
+          <a:chOff x="0" y="0"/>
+          <a:chExt cx="0" cy="0"/>
+        </a:xfrm>
+      </p:grpSpPr>
+      <p:sp>
+        <p:nvSpPr>
+          <p:cNvPr id="2" name="Slide Image Placeholder 1"/>
+          <p:cNvSpPr>
+            <a:spLocks noGrp="1" noRot="1" noChangeAspect="1"/>
+          </p:cNvSpPr>
+          <p:nvPr>
+            <p:ph type="sldImg"/>
+          </p:nvPr>
+        </p:nvSpPr>
+        <p:spPr/>
+      </p:sp>
+      <p:sp>
+        <p:nvSpPr>
+          <p:cNvPr id="3" name="Notes Placeholder 2"/>
+          <p:cNvSpPr>
+            <a:spLocks noGrp="1"/>
+          </p:cNvSpPr>
+          <p:nvPr>
+            <p:ph type="body" idx="1"/>
+          </p:nvPr>
+        </p:nvSpPr>
+        <p:spPr/>
+        <p:txBody>
+          <a:bodyPr/>
+          <a:lstStyle/>
+          <a:p>
+            <a:r>
+              <a:rPr lang="en-US" dirty="0"/>
+              <a:t>Cohort: 72,874 customers holding Save Max in the prior period. 6,781 of them (9.3%) now show zero Save Max balance. Save Max fell from THB 992,865,806 to THB 784,226,953, down 21.0%, of which THB 128,954,934 came from movers zeroing out and THB 79,683,919 from non-movers trimming. Total deposit balance nevertheless rose from THB 4,128,011,139 to THB 4,282,985,037, up 3.8%. Save Max fell from 24.1% to 18.3% of the book. Move rate is not monotonic in rate sensitivity: the High band moves at 49.5% against 12.8% for Very High, so the current cut-offs do not rank runoff risk correctly and should be recalibrated on this outcome.</a:t>
+            </a:r>
+            <a:endParaRPr lang="en-US" dirty="0"/>
+          </a:p>
+        </p:txBody>
+      </p:sp>
+      <p:sp>
+        <p:nvSpPr>
+          <p:cNvPr id="4" name="Slide Number Placeholder 3"/>
+          <p:cNvSpPr>
+            <a:spLocks noGrp="1"/>
+          </p:cNvSpPr>
+          <p:nvPr>
+            <p:ph type="sldNum" sz="quarter" idx="10"/>
+          </p:nvPr>
+        </p:nvSpPr>
+        <p:spPr/>
+        <p:txBody>
+          <a:bodyPr/>
+          <a:lstStyle/>
+          <a:p>
+            <a:fld id="{F7021451-1387-4CA6-816F-3879F97B5CBC}" type="slidenum">
+              <a:rPr lang="en-US"/>
+              <a:t>10</a:t>
+            </a:fld>
+            <a:endParaRPr lang="en-US"/>
+          </a:p>
+        </p:txBody>
+      </p:sp>
+    </p:spTree>
+    <p:extLst>
+      <p:ext uri="{BB962C8B-B14F-4D97-AF65-F5344CB8AC3E}">
+        <p14:creationId xmlns:p14="http://schemas.microsoft.com/office/powerpoint/2010/main" val="1024086991"/>
+      </p:ext>
+    </p:extLst>
+  </p:cSld>
+  <p:clrMapOvr>
+    <a:masterClrMapping/>
+  </p:clrMapOvr>
+</p:notes>
+</file>
+
+<file path=ppt/notesSlides/notesSlide11.xml><?xml version="1.0" encoding="utf-8"?>
+<p:notes xmlns:a="http://schemas.openxmlformats.org/drawingml/2006/main" xmlns:r="http://schemas.openxmlformats.org/officeDocument/2006/relationships" xmlns:p="http://schemas.openxmlformats.org/presentationml/2006/main">
+  <p:cSld>
+    <p:spTree>
+      <p:nvGrpSpPr>
+        <p:cNvPr id="1" name=""/>
+        <p:cNvGrpSpPr/>
+        <p:nvPr/>
+      </p:nvGrpSpPr>
+      <p:grpSpPr>
+        <a:xfrm>
+          <a:off x="0" y="0"/>
+          <a:ext cx="0" cy="0"/>
+          <a:chOff x="0" y="0"/>
+          <a:chExt cx="0" cy="0"/>
+        </a:xfrm>
+      </p:grpSpPr>
+      <p:sp>
+        <p:nvSpPr>
+          <p:cNvPr id="2" name="Slide Image Placeholder 1"/>
+          <p:cNvSpPr>
+            <a:spLocks noGrp="1" noRot="1" noChangeAspect="1"/>
+          </p:cNvSpPr>
+          <p:nvPr>
+            <p:ph type="sldImg"/>
+          </p:nvPr>
+        </p:nvSpPr>
+        <p:spPr/>
+      </p:sp>
+      <p:sp>
+        <p:nvSpPr>
+          <p:cNvPr id="3" name="Notes Placeholder 2"/>
+          <p:cNvSpPr>
+            <a:spLocks noGrp="1"/>
+          </p:cNvSpPr>
+          <p:nvPr>
+            <p:ph type="body" idx="1"/>
+          </p:nvPr>
+        </p:nvSpPr>
+        <p:spPr/>
+        <p:txBody>
+          <a:bodyPr/>
+          <a:lstStyle/>
+          <a:p>
+            <a:r>
+              <a:rPr lang="en-US" dirty="0"/>
+              <a:t>Movers split sharply on the Save More flag. With Save More: 3,955 customers, THB 978,749,019 → THB 1,065,459,593, 108.9% retained. Without: 2,826 customers, THB 55,956,197 → THB 14,769,378, only 26.4% retained. Non-movers are stable either way: 105.8% with Save More and 98.2% without. Caveat on causality: Save More holders are also much larger balances, so part of the gap is cohort composition rather than the product itself. The actionable read is still that a second promotional pocket gives maturing Save Max money somewhere to go inside the bank - worth testing as a deliberate retention offer before the next maturity wave.</a:t>
+            </a:r>
+            <a:endParaRPr lang="en-US" dirty="0"/>
+          </a:p>
+        </p:txBody>
+      </p:sp>
+      <p:sp>
+        <p:nvSpPr>
+          <p:cNvPr id="4" name="Slide Number Placeholder 3"/>
+          <p:cNvSpPr>
+            <a:spLocks noGrp="1"/>
+          </p:cNvSpPr>
+          <p:nvPr>
+            <p:ph type="sldNum" sz="quarter" idx="10"/>
+          </p:nvPr>
+        </p:nvSpPr>
+        <p:spPr/>
+        <p:txBody>
+          <a:bodyPr/>
+          <a:lstStyle/>
+          <a:p>
+            <a:fld id="{F7021451-1387-4CA6-816F-3879F97B5CBC}" type="slidenum">
+              <a:rPr lang="en-US"/>
+              <a:t>11</a:t>
             </a:fld>
             <a:endParaRPr lang="en-US"/>
           </a:p>
@@ -3690,6 +3868,4773 @@
 </p:sld>
 </file>
 
+<file path=ppt/slides/slide10.xml><?xml version="1.0" encoding="utf-8"?>
+<p:sld xmlns:a="http://schemas.openxmlformats.org/drawingml/2006/main" xmlns:r="http://schemas.openxmlformats.org/officeDocument/2006/relationships" xmlns:p="http://schemas.openxmlformats.org/presentationml/2006/main">
+  <p:cSld name="Slide 10">
+    <p:bg>
+      <p:bgPr>
+        <a:solidFill>
+          <a:srgbClr val="FFFFFF"/>
+        </a:solidFill>
+      </p:bgPr>
+    </p:bg>
+    <p:spTree>
+      <p:nvGrpSpPr>
+        <p:cNvPr id="1" name=""/>
+        <p:cNvGrpSpPr/>
+        <p:nvPr/>
+      </p:nvGrpSpPr>
+      <p:grpSpPr>
+        <a:xfrm>
+          <a:off x="0" y="0"/>
+          <a:ext cx="0" cy="0"/>
+          <a:chOff x="0" y="0"/>
+          <a:chExt cx="0" cy="0"/>
+        </a:xfrm>
+      </p:grpSpPr>
+      <p:sp>
+        <p:nvSpPr>
+          <p:cNvPr id="2" name="Text 0"/>
+          <p:cNvSpPr/>
+          <p:nvPr/>
+        </p:nvSpPr>
+        <p:spPr>
+          <a:xfrm>
+            <a:off x="530352" y="283464"/>
+            <a:ext cx="11274552" cy="384048"/>
+          </a:xfrm>
+          <a:prstGeom prst="rect">
+            <a:avLst/>
+          </a:prstGeom>
+          <a:noFill/>
+          <a:ln/>
+        </p:spPr>
+        <p:txBody>
+          <a:bodyPr wrap="square" lIns="0" tIns="0" rIns="0" bIns="0" rtlCol="0" anchor="ctr"/>
+          <a:lstStyle/>
+          <a:p>
+            <a:pPr indent="0" marL="0">
+              <a:buNone/>
+            </a:pPr>
+            <a:r>
+              <a:rPr lang="en-US" sz="2200" b="1" dirty="0">
+                <a:solidFill>
+                  <a:srgbClr val="045D66"/>
+                </a:solidFill>
+                <a:latin typeface="Graphik TH" pitchFamily="34" charset="0"/>
+                <a:ea typeface="Graphik TH" pitchFamily="34" charset="-122"/>
+                <a:cs typeface="Graphik TH" pitchFamily="34" charset="-120"/>
+              </a:rPr>
+              <a:t>Maturity outcome : Save Max −THB 209m, total balance +THB 155m</a:t>
+            </a:r>
+            <a:endParaRPr lang="en-US" sz="2200" dirty="0"/>
+          </a:p>
+        </p:txBody>
+      </p:sp>
+      <p:sp>
+        <p:nvSpPr>
+          <p:cNvPr id="3" name="Text 1"/>
+          <p:cNvSpPr/>
+          <p:nvPr/>
+        </p:nvSpPr>
+        <p:spPr>
+          <a:xfrm>
+            <a:off x="530352" y="713232"/>
+            <a:ext cx="11274552" cy="237744"/>
+          </a:xfrm>
+          <a:prstGeom prst="rect">
+            <a:avLst/>
+          </a:prstGeom>
+          <a:noFill/>
+          <a:ln/>
+        </p:spPr>
+        <p:txBody>
+          <a:bodyPr wrap="square" lIns="0" tIns="0" rIns="0" bIns="0" rtlCol="0" anchor="ctr"/>
+          <a:lstStyle/>
+          <a:p>
+            <a:pPr indent="0" marL="0">
+              <a:buNone/>
+            </a:pPr>
+            <a:r>
+              <a:rPr lang="en-US" sz="1150" i="1" dirty="0">
+                <a:solidFill>
+                  <a:srgbClr val="6B6B6B"/>
+                </a:solidFill>
+                <a:latin typeface="Graphik TH" pitchFamily="34" charset="0"/>
+                <a:ea typeface="Graphik TH" pitchFamily="34" charset="-122"/>
+                <a:cs typeface="Graphik TH" pitchFamily="34" charset="-120"/>
+              </a:rPr>
+              <a:t>*Save Max holders with prior balance &gt; 0. 'Move' = Save Max now zero. prev / latest balance is the customer's total deposit balance.</a:t>
+            </a:r>
+            <a:endParaRPr lang="en-US" sz="1150" dirty="0"/>
+          </a:p>
+        </p:txBody>
+      </p:sp>
+      <p:sp>
+        <p:nvSpPr>
+          <p:cNvPr id="4" name="Text 2"/>
+          <p:cNvSpPr/>
+          <p:nvPr/>
+        </p:nvSpPr>
+        <p:spPr>
+          <a:xfrm>
+            <a:off x="548640" y="996696"/>
+            <a:ext cx="11064240" cy="237744"/>
+          </a:xfrm>
+          <a:prstGeom prst="rect">
+            <a:avLst/>
+          </a:prstGeom>
+          <a:noFill/>
+          <a:ln/>
+        </p:spPr>
+        <p:txBody>
+          <a:bodyPr wrap="square" lIns="0" tIns="0" rIns="0" bIns="0" rtlCol="0" anchor="ctr"/>
+          <a:lstStyle/>
+          <a:p>
+            <a:pPr indent="0" marL="0">
+              <a:buNone/>
+            </a:pPr>
+            <a:r>
+              <a:rPr lang="en-US" sz="1300" b="1" dirty="0">
+                <a:solidFill>
+                  <a:srgbClr val="045D66"/>
+                </a:solidFill>
+                <a:latin typeface="Graphik TH" pitchFamily="34" charset="0"/>
+                <a:ea typeface="Graphik TH" pitchFamily="34" charset="-122"/>
+                <a:cs typeface="Graphik TH" pitchFamily="34" charset="-120"/>
+              </a:rPr>
+              <a:t>Customers 72,874  ·  Moved 6,781 (9.3%)  ·  Save Max THB 993m → 784m  ·  Total THB 4.13bn → 4.28bn</a:t>
+            </a:r>
+            <a:endParaRPr lang="en-US" sz="1300" dirty="0"/>
+          </a:p>
+        </p:txBody>
+      </p:sp>
+      <p:sp>
+        <p:nvSpPr>
+          <p:cNvPr id="5" name="Text 3"/>
+          <p:cNvSpPr/>
+          <p:nvPr/>
+        </p:nvSpPr>
+        <p:spPr>
+          <a:xfrm>
+            <a:off x="548640" y="1280160"/>
+            <a:ext cx="11064240" cy="274320"/>
+          </a:xfrm>
+          <a:prstGeom prst="rect">
+            <a:avLst/>
+          </a:prstGeom>
+          <a:noFill/>
+          <a:ln/>
+        </p:spPr>
+        <p:txBody>
+          <a:bodyPr wrap="square" lIns="0" tIns="0" rIns="0" bIns="0" rtlCol="0" anchor="ctr"/>
+          <a:lstStyle/>
+          <a:p>
+            <a:pPr indent="0" marL="0">
+              <a:buNone/>
+            </a:pPr>
+            <a:r>
+              <a:rPr lang="en-US" sz="1400" dirty="0">
+                <a:solidFill>
+                  <a:srgbClr val="16233D"/>
+                </a:solidFill>
+                <a:latin typeface="Graphik TH" pitchFamily="34" charset="0"/>
+                <a:ea typeface="Graphik TH" pitchFamily="34" charset="-122"/>
+                <a:cs typeface="Graphik TH" pitchFamily="34" charset="-120"/>
+              </a:rPr>
+              <a:t>The money left the pocket, not the bank — Save Max fell 21% while total deposit balance rose 4%.</a:t>
+            </a:r>
+            <a:endParaRPr lang="en-US" sz="1400" dirty="0"/>
+          </a:p>
+        </p:txBody>
+      </p:sp>
+      <p:sp>
+        <p:nvSpPr>
+          <p:cNvPr id="6" name="Shape 4"/>
+          <p:cNvSpPr/>
+          <p:nvPr/>
+        </p:nvSpPr>
+        <p:spPr>
+          <a:xfrm>
+            <a:off x="530352" y="1645920"/>
+            <a:ext cx="2647188" cy="987552"/>
+          </a:xfrm>
+          <a:prstGeom prst="roundRect">
+            <a:avLst>
+              <a:gd name="adj" fmla="val 8333"/>
+            </a:avLst>
+          </a:prstGeom>
+          <a:solidFill>
+            <a:srgbClr val="F1F4F9"/>
+          </a:solidFill>
+          <a:ln/>
+        </p:spPr>
+      </p:sp>
+      <p:sp>
+        <p:nvSpPr>
+          <p:cNvPr id="7" name="Text 5"/>
+          <p:cNvSpPr/>
+          <p:nvPr/>
+        </p:nvSpPr>
+        <p:spPr>
+          <a:xfrm>
+            <a:off x="749808" y="1719072"/>
+            <a:ext cx="2208276" cy="402336"/>
+          </a:xfrm>
+          <a:prstGeom prst="rect">
+            <a:avLst/>
+          </a:prstGeom>
+          <a:noFill/>
+          <a:ln/>
+        </p:spPr>
+        <p:txBody>
+          <a:bodyPr wrap="square" lIns="0" tIns="0" rIns="0" bIns="0" rtlCol="0" anchor="ctr"/>
+          <a:lstStyle/>
+          <a:p>
+            <a:pPr indent="0" marL="0">
+              <a:buNone/>
+            </a:pPr>
+            <a:r>
+              <a:rPr lang="en-US" sz="2400" b="1" dirty="0">
+                <a:solidFill>
+                  <a:srgbClr val="00A896"/>
+                </a:solidFill>
+                <a:latin typeface="Graphik TH" pitchFamily="34" charset="0"/>
+                <a:ea typeface="Graphik TH" pitchFamily="34" charset="-122"/>
+                <a:cs typeface="Graphik TH" pitchFamily="34" charset="-120"/>
+              </a:rPr>
+              <a:t>72.9k</a:t>
+            </a:r>
+            <a:endParaRPr lang="en-US" sz="2400" dirty="0"/>
+          </a:p>
+        </p:txBody>
+      </p:sp>
+      <p:sp>
+        <p:nvSpPr>
+          <p:cNvPr id="8" name="Text 6"/>
+          <p:cNvSpPr/>
+          <p:nvPr/>
+        </p:nvSpPr>
+        <p:spPr>
+          <a:xfrm>
+            <a:off x="749808" y="2121408"/>
+            <a:ext cx="2208276" cy="237744"/>
+          </a:xfrm>
+          <a:prstGeom prst="rect">
+            <a:avLst/>
+          </a:prstGeom>
+          <a:noFill/>
+          <a:ln/>
+        </p:spPr>
+        <p:txBody>
+          <a:bodyPr wrap="square" lIns="0" tIns="0" rIns="0" bIns="0" rtlCol="0" anchor="t"/>
+          <a:lstStyle/>
+          <a:p>
+            <a:pPr indent="0" marL="0">
+              <a:buNone/>
+            </a:pPr>
+            <a:r>
+              <a:rPr lang="en-US" sz="1150" b="1" dirty="0">
+                <a:solidFill>
+                  <a:srgbClr val="16233D"/>
+                </a:solidFill>
+                <a:latin typeface="Graphik TH" pitchFamily="34" charset="0"/>
+                <a:ea typeface="Graphik TH" pitchFamily="34" charset="-122"/>
+                <a:cs typeface="Graphik TH" pitchFamily="34" charset="-120"/>
+              </a:rPr>
+              <a:t>customers in cohort</a:t>
+            </a:r>
+            <a:endParaRPr lang="en-US" sz="1150" dirty="0"/>
+          </a:p>
+        </p:txBody>
+      </p:sp>
+      <p:sp>
+        <p:nvSpPr>
+          <p:cNvPr id="9" name="Text 7"/>
+          <p:cNvSpPr/>
+          <p:nvPr/>
+        </p:nvSpPr>
+        <p:spPr>
+          <a:xfrm>
+            <a:off x="749808" y="2350008"/>
+            <a:ext cx="2208276" cy="237744"/>
+          </a:xfrm>
+          <a:prstGeom prst="rect">
+            <a:avLst/>
+          </a:prstGeom>
+          <a:noFill/>
+          <a:ln/>
+        </p:spPr>
+        <p:txBody>
+          <a:bodyPr wrap="square" lIns="0" tIns="0" rIns="0" bIns="0" rtlCol="0" anchor="t"/>
+          <a:lstStyle/>
+          <a:p>
+            <a:pPr indent="0" marL="0">
+              <a:buNone/>
+            </a:pPr>
+            <a:r>
+              <a:rPr lang="en-US" sz="950" dirty="0">
+                <a:solidFill>
+                  <a:srgbClr val="6B7A90"/>
+                </a:solidFill>
+                <a:latin typeface="Graphik TH" pitchFamily="34" charset="0"/>
+                <a:ea typeface="Graphik TH" pitchFamily="34" charset="-122"/>
+                <a:cs typeface="Graphik TH" pitchFamily="34" charset="-120"/>
+              </a:rPr>
+              <a:t>held Save Max last period</a:t>
+            </a:r>
+            <a:endParaRPr lang="en-US" sz="950" dirty="0"/>
+          </a:p>
+        </p:txBody>
+      </p:sp>
+      <p:sp>
+        <p:nvSpPr>
+          <p:cNvPr id="10" name="Shape 8"/>
+          <p:cNvSpPr/>
+          <p:nvPr/>
+        </p:nvSpPr>
+        <p:spPr>
+          <a:xfrm>
+            <a:off x="3406140" y="1645920"/>
+            <a:ext cx="2647188" cy="987552"/>
+          </a:xfrm>
+          <a:prstGeom prst="roundRect">
+            <a:avLst>
+              <a:gd name="adj" fmla="val 8333"/>
+            </a:avLst>
+          </a:prstGeom>
+          <a:solidFill>
+            <a:srgbClr val="F1F4F9"/>
+          </a:solidFill>
+          <a:ln/>
+        </p:spPr>
+      </p:sp>
+      <p:sp>
+        <p:nvSpPr>
+          <p:cNvPr id="11" name="Text 9"/>
+          <p:cNvSpPr/>
+          <p:nvPr/>
+        </p:nvSpPr>
+        <p:spPr>
+          <a:xfrm>
+            <a:off x="3625596" y="1719072"/>
+            <a:ext cx="2208276" cy="402336"/>
+          </a:xfrm>
+          <a:prstGeom prst="rect">
+            <a:avLst/>
+          </a:prstGeom>
+          <a:noFill/>
+          <a:ln/>
+        </p:spPr>
+        <p:txBody>
+          <a:bodyPr wrap="square" lIns="0" tIns="0" rIns="0" bIns="0" rtlCol="0" anchor="ctr"/>
+          <a:lstStyle/>
+          <a:p>
+            <a:pPr indent="0" marL="0">
+              <a:buNone/>
+            </a:pPr>
+            <a:r>
+              <a:rPr lang="en-US" sz="2400" b="1" dirty="0">
+                <a:solidFill>
+                  <a:srgbClr val="E9A03B"/>
+                </a:solidFill>
+                <a:latin typeface="Graphik TH" pitchFamily="34" charset="0"/>
+                <a:ea typeface="Graphik TH" pitchFamily="34" charset="-122"/>
+                <a:cs typeface="Graphik TH" pitchFamily="34" charset="-120"/>
+              </a:rPr>
+              <a:t>6,781</a:t>
+            </a:r>
+            <a:endParaRPr lang="en-US" sz="2400" dirty="0"/>
+          </a:p>
+        </p:txBody>
+      </p:sp>
+      <p:sp>
+        <p:nvSpPr>
+          <p:cNvPr id="12" name="Text 10"/>
+          <p:cNvSpPr/>
+          <p:nvPr/>
+        </p:nvSpPr>
+        <p:spPr>
+          <a:xfrm>
+            <a:off x="3625596" y="2121408"/>
+            <a:ext cx="2208276" cy="237744"/>
+          </a:xfrm>
+          <a:prstGeom prst="rect">
+            <a:avLst/>
+          </a:prstGeom>
+          <a:noFill/>
+          <a:ln/>
+        </p:spPr>
+        <p:txBody>
+          <a:bodyPr wrap="square" lIns="0" tIns="0" rIns="0" bIns="0" rtlCol="0" anchor="t"/>
+          <a:lstStyle/>
+          <a:p>
+            <a:pPr indent="0" marL="0">
+              <a:buNone/>
+            </a:pPr>
+            <a:r>
+              <a:rPr lang="en-US" sz="1150" b="1" dirty="0">
+                <a:solidFill>
+                  <a:srgbClr val="16233D"/>
+                </a:solidFill>
+                <a:latin typeface="Graphik TH" pitchFamily="34" charset="0"/>
+                <a:ea typeface="Graphik TH" pitchFamily="34" charset="-122"/>
+                <a:cs typeface="Graphik TH" pitchFamily="34" charset="-120"/>
+              </a:rPr>
+              <a:t>moved out of Save Max</a:t>
+            </a:r>
+            <a:endParaRPr lang="en-US" sz="1150" dirty="0"/>
+          </a:p>
+        </p:txBody>
+      </p:sp>
+      <p:sp>
+        <p:nvSpPr>
+          <p:cNvPr id="13" name="Text 11"/>
+          <p:cNvSpPr/>
+          <p:nvPr/>
+        </p:nvSpPr>
+        <p:spPr>
+          <a:xfrm>
+            <a:off x="3625596" y="2350008"/>
+            <a:ext cx="2208276" cy="237744"/>
+          </a:xfrm>
+          <a:prstGeom prst="rect">
+            <a:avLst/>
+          </a:prstGeom>
+          <a:noFill/>
+          <a:ln/>
+        </p:spPr>
+        <p:txBody>
+          <a:bodyPr wrap="square" lIns="0" tIns="0" rIns="0" bIns="0" rtlCol="0" anchor="t"/>
+          <a:lstStyle/>
+          <a:p>
+            <a:pPr indent="0" marL="0">
+              <a:buNone/>
+            </a:pPr>
+            <a:r>
+              <a:rPr lang="en-US" sz="950" dirty="0">
+                <a:solidFill>
+                  <a:srgbClr val="6B7A90"/>
+                </a:solidFill>
+                <a:latin typeface="Graphik TH" pitchFamily="34" charset="0"/>
+                <a:ea typeface="Graphik TH" pitchFamily="34" charset="-122"/>
+                <a:cs typeface="Graphik TH" pitchFamily="34" charset="-120"/>
+              </a:rPr>
+              <a:t>9.3% · Save Max now zero</a:t>
+            </a:r>
+            <a:endParaRPr lang="en-US" sz="950" dirty="0"/>
+          </a:p>
+        </p:txBody>
+      </p:sp>
+      <p:sp>
+        <p:nvSpPr>
+          <p:cNvPr id="14" name="Shape 12"/>
+          <p:cNvSpPr/>
+          <p:nvPr/>
+        </p:nvSpPr>
+        <p:spPr>
+          <a:xfrm>
+            <a:off x="6281928" y="1645920"/>
+            <a:ext cx="2647188" cy="987552"/>
+          </a:xfrm>
+          <a:prstGeom prst="roundRect">
+            <a:avLst>
+              <a:gd name="adj" fmla="val 8333"/>
+            </a:avLst>
+          </a:prstGeom>
+          <a:solidFill>
+            <a:srgbClr val="F1F4F9"/>
+          </a:solidFill>
+          <a:ln/>
+        </p:spPr>
+      </p:sp>
+      <p:sp>
+        <p:nvSpPr>
+          <p:cNvPr id="15" name="Text 13"/>
+          <p:cNvSpPr/>
+          <p:nvPr/>
+        </p:nvSpPr>
+        <p:spPr>
+          <a:xfrm>
+            <a:off x="6501384" y="1719072"/>
+            <a:ext cx="2208276" cy="402336"/>
+          </a:xfrm>
+          <a:prstGeom prst="rect">
+            <a:avLst/>
+          </a:prstGeom>
+          <a:noFill/>
+          <a:ln/>
+        </p:spPr>
+        <p:txBody>
+          <a:bodyPr wrap="square" lIns="0" tIns="0" rIns="0" bIns="0" rtlCol="0" anchor="ctr"/>
+          <a:lstStyle/>
+          <a:p>
+            <a:pPr indent="0" marL="0">
+              <a:buNone/>
+            </a:pPr>
+            <a:r>
+              <a:rPr lang="en-US" sz="2400" b="1" dirty="0">
+                <a:solidFill>
+                  <a:srgbClr val="C00000"/>
+                </a:solidFill>
+                <a:latin typeface="Graphik TH" pitchFamily="34" charset="0"/>
+                <a:ea typeface="Graphik TH" pitchFamily="34" charset="-122"/>
+                <a:cs typeface="Graphik TH" pitchFamily="34" charset="-120"/>
+              </a:rPr>
+              <a:t>−THB 209m</a:t>
+            </a:r>
+            <a:endParaRPr lang="en-US" sz="2400" dirty="0"/>
+          </a:p>
+        </p:txBody>
+      </p:sp>
+      <p:sp>
+        <p:nvSpPr>
+          <p:cNvPr id="16" name="Text 14"/>
+          <p:cNvSpPr/>
+          <p:nvPr/>
+        </p:nvSpPr>
+        <p:spPr>
+          <a:xfrm>
+            <a:off x="6501384" y="2121408"/>
+            <a:ext cx="2208276" cy="237744"/>
+          </a:xfrm>
+          <a:prstGeom prst="rect">
+            <a:avLst/>
+          </a:prstGeom>
+          <a:noFill/>
+          <a:ln/>
+        </p:spPr>
+        <p:txBody>
+          <a:bodyPr wrap="square" lIns="0" tIns="0" rIns="0" bIns="0" rtlCol="0" anchor="t"/>
+          <a:lstStyle/>
+          <a:p>
+            <a:pPr indent="0" marL="0">
+              <a:buNone/>
+            </a:pPr>
+            <a:r>
+              <a:rPr lang="en-US" sz="1150" b="1" dirty="0">
+                <a:solidFill>
+                  <a:srgbClr val="16233D"/>
+                </a:solidFill>
+                <a:latin typeface="Graphik TH" pitchFamily="34" charset="0"/>
+                <a:ea typeface="Graphik TH" pitchFamily="34" charset="-122"/>
+                <a:cs typeface="Graphik TH" pitchFamily="34" charset="-120"/>
+              </a:rPr>
+              <a:t>Save Max balance</a:t>
+            </a:r>
+            <a:endParaRPr lang="en-US" sz="1150" dirty="0"/>
+          </a:p>
+        </p:txBody>
+      </p:sp>
+      <p:sp>
+        <p:nvSpPr>
+          <p:cNvPr id="17" name="Text 15"/>
+          <p:cNvSpPr/>
+          <p:nvPr/>
+        </p:nvSpPr>
+        <p:spPr>
+          <a:xfrm>
+            <a:off x="6501384" y="2350008"/>
+            <a:ext cx="2208276" cy="237744"/>
+          </a:xfrm>
+          <a:prstGeom prst="rect">
+            <a:avLst/>
+          </a:prstGeom>
+          <a:noFill/>
+          <a:ln/>
+        </p:spPr>
+        <p:txBody>
+          <a:bodyPr wrap="square" lIns="0" tIns="0" rIns="0" bIns="0" rtlCol="0" anchor="t"/>
+          <a:lstStyle/>
+          <a:p>
+            <a:pPr indent="0" marL="0">
+              <a:buNone/>
+            </a:pPr>
+            <a:r>
+              <a:rPr lang="en-US" sz="950" dirty="0">
+                <a:solidFill>
+                  <a:srgbClr val="6B7A90"/>
+                </a:solidFill>
+                <a:latin typeface="Graphik TH" pitchFamily="34" charset="0"/>
+                <a:ea typeface="Graphik TH" pitchFamily="34" charset="-122"/>
+                <a:cs typeface="Graphik TH" pitchFamily="34" charset="-120"/>
+              </a:rPr>
+              <a:t>−21.0% period on period</a:t>
+            </a:r>
+            <a:endParaRPr lang="en-US" sz="950" dirty="0"/>
+          </a:p>
+        </p:txBody>
+      </p:sp>
+      <p:sp>
+        <p:nvSpPr>
+          <p:cNvPr id="18" name="Shape 16"/>
+          <p:cNvSpPr/>
+          <p:nvPr/>
+        </p:nvSpPr>
+        <p:spPr>
+          <a:xfrm>
+            <a:off x="9157716" y="1645920"/>
+            <a:ext cx="2647188" cy="987552"/>
+          </a:xfrm>
+          <a:prstGeom prst="roundRect">
+            <a:avLst>
+              <a:gd name="adj" fmla="val 8333"/>
+            </a:avLst>
+          </a:prstGeom>
+          <a:solidFill>
+            <a:srgbClr val="F1F4F9"/>
+          </a:solidFill>
+          <a:ln/>
+        </p:spPr>
+      </p:sp>
+      <p:sp>
+        <p:nvSpPr>
+          <p:cNvPr id="19" name="Text 17"/>
+          <p:cNvSpPr/>
+          <p:nvPr/>
+        </p:nvSpPr>
+        <p:spPr>
+          <a:xfrm>
+            <a:off x="9377172" y="1719072"/>
+            <a:ext cx="2208276" cy="402336"/>
+          </a:xfrm>
+          <a:prstGeom prst="rect">
+            <a:avLst/>
+          </a:prstGeom>
+          <a:noFill/>
+          <a:ln/>
+        </p:spPr>
+        <p:txBody>
+          <a:bodyPr wrap="square" lIns="0" tIns="0" rIns="0" bIns="0" rtlCol="0" anchor="ctr"/>
+          <a:lstStyle/>
+          <a:p>
+            <a:pPr indent="0" marL="0">
+              <a:buNone/>
+            </a:pPr>
+            <a:r>
+              <a:rPr lang="en-US" sz="2400" b="1" dirty="0">
+                <a:solidFill>
+                  <a:srgbClr val="00A896"/>
+                </a:solidFill>
+                <a:latin typeface="Graphik TH" pitchFamily="34" charset="0"/>
+                <a:ea typeface="Graphik TH" pitchFamily="34" charset="-122"/>
+                <a:cs typeface="Graphik TH" pitchFamily="34" charset="-120"/>
+              </a:rPr>
+              <a:t>+THB 155m</a:t>
+            </a:r>
+            <a:endParaRPr lang="en-US" sz="2400" dirty="0"/>
+          </a:p>
+        </p:txBody>
+      </p:sp>
+      <p:sp>
+        <p:nvSpPr>
+          <p:cNvPr id="20" name="Text 18"/>
+          <p:cNvSpPr/>
+          <p:nvPr/>
+        </p:nvSpPr>
+        <p:spPr>
+          <a:xfrm>
+            <a:off x="9377172" y="2121408"/>
+            <a:ext cx="2208276" cy="237744"/>
+          </a:xfrm>
+          <a:prstGeom prst="rect">
+            <a:avLst/>
+          </a:prstGeom>
+          <a:noFill/>
+          <a:ln/>
+        </p:spPr>
+        <p:txBody>
+          <a:bodyPr wrap="square" lIns="0" tIns="0" rIns="0" bIns="0" rtlCol="0" anchor="t"/>
+          <a:lstStyle/>
+          <a:p>
+            <a:pPr indent="0" marL="0">
+              <a:buNone/>
+            </a:pPr>
+            <a:r>
+              <a:rPr lang="en-US" sz="1150" b="1" dirty="0">
+                <a:solidFill>
+                  <a:srgbClr val="16233D"/>
+                </a:solidFill>
+                <a:latin typeface="Graphik TH" pitchFamily="34" charset="0"/>
+                <a:ea typeface="Graphik TH" pitchFamily="34" charset="-122"/>
+                <a:cs typeface="Graphik TH" pitchFamily="34" charset="-120"/>
+              </a:rPr>
+              <a:t>total deposit balance</a:t>
+            </a:r>
+            <a:endParaRPr lang="en-US" sz="1150" dirty="0"/>
+          </a:p>
+        </p:txBody>
+      </p:sp>
+      <p:sp>
+        <p:nvSpPr>
+          <p:cNvPr id="21" name="Text 19"/>
+          <p:cNvSpPr/>
+          <p:nvPr/>
+        </p:nvSpPr>
+        <p:spPr>
+          <a:xfrm>
+            <a:off x="9377172" y="2350008"/>
+            <a:ext cx="2208276" cy="237744"/>
+          </a:xfrm>
+          <a:prstGeom prst="rect">
+            <a:avLst/>
+          </a:prstGeom>
+          <a:noFill/>
+          <a:ln/>
+        </p:spPr>
+        <p:txBody>
+          <a:bodyPr wrap="square" lIns="0" tIns="0" rIns="0" bIns="0" rtlCol="0" anchor="t"/>
+          <a:lstStyle/>
+          <a:p>
+            <a:pPr indent="0" marL="0">
+              <a:buNone/>
+            </a:pPr>
+            <a:r>
+              <a:rPr lang="en-US" sz="950" dirty="0">
+                <a:solidFill>
+                  <a:srgbClr val="6B7A90"/>
+                </a:solidFill>
+                <a:latin typeface="Graphik TH" pitchFamily="34" charset="0"/>
+                <a:ea typeface="Graphik TH" pitchFamily="34" charset="-122"/>
+                <a:cs typeface="Graphik TH" pitchFamily="34" charset="-120"/>
+              </a:rPr>
+              <a:t>+3.8% period on period</a:t>
+            </a:r>
+            <a:endParaRPr lang="en-US" sz="950" dirty="0"/>
+          </a:p>
+        </p:txBody>
+      </p:sp>
+      <p:sp>
+        <p:nvSpPr>
+          <p:cNvPr id="22" name="Shape 20"/>
+          <p:cNvSpPr/>
+          <p:nvPr/>
+        </p:nvSpPr>
+        <p:spPr>
+          <a:xfrm>
+            <a:off x="530352" y="2798064"/>
+            <a:ext cx="5522976" cy="2322576"/>
+          </a:xfrm>
+          <a:prstGeom prst="roundRect">
+            <a:avLst>
+              <a:gd name="adj" fmla="val 3543"/>
+            </a:avLst>
+          </a:prstGeom>
+          <a:solidFill>
+            <a:srgbClr val="F1F4F9"/>
+          </a:solidFill>
+          <a:ln/>
+        </p:spPr>
+      </p:sp>
+      <p:sp>
+        <p:nvSpPr>
+          <p:cNvPr id="23" name="Text 21"/>
+          <p:cNvSpPr/>
+          <p:nvPr/>
+        </p:nvSpPr>
+        <p:spPr>
+          <a:xfrm>
+            <a:off x="786384" y="2944368"/>
+            <a:ext cx="5010912" cy="274320"/>
+          </a:xfrm>
+          <a:prstGeom prst="rect">
+            <a:avLst/>
+          </a:prstGeom>
+          <a:noFill/>
+          <a:ln/>
+        </p:spPr>
+        <p:txBody>
+          <a:bodyPr wrap="square" lIns="0" tIns="0" rIns="0" bIns="0" rtlCol="0" anchor="ctr"/>
+          <a:lstStyle/>
+          <a:p>
+            <a:pPr indent="0" marL="0">
+              <a:buNone/>
+            </a:pPr>
+            <a:r>
+              <a:rPr lang="en-US" sz="1400" b="1" dirty="0">
+                <a:solidFill>
+                  <a:srgbClr val="16233D"/>
+                </a:solidFill>
+                <a:latin typeface="Cambria" pitchFamily="34" charset="0"/>
+                <a:ea typeface="Cambria" pitchFamily="34" charset="-122"/>
+                <a:cs typeface="Cambria" pitchFamily="34" charset="-120"/>
+              </a:rPr>
+              <a:t>Prior period against latest</a:t>
+            </a:r>
+            <a:endParaRPr lang="en-US" sz="1400" dirty="0"/>
+          </a:p>
+        </p:txBody>
+      </p:sp>
+      <p:sp>
+        <p:nvSpPr>
+          <p:cNvPr id="24" name="Text 22"/>
+          <p:cNvSpPr/>
+          <p:nvPr/>
+        </p:nvSpPr>
+        <p:spPr>
+          <a:xfrm>
+            <a:off x="786384" y="3218688"/>
+            <a:ext cx="5010912" cy="237744"/>
+          </a:xfrm>
+          <a:prstGeom prst="rect">
+            <a:avLst/>
+          </a:prstGeom>
+          <a:noFill/>
+          <a:ln/>
+        </p:spPr>
+        <p:txBody>
+          <a:bodyPr wrap="square" lIns="0" tIns="0" rIns="0" bIns="0" rtlCol="0" anchor="ctr"/>
+          <a:lstStyle/>
+          <a:p>
+            <a:pPr indent="0" marL="0">
+              <a:buNone/>
+            </a:pPr>
+            <a:r>
+              <a:rPr lang="en-US" sz="950" dirty="0">
+                <a:solidFill>
+                  <a:srgbClr val="6B7A90"/>
+                </a:solidFill>
+                <a:latin typeface="Graphik TH" pitchFamily="34" charset="0"/>
+                <a:ea typeface="Graphik TH" pitchFamily="34" charset="-122"/>
+                <a:cs typeface="Graphik TH" pitchFamily="34" charset="-120"/>
+              </a:rPr>
+              <a:t>Both measures on one scale — Save Max is a pocket inside the total</a:t>
+            </a:r>
+            <a:endParaRPr lang="en-US" sz="950" dirty="0"/>
+          </a:p>
+        </p:txBody>
+      </p:sp>
+      <p:sp>
+        <p:nvSpPr>
+          <p:cNvPr id="25" name="Text 23"/>
+          <p:cNvSpPr/>
+          <p:nvPr/>
+        </p:nvSpPr>
+        <p:spPr>
+          <a:xfrm>
+            <a:off x="786384" y="3401568"/>
+            <a:ext cx="5010912" cy="201168"/>
+          </a:xfrm>
+          <a:prstGeom prst="rect">
+            <a:avLst/>
+          </a:prstGeom>
+          <a:noFill/>
+          <a:ln/>
+        </p:spPr>
+        <p:txBody>
+          <a:bodyPr wrap="square" lIns="0" tIns="0" rIns="0" bIns="0" rtlCol="0" anchor="ctr"/>
+          <a:lstStyle/>
+          <a:p>
+            <a:pPr indent="0" marL="0">
+              <a:buNone/>
+            </a:pPr>
+            <a:r>
+              <a:rPr lang="en-US" sz="1050" b="1" dirty="0">
+                <a:solidFill>
+                  <a:srgbClr val="045D66"/>
+                </a:solidFill>
+                <a:latin typeface="Graphik TH" pitchFamily="34" charset="0"/>
+                <a:ea typeface="Graphik TH" pitchFamily="34" charset="-122"/>
+                <a:cs typeface="Graphik TH" pitchFamily="34" charset="-120"/>
+              </a:rPr>
+              <a:t>Save Max pocket</a:t>
+            </a:r>
+            <a:endParaRPr lang="en-US" sz="1050" dirty="0"/>
+          </a:p>
+        </p:txBody>
+      </p:sp>
+      <p:sp>
+        <p:nvSpPr>
+          <p:cNvPr id="26" name="Text 24"/>
+          <p:cNvSpPr/>
+          <p:nvPr/>
+        </p:nvSpPr>
+        <p:spPr>
+          <a:xfrm>
+            <a:off x="786384" y="3621024"/>
+            <a:ext cx="1234440" cy="256032"/>
+          </a:xfrm>
+          <a:prstGeom prst="rect">
+            <a:avLst/>
+          </a:prstGeom>
+          <a:noFill/>
+          <a:ln/>
+        </p:spPr>
+        <p:txBody>
+          <a:bodyPr wrap="square" lIns="0" tIns="0" rIns="0" bIns="0" rtlCol="0" anchor="ctr"/>
+          <a:lstStyle/>
+          <a:p>
+            <a:pPr indent="0" marL="0">
+              <a:buNone/>
+            </a:pPr>
+            <a:r>
+              <a:rPr lang="en-US" sz="1000" dirty="0">
+                <a:solidFill>
+                  <a:srgbClr val="16233D"/>
+                </a:solidFill>
+                <a:latin typeface="Graphik TH" pitchFamily="34" charset="0"/>
+                <a:ea typeface="Graphik TH" pitchFamily="34" charset="-122"/>
+                <a:cs typeface="Graphik TH" pitchFamily="34" charset="-120"/>
+              </a:rPr>
+              <a:t>Prior</a:t>
+            </a:r>
+            <a:endParaRPr lang="en-US" sz="1000" dirty="0"/>
+          </a:p>
+        </p:txBody>
+      </p:sp>
+      <p:sp>
+        <p:nvSpPr>
+          <p:cNvPr id="27" name="Shape 25"/>
+          <p:cNvSpPr/>
+          <p:nvPr/>
+        </p:nvSpPr>
+        <p:spPr>
+          <a:xfrm>
+            <a:off x="2130552" y="3666744"/>
+            <a:ext cx="2331720" cy="164592"/>
+          </a:xfrm>
+          <a:prstGeom prst="roundRect">
+            <a:avLst>
+              <a:gd name="adj" fmla="val 16667"/>
+            </a:avLst>
+          </a:prstGeom>
+          <a:solidFill>
+            <a:srgbClr val="E4E9F0"/>
+          </a:solidFill>
+          <a:ln/>
+        </p:spPr>
+      </p:sp>
+      <p:sp>
+        <p:nvSpPr>
+          <p:cNvPr id="28" name="Shape 26"/>
+          <p:cNvSpPr/>
+          <p:nvPr/>
+        </p:nvSpPr>
+        <p:spPr>
+          <a:xfrm>
+            <a:off x="2130552" y="3666744"/>
+            <a:ext cx="540531" cy="164592"/>
+          </a:xfrm>
+          <a:prstGeom prst="roundRect">
+            <a:avLst>
+              <a:gd name="adj" fmla="val 16667"/>
+            </a:avLst>
+          </a:prstGeom>
+          <a:solidFill>
+            <a:srgbClr val="8DA0B8"/>
+          </a:solidFill>
+          <a:ln/>
+        </p:spPr>
+      </p:sp>
+      <p:sp>
+        <p:nvSpPr>
+          <p:cNvPr id="29" name="Text 27"/>
+          <p:cNvSpPr/>
+          <p:nvPr/>
+        </p:nvSpPr>
+        <p:spPr>
+          <a:xfrm>
+            <a:off x="4553712" y="3621024"/>
+            <a:ext cx="1243584" cy="256032"/>
+          </a:xfrm>
+          <a:prstGeom prst="rect">
+            <a:avLst/>
+          </a:prstGeom>
+          <a:noFill/>
+          <a:ln/>
+        </p:spPr>
+        <p:txBody>
+          <a:bodyPr wrap="square" lIns="0" tIns="0" rIns="0" bIns="0" rtlCol="0" anchor="ctr"/>
+          <a:lstStyle/>
+          <a:p>
+            <a:pPr algn="r" indent="0" marL="0">
+              <a:buNone/>
+            </a:pPr>
+            <a:r>
+              <a:rPr lang="en-US" sz="1000" b="1" dirty="0">
+                <a:solidFill>
+                  <a:srgbClr val="8DA0B8"/>
+                </a:solidFill>
+                <a:latin typeface="Graphik TH" pitchFamily="34" charset="0"/>
+                <a:ea typeface="Graphik TH" pitchFamily="34" charset="-122"/>
+                <a:cs typeface="Graphik TH" pitchFamily="34" charset="-120"/>
+              </a:rPr>
+              <a:t>THB 993m</a:t>
+            </a:r>
+            <a:endParaRPr lang="en-US" sz="1000" dirty="0"/>
+          </a:p>
+        </p:txBody>
+      </p:sp>
+      <p:sp>
+        <p:nvSpPr>
+          <p:cNvPr id="30" name="Text 28"/>
+          <p:cNvSpPr/>
+          <p:nvPr/>
+        </p:nvSpPr>
+        <p:spPr>
+          <a:xfrm>
+            <a:off x="786384" y="3913632"/>
+            <a:ext cx="1234440" cy="256032"/>
+          </a:xfrm>
+          <a:prstGeom prst="rect">
+            <a:avLst/>
+          </a:prstGeom>
+          <a:noFill/>
+          <a:ln/>
+        </p:spPr>
+        <p:txBody>
+          <a:bodyPr wrap="square" lIns="0" tIns="0" rIns="0" bIns="0" rtlCol="0" anchor="ctr"/>
+          <a:lstStyle/>
+          <a:p>
+            <a:pPr indent="0" marL="0">
+              <a:buNone/>
+            </a:pPr>
+            <a:r>
+              <a:rPr lang="en-US" sz="1000" dirty="0">
+                <a:solidFill>
+                  <a:srgbClr val="16233D"/>
+                </a:solidFill>
+                <a:latin typeface="Graphik TH" pitchFamily="34" charset="0"/>
+                <a:ea typeface="Graphik TH" pitchFamily="34" charset="-122"/>
+                <a:cs typeface="Graphik TH" pitchFamily="34" charset="-120"/>
+              </a:rPr>
+              <a:t>Latest</a:t>
+            </a:r>
+            <a:endParaRPr lang="en-US" sz="1000" dirty="0"/>
+          </a:p>
+        </p:txBody>
+      </p:sp>
+      <p:sp>
+        <p:nvSpPr>
+          <p:cNvPr id="31" name="Shape 29"/>
+          <p:cNvSpPr/>
+          <p:nvPr/>
+        </p:nvSpPr>
+        <p:spPr>
+          <a:xfrm>
+            <a:off x="2130552" y="3959352"/>
+            <a:ext cx="2331720" cy="164592"/>
+          </a:xfrm>
+          <a:prstGeom prst="roundRect">
+            <a:avLst>
+              <a:gd name="adj" fmla="val 16667"/>
+            </a:avLst>
+          </a:prstGeom>
+          <a:solidFill>
+            <a:srgbClr val="E4E9F0"/>
+          </a:solidFill>
+          <a:ln/>
+        </p:spPr>
+      </p:sp>
+      <p:sp>
+        <p:nvSpPr>
+          <p:cNvPr id="32" name="Shape 30"/>
+          <p:cNvSpPr/>
+          <p:nvPr/>
+        </p:nvSpPr>
+        <p:spPr>
+          <a:xfrm>
+            <a:off x="2130552" y="3959352"/>
+            <a:ext cx="426945" cy="164592"/>
+          </a:xfrm>
+          <a:prstGeom prst="roundRect">
+            <a:avLst>
+              <a:gd name="adj" fmla="val 16667"/>
+            </a:avLst>
+          </a:prstGeom>
+          <a:solidFill>
+            <a:srgbClr val="C00000"/>
+          </a:solidFill>
+          <a:ln/>
+        </p:spPr>
+      </p:sp>
+      <p:sp>
+        <p:nvSpPr>
+          <p:cNvPr id="33" name="Text 31"/>
+          <p:cNvSpPr/>
+          <p:nvPr/>
+        </p:nvSpPr>
+        <p:spPr>
+          <a:xfrm>
+            <a:off x="4553712" y="3913632"/>
+            <a:ext cx="1243584" cy="256032"/>
+          </a:xfrm>
+          <a:prstGeom prst="rect">
+            <a:avLst/>
+          </a:prstGeom>
+          <a:noFill/>
+          <a:ln/>
+        </p:spPr>
+        <p:txBody>
+          <a:bodyPr wrap="square" lIns="0" tIns="0" rIns="0" bIns="0" rtlCol="0" anchor="ctr"/>
+          <a:lstStyle/>
+          <a:p>
+            <a:pPr algn="r" indent="0" marL="0">
+              <a:buNone/>
+            </a:pPr>
+            <a:r>
+              <a:rPr lang="en-US" sz="1000" b="1" dirty="0">
+                <a:solidFill>
+                  <a:srgbClr val="C00000"/>
+                </a:solidFill>
+                <a:latin typeface="Graphik TH" pitchFamily="34" charset="0"/>
+                <a:ea typeface="Graphik TH" pitchFamily="34" charset="-122"/>
+                <a:cs typeface="Graphik TH" pitchFamily="34" charset="-120"/>
+              </a:rPr>
+              <a:t>THB 784m</a:t>
+            </a:r>
+            <a:endParaRPr lang="en-US" sz="1000" dirty="0"/>
+          </a:p>
+        </p:txBody>
+      </p:sp>
+      <p:sp>
+        <p:nvSpPr>
+          <p:cNvPr id="34" name="Text 32"/>
+          <p:cNvSpPr/>
+          <p:nvPr/>
+        </p:nvSpPr>
+        <p:spPr>
+          <a:xfrm>
+            <a:off x="786384" y="4242816"/>
+            <a:ext cx="5010912" cy="201168"/>
+          </a:xfrm>
+          <a:prstGeom prst="rect">
+            <a:avLst/>
+          </a:prstGeom>
+          <a:noFill/>
+          <a:ln/>
+        </p:spPr>
+        <p:txBody>
+          <a:bodyPr wrap="square" lIns="0" tIns="0" rIns="0" bIns="0" rtlCol="0" anchor="ctr"/>
+          <a:lstStyle/>
+          <a:p>
+            <a:pPr indent="0" marL="0">
+              <a:buNone/>
+            </a:pPr>
+            <a:r>
+              <a:rPr lang="en-US" sz="1050" b="1" dirty="0">
+                <a:solidFill>
+                  <a:srgbClr val="045D66"/>
+                </a:solidFill>
+                <a:latin typeface="Graphik TH" pitchFamily="34" charset="0"/>
+                <a:ea typeface="Graphik TH" pitchFamily="34" charset="-122"/>
+                <a:cs typeface="Graphik TH" pitchFamily="34" charset="-120"/>
+              </a:rPr>
+              <a:t>Total deposit balance</a:t>
+            </a:r>
+            <a:endParaRPr lang="en-US" sz="1050" dirty="0"/>
+          </a:p>
+        </p:txBody>
+      </p:sp>
+      <p:sp>
+        <p:nvSpPr>
+          <p:cNvPr id="35" name="Text 33"/>
+          <p:cNvSpPr/>
+          <p:nvPr/>
+        </p:nvSpPr>
+        <p:spPr>
+          <a:xfrm>
+            <a:off x="786384" y="4462272"/>
+            <a:ext cx="1234440" cy="256032"/>
+          </a:xfrm>
+          <a:prstGeom prst="rect">
+            <a:avLst/>
+          </a:prstGeom>
+          <a:noFill/>
+          <a:ln/>
+        </p:spPr>
+        <p:txBody>
+          <a:bodyPr wrap="square" lIns="0" tIns="0" rIns="0" bIns="0" rtlCol="0" anchor="ctr"/>
+          <a:lstStyle/>
+          <a:p>
+            <a:pPr indent="0" marL="0">
+              <a:buNone/>
+            </a:pPr>
+            <a:r>
+              <a:rPr lang="en-US" sz="1000" dirty="0">
+                <a:solidFill>
+                  <a:srgbClr val="16233D"/>
+                </a:solidFill>
+                <a:latin typeface="Graphik TH" pitchFamily="34" charset="0"/>
+                <a:ea typeface="Graphik TH" pitchFamily="34" charset="-122"/>
+                <a:cs typeface="Graphik TH" pitchFamily="34" charset="-120"/>
+              </a:rPr>
+              <a:t>Prior</a:t>
+            </a:r>
+            <a:endParaRPr lang="en-US" sz="1000" dirty="0"/>
+          </a:p>
+        </p:txBody>
+      </p:sp>
+      <p:sp>
+        <p:nvSpPr>
+          <p:cNvPr id="36" name="Shape 34"/>
+          <p:cNvSpPr/>
+          <p:nvPr/>
+        </p:nvSpPr>
+        <p:spPr>
+          <a:xfrm>
+            <a:off x="2130552" y="4507992"/>
+            <a:ext cx="2331720" cy="164592"/>
+          </a:xfrm>
+          <a:prstGeom prst="roundRect">
+            <a:avLst>
+              <a:gd name="adj" fmla="val 16667"/>
+            </a:avLst>
+          </a:prstGeom>
+          <a:solidFill>
+            <a:srgbClr val="E4E9F0"/>
+          </a:solidFill>
+          <a:ln/>
+        </p:spPr>
+      </p:sp>
+      <p:sp>
+        <p:nvSpPr>
+          <p:cNvPr id="37" name="Shape 35"/>
+          <p:cNvSpPr/>
+          <p:nvPr/>
+        </p:nvSpPr>
+        <p:spPr>
+          <a:xfrm>
+            <a:off x="2130552" y="4507992"/>
+            <a:ext cx="2247350" cy="164592"/>
+          </a:xfrm>
+          <a:prstGeom prst="roundRect">
+            <a:avLst>
+              <a:gd name="adj" fmla="val 16667"/>
+            </a:avLst>
+          </a:prstGeom>
+          <a:solidFill>
+            <a:srgbClr val="8DA0B8"/>
+          </a:solidFill>
+          <a:ln/>
+        </p:spPr>
+      </p:sp>
+      <p:sp>
+        <p:nvSpPr>
+          <p:cNvPr id="38" name="Text 36"/>
+          <p:cNvSpPr/>
+          <p:nvPr/>
+        </p:nvSpPr>
+        <p:spPr>
+          <a:xfrm>
+            <a:off x="4553712" y="4462272"/>
+            <a:ext cx="1243584" cy="256032"/>
+          </a:xfrm>
+          <a:prstGeom prst="rect">
+            <a:avLst/>
+          </a:prstGeom>
+          <a:noFill/>
+          <a:ln/>
+        </p:spPr>
+        <p:txBody>
+          <a:bodyPr wrap="square" lIns="0" tIns="0" rIns="0" bIns="0" rtlCol="0" anchor="ctr"/>
+          <a:lstStyle/>
+          <a:p>
+            <a:pPr algn="r" indent="0" marL="0">
+              <a:buNone/>
+            </a:pPr>
+            <a:r>
+              <a:rPr lang="en-US" sz="1000" b="1" dirty="0">
+                <a:solidFill>
+                  <a:srgbClr val="8DA0B8"/>
+                </a:solidFill>
+                <a:latin typeface="Graphik TH" pitchFamily="34" charset="0"/>
+                <a:ea typeface="Graphik TH" pitchFamily="34" charset="-122"/>
+                <a:cs typeface="Graphik TH" pitchFamily="34" charset="-120"/>
+              </a:rPr>
+              <a:t>THB 4,128m</a:t>
+            </a:r>
+            <a:endParaRPr lang="en-US" sz="1000" dirty="0"/>
+          </a:p>
+        </p:txBody>
+      </p:sp>
+      <p:sp>
+        <p:nvSpPr>
+          <p:cNvPr id="39" name="Text 37"/>
+          <p:cNvSpPr/>
+          <p:nvPr/>
+        </p:nvSpPr>
+        <p:spPr>
+          <a:xfrm>
+            <a:off x="786384" y="4754880"/>
+            <a:ext cx="1234440" cy="256032"/>
+          </a:xfrm>
+          <a:prstGeom prst="rect">
+            <a:avLst/>
+          </a:prstGeom>
+          <a:noFill/>
+          <a:ln/>
+        </p:spPr>
+        <p:txBody>
+          <a:bodyPr wrap="square" lIns="0" tIns="0" rIns="0" bIns="0" rtlCol="0" anchor="ctr"/>
+          <a:lstStyle/>
+          <a:p>
+            <a:pPr indent="0" marL="0">
+              <a:buNone/>
+            </a:pPr>
+            <a:r>
+              <a:rPr lang="en-US" sz="1000" dirty="0">
+                <a:solidFill>
+                  <a:srgbClr val="16233D"/>
+                </a:solidFill>
+                <a:latin typeface="Graphik TH" pitchFamily="34" charset="0"/>
+                <a:ea typeface="Graphik TH" pitchFamily="34" charset="-122"/>
+                <a:cs typeface="Graphik TH" pitchFamily="34" charset="-120"/>
+              </a:rPr>
+              <a:t>Latest</a:t>
+            </a:r>
+            <a:endParaRPr lang="en-US" sz="1000" dirty="0"/>
+          </a:p>
+        </p:txBody>
+      </p:sp>
+      <p:sp>
+        <p:nvSpPr>
+          <p:cNvPr id="40" name="Shape 38"/>
+          <p:cNvSpPr/>
+          <p:nvPr/>
+        </p:nvSpPr>
+        <p:spPr>
+          <a:xfrm>
+            <a:off x="2130552" y="4800600"/>
+            <a:ext cx="2331720" cy="164592"/>
+          </a:xfrm>
+          <a:prstGeom prst="roundRect">
+            <a:avLst>
+              <a:gd name="adj" fmla="val 16667"/>
+            </a:avLst>
+          </a:prstGeom>
+          <a:solidFill>
+            <a:srgbClr val="E4E9F0"/>
+          </a:solidFill>
+          <a:ln/>
+        </p:spPr>
+      </p:sp>
+      <p:sp>
+        <p:nvSpPr>
+          <p:cNvPr id="41" name="Shape 39"/>
+          <p:cNvSpPr/>
+          <p:nvPr/>
+        </p:nvSpPr>
+        <p:spPr>
+          <a:xfrm>
+            <a:off x="2130552" y="4800600"/>
+            <a:ext cx="2331720" cy="164592"/>
+          </a:xfrm>
+          <a:prstGeom prst="roundRect">
+            <a:avLst>
+              <a:gd name="adj" fmla="val 16667"/>
+            </a:avLst>
+          </a:prstGeom>
+          <a:solidFill>
+            <a:srgbClr val="1E8E86"/>
+          </a:solidFill>
+          <a:ln/>
+        </p:spPr>
+      </p:sp>
+      <p:sp>
+        <p:nvSpPr>
+          <p:cNvPr id="42" name="Text 40"/>
+          <p:cNvSpPr/>
+          <p:nvPr/>
+        </p:nvSpPr>
+        <p:spPr>
+          <a:xfrm>
+            <a:off x="4553712" y="4754880"/>
+            <a:ext cx="1243584" cy="256032"/>
+          </a:xfrm>
+          <a:prstGeom prst="rect">
+            <a:avLst/>
+          </a:prstGeom>
+          <a:noFill/>
+          <a:ln/>
+        </p:spPr>
+        <p:txBody>
+          <a:bodyPr wrap="square" lIns="0" tIns="0" rIns="0" bIns="0" rtlCol="0" anchor="ctr"/>
+          <a:lstStyle/>
+          <a:p>
+            <a:pPr algn="r" indent="0" marL="0">
+              <a:buNone/>
+            </a:pPr>
+            <a:r>
+              <a:rPr lang="en-US" sz="1000" b="1" dirty="0">
+                <a:solidFill>
+                  <a:srgbClr val="1E8E86"/>
+                </a:solidFill>
+                <a:latin typeface="Graphik TH" pitchFamily="34" charset="0"/>
+                <a:ea typeface="Graphik TH" pitchFamily="34" charset="-122"/>
+                <a:cs typeface="Graphik TH" pitchFamily="34" charset="-120"/>
+              </a:rPr>
+              <a:t>THB 4,283m</a:t>
+            </a:r>
+            <a:endParaRPr lang="en-US" sz="1000" dirty="0"/>
+          </a:p>
+        </p:txBody>
+      </p:sp>
+      <p:sp>
+        <p:nvSpPr>
+          <p:cNvPr id="43" name="Shape 41"/>
+          <p:cNvSpPr/>
+          <p:nvPr/>
+        </p:nvSpPr>
+        <p:spPr>
+          <a:xfrm>
+            <a:off x="6281928" y="2798064"/>
+            <a:ext cx="5522976" cy="2322576"/>
+          </a:xfrm>
+          <a:prstGeom prst="roundRect">
+            <a:avLst>
+              <a:gd name="adj" fmla="val 3543"/>
+            </a:avLst>
+          </a:prstGeom>
+          <a:solidFill>
+            <a:srgbClr val="F1F4F9"/>
+          </a:solidFill>
+          <a:ln/>
+        </p:spPr>
+      </p:sp>
+      <p:sp>
+        <p:nvSpPr>
+          <p:cNvPr id="44" name="Text 42"/>
+          <p:cNvSpPr/>
+          <p:nvPr/>
+        </p:nvSpPr>
+        <p:spPr>
+          <a:xfrm>
+            <a:off x="6537960" y="2944368"/>
+            <a:ext cx="5010912" cy="274320"/>
+          </a:xfrm>
+          <a:prstGeom prst="rect">
+            <a:avLst/>
+          </a:prstGeom>
+          <a:noFill/>
+          <a:ln/>
+        </p:spPr>
+        <p:txBody>
+          <a:bodyPr wrap="square" lIns="0" tIns="0" rIns="0" bIns="0" rtlCol="0" anchor="ctr"/>
+          <a:lstStyle/>
+          <a:p>
+            <a:pPr indent="0" marL="0">
+              <a:buNone/>
+            </a:pPr>
+            <a:r>
+              <a:rPr lang="en-US" sz="1400" b="1" dirty="0">
+                <a:solidFill>
+                  <a:srgbClr val="16233D"/>
+                </a:solidFill>
+                <a:latin typeface="Cambria" pitchFamily="34" charset="0"/>
+                <a:ea typeface="Cambria" pitchFamily="34" charset="-122"/>
+                <a:cs typeface="Cambria" pitchFamily="34" charset="-120"/>
+              </a:rPr>
+              <a:t>Who emptied Save Max</a:t>
+            </a:r>
+            <a:endParaRPr lang="en-US" sz="1400" dirty="0"/>
+          </a:p>
+        </p:txBody>
+      </p:sp>
+      <p:sp>
+        <p:nvSpPr>
+          <p:cNvPr id="45" name="Text 43"/>
+          <p:cNvSpPr/>
+          <p:nvPr/>
+        </p:nvSpPr>
+        <p:spPr>
+          <a:xfrm>
+            <a:off x="6537960" y="3218688"/>
+            <a:ext cx="5010912" cy="237744"/>
+          </a:xfrm>
+          <a:prstGeom prst="rect">
+            <a:avLst/>
+          </a:prstGeom>
+          <a:noFill/>
+          <a:ln/>
+        </p:spPr>
+        <p:txBody>
+          <a:bodyPr wrap="square" lIns="0" tIns="0" rIns="0" bIns="0" rtlCol="0" anchor="ctr"/>
+          <a:lstStyle/>
+          <a:p>
+            <a:pPr indent="0" marL="0">
+              <a:buNone/>
+            </a:pPr>
+            <a:r>
+              <a:rPr lang="en-US" sz="950" dirty="0">
+                <a:solidFill>
+                  <a:srgbClr val="6B7A90"/>
+                </a:solidFill>
+                <a:latin typeface="Graphik TH" pitchFamily="34" charset="0"/>
+                <a:ea typeface="Graphik TH" pitchFamily="34" charset="-122"/>
+                <a:cs typeface="Graphik TH" pitchFamily="34" charset="-120"/>
+              </a:rPr>
+              <a:t>Share of each rate-sensitivity segment that moved</a:t>
+            </a:r>
+            <a:endParaRPr lang="en-US" sz="950" dirty="0"/>
+          </a:p>
+        </p:txBody>
+      </p:sp>
+      <p:sp>
+        <p:nvSpPr>
+          <p:cNvPr id="46" name="Text 44"/>
+          <p:cNvSpPr/>
+          <p:nvPr/>
+        </p:nvSpPr>
+        <p:spPr>
+          <a:xfrm>
+            <a:off x="6537960" y="3438144"/>
+            <a:ext cx="1051560" cy="256032"/>
+          </a:xfrm>
+          <a:prstGeom prst="rect">
+            <a:avLst/>
+          </a:prstGeom>
+          <a:noFill/>
+          <a:ln/>
+        </p:spPr>
+        <p:txBody>
+          <a:bodyPr wrap="square" lIns="0" tIns="0" rIns="0" bIns="0" rtlCol="0" anchor="ctr"/>
+          <a:lstStyle/>
+          <a:p>
+            <a:pPr indent="0" marL="0">
+              <a:buNone/>
+            </a:pPr>
+            <a:r>
+              <a:rPr lang="en-US" sz="1000" b="1" dirty="0">
+                <a:solidFill>
+                  <a:srgbClr val="16233D"/>
+                </a:solidFill>
+                <a:latin typeface="Graphik TH" pitchFamily="34" charset="0"/>
+                <a:ea typeface="Graphik TH" pitchFamily="34" charset="-122"/>
+                <a:cs typeface="Graphik TH" pitchFamily="34" charset="-120"/>
+              </a:rPr>
+              <a:t>Very High</a:t>
+            </a:r>
+            <a:endParaRPr lang="en-US" sz="1000" dirty="0"/>
+          </a:p>
+        </p:txBody>
+      </p:sp>
+      <p:sp>
+        <p:nvSpPr>
+          <p:cNvPr id="47" name="Shape 45"/>
+          <p:cNvSpPr/>
+          <p:nvPr/>
+        </p:nvSpPr>
+        <p:spPr>
+          <a:xfrm>
+            <a:off x="7680960" y="3483864"/>
+            <a:ext cx="1828800" cy="164592"/>
+          </a:xfrm>
+          <a:prstGeom prst="roundRect">
+            <a:avLst>
+              <a:gd name="adj" fmla="val 16667"/>
+            </a:avLst>
+          </a:prstGeom>
+          <a:solidFill>
+            <a:srgbClr val="E4E9F0"/>
+          </a:solidFill>
+          <a:ln/>
+        </p:spPr>
+      </p:sp>
+      <p:sp>
+        <p:nvSpPr>
+          <p:cNvPr id="48" name="Shape 46"/>
+          <p:cNvSpPr/>
+          <p:nvPr/>
+        </p:nvSpPr>
+        <p:spPr>
+          <a:xfrm>
+            <a:off x="7680960" y="3483864"/>
+            <a:ext cx="234971" cy="164592"/>
+          </a:xfrm>
+          <a:prstGeom prst="roundRect">
+            <a:avLst>
+              <a:gd name="adj" fmla="val 16667"/>
+            </a:avLst>
+          </a:prstGeom>
+          <a:solidFill>
+            <a:srgbClr val="165A73"/>
+          </a:solidFill>
+          <a:ln/>
+        </p:spPr>
+      </p:sp>
+      <p:sp>
+        <p:nvSpPr>
+          <p:cNvPr id="49" name="Text 47"/>
+          <p:cNvSpPr/>
+          <p:nvPr/>
+        </p:nvSpPr>
+        <p:spPr>
+          <a:xfrm>
+            <a:off x="9601200" y="3438144"/>
+            <a:ext cx="777240" cy="256032"/>
+          </a:xfrm>
+          <a:prstGeom prst="rect">
+            <a:avLst/>
+          </a:prstGeom>
+          <a:noFill/>
+          <a:ln/>
+        </p:spPr>
+        <p:txBody>
+          <a:bodyPr wrap="square" lIns="0" tIns="0" rIns="0" bIns="0" rtlCol="0" anchor="ctr"/>
+          <a:lstStyle/>
+          <a:p>
+            <a:pPr algn="r" indent="0" marL="0">
+              <a:buNone/>
+            </a:pPr>
+            <a:r>
+              <a:rPr lang="en-US" sz="1000" b="1" dirty="0">
+                <a:solidFill>
+                  <a:srgbClr val="165A73"/>
+                </a:solidFill>
+                <a:latin typeface="Graphik TH" pitchFamily="34" charset="0"/>
+                <a:ea typeface="Graphik TH" pitchFamily="34" charset="-122"/>
+                <a:cs typeface="Graphik TH" pitchFamily="34" charset="-120"/>
+              </a:rPr>
+              <a:t>12.8%</a:t>
+            </a:r>
+            <a:endParaRPr lang="en-US" sz="1000" dirty="0"/>
+          </a:p>
+        </p:txBody>
+      </p:sp>
+      <p:sp>
+        <p:nvSpPr>
+          <p:cNvPr id="50" name="Text 48"/>
+          <p:cNvSpPr/>
+          <p:nvPr/>
+        </p:nvSpPr>
+        <p:spPr>
+          <a:xfrm>
+            <a:off x="10469880" y="3438144"/>
+            <a:ext cx="1280160" cy="256032"/>
+          </a:xfrm>
+          <a:prstGeom prst="rect">
+            <a:avLst/>
+          </a:prstGeom>
+          <a:noFill/>
+          <a:ln/>
+        </p:spPr>
+        <p:txBody>
+          <a:bodyPr wrap="square" lIns="0" tIns="0" rIns="0" bIns="0" rtlCol="0" anchor="ctr"/>
+          <a:lstStyle/>
+          <a:p>
+            <a:pPr algn="r" indent="0" marL="0">
+              <a:buNone/>
+            </a:pPr>
+            <a:r>
+              <a:rPr lang="en-US" sz="900" dirty="0">
+                <a:solidFill>
+                  <a:srgbClr val="6B7A90"/>
+                </a:solidFill>
+                <a:latin typeface="Graphik TH" pitchFamily="34" charset="0"/>
+                <a:ea typeface="Graphik TH" pitchFamily="34" charset="-122"/>
+                <a:cs typeface="Graphik TH" pitchFamily="34" charset="-120"/>
+              </a:rPr>
+              <a:t>2,388 of 18,586</a:t>
+            </a:r>
+            <a:endParaRPr lang="en-US" sz="900" dirty="0"/>
+          </a:p>
+        </p:txBody>
+      </p:sp>
+      <p:sp>
+        <p:nvSpPr>
+          <p:cNvPr id="51" name="Text 49"/>
+          <p:cNvSpPr/>
+          <p:nvPr/>
+        </p:nvSpPr>
+        <p:spPr>
+          <a:xfrm>
+            <a:off x="6537960" y="3749040"/>
+            <a:ext cx="1051560" cy="256032"/>
+          </a:xfrm>
+          <a:prstGeom prst="rect">
+            <a:avLst/>
+          </a:prstGeom>
+          <a:noFill/>
+          <a:ln/>
+        </p:spPr>
+        <p:txBody>
+          <a:bodyPr wrap="square" lIns="0" tIns="0" rIns="0" bIns="0" rtlCol="0" anchor="ctr"/>
+          <a:lstStyle/>
+          <a:p>
+            <a:pPr indent="0" marL="0">
+              <a:buNone/>
+            </a:pPr>
+            <a:r>
+              <a:rPr lang="en-US" sz="1000" b="1" dirty="0">
+                <a:solidFill>
+                  <a:srgbClr val="16233D"/>
+                </a:solidFill>
+                <a:latin typeface="Graphik TH" pitchFamily="34" charset="0"/>
+                <a:ea typeface="Graphik TH" pitchFamily="34" charset="-122"/>
+                <a:cs typeface="Graphik TH" pitchFamily="34" charset="-120"/>
+              </a:rPr>
+              <a:t>High</a:t>
+            </a:r>
+            <a:endParaRPr lang="en-US" sz="1000" dirty="0"/>
+          </a:p>
+        </p:txBody>
+      </p:sp>
+      <p:sp>
+        <p:nvSpPr>
+          <p:cNvPr id="52" name="Shape 50"/>
+          <p:cNvSpPr/>
+          <p:nvPr/>
+        </p:nvSpPr>
+        <p:spPr>
+          <a:xfrm>
+            <a:off x="7680960" y="3794760"/>
+            <a:ext cx="1828800" cy="164592"/>
+          </a:xfrm>
+          <a:prstGeom prst="roundRect">
+            <a:avLst>
+              <a:gd name="adj" fmla="val 16667"/>
+            </a:avLst>
+          </a:prstGeom>
+          <a:solidFill>
+            <a:srgbClr val="E4E9F0"/>
+          </a:solidFill>
+          <a:ln/>
+        </p:spPr>
+      </p:sp>
+      <p:sp>
+        <p:nvSpPr>
+          <p:cNvPr id="53" name="Shape 51"/>
+          <p:cNvSpPr/>
+          <p:nvPr/>
+        </p:nvSpPr>
+        <p:spPr>
+          <a:xfrm>
+            <a:off x="7680960" y="3794760"/>
+            <a:ext cx="904864" cy="164592"/>
+          </a:xfrm>
+          <a:prstGeom prst="roundRect">
+            <a:avLst>
+              <a:gd name="adj" fmla="val 16667"/>
+            </a:avLst>
+          </a:prstGeom>
+          <a:solidFill>
+            <a:srgbClr val="C00000"/>
+          </a:solidFill>
+          <a:ln/>
+        </p:spPr>
+      </p:sp>
+      <p:sp>
+        <p:nvSpPr>
+          <p:cNvPr id="54" name="Text 52"/>
+          <p:cNvSpPr/>
+          <p:nvPr/>
+        </p:nvSpPr>
+        <p:spPr>
+          <a:xfrm>
+            <a:off x="9601200" y="3749040"/>
+            <a:ext cx="777240" cy="256032"/>
+          </a:xfrm>
+          <a:prstGeom prst="rect">
+            <a:avLst/>
+          </a:prstGeom>
+          <a:noFill/>
+          <a:ln/>
+        </p:spPr>
+        <p:txBody>
+          <a:bodyPr wrap="square" lIns="0" tIns="0" rIns="0" bIns="0" rtlCol="0" anchor="ctr"/>
+          <a:lstStyle/>
+          <a:p>
+            <a:pPr algn="r" indent="0" marL="0">
+              <a:buNone/>
+            </a:pPr>
+            <a:r>
+              <a:rPr lang="en-US" sz="1000" b="1" dirty="0">
+                <a:solidFill>
+                  <a:srgbClr val="C00000"/>
+                </a:solidFill>
+                <a:latin typeface="Graphik TH" pitchFamily="34" charset="0"/>
+                <a:ea typeface="Graphik TH" pitchFamily="34" charset="-122"/>
+                <a:cs typeface="Graphik TH" pitchFamily="34" charset="-120"/>
+              </a:rPr>
+              <a:t>49.5%</a:t>
+            </a:r>
+            <a:endParaRPr lang="en-US" sz="1000" dirty="0"/>
+          </a:p>
+        </p:txBody>
+      </p:sp>
+      <p:sp>
+        <p:nvSpPr>
+          <p:cNvPr id="55" name="Text 53"/>
+          <p:cNvSpPr/>
+          <p:nvPr/>
+        </p:nvSpPr>
+        <p:spPr>
+          <a:xfrm>
+            <a:off x="10469880" y="3749040"/>
+            <a:ext cx="1280160" cy="256032"/>
+          </a:xfrm>
+          <a:prstGeom prst="rect">
+            <a:avLst/>
+          </a:prstGeom>
+          <a:noFill/>
+          <a:ln/>
+        </p:spPr>
+        <p:txBody>
+          <a:bodyPr wrap="square" lIns="0" tIns="0" rIns="0" bIns="0" rtlCol="0" anchor="ctr"/>
+          <a:lstStyle/>
+          <a:p>
+            <a:pPr algn="r" indent="0" marL="0">
+              <a:buNone/>
+            </a:pPr>
+            <a:r>
+              <a:rPr lang="en-US" sz="900" dirty="0">
+                <a:solidFill>
+                  <a:srgbClr val="6B7A90"/>
+                </a:solidFill>
+                <a:latin typeface="Graphik TH" pitchFamily="34" charset="0"/>
+                <a:ea typeface="Graphik TH" pitchFamily="34" charset="-122"/>
+                <a:cs typeface="Graphik TH" pitchFamily="34" charset="-120"/>
+              </a:rPr>
+              <a:t>2,562 of 5,178</a:t>
+            </a:r>
+            <a:endParaRPr lang="en-US" sz="900" dirty="0"/>
+          </a:p>
+        </p:txBody>
+      </p:sp>
+      <p:sp>
+        <p:nvSpPr>
+          <p:cNvPr id="56" name="Text 54"/>
+          <p:cNvSpPr/>
+          <p:nvPr/>
+        </p:nvSpPr>
+        <p:spPr>
+          <a:xfrm>
+            <a:off x="6537960" y="4059936"/>
+            <a:ext cx="1051560" cy="256032"/>
+          </a:xfrm>
+          <a:prstGeom prst="rect">
+            <a:avLst/>
+          </a:prstGeom>
+          <a:noFill/>
+          <a:ln/>
+        </p:spPr>
+        <p:txBody>
+          <a:bodyPr wrap="square" lIns="0" tIns="0" rIns="0" bIns="0" rtlCol="0" anchor="ctr"/>
+          <a:lstStyle/>
+          <a:p>
+            <a:pPr indent="0" marL="0">
+              <a:buNone/>
+            </a:pPr>
+            <a:r>
+              <a:rPr lang="en-US" sz="1000" b="1" dirty="0">
+                <a:solidFill>
+                  <a:srgbClr val="16233D"/>
+                </a:solidFill>
+                <a:latin typeface="Graphik TH" pitchFamily="34" charset="0"/>
+                <a:ea typeface="Graphik TH" pitchFamily="34" charset="-122"/>
+                <a:cs typeface="Graphik TH" pitchFamily="34" charset="-120"/>
+              </a:rPr>
+              <a:t>Medium</a:t>
+            </a:r>
+            <a:endParaRPr lang="en-US" sz="1000" dirty="0"/>
+          </a:p>
+        </p:txBody>
+      </p:sp>
+      <p:sp>
+        <p:nvSpPr>
+          <p:cNvPr id="57" name="Shape 55"/>
+          <p:cNvSpPr/>
+          <p:nvPr/>
+        </p:nvSpPr>
+        <p:spPr>
+          <a:xfrm>
+            <a:off x="7680960" y="4105656"/>
+            <a:ext cx="1828800" cy="164592"/>
+          </a:xfrm>
+          <a:prstGeom prst="roundRect">
+            <a:avLst>
+              <a:gd name="adj" fmla="val 16667"/>
+            </a:avLst>
+          </a:prstGeom>
+          <a:solidFill>
+            <a:srgbClr val="E4E9F0"/>
+          </a:solidFill>
+          <a:ln/>
+        </p:spPr>
+      </p:sp>
+      <p:sp>
+        <p:nvSpPr>
+          <p:cNvPr id="58" name="Shape 56"/>
+          <p:cNvSpPr/>
+          <p:nvPr/>
+        </p:nvSpPr>
+        <p:spPr>
+          <a:xfrm>
+            <a:off x="7680960" y="4105656"/>
+            <a:ext cx="36576" cy="164592"/>
+          </a:xfrm>
+          <a:prstGeom prst="roundRect">
+            <a:avLst>
+              <a:gd name="adj" fmla="val 75000"/>
+            </a:avLst>
+          </a:prstGeom>
+          <a:solidFill>
+            <a:srgbClr val="3FB89F"/>
+          </a:solidFill>
+          <a:ln/>
+        </p:spPr>
+      </p:sp>
+      <p:sp>
+        <p:nvSpPr>
+          <p:cNvPr id="59" name="Text 57"/>
+          <p:cNvSpPr/>
+          <p:nvPr/>
+        </p:nvSpPr>
+        <p:spPr>
+          <a:xfrm>
+            <a:off x="9601200" y="4059936"/>
+            <a:ext cx="777240" cy="256032"/>
+          </a:xfrm>
+          <a:prstGeom prst="rect">
+            <a:avLst/>
+          </a:prstGeom>
+          <a:noFill/>
+          <a:ln/>
+        </p:spPr>
+        <p:txBody>
+          <a:bodyPr wrap="square" lIns="0" tIns="0" rIns="0" bIns="0" rtlCol="0" anchor="ctr"/>
+          <a:lstStyle/>
+          <a:p>
+            <a:pPr algn="r" indent="0" marL="0">
+              <a:buNone/>
+            </a:pPr>
+            <a:r>
+              <a:rPr lang="en-US" sz="1000" b="1" dirty="0">
+                <a:solidFill>
+                  <a:srgbClr val="3FB89F"/>
+                </a:solidFill>
+                <a:latin typeface="Graphik TH" pitchFamily="34" charset="0"/>
+                <a:ea typeface="Graphik TH" pitchFamily="34" charset="-122"/>
+                <a:cs typeface="Graphik TH" pitchFamily="34" charset="-120"/>
+              </a:rPr>
+              <a:t>0.0%</a:t>
+            </a:r>
+            <a:endParaRPr lang="en-US" sz="1000" dirty="0"/>
+          </a:p>
+        </p:txBody>
+      </p:sp>
+      <p:sp>
+        <p:nvSpPr>
+          <p:cNvPr id="60" name="Text 58"/>
+          <p:cNvSpPr/>
+          <p:nvPr/>
+        </p:nvSpPr>
+        <p:spPr>
+          <a:xfrm>
+            <a:off x="10469880" y="4059936"/>
+            <a:ext cx="1280160" cy="256032"/>
+          </a:xfrm>
+          <a:prstGeom prst="rect">
+            <a:avLst/>
+          </a:prstGeom>
+          <a:noFill/>
+          <a:ln/>
+        </p:spPr>
+        <p:txBody>
+          <a:bodyPr wrap="square" lIns="0" tIns="0" rIns="0" bIns="0" rtlCol="0" anchor="ctr"/>
+          <a:lstStyle/>
+          <a:p>
+            <a:pPr algn="r" indent="0" marL="0">
+              <a:buNone/>
+            </a:pPr>
+            <a:r>
+              <a:rPr lang="en-US" sz="900" dirty="0">
+                <a:solidFill>
+                  <a:srgbClr val="6B7A90"/>
+                </a:solidFill>
+                <a:latin typeface="Graphik TH" pitchFamily="34" charset="0"/>
+                <a:ea typeface="Graphik TH" pitchFamily="34" charset="-122"/>
+                <a:cs typeface="Graphik TH" pitchFamily="34" charset="-120"/>
+              </a:rPr>
+              <a:t>0 of 4</a:t>
+            </a:r>
+            <a:endParaRPr lang="en-US" sz="900" dirty="0"/>
+          </a:p>
+        </p:txBody>
+      </p:sp>
+      <p:sp>
+        <p:nvSpPr>
+          <p:cNvPr id="61" name="Text 59"/>
+          <p:cNvSpPr/>
+          <p:nvPr/>
+        </p:nvSpPr>
+        <p:spPr>
+          <a:xfrm>
+            <a:off x="6537960" y="4370832"/>
+            <a:ext cx="1051560" cy="256032"/>
+          </a:xfrm>
+          <a:prstGeom prst="rect">
+            <a:avLst/>
+          </a:prstGeom>
+          <a:noFill/>
+          <a:ln/>
+        </p:spPr>
+        <p:txBody>
+          <a:bodyPr wrap="square" lIns="0" tIns="0" rIns="0" bIns="0" rtlCol="0" anchor="ctr"/>
+          <a:lstStyle/>
+          <a:p>
+            <a:pPr indent="0" marL="0">
+              <a:buNone/>
+            </a:pPr>
+            <a:r>
+              <a:rPr lang="en-US" sz="1000" b="1" dirty="0">
+                <a:solidFill>
+                  <a:srgbClr val="16233D"/>
+                </a:solidFill>
+                <a:latin typeface="Graphik TH" pitchFamily="34" charset="0"/>
+                <a:ea typeface="Graphik TH" pitchFamily="34" charset="-122"/>
+                <a:cs typeface="Graphik TH" pitchFamily="34" charset="-120"/>
+              </a:rPr>
+              <a:t>Low</a:t>
+            </a:r>
+            <a:endParaRPr lang="en-US" sz="1000" dirty="0"/>
+          </a:p>
+        </p:txBody>
+      </p:sp>
+      <p:sp>
+        <p:nvSpPr>
+          <p:cNvPr id="62" name="Shape 60"/>
+          <p:cNvSpPr/>
+          <p:nvPr/>
+        </p:nvSpPr>
+        <p:spPr>
+          <a:xfrm>
+            <a:off x="7680960" y="4416552"/>
+            <a:ext cx="1828800" cy="164592"/>
+          </a:xfrm>
+          <a:prstGeom prst="roundRect">
+            <a:avLst>
+              <a:gd name="adj" fmla="val 16667"/>
+            </a:avLst>
+          </a:prstGeom>
+          <a:solidFill>
+            <a:srgbClr val="E4E9F0"/>
+          </a:solidFill>
+          <a:ln/>
+        </p:spPr>
+      </p:sp>
+      <p:sp>
+        <p:nvSpPr>
+          <p:cNvPr id="63" name="Shape 61"/>
+          <p:cNvSpPr/>
+          <p:nvPr/>
+        </p:nvSpPr>
+        <p:spPr>
+          <a:xfrm>
+            <a:off x="7680960" y="4416552"/>
+            <a:ext cx="130467" cy="164592"/>
+          </a:xfrm>
+          <a:prstGeom prst="roundRect">
+            <a:avLst>
+              <a:gd name="adj" fmla="val 21026"/>
+            </a:avLst>
+          </a:prstGeom>
+          <a:solidFill>
+            <a:srgbClr val="E9A03B"/>
+          </a:solidFill>
+          <a:ln/>
+        </p:spPr>
+      </p:sp>
+      <p:sp>
+        <p:nvSpPr>
+          <p:cNvPr id="64" name="Text 62"/>
+          <p:cNvSpPr/>
+          <p:nvPr/>
+        </p:nvSpPr>
+        <p:spPr>
+          <a:xfrm>
+            <a:off x="9601200" y="4370832"/>
+            <a:ext cx="777240" cy="256032"/>
+          </a:xfrm>
+          <a:prstGeom prst="rect">
+            <a:avLst/>
+          </a:prstGeom>
+          <a:noFill/>
+          <a:ln/>
+        </p:spPr>
+        <p:txBody>
+          <a:bodyPr wrap="square" lIns="0" tIns="0" rIns="0" bIns="0" rtlCol="0" anchor="ctr"/>
+          <a:lstStyle/>
+          <a:p>
+            <a:pPr algn="r" indent="0" marL="0">
+              <a:buNone/>
+            </a:pPr>
+            <a:r>
+              <a:rPr lang="en-US" sz="1000" b="1" dirty="0">
+                <a:solidFill>
+                  <a:srgbClr val="E9A03B"/>
+                </a:solidFill>
+                <a:latin typeface="Graphik TH" pitchFamily="34" charset="0"/>
+                <a:ea typeface="Graphik TH" pitchFamily="34" charset="-122"/>
+                <a:cs typeface="Graphik TH" pitchFamily="34" charset="-120"/>
+              </a:rPr>
+              <a:t>7.1%</a:t>
+            </a:r>
+            <a:endParaRPr lang="en-US" sz="1000" dirty="0"/>
+          </a:p>
+        </p:txBody>
+      </p:sp>
+      <p:sp>
+        <p:nvSpPr>
+          <p:cNvPr id="65" name="Text 63"/>
+          <p:cNvSpPr/>
+          <p:nvPr/>
+        </p:nvSpPr>
+        <p:spPr>
+          <a:xfrm>
+            <a:off x="10469880" y="4370832"/>
+            <a:ext cx="1280160" cy="256032"/>
+          </a:xfrm>
+          <a:prstGeom prst="rect">
+            <a:avLst/>
+          </a:prstGeom>
+          <a:noFill/>
+          <a:ln/>
+        </p:spPr>
+        <p:txBody>
+          <a:bodyPr wrap="square" lIns="0" tIns="0" rIns="0" bIns="0" rtlCol="0" anchor="ctr"/>
+          <a:lstStyle/>
+          <a:p>
+            <a:pPr algn="r" indent="0" marL="0">
+              <a:buNone/>
+            </a:pPr>
+            <a:r>
+              <a:rPr lang="en-US" sz="900" dirty="0">
+                <a:solidFill>
+                  <a:srgbClr val="6B7A90"/>
+                </a:solidFill>
+                <a:latin typeface="Graphik TH" pitchFamily="34" charset="0"/>
+                <a:ea typeface="Graphik TH" pitchFamily="34" charset="-122"/>
+                <a:cs typeface="Graphik TH" pitchFamily="34" charset="-120"/>
+              </a:rPr>
+              <a:t>1,562 of 21,895</a:t>
+            </a:r>
+            <a:endParaRPr lang="en-US" sz="900" dirty="0"/>
+          </a:p>
+        </p:txBody>
+      </p:sp>
+      <p:sp>
+        <p:nvSpPr>
+          <p:cNvPr id="66" name="Text 64"/>
+          <p:cNvSpPr/>
+          <p:nvPr/>
+        </p:nvSpPr>
+        <p:spPr>
+          <a:xfrm>
+            <a:off x="6537960" y="4681728"/>
+            <a:ext cx="1051560" cy="256032"/>
+          </a:xfrm>
+          <a:prstGeom prst="rect">
+            <a:avLst/>
+          </a:prstGeom>
+          <a:noFill/>
+          <a:ln/>
+        </p:spPr>
+        <p:txBody>
+          <a:bodyPr wrap="square" lIns="0" tIns="0" rIns="0" bIns="0" rtlCol="0" anchor="ctr"/>
+          <a:lstStyle/>
+          <a:p>
+            <a:pPr indent="0" marL="0">
+              <a:buNone/>
+            </a:pPr>
+            <a:r>
+              <a:rPr lang="en-US" sz="1000" b="1" dirty="0">
+                <a:solidFill>
+                  <a:srgbClr val="16233D"/>
+                </a:solidFill>
+                <a:latin typeface="Graphik TH" pitchFamily="34" charset="0"/>
+                <a:ea typeface="Graphik TH" pitchFamily="34" charset="-122"/>
+                <a:cs typeface="Graphik TH" pitchFamily="34" charset="-120"/>
+              </a:rPr>
+              <a:t>Very Low</a:t>
+            </a:r>
+            <a:endParaRPr lang="en-US" sz="1000" dirty="0"/>
+          </a:p>
+        </p:txBody>
+      </p:sp>
+      <p:sp>
+        <p:nvSpPr>
+          <p:cNvPr id="67" name="Shape 65"/>
+          <p:cNvSpPr/>
+          <p:nvPr/>
+        </p:nvSpPr>
+        <p:spPr>
+          <a:xfrm>
+            <a:off x="7680960" y="4727448"/>
+            <a:ext cx="1828800" cy="164592"/>
+          </a:xfrm>
+          <a:prstGeom prst="roundRect">
+            <a:avLst>
+              <a:gd name="adj" fmla="val 16667"/>
+            </a:avLst>
+          </a:prstGeom>
+          <a:solidFill>
+            <a:srgbClr val="E4E9F0"/>
+          </a:solidFill>
+          <a:ln/>
+        </p:spPr>
+      </p:sp>
+      <p:sp>
+        <p:nvSpPr>
+          <p:cNvPr id="68" name="Shape 66"/>
+          <p:cNvSpPr/>
+          <p:nvPr/>
+        </p:nvSpPr>
+        <p:spPr>
+          <a:xfrm>
+            <a:off x="7680960" y="4727448"/>
+            <a:ext cx="36576" cy="164592"/>
+          </a:xfrm>
+          <a:prstGeom prst="roundRect">
+            <a:avLst>
+              <a:gd name="adj" fmla="val 75000"/>
+            </a:avLst>
+          </a:prstGeom>
+          <a:solidFill>
+            <a:srgbClr val="8DA0B8"/>
+          </a:solidFill>
+          <a:ln/>
+        </p:spPr>
+      </p:sp>
+      <p:sp>
+        <p:nvSpPr>
+          <p:cNvPr id="69" name="Text 67"/>
+          <p:cNvSpPr/>
+          <p:nvPr/>
+        </p:nvSpPr>
+        <p:spPr>
+          <a:xfrm>
+            <a:off x="9601200" y="4681728"/>
+            <a:ext cx="777240" cy="256032"/>
+          </a:xfrm>
+          <a:prstGeom prst="rect">
+            <a:avLst/>
+          </a:prstGeom>
+          <a:noFill/>
+          <a:ln/>
+        </p:spPr>
+        <p:txBody>
+          <a:bodyPr wrap="square" lIns="0" tIns="0" rIns="0" bIns="0" rtlCol="0" anchor="ctr"/>
+          <a:lstStyle/>
+          <a:p>
+            <a:pPr algn="r" indent="0" marL="0">
+              <a:buNone/>
+            </a:pPr>
+            <a:r>
+              <a:rPr lang="en-US" sz="1000" b="1" dirty="0">
+                <a:solidFill>
+                  <a:srgbClr val="8DA0B8"/>
+                </a:solidFill>
+                <a:latin typeface="Graphik TH" pitchFamily="34" charset="0"/>
+                <a:ea typeface="Graphik TH" pitchFamily="34" charset="-122"/>
+                <a:cs typeface="Graphik TH" pitchFamily="34" charset="-120"/>
+              </a:rPr>
+              <a:t>1.0%</a:t>
+            </a:r>
+            <a:endParaRPr lang="en-US" sz="1000" dirty="0"/>
+          </a:p>
+        </p:txBody>
+      </p:sp>
+      <p:sp>
+        <p:nvSpPr>
+          <p:cNvPr id="70" name="Text 68"/>
+          <p:cNvSpPr/>
+          <p:nvPr/>
+        </p:nvSpPr>
+        <p:spPr>
+          <a:xfrm>
+            <a:off x="10469880" y="4681728"/>
+            <a:ext cx="1280160" cy="256032"/>
+          </a:xfrm>
+          <a:prstGeom prst="rect">
+            <a:avLst/>
+          </a:prstGeom>
+          <a:noFill/>
+          <a:ln/>
+        </p:spPr>
+        <p:txBody>
+          <a:bodyPr wrap="square" lIns="0" tIns="0" rIns="0" bIns="0" rtlCol="0" anchor="ctr"/>
+          <a:lstStyle/>
+          <a:p>
+            <a:pPr algn="r" indent="0" marL="0">
+              <a:buNone/>
+            </a:pPr>
+            <a:r>
+              <a:rPr lang="en-US" sz="900" dirty="0">
+                <a:solidFill>
+                  <a:srgbClr val="6B7A90"/>
+                </a:solidFill>
+                <a:latin typeface="Graphik TH" pitchFamily="34" charset="0"/>
+                <a:ea typeface="Graphik TH" pitchFamily="34" charset="-122"/>
+                <a:cs typeface="Graphik TH" pitchFamily="34" charset="-120"/>
+              </a:rPr>
+              <a:t>269 of 27,211</a:t>
+            </a:r>
+            <a:endParaRPr lang="en-US" sz="900" dirty="0"/>
+          </a:p>
+        </p:txBody>
+      </p:sp>
+      <p:sp>
+        <p:nvSpPr>
+          <p:cNvPr id="71" name="Text 69"/>
+          <p:cNvSpPr/>
+          <p:nvPr/>
+        </p:nvSpPr>
+        <p:spPr>
+          <a:xfrm>
+            <a:off x="6537960" y="4956048"/>
+            <a:ext cx="5010912" cy="164592"/>
+          </a:xfrm>
+          <a:prstGeom prst="rect">
+            <a:avLst/>
+          </a:prstGeom>
+          <a:noFill/>
+          <a:ln/>
+        </p:spPr>
+        <p:txBody>
+          <a:bodyPr wrap="square" lIns="0" tIns="0" rIns="0" bIns="0" rtlCol="0" anchor="ctr"/>
+          <a:lstStyle/>
+          <a:p>
+            <a:pPr indent="0" marL="0">
+              <a:buNone/>
+            </a:pPr>
+            <a:r>
+              <a:rPr lang="en-US" sz="850" i="1" dirty="0">
+                <a:solidFill>
+                  <a:srgbClr val="6B7A90"/>
+                </a:solidFill>
+                <a:latin typeface="Graphik TH" pitchFamily="34" charset="0"/>
+                <a:ea typeface="Graphik TH" pitchFamily="34" charset="-122"/>
+                <a:cs typeface="Graphik TH" pitchFamily="34" charset="-120"/>
+              </a:rPr>
+              <a:t>High is the mover band — Very High moves at barely a quarter of that rate.</a:t>
+            </a:r>
+            <a:endParaRPr lang="en-US" sz="850" dirty="0"/>
+          </a:p>
+        </p:txBody>
+      </p:sp>
+      <p:sp>
+        <p:nvSpPr>
+          <p:cNvPr id="72" name="Shape 70"/>
+          <p:cNvSpPr/>
+          <p:nvPr/>
+        </p:nvSpPr>
+        <p:spPr>
+          <a:xfrm>
+            <a:off x="530352" y="5285232"/>
+            <a:ext cx="11274552" cy="786384"/>
+          </a:xfrm>
+          <a:prstGeom prst="roundRect">
+            <a:avLst>
+              <a:gd name="adj" fmla="val 10465"/>
+            </a:avLst>
+          </a:prstGeom>
+          <a:solidFill>
+            <a:srgbClr val="E8F6F3"/>
+          </a:solidFill>
+          <a:ln/>
+        </p:spPr>
+      </p:sp>
+      <p:sp>
+        <p:nvSpPr>
+          <p:cNvPr id="73" name="Text 71"/>
+          <p:cNvSpPr/>
+          <p:nvPr/>
+        </p:nvSpPr>
+        <p:spPr>
+          <a:xfrm>
+            <a:off x="804672" y="5285232"/>
+            <a:ext cx="10725912" cy="786384"/>
+          </a:xfrm>
+          <a:prstGeom prst="rect">
+            <a:avLst/>
+          </a:prstGeom>
+          <a:noFill/>
+          <a:ln/>
+        </p:spPr>
+        <p:txBody>
+          <a:bodyPr wrap="square" lIns="0" tIns="0" rIns="0" bIns="0" rtlCol="0" anchor="ctr"/>
+          <a:lstStyle/>
+          <a:p>
+            <a:pPr indent="0" marL="0">
+              <a:buNone/>
+            </a:pPr>
+            <a:r>
+              <a:rPr lang="en-US" sz="1100" b="1" dirty="0">
+                <a:solidFill>
+                  <a:srgbClr val="045D66"/>
+                </a:solidFill>
+                <a:latin typeface="Graphik TH" pitchFamily="34" charset="0"/>
+                <a:ea typeface="Graphik TH" pitchFamily="34" charset="-122"/>
+                <a:cs typeface="Graphik TH" pitchFamily="34" charset="-120"/>
+              </a:rPr>
+              <a:t>Save Max lost THB 209m but the book gained THB 155m</a:t>
+            </a:r>
+            <a:pPr indent="0" marL="0">
+              <a:buNone/>
+            </a:pPr>
+            <a:r>
+              <a:rPr lang="en-US" sz="1100" dirty="0">
+                <a:solidFill>
+                  <a:srgbClr val="16233D"/>
+                </a:solidFill>
+                <a:latin typeface="Graphik TH" pitchFamily="34" charset="0"/>
+                <a:ea typeface="Graphik TH" pitchFamily="34" charset="-122"/>
+                <a:cs typeface="Graphik TH" pitchFamily="34" charset="-120"/>
+              </a:rPr>
+              <a:t>  —  the 6,781 customers who emptied Save Max took THB 129m out of the pocket, yet total deposits rose. Runoff from the promotional pocket is not the same as runoff from the bank.</a:t>
+            </a:r>
+            <a:endParaRPr lang="en-US" sz="1100" dirty="0"/>
+          </a:p>
+        </p:txBody>
+      </p:sp>
+    </p:spTree>
+  </p:cSld>
+  <p:clrMapOvr>
+    <a:masterClrMapping/>
+  </p:clrMapOvr>
+</p:sld>
+</file>
+
+<file path=ppt/slides/slide11.xml><?xml version="1.0" encoding="utf-8"?>
+<p:sld xmlns:a="http://schemas.openxmlformats.org/drawingml/2006/main" xmlns:r="http://schemas.openxmlformats.org/officeDocument/2006/relationships" xmlns:p="http://schemas.openxmlformats.org/presentationml/2006/main">
+  <p:cSld name="Slide 11">
+    <p:bg>
+      <p:bgPr>
+        <a:solidFill>
+          <a:srgbClr val="FFFFFF"/>
+        </a:solidFill>
+      </p:bgPr>
+    </p:bg>
+    <p:spTree>
+      <p:nvGrpSpPr>
+        <p:cNvPr id="1" name=""/>
+        <p:cNvGrpSpPr/>
+        <p:nvPr/>
+      </p:nvGrpSpPr>
+      <p:grpSpPr>
+        <a:xfrm>
+          <a:off x="0" y="0"/>
+          <a:ext cx="0" cy="0"/>
+          <a:chOff x="0" y="0"/>
+          <a:chExt cx="0" cy="0"/>
+        </a:xfrm>
+      </p:grpSpPr>
+      <p:sp>
+        <p:nvSpPr>
+          <p:cNvPr id="2" name="Text 0"/>
+          <p:cNvSpPr/>
+          <p:nvPr/>
+        </p:nvSpPr>
+        <p:spPr>
+          <a:xfrm>
+            <a:off x="530352" y="283464"/>
+            <a:ext cx="11274552" cy="384048"/>
+          </a:xfrm>
+          <a:prstGeom prst="rect">
+            <a:avLst/>
+          </a:prstGeom>
+          <a:noFill/>
+          <a:ln/>
+        </p:spPr>
+        <p:txBody>
+          <a:bodyPr wrap="square" lIns="0" tIns="0" rIns="0" bIns="0" rtlCol="0" anchor="ctr"/>
+          <a:lstStyle/>
+          <a:p>
+            <a:pPr indent="0" marL="0">
+              <a:buNone/>
+            </a:pPr>
+            <a:r>
+              <a:rPr lang="en-US" sz="2200" b="1" dirty="0">
+                <a:solidFill>
+                  <a:srgbClr val="045D66"/>
+                </a:solidFill>
+                <a:latin typeface="Graphik TH" pitchFamily="34" charset="0"/>
+                <a:ea typeface="Graphik TH" pitchFamily="34" charset="-122"/>
+                <a:cs typeface="Graphik TH" pitchFamily="34" charset="-120"/>
+              </a:rPr>
+              <a:t>The Save More flag decides whether the money stays</a:t>
+            </a:r>
+            <a:endParaRPr lang="en-US" sz="2200" dirty="0"/>
+          </a:p>
+        </p:txBody>
+      </p:sp>
+      <p:sp>
+        <p:nvSpPr>
+          <p:cNvPr id="3" name="Text 1"/>
+          <p:cNvSpPr/>
+          <p:nvPr/>
+        </p:nvSpPr>
+        <p:spPr>
+          <a:xfrm>
+            <a:off x="530352" y="713232"/>
+            <a:ext cx="11274552" cy="237744"/>
+          </a:xfrm>
+          <a:prstGeom prst="rect">
+            <a:avLst/>
+          </a:prstGeom>
+          <a:noFill/>
+          <a:ln/>
+        </p:spPr>
+        <p:txBody>
+          <a:bodyPr wrap="square" lIns="0" tIns="0" rIns="0" bIns="0" rtlCol="0" anchor="ctr"/>
+          <a:lstStyle/>
+          <a:p>
+            <a:pPr indent="0" marL="0">
+              <a:buNone/>
+            </a:pPr>
+            <a:r>
+              <a:rPr lang="en-US" sz="1150" i="1" dirty="0">
+                <a:solidFill>
+                  <a:srgbClr val="6B6B6B"/>
+                </a:solidFill>
+                <a:latin typeface="Graphik TH" pitchFamily="34" charset="0"/>
+                <a:ea typeface="Graphik TH" pitchFamily="34" charset="-122"/>
+                <a:cs typeface="Graphik TH" pitchFamily="34" charset="-120"/>
+              </a:rPr>
+              <a:t>*Balance retained = latest total deposit balance ÷ prior total deposit balance, for the same customers.</a:t>
+            </a:r>
+            <a:endParaRPr lang="en-US" sz="1150" dirty="0"/>
+          </a:p>
+        </p:txBody>
+      </p:sp>
+      <p:sp>
+        <p:nvSpPr>
+          <p:cNvPr id="4" name="Text 2"/>
+          <p:cNvSpPr/>
+          <p:nvPr/>
+        </p:nvSpPr>
+        <p:spPr>
+          <a:xfrm>
+            <a:off x="548640" y="996696"/>
+            <a:ext cx="11064240" cy="237744"/>
+          </a:xfrm>
+          <a:prstGeom prst="rect">
+            <a:avLst/>
+          </a:prstGeom>
+          <a:noFill/>
+          <a:ln/>
+        </p:spPr>
+        <p:txBody>
+          <a:bodyPr wrap="square" lIns="0" tIns="0" rIns="0" bIns="0" rtlCol="0" anchor="ctr"/>
+          <a:lstStyle/>
+          <a:p>
+            <a:pPr indent="0" marL="0">
+              <a:buNone/>
+            </a:pPr>
+            <a:r>
+              <a:rPr lang="en-US" sz="1300" b="1" dirty="0">
+                <a:solidFill>
+                  <a:srgbClr val="045D66"/>
+                </a:solidFill>
+                <a:latin typeface="Graphik TH" pitchFamily="34" charset="0"/>
+                <a:ea typeface="Graphik TH" pitchFamily="34" charset="-122"/>
+                <a:cs typeface="Graphik TH" pitchFamily="34" charset="-120"/>
+              </a:rPr>
+              <a:t>Movers 6,781   ·   With Save More 3,955 → +THB 87m (+8.9%)   ·   Without Save More 2,826 → −THB 41m (−73.6%)</a:t>
+            </a:r>
+            <a:endParaRPr lang="en-US" sz="1300" dirty="0"/>
+          </a:p>
+        </p:txBody>
+      </p:sp>
+      <p:sp>
+        <p:nvSpPr>
+          <p:cNvPr id="5" name="Text 3"/>
+          <p:cNvSpPr/>
+          <p:nvPr/>
+        </p:nvSpPr>
+        <p:spPr>
+          <a:xfrm>
+            <a:off x="548640" y="1280160"/>
+            <a:ext cx="11064240" cy="274320"/>
+          </a:xfrm>
+          <a:prstGeom prst="rect">
+            <a:avLst/>
+          </a:prstGeom>
+          <a:noFill/>
+          <a:ln/>
+        </p:spPr>
+        <p:txBody>
+          <a:bodyPr wrap="square" lIns="0" tIns="0" rIns="0" bIns="0" rtlCol="0" anchor="ctr"/>
+          <a:lstStyle/>
+          <a:p>
+            <a:pPr indent="0" marL="0">
+              <a:buNone/>
+            </a:pPr>
+            <a:r>
+              <a:rPr lang="en-US" sz="1400" dirty="0">
+                <a:solidFill>
+                  <a:srgbClr val="16233D"/>
+                </a:solidFill>
+                <a:latin typeface="Graphik TH" pitchFamily="34" charset="0"/>
+                <a:ea typeface="Graphik TH" pitchFamily="34" charset="-122"/>
+                <a:cs typeface="Graphik TH" pitchFamily="34" charset="-120"/>
+              </a:rPr>
+              <a:t>Among customers who emptied Save Max, holding Save More is the difference between growth and near-total runoff.</a:t>
+            </a:r>
+            <a:endParaRPr lang="en-US" sz="1400" dirty="0"/>
+          </a:p>
+        </p:txBody>
+      </p:sp>
+      <p:sp>
+        <p:nvSpPr>
+          <p:cNvPr id="6" name="Shape 4"/>
+          <p:cNvSpPr/>
+          <p:nvPr/>
+        </p:nvSpPr>
+        <p:spPr>
+          <a:xfrm>
+            <a:off x="530352" y="1645920"/>
+            <a:ext cx="2647188" cy="987552"/>
+          </a:xfrm>
+          <a:prstGeom prst="roundRect">
+            <a:avLst>
+              <a:gd name="adj" fmla="val 8333"/>
+            </a:avLst>
+          </a:prstGeom>
+          <a:solidFill>
+            <a:srgbClr val="F1F4F9"/>
+          </a:solidFill>
+          <a:ln/>
+        </p:spPr>
+      </p:sp>
+      <p:sp>
+        <p:nvSpPr>
+          <p:cNvPr id="7" name="Text 5"/>
+          <p:cNvSpPr/>
+          <p:nvPr/>
+        </p:nvSpPr>
+        <p:spPr>
+          <a:xfrm>
+            <a:off x="749808" y="1719072"/>
+            <a:ext cx="2208276" cy="402336"/>
+          </a:xfrm>
+          <a:prstGeom prst="rect">
+            <a:avLst/>
+          </a:prstGeom>
+          <a:noFill/>
+          <a:ln/>
+        </p:spPr>
+        <p:txBody>
+          <a:bodyPr wrap="square" lIns="0" tIns="0" rIns="0" bIns="0" rtlCol="0" anchor="ctr"/>
+          <a:lstStyle/>
+          <a:p>
+            <a:pPr indent="0" marL="0">
+              <a:buNone/>
+            </a:pPr>
+            <a:r>
+              <a:rPr lang="en-US" sz="2400" b="1" dirty="0">
+                <a:solidFill>
+                  <a:srgbClr val="00A896"/>
+                </a:solidFill>
+                <a:latin typeface="Graphik TH" pitchFamily="34" charset="0"/>
+                <a:ea typeface="Graphik TH" pitchFamily="34" charset="-122"/>
+                <a:cs typeface="Graphik TH" pitchFamily="34" charset="-120"/>
+              </a:rPr>
+              <a:t>3,955</a:t>
+            </a:r>
+            <a:endParaRPr lang="en-US" sz="2400" dirty="0"/>
+          </a:p>
+        </p:txBody>
+      </p:sp>
+      <p:sp>
+        <p:nvSpPr>
+          <p:cNvPr id="8" name="Text 6"/>
+          <p:cNvSpPr/>
+          <p:nvPr/>
+        </p:nvSpPr>
+        <p:spPr>
+          <a:xfrm>
+            <a:off x="749808" y="2121408"/>
+            <a:ext cx="2208276" cy="237744"/>
+          </a:xfrm>
+          <a:prstGeom prst="rect">
+            <a:avLst/>
+          </a:prstGeom>
+          <a:noFill/>
+          <a:ln/>
+        </p:spPr>
+        <p:txBody>
+          <a:bodyPr wrap="square" lIns="0" tIns="0" rIns="0" bIns="0" rtlCol="0" anchor="t"/>
+          <a:lstStyle/>
+          <a:p>
+            <a:pPr indent="0" marL="0">
+              <a:buNone/>
+            </a:pPr>
+            <a:r>
+              <a:rPr lang="en-US" sz="1150" b="1" dirty="0">
+                <a:solidFill>
+                  <a:srgbClr val="16233D"/>
+                </a:solidFill>
+                <a:latin typeface="Graphik TH" pitchFamily="34" charset="0"/>
+                <a:ea typeface="Graphik TH" pitchFamily="34" charset="-122"/>
+                <a:cs typeface="Graphik TH" pitchFamily="34" charset="-120"/>
+              </a:rPr>
+              <a:t>movers holding Save More</a:t>
+            </a:r>
+            <a:endParaRPr lang="en-US" sz="1150" dirty="0"/>
+          </a:p>
+        </p:txBody>
+      </p:sp>
+      <p:sp>
+        <p:nvSpPr>
+          <p:cNvPr id="9" name="Text 7"/>
+          <p:cNvSpPr/>
+          <p:nvPr/>
+        </p:nvSpPr>
+        <p:spPr>
+          <a:xfrm>
+            <a:off x="749808" y="2350008"/>
+            <a:ext cx="2208276" cy="237744"/>
+          </a:xfrm>
+          <a:prstGeom prst="rect">
+            <a:avLst/>
+          </a:prstGeom>
+          <a:noFill/>
+          <a:ln/>
+        </p:spPr>
+        <p:txBody>
+          <a:bodyPr wrap="square" lIns="0" tIns="0" rIns="0" bIns="0" rtlCol="0" anchor="t"/>
+          <a:lstStyle/>
+          <a:p>
+            <a:pPr indent="0" marL="0">
+              <a:buNone/>
+            </a:pPr>
+            <a:r>
+              <a:rPr lang="en-US" sz="950" dirty="0">
+                <a:solidFill>
+                  <a:srgbClr val="6B7A90"/>
+                </a:solidFill>
+                <a:latin typeface="Graphik TH" pitchFamily="34" charset="0"/>
+                <a:ea typeface="Graphik TH" pitchFamily="34" charset="-122"/>
+                <a:cs typeface="Graphik TH" pitchFamily="34" charset="-120"/>
+              </a:rPr>
+              <a:t>58% of all movers</a:t>
+            </a:r>
+            <a:endParaRPr lang="en-US" sz="950" dirty="0"/>
+          </a:p>
+        </p:txBody>
+      </p:sp>
+      <p:sp>
+        <p:nvSpPr>
+          <p:cNvPr id="10" name="Shape 8"/>
+          <p:cNvSpPr/>
+          <p:nvPr/>
+        </p:nvSpPr>
+        <p:spPr>
+          <a:xfrm>
+            <a:off x="3406140" y="1645920"/>
+            <a:ext cx="2647188" cy="987552"/>
+          </a:xfrm>
+          <a:prstGeom prst="roundRect">
+            <a:avLst>
+              <a:gd name="adj" fmla="val 8333"/>
+            </a:avLst>
+          </a:prstGeom>
+          <a:solidFill>
+            <a:srgbClr val="F1F4F9"/>
+          </a:solidFill>
+          <a:ln/>
+        </p:spPr>
+      </p:sp>
+      <p:sp>
+        <p:nvSpPr>
+          <p:cNvPr id="11" name="Text 9"/>
+          <p:cNvSpPr/>
+          <p:nvPr/>
+        </p:nvSpPr>
+        <p:spPr>
+          <a:xfrm>
+            <a:off x="3625596" y="1719072"/>
+            <a:ext cx="2208276" cy="402336"/>
+          </a:xfrm>
+          <a:prstGeom prst="rect">
+            <a:avLst/>
+          </a:prstGeom>
+          <a:noFill/>
+          <a:ln/>
+        </p:spPr>
+        <p:txBody>
+          <a:bodyPr wrap="square" lIns="0" tIns="0" rIns="0" bIns="0" rtlCol="0" anchor="ctr"/>
+          <a:lstStyle/>
+          <a:p>
+            <a:pPr indent="0" marL="0">
+              <a:buNone/>
+            </a:pPr>
+            <a:r>
+              <a:rPr lang="en-US" sz="2400" b="1" dirty="0">
+                <a:solidFill>
+                  <a:srgbClr val="00A896"/>
+                </a:solidFill>
+                <a:latin typeface="Graphik TH" pitchFamily="34" charset="0"/>
+                <a:ea typeface="Graphik TH" pitchFamily="34" charset="-122"/>
+                <a:cs typeface="Graphik TH" pitchFamily="34" charset="-120"/>
+              </a:rPr>
+              <a:t>109%</a:t>
+            </a:r>
+            <a:endParaRPr lang="en-US" sz="2400" dirty="0"/>
+          </a:p>
+        </p:txBody>
+      </p:sp>
+      <p:sp>
+        <p:nvSpPr>
+          <p:cNvPr id="12" name="Text 10"/>
+          <p:cNvSpPr/>
+          <p:nvPr/>
+        </p:nvSpPr>
+        <p:spPr>
+          <a:xfrm>
+            <a:off x="3625596" y="2121408"/>
+            <a:ext cx="2208276" cy="237744"/>
+          </a:xfrm>
+          <a:prstGeom prst="rect">
+            <a:avLst/>
+          </a:prstGeom>
+          <a:noFill/>
+          <a:ln/>
+        </p:spPr>
+        <p:txBody>
+          <a:bodyPr wrap="square" lIns="0" tIns="0" rIns="0" bIns="0" rtlCol="0" anchor="t"/>
+          <a:lstStyle/>
+          <a:p>
+            <a:pPr indent="0" marL="0">
+              <a:buNone/>
+            </a:pPr>
+            <a:r>
+              <a:rPr lang="en-US" sz="1150" b="1" dirty="0">
+                <a:solidFill>
+                  <a:srgbClr val="16233D"/>
+                </a:solidFill>
+                <a:latin typeface="Graphik TH" pitchFamily="34" charset="0"/>
+                <a:ea typeface="Graphik TH" pitchFamily="34" charset="-122"/>
+                <a:cs typeface="Graphik TH" pitchFamily="34" charset="-120"/>
+              </a:rPr>
+              <a:t>balance retained</a:t>
+            </a:r>
+            <a:endParaRPr lang="en-US" sz="1150" dirty="0"/>
+          </a:p>
+        </p:txBody>
+      </p:sp>
+      <p:sp>
+        <p:nvSpPr>
+          <p:cNvPr id="13" name="Text 11"/>
+          <p:cNvSpPr/>
+          <p:nvPr/>
+        </p:nvSpPr>
+        <p:spPr>
+          <a:xfrm>
+            <a:off x="3625596" y="2350008"/>
+            <a:ext cx="2208276" cy="237744"/>
+          </a:xfrm>
+          <a:prstGeom prst="rect">
+            <a:avLst/>
+          </a:prstGeom>
+          <a:noFill/>
+          <a:ln/>
+        </p:spPr>
+        <p:txBody>
+          <a:bodyPr wrap="square" lIns="0" tIns="0" rIns="0" bIns="0" rtlCol="0" anchor="t"/>
+          <a:lstStyle/>
+          <a:p>
+            <a:pPr indent="0" marL="0">
+              <a:buNone/>
+            </a:pPr>
+            <a:r>
+              <a:rPr lang="en-US" sz="950" dirty="0">
+                <a:solidFill>
+                  <a:srgbClr val="6B7A90"/>
+                </a:solidFill>
+                <a:latin typeface="Graphik TH" pitchFamily="34" charset="0"/>
+                <a:ea typeface="Graphik TH" pitchFamily="34" charset="-122"/>
+                <a:cs typeface="Graphik TH" pitchFamily="34" charset="-120"/>
+              </a:rPr>
+              <a:t>THB 979m → THB 1.07bn</a:t>
+            </a:r>
+            <a:endParaRPr lang="en-US" sz="950" dirty="0"/>
+          </a:p>
+        </p:txBody>
+      </p:sp>
+      <p:sp>
+        <p:nvSpPr>
+          <p:cNvPr id="14" name="Shape 12"/>
+          <p:cNvSpPr/>
+          <p:nvPr/>
+        </p:nvSpPr>
+        <p:spPr>
+          <a:xfrm>
+            <a:off x="6281928" y="1645920"/>
+            <a:ext cx="2647188" cy="987552"/>
+          </a:xfrm>
+          <a:prstGeom prst="roundRect">
+            <a:avLst>
+              <a:gd name="adj" fmla="val 8333"/>
+            </a:avLst>
+          </a:prstGeom>
+          <a:solidFill>
+            <a:srgbClr val="F1F4F9"/>
+          </a:solidFill>
+          <a:ln/>
+        </p:spPr>
+      </p:sp>
+      <p:sp>
+        <p:nvSpPr>
+          <p:cNvPr id="15" name="Text 13"/>
+          <p:cNvSpPr/>
+          <p:nvPr/>
+        </p:nvSpPr>
+        <p:spPr>
+          <a:xfrm>
+            <a:off x="6501384" y="1719072"/>
+            <a:ext cx="2208276" cy="402336"/>
+          </a:xfrm>
+          <a:prstGeom prst="rect">
+            <a:avLst/>
+          </a:prstGeom>
+          <a:noFill/>
+          <a:ln/>
+        </p:spPr>
+        <p:txBody>
+          <a:bodyPr wrap="square" lIns="0" tIns="0" rIns="0" bIns="0" rtlCol="0" anchor="ctr"/>
+          <a:lstStyle/>
+          <a:p>
+            <a:pPr indent="0" marL="0">
+              <a:buNone/>
+            </a:pPr>
+            <a:r>
+              <a:rPr lang="en-US" sz="2400" b="1" dirty="0">
+                <a:solidFill>
+                  <a:srgbClr val="C00000"/>
+                </a:solidFill>
+                <a:latin typeface="Graphik TH" pitchFamily="34" charset="0"/>
+                <a:ea typeface="Graphik TH" pitchFamily="34" charset="-122"/>
+                <a:cs typeface="Graphik TH" pitchFamily="34" charset="-120"/>
+              </a:rPr>
+              <a:t>2,826</a:t>
+            </a:r>
+            <a:endParaRPr lang="en-US" sz="2400" dirty="0"/>
+          </a:p>
+        </p:txBody>
+      </p:sp>
+      <p:sp>
+        <p:nvSpPr>
+          <p:cNvPr id="16" name="Text 14"/>
+          <p:cNvSpPr/>
+          <p:nvPr/>
+        </p:nvSpPr>
+        <p:spPr>
+          <a:xfrm>
+            <a:off x="6501384" y="2121408"/>
+            <a:ext cx="2208276" cy="237744"/>
+          </a:xfrm>
+          <a:prstGeom prst="rect">
+            <a:avLst/>
+          </a:prstGeom>
+          <a:noFill/>
+          <a:ln/>
+        </p:spPr>
+        <p:txBody>
+          <a:bodyPr wrap="square" lIns="0" tIns="0" rIns="0" bIns="0" rtlCol="0" anchor="t"/>
+          <a:lstStyle/>
+          <a:p>
+            <a:pPr indent="0" marL="0">
+              <a:buNone/>
+            </a:pPr>
+            <a:r>
+              <a:rPr lang="en-US" sz="1150" b="1" dirty="0">
+                <a:solidFill>
+                  <a:srgbClr val="16233D"/>
+                </a:solidFill>
+                <a:latin typeface="Graphik TH" pitchFamily="34" charset="0"/>
+                <a:ea typeface="Graphik TH" pitchFamily="34" charset="-122"/>
+                <a:cs typeface="Graphik TH" pitchFamily="34" charset="-120"/>
+              </a:rPr>
+              <a:t>movers without Save More</a:t>
+            </a:r>
+            <a:endParaRPr lang="en-US" sz="1150" dirty="0"/>
+          </a:p>
+        </p:txBody>
+      </p:sp>
+      <p:sp>
+        <p:nvSpPr>
+          <p:cNvPr id="17" name="Text 15"/>
+          <p:cNvSpPr/>
+          <p:nvPr/>
+        </p:nvSpPr>
+        <p:spPr>
+          <a:xfrm>
+            <a:off x="6501384" y="2350008"/>
+            <a:ext cx="2208276" cy="237744"/>
+          </a:xfrm>
+          <a:prstGeom prst="rect">
+            <a:avLst/>
+          </a:prstGeom>
+          <a:noFill/>
+          <a:ln/>
+        </p:spPr>
+        <p:txBody>
+          <a:bodyPr wrap="square" lIns="0" tIns="0" rIns="0" bIns="0" rtlCol="0" anchor="t"/>
+          <a:lstStyle/>
+          <a:p>
+            <a:pPr indent="0" marL="0">
+              <a:buNone/>
+            </a:pPr>
+            <a:r>
+              <a:rPr lang="en-US" sz="950" dirty="0">
+                <a:solidFill>
+                  <a:srgbClr val="6B7A90"/>
+                </a:solidFill>
+                <a:latin typeface="Graphik TH" pitchFamily="34" charset="0"/>
+                <a:ea typeface="Graphik TH" pitchFamily="34" charset="-122"/>
+                <a:cs typeface="Graphik TH" pitchFamily="34" charset="-120"/>
+              </a:rPr>
+              <a:t>42% of all movers</a:t>
+            </a:r>
+            <a:endParaRPr lang="en-US" sz="950" dirty="0"/>
+          </a:p>
+        </p:txBody>
+      </p:sp>
+      <p:sp>
+        <p:nvSpPr>
+          <p:cNvPr id="18" name="Shape 16"/>
+          <p:cNvSpPr/>
+          <p:nvPr/>
+        </p:nvSpPr>
+        <p:spPr>
+          <a:xfrm>
+            <a:off x="9157716" y="1645920"/>
+            <a:ext cx="2647188" cy="987552"/>
+          </a:xfrm>
+          <a:prstGeom prst="roundRect">
+            <a:avLst>
+              <a:gd name="adj" fmla="val 8333"/>
+            </a:avLst>
+          </a:prstGeom>
+          <a:solidFill>
+            <a:srgbClr val="F1F4F9"/>
+          </a:solidFill>
+          <a:ln/>
+        </p:spPr>
+      </p:sp>
+      <p:sp>
+        <p:nvSpPr>
+          <p:cNvPr id="19" name="Text 17"/>
+          <p:cNvSpPr/>
+          <p:nvPr/>
+        </p:nvSpPr>
+        <p:spPr>
+          <a:xfrm>
+            <a:off x="9377172" y="1719072"/>
+            <a:ext cx="2208276" cy="402336"/>
+          </a:xfrm>
+          <a:prstGeom prst="rect">
+            <a:avLst/>
+          </a:prstGeom>
+          <a:noFill/>
+          <a:ln/>
+        </p:spPr>
+        <p:txBody>
+          <a:bodyPr wrap="square" lIns="0" tIns="0" rIns="0" bIns="0" rtlCol="0" anchor="ctr"/>
+          <a:lstStyle/>
+          <a:p>
+            <a:pPr indent="0" marL="0">
+              <a:buNone/>
+            </a:pPr>
+            <a:r>
+              <a:rPr lang="en-US" sz="2400" b="1" dirty="0">
+                <a:solidFill>
+                  <a:srgbClr val="C00000"/>
+                </a:solidFill>
+                <a:latin typeface="Graphik TH" pitchFamily="34" charset="0"/>
+                <a:ea typeface="Graphik TH" pitchFamily="34" charset="-122"/>
+                <a:cs typeface="Graphik TH" pitchFamily="34" charset="-120"/>
+              </a:rPr>
+              <a:t>26%</a:t>
+            </a:r>
+            <a:endParaRPr lang="en-US" sz="2400" dirty="0"/>
+          </a:p>
+        </p:txBody>
+      </p:sp>
+      <p:sp>
+        <p:nvSpPr>
+          <p:cNvPr id="20" name="Text 18"/>
+          <p:cNvSpPr/>
+          <p:nvPr/>
+        </p:nvSpPr>
+        <p:spPr>
+          <a:xfrm>
+            <a:off x="9377172" y="2121408"/>
+            <a:ext cx="2208276" cy="237744"/>
+          </a:xfrm>
+          <a:prstGeom prst="rect">
+            <a:avLst/>
+          </a:prstGeom>
+          <a:noFill/>
+          <a:ln/>
+        </p:spPr>
+        <p:txBody>
+          <a:bodyPr wrap="square" lIns="0" tIns="0" rIns="0" bIns="0" rtlCol="0" anchor="t"/>
+          <a:lstStyle/>
+          <a:p>
+            <a:pPr indent="0" marL="0">
+              <a:buNone/>
+            </a:pPr>
+            <a:r>
+              <a:rPr lang="en-US" sz="1150" b="1" dirty="0">
+                <a:solidFill>
+                  <a:srgbClr val="16233D"/>
+                </a:solidFill>
+                <a:latin typeface="Graphik TH" pitchFamily="34" charset="0"/>
+                <a:ea typeface="Graphik TH" pitchFamily="34" charset="-122"/>
+                <a:cs typeface="Graphik TH" pitchFamily="34" charset="-120"/>
+              </a:rPr>
+              <a:t>balance retained</a:t>
+            </a:r>
+            <a:endParaRPr lang="en-US" sz="1150" dirty="0"/>
+          </a:p>
+        </p:txBody>
+      </p:sp>
+      <p:sp>
+        <p:nvSpPr>
+          <p:cNvPr id="21" name="Text 19"/>
+          <p:cNvSpPr/>
+          <p:nvPr/>
+        </p:nvSpPr>
+        <p:spPr>
+          <a:xfrm>
+            <a:off x="9377172" y="2350008"/>
+            <a:ext cx="2208276" cy="237744"/>
+          </a:xfrm>
+          <a:prstGeom prst="rect">
+            <a:avLst/>
+          </a:prstGeom>
+          <a:noFill/>
+          <a:ln/>
+        </p:spPr>
+        <p:txBody>
+          <a:bodyPr wrap="square" lIns="0" tIns="0" rIns="0" bIns="0" rtlCol="0" anchor="t"/>
+          <a:lstStyle/>
+          <a:p>
+            <a:pPr indent="0" marL="0">
+              <a:buNone/>
+            </a:pPr>
+            <a:r>
+              <a:rPr lang="en-US" sz="950" dirty="0">
+                <a:solidFill>
+                  <a:srgbClr val="6B7A90"/>
+                </a:solidFill>
+                <a:latin typeface="Graphik TH" pitchFamily="34" charset="0"/>
+                <a:ea typeface="Graphik TH" pitchFamily="34" charset="-122"/>
+                <a:cs typeface="Graphik TH" pitchFamily="34" charset="-120"/>
+              </a:rPr>
+              <a:t>THB 56m → THB 15m</a:t>
+            </a:r>
+            <a:endParaRPr lang="en-US" sz="950" dirty="0"/>
+          </a:p>
+        </p:txBody>
+      </p:sp>
+      <p:sp>
+        <p:nvSpPr>
+          <p:cNvPr id="22" name="Shape 20"/>
+          <p:cNvSpPr/>
+          <p:nvPr/>
+        </p:nvSpPr>
+        <p:spPr>
+          <a:xfrm>
+            <a:off x="530352" y="2798064"/>
+            <a:ext cx="5522976" cy="2322576"/>
+          </a:xfrm>
+          <a:prstGeom prst="roundRect">
+            <a:avLst>
+              <a:gd name="adj" fmla="val 3543"/>
+            </a:avLst>
+          </a:prstGeom>
+          <a:solidFill>
+            <a:srgbClr val="F1F4F9"/>
+          </a:solidFill>
+          <a:ln/>
+        </p:spPr>
+      </p:sp>
+      <p:sp>
+        <p:nvSpPr>
+          <p:cNvPr id="23" name="Text 21"/>
+          <p:cNvSpPr/>
+          <p:nvPr/>
+        </p:nvSpPr>
+        <p:spPr>
+          <a:xfrm>
+            <a:off x="786384" y="2944368"/>
+            <a:ext cx="5010912" cy="274320"/>
+          </a:xfrm>
+          <a:prstGeom prst="rect">
+            <a:avLst/>
+          </a:prstGeom>
+          <a:noFill/>
+          <a:ln/>
+        </p:spPr>
+        <p:txBody>
+          <a:bodyPr wrap="square" lIns="0" tIns="0" rIns="0" bIns="0" rtlCol="0" anchor="ctr"/>
+          <a:lstStyle/>
+          <a:p>
+            <a:pPr indent="0" marL="0">
+              <a:buNone/>
+            </a:pPr>
+            <a:r>
+              <a:rPr lang="en-US" sz="1400" b="1" dirty="0">
+                <a:solidFill>
+                  <a:srgbClr val="16233D"/>
+                </a:solidFill>
+                <a:latin typeface="Cambria" pitchFamily="34" charset="0"/>
+                <a:ea typeface="Cambria" pitchFamily="34" charset="-122"/>
+                <a:cs typeface="Cambria" pitchFamily="34" charset="-120"/>
+              </a:rPr>
+              <a:t>Balance retained after maturity</a:t>
+            </a:r>
+            <a:endParaRPr lang="en-US" sz="1400" dirty="0"/>
+          </a:p>
+        </p:txBody>
+      </p:sp>
+      <p:sp>
+        <p:nvSpPr>
+          <p:cNvPr id="24" name="Text 22"/>
+          <p:cNvSpPr/>
+          <p:nvPr/>
+        </p:nvSpPr>
+        <p:spPr>
+          <a:xfrm>
+            <a:off x="786384" y="3218688"/>
+            <a:ext cx="5010912" cy="237744"/>
+          </a:xfrm>
+          <a:prstGeom prst="rect">
+            <a:avLst/>
+          </a:prstGeom>
+          <a:noFill/>
+          <a:ln/>
+        </p:spPr>
+        <p:txBody>
+          <a:bodyPr wrap="square" lIns="0" tIns="0" rIns="0" bIns="0" rtlCol="0" anchor="ctr"/>
+          <a:lstStyle/>
+          <a:p>
+            <a:pPr indent="0" marL="0">
+              <a:buNone/>
+            </a:pPr>
+            <a:r>
+              <a:rPr lang="en-US" sz="950" dirty="0">
+                <a:solidFill>
+                  <a:srgbClr val="6B7A90"/>
+                </a:solidFill>
+                <a:latin typeface="Graphik TH" pitchFamily="34" charset="0"/>
+                <a:ea typeface="Graphik TH" pitchFamily="34" charset="-122"/>
+                <a:cs typeface="Graphik TH" pitchFamily="34" charset="-120"/>
+              </a:rPr>
+              <a:t>Latest ÷ prior total deposit balance · the rule marks 100%</a:t>
+            </a:r>
+            <a:endParaRPr lang="en-US" sz="950" dirty="0"/>
+          </a:p>
+        </p:txBody>
+      </p:sp>
+      <p:sp>
+        <p:nvSpPr>
+          <p:cNvPr id="25" name="Shape 23"/>
+          <p:cNvSpPr/>
+          <p:nvPr/>
+        </p:nvSpPr>
+        <p:spPr>
+          <a:xfrm>
+            <a:off x="4512148" y="3419856"/>
+            <a:ext cx="10973" cy="1499616"/>
+          </a:xfrm>
+          <a:prstGeom prst="rect">
+            <a:avLst/>
+          </a:prstGeom>
+          <a:solidFill>
+            <a:srgbClr val="6B7A90"/>
+          </a:solidFill>
+          <a:ln/>
+        </p:spPr>
+      </p:sp>
+      <p:sp>
+        <p:nvSpPr>
+          <p:cNvPr id="26" name="Text 24"/>
+          <p:cNvSpPr/>
+          <p:nvPr/>
+        </p:nvSpPr>
+        <p:spPr>
+          <a:xfrm>
+            <a:off x="786384" y="3474720"/>
+            <a:ext cx="1828800" cy="256032"/>
+          </a:xfrm>
+          <a:prstGeom prst="rect">
+            <a:avLst/>
+          </a:prstGeom>
+          <a:noFill/>
+          <a:ln/>
+        </p:spPr>
+        <p:txBody>
+          <a:bodyPr wrap="square" lIns="0" tIns="0" rIns="0" bIns="0" rtlCol="0" anchor="ctr"/>
+          <a:lstStyle/>
+          <a:p>
+            <a:pPr indent="0" marL="0">
+              <a:buNone/>
+            </a:pPr>
+            <a:r>
+              <a:rPr lang="en-US" sz="1000" dirty="0">
+                <a:solidFill>
+                  <a:srgbClr val="16233D"/>
+                </a:solidFill>
+                <a:latin typeface="Graphik TH" pitchFamily="34" charset="0"/>
+                <a:ea typeface="Graphik TH" pitchFamily="34" charset="-122"/>
+                <a:cs typeface="Graphik TH" pitchFamily="34" charset="-120"/>
+              </a:rPr>
+              <a:t>Moved  ·  holds Save More</a:t>
+            </a:r>
+            <a:endParaRPr lang="en-US" sz="1000" dirty="0"/>
+          </a:p>
+        </p:txBody>
+      </p:sp>
+      <p:sp>
+        <p:nvSpPr>
+          <p:cNvPr id="27" name="Shape 25"/>
+          <p:cNvSpPr/>
+          <p:nvPr/>
+        </p:nvSpPr>
+        <p:spPr>
+          <a:xfrm>
+            <a:off x="2724912" y="3520440"/>
+            <a:ext cx="1965960" cy="164592"/>
+          </a:xfrm>
+          <a:prstGeom prst="roundRect">
+            <a:avLst>
+              <a:gd name="adj" fmla="val 16667"/>
+            </a:avLst>
+          </a:prstGeom>
+          <a:solidFill>
+            <a:srgbClr val="E4E9F0"/>
+          </a:solidFill>
+          <a:ln/>
+        </p:spPr>
+      </p:sp>
+      <p:sp>
+        <p:nvSpPr>
+          <p:cNvPr id="28" name="Shape 26"/>
+          <p:cNvSpPr/>
+          <p:nvPr/>
+        </p:nvSpPr>
+        <p:spPr>
+          <a:xfrm>
+            <a:off x="2724912" y="3520440"/>
+            <a:ext cx="1945573" cy="164592"/>
+          </a:xfrm>
+          <a:prstGeom prst="roundRect">
+            <a:avLst>
+              <a:gd name="adj" fmla="val 16667"/>
+            </a:avLst>
+          </a:prstGeom>
+          <a:solidFill>
+            <a:srgbClr val="1E8E86"/>
+          </a:solidFill>
+          <a:ln/>
+        </p:spPr>
+      </p:sp>
+      <p:sp>
+        <p:nvSpPr>
+          <p:cNvPr id="29" name="Text 27"/>
+          <p:cNvSpPr/>
+          <p:nvPr/>
+        </p:nvSpPr>
+        <p:spPr>
+          <a:xfrm>
+            <a:off x="4782312" y="3474720"/>
+            <a:ext cx="1014984" cy="256032"/>
+          </a:xfrm>
+          <a:prstGeom prst="rect">
+            <a:avLst/>
+          </a:prstGeom>
+          <a:noFill/>
+          <a:ln/>
+        </p:spPr>
+        <p:txBody>
+          <a:bodyPr wrap="square" lIns="0" tIns="0" rIns="0" bIns="0" rtlCol="0" anchor="ctr"/>
+          <a:lstStyle/>
+          <a:p>
+            <a:pPr algn="r" indent="0" marL="0">
+              <a:buNone/>
+            </a:pPr>
+            <a:r>
+              <a:rPr lang="en-US" sz="1000" b="1" dirty="0">
+                <a:solidFill>
+                  <a:srgbClr val="1E8E86"/>
+                </a:solidFill>
+                <a:latin typeface="Graphik TH" pitchFamily="34" charset="0"/>
+                <a:ea typeface="Graphik TH" pitchFamily="34" charset="-122"/>
+                <a:cs typeface="Graphik TH" pitchFamily="34" charset="-120"/>
+              </a:rPr>
+              <a:t>108.9%</a:t>
+            </a:r>
+            <a:endParaRPr lang="en-US" sz="1000" dirty="0"/>
+          </a:p>
+        </p:txBody>
+      </p:sp>
+      <p:sp>
+        <p:nvSpPr>
+          <p:cNvPr id="30" name="Text 28"/>
+          <p:cNvSpPr/>
+          <p:nvPr/>
+        </p:nvSpPr>
+        <p:spPr>
+          <a:xfrm>
+            <a:off x="786384" y="3858768"/>
+            <a:ext cx="1828800" cy="256032"/>
+          </a:xfrm>
+          <a:prstGeom prst="rect">
+            <a:avLst/>
+          </a:prstGeom>
+          <a:noFill/>
+          <a:ln/>
+        </p:spPr>
+        <p:txBody>
+          <a:bodyPr wrap="square" lIns="0" tIns="0" rIns="0" bIns="0" rtlCol="0" anchor="ctr"/>
+          <a:lstStyle/>
+          <a:p>
+            <a:pPr indent="0" marL="0">
+              <a:buNone/>
+            </a:pPr>
+            <a:r>
+              <a:rPr lang="en-US" sz="1000" dirty="0">
+                <a:solidFill>
+                  <a:srgbClr val="16233D"/>
+                </a:solidFill>
+                <a:latin typeface="Graphik TH" pitchFamily="34" charset="0"/>
+                <a:ea typeface="Graphik TH" pitchFamily="34" charset="-122"/>
+                <a:cs typeface="Graphik TH" pitchFamily="34" charset="-120"/>
+              </a:rPr>
+              <a:t>Moved  ·  no Save More</a:t>
+            </a:r>
+            <a:endParaRPr lang="en-US" sz="1000" dirty="0"/>
+          </a:p>
+        </p:txBody>
+      </p:sp>
+      <p:sp>
+        <p:nvSpPr>
+          <p:cNvPr id="31" name="Shape 29"/>
+          <p:cNvSpPr/>
+          <p:nvPr/>
+        </p:nvSpPr>
+        <p:spPr>
+          <a:xfrm>
+            <a:off x="2724912" y="3904488"/>
+            <a:ext cx="1965960" cy="164592"/>
+          </a:xfrm>
+          <a:prstGeom prst="roundRect">
+            <a:avLst>
+              <a:gd name="adj" fmla="val 16667"/>
+            </a:avLst>
+          </a:prstGeom>
+          <a:solidFill>
+            <a:srgbClr val="E4E9F0"/>
+          </a:solidFill>
+          <a:ln/>
+        </p:spPr>
+      </p:sp>
+      <p:sp>
+        <p:nvSpPr>
+          <p:cNvPr id="32" name="Shape 30"/>
+          <p:cNvSpPr/>
+          <p:nvPr/>
+        </p:nvSpPr>
+        <p:spPr>
+          <a:xfrm>
+            <a:off x="2724912" y="3904488"/>
+            <a:ext cx="471733" cy="164592"/>
+          </a:xfrm>
+          <a:prstGeom prst="roundRect">
+            <a:avLst>
+              <a:gd name="adj" fmla="val 16667"/>
+            </a:avLst>
+          </a:prstGeom>
+          <a:solidFill>
+            <a:srgbClr val="C00000"/>
+          </a:solidFill>
+          <a:ln/>
+        </p:spPr>
+      </p:sp>
+      <p:sp>
+        <p:nvSpPr>
+          <p:cNvPr id="33" name="Text 31"/>
+          <p:cNvSpPr/>
+          <p:nvPr/>
+        </p:nvSpPr>
+        <p:spPr>
+          <a:xfrm>
+            <a:off x="4782312" y="3858768"/>
+            <a:ext cx="1014984" cy="256032"/>
+          </a:xfrm>
+          <a:prstGeom prst="rect">
+            <a:avLst/>
+          </a:prstGeom>
+          <a:noFill/>
+          <a:ln/>
+        </p:spPr>
+        <p:txBody>
+          <a:bodyPr wrap="square" lIns="0" tIns="0" rIns="0" bIns="0" rtlCol="0" anchor="ctr"/>
+          <a:lstStyle/>
+          <a:p>
+            <a:pPr algn="r" indent="0" marL="0">
+              <a:buNone/>
+            </a:pPr>
+            <a:r>
+              <a:rPr lang="en-US" sz="1000" b="1" dirty="0">
+                <a:solidFill>
+                  <a:srgbClr val="C00000"/>
+                </a:solidFill>
+                <a:latin typeface="Graphik TH" pitchFamily="34" charset="0"/>
+                <a:ea typeface="Graphik TH" pitchFamily="34" charset="-122"/>
+                <a:cs typeface="Graphik TH" pitchFamily="34" charset="-120"/>
+              </a:rPr>
+              <a:t>26.4%</a:t>
+            </a:r>
+            <a:endParaRPr lang="en-US" sz="1000" dirty="0"/>
+          </a:p>
+        </p:txBody>
+      </p:sp>
+      <p:sp>
+        <p:nvSpPr>
+          <p:cNvPr id="34" name="Text 32"/>
+          <p:cNvSpPr/>
+          <p:nvPr/>
+        </p:nvSpPr>
+        <p:spPr>
+          <a:xfrm>
+            <a:off x="786384" y="4242816"/>
+            <a:ext cx="1828800" cy="256032"/>
+          </a:xfrm>
+          <a:prstGeom prst="rect">
+            <a:avLst/>
+          </a:prstGeom>
+          <a:noFill/>
+          <a:ln/>
+        </p:spPr>
+        <p:txBody>
+          <a:bodyPr wrap="square" lIns="0" tIns="0" rIns="0" bIns="0" rtlCol="0" anchor="ctr"/>
+          <a:lstStyle/>
+          <a:p>
+            <a:pPr indent="0" marL="0">
+              <a:buNone/>
+            </a:pPr>
+            <a:r>
+              <a:rPr lang="en-US" sz="1000" dirty="0">
+                <a:solidFill>
+                  <a:srgbClr val="16233D"/>
+                </a:solidFill>
+                <a:latin typeface="Graphik TH" pitchFamily="34" charset="0"/>
+                <a:ea typeface="Graphik TH" pitchFamily="34" charset="-122"/>
+                <a:cs typeface="Graphik TH" pitchFamily="34" charset="-120"/>
+              </a:rPr>
+              <a:t>Stayed  ·  holds Save More</a:t>
+            </a:r>
+            <a:endParaRPr lang="en-US" sz="1000" dirty="0"/>
+          </a:p>
+        </p:txBody>
+      </p:sp>
+      <p:sp>
+        <p:nvSpPr>
+          <p:cNvPr id="35" name="Shape 33"/>
+          <p:cNvSpPr/>
+          <p:nvPr/>
+        </p:nvSpPr>
+        <p:spPr>
+          <a:xfrm>
+            <a:off x="2724912" y="4288536"/>
+            <a:ext cx="1965960" cy="164592"/>
+          </a:xfrm>
+          <a:prstGeom prst="roundRect">
+            <a:avLst>
+              <a:gd name="adj" fmla="val 16667"/>
+            </a:avLst>
+          </a:prstGeom>
+          <a:solidFill>
+            <a:srgbClr val="E4E9F0"/>
+          </a:solidFill>
+          <a:ln/>
+        </p:spPr>
+      </p:sp>
+      <p:sp>
+        <p:nvSpPr>
+          <p:cNvPr id="36" name="Shape 34"/>
+          <p:cNvSpPr/>
+          <p:nvPr/>
+        </p:nvSpPr>
+        <p:spPr>
+          <a:xfrm>
+            <a:off x="2724912" y="4288536"/>
+            <a:ext cx="1890007" cy="164592"/>
+          </a:xfrm>
+          <a:prstGeom prst="roundRect">
+            <a:avLst>
+              <a:gd name="adj" fmla="val 16667"/>
+            </a:avLst>
+          </a:prstGeom>
+          <a:solidFill>
+            <a:srgbClr val="1E8E86"/>
+          </a:solidFill>
+          <a:ln/>
+        </p:spPr>
+      </p:sp>
+      <p:sp>
+        <p:nvSpPr>
+          <p:cNvPr id="37" name="Text 35"/>
+          <p:cNvSpPr/>
+          <p:nvPr/>
+        </p:nvSpPr>
+        <p:spPr>
+          <a:xfrm>
+            <a:off x="4782312" y="4242816"/>
+            <a:ext cx="1014984" cy="256032"/>
+          </a:xfrm>
+          <a:prstGeom prst="rect">
+            <a:avLst/>
+          </a:prstGeom>
+          <a:noFill/>
+          <a:ln/>
+        </p:spPr>
+        <p:txBody>
+          <a:bodyPr wrap="square" lIns="0" tIns="0" rIns="0" bIns="0" rtlCol="0" anchor="ctr"/>
+          <a:lstStyle/>
+          <a:p>
+            <a:pPr algn="r" indent="0" marL="0">
+              <a:buNone/>
+            </a:pPr>
+            <a:r>
+              <a:rPr lang="en-US" sz="1000" b="1" dirty="0">
+                <a:solidFill>
+                  <a:srgbClr val="1E8E86"/>
+                </a:solidFill>
+                <a:latin typeface="Graphik TH" pitchFamily="34" charset="0"/>
+                <a:ea typeface="Graphik TH" pitchFamily="34" charset="-122"/>
+                <a:cs typeface="Graphik TH" pitchFamily="34" charset="-120"/>
+              </a:rPr>
+              <a:t>105.8%</a:t>
+            </a:r>
+            <a:endParaRPr lang="en-US" sz="1000" dirty="0"/>
+          </a:p>
+        </p:txBody>
+      </p:sp>
+      <p:sp>
+        <p:nvSpPr>
+          <p:cNvPr id="38" name="Text 36"/>
+          <p:cNvSpPr/>
+          <p:nvPr/>
+        </p:nvSpPr>
+        <p:spPr>
+          <a:xfrm>
+            <a:off x="786384" y="4626864"/>
+            <a:ext cx="1828800" cy="256032"/>
+          </a:xfrm>
+          <a:prstGeom prst="rect">
+            <a:avLst/>
+          </a:prstGeom>
+          <a:noFill/>
+          <a:ln/>
+        </p:spPr>
+        <p:txBody>
+          <a:bodyPr wrap="square" lIns="0" tIns="0" rIns="0" bIns="0" rtlCol="0" anchor="ctr"/>
+          <a:lstStyle/>
+          <a:p>
+            <a:pPr indent="0" marL="0">
+              <a:buNone/>
+            </a:pPr>
+            <a:r>
+              <a:rPr lang="en-US" sz="1000" dirty="0">
+                <a:solidFill>
+                  <a:srgbClr val="16233D"/>
+                </a:solidFill>
+                <a:latin typeface="Graphik TH" pitchFamily="34" charset="0"/>
+                <a:ea typeface="Graphik TH" pitchFamily="34" charset="-122"/>
+                <a:cs typeface="Graphik TH" pitchFamily="34" charset="-120"/>
+              </a:rPr>
+              <a:t>Stayed  ·  no Save More</a:t>
+            </a:r>
+            <a:endParaRPr lang="en-US" sz="1000" dirty="0"/>
+          </a:p>
+        </p:txBody>
+      </p:sp>
+      <p:sp>
+        <p:nvSpPr>
+          <p:cNvPr id="39" name="Shape 37"/>
+          <p:cNvSpPr/>
+          <p:nvPr/>
+        </p:nvSpPr>
+        <p:spPr>
+          <a:xfrm>
+            <a:off x="2724912" y="4672584"/>
+            <a:ext cx="1965960" cy="164592"/>
+          </a:xfrm>
+          <a:prstGeom prst="roundRect">
+            <a:avLst>
+              <a:gd name="adj" fmla="val 16667"/>
+            </a:avLst>
+          </a:prstGeom>
+          <a:solidFill>
+            <a:srgbClr val="E4E9F0"/>
+          </a:solidFill>
+          <a:ln/>
+        </p:spPr>
+      </p:sp>
+      <p:sp>
+        <p:nvSpPr>
+          <p:cNvPr id="40" name="Shape 38"/>
+          <p:cNvSpPr/>
+          <p:nvPr/>
+        </p:nvSpPr>
+        <p:spPr>
+          <a:xfrm>
+            <a:off x="2724912" y="4672584"/>
+            <a:ext cx="1754371" cy="164592"/>
+          </a:xfrm>
+          <a:prstGeom prst="roundRect">
+            <a:avLst>
+              <a:gd name="adj" fmla="val 16667"/>
+            </a:avLst>
+          </a:prstGeom>
+          <a:solidFill>
+            <a:srgbClr val="8DA0B8"/>
+          </a:solidFill>
+          <a:ln/>
+        </p:spPr>
+      </p:sp>
+      <p:sp>
+        <p:nvSpPr>
+          <p:cNvPr id="41" name="Text 39"/>
+          <p:cNvSpPr/>
+          <p:nvPr/>
+        </p:nvSpPr>
+        <p:spPr>
+          <a:xfrm>
+            <a:off x="4782312" y="4626864"/>
+            <a:ext cx="1014984" cy="256032"/>
+          </a:xfrm>
+          <a:prstGeom prst="rect">
+            <a:avLst/>
+          </a:prstGeom>
+          <a:noFill/>
+          <a:ln/>
+        </p:spPr>
+        <p:txBody>
+          <a:bodyPr wrap="square" lIns="0" tIns="0" rIns="0" bIns="0" rtlCol="0" anchor="ctr"/>
+          <a:lstStyle/>
+          <a:p>
+            <a:pPr algn="r" indent="0" marL="0">
+              <a:buNone/>
+            </a:pPr>
+            <a:r>
+              <a:rPr lang="en-US" sz="1000" b="1" dirty="0">
+                <a:solidFill>
+                  <a:srgbClr val="8DA0B8"/>
+                </a:solidFill>
+                <a:latin typeface="Graphik TH" pitchFamily="34" charset="0"/>
+                <a:ea typeface="Graphik TH" pitchFamily="34" charset="-122"/>
+                <a:cs typeface="Graphik TH" pitchFamily="34" charset="-120"/>
+              </a:rPr>
+              <a:t>98.2%</a:t>
+            </a:r>
+            <a:endParaRPr lang="en-US" sz="1000" dirty="0"/>
+          </a:p>
+        </p:txBody>
+      </p:sp>
+      <p:sp>
+        <p:nvSpPr>
+          <p:cNvPr id="42" name="Text 40"/>
+          <p:cNvSpPr/>
+          <p:nvPr/>
+        </p:nvSpPr>
+        <p:spPr>
+          <a:xfrm>
+            <a:off x="4237828" y="4937760"/>
+            <a:ext cx="548640" cy="164592"/>
+          </a:xfrm>
+          <a:prstGeom prst="rect">
+            <a:avLst/>
+          </a:prstGeom>
+          <a:noFill/>
+          <a:ln/>
+        </p:spPr>
+        <p:txBody>
+          <a:bodyPr wrap="square" lIns="0" tIns="0" rIns="0" bIns="0" rtlCol="0" anchor="ctr"/>
+          <a:lstStyle/>
+          <a:p>
+            <a:pPr algn="ctr" indent="0" marL="0">
+              <a:buNone/>
+            </a:pPr>
+            <a:r>
+              <a:rPr lang="en-US" sz="800" dirty="0">
+                <a:solidFill>
+                  <a:srgbClr val="6B7A90"/>
+                </a:solidFill>
+                <a:latin typeface="Graphik TH" pitchFamily="34" charset="0"/>
+                <a:ea typeface="Graphik TH" pitchFamily="34" charset="-122"/>
+                <a:cs typeface="Graphik TH" pitchFamily="34" charset="-120"/>
+              </a:rPr>
+              <a:t>100%</a:t>
+            </a:r>
+            <a:endParaRPr lang="en-US" sz="800" dirty="0"/>
+          </a:p>
+        </p:txBody>
+      </p:sp>
+      <p:sp>
+        <p:nvSpPr>
+          <p:cNvPr id="43" name="Shape 41"/>
+          <p:cNvSpPr/>
+          <p:nvPr/>
+        </p:nvSpPr>
+        <p:spPr>
+          <a:xfrm>
+            <a:off x="6281928" y="2798064"/>
+            <a:ext cx="5522976" cy="2322576"/>
+          </a:xfrm>
+          <a:prstGeom prst="roundRect">
+            <a:avLst>
+              <a:gd name="adj" fmla="val 3543"/>
+            </a:avLst>
+          </a:prstGeom>
+          <a:solidFill>
+            <a:srgbClr val="F1F4F9"/>
+          </a:solidFill>
+          <a:ln/>
+        </p:spPr>
+      </p:sp>
+      <p:sp>
+        <p:nvSpPr>
+          <p:cNvPr id="44" name="Text 42"/>
+          <p:cNvSpPr/>
+          <p:nvPr/>
+        </p:nvSpPr>
+        <p:spPr>
+          <a:xfrm>
+            <a:off x="6537960" y="2944368"/>
+            <a:ext cx="5010912" cy="274320"/>
+          </a:xfrm>
+          <a:prstGeom prst="rect">
+            <a:avLst/>
+          </a:prstGeom>
+          <a:noFill/>
+          <a:ln/>
+        </p:spPr>
+        <p:txBody>
+          <a:bodyPr wrap="square" lIns="0" tIns="0" rIns="0" bIns="0" rtlCol="0" anchor="ctr"/>
+          <a:lstStyle/>
+          <a:p>
+            <a:pPr indent="0" marL="0">
+              <a:buNone/>
+            </a:pPr>
+            <a:r>
+              <a:rPr lang="en-US" sz="1400" b="1" dirty="0">
+                <a:solidFill>
+                  <a:srgbClr val="16233D"/>
+                </a:solidFill>
+                <a:latin typeface="Cambria" pitchFamily="34" charset="0"/>
+                <a:ea typeface="Cambria" pitchFamily="34" charset="-122"/>
+                <a:cs typeface="Cambria" pitchFamily="34" charset="-120"/>
+              </a:rPr>
+              <a:t>Customers and balance change</a:t>
+            </a:r>
+            <a:endParaRPr lang="en-US" sz="1400" dirty="0"/>
+          </a:p>
+        </p:txBody>
+      </p:sp>
+      <p:sp>
+        <p:nvSpPr>
+          <p:cNvPr id="45" name="Text 43"/>
+          <p:cNvSpPr/>
+          <p:nvPr/>
+        </p:nvSpPr>
+        <p:spPr>
+          <a:xfrm>
+            <a:off x="6537960" y="3218688"/>
+            <a:ext cx="5010912" cy="237744"/>
+          </a:xfrm>
+          <a:prstGeom prst="rect">
+            <a:avLst/>
+          </a:prstGeom>
+          <a:noFill/>
+          <a:ln/>
+        </p:spPr>
+        <p:txBody>
+          <a:bodyPr wrap="square" lIns="0" tIns="0" rIns="0" bIns="0" rtlCol="0" anchor="ctr"/>
+          <a:lstStyle/>
+          <a:p>
+            <a:pPr indent="0" marL="0">
+              <a:buNone/>
+            </a:pPr>
+            <a:r>
+              <a:rPr lang="en-US" sz="950" dirty="0">
+                <a:solidFill>
+                  <a:srgbClr val="6B7A90"/>
+                </a:solidFill>
+                <a:latin typeface="Graphik TH" pitchFamily="34" charset="0"/>
+                <a:ea typeface="Graphik TH" pitchFamily="34" charset="-122"/>
+                <a:cs typeface="Graphik TH" pitchFamily="34" charset="-120"/>
+              </a:rPr>
+              <a:t>Rows: Save Max behaviour · columns: Save More holding</a:t>
+            </a:r>
+            <a:endParaRPr lang="en-US" sz="950" dirty="0"/>
+          </a:p>
+        </p:txBody>
+      </p:sp>
+      <p:graphicFrame>
+        <p:nvGraphicFramePr>
+          <p:cNvPr id="12" name="Table 0"/>
+          <p:cNvGraphicFramePr>
+            <a:graphicFrameLocks noGrp="1"/>
+          </p:cNvGraphicFramePr>
+          <p:nvPr>
+            <p:extLst>
+              <p:ext uri="{D42A27DB-BD31-4B8C-83A1-F6EECF244321}">
+                <p14:modId xmlns:p14="http://schemas.microsoft.com/office/powerpoint/2010/main" val="1579011935"/>
+              </p:ext>
+            </p:extLst>
+          </p:nvPr>
+        </p:nvGraphicFramePr>
+        <p:xfrm>
+          <a:off x="6501384" y="3438144"/>
+          <a:ext cx="5084064" cy="914400"/>
+        </p:xfrm>
+        <a:graphic>
+          <a:graphicData uri="http://schemas.openxmlformats.org/drawingml/2006/table">
+            <a:tbl>
+              <a:tblPr/>
+              <a:tblGrid>
+                <a:gridCol w="1463040"/>
+                <a:gridCol w="1810512"/>
+                <a:gridCol w="1810512"/>
+              </a:tblGrid>
+              <a:tr h="365760">
+                <a:tc>
+                  <a:txBody>
+                    <a:bodyPr/>
+                    <a:lstStyle/>
+                    <a:p>
+                      <a:pPr algn="l" indent="0" marL="0">
+                        <a:buNone/>
+                      </a:pPr>
+                      <a:r>
+                        <a:rPr lang="en-US" sz="900" b="1" dirty="0">
+                          <a:solidFill>
+                            <a:srgbClr val="FFFFFF"/>
+                          </a:solidFill>
+                          <a:latin typeface="Graphik TH" pitchFamily="34" charset="0"/>
+                          <a:ea typeface="Graphik TH" pitchFamily="34" charset="-122"/>
+                          <a:cs typeface="Graphik TH" pitchFamily="34" charset="-120"/>
+                        </a:rPr>
+                        <a:t>Save Max</a:t>
+                      </a:r>
+                      <a:endParaRPr lang="en-US" sz="900" dirty="0">
+                        <a:latin typeface="Graphik TH" charset="0"/>
+                        <a:ea typeface="Graphik TH" charset="0"/>
+                        <a:cs typeface="Graphik TH" charset="0"/>
+                      </a:endParaRPr>
+                    </a:p>
+                  </a:txBody>
+                  <a:tcPr marL="73152" marR="73152" marT="36576" marB="36576" anchor="ctr">
+                    <a:lnL w="6350" cap="flat" cmpd="sng" algn="ctr">
+                      <a:solidFill>
+                        <a:srgbClr val="D8DFE9"/>
+                      </a:solidFill>
+                      <a:prstDash val="solid"/>
+                      <a:round/>
+                      <a:headEnd type="none" w="med" len="med"/>
+                      <a:tailEnd type="none" w="med" len="med"/>
+                    </a:lnL>
+                    <a:lnR w="6350" cap="flat" cmpd="sng" algn="ctr">
+                      <a:solidFill>
+                        <a:srgbClr val="D8DFE9"/>
+                      </a:solidFill>
+                      <a:prstDash val="solid"/>
+                      <a:round/>
+                      <a:headEnd type="none" w="med" len="med"/>
+                      <a:tailEnd type="none" w="med" len="med"/>
+                    </a:lnR>
+                    <a:lnT w="6350" cap="flat" cmpd="sng" algn="ctr">
+                      <a:solidFill>
+                        <a:srgbClr val="D8DFE9"/>
+                      </a:solidFill>
+                      <a:prstDash val="solid"/>
+                      <a:round/>
+                      <a:headEnd type="none" w="med" len="med"/>
+                      <a:tailEnd type="none" w="med" len="med"/>
+                    </a:lnT>
+                    <a:lnB w="6350" cap="flat" cmpd="sng" algn="ctr">
+                      <a:solidFill>
+                        <a:srgbClr val="D8DFE9"/>
+                      </a:solidFill>
+                      <a:prstDash val="solid"/>
+                      <a:round/>
+                      <a:headEnd type="none" w="med" len="med"/>
+                      <a:tailEnd type="none" w="med" len="med"/>
+                    </a:lnB>
+                    <a:solidFill>
+                      <a:srgbClr val="045D66"/>
+                    </a:solidFill>
+                  </a:tcPr>
+                </a:tc>
+                <a:tc>
+                  <a:txBody>
+                    <a:bodyPr/>
+                    <a:lstStyle/>
+                    <a:p>
+                      <a:pPr algn="ctr" indent="0" marL="0">
+                        <a:buNone/>
+                      </a:pPr>
+                      <a:r>
+                        <a:rPr lang="en-US" sz="900" b="1" dirty="0">
+                          <a:solidFill>
+                            <a:srgbClr val="FFFFFF"/>
+                          </a:solidFill>
+                          <a:latin typeface="Graphik TH" pitchFamily="34" charset="0"/>
+                          <a:ea typeface="Graphik TH" pitchFamily="34" charset="-122"/>
+                          <a:cs typeface="Graphik TH" pitchFamily="34" charset="-120"/>
+                        </a:rPr>
+                        <a:t>Holds Save More</a:t>
+                      </a:r>
+                      <a:endParaRPr lang="en-US" sz="900" dirty="0">
+                        <a:latin typeface="Graphik TH" charset="0"/>
+                        <a:ea typeface="Graphik TH" charset="0"/>
+                        <a:cs typeface="Graphik TH" charset="0"/>
+                      </a:endParaRPr>
+                    </a:p>
+                  </a:txBody>
+                  <a:tcPr marL="73152" marR="73152" marT="36576" marB="36576" anchor="ctr">
+                    <a:lnL w="6350" cap="flat" cmpd="sng" algn="ctr">
+                      <a:solidFill>
+                        <a:srgbClr val="D8DFE9"/>
+                      </a:solidFill>
+                      <a:prstDash val="solid"/>
+                      <a:round/>
+                      <a:headEnd type="none" w="med" len="med"/>
+                      <a:tailEnd type="none" w="med" len="med"/>
+                    </a:lnL>
+                    <a:lnR w="6350" cap="flat" cmpd="sng" algn="ctr">
+                      <a:solidFill>
+                        <a:srgbClr val="D8DFE9"/>
+                      </a:solidFill>
+                      <a:prstDash val="solid"/>
+                      <a:round/>
+                      <a:headEnd type="none" w="med" len="med"/>
+                      <a:tailEnd type="none" w="med" len="med"/>
+                    </a:lnR>
+                    <a:lnT w="6350" cap="flat" cmpd="sng" algn="ctr">
+                      <a:solidFill>
+                        <a:srgbClr val="D8DFE9"/>
+                      </a:solidFill>
+                      <a:prstDash val="solid"/>
+                      <a:round/>
+                      <a:headEnd type="none" w="med" len="med"/>
+                      <a:tailEnd type="none" w="med" len="med"/>
+                    </a:lnT>
+                    <a:lnB w="6350" cap="flat" cmpd="sng" algn="ctr">
+                      <a:solidFill>
+                        <a:srgbClr val="D8DFE9"/>
+                      </a:solidFill>
+                      <a:prstDash val="solid"/>
+                      <a:round/>
+                      <a:headEnd type="none" w="med" len="med"/>
+                      <a:tailEnd type="none" w="med" len="med"/>
+                    </a:lnB>
+                    <a:solidFill>
+                      <a:srgbClr val="045D66"/>
+                    </a:solidFill>
+                  </a:tcPr>
+                </a:tc>
+                <a:tc>
+                  <a:txBody>
+                    <a:bodyPr/>
+                    <a:lstStyle/>
+                    <a:p>
+                      <a:pPr algn="ctr" indent="0" marL="0">
+                        <a:buNone/>
+                      </a:pPr>
+                      <a:r>
+                        <a:rPr lang="en-US" sz="900" b="1" dirty="0">
+                          <a:solidFill>
+                            <a:srgbClr val="FFFFFF"/>
+                          </a:solidFill>
+                          <a:latin typeface="Graphik TH" pitchFamily="34" charset="0"/>
+                          <a:ea typeface="Graphik TH" pitchFamily="34" charset="-122"/>
+                          <a:cs typeface="Graphik TH" pitchFamily="34" charset="-120"/>
+                        </a:rPr>
+                        <a:t>No Save More</a:t>
+                      </a:r>
+                      <a:endParaRPr lang="en-US" sz="900" dirty="0">
+                        <a:latin typeface="Graphik TH" charset="0"/>
+                        <a:ea typeface="Graphik TH" charset="0"/>
+                        <a:cs typeface="Graphik TH" charset="0"/>
+                      </a:endParaRPr>
+                    </a:p>
+                  </a:txBody>
+                  <a:tcPr marL="73152" marR="73152" marT="36576" marB="36576" anchor="ctr">
+                    <a:lnL w="6350" cap="flat" cmpd="sng" algn="ctr">
+                      <a:solidFill>
+                        <a:srgbClr val="D8DFE9"/>
+                      </a:solidFill>
+                      <a:prstDash val="solid"/>
+                      <a:round/>
+                      <a:headEnd type="none" w="med" len="med"/>
+                      <a:tailEnd type="none" w="med" len="med"/>
+                    </a:lnL>
+                    <a:lnR w="6350" cap="flat" cmpd="sng" algn="ctr">
+                      <a:solidFill>
+                        <a:srgbClr val="D8DFE9"/>
+                      </a:solidFill>
+                      <a:prstDash val="solid"/>
+                      <a:round/>
+                      <a:headEnd type="none" w="med" len="med"/>
+                      <a:tailEnd type="none" w="med" len="med"/>
+                    </a:lnR>
+                    <a:lnT w="6350" cap="flat" cmpd="sng" algn="ctr">
+                      <a:solidFill>
+                        <a:srgbClr val="D8DFE9"/>
+                      </a:solidFill>
+                      <a:prstDash val="solid"/>
+                      <a:round/>
+                      <a:headEnd type="none" w="med" len="med"/>
+                      <a:tailEnd type="none" w="med" len="med"/>
+                    </a:lnT>
+                    <a:lnB w="6350" cap="flat" cmpd="sng" algn="ctr">
+                      <a:solidFill>
+                        <a:srgbClr val="D8DFE9"/>
+                      </a:solidFill>
+                      <a:prstDash val="solid"/>
+                      <a:round/>
+                      <a:headEnd type="none" w="med" len="med"/>
+                      <a:tailEnd type="none" w="med" len="med"/>
+                    </a:lnB>
+                    <a:solidFill>
+                      <a:srgbClr val="045D66"/>
+                    </a:solidFill>
+                  </a:tcPr>
+                </a:tc>
+              </a:tr>
+              <a:tr h="365760">
+                <a:tc>
+                  <a:txBody>
+                    <a:bodyPr/>
+                    <a:lstStyle/>
+                    <a:p>
+                      <a:pPr algn="l" indent="0" marL="0">
+                        <a:buNone/>
+                      </a:pPr>
+                      <a:r>
+                        <a:rPr lang="en-US" sz="950" b="1" dirty="0">
+                          <a:solidFill>
+                            <a:srgbClr val="16233D"/>
+                          </a:solidFill>
+                          <a:latin typeface="Graphik TH" pitchFamily="34" charset="0"/>
+                          <a:ea typeface="Graphik TH" pitchFamily="34" charset="-122"/>
+                          <a:cs typeface="Graphik TH" pitchFamily="34" charset="-120"/>
+                        </a:rPr>
+                        <a:t>Moved out</a:t>
+                      </a:r>
+                      <a:endParaRPr lang="en-US" sz="950" dirty="0">
+                        <a:latin typeface="Graphik TH" charset="0"/>
+                        <a:ea typeface="Graphik TH" charset="0"/>
+                        <a:cs typeface="Graphik TH" charset="0"/>
+                      </a:endParaRPr>
+                    </a:p>
+                  </a:txBody>
+                  <a:tcPr marL="73152" marR="73152" marT="36576" marB="36576" anchor="ctr">
+                    <a:lnL w="6350" cap="flat" cmpd="sng" algn="ctr">
+                      <a:solidFill>
+                        <a:srgbClr val="D8DFE9"/>
+                      </a:solidFill>
+                      <a:prstDash val="solid"/>
+                      <a:round/>
+                      <a:headEnd type="none" w="med" len="med"/>
+                      <a:tailEnd type="none" w="med" len="med"/>
+                    </a:lnL>
+                    <a:lnR w="6350" cap="flat" cmpd="sng" algn="ctr">
+                      <a:solidFill>
+                        <a:srgbClr val="D8DFE9"/>
+                      </a:solidFill>
+                      <a:prstDash val="solid"/>
+                      <a:round/>
+                      <a:headEnd type="none" w="med" len="med"/>
+                      <a:tailEnd type="none" w="med" len="med"/>
+                    </a:lnR>
+                    <a:lnT w="6350" cap="flat" cmpd="sng" algn="ctr">
+                      <a:solidFill>
+                        <a:srgbClr val="D8DFE9"/>
+                      </a:solidFill>
+                      <a:prstDash val="solid"/>
+                      <a:round/>
+                      <a:headEnd type="none" w="med" len="med"/>
+                      <a:tailEnd type="none" w="med" len="med"/>
+                    </a:lnT>
+                    <a:lnB w="6350" cap="flat" cmpd="sng" algn="ctr">
+                      <a:solidFill>
+                        <a:srgbClr val="D8DFE9"/>
+                      </a:solidFill>
+                      <a:prstDash val="solid"/>
+                      <a:round/>
+                      <a:headEnd type="none" w="med" len="med"/>
+                      <a:tailEnd type="none" w="med" len="med"/>
+                    </a:lnB>
+                    <a:solidFill>
+                      <a:srgbClr val="F1F4F9"/>
+                    </a:solidFill>
+                  </a:tcPr>
+                </a:tc>
+                <a:tc>
+                  <a:txBody>
+                    <a:bodyPr/>
+                    <a:lstStyle/>
+                    <a:p>
+                      <a:pPr algn="ctr" indent="0" marL="0">
+                        <a:buNone/>
+                      </a:pPr>
+                      <a:r>
+                        <a:rPr lang="en-US" sz="950" dirty="0">
+                          <a:solidFill>
+                            <a:srgbClr val="16233D"/>
+                          </a:solidFill>
+                          <a:latin typeface="Graphik TH" pitchFamily="34" charset="0"/>
+                          <a:ea typeface="Graphik TH" pitchFamily="34" charset="-122"/>
+                          <a:cs typeface="Graphik TH" pitchFamily="34" charset="-120"/>
+                        </a:rPr>
+                        <a:t>3,955</a:t>
+                      </a:r>
+                      <a:endParaRPr lang="en-US" sz="950" dirty="0">
+                        <a:latin typeface="Graphik TH" charset="0"/>
+                        <a:ea typeface="Graphik TH" charset="0"/>
+                        <a:cs typeface="Graphik TH" charset="0"/>
+                      </a:endParaRPr>
+                    </a:p>
+                    <a:p>
+                      <a:pPr algn="ctr" indent="0" marL="0">
+                        <a:buNone/>
+                      </a:pPr>
+                      <a:r>
+                        <a:rPr lang="en-US" sz="950" dirty="0">
+                          <a:solidFill>
+                            <a:srgbClr val="16233D"/>
+                          </a:solidFill>
+                          <a:latin typeface="Graphik TH" pitchFamily="34" charset="0"/>
+                          <a:ea typeface="Graphik TH" pitchFamily="34" charset="-122"/>
+                          <a:cs typeface="Graphik TH" pitchFamily="34" charset="-120"/>
+                        </a:rPr>
+                        <a:t>+8.9%   +THB 87m</a:t>
+                      </a:r>
+                      <a:endParaRPr lang="en-US" sz="950" dirty="0">
+                        <a:latin typeface="Graphik TH" charset="0"/>
+                        <a:ea typeface="Graphik TH" charset="0"/>
+                        <a:cs typeface="Graphik TH" charset="0"/>
+                      </a:endParaRPr>
+                    </a:p>
+                  </a:txBody>
+                  <a:tcPr marL="73152" marR="73152" marT="36576" marB="36576" anchor="ctr">
+                    <a:lnL w="6350" cap="flat" cmpd="sng" algn="ctr">
+                      <a:solidFill>
+                        <a:srgbClr val="D8DFE9"/>
+                      </a:solidFill>
+                      <a:prstDash val="solid"/>
+                      <a:round/>
+                      <a:headEnd type="none" w="med" len="med"/>
+                      <a:tailEnd type="none" w="med" len="med"/>
+                    </a:lnL>
+                    <a:lnR w="6350" cap="flat" cmpd="sng" algn="ctr">
+                      <a:solidFill>
+                        <a:srgbClr val="D8DFE9"/>
+                      </a:solidFill>
+                      <a:prstDash val="solid"/>
+                      <a:round/>
+                      <a:headEnd type="none" w="med" len="med"/>
+                      <a:tailEnd type="none" w="med" len="med"/>
+                    </a:lnR>
+                    <a:lnT w="6350" cap="flat" cmpd="sng" algn="ctr">
+                      <a:solidFill>
+                        <a:srgbClr val="D8DFE9"/>
+                      </a:solidFill>
+                      <a:prstDash val="solid"/>
+                      <a:round/>
+                      <a:headEnd type="none" w="med" len="med"/>
+                      <a:tailEnd type="none" w="med" len="med"/>
+                    </a:lnT>
+                    <a:lnB w="6350" cap="flat" cmpd="sng" algn="ctr">
+                      <a:solidFill>
+                        <a:srgbClr val="D8DFE9"/>
+                      </a:solidFill>
+                      <a:prstDash val="solid"/>
+                      <a:round/>
+                      <a:headEnd type="none" w="med" len="med"/>
+                      <a:tailEnd type="none" w="med" len="med"/>
+                    </a:lnB>
+                    <a:solidFill>
+                      <a:srgbClr val="FFFFFF"/>
+                    </a:solidFill>
+                  </a:tcPr>
+                </a:tc>
+                <a:tc>
+                  <a:txBody>
+                    <a:bodyPr/>
+                    <a:lstStyle/>
+                    <a:p>
+                      <a:pPr algn="ctr" indent="0" marL="0">
+                        <a:buNone/>
+                      </a:pPr>
+                      <a:r>
+                        <a:rPr lang="en-US" sz="950" b="1" dirty="0">
+                          <a:solidFill>
+                            <a:srgbClr val="C00000"/>
+                          </a:solidFill>
+                          <a:latin typeface="Graphik TH" pitchFamily="34" charset="0"/>
+                          <a:ea typeface="Graphik TH" pitchFamily="34" charset="-122"/>
+                          <a:cs typeface="Graphik TH" pitchFamily="34" charset="-120"/>
+                        </a:rPr>
+                        <a:t>2,826</a:t>
+                      </a:r>
+                      <a:endParaRPr lang="en-US" sz="950" dirty="0">
+                        <a:latin typeface="Graphik TH" charset="0"/>
+                        <a:ea typeface="Graphik TH" charset="0"/>
+                        <a:cs typeface="Graphik TH" charset="0"/>
+                      </a:endParaRPr>
+                    </a:p>
+                    <a:p>
+                      <a:pPr algn="ctr" indent="0" marL="0">
+                        <a:buNone/>
+                      </a:pPr>
+                      <a:r>
+                        <a:rPr lang="en-US" sz="950" b="1" dirty="0">
+                          <a:solidFill>
+                            <a:srgbClr val="C00000"/>
+                          </a:solidFill>
+                          <a:latin typeface="Graphik TH" pitchFamily="34" charset="0"/>
+                          <a:ea typeface="Graphik TH" pitchFamily="34" charset="-122"/>
+                          <a:cs typeface="Graphik TH" pitchFamily="34" charset="-120"/>
+                        </a:rPr>
+                        <a:t>−73.6%   −THB 41m</a:t>
+                      </a:r>
+                      <a:endParaRPr lang="en-US" sz="950" dirty="0">
+                        <a:latin typeface="Graphik TH" charset="0"/>
+                        <a:ea typeface="Graphik TH" charset="0"/>
+                        <a:cs typeface="Graphik TH" charset="0"/>
+                      </a:endParaRPr>
+                    </a:p>
+                  </a:txBody>
+                  <a:tcPr marL="73152" marR="73152" marT="36576" marB="36576" anchor="ctr">
+                    <a:lnL w="6350" cap="flat" cmpd="sng" algn="ctr">
+                      <a:solidFill>
+                        <a:srgbClr val="D8DFE9"/>
+                      </a:solidFill>
+                      <a:prstDash val="solid"/>
+                      <a:round/>
+                      <a:headEnd type="none" w="med" len="med"/>
+                      <a:tailEnd type="none" w="med" len="med"/>
+                    </a:lnL>
+                    <a:lnR w="6350" cap="flat" cmpd="sng" algn="ctr">
+                      <a:solidFill>
+                        <a:srgbClr val="D8DFE9"/>
+                      </a:solidFill>
+                      <a:prstDash val="solid"/>
+                      <a:round/>
+                      <a:headEnd type="none" w="med" len="med"/>
+                      <a:tailEnd type="none" w="med" len="med"/>
+                    </a:lnR>
+                    <a:lnT w="6350" cap="flat" cmpd="sng" algn="ctr">
+                      <a:solidFill>
+                        <a:srgbClr val="D8DFE9"/>
+                      </a:solidFill>
+                      <a:prstDash val="solid"/>
+                      <a:round/>
+                      <a:headEnd type="none" w="med" len="med"/>
+                      <a:tailEnd type="none" w="med" len="med"/>
+                    </a:lnT>
+                    <a:lnB w="6350" cap="flat" cmpd="sng" algn="ctr">
+                      <a:solidFill>
+                        <a:srgbClr val="D8DFE9"/>
+                      </a:solidFill>
+                      <a:prstDash val="solid"/>
+                      <a:round/>
+                      <a:headEnd type="none" w="med" len="med"/>
+                      <a:tailEnd type="none" w="med" len="med"/>
+                    </a:lnB>
+                    <a:solidFill>
+                      <a:srgbClr val="F7DEDE"/>
+                    </a:solidFill>
+                  </a:tcPr>
+                </a:tc>
+              </a:tr>
+              <a:tr h="365760">
+                <a:tc>
+                  <a:txBody>
+                    <a:bodyPr/>
+                    <a:lstStyle/>
+                    <a:p>
+                      <a:pPr algn="l" indent="0" marL="0">
+                        <a:buNone/>
+                      </a:pPr>
+                      <a:r>
+                        <a:rPr lang="en-US" sz="950" b="1" dirty="0">
+                          <a:solidFill>
+                            <a:srgbClr val="16233D"/>
+                          </a:solidFill>
+                          <a:latin typeface="Graphik TH" pitchFamily="34" charset="0"/>
+                          <a:ea typeface="Graphik TH" pitchFamily="34" charset="-122"/>
+                          <a:cs typeface="Graphik TH" pitchFamily="34" charset="-120"/>
+                        </a:rPr>
+                        <a:t>Stayed</a:t>
+                      </a:r>
+                      <a:endParaRPr lang="en-US" sz="950" dirty="0">
+                        <a:latin typeface="Graphik TH" charset="0"/>
+                        <a:ea typeface="Graphik TH" charset="0"/>
+                        <a:cs typeface="Graphik TH" charset="0"/>
+                      </a:endParaRPr>
+                    </a:p>
+                  </a:txBody>
+                  <a:tcPr marL="73152" marR="73152" marT="36576" marB="36576" anchor="ctr">
+                    <a:lnL w="6350" cap="flat" cmpd="sng" algn="ctr">
+                      <a:solidFill>
+                        <a:srgbClr val="D8DFE9"/>
+                      </a:solidFill>
+                      <a:prstDash val="solid"/>
+                      <a:round/>
+                      <a:headEnd type="none" w="med" len="med"/>
+                      <a:tailEnd type="none" w="med" len="med"/>
+                    </a:lnL>
+                    <a:lnR w="6350" cap="flat" cmpd="sng" algn="ctr">
+                      <a:solidFill>
+                        <a:srgbClr val="D8DFE9"/>
+                      </a:solidFill>
+                      <a:prstDash val="solid"/>
+                      <a:round/>
+                      <a:headEnd type="none" w="med" len="med"/>
+                      <a:tailEnd type="none" w="med" len="med"/>
+                    </a:lnR>
+                    <a:lnT w="6350" cap="flat" cmpd="sng" algn="ctr">
+                      <a:solidFill>
+                        <a:srgbClr val="D8DFE9"/>
+                      </a:solidFill>
+                      <a:prstDash val="solid"/>
+                      <a:round/>
+                      <a:headEnd type="none" w="med" len="med"/>
+                      <a:tailEnd type="none" w="med" len="med"/>
+                    </a:lnT>
+                    <a:lnB w="6350" cap="flat" cmpd="sng" algn="ctr">
+                      <a:solidFill>
+                        <a:srgbClr val="D8DFE9"/>
+                      </a:solidFill>
+                      <a:prstDash val="solid"/>
+                      <a:round/>
+                      <a:headEnd type="none" w="med" len="med"/>
+                      <a:tailEnd type="none" w="med" len="med"/>
+                    </a:lnB>
+                    <a:solidFill>
+                      <a:srgbClr val="F1F4F9"/>
+                    </a:solidFill>
+                  </a:tcPr>
+                </a:tc>
+                <a:tc>
+                  <a:txBody>
+                    <a:bodyPr/>
+                    <a:lstStyle/>
+                    <a:p>
+                      <a:pPr algn="ctr" indent="0" marL="0">
+                        <a:buNone/>
+                      </a:pPr>
+                      <a:r>
+                        <a:rPr lang="en-US" sz="950" dirty="0">
+                          <a:solidFill>
+                            <a:srgbClr val="16233D"/>
+                          </a:solidFill>
+                          <a:latin typeface="Graphik TH" pitchFamily="34" charset="0"/>
+                          <a:ea typeface="Graphik TH" pitchFamily="34" charset="-122"/>
+                          <a:cs typeface="Graphik TH" pitchFamily="34" charset="-120"/>
+                        </a:rPr>
+                        <a:t>8,658</a:t>
+                      </a:r>
+                      <a:endParaRPr lang="en-US" sz="950" dirty="0">
+                        <a:latin typeface="Graphik TH" charset="0"/>
+                        <a:ea typeface="Graphik TH" charset="0"/>
+                        <a:cs typeface="Graphik TH" charset="0"/>
+                      </a:endParaRPr>
+                    </a:p>
+                    <a:p>
+                      <a:pPr algn="ctr" indent="0" marL="0">
+                        <a:buNone/>
+                      </a:pPr>
+                      <a:r>
+                        <a:rPr lang="en-US" sz="950" dirty="0">
+                          <a:solidFill>
+                            <a:srgbClr val="16233D"/>
+                          </a:solidFill>
+                          <a:latin typeface="Graphik TH" pitchFamily="34" charset="0"/>
+                          <a:ea typeface="Graphik TH" pitchFamily="34" charset="-122"/>
+                          <a:cs typeface="Graphik TH" pitchFamily="34" charset="-120"/>
+                        </a:rPr>
+                        <a:t>+5.8%   +THB 126m</a:t>
+                      </a:r>
+                      <a:endParaRPr lang="en-US" sz="950" dirty="0">
+                        <a:latin typeface="Graphik TH" charset="0"/>
+                        <a:ea typeface="Graphik TH" charset="0"/>
+                        <a:cs typeface="Graphik TH" charset="0"/>
+                      </a:endParaRPr>
+                    </a:p>
+                  </a:txBody>
+                  <a:tcPr marL="73152" marR="73152" marT="36576" marB="36576" anchor="ctr">
+                    <a:lnL w="6350" cap="flat" cmpd="sng" algn="ctr">
+                      <a:solidFill>
+                        <a:srgbClr val="D8DFE9"/>
+                      </a:solidFill>
+                      <a:prstDash val="solid"/>
+                      <a:round/>
+                      <a:headEnd type="none" w="med" len="med"/>
+                      <a:tailEnd type="none" w="med" len="med"/>
+                    </a:lnL>
+                    <a:lnR w="6350" cap="flat" cmpd="sng" algn="ctr">
+                      <a:solidFill>
+                        <a:srgbClr val="D8DFE9"/>
+                      </a:solidFill>
+                      <a:prstDash val="solid"/>
+                      <a:round/>
+                      <a:headEnd type="none" w="med" len="med"/>
+                      <a:tailEnd type="none" w="med" len="med"/>
+                    </a:lnR>
+                    <a:lnT w="6350" cap="flat" cmpd="sng" algn="ctr">
+                      <a:solidFill>
+                        <a:srgbClr val="D8DFE9"/>
+                      </a:solidFill>
+                      <a:prstDash val="solid"/>
+                      <a:round/>
+                      <a:headEnd type="none" w="med" len="med"/>
+                      <a:tailEnd type="none" w="med" len="med"/>
+                    </a:lnT>
+                    <a:lnB w="6350" cap="flat" cmpd="sng" algn="ctr">
+                      <a:solidFill>
+                        <a:srgbClr val="D8DFE9"/>
+                      </a:solidFill>
+                      <a:prstDash val="solid"/>
+                      <a:round/>
+                      <a:headEnd type="none" w="med" len="med"/>
+                      <a:tailEnd type="none" w="med" len="med"/>
+                    </a:lnB>
+                    <a:solidFill>
+                      <a:srgbClr val="FFFFFF"/>
+                    </a:solidFill>
+                  </a:tcPr>
+                </a:tc>
+                <a:tc>
+                  <a:txBody>
+                    <a:bodyPr/>
+                    <a:lstStyle/>
+                    <a:p>
+                      <a:pPr algn="ctr" indent="0" marL="0">
+                        <a:buNone/>
+                      </a:pPr>
+                      <a:r>
+                        <a:rPr lang="en-US" sz="950" dirty="0">
+                          <a:solidFill>
+                            <a:srgbClr val="16233D"/>
+                          </a:solidFill>
+                          <a:latin typeface="Graphik TH" pitchFamily="34" charset="0"/>
+                          <a:ea typeface="Graphik TH" pitchFamily="34" charset="-122"/>
+                          <a:cs typeface="Graphik TH" pitchFamily="34" charset="-120"/>
+                        </a:rPr>
+                        <a:t>57,435</a:t>
+                      </a:r>
+                      <a:endParaRPr lang="en-US" sz="950" dirty="0">
+                        <a:latin typeface="Graphik TH" charset="0"/>
+                        <a:ea typeface="Graphik TH" charset="0"/>
+                        <a:cs typeface="Graphik TH" charset="0"/>
+                      </a:endParaRPr>
+                    </a:p>
+                    <a:p>
+                      <a:pPr algn="ctr" indent="0" marL="0">
+                        <a:buNone/>
+                      </a:pPr>
+                      <a:r>
+                        <a:rPr lang="en-US" sz="950" dirty="0">
+                          <a:solidFill>
+                            <a:srgbClr val="16233D"/>
+                          </a:solidFill>
+                          <a:latin typeface="Graphik TH" pitchFamily="34" charset="0"/>
+                          <a:ea typeface="Graphik TH" pitchFamily="34" charset="-122"/>
+                          <a:cs typeface="Graphik TH" pitchFamily="34" charset="-120"/>
+                        </a:rPr>
+                        <a:t>−1.8%   −THB 17m</a:t>
+                      </a:r>
+                      <a:endParaRPr lang="en-US" sz="950" dirty="0">
+                        <a:latin typeface="Graphik TH" charset="0"/>
+                        <a:ea typeface="Graphik TH" charset="0"/>
+                        <a:cs typeface="Graphik TH" charset="0"/>
+                      </a:endParaRPr>
+                    </a:p>
+                  </a:txBody>
+                  <a:tcPr marL="73152" marR="73152" marT="36576" marB="36576" anchor="ctr">
+                    <a:lnL w="6350" cap="flat" cmpd="sng" algn="ctr">
+                      <a:solidFill>
+                        <a:srgbClr val="D8DFE9"/>
+                      </a:solidFill>
+                      <a:prstDash val="solid"/>
+                      <a:round/>
+                      <a:headEnd type="none" w="med" len="med"/>
+                      <a:tailEnd type="none" w="med" len="med"/>
+                    </a:lnL>
+                    <a:lnR w="6350" cap="flat" cmpd="sng" algn="ctr">
+                      <a:solidFill>
+                        <a:srgbClr val="D8DFE9"/>
+                      </a:solidFill>
+                      <a:prstDash val="solid"/>
+                      <a:round/>
+                      <a:headEnd type="none" w="med" len="med"/>
+                      <a:tailEnd type="none" w="med" len="med"/>
+                    </a:lnR>
+                    <a:lnT w="6350" cap="flat" cmpd="sng" algn="ctr">
+                      <a:solidFill>
+                        <a:srgbClr val="D8DFE9"/>
+                      </a:solidFill>
+                      <a:prstDash val="solid"/>
+                      <a:round/>
+                      <a:headEnd type="none" w="med" len="med"/>
+                      <a:tailEnd type="none" w="med" len="med"/>
+                    </a:lnT>
+                    <a:lnB w="6350" cap="flat" cmpd="sng" algn="ctr">
+                      <a:solidFill>
+                        <a:srgbClr val="D8DFE9"/>
+                      </a:solidFill>
+                      <a:prstDash val="solid"/>
+                      <a:round/>
+                      <a:headEnd type="none" w="med" len="med"/>
+                      <a:tailEnd type="none" w="med" len="med"/>
+                    </a:lnB>
+                    <a:solidFill>
+                      <a:srgbClr val="FFFFFF"/>
+                    </a:solidFill>
+                  </a:tcPr>
+                </a:tc>
+              </a:tr>
+            </a:tbl>
+          </a:graphicData>
+        </a:graphic>
+      </p:graphicFrame>
+      <p:sp>
+        <p:nvSpPr>
+          <p:cNvPr id="47" name="Text 44"/>
+          <p:cNvSpPr/>
+          <p:nvPr/>
+        </p:nvSpPr>
+        <p:spPr>
+          <a:xfrm>
+            <a:off x="6537960" y="4626864"/>
+            <a:ext cx="5010912" cy="402336"/>
+          </a:xfrm>
+          <a:prstGeom prst="rect">
+            <a:avLst/>
+          </a:prstGeom>
+          <a:noFill/>
+          <a:ln/>
+        </p:spPr>
+        <p:txBody>
+          <a:bodyPr wrap="square" lIns="0" tIns="0" rIns="0" bIns="0" rtlCol="0" anchor="t"/>
+          <a:lstStyle/>
+          <a:p>
+            <a:pPr indent="0" marL="0">
+              <a:buNone/>
+            </a:pPr>
+            <a:r>
+              <a:rPr lang="en-US" sz="950" dirty="0">
+                <a:solidFill>
+                  <a:srgbClr val="16233D"/>
+                </a:solidFill>
+                <a:latin typeface="Graphik TH" pitchFamily="34" charset="0"/>
+                <a:ea typeface="Graphik TH" pitchFamily="34" charset="-122"/>
+                <a:cs typeface="Graphik TH" pitchFamily="34" charset="-120"/>
+              </a:rPr>
+              <a:t>Save More holders move 31.4% of the time against 4.7% — they move far more often, but into the next pocket rather than out of the bank.</a:t>
+            </a:r>
+            <a:endParaRPr lang="en-US" sz="950" dirty="0"/>
+          </a:p>
+        </p:txBody>
+      </p:sp>
+      <p:sp>
+        <p:nvSpPr>
+          <p:cNvPr id="48" name="Shape 45"/>
+          <p:cNvSpPr/>
+          <p:nvPr/>
+        </p:nvSpPr>
+        <p:spPr>
+          <a:xfrm>
+            <a:off x="530352" y="5285232"/>
+            <a:ext cx="11274552" cy="786384"/>
+          </a:xfrm>
+          <a:prstGeom prst="roundRect">
+            <a:avLst>
+              <a:gd name="adj" fmla="val 10465"/>
+            </a:avLst>
+          </a:prstGeom>
+          <a:solidFill>
+            <a:srgbClr val="FBF0E6"/>
+          </a:solidFill>
+          <a:ln/>
+        </p:spPr>
+      </p:sp>
+      <p:sp>
+        <p:nvSpPr>
+          <p:cNvPr id="49" name="Text 46"/>
+          <p:cNvSpPr/>
+          <p:nvPr/>
+        </p:nvSpPr>
+        <p:spPr>
+          <a:xfrm>
+            <a:off x="804672" y="5285232"/>
+            <a:ext cx="10725912" cy="786384"/>
+          </a:xfrm>
+          <a:prstGeom prst="rect">
+            <a:avLst/>
+          </a:prstGeom>
+          <a:noFill/>
+          <a:ln/>
+        </p:spPr>
+        <p:txBody>
+          <a:bodyPr wrap="square" lIns="0" tIns="0" rIns="0" bIns="0" rtlCol="0" anchor="ctr"/>
+          <a:lstStyle/>
+          <a:p>
+            <a:pPr indent="0" marL="0">
+              <a:buNone/>
+            </a:pPr>
+            <a:r>
+              <a:rPr lang="en-US" sz="1100" b="1" dirty="0">
+                <a:solidFill>
+                  <a:srgbClr val="C00000"/>
+                </a:solidFill>
+                <a:latin typeface="Graphik TH" pitchFamily="34" charset="0"/>
+                <a:ea typeface="Graphik TH" pitchFamily="34" charset="-122"/>
+                <a:cs typeface="Graphik TH" pitchFamily="34" charset="-120"/>
+              </a:rPr>
+              <a:t>The 2,826 movers with no Save More kept only 26% of their balance</a:t>
+            </a:r>
+            <a:pPr indent="0" marL="0">
+              <a:buNone/>
+            </a:pPr>
+            <a:r>
+              <a:rPr lang="en-US" sz="1100" dirty="0">
+                <a:solidFill>
+                  <a:srgbClr val="16233D"/>
+                </a:solidFill>
+                <a:latin typeface="Graphik TH" pitchFamily="34" charset="0"/>
+                <a:ea typeface="Graphik TH" pitchFamily="34" charset="-122"/>
+                <a:cs typeface="Graphik TH" pitchFamily="34" charset="-120"/>
+              </a:rPr>
+              <a:t>  —  −THB 41m gone. The same behaviour with a Save More holding grew +8.9%. Cross-holding, not the stickiness score, is what converts a maturing promotion into retained deposits.</a:t>
+            </a:r>
+            <a:endParaRPr lang="en-US" sz="1100" dirty="0"/>
+          </a:p>
+        </p:txBody>
+      </p:sp>
+    </p:spTree>
+  </p:cSld>
+  <p:clrMapOvr>
+    <a:masterClrMapping/>
+  </p:clrMapOvr>
+</p:sld>
+</file>
+
 <file path=ppt/slides/slide2.xml><?xml version="1.0" encoding="utf-8"?>
 <p:sld xmlns:a="http://schemas.openxmlformats.org/drawingml/2006/main" xmlns:r="http://schemas.openxmlformats.org/officeDocument/2006/relationships" xmlns:p="http://schemas.openxmlformats.org/presentationml/2006/main">
   <p:cSld name="Slide 2">

</xml_diff>

<commit_message>
Refresh Save Max maturity figures with the revised extract
Balances are materially lower across the board and three segment counts
moved by one or two customers. Every figure on both maturity slides is
aggregated from the TSV, so the headline, tiles, bars, 2x2 and speaker
notes all follow: Save Max now -THB 189m (-27.6%) against total balance
+THB 117m (+3.9%), and mover retention 108.8% with Save More against
27.1% without.

Move rates by rate-sensitivity segment are unchanged to one decimal, so
the non-monotonic ranking still holds.

Co-Authored-By: Claude Opus 5 <noreply@anthropic.com>
Claude-Session: https://claude.ai/code/session_01VKpfo226Go9vQJYa4eoC1d
</commit_message>
<xml_diff>
--- a/Deposit_Stickiness_Framework.pptx
+++ b/Deposit_Stickiness_Framework.pptx
@@ -600,7 +600,7 @@
           <a:p>
             <a:r>
               <a:rPr lang="en-US" dirty="0"/>
-              <a:t>Cohort: 72,874 customers holding Save Max in the prior period. 6,781 of them (9.3%) now show zero Save Max balance. Save Max fell from THB 992,865,806 to THB 784,226,953, down 21.0%, of which THB 128,954,934 came from movers zeroing out and THB 79,683,919 from non-movers trimming. Total deposit balance nevertheless rose from THB 4,128,011,139 to THB 4,282,985,037, up 3.8%. Save Max fell from 24.1% to 18.3% of the book. Move rate is not monotonic in rate sensitivity: the High band moves at 49.5% against 12.8% for Very High, so the current cut-offs do not rank runoff risk correctly and should be recalibrated on this outcome.</a:t>
+              <a:t>Cohort: 72,870 customers holding Save Max in the prior period. 6,777 of them (9.3%) now show zero Save Max balance. Save Max fell from THB 685,023,127 to THB 495,681,749, down 27.6%, of which THB 123,073,643 came from movers zeroing out and THB 66,267,735 from non-movers trimming. Total deposit balance nevertheless rose from THB 2,966,348,100 to THB 3,083,304,918, up 3.9%. Save Max fell from 23.1% to 16.1% of the book. Move rate is not monotonic in rate sensitivity: the High band moves at 49.5% against 12.8% for Very High, so the current cut-offs do not rank runoff risk correctly and should be recalibrated on this outcome.</a:t>
             </a:r>
             <a:endParaRPr lang="en-US" dirty="0"/>
           </a:p>
@@ -688,7 +688,7 @@
           <a:p>
             <a:r>
               <a:rPr lang="en-US" dirty="0"/>
-              <a:t>Movers split sharply on the Save More flag. With Save More: 3,955 customers, THB 978,749,019 → THB 1,065,459,593, 108.9% retained. Without: 2,826 customers, THB 55,956,197 → THB 14,769,378, only 26.4% retained. Non-movers are stable either way: 105.8% with Save More and 98.2% without. Caveat on causality: Save More holders are also much larger balances, so part of the gap is cohort composition rather than the product itself. The actionable read is still that a second promotional pocket gives maturing Save Max money somewhere to go inside the bank - worth testing as a deliberate retention offer before the next maturity wave.</a:t>
+              <a:t>Movers split sharply on the Save More flag. With Save More: 3,954 customers, THB 926,675,679 → THB 1,008,521,954, 108.8% retained. Without: 2,823 customers, THB 54,222,669 → THB 14,691,353, only 27.1% retained. Non-movers are stable either way: 106.0% with Save More and 98.4% without. Caveat on causality: Save More holders are also much larger balances, so part of the gap is cohort composition rather than the product itself. The actionable read is still that a second promotional pocket gives maturing Save Max money somewhere to go inside the bank - worth testing as a deliberate retention offer before the next maturity wave.</a:t>
             </a:r>
             <a:endParaRPr lang="en-US" dirty="0"/>
           </a:p>
@@ -3925,7 +3925,7 @@
                 <a:ea typeface="Graphik TH" pitchFamily="34" charset="-122"/>
                 <a:cs typeface="Graphik TH" pitchFamily="34" charset="-120"/>
               </a:rPr>
-              <a:t>Maturity outcome : Save Max −THB 209m, total balance +THB 155m</a:t>
+              <a:t>Maturity outcome : Save Max −THB 189m, total balance +THB 117m</a:t>
             </a:r>
             <a:endParaRPr lang="en-US" sz="2200" dirty="0"/>
           </a:p>
@@ -4003,7 +4003,7 @@
                 <a:ea typeface="Graphik TH" pitchFamily="34" charset="-122"/>
                 <a:cs typeface="Graphik TH" pitchFamily="34" charset="-120"/>
               </a:rPr>
-              <a:t>Customers 72,874  ·  Moved 6,781 (9.3%)  ·  Save Max THB 993m → 784m  ·  Total THB 4.13bn → 4.28bn</a:t>
+              <a:t>Customers 72,870  ·  Moved 6,777 (9.3%)  ·  Save Max THB 685m → 496m  ·  Total THB 2.97bn → 3.08bn</a:t>
             </a:r>
             <a:endParaRPr lang="en-US" sz="1300" dirty="0"/>
           </a:p>
@@ -4042,7 +4042,7 @@
                 <a:ea typeface="Graphik TH" pitchFamily="34" charset="-122"/>
                 <a:cs typeface="Graphik TH" pitchFamily="34" charset="-120"/>
               </a:rPr>
-              <a:t>The money left the pocket, not the bank — Save Max fell 21% while total deposit balance rose 4%.</a:t>
+              <a:t>The money left the pocket, not the bank — Save Max fell 28% while total deposit balance rose 4%.</a:t>
             </a:r>
             <a:endParaRPr lang="en-US" sz="1400" dirty="0"/>
           </a:p>
@@ -4242,7 +4242,7 @@
                 <a:ea typeface="Graphik TH" pitchFamily="34" charset="-122"/>
                 <a:cs typeface="Graphik TH" pitchFamily="34" charset="-120"/>
               </a:rPr>
-              <a:t>6,781</a:t>
+              <a:t>6,777</a:t>
             </a:r>
             <a:endParaRPr lang="en-US" sz="2400" dirty="0"/>
           </a:p>
@@ -4381,7 +4381,7 @@
                 <a:ea typeface="Graphik TH" pitchFamily="34" charset="-122"/>
                 <a:cs typeface="Graphik TH" pitchFamily="34" charset="-120"/>
               </a:rPr>
-              <a:t>−THB 209m</a:t>
+              <a:t>−THB 189m</a:t>
             </a:r>
             <a:endParaRPr lang="en-US" sz="2400" dirty="0"/>
           </a:p>
@@ -4459,7 +4459,7 @@
                 <a:ea typeface="Graphik TH" pitchFamily="34" charset="-122"/>
                 <a:cs typeface="Graphik TH" pitchFamily="34" charset="-120"/>
               </a:rPr>
-              <a:t>−21.0% period on period</a:t>
+              <a:t>−27.6% period on period</a:t>
             </a:r>
             <a:endParaRPr lang="en-US" sz="950" dirty="0"/>
           </a:p>
@@ -4520,7 +4520,7 @@
                 <a:ea typeface="Graphik TH" pitchFamily="34" charset="-122"/>
                 <a:cs typeface="Graphik TH" pitchFamily="34" charset="-120"/>
               </a:rPr>
-              <a:t>+THB 155m</a:t>
+              <a:t>+THB 117m</a:t>
             </a:r>
             <a:endParaRPr lang="en-US" sz="2400" dirty="0"/>
           </a:p>
@@ -4598,7 +4598,7 @@
                 <a:ea typeface="Graphik TH" pitchFamily="34" charset="-122"/>
                 <a:cs typeface="Graphik TH" pitchFamily="34" charset="-120"/>
               </a:rPr>
-              <a:t>+3.8% period on period</a:t>
+              <a:t>+3.9% period on period</a:t>
             </a:r>
             <a:endParaRPr lang="en-US" sz="950" dirty="0"/>
           </a:p>
@@ -4813,7 +4813,7 @@
         <p:spPr>
           <a:xfrm>
             <a:off x="2130552" y="3666744"/>
-            <a:ext cx="540531" cy="164592"/>
+            <a:ext cx="518042" cy="164592"/>
           </a:xfrm>
           <a:prstGeom prst="roundRect">
             <a:avLst>
@@ -4859,7 +4859,7 @@
                 <a:ea typeface="Graphik TH" pitchFamily="34" charset="-122"/>
                 <a:cs typeface="Graphik TH" pitchFamily="34" charset="-120"/>
               </a:rPr>
-              <a:t>THB 993m</a:t>
+              <a:t>THB 685m</a:t>
             </a:r>
             <a:endParaRPr lang="en-US" sz="1000" dirty="0"/>
           </a:p>
@@ -4935,7 +4935,7 @@
         <p:spPr>
           <a:xfrm>
             <a:off x="2130552" y="3959352"/>
-            <a:ext cx="426945" cy="164592"/>
+            <a:ext cx="374855" cy="164592"/>
           </a:xfrm>
           <a:prstGeom prst="roundRect">
             <a:avLst>
@@ -4981,7 +4981,7 @@
                 <a:ea typeface="Graphik TH" pitchFamily="34" charset="-122"/>
                 <a:cs typeface="Graphik TH" pitchFamily="34" charset="-120"/>
               </a:rPr>
-              <a:t>THB 784m</a:t>
+              <a:t>THB 496m</a:t>
             </a:r>
             <a:endParaRPr lang="en-US" sz="1000" dirty="0"/>
           </a:p>
@@ -5096,7 +5096,7 @@
         <p:spPr>
           <a:xfrm>
             <a:off x="2130552" y="4507992"/>
-            <a:ext cx="2247350" cy="164592"/>
+            <a:ext cx="2243273" cy="164592"/>
           </a:xfrm>
           <a:prstGeom prst="roundRect">
             <a:avLst>
@@ -5142,7 +5142,7 @@
                 <a:ea typeface="Graphik TH" pitchFamily="34" charset="-122"/>
                 <a:cs typeface="Graphik TH" pitchFamily="34" charset="-120"/>
               </a:rPr>
-              <a:t>THB 4,128m</a:t>
+              <a:t>THB 2,966m</a:t>
             </a:r>
             <a:endParaRPr lang="en-US" sz="1000" dirty="0"/>
           </a:p>
@@ -5264,7 +5264,7 @@
                 <a:ea typeface="Graphik TH" pitchFamily="34" charset="-122"/>
                 <a:cs typeface="Graphik TH" pitchFamily="34" charset="-120"/>
               </a:rPr>
-              <a:t>THB 4,283m</a:t>
+              <a:t>THB 3,083m</a:t>
             </a:r>
             <a:endParaRPr lang="en-US" sz="1000" dirty="0"/>
           </a:p>
@@ -5923,11 +5923,11 @@
         <p:spPr>
           <a:xfrm>
             <a:off x="7680960" y="4416552"/>
-            <a:ext cx="130467" cy="164592"/>
+            <a:ext cx="130390" cy="164592"/>
           </a:xfrm>
           <a:prstGeom prst="roundRect">
             <a:avLst>
-              <a:gd name="adj" fmla="val 21026"/>
+              <a:gd name="adj" fmla="val 21038"/>
             </a:avLst>
           </a:prstGeom>
           <a:solidFill>
@@ -6008,7 +6008,7 @@
                 <a:ea typeface="Graphik TH" pitchFamily="34" charset="-122"/>
                 <a:cs typeface="Graphik TH" pitchFamily="34" charset="-120"/>
               </a:rPr>
-              <a:t>1,562 of 21,895</a:t>
+              <a:t>1,561 of 21,894</a:t>
             </a:r>
             <a:endParaRPr lang="en-US" sz="900" dirty="0"/>
           </a:p>
@@ -6169,7 +6169,7 @@
                 <a:ea typeface="Graphik TH" pitchFamily="34" charset="-122"/>
                 <a:cs typeface="Graphik TH" pitchFamily="34" charset="-120"/>
               </a:rPr>
-              <a:t>269 of 27,211</a:t>
+              <a:t>266 of 27,208</a:t>
             </a:r>
             <a:endParaRPr lang="en-US" sz="900" dirty="0"/>
           </a:p>
@@ -6269,7 +6269,7 @@
                 <a:ea typeface="Graphik TH" pitchFamily="34" charset="-122"/>
                 <a:cs typeface="Graphik TH" pitchFamily="34" charset="-120"/>
               </a:rPr>
-              <a:t>Save Max lost THB 209m but the book gained THB 155m</a:t>
+              <a:t>Save Max lost THB 189m but the book gained THB 117m</a:t>
             </a:r>
             <a:pPr indent="0" marL="0">
               <a:buNone/>
@@ -6283,7 +6283,7 @@
                 <a:ea typeface="Graphik TH" pitchFamily="34" charset="-122"/>
                 <a:cs typeface="Graphik TH" pitchFamily="34" charset="-120"/>
               </a:rPr>
-              <a:t>  —  the 6,781 customers who emptied Save Max took THB 129m out of the pocket, yet total deposits rose. Runoff from the promotional pocket is not the same as runoff from the bank.</a:t>
+              <a:t>  —  the 6,777 customers who emptied Save Max took THB 123m out of the pocket, yet total deposits rose. Runoff from the promotional pocket is not the same as runoff from the bank.</a:t>
             </a:r>
             <a:endParaRPr lang="en-US" sz="1100" dirty="0"/>
           </a:p>
@@ -6432,7 +6432,7 @@
                 <a:ea typeface="Graphik TH" pitchFamily="34" charset="-122"/>
                 <a:cs typeface="Graphik TH" pitchFamily="34" charset="-120"/>
               </a:rPr>
-              <a:t>Movers 6,781   ·   With Save More 3,955 → +THB 87m (+8.9%)   ·   Without Save More 2,826 → −THB 41m (−73.6%)</a:t>
+              <a:t>Movers 6,777   ·   With Save More 3,954 → +THB 82m (+8.8%)   ·   Without Save More 2,823 → −THB 40m (−72.9%)</a:t>
             </a:r>
             <a:endParaRPr lang="en-US" sz="1300" dirty="0"/>
           </a:p>
@@ -6532,7 +6532,7 @@
                 <a:ea typeface="Graphik TH" pitchFamily="34" charset="-122"/>
                 <a:cs typeface="Graphik TH" pitchFamily="34" charset="-120"/>
               </a:rPr>
-              <a:t>3,955</a:t>
+              <a:t>3,954</a:t>
             </a:r>
             <a:endParaRPr lang="en-US" sz="2400" dirty="0"/>
           </a:p>
@@ -6749,7 +6749,7 @@
                 <a:ea typeface="Graphik TH" pitchFamily="34" charset="-122"/>
                 <a:cs typeface="Graphik TH" pitchFamily="34" charset="-120"/>
               </a:rPr>
-              <a:t>THB 979m → THB 1.07bn</a:t>
+              <a:t>THB 927m → THB 1.01bn</a:t>
             </a:r>
             <a:endParaRPr lang="en-US" sz="950" dirty="0"/>
           </a:p>
@@ -6810,7 +6810,7 @@
                 <a:ea typeface="Graphik TH" pitchFamily="34" charset="-122"/>
                 <a:cs typeface="Graphik TH" pitchFamily="34" charset="-120"/>
               </a:rPr>
-              <a:t>2,826</a:t>
+              <a:t>2,823</a:t>
             </a:r>
             <a:endParaRPr lang="en-US" sz="2400" dirty="0"/>
           </a:p>
@@ -6949,7 +6949,7 @@
                 <a:ea typeface="Graphik TH" pitchFamily="34" charset="-122"/>
                 <a:cs typeface="Graphik TH" pitchFamily="34" charset="-120"/>
               </a:rPr>
-              <a:t>26%</a:t>
+              <a:t>27%</a:t>
             </a:r>
             <a:endParaRPr lang="en-US" sz="2400" dirty="0"/>
           </a:p>
@@ -7027,7 +7027,7 @@
                 <a:ea typeface="Graphik TH" pitchFamily="34" charset="-122"/>
                 <a:cs typeface="Graphik TH" pitchFamily="34" charset="-120"/>
               </a:rPr>
-              <a:t>THB 56m → THB 15m</a:t>
+              <a:t>THB 54m → THB 15m</a:t>
             </a:r>
             <a:endParaRPr lang="en-US" sz="950" dirty="0"/>
           </a:p>
@@ -7223,7 +7223,7 @@
         <p:spPr>
           <a:xfrm>
             <a:off x="2724912" y="3520440"/>
-            <a:ext cx="1945573" cy="164592"/>
+            <a:ext cx="1945089" cy="164592"/>
           </a:xfrm>
           <a:prstGeom prst="roundRect">
             <a:avLst>
@@ -7269,7 +7269,7 @@
                 <a:ea typeface="Graphik TH" pitchFamily="34" charset="-122"/>
                 <a:cs typeface="Graphik TH" pitchFamily="34" charset="-120"/>
               </a:rPr>
-              <a:t>108.9%</a:t>
+              <a:t>108.8%</a:t>
             </a:r>
             <a:endParaRPr lang="en-US" sz="1000" dirty="0"/>
           </a:p>
@@ -7345,7 +7345,7 @@
         <p:spPr>
           <a:xfrm>
             <a:off x="2724912" y="3904488"/>
-            <a:ext cx="471733" cy="164592"/>
+            <a:ext cx="484242" cy="164592"/>
           </a:xfrm>
           <a:prstGeom prst="roundRect">
             <a:avLst>
@@ -7391,7 +7391,7 @@
                 <a:ea typeface="Graphik TH" pitchFamily="34" charset="-122"/>
                 <a:cs typeface="Graphik TH" pitchFamily="34" charset="-120"/>
               </a:rPr>
-              <a:t>26.4%</a:t>
+              <a:t>27.1%</a:t>
             </a:r>
             <a:endParaRPr lang="en-US" sz="1000" dirty="0"/>
           </a:p>
@@ -7467,7 +7467,7 @@
         <p:spPr>
           <a:xfrm>
             <a:off x="2724912" y="4288536"/>
-            <a:ext cx="1890007" cy="164592"/>
+            <a:ext cx="1894648" cy="164592"/>
           </a:xfrm>
           <a:prstGeom prst="roundRect">
             <a:avLst>
@@ -7513,7 +7513,7 @@
                 <a:ea typeface="Graphik TH" pitchFamily="34" charset="-122"/>
                 <a:cs typeface="Graphik TH" pitchFamily="34" charset="-120"/>
               </a:rPr>
-              <a:t>105.8%</a:t>
+              <a:t>106.0%</a:t>
             </a:r>
             <a:endParaRPr lang="en-US" sz="1000" dirty="0"/>
           </a:p>
@@ -7589,7 +7589,7 @@
         <p:spPr>
           <a:xfrm>
             <a:off x="2724912" y="4672584"/>
-            <a:ext cx="1754371" cy="164592"/>
+            <a:ext cx="1757898" cy="164592"/>
           </a:xfrm>
           <a:prstGeom prst="roundRect">
             <a:avLst>
@@ -7635,7 +7635,7 @@
                 <a:ea typeface="Graphik TH" pitchFamily="34" charset="-122"/>
                 <a:cs typeface="Graphik TH" pitchFamily="34" charset="-120"/>
               </a:rPr>
-              <a:t>98.2%</a:t>
+              <a:t>98.4%</a:t>
             </a:r>
             <a:endParaRPr lang="en-US" sz="1000" dirty="0"/>
           </a:p>
@@ -8099,7 +8099,7 @@
                           <a:ea typeface="Graphik TH" pitchFamily="34" charset="-122"/>
                           <a:cs typeface="Graphik TH" pitchFamily="34" charset="-120"/>
                         </a:rPr>
-                        <a:t>3,955</a:t>
+                        <a:t>3,954</a:t>
                       </a:r>
                       <a:endParaRPr lang="en-US" sz="950" dirty="0">
                         <a:latin typeface="Graphik TH" charset="0"/>
@@ -8120,7 +8120,7 @@
                           <a:ea typeface="Graphik TH" pitchFamily="34" charset="-122"/>
                           <a:cs typeface="Graphik TH" pitchFamily="34" charset="-120"/>
                         </a:rPr>
-                        <a:t>+8.9%   +THB 87m</a:t>
+                        <a:t>+8.8%   +THB 82m</a:t>
                       </a:r>
                       <a:endParaRPr lang="en-US" sz="950" dirty="0">
                         <a:latin typeface="Graphik TH" charset="0"/>
@@ -8188,7 +8188,7 @@
                           <a:ea typeface="Graphik TH" pitchFamily="34" charset="-122"/>
                           <a:cs typeface="Graphik TH" pitchFamily="34" charset="-120"/>
                         </a:rPr>
-                        <a:t>2,826</a:t>
+                        <a:t>2,823</a:t>
                       </a:r>
                       <a:endParaRPr lang="en-US" sz="950" dirty="0">
                         <a:latin typeface="Graphik TH" charset="0"/>
@@ -8209,7 +8209,7 @@
                           <a:ea typeface="Graphik TH" pitchFamily="34" charset="-122"/>
                           <a:cs typeface="Graphik TH" pitchFamily="34" charset="-120"/>
                         </a:rPr>
-                        <a:t>−73.6%   −THB 41m</a:t>
+                        <a:t>−72.9%   −THB 40m</a:t>
                       </a:r>
                       <a:endParaRPr lang="en-US" sz="950" dirty="0">
                         <a:latin typeface="Graphik TH" charset="0"/>
@@ -8368,7 +8368,7 @@
                           <a:ea typeface="Graphik TH" pitchFamily="34" charset="-122"/>
                           <a:cs typeface="Graphik TH" pitchFamily="34" charset="-120"/>
                         </a:rPr>
-                        <a:t>+5.8%   +THB 126m</a:t>
+                        <a:t>+6.0%   +THB 84m</a:t>
                       </a:r>
                       <a:endParaRPr lang="en-US" sz="950" dirty="0">
                         <a:latin typeface="Graphik TH" charset="0"/>
@@ -8457,7 +8457,7 @@
                           <a:ea typeface="Graphik TH" pitchFamily="34" charset="-122"/>
                           <a:cs typeface="Graphik TH" pitchFamily="34" charset="-120"/>
                         </a:rPr>
-                        <a:t>−1.8%   −THB 17m</a:t>
+                        <a:t>−1.6%   −THB 10m</a:t>
                       </a:r>
                       <a:endParaRPr lang="en-US" sz="950" dirty="0">
                         <a:latin typeface="Graphik TH" charset="0"/>
@@ -8607,7 +8607,7 @@
                 <a:ea typeface="Graphik TH" pitchFamily="34" charset="-122"/>
                 <a:cs typeface="Graphik TH" pitchFamily="34" charset="-120"/>
               </a:rPr>
-              <a:t>The 2,826 movers with no Save More kept only 26% of their balance</a:t>
+              <a:t>The 2,823 movers with no Save More kept only 27% of their balance</a:t>
             </a:r>
             <a:pPr indent="0" marL="0">
               <a:buNone/>
@@ -8621,7 +8621,7 @@
                 <a:ea typeface="Graphik TH" pitchFamily="34" charset="-122"/>
                 <a:cs typeface="Graphik TH" pitchFamily="34" charset="-120"/>
               </a:rPr>
-              <a:t>  —  −THB 41m gone. The same behaviour with a Save More holding grew +8.9%. Cross-holding, not the stickiness score, is what converts a maturing promotion into retained deposits.</a:t>
+              <a:t>  —  −THB 40m gone. The same behaviour with a Save More holding grew +8.8%. Cross-holding, not the stickiness score, is what converts a maturing promotion into retained deposits.</a:t>
             </a:r>
             <a:endParaRPr lang="en-US" sz="1100" dirty="0"/>
           </a:p>

</xml_diff>

<commit_message>
Filter the maturity cohort to Save Max customers with balance > 0
Cohort drops from 72,870 to 47,184, matching the funded Save Max base
used on the earlier slides. Unfunded customers were almost all
non-movers, so the observed move rate rises from 9.3% to 14.1% and Very
Low rate sensitivity goes from 1.0% to 9.6% as its denominator collapses
from 27,208 to 1,754.

Save Max is now -THB 193m (-28.2%) against total balance +THB 111m
(+3.8%). Mover retention on the Save More split is unchanged at 108.8%
against 27.1%. Slide note updated to state the new filter.

Co-Authored-By: Claude Opus 5 <noreply@anthropic.com>
Claude-Session: https://claude.ai/code/session_01VKpfo226Go9vQJYa4eoC1d
</commit_message>
<xml_diff>
--- a/Deposit_Stickiness_Framework.pptx
+++ b/Deposit_Stickiness_Framework.pptx
@@ -600,7 +600,7 @@
           <a:p>
             <a:r>
               <a:rPr lang="en-US" dirty="0"/>
-              <a:t>Cohort: 72,870 customers holding Save Max in the prior period. 6,777 of them (9.3%) now show zero Save Max balance. Save Max fell from THB 685,023,127 to THB 495,681,749, down 27.6%, of which THB 123,073,643 came from movers zeroing out and THB 66,267,735 from non-movers trimming. Total deposit balance nevertheless rose from THB 2,966,348,100 to THB 3,083,304,918, up 3.9%. Save Max fell from 23.1% to 16.1% of the book. Move rate is not monotonic in rate sensitivity: the High band moves at 49.5% against 12.8% for Very High, so the current cut-offs do not rank runoff risk correctly and should be recalibrated on this outcome.</a:t>
+              <a:t>Cohort: 47,184 customers holding Save Max in the prior period. 6,671 of them (14.1%) now show zero Save Max balance. Save Max fell from THB 685,023,127 to THB 491,897,976, down 28.2%, of which THB 123,073,643 came from movers zeroing out and THB 70,051,509 from non-movers trimming. Total deposit balance nevertheless rose from THB 2,901,915,577 to THB 3,013,181,725, up 3.8%. Save Max fell from 23.6% to 16.3% of the book. Move rate is not monotonic in rate sensitivity: the High band moves at 49.5% against 12.8% for Very High, so the current cut-offs do not rank runoff risk correctly and should be recalibrated on this outcome.</a:t>
             </a:r>
             <a:endParaRPr lang="en-US" dirty="0"/>
           </a:p>
@@ -688,7 +688,7 @@
           <a:p>
             <a:r>
               <a:rPr lang="en-US" dirty="0"/>
-              <a:t>Movers split sharply on the Save More flag. With Save More: 3,954 customers, THB 926,675,679 → THB 1,008,521,954, 108.8% retained. Without: 2,823 customers, THB 54,222,669 → THB 14,691,353, only 27.1% retained. Non-movers are stable either way: 106.0% with Save More and 98.4% without. Caveat on causality: Save More holders are also much larger balances, so part of the gap is cohort composition rather than the product itself. The actionable read is still that a second promotional pocket gives maturing Save Max money somewhere to go inside the bank - worth testing as a deliberate retention offer before the next maturity wave.</a:t>
+              <a:t>Movers split sharply on the Save More flag. With Save More: 3,912 customers, THB 924,465,529 → THB 1,005,619,905, 108.8% retained. Without: 2,759 customers, THB 54,112,917 → THB 14,656,265, only 27.1% retained. Non-movers are stable either way: 106.0% with Save More and 97.6% without. Caveat on causality: Save More holders are also much larger balances, so part of the gap is cohort composition rather than the product itself. The actionable read is still that a second promotional pocket gives maturing Save Max money somewhere to go inside the bank - worth testing as a deliberate retention offer before the next maturity wave.</a:t>
             </a:r>
             <a:endParaRPr lang="en-US" dirty="0"/>
           </a:p>
@@ -3925,7 +3925,7 @@
                 <a:ea typeface="Graphik TH" pitchFamily="34" charset="-122"/>
                 <a:cs typeface="Graphik TH" pitchFamily="34" charset="-120"/>
               </a:rPr>
-              <a:t>Maturity outcome : Save Max −THB 189m, total balance +THB 117m</a:t>
+              <a:t>Maturity outcome : Save Max −THB 193m, total balance +THB 111m</a:t>
             </a:r>
             <a:endParaRPr lang="en-US" sz="2200" dirty="0"/>
           </a:p>
@@ -3964,7 +3964,7 @@
                 <a:ea typeface="Graphik TH" pitchFamily="34" charset="-122"/>
                 <a:cs typeface="Graphik TH" pitchFamily="34" charset="-120"/>
               </a:rPr>
-              <a:t>*Save Max holders with prior balance &gt; 0. 'Move' = Save Max now zero. prev / latest balance is the customer's total deposit balance.</a:t>
+              <a:t>*Save Max holders with balance &gt; 0. 'Move' = Save Max now zero. prev / latest balance is the customer's total deposit balance, not Save Max alone.</a:t>
             </a:r>
             <a:endParaRPr lang="en-US" sz="1150" dirty="0"/>
           </a:p>
@@ -4003,7 +4003,7 @@
                 <a:ea typeface="Graphik TH" pitchFamily="34" charset="-122"/>
                 <a:cs typeface="Graphik TH" pitchFamily="34" charset="-120"/>
               </a:rPr>
-              <a:t>Customers 72,870  ·  Moved 6,777 (9.3%)  ·  Save Max THB 685m → 496m  ·  Total THB 2.97bn → 3.08bn</a:t>
+              <a:t>Customers 47,184  ·  Moved 6,671 (14.1%)  ·  Save Max THB 685m → 492m  ·  Total THB 2.90bn → 3.01bn</a:t>
             </a:r>
             <a:endParaRPr lang="en-US" sz="1300" dirty="0"/>
           </a:p>
@@ -4103,7 +4103,7 @@
                 <a:ea typeface="Graphik TH" pitchFamily="34" charset="-122"/>
                 <a:cs typeface="Graphik TH" pitchFamily="34" charset="-120"/>
               </a:rPr>
-              <a:t>72.9k</a:t>
+              <a:t>47.2k</a:t>
             </a:r>
             <a:endParaRPr lang="en-US" sz="2400" dirty="0"/>
           </a:p>
@@ -4242,7 +4242,7 @@
                 <a:ea typeface="Graphik TH" pitchFamily="34" charset="-122"/>
                 <a:cs typeface="Graphik TH" pitchFamily="34" charset="-120"/>
               </a:rPr>
-              <a:t>6,777</a:t>
+              <a:t>6,671</a:t>
             </a:r>
             <a:endParaRPr lang="en-US" sz="2400" dirty="0"/>
           </a:p>
@@ -4320,7 +4320,7 @@
                 <a:ea typeface="Graphik TH" pitchFamily="34" charset="-122"/>
                 <a:cs typeface="Graphik TH" pitchFamily="34" charset="-120"/>
               </a:rPr>
-              <a:t>9.3% · Save Max now zero</a:t>
+              <a:t>14.1% · Save Max now zero</a:t>
             </a:r>
             <a:endParaRPr lang="en-US" sz="950" dirty="0"/>
           </a:p>
@@ -4381,7 +4381,7 @@
                 <a:ea typeface="Graphik TH" pitchFamily="34" charset="-122"/>
                 <a:cs typeface="Graphik TH" pitchFamily="34" charset="-120"/>
               </a:rPr>
-              <a:t>−THB 189m</a:t>
+              <a:t>−THB 193m</a:t>
             </a:r>
             <a:endParaRPr lang="en-US" sz="2400" dirty="0"/>
           </a:p>
@@ -4459,7 +4459,7 @@
                 <a:ea typeface="Graphik TH" pitchFamily="34" charset="-122"/>
                 <a:cs typeface="Graphik TH" pitchFamily="34" charset="-120"/>
               </a:rPr>
-              <a:t>−27.6% period on period</a:t>
+              <a:t>−28.2% period on period</a:t>
             </a:r>
             <a:endParaRPr lang="en-US" sz="950" dirty="0"/>
           </a:p>
@@ -4520,7 +4520,7 @@
                 <a:ea typeface="Graphik TH" pitchFamily="34" charset="-122"/>
                 <a:cs typeface="Graphik TH" pitchFamily="34" charset="-120"/>
               </a:rPr>
-              <a:t>+THB 117m</a:t>
+              <a:t>+THB 111m</a:t>
             </a:r>
             <a:endParaRPr lang="en-US" sz="2400" dirty="0"/>
           </a:p>
@@ -4598,7 +4598,7 @@
                 <a:ea typeface="Graphik TH" pitchFamily="34" charset="-122"/>
                 <a:cs typeface="Graphik TH" pitchFamily="34" charset="-120"/>
               </a:rPr>
-              <a:t>+3.9% period on period</a:t>
+              <a:t>+3.8% period on period</a:t>
             </a:r>
             <a:endParaRPr lang="en-US" sz="950" dirty="0"/>
           </a:p>
@@ -4813,7 +4813,7 @@
         <p:spPr>
           <a:xfrm>
             <a:off x="2130552" y="3666744"/>
-            <a:ext cx="518042" cy="164592"/>
+            <a:ext cx="530098" cy="164592"/>
           </a:xfrm>
           <a:prstGeom prst="roundRect">
             <a:avLst>
@@ -4935,7 +4935,7 @@
         <p:spPr>
           <a:xfrm>
             <a:off x="2130552" y="3959352"/>
-            <a:ext cx="374855" cy="164592"/>
+            <a:ext cx="380650" cy="164592"/>
           </a:xfrm>
           <a:prstGeom prst="roundRect">
             <a:avLst>
@@ -4981,7 +4981,7 @@
                 <a:ea typeface="Graphik TH" pitchFamily="34" charset="-122"/>
                 <a:cs typeface="Graphik TH" pitchFamily="34" charset="-120"/>
               </a:rPr>
-              <a:t>THB 496m</a:t>
+              <a:t>THB 492m</a:t>
             </a:r>
             <a:endParaRPr lang="en-US" sz="1000" dirty="0"/>
           </a:p>
@@ -5096,7 +5096,7 @@
         <p:spPr>
           <a:xfrm>
             <a:off x="2130552" y="4507992"/>
-            <a:ext cx="2243273" cy="164592"/>
+            <a:ext cx="2245618" cy="164592"/>
           </a:xfrm>
           <a:prstGeom prst="roundRect">
             <a:avLst>
@@ -5142,7 +5142,7 @@
                 <a:ea typeface="Graphik TH" pitchFamily="34" charset="-122"/>
                 <a:cs typeface="Graphik TH" pitchFamily="34" charset="-120"/>
               </a:rPr>
-              <a:t>THB 2,966m</a:t>
+              <a:t>THB 2,902m</a:t>
             </a:r>
             <a:endParaRPr lang="en-US" sz="1000" dirty="0"/>
           </a:p>
@@ -5264,7 +5264,7 @@
                 <a:ea typeface="Graphik TH" pitchFamily="34" charset="-122"/>
                 <a:cs typeface="Graphik TH" pitchFamily="34" charset="-120"/>
               </a:rPr>
-              <a:t>THB 3,083m</a:t>
+              <a:t>THB 3,013m</a:t>
             </a:r>
             <a:endParaRPr lang="en-US" sz="1000" dirty="0"/>
           </a:p>
@@ -5440,7 +5440,7 @@
         <p:spPr>
           <a:xfrm>
             <a:off x="7680960" y="3483864"/>
-            <a:ext cx="234971" cy="164592"/>
+            <a:ext cx="235050" cy="164592"/>
           </a:xfrm>
           <a:prstGeom prst="roundRect">
             <a:avLst>
@@ -5486,7 +5486,7 @@
                 <a:ea typeface="Graphik TH" pitchFamily="34" charset="-122"/>
                 <a:cs typeface="Graphik TH" pitchFamily="34" charset="-120"/>
               </a:rPr>
-              <a:t>12.8%</a:t>
+              <a:t>12.9%</a:t>
             </a:r>
             <a:endParaRPr lang="en-US" sz="1000" dirty="0"/>
           </a:p>
@@ -5525,7 +5525,7 @@
                 <a:ea typeface="Graphik TH" pitchFamily="34" charset="-122"/>
                 <a:cs typeface="Graphik TH" pitchFamily="34" charset="-120"/>
               </a:rPr>
-              <a:t>2,388 of 18,586</a:t>
+              <a:t>2,387 of 18,572</a:t>
             </a:r>
             <a:endParaRPr lang="en-US" sz="900" dirty="0"/>
           </a:p>
@@ -5923,11 +5923,11 @@
         <p:spPr>
           <a:xfrm>
             <a:off x="7680960" y="4416552"/>
-            <a:ext cx="130390" cy="164592"/>
+            <a:ext cx="131026" cy="164592"/>
           </a:xfrm>
           <a:prstGeom prst="roundRect">
             <a:avLst>
-              <a:gd name="adj" fmla="val 21038"/>
+              <a:gd name="adj" fmla="val 20936"/>
             </a:avLst>
           </a:prstGeom>
           <a:solidFill>
@@ -5969,7 +5969,7 @@
                 <a:ea typeface="Graphik TH" pitchFamily="34" charset="-122"/>
                 <a:cs typeface="Graphik TH" pitchFamily="34" charset="-120"/>
               </a:rPr>
-              <a:t>7.1%</a:t>
+              <a:t>7.2%</a:t>
             </a:r>
             <a:endParaRPr lang="en-US" sz="1000" dirty="0"/>
           </a:p>
@@ -6008,7 +6008,7 @@
                 <a:ea typeface="Graphik TH" pitchFamily="34" charset="-122"/>
                 <a:cs typeface="Graphik TH" pitchFamily="34" charset="-120"/>
               </a:rPr>
-              <a:t>1,561 of 21,894</a:t>
+              <a:t>1,553 of 21,676</a:t>
             </a:r>
             <a:endParaRPr lang="en-US" sz="900" dirty="0"/>
           </a:p>
@@ -6084,11 +6084,11 @@
         <p:spPr>
           <a:xfrm>
             <a:off x="7680960" y="4727448"/>
-            <a:ext cx="36576" cy="164592"/>
+            <a:ext cx="176207" cy="164592"/>
           </a:xfrm>
           <a:prstGeom prst="roundRect">
             <a:avLst>
-              <a:gd name="adj" fmla="val 75000"/>
+              <a:gd name="adj" fmla="val 16667"/>
             </a:avLst>
           </a:prstGeom>
           <a:solidFill>
@@ -6130,7 +6130,7 @@
                 <a:ea typeface="Graphik TH" pitchFamily="34" charset="-122"/>
                 <a:cs typeface="Graphik TH" pitchFamily="34" charset="-120"/>
               </a:rPr>
-              <a:t>1.0%</a:t>
+              <a:t>9.6%</a:t>
             </a:r>
             <a:endParaRPr lang="en-US" sz="1000" dirty="0"/>
           </a:p>
@@ -6169,7 +6169,7 @@
                 <a:ea typeface="Graphik TH" pitchFamily="34" charset="-122"/>
                 <a:cs typeface="Graphik TH" pitchFamily="34" charset="-120"/>
               </a:rPr>
-              <a:t>266 of 27,208</a:t>
+              <a:t>169 of 1,754</a:t>
             </a:r>
             <a:endParaRPr lang="en-US" sz="900" dirty="0"/>
           </a:p>
@@ -6269,7 +6269,7 @@
                 <a:ea typeface="Graphik TH" pitchFamily="34" charset="-122"/>
                 <a:cs typeface="Graphik TH" pitchFamily="34" charset="-120"/>
               </a:rPr>
-              <a:t>Save Max lost THB 189m but the book gained THB 117m</a:t>
+              <a:t>Save Max lost THB 193m but the book gained THB 111m</a:t>
             </a:r>
             <a:pPr indent="0" marL="0">
               <a:buNone/>
@@ -6283,7 +6283,7 @@
                 <a:ea typeface="Graphik TH" pitchFamily="34" charset="-122"/>
                 <a:cs typeface="Graphik TH" pitchFamily="34" charset="-120"/>
               </a:rPr>
-              <a:t>  —  the 6,777 customers who emptied Save Max took THB 123m out of the pocket, yet total deposits rose. Runoff from the promotional pocket is not the same as runoff from the bank.</a:t>
+              <a:t>  —  the 6,671 customers who emptied Save Max took THB 123m out of the pocket, yet total deposits rose. Runoff from the promotional pocket is not the same as runoff from the bank.</a:t>
             </a:r>
             <a:endParaRPr lang="en-US" sz="1100" dirty="0"/>
           </a:p>
@@ -6432,7 +6432,7 @@
                 <a:ea typeface="Graphik TH" pitchFamily="34" charset="-122"/>
                 <a:cs typeface="Graphik TH" pitchFamily="34" charset="-120"/>
               </a:rPr>
-              <a:t>Movers 6,777   ·   With Save More 3,954 → +THB 82m (+8.8%)   ·   Without Save More 2,823 → −THB 40m (−72.9%)</a:t>
+              <a:t>Movers 6,671   ·   With Save More 3,912 → +THB 81m (+8.8%)   ·   Without Save More 2,759 → −THB 39m (−72.9%)</a:t>
             </a:r>
             <a:endParaRPr lang="en-US" sz="1300" dirty="0"/>
           </a:p>
@@ -6532,7 +6532,7 @@
                 <a:ea typeface="Graphik TH" pitchFamily="34" charset="-122"/>
                 <a:cs typeface="Graphik TH" pitchFamily="34" charset="-120"/>
               </a:rPr>
-              <a:t>3,954</a:t>
+              <a:t>3,912</a:t>
             </a:r>
             <a:endParaRPr lang="en-US" sz="2400" dirty="0"/>
           </a:p>
@@ -6610,7 +6610,7 @@
                 <a:ea typeface="Graphik TH" pitchFamily="34" charset="-122"/>
                 <a:cs typeface="Graphik TH" pitchFamily="34" charset="-120"/>
               </a:rPr>
-              <a:t>58% of all movers</a:t>
+              <a:t>59% of all movers</a:t>
             </a:r>
             <a:endParaRPr lang="en-US" sz="950" dirty="0"/>
           </a:p>
@@ -6749,7 +6749,7 @@
                 <a:ea typeface="Graphik TH" pitchFamily="34" charset="-122"/>
                 <a:cs typeface="Graphik TH" pitchFamily="34" charset="-120"/>
               </a:rPr>
-              <a:t>THB 927m → THB 1.01bn</a:t>
+              <a:t>THB 924m → THB 1.01bn</a:t>
             </a:r>
             <a:endParaRPr lang="en-US" sz="950" dirty="0"/>
           </a:p>
@@ -6810,7 +6810,7 @@
                 <a:ea typeface="Graphik TH" pitchFamily="34" charset="-122"/>
                 <a:cs typeface="Graphik TH" pitchFamily="34" charset="-120"/>
               </a:rPr>
-              <a:t>2,823</a:t>
+              <a:t>2,759</a:t>
             </a:r>
             <a:endParaRPr lang="en-US" sz="2400" dirty="0"/>
           </a:p>
@@ -6888,7 +6888,7 @@
                 <a:ea typeface="Graphik TH" pitchFamily="34" charset="-122"/>
                 <a:cs typeface="Graphik TH" pitchFamily="34" charset="-120"/>
               </a:rPr>
-              <a:t>42% of all movers</a:t>
+              <a:t>41% of all movers</a:t>
             </a:r>
             <a:endParaRPr lang="en-US" sz="950" dirty="0"/>
           </a:p>
@@ -7223,7 +7223,7 @@
         <p:spPr>
           <a:xfrm>
             <a:off x="2724912" y="3520440"/>
-            <a:ext cx="1945089" cy="164592"/>
+            <a:ext cx="1944129" cy="164592"/>
           </a:xfrm>
           <a:prstGeom prst="roundRect">
             <a:avLst>
@@ -7345,7 +7345,7 @@
         <p:spPr>
           <a:xfrm>
             <a:off x="2724912" y="3904488"/>
-            <a:ext cx="484242" cy="164592"/>
+            <a:ext cx="484066" cy="164592"/>
           </a:xfrm>
           <a:prstGeom prst="roundRect">
             <a:avLst>
@@ -7467,7 +7467,7 @@
         <p:spPr>
           <a:xfrm>
             <a:off x="2724912" y="4288536"/>
-            <a:ext cx="1894648" cy="164592"/>
+            <a:ext cx="1895287" cy="164592"/>
           </a:xfrm>
           <a:prstGeom prst="roundRect">
             <a:avLst>
@@ -7589,7 +7589,7 @@
         <p:spPr>
           <a:xfrm>
             <a:off x="2724912" y="4672584"/>
-            <a:ext cx="1757898" cy="164592"/>
+            <a:ext cx="1744873" cy="164592"/>
           </a:xfrm>
           <a:prstGeom prst="roundRect">
             <a:avLst>
@@ -7635,7 +7635,7 @@
                 <a:ea typeface="Graphik TH" pitchFamily="34" charset="-122"/>
                 <a:cs typeface="Graphik TH" pitchFamily="34" charset="-120"/>
               </a:rPr>
-              <a:t>98.4%</a:t>
+              <a:t>97.6%</a:t>
             </a:r>
             <a:endParaRPr lang="en-US" sz="1000" dirty="0"/>
           </a:p>
@@ -8099,7 +8099,7 @@
                           <a:ea typeface="Graphik TH" pitchFamily="34" charset="-122"/>
                           <a:cs typeface="Graphik TH" pitchFamily="34" charset="-120"/>
                         </a:rPr>
-                        <a:t>3,954</a:t>
+                        <a:t>3,912</a:t>
                       </a:r>
                       <a:endParaRPr lang="en-US" sz="950" dirty="0">
                         <a:latin typeface="Graphik TH" charset="0"/>
@@ -8120,7 +8120,7 @@
                           <a:ea typeface="Graphik TH" pitchFamily="34" charset="-122"/>
                           <a:cs typeface="Graphik TH" pitchFamily="34" charset="-120"/>
                         </a:rPr>
-                        <a:t>+8.8%   +THB 82m</a:t>
+                        <a:t>+8.8%   +THB 81m</a:t>
                       </a:r>
                       <a:endParaRPr lang="en-US" sz="950" dirty="0">
                         <a:latin typeface="Graphik TH" charset="0"/>
@@ -8188,7 +8188,7 @@
                           <a:ea typeface="Graphik TH" pitchFamily="34" charset="-122"/>
                           <a:cs typeface="Graphik TH" pitchFamily="34" charset="-120"/>
                         </a:rPr>
-                        <a:t>2,823</a:t>
+                        <a:t>2,759</a:t>
                       </a:r>
                       <a:endParaRPr lang="en-US" sz="950" dirty="0">
                         <a:latin typeface="Graphik TH" charset="0"/>
@@ -8209,7 +8209,7 @@
                           <a:ea typeface="Graphik TH" pitchFamily="34" charset="-122"/>
                           <a:cs typeface="Graphik TH" pitchFamily="34" charset="-120"/>
                         </a:rPr>
-                        <a:t>−72.9%   −THB 40m</a:t>
+                        <a:t>−72.9%   −THB 39m</a:t>
                       </a:r>
                       <a:endParaRPr lang="en-US" sz="950" dirty="0">
                         <a:latin typeface="Graphik TH" charset="0"/>
@@ -8347,7 +8347,7 @@
                           <a:ea typeface="Graphik TH" pitchFamily="34" charset="-122"/>
                           <a:cs typeface="Graphik TH" pitchFamily="34" charset="-120"/>
                         </a:rPr>
-                        <a:t>8,658</a:t>
+                        <a:t>6,414</a:t>
                       </a:r>
                       <a:endParaRPr lang="en-US" sz="950" dirty="0">
                         <a:latin typeface="Graphik TH" charset="0"/>
@@ -8368,7 +8368,7 @@
                           <a:ea typeface="Graphik TH" pitchFamily="34" charset="-122"/>
                           <a:cs typeface="Graphik TH" pitchFamily="34" charset="-120"/>
                         </a:rPr>
-                        <a:t>+6.0%   +THB 84m</a:t>
+                        <a:t>+6.0%   +THB 83m</a:t>
                       </a:r>
                       <a:endParaRPr lang="en-US" sz="950" dirty="0">
                         <a:latin typeface="Graphik TH" charset="0"/>
@@ -8436,7 +8436,7 @@
                           <a:ea typeface="Graphik TH" pitchFamily="34" charset="-122"/>
                           <a:cs typeface="Graphik TH" pitchFamily="34" charset="-120"/>
                         </a:rPr>
-                        <a:t>57,435</a:t>
+                        <a:t>34,099</a:t>
                       </a:r>
                       <a:endParaRPr lang="en-US" sz="950" dirty="0">
                         <a:latin typeface="Graphik TH" charset="0"/>
@@ -8457,7 +8457,7 @@
                           <a:ea typeface="Graphik TH" pitchFamily="34" charset="-122"/>
                           <a:cs typeface="Graphik TH" pitchFamily="34" charset="-120"/>
                         </a:rPr>
-                        <a:t>−1.6%   −THB 10m</a:t>
+                        <a:t>−2.4%   −THB 13m</a:t>
                       </a:r>
                       <a:endParaRPr lang="en-US" sz="950" dirty="0">
                         <a:latin typeface="Graphik TH" charset="0"/>
@@ -8546,7 +8546,7 @@
                 <a:ea typeface="Graphik TH" pitchFamily="34" charset="-122"/>
                 <a:cs typeface="Graphik TH" pitchFamily="34" charset="-120"/>
               </a:rPr>
-              <a:t>Save More holders move 31.4% of the time against 4.7% — they move far more often, but into the next pocket rather than out of the bank.</a:t>
+              <a:t>Save More holders move 37.9% of the time against 7.5% — they move far more often, but into the next pocket rather than out of the bank.</a:t>
             </a:r>
             <a:endParaRPr lang="en-US" sz="950" dirty="0"/>
           </a:p>
@@ -8607,7 +8607,7 @@
                 <a:ea typeface="Graphik TH" pitchFamily="34" charset="-122"/>
                 <a:cs typeface="Graphik TH" pitchFamily="34" charset="-120"/>
               </a:rPr>
-              <a:t>The 2,823 movers with no Save More kept only 27% of their balance</a:t>
+              <a:t>The 2,759 movers with no Save More kept only 27% of their balance</a:t>
             </a:r>
             <a:pPr indent="0" marL="0">
               <a:buNone/>
@@ -8621,7 +8621,7 @@
                 <a:ea typeface="Graphik TH" pitchFamily="34" charset="-122"/>
                 <a:cs typeface="Graphik TH" pitchFamily="34" charset="-120"/>
               </a:rPr>
-              <a:t>  —  −THB 40m gone. The same behaviour with a Save More holding grew +8.8%. Cross-holding, not the stickiness score, is what converts a maturing promotion into retained deposits.</a:t>
+              <a:t>  —  −THB 39m gone. The same behaviour with a Save More holding grew +8.8%. Cross-holding, not the stickiness score, is what converts a maturing promotion into retained deposits.</a:t>
             </a:r>
             <a:endParaRPr lang="en-US" sz="1100" dirty="0"/>
           </a:p>

</xml_diff>

<commit_message>
Add move-rate matrix across deposit stickiness and rate sensitivity
Slide 12 puts deposit stickiness on the rows and rate sensitivity on the
columns, matching the matrices earlier in the deck, shaded by move rate.
Cells under 50 customers are left unshaded and muted so small-sample
rates are not read as signal.

The grid shows move rate rising with stickiness rather than falling -
Very High 19.2% against Very Low 1.9% - because the low tiers are
dormant micro-balance accounts. 98.7% of the Save Max balance that
walked came from customers scoring stickiness >= 60, while the
low-stickiness corner the decision view treats as fragile holds 297
customers and THB 5.9m.

Co-Authored-By: Claude Opus 5 <noreply@anthropic.com>
Claude-Session: https://claude.ai/code/session_01VKpfo226Go9vQJYa4eoC1d
</commit_message>
<xml_diff>
--- a/Deposit_Stickiness_Framework.pptx
+++ b/Deposit_Stickiness_Framework.pptx
@@ -16,9 +16,10 @@
     <p:sldId id="264" r:id="rId10"/>
     <p:sldId id="265" r:id="rId11"/>
     <p:sldId id="266" r:id="rId12"/>
+    <p:sldId id="267" r:id="rId13"/>
   </p:sldIdLst>
   <p:notesMasterIdLst>
-    <p:notesMasterId r:id="rId13"/>
+    <p:notesMasterId r:id="rId14"/>
   </p:notesMasterIdLst>
   <p:sldSz cx="12192000" cy="6858000"/>
   <p:notesSz cx="6858000" cy="12192000"/>
@@ -712,6 +713,94 @@
             <a:fld id="{F7021451-1387-4CA6-816F-3879F97B5CBC}" type="slidenum">
               <a:rPr lang="en-US"/>
               <a:t>11</a:t>
+            </a:fld>
+            <a:endParaRPr lang="en-US"/>
+          </a:p>
+        </p:txBody>
+      </p:sp>
+    </p:spTree>
+    <p:extLst>
+      <p:ext uri="{BB962C8B-B14F-4D97-AF65-F5344CB8AC3E}">
+        <p14:creationId xmlns:p14="http://schemas.microsoft.com/office/powerpoint/2010/main" val="1024086991"/>
+      </p:ext>
+    </p:extLst>
+  </p:cSld>
+  <p:clrMapOvr>
+    <a:masterClrMapping/>
+  </p:clrMapOvr>
+</p:notes>
+</file>
+
+<file path=ppt/notesSlides/notesSlide12.xml><?xml version="1.0" encoding="utf-8"?>
+<p:notes xmlns:a="http://schemas.openxmlformats.org/drawingml/2006/main" xmlns:r="http://schemas.openxmlformats.org/officeDocument/2006/relationships" xmlns:p="http://schemas.openxmlformats.org/presentationml/2006/main">
+  <p:cSld>
+    <p:spTree>
+      <p:nvGrpSpPr>
+        <p:cNvPr id="1" name=""/>
+        <p:cNvGrpSpPr/>
+        <p:nvPr/>
+      </p:nvGrpSpPr>
+      <p:grpSpPr>
+        <a:xfrm>
+          <a:off x="0" y="0"/>
+          <a:ext cx="0" cy="0"/>
+          <a:chOff x="0" y="0"/>
+          <a:chExt cx="0" cy="0"/>
+        </a:xfrm>
+      </p:grpSpPr>
+      <p:sp>
+        <p:nvSpPr>
+          <p:cNvPr id="2" name="Slide Image Placeholder 1"/>
+          <p:cNvSpPr>
+            <a:spLocks noGrp="1" noRot="1" noChangeAspect="1"/>
+          </p:cNvSpPr>
+          <p:nvPr>
+            <p:ph type="sldImg"/>
+          </p:nvPr>
+        </p:nvSpPr>
+        <p:spPr/>
+      </p:sp>
+      <p:sp>
+        <p:nvSpPr>
+          <p:cNvPr id="3" name="Notes Placeholder 2"/>
+          <p:cNvSpPr>
+            <a:spLocks noGrp="1"/>
+          </p:cNvSpPr>
+          <p:nvPr>
+            <p:ph type="body" idx="1"/>
+          </p:nvPr>
+        </p:nvSpPr>
+        <p:spPr/>
+        <p:txBody>
+          <a:bodyPr/>
+          <a:lstStyle/>
+          <a:p>
+            <a:r>
+              <a:rPr lang="en-US" dirty="0"/>
+              <a:t>Move rate rises with stickiness, which is the opposite of what the name suggests: Very High 19.2% against Very Low 1.9%. The reason is dormancy, not loyalty - average Save Max balance falls from THB 18,104 in the Very High tier to THB 18 in the Very Low tier, so the low tiers have nothing to move and nobody managing the account. Read the columns, not the rows: the High rate-sensitivity column is hot at every stickiness level, peaking at 56.2% for High stickiness. The fragile quadrant - stickiness &lt; 60 with rate sensitivity &gt;= 60 - is 297 customers holding THB 5,903,833, so the decision view on slide 2 points at an almost empty cell. On predictive value, stickiness adds little once rate sensitivity and the Save More flag are in hand (AUC 0.766 to 0.779), so its practical use is as an eligibility filter to suppress dormant micro-balance accounts from retention campaigns, not as a targeting dimension.</a:t>
+            </a:r>
+            <a:endParaRPr lang="en-US" dirty="0"/>
+          </a:p>
+        </p:txBody>
+      </p:sp>
+      <p:sp>
+        <p:nvSpPr>
+          <p:cNvPr id="4" name="Slide Number Placeholder 3"/>
+          <p:cNvSpPr>
+            <a:spLocks noGrp="1"/>
+          </p:cNvSpPr>
+          <p:nvPr>
+            <p:ph type="sldNum" sz="quarter" idx="10"/>
+          </p:nvPr>
+        </p:nvSpPr>
+        <p:spPr/>
+        <p:txBody>
+          <a:bodyPr/>
+          <a:lstStyle/>
+          <a:p>
+            <a:fld id="{F7021451-1387-4CA6-816F-3879F97B5CBC}" type="slidenum">
+              <a:rPr lang="en-US"/>
+              <a:t>12</a:t>
             </a:fld>
             <a:endParaRPr lang="en-US"/>
           </a:p>
@@ -8635,6 +8724,4579 @@
 </p:sld>
 </file>
 
+<file path=ppt/slides/slide12.xml><?xml version="1.0" encoding="utf-8"?>
+<p:sld xmlns:a="http://schemas.openxmlformats.org/drawingml/2006/main" xmlns:r="http://schemas.openxmlformats.org/officeDocument/2006/relationships" xmlns:p="http://schemas.openxmlformats.org/presentationml/2006/main">
+  <p:cSld name="Slide 12">
+    <p:bg>
+      <p:bgPr>
+        <a:solidFill>
+          <a:srgbClr val="FFFFFF"/>
+        </a:solidFill>
+      </p:bgPr>
+    </p:bg>
+    <p:spTree>
+      <p:nvGrpSpPr>
+        <p:cNvPr id="1" name=""/>
+        <p:cNvGrpSpPr/>
+        <p:nvPr/>
+      </p:nvGrpSpPr>
+      <p:grpSpPr>
+        <a:xfrm>
+          <a:off x="0" y="0"/>
+          <a:ext cx="0" cy="0"/>
+          <a:chOff x="0" y="0"/>
+          <a:chExt cx="0" cy="0"/>
+        </a:xfrm>
+      </p:grpSpPr>
+      <p:sp>
+        <p:nvSpPr>
+          <p:cNvPr id="2" name="Text 0"/>
+          <p:cNvSpPr/>
+          <p:nvPr/>
+        </p:nvSpPr>
+        <p:spPr>
+          <a:xfrm>
+            <a:off x="530352" y="283464"/>
+            <a:ext cx="11274552" cy="384048"/>
+          </a:xfrm>
+          <a:prstGeom prst="rect">
+            <a:avLst/>
+          </a:prstGeom>
+          <a:noFill/>
+          <a:ln/>
+        </p:spPr>
+        <p:txBody>
+          <a:bodyPr wrap="square" lIns="0" tIns="0" rIns="0" bIns="0" rtlCol="0" anchor="ctr"/>
+          <a:lstStyle/>
+          <a:p>
+            <a:pPr indent="0" marL="0">
+              <a:buNone/>
+            </a:pPr>
+            <a:r>
+              <a:rPr lang="en-US" sz="2200" b="1" dirty="0">
+                <a:solidFill>
+                  <a:srgbClr val="045D66"/>
+                </a:solidFill>
+                <a:latin typeface="Graphik TH" pitchFamily="34" charset="0"/>
+                <a:ea typeface="Graphik TH" pitchFamily="34" charset="-122"/>
+                <a:cs typeface="Graphik TH" pitchFamily="34" charset="-120"/>
+              </a:rPr>
+              <a:t>Move rate : deposit stickiness against rate sensitivity</a:t>
+            </a:r>
+            <a:endParaRPr lang="en-US" sz="2200" dirty="0"/>
+          </a:p>
+        </p:txBody>
+      </p:sp>
+      <p:sp>
+        <p:nvSpPr>
+          <p:cNvPr id="3" name="Text 1"/>
+          <p:cNvSpPr/>
+          <p:nvPr/>
+        </p:nvSpPr>
+        <p:spPr>
+          <a:xfrm>
+            <a:off x="530352" y="713232"/>
+            <a:ext cx="11274552" cy="237744"/>
+          </a:xfrm>
+          <a:prstGeom prst="rect">
+            <a:avLst/>
+          </a:prstGeom>
+          <a:noFill/>
+          <a:ln/>
+        </p:spPr>
+        <p:txBody>
+          <a:bodyPr wrap="square" lIns="0" tIns="0" rIns="0" bIns="0" rtlCol="0" anchor="ctr"/>
+          <a:lstStyle/>
+          <a:p>
+            <a:pPr indent="0" marL="0">
+              <a:buNone/>
+            </a:pPr>
+            <a:r>
+              <a:rPr lang="en-US" sz="1150" i="1" dirty="0">
+                <a:solidFill>
+                  <a:srgbClr val="6B6B6B"/>
+                </a:solidFill>
+                <a:latin typeface="Graphik TH" pitchFamily="34" charset="0"/>
+                <a:ea typeface="Graphik TH" pitchFamily="34" charset="-122"/>
+                <a:cs typeface="Graphik TH" pitchFamily="34" charset="-120"/>
+              </a:rPr>
+              <a:t>*Save Max holders with balance &gt; 0. 'Move' = Save Max balance now zero. Each cell shows the move rate with its customer count beneath.</a:t>
+            </a:r>
+            <a:endParaRPr lang="en-US" sz="1150" dirty="0"/>
+          </a:p>
+        </p:txBody>
+      </p:sp>
+      <p:sp>
+        <p:nvSpPr>
+          <p:cNvPr id="4" name="Text 2"/>
+          <p:cNvSpPr/>
+          <p:nvPr/>
+        </p:nvSpPr>
+        <p:spPr>
+          <a:xfrm>
+            <a:off x="548640" y="996696"/>
+            <a:ext cx="11064240" cy="237744"/>
+          </a:xfrm>
+          <a:prstGeom prst="rect">
+            <a:avLst/>
+          </a:prstGeom>
+          <a:noFill/>
+          <a:ln/>
+        </p:spPr>
+        <p:txBody>
+          <a:bodyPr wrap="square" lIns="0" tIns="0" rIns="0" bIns="0" rtlCol="0" anchor="ctr"/>
+          <a:lstStyle/>
+          <a:p>
+            <a:pPr indent="0" marL="0">
+              <a:buNone/>
+            </a:pPr>
+            <a:r>
+              <a:rPr lang="en-US" sz="1300" b="1" dirty="0">
+                <a:solidFill>
+                  <a:srgbClr val="045D66"/>
+                </a:solidFill>
+                <a:latin typeface="Graphik TH" pitchFamily="34" charset="0"/>
+                <a:ea typeface="Graphik TH" pitchFamily="34" charset="-122"/>
+                <a:cs typeface="Graphik TH" pitchFamily="34" charset="-120"/>
+              </a:rPr>
+              <a:t>Cohort 47,184   ·   Moved 6,671 (14.1%)   ·   Hottest cell: High stickiness × High sensitivity 56.2% on 2,788 customers</a:t>
+            </a:r>
+            <a:endParaRPr lang="en-US" sz="1300" dirty="0"/>
+          </a:p>
+        </p:txBody>
+      </p:sp>
+      <p:sp>
+        <p:nvSpPr>
+          <p:cNvPr id="5" name="Text 3"/>
+          <p:cNvSpPr/>
+          <p:nvPr/>
+        </p:nvSpPr>
+        <p:spPr>
+          <a:xfrm>
+            <a:off x="548640" y="1280160"/>
+            <a:ext cx="11064240" cy="274320"/>
+          </a:xfrm>
+          <a:prstGeom prst="rect">
+            <a:avLst/>
+          </a:prstGeom>
+          <a:noFill/>
+          <a:ln/>
+        </p:spPr>
+        <p:txBody>
+          <a:bodyPr wrap="square" lIns="0" tIns="0" rIns="0" bIns="0" rtlCol="0" anchor="ctr"/>
+          <a:lstStyle/>
+          <a:p>
+            <a:pPr indent="0" marL="0">
+              <a:buNone/>
+            </a:pPr>
+            <a:r>
+              <a:rPr lang="en-US" sz="1400" dirty="0">
+                <a:solidFill>
+                  <a:srgbClr val="16233D"/>
+                </a:solidFill>
+                <a:latin typeface="Graphik TH" pitchFamily="34" charset="0"/>
+                <a:ea typeface="Graphik TH" pitchFamily="34" charset="-122"/>
+                <a:cs typeface="Graphik TH" pitchFamily="34" charset="-120"/>
+              </a:rPr>
+              <a:t>Move rate climbs with both scores — the runoff sits in the sticky, rate-sensitive core, not in the low-stickiness corner.</a:t>
+            </a:r>
+            <a:endParaRPr lang="en-US" sz="1400" dirty="0"/>
+          </a:p>
+        </p:txBody>
+      </p:sp>
+      <p:sp>
+        <p:nvSpPr>
+          <p:cNvPr id="6" name="Shape 4"/>
+          <p:cNvSpPr/>
+          <p:nvPr/>
+        </p:nvSpPr>
+        <p:spPr>
+          <a:xfrm>
+            <a:off x="530352" y="1645920"/>
+            <a:ext cx="2647188" cy="987552"/>
+          </a:xfrm>
+          <a:prstGeom prst="roundRect">
+            <a:avLst>
+              <a:gd name="adj" fmla="val 8333"/>
+            </a:avLst>
+          </a:prstGeom>
+          <a:solidFill>
+            <a:srgbClr val="F1F4F9"/>
+          </a:solidFill>
+          <a:ln/>
+        </p:spPr>
+      </p:sp>
+      <p:sp>
+        <p:nvSpPr>
+          <p:cNvPr id="7" name="Text 5"/>
+          <p:cNvSpPr/>
+          <p:nvPr/>
+        </p:nvSpPr>
+        <p:spPr>
+          <a:xfrm>
+            <a:off x="749808" y="1719072"/>
+            <a:ext cx="2208276" cy="402336"/>
+          </a:xfrm>
+          <a:prstGeom prst="rect">
+            <a:avLst/>
+          </a:prstGeom>
+          <a:noFill/>
+          <a:ln/>
+        </p:spPr>
+        <p:txBody>
+          <a:bodyPr wrap="square" lIns="0" tIns="0" rIns="0" bIns="0" rtlCol="0" anchor="ctr"/>
+          <a:lstStyle/>
+          <a:p>
+            <a:pPr indent="0" marL="0">
+              <a:buNone/>
+            </a:pPr>
+            <a:r>
+              <a:rPr lang="en-US" sz="2400" b="1" dirty="0">
+                <a:solidFill>
+                  <a:srgbClr val="00A896"/>
+                </a:solidFill>
+                <a:latin typeface="Graphik TH" pitchFamily="34" charset="0"/>
+                <a:ea typeface="Graphik TH" pitchFamily="34" charset="-122"/>
+                <a:cs typeface="Graphik TH" pitchFamily="34" charset="-120"/>
+              </a:rPr>
+              <a:t>14.1%</a:t>
+            </a:r>
+            <a:endParaRPr lang="en-US" sz="2400" dirty="0"/>
+          </a:p>
+        </p:txBody>
+      </p:sp>
+      <p:sp>
+        <p:nvSpPr>
+          <p:cNvPr id="8" name="Text 6"/>
+          <p:cNvSpPr/>
+          <p:nvPr/>
+        </p:nvSpPr>
+        <p:spPr>
+          <a:xfrm>
+            <a:off x="749808" y="2121408"/>
+            <a:ext cx="2208276" cy="237744"/>
+          </a:xfrm>
+          <a:prstGeom prst="rect">
+            <a:avLst/>
+          </a:prstGeom>
+          <a:noFill/>
+          <a:ln/>
+        </p:spPr>
+        <p:txBody>
+          <a:bodyPr wrap="square" lIns="0" tIns="0" rIns="0" bIns="0" rtlCol="0" anchor="t"/>
+          <a:lstStyle/>
+          <a:p>
+            <a:pPr indent="0" marL="0">
+              <a:buNone/>
+            </a:pPr>
+            <a:r>
+              <a:rPr lang="en-US" sz="1150" b="1" dirty="0">
+                <a:solidFill>
+                  <a:srgbClr val="16233D"/>
+                </a:solidFill>
+                <a:latin typeface="Graphik TH" pitchFamily="34" charset="0"/>
+                <a:ea typeface="Graphik TH" pitchFamily="34" charset="-122"/>
+                <a:cs typeface="Graphik TH" pitchFamily="34" charset="-120"/>
+              </a:rPr>
+              <a:t>cohort move rate</a:t>
+            </a:r>
+            <a:endParaRPr lang="en-US" sz="1150" dirty="0"/>
+          </a:p>
+        </p:txBody>
+      </p:sp>
+      <p:sp>
+        <p:nvSpPr>
+          <p:cNvPr id="9" name="Text 7"/>
+          <p:cNvSpPr/>
+          <p:nvPr/>
+        </p:nvSpPr>
+        <p:spPr>
+          <a:xfrm>
+            <a:off x="749808" y="2350008"/>
+            <a:ext cx="2208276" cy="237744"/>
+          </a:xfrm>
+          <a:prstGeom prst="rect">
+            <a:avLst/>
+          </a:prstGeom>
+          <a:noFill/>
+          <a:ln/>
+        </p:spPr>
+        <p:txBody>
+          <a:bodyPr wrap="square" lIns="0" tIns="0" rIns="0" bIns="0" rtlCol="0" anchor="t"/>
+          <a:lstStyle/>
+          <a:p>
+            <a:pPr indent="0" marL="0">
+              <a:buNone/>
+            </a:pPr>
+            <a:r>
+              <a:rPr lang="en-US" sz="950" dirty="0">
+                <a:solidFill>
+                  <a:srgbClr val="6B7A90"/>
+                </a:solidFill>
+                <a:latin typeface="Graphik TH" pitchFamily="34" charset="0"/>
+                <a:ea typeface="Graphik TH" pitchFamily="34" charset="-122"/>
+                <a:cs typeface="Graphik TH" pitchFamily="34" charset="-120"/>
+              </a:rPr>
+              <a:t>6,671 of 47,184 emptied Save Max</a:t>
+            </a:r>
+            <a:endParaRPr lang="en-US" sz="950" dirty="0"/>
+          </a:p>
+        </p:txBody>
+      </p:sp>
+      <p:sp>
+        <p:nvSpPr>
+          <p:cNvPr id="10" name="Shape 8"/>
+          <p:cNvSpPr/>
+          <p:nvPr/>
+        </p:nvSpPr>
+        <p:spPr>
+          <a:xfrm>
+            <a:off x="3406140" y="1645920"/>
+            <a:ext cx="2647188" cy="987552"/>
+          </a:xfrm>
+          <a:prstGeom prst="roundRect">
+            <a:avLst>
+              <a:gd name="adj" fmla="val 8333"/>
+            </a:avLst>
+          </a:prstGeom>
+          <a:solidFill>
+            <a:srgbClr val="F1F4F9"/>
+          </a:solidFill>
+          <a:ln/>
+        </p:spPr>
+      </p:sp>
+      <p:sp>
+        <p:nvSpPr>
+          <p:cNvPr id="11" name="Text 9"/>
+          <p:cNvSpPr/>
+          <p:nvPr/>
+        </p:nvSpPr>
+        <p:spPr>
+          <a:xfrm>
+            <a:off x="3625596" y="1719072"/>
+            <a:ext cx="2208276" cy="402336"/>
+          </a:xfrm>
+          <a:prstGeom prst="rect">
+            <a:avLst/>
+          </a:prstGeom>
+          <a:noFill/>
+          <a:ln/>
+        </p:spPr>
+        <p:txBody>
+          <a:bodyPr wrap="square" lIns="0" tIns="0" rIns="0" bIns="0" rtlCol="0" anchor="ctr"/>
+          <a:lstStyle/>
+          <a:p>
+            <a:pPr indent="0" marL="0">
+              <a:buNone/>
+            </a:pPr>
+            <a:r>
+              <a:rPr lang="en-US" sz="2400" b="1" dirty="0">
+                <a:solidFill>
+                  <a:srgbClr val="C00000"/>
+                </a:solidFill>
+                <a:latin typeface="Graphik TH" pitchFamily="34" charset="0"/>
+                <a:ea typeface="Graphik TH" pitchFamily="34" charset="-122"/>
+                <a:cs typeface="Graphik TH" pitchFamily="34" charset="-120"/>
+              </a:rPr>
+              <a:t>56.2%</a:t>
+            </a:r>
+            <a:endParaRPr lang="en-US" sz="2400" dirty="0"/>
+          </a:p>
+        </p:txBody>
+      </p:sp>
+      <p:sp>
+        <p:nvSpPr>
+          <p:cNvPr id="12" name="Text 10"/>
+          <p:cNvSpPr/>
+          <p:nvPr/>
+        </p:nvSpPr>
+        <p:spPr>
+          <a:xfrm>
+            <a:off x="3625596" y="2121408"/>
+            <a:ext cx="2208276" cy="237744"/>
+          </a:xfrm>
+          <a:prstGeom prst="rect">
+            <a:avLst/>
+          </a:prstGeom>
+          <a:noFill/>
+          <a:ln/>
+        </p:spPr>
+        <p:txBody>
+          <a:bodyPr wrap="square" lIns="0" tIns="0" rIns="0" bIns="0" rtlCol="0" anchor="t"/>
+          <a:lstStyle/>
+          <a:p>
+            <a:pPr indent="0" marL="0">
+              <a:buNone/>
+            </a:pPr>
+            <a:r>
+              <a:rPr lang="en-US" sz="1150" b="1" dirty="0">
+                <a:solidFill>
+                  <a:srgbClr val="16233D"/>
+                </a:solidFill>
+                <a:latin typeface="Graphik TH" pitchFamily="34" charset="0"/>
+                <a:ea typeface="Graphik TH" pitchFamily="34" charset="-122"/>
+                <a:cs typeface="Graphik TH" pitchFamily="34" charset="-120"/>
+              </a:rPr>
+              <a:t>hottest cell</a:t>
+            </a:r>
+            <a:endParaRPr lang="en-US" sz="1150" dirty="0"/>
+          </a:p>
+        </p:txBody>
+      </p:sp>
+      <p:sp>
+        <p:nvSpPr>
+          <p:cNvPr id="13" name="Text 11"/>
+          <p:cNvSpPr/>
+          <p:nvPr/>
+        </p:nvSpPr>
+        <p:spPr>
+          <a:xfrm>
+            <a:off x="3625596" y="2350008"/>
+            <a:ext cx="2208276" cy="237744"/>
+          </a:xfrm>
+          <a:prstGeom prst="rect">
+            <a:avLst/>
+          </a:prstGeom>
+          <a:noFill/>
+          <a:ln/>
+        </p:spPr>
+        <p:txBody>
+          <a:bodyPr wrap="square" lIns="0" tIns="0" rIns="0" bIns="0" rtlCol="0" anchor="t"/>
+          <a:lstStyle/>
+          <a:p>
+            <a:pPr indent="0" marL="0">
+              <a:buNone/>
+            </a:pPr>
+            <a:r>
+              <a:rPr lang="en-US" sz="950" dirty="0">
+                <a:solidFill>
+                  <a:srgbClr val="6B7A90"/>
+                </a:solidFill>
+                <a:latin typeface="Graphik TH" pitchFamily="34" charset="0"/>
+                <a:ea typeface="Graphik TH" pitchFamily="34" charset="-122"/>
+                <a:cs typeface="Graphik TH" pitchFamily="34" charset="-120"/>
+              </a:rPr>
+              <a:t>High stickiness × High sensitivity</a:t>
+            </a:r>
+            <a:endParaRPr lang="en-US" sz="950" dirty="0"/>
+          </a:p>
+        </p:txBody>
+      </p:sp>
+      <p:sp>
+        <p:nvSpPr>
+          <p:cNvPr id="14" name="Shape 12"/>
+          <p:cNvSpPr/>
+          <p:nvPr/>
+        </p:nvSpPr>
+        <p:spPr>
+          <a:xfrm>
+            <a:off x="6281928" y="1645920"/>
+            <a:ext cx="2647188" cy="987552"/>
+          </a:xfrm>
+          <a:prstGeom prst="roundRect">
+            <a:avLst>
+              <a:gd name="adj" fmla="val 8333"/>
+            </a:avLst>
+          </a:prstGeom>
+          <a:solidFill>
+            <a:srgbClr val="F1F4F9"/>
+          </a:solidFill>
+          <a:ln/>
+        </p:spPr>
+      </p:sp>
+      <p:sp>
+        <p:nvSpPr>
+          <p:cNvPr id="15" name="Text 13"/>
+          <p:cNvSpPr/>
+          <p:nvPr/>
+        </p:nvSpPr>
+        <p:spPr>
+          <a:xfrm>
+            <a:off x="6501384" y="1719072"/>
+            <a:ext cx="2208276" cy="402336"/>
+          </a:xfrm>
+          <a:prstGeom prst="rect">
+            <a:avLst/>
+          </a:prstGeom>
+          <a:noFill/>
+          <a:ln/>
+        </p:spPr>
+        <p:txBody>
+          <a:bodyPr wrap="square" lIns="0" tIns="0" rIns="0" bIns="0" rtlCol="0" anchor="ctr"/>
+          <a:lstStyle/>
+          <a:p>
+            <a:pPr indent="0" marL="0">
+              <a:buNone/>
+            </a:pPr>
+            <a:r>
+              <a:rPr lang="en-US" sz="2400" b="1" dirty="0">
+                <a:solidFill>
+                  <a:srgbClr val="C00000"/>
+                </a:solidFill>
+                <a:latin typeface="Graphik TH" pitchFamily="34" charset="0"/>
+                <a:ea typeface="Graphik TH" pitchFamily="34" charset="-122"/>
+                <a:cs typeface="Graphik TH" pitchFamily="34" charset="-120"/>
+              </a:rPr>
+              <a:t>98.7%</a:t>
+            </a:r>
+            <a:endParaRPr lang="en-US" sz="2400" dirty="0"/>
+          </a:p>
+        </p:txBody>
+      </p:sp>
+      <p:sp>
+        <p:nvSpPr>
+          <p:cNvPr id="16" name="Text 14"/>
+          <p:cNvSpPr/>
+          <p:nvPr/>
+        </p:nvSpPr>
+        <p:spPr>
+          <a:xfrm>
+            <a:off x="6501384" y="2121408"/>
+            <a:ext cx="2208276" cy="237744"/>
+          </a:xfrm>
+          <a:prstGeom prst="rect">
+            <a:avLst/>
+          </a:prstGeom>
+          <a:noFill/>
+          <a:ln/>
+        </p:spPr>
+        <p:txBody>
+          <a:bodyPr wrap="square" lIns="0" tIns="0" rIns="0" bIns="0" rtlCol="0" anchor="t"/>
+          <a:lstStyle/>
+          <a:p>
+            <a:pPr indent="0" marL="0">
+              <a:buNone/>
+            </a:pPr>
+            <a:r>
+              <a:rPr lang="en-US" sz="1150" b="1" dirty="0">
+                <a:solidFill>
+                  <a:srgbClr val="16233D"/>
+                </a:solidFill>
+                <a:latin typeface="Graphik TH" pitchFamily="34" charset="0"/>
+                <a:ea typeface="Graphik TH" pitchFamily="34" charset="-122"/>
+                <a:cs typeface="Graphik TH" pitchFamily="34" charset="-120"/>
+              </a:rPr>
+              <a:t>of walked balance</a:t>
+            </a:r>
+            <a:endParaRPr lang="en-US" sz="1150" dirty="0"/>
+          </a:p>
+        </p:txBody>
+      </p:sp>
+      <p:sp>
+        <p:nvSpPr>
+          <p:cNvPr id="17" name="Text 15"/>
+          <p:cNvSpPr/>
+          <p:nvPr/>
+        </p:nvSpPr>
+        <p:spPr>
+          <a:xfrm>
+            <a:off x="6501384" y="2350008"/>
+            <a:ext cx="2208276" cy="237744"/>
+          </a:xfrm>
+          <a:prstGeom prst="rect">
+            <a:avLst/>
+          </a:prstGeom>
+          <a:noFill/>
+          <a:ln/>
+        </p:spPr>
+        <p:txBody>
+          <a:bodyPr wrap="square" lIns="0" tIns="0" rIns="0" bIns="0" rtlCol="0" anchor="t"/>
+          <a:lstStyle/>
+          <a:p>
+            <a:pPr indent="0" marL="0">
+              <a:buNone/>
+            </a:pPr>
+            <a:r>
+              <a:rPr lang="en-US" sz="950" dirty="0">
+                <a:solidFill>
+                  <a:srgbClr val="6B7A90"/>
+                </a:solidFill>
+                <a:latin typeface="Graphik TH" pitchFamily="34" charset="0"/>
+                <a:ea typeface="Graphik TH" pitchFamily="34" charset="-122"/>
+                <a:cs typeface="Graphik TH" pitchFamily="34" charset="-120"/>
+              </a:rPr>
+              <a:t>came from stickiness ≥ 60</a:t>
+            </a:r>
+            <a:endParaRPr lang="en-US" sz="950" dirty="0"/>
+          </a:p>
+        </p:txBody>
+      </p:sp>
+      <p:sp>
+        <p:nvSpPr>
+          <p:cNvPr id="18" name="Shape 16"/>
+          <p:cNvSpPr/>
+          <p:nvPr/>
+        </p:nvSpPr>
+        <p:spPr>
+          <a:xfrm>
+            <a:off x="9157716" y="1645920"/>
+            <a:ext cx="2647188" cy="987552"/>
+          </a:xfrm>
+          <a:prstGeom prst="roundRect">
+            <a:avLst>
+              <a:gd name="adj" fmla="val 8333"/>
+            </a:avLst>
+          </a:prstGeom>
+          <a:solidFill>
+            <a:srgbClr val="F1F4F9"/>
+          </a:solidFill>
+          <a:ln/>
+        </p:spPr>
+      </p:sp>
+      <p:sp>
+        <p:nvSpPr>
+          <p:cNvPr id="19" name="Text 17"/>
+          <p:cNvSpPr/>
+          <p:nvPr/>
+        </p:nvSpPr>
+        <p:spPr>
+          <a:xfrm>
+            <a:off x="9377172" y="1719072"/>
+            <a:ext cx="2208276" cy="402336"/>
+          </a:xfrm>
+          <a:prstGeom prst="rect">
+            <a:avLst/>
+          </a:prstGeom>
+          <a:noFill/>
+          <a:ln/>
+        </p:spPr>
+        <p:txBody>
+          <a:bodyPr wrap="square" lIns="0" tIns="0" rIns="0" bIns="0" rtlCol="0" anchor="ctr"/>
+          <a:lstStyle/>
+          <a:p>
+            <a:pPr indent="0" marL="0">
+              <a:buNone/>
+            </a:pPr>
+            <a:r>
+              <a:rPr lang="en-US" sz="2400" b="1" dirty="0">
+                <a:solidFill>
+                  <a:srgbClr val="6B7A90"/>
+                </a:solidFill>
+                <a:latin typeface="Graphik TH" pitchFamily="34" charset="0"/>
+                <a:ea typeface="Graphik TH" pitchFamily="34" charset="-122"/>
+                <a:cs typeface="Graphik TH" pitchFamily="34" charset="-120"/>
+              </a:rPr>
+              <a:t>297</a:t>
+            </a:r>
+            <a:endParaRPr lang="en-US" sz="2400" dirty="0"/>
+          </a:p>
+        </p:txBody>
+      </p:sp>
+      <p:sp>
+        <p:nvSpPr>
+          <p:cNvPr id="20" name="Text 18"/>
+          <p:cNvSpPr/>
+          <p:nvPr/>
+        </p:nvSpPr>
+        <p:spPr>
+          <a:xfrm>
+            <a:off x="9377172" y="2121408"/>
+            <a:ext cx="2208276" cy="237744"/>
+          </a:xfrm>
+          <a:prstGeom prst="rect">
+            <a:avLst/>
+          </a:prstGeom>
+          <a:noFill/>
+          <a:ln/>
+        </p:spPr>
+        <p:txBody>
+          <a:bodyPr wrap="square" lIns="0" tIns="0" rIns="0" bIns="0" rtlCol="0" anchor="t"/>
+          <a:lstStyle/>
+          <a:p>
+            <a:pPr indent="0" marL="0">
+              <a:buNone/>
+            </a:pPr>
+            <a:r>
+              <a:rPr lang="en-US" sz="1150" b="1" dirty="0">
+                <a:solidFill>
+                  <a:srgbClr val="16233D"/>
+                </a:solidFill>
+                <a:latin typeface="Graphik TH" pitchFamily="34" charset="0"/>
+                <a:ea typeface="Graphik TH" pitchFamily="34" charset="-122"/>
+                <a:cs typeface="Graphik TH" pitchFamily="34" charset="-120"/>
+              </a:rPr>
+              <a:t>in the 'fragile' corner</a:t>
+            </a:r>
+            <a:endParaRPr lang="en-US" sz="1150" dirty="0"/>
+          </a:p>
+        </p:txBody>
+      </p:sp>
+      <p:sp>
+        <p:nvSpPr>
+          <p:cNvPr id="21" name="Text 19"/>
+          <p:cNvSpPr/>
+          <p:nvPr/>
+        </p:nvSpPr>
+        <p:spPr>
+          <a:xfrm>
+            <a:off x="9377172" y="2350008"/>
+            <a:ext cx="2208276" cy="237744"/>
+          </a:xfrm>
+          <a:prstGeom prst="rect">
+            <a:avLst/>
+          </a:prstGeom>
+          <a:noFill/>
+          <a:ln/>
+        </p:spPr>
+        <p:txBody>
+          <a:bodyPr wrap="square" lIns="0" tIns="0" rIns="0" bIns="0" rtlCol="0" anchor="t"/>
+          <a:lstStyle/>
+          <a:p>
+            <a:pPr indent="0" marL="0">
+              <a:buNone/>
+            </a:pPr>
+            <a:r>
+              <a:rPr lang="en-US" sz="950" dirty="0">
+                <a:solidFill>
+                  <a:srgbClr val="6B7A90"/>
+                </a:solidFill>
+                <a:latin typeface="Graphik TH" pitchFamily="34" charset="0"/>
+                <a:ea typeface="Graphik TH" pitchFamily="34" charset="-122"/>
+                <a:cs typeface="Graphik TH" pitchFamily="34" charset="-120"/>
+              </a:rPr>
+              <a:t>stickiness &lt; 60 and RS ≥ 60</a:t>
+            </a:r>
+            <a:endParaRPr lang="en-US" sz="950" dirty="0"/>
+          </a:p>
+        </p:txBody>
+      </p:sp>
+      <p:sp>
+        <p:nvSpPr>
+          <p:cNvPr id="22" name="Shape 20"/>
+          <p:cNvSpPr/>
+          <p:nvPr/>
+        </p:nvSpPr>
+        <p:spPr>
+          <a:xfrm>
+            <a:off x="530352" y="2798064"/>
+            <a:ext cx="6720840" cy="2322576"/>
+          </a:xfrm>
+          <a:prstGeom prst="roundRect">
+            <a:avLst>
+              <a:gd name="adj" fmla="val 3543"/>
+            </a:avLst>
+          </a:prstGeom>
+          <a:solidFill>
+            <a:srgbClr val="F1F4F9"/>
+          </a:solidFill>
+          <a:ln/>
+        </p:spPr>
+      </p:sp>
+      <p:sp>
+        <p:nvSpPr>
+          <p:cNvPr id="23" name="Text 21"/>
+          <p:cNvSpPr/>
+          <p:nvPr/>
+        </p:nvSpPr>
+        <p:spPr>
+          <a:xfrm>
+            <a:off x="786384" y="2944368"/>
+            <a:ext cx="6208776" cy="274320"/>
+          </a:xfrm>
+          <a:prstGeom prst="rect">
+            <a:avLst/>
+          </a:prstGeom>
+          <a:noFill/>
+          <a:ln/>
+        </p:spPr>
+        <p:txBody>
+          <a:bodyPr wrap="square" lIns="0" tIns="0" rIns="0" bIns="0" rtlCol="0" anchor="ctr"/>
+          <a:lstStyle/>
+          <a:p>
+            <a:pPr indent="0" marL="0">
+              <a:buNone/>
+            </a:pPr>
+            <a:r>
+              <a:rPr lang="en-US" sz="1400" b="1" dirty="0">
+                <a:solidFill>
+                  <a:srgbClr val="16233D"/>
+                </a:solidFill>
+                <a:latin typeface="Cambria" pitchFamily="34" charset="0"/>
+                <a:ea typeface="Cambria" pitchFamily="34" charset="-122"/>
+                <a:cs typeface="Cambria" pitchFamily="34" charset="-120"/>
+              </a:rPr>
+              <a:t>Move rate by cell</a:t>
+            </a:r>
+            <a:endParaRPr lang="en-US" sz="1400" dirty="0"/>
+          </a:p>
+        </p:txBody>
+      </p:sp>
+      <p:sp>
+        <p:nvSpPr>
+          <p:cNvPr id="24" name="Text 22"/>
+          <p:cNvSpPr/>
+          <p:nvPr/>
+        </p:nvSpPr>
+        <p:spPr>
+          <a:xfrm>
+            <a:off x="786384" y="3218688"/>
+            <a:ext cx="6208776" cy="237744"/>
+          </a:xfrm>
+          <a:prstGeom prst="rect">
+            <a:avLst/>
+          </a:prstGeom>
+          <a:noFill/>
+          <a:ln/>
+        </p:spPr>
+        <p:txBody>
+          <a:bodyPr wrap="square" lIns="0" tIns="0" rIns="0" bIns="0" rtlCol="0" anchor="ctr"/>
+          <a:lstStyle/>
+          <a:p>
+            <a:pPr indent="0" marL="0">
+              <a:buNone/>
+            </a:pPr>
+            <a:r>
+              <a:rPr lang="en-US" sz="950" dirty="0">
+                <a:solidFill>
+                  <a:srgbClr val="6B7A90"/>
+                </a:solidFill>
+                <a:latin typeface="Graphik TH" pitchFamily="34" charset="0"/>
+                <a:ea typeface="Graphik TH" pitchFamily="34" charset="-122"/>
+                <a:cs typeface="Graphik TH" pitchFamily="34" charset="-120"/>
+              </a:rPr>
+              <a:t>Rows: deposit stickiness · columns: rate sensitivity · shaded by move rate</a:t>
+            </a:r>
+            <a:endParaRPr lang="en-US" sz="950" dirty="0"/>
+          </a:p>
+        </p:txBody>
+      </p:sp>
+      <p:graphicFrame>
+        <p:nvGraphicFramePr>
+          <p:cNvPr id="13" name="Table 0"/>
+          <p:cNvGraphicFramePr>
+            <a:graphicFrameLocks noGrp="1"/>
+          </p:cNvGraphicFramePr>
+          <p:nvPr>
+            <p:extLst>
+              <p:ext uri="{D42A27DB-BD31-4B8C-83A1-F6EECF244321}">
+                <p14:modId xmlns:p14="http://schemas.microsoft.com/office/powerpoint/2010/main" val="1579011935"/>
+              </p:ext>
+            </p:extLst>
+          </p:nvPr>
+        </p:nvGraphicFramePr>
+        <p:xfrm>
+          <a:off x="749808" y="3474720"/>
+          <a:ext cx="6281928" cy="914400"/>
+        </p:xfrm>
+        <a:graphic>
+          <a:graphicData uri="http://schemas.openxmlformats.org/drawingml/2006/table">
+            <a:tbl>
+              <a:tblPr/>
+              <a:tblGrid>
+                <a:gridCol w="1161288"/>
+                <a:gridCol w="1024128"/>
+                <a:gridCol w="1024128"/>
+                <a:gridCol w="1024128"/>
+                <a:gridCol w="1024128"/>
+                <a:gridCol w="1024128"/>
+              </a:tblGrid>
+              <a:tr h="237744">
+                <a:tc>
+                  <a:txBody>
+                    <a:bodyPr/>
+                    <a:lstStyle/>
+                    <a:p>
+                      <a:pPr algn="l" indent="0" marL="0">
+                        <a:buNone/>
+                      </a:pPr>
+                      <a:r>
+                        <a:rPr lang="en-US" sz="900" b="1" dirty="0">
+                          <a:solidFill>
+                            <a:srgbClr val="FFFFFF"/>
+                          </a:solidFill>
+                          <a:latin typeface="Graphik TH" pitchFamily="34" charset="0"/>
+                          <a:ea typeface="Graphik TH" pitchFamily="34" charset="-122"/>
+                          <a:cs typeface="Graphik TH" pitchFamily="34" charset="-120"/>
+                        </a:rPr>
+                        <a:t>Stickiness</a:t>
+                      </a:r>
+                      <a:endParaRPr lang="en-US" sz="900" dirty="0">
+                        <a:latin typeface="Graphik TH" charset="0"/>
+                        <a:ea typeface="Graphik TH" charset="0"/>
+                        <a:cs typeface="Graphik TH" charset="0"/>
+                      </a:endParaRPr>
+                    </a:p>
+                  </a:txBody>
+                  <a:tcPr marL="36576" marR="36576" marT="9144" marB="9144" anchor="ctr">
+                    <a:lnL w="6350" cap="flat" cmpd="sng" algn="ctr">
+                      <a:solidFill>
+                        <a:srgbClr val="D8DFE9"/>
+                      </a:solidFill>
+                      <a:prstDash val="solid"/>
+                      <a:round/>
+                      <a:headEnd type="none" w="med" len="med"/>
+                      <a:tailEnd type="none" w="med" len="med"/>
+                    </a:lnL>
+                    <a:lnR w="6350" cap="flat" cmpd="sng" algn="ctr">
+                      <a:solidFill>
+                        <a:srgbClr val="D8DFE9"/>
+                      </a:solidFill>
+                      <a:prstDash val="solid"/>
+                      <a:round/>
+                      <a:headEnd type="none" w="med" len="med"/>
+                      <a:tailEnd type="none" w="med" len="med"/>
+                    </a:lnR>
+                    <a:lnT w="6350" cap="flat" cmpd="sng" algn="ctr">
+                      <a:solidFill>
+                        <a:srgbClr val="D8DFE9"/>
+                      </a:solidFill>
+                      <a:prstDash val="solid"/>
+                      <a:round/>
+                      <a:headEnd type="none" w="med" len="med"/>
+                      <a:tailEnd type="none" w="med" len="med"/>
+                    </a:lnT>
+                    <a:lnB w="6350" cap="flat" cmpd="sng" algn="ctr">
+                      <a:solidFill>
+                        <a:srgbClr val="D8DFE9"/>
+                      </a:solidFill>
+                      <a:prstDash val="solid"/>
+                      <a:round/>
+                      <a:headEnd type="none" w="med" len="med"/>
+                      <a:tailEnd type="none" w="med" len="med"/>
+                    </a:lnB>
+                    <a:solidFill>
+                      <a:srgbClr val="045D66"/>
+                    </a:solidFill>
+                  </a:tcPr>
+                </a:tc>
+                <a:tc>
+                  <a:txBody>
+                    <a:bodyPr/>
+                    <a:lstStyle/>
+                    <a:p>
+                      <a:pPr algn="ctr" indent="0" marL="0">
+                        <a:buNone/>
+                      </a:pPr>
+                      <a:r>
+                        <a:rPr lang="en-US" sz="900" b="1" dirty="0">
+                          <a:solidFill>
+                            <a:srgbClr val="FFFFFF"/>
+                          </a:solidFill>
+                          <a:latin typeface="Graphik TH" pitchFamily="34" charset="0"/>
+                          <a:ea typeface="Graphik TH" pitchFamily="34" charset="-122"/>
+                          <a:cs typeface="Graphik TH" pitchFamily="34" charset="-120"/>
+                        </a:rPr>
+                        <a:t>Very Low</a:t>
+                      </a:r>
+                      <a:endParaRPr lang="en-US" sz="900" dirty="0">
+                        <a:latin typeface="Graphik TH" charset="0"/>
+                        <a:ea typeface="Graphik TH" charset="0"/>
+                        <a:cs typeface="Graphik TH" charset="0"/>
+                      </a:endParaRPr>
+                    </a:p>
+                  </a:txBody>
+                  <a:tcPr marL="36576" marR="36576" marT="9144" marB="9144" anchor="ctr">
+                    <a:lnL w="6350" cap="flat" cmpd="sng" algn="ctr">
+                      <a:solidFill>
+                        <a:srgbClr val="D8DFE9"/>
+                      </a:solidFill>
+                      <a:prstDash val="solid"/>
+                      <a:round/>
+                      <a:headEnd type="none" w="med" len="med"/>
+                      <a:tailEnd type="none" w="med" len="med"/>
+                    </a:lnL>
+                    <a:lnR w="6350" cap="flat" cmpd="sng" algn="ctr">
+                      <a:solidFill>
+                        <a:srgbClr val="D8DFE9"/>
+                      </a:solidFill>
+                      <a:prstDash val="solid"/>
+                      <a:round/>
+                      <a:headEnd type="none" w="med" len="med"/>
+                      <a:tailEnd type="none" w="med" len="med"/>
+                    </a:lnR>
+                    <a:lnT w="6350" cap="flat" cmpd="sng" algn="ctr">
+                      <a:solidFill>
+                        <a:srgbClr val="D8DFE9"/>
+                      </a:solidFill>
+                      <a:prstDash val="solid"/>
+                      <a:round/>
+                      <a:headEnd type="none" w="med" len="med"/>
+                      <a:tailEnd type="none" w="med" len="med"/>
+                    </a:lnT>
+                    <a:lnB w="6350" cap="flat" cmpd="sng" algn="ctr">
+                      <a:solidFill>
+                        <a:srgbClr val="D8DFE9"/>
+                      </a:solidFill>
+                      <a:prstDash val="solid"/>
+                      <a:round/>
+                      <a:headEnd type="none" w="med" len="med"/>
+                      <a:tailEnd type="none" w="med" len="med"/>
+                    </a:lnB>
+                    <a:solidFill>
+                      <a:srgbClr val="045D66"/>
+                    </a:solidFill>
+                  </a:tcPr>
+                </a:tc>
+                <a:tc>
+                  <a:txBody>
+                    <a:bodyPr/>
+                    <a:lstStyle/>
+                    <a:p>
+                      <a:pPr algn="ctr" indent="0" marL="0">
+                        <a:buNone/>
+                      </a:pPr>
+                      <a:r>
+                        <a:rPr lang="en-US" sz="900" b="1" dirty="0">
+                          <a:solidFill>
+                            <a:srgbClr val="FFFFFF"/>
+                          </a:solidFill>
+                          <a:latin typeface="Graphik TH" pitchFamily="34" charset="0"/>
+                          <a:ea typeface="Graphik TH" pitchFamily="34" charset="-122"/>
+                          <a:cs typeface="Graphik TH" pitchFamily="34" charset="-120"/>
+                        </a:rPr>
+                        <a:t>Low</a:t>
+                      </a:r>
+                      <a:endParaRPr lang="en-US" sz="900" dirty="0">
+                        <a:latin typeface="Graphik TH" charset="0"/>
+                        <a:ea typeface="Graphik TH" charset="0"/>
+                        <a:cs typeface="Graphik TH" charset="0"/>
+                      </a:endParaRPr>
+                    </a:p>
+                  </a:txBody>
+                  <a:tcPr marL="36576" marR="36576" marT="9144" marB="9144" anchor="ctr">
+                    <a:lnL w="6350" cap="flat" cmpd="sng" algn="ctr">
+                      <a:solidFill>
+                        <a:srgbClr val="D8DFE9"/>
+                      </a:solidFill>
+                      <a:prstDash val="solid"/>
+                      <a:round/>
+                      <a:headEnd type="none" w="med" len="med"/>
+                      <a:tailEnd type="none" w="med" len="med"/>
+                    </a:lnL>
+                    <a:lnR w="6350" cap="flat" cmpd="sng" algn="ctr">
+                      <a:solidFill>
+                        <a:srgbClr val="D8DFE9"/>
+                      </a:solidFill>
+                      <a:prstDash val="solid"/>
+                      <a:round/>
+                      <a:headEnd type="none" w="med" len="med"/>
+                      <a:tailEnd type="none" w="med" len="med"/>
+                    </a:lnR>
+                    <a:lnT w="6350" cap="flat" cmpd="sng" algn="ctr">
+                      <a:solidFill>
+                        <a:srgbClr val="D8DFE9"/>
+                      </a:solidFill>
+                      <a:prstDash val="solid"/>
+                      <a:round/>
+                      <a:headEnd type="none" w="med" len="med"/>
+                      <a:tailEnd type="none" w="med" len="med"/>
+                    </a:lnT>
+                    <a:lnB w="6350" cap="flat" cmpd="sng" algn="ctr">
+                      <a:solidFill>
+                        <a:srgbClr val="D8DFE9"/>
+                      </a:solidFill>
+                      <a:prstDash val="solid"/>
+                      <a:round/>
+                      <a:headEnd type="none" w="med" len="med"/>
+                      <a:tailEnd type="none" w="med" len="med"/>
+                    </a:lnB>
+                    <a:solidFill>
+                      <a:srgbClr val="045D66"/>
+                    </a:solidFill>
+                  </a:tcPr>
+                </a:tc>
+                <a:tc>
+                  <a:txBody>
+                    <a:bodyPr/>
+                    <a:lstStyle/>
+                    <a:p>
+                      <a:pPr algn="ctr" indent="0" marL="0">
+                        <a:buNone/>
+                      </a:pPr>
+                      <a:r>
+                        <a:rPr lang="en-US" sz="900" b="1" dirty="0">
+                          <a:solidFill>
+                            <a:srgbClr val="FFFFFF"/>
+                          </a:solidFill>
+                          <a:latin typeface="Graphik TH" pitchFamily="34" charset="0"/>
+                          <a:ea typeface="Graphik TH" pitchFamily="34" charset="-122"/>
+                          <a:cs typeface="Graphik TH" pitchFamily="34" charset="-120"/>
+                        </a:rPr>
+                        <a:t>Medium</a:t>
+                      </a:r>
+                      <a:endParaRPr lang="en-US" sz="900" dirty="0">
+                        <a:latin typeface="Graphik TH" charset="0"/>
+                        <a:ea typeface="Graphik TH" charset="0"/>
+                        <a:cs typeface="Graphik TH" charset="0"/>
+                      </a:endParaRPr>
+                    </a:p>
+                  </a:txBody>
+                  <a:tcPr marL="36576" marR="36576" marT="9144" marB="9144" anchor="ctr">
+                    <a:lnL w="6350" cap="flat" cmpd="sng" algn="ctr">
+                      <a:solidFill>
+                        <a:srgbClr val="D8DFE9"/>
+                      </a:solidFill>
+                      <a:prstDash val="solid"/>
+                      <a:round/>
+                      <a:headEnd type="none" w="med" len="med"/>
+                      <a:tailEnd type="none" w="med" len="med"/>
+                    </a:lnL>
+                    <a:lnR w="6350" cap="flat" cmpd="sng" algn="ctr">
+                      <a:solidFill>
+                        <a:srgbClr val="D8DFE9"/>
+                      </a:solidFill>
+                      <a:prstDash val="solid"/>
+                      <a:round/>
+                      <a:headEnd type="none" w="med" len="med"/>
+                      <a:tailEnd type="none" w="med" len="med"/>
+                    </a:lnR>
+                    <a:lnT w="6350" cap="flat" cmpd="sng" algn="ctr">
+                      <a:solidFill>
+                        <a:srgbClr val="D8DFE9"/>
+                      </a:solidFill>
+                      <a:prstDash val="solid"/>
+                      <a:round/>
+                      <a:headEnd type="none" w="med" len="med"/>
+                      <a:tailEnd type="none" w="med" len="med"/>
+                    </a:lnT>
+                    <a:lnB w="6350" cap="flat" cmpd="sng" algn="ctr">
+                      <a:solidFill>
+                        <a:srgbClr val="D8DFE9"/>
+                      </a:solidFill>
+                      <a:prstDash val="solid"/>
+                      <a:round/>
+                      <a:headEnd type="none" w="med" len="med"/>
+                      <a:tailEnd type="none" w="med" len="med"/>
+                    </a:lnB>
+                    <a:solidFill>
+                      <a:srgbClr val="045D66"/>
+                    </a:solidFill>
+                  </a:tcPr>
+                </a:tc>
+                <a:tc>
+                  <a:txBody>
+                    <a:bodyPr/>
+                    <a:lstStyle/>
+                    <a:p>
+                      <a:pPr algn="ctr" indent="0" marL="0">
+                        <a:buNone/>
+                      </a:pPr>
+                      <a:r>
+                        <a:rPr lang="en-US" sz="900" b="1" dirty="0">
+                          <a:solidFill>
+                            <a:srgbClr val="FFFFFF"/>
+                          </a:solidFill>
+                          <a:latin typeface="Graphik TH" pitchFamily="34" charset="0"/>
+                          <a:ea typeface="Graphik TH" pitchFamily="34" charset="-122"/>
+                          <a:cs typeface="Graphik TH" pitchFamily="34" charset="-120"/>
+                        </a:rPr>
+                        <a:t>High</a:t>
+                      </a:r>
+                      <a:endParaRPr lang="en-US" sz="900" dirty="0">
+                        <a:latin typeface="Graphik TH" charset="0"/>
+                        <a:ea typeface="Graphik TH" charset="0"/>
+                        <a:cs typeface="Graphik TH" charset="0"/>
+                      </a:endParaRPr>
+                    </a:p>
+                  </a:txBody>
+                  <a:tcPr marL="36576" marR="36576" marT="9144" marB="9144" anchor="ctr">
+                    <a:lnL w="6350" cap="flat" cmpd="sng" algn="ctr">
+                      <a:solidFill>
+                        <a:srgbClr val="D8DFE9"/>
+                      </a:solidFill>
+                      <a:prstDash val="solid"/>
+                      <a:round/>
+                      <a:headEnd type="none" w="med" len="med"/>
+                      <a:tailEnd type="none" w="med" len="med"/>
+                    </a:lnL>
+                    <a:lnR w="6350" cap="flat" cmpd="sng" algn="ctr">
+                      <a:solidFill>
+                        <a:srgbClr val="D8DFE9"/>
+                      </a:solidFill>
+                      <a:prstDash val="solid"/>
+                      <a:round/>
+                      <a:headEnd type="none" w="med" len="med"/>
+                      <a:tailEnd type="none" w="med" len="med"/>
+                    </a:lnR>
+                    <a:lnT w="6350" cap="flat" cmpd="sng" algn="ctr">
+                      <a:solidFill>
+                        <a:srgbClr val="D8DFE9"/>
+                      </a:solidFill>
+                      <a:prstDash val="solid"/>
+                      <a:round/>
+                      <a:headEnd type="none" w="med" len="med"/>
+                      <a:tailEnd type="none" w="med" len="med"/>
+                    </a:lnT>
+                    <a:lnB w="6350" cap="flat" cmpd="sng" algn="ctr">
+                      <a:solidFill>
+                        <a:srgbClr val="D8DFE9"/>
+                      </a:solidFill>
+                      <a:prstDash val="solid"/>
+                      <a:round/>
+                      <a:headEnd type="none" w="med" len="med"/>
+                      <a:tailEnd type="none" w="med" len="med"/>
+                    </a:lnB>
+                    <a:solidFill>
+                      <a:srgbClr val="045D66"/>
+                    </a:solidFill>
+                  </a:tcPr>
+                </a:tc>
+                <a:tc>
+                  <a:txBody>
+                    <a:bodyPr/>
+                    <a:lstStyle/>
+                    <a:p>
+                      <a:pPr algn="ctr" indent="0" marL="0">
+                        <a:buNone/>
+                      </a:pPr>
+                      <a:r>
+                        <a:rPr lang="en-US" sz="900" b="1" dirty="0">
+                          <a:solidFill>
+                            <a:srgbClr val="FFFFFF"/>
+                          </a:solidFill>
+                          <a:latin typeface="Graphik TH" pitchFamily="34" charset="0"/>
+                          <a:ea typeface="Graphik TH" pitchFamily="34" charset="-122"/>
+                          <a:cs typeface="Graphik TH" pitchFamily="34" charset="-120"/>
+                        </a:rPr>
+                        <a:t>Very High</a:t>
+                      </a:r>
+                      <a:endParaRPr lang="en-US" sz="900" dirty="0">
+                        <a:latin typeface="Graphik TH" charset="0"/>
+                        <a:ea typeface="Graphik TH" charset="0"/>
+                        <a:cs typeface="Graphik TH" charset="0"/>
+                      </a:endParaRPr>
+                    </a:p>
+                  </a:txBody>
+                  <a:tcPr marL="36576" marR="36576" marT="9144" marB="9144" anchor="ctr">
+                    <a:lnL w="6350" cap="flat" cmpd="sng" algn="ctr">
+                      <a:solidFill>
+                        <a:srgbClr val="D8DFE9"/>
+                      </a:solidFill>
+                      <a:prstDash val="solid"/>
+                      <a:round/>
+                      <a:headEnd type="none" w="med" len="med"/>
+                      <a:tailEnd type="none" w="med" len="med"/>
+                    </a:lnL>
+                    <a:lnR w="6350" cap="flat" cmpd="sng" algn="ctr">
+                      <a:solidFill>
+                        <a:srgbClr val="D8DFE9"/>
+                      </a:solidFill>
+                      <a:prstDash val="solid"/>
+                      <a:round/>
+                      <a:headEnd type="none" w="med" len="med"/>
+                      <a:tailEnd type="none" w="med" len="med"/>
+                    </a:lnR>
+                    <a:lnT w="6350" cap="flat" cmpd="sng" algn="ctr">
+                      <a:solidFill>
+                        <a:srgbClr val="D8DFE9"/>
+                      </a:solidFill>
+                      <a:prstDash val="solid"/>
+                      <a:round/>
+                      <a:headEnd type="none" w="med" len="med"/>
+                      <a:tailEnd type="none" w="med" len="med"/>
+                    </a:lnT>
+                    <a:lnB w="6350" cap="flat" cmpd="sng" algn="ctr">
+                      <a:solidFill>
+                        <a:srgbClr val="D8DFE9"/>
+                      </a:solidFill>
+                      <a:prstDash val="solid"/>
+                      <a:round/>
+                      <a:headEnd type="none" w="med" len="med"/>
+                      <a:tailEnd type="none" w="med" len="med"/>
+                    </a:lnB>
+                    <a:solidFill>
+                      <a:srgbClr val="045D66"/>
+                    </a:solidFill>
+                  </a:tcPr>
+                </a:tc>
+              </a:tr>
+              <a:tr h="274320">
+                <a:tc>
+                  <a:txBody>
+                    <a:bodyPr/>
+                    <a:lstStyle/>
+                    <a:p>
+                      <a:pPr algn="l" indent="0" marL="0">
+                        <a:buNone/>
+                      </a:pPr>
+                      <a:r>
+                        <a:rPr lang="en-US" sz="950" b="1" dirty="0">
+                          <a:solidFill>
+                            <a:srgbClr val="16233D"/>
+                          </a:solidFill>
+                          <a:latin typeface="Graphik TH" pitchFamily="34" charset="0"/>
+                          <a:ea typeface="Graphik TH" pitchFamily="34" charset="-122"/>
+                          <a:cs typeface="Graphik TH" pitchFamily="34" charset="-120"/>
+                        </a:rPr>
+                        <a:t>Very High</a:t>
+                      </a:r>
+                      <a:endParaRPr lang="en-US" sz="950" dirty="0">
+                        <a:latin typeface="Graphik TH" charset="0"/>
+                        <a:ea typeface="Graphik TH" charset="0"/>
+                        <a:cs typeface="Graphik TH" charset="0"/>
+                      </a:endParaRPr>
+                    </a:p>
+                  </a:txBody>
+                  <a:tcPr marL="36576" marR="36576" marT="9144" marB="9144" anchor="ctr">
+                    <a:lnL w="6350" cap="flat" cmpd="sng" algn="ctr">
+                      <a:solidFill>
+                        <a:srgbClr val="D8DFE9"/>
+                      </a:solidFill>
+                      <a:prstDash val="solid"/>
+                      <a:round/>
+                      <a:headEnd type="none" w="med" len="med"/>
+                      <a:tailEnd type="none" w="med" len="med"/>
+                    </a:lnL>
+                    <a:lnR w="6350" cap="flat" cmpd="sng" algn="ctr">
+                      <a:solidFill>
+                        <a:srgbClr val="D8DFE9"/>
+                      </a:solidFill>
+                      <a:prstDash val="solid"/>
+                      <a:round/>
+                      <a:headEnd type="none" w="med" len="med"/>
+                      <a:tailEnd type="none" w="med" len="med"/>
+                    </a:lnR>
+                    <a:lnT w="6350" cap="flat" cmpd="sng" algn="ctr">
+                      <a:solidFill>
+                        <a:srgbClr val="D8DFE9"/>
+                      </a:solidFill>
+                      <a:prstDash val="solid"/>
+                      <a:round/>
+                      <a:headEnd type="none" w="med" len="med"/>
+                      <a:tailEnd type="none" w="med" len="med"/>
+                    </a:lnT>
+                    <a:lnB w="6350" cap="flat" cmpd="sng" algn="ctr">
+                      <a:solidFill>
+                        <a:srgbClr val="D8DFE9"/>
+                      </a:solidFill>
+                      <a:prstDash val="solid"/>
+                      <a:round/>
+                      <a:headEnd type="none" w="med" len="med"/>
+                      <a:tailEnd type="none" w="med" len="med"/>
+                    </a:lnB>
+                    <a:solidFill>
+                      <a:srgbClr val="F1F4F9"/>
+                    </a:solidFill>
+                  </a:tcPr>
+                </a:tc>
+                <a:tc>
+                  <a:txBody>
+                    <a:bodyPr/>
+                    <a:lstStyle/>
+                    <a:p>
+                      <a:pPr algn="ctr" indent="0" marL="0">
+                        <a:buNone/>
+                      </a:pPr>
+                      <a:r>
+                        <a:rPr lang="en-US" sz="950" b="1" dirty="0">
+                          <a:solidFill>
+                            <a:srgbClr val="16233D"/>
+                          </a:solidFill>
+                          <a:latin typeface="Graphik TH" pitchFamily="34" charset="0"/>
+                          <a:ea typeface="Graphik TH" pitchFamily="34" charset="-122"/>
+                          <a:cs typeface="Graphik TH" pitchFamily="34" charset="-120"/>
+                        </a:rPr>
+                        <a:t>12.8%</a:t>
+                      </a:r>
+                      <a:pPr algn="ctr" indent="0" marL="0">
+                        <a:buNone/>
+                      </a:pPr>
+                      <a:endParaRPr lang="en-US" sz="1200" dirty="0"/>
+                    </a:p>
+                    <a:p>
+                      <a:pPr algn="ctr" indent="0" marL="0">
+                        <a:buNone/>
+                      </a:pPr>
+                      <a:r>
+                        <a:rPr lang="en-US" sz="700" dirty="0">
+                          <a:solidFill>
+                            <a:srgbClr val="6B7A90"/>
+                          </a:solidFill>
+                          <a:latin typeface="Graphik TH" pitchFamily="34" charset="0"/>
+                          <a:ea typeface="Graphik TH" pitchFamily="34" charset="-122"/>
+                          <a:cs typeface="Graphik TH" pitchFamily="34" charset="-120"/>
+                        </a:rPr>
+                        <a:t>890</a:t>
+                      </a:r>
+                      <a:endParaRPr lang="en-US" sz="1200" dirty="0"/>
+                    </a:p>
+                  </a:txBody>
+                  <a:tcPr marL="36576" marR="36576" marT="9144" marB="9144" anchor="ctr">
+                    <a:lnL w="6350" cap="flat" cmpd="sng" algn="ctr">
+                      <a:solidFill>
+                        <a:srgbClr val="D8DFE9"/>
+                      </a:solidFill>
+                      <a:prstDash val="solid"/>
+                      <a:round/>
+                      <a:headEnd type="none" w="med" len="med"/>
+                      <a:tailEnd type="none" w="med" len="med"/>
+                    </a:lnL>
+                    <a:lnR w="6350" cap="flat" cmpd="sng" algn="ctr">
+                      <a:solidFill>
+                        <a:srgbClr val="D8DFE9"/>
+                      </a:solidFill>
+                      <a:prstDash val="solid"/>
+                      <a:round/>
+                      <a:headEnd type="none" w="med" len="med"/>
+                      <a:tailEnd type="none" w="med" len="med"/>
+                    </a:lnR>
+                    <a:lnT w="6350" cap="flat" cmpd="sng" algn="ctr">
+                      <a:solidFill>
+                        <a:srgbClr val="D8DFE9"/>
+                      </a:solidFill>
+                      <a:prstDash val="solid"/>
+                      <a:round/>
+                      <a:headEnd type="none" w="med" len="med"/>
+                      <a:tailEnd type="none" w="med" len="med"/>
+                    </a:lnT>
+                    <a:lnB w="6350" cap="flat" cmpd="sng" algn="ctr">
+                      <a:solidFill>
+                        <a:srgbClr val="D8DFE9"/>
+                      </a:solidFill>
+                      <a:prstDash val="solid"/>
+                      <a:round/>
+                      <a:headEnd type="none" w="med" len="med"/>
+                      <a:tailEnd type="none" w="med" len="med"/>
+                    </a:lnB>
+                    <a:solidFill>
+                      <a:srgbClr val="F1C5C5"/>
+                    </a:solidFill>
+                  </a:tcPr>
+                </a:tc>
+                <a:tc>
+                  <a:txBody>
+                    <a:bodyPr/>
+                    <a:lstStyle/>
+                    <a:p>
+                      <a:pPr algn="ctr" indent="0" marL="0">
+                        <a:buNone/>
+                      </a:pPr>
+                      <a:r>
+                        <a:rPr lang="en-US" sz="950" b="1" dirty="0">
+                          <a:solidFill>
+                            <a:srgbClr val="16233D"/>
+                          </a:solidFill>
+                          <a:latin typeface="Graphik TH" pitchFamily="34" charset="0"/>
+                          <a:ea typeface="Graphik TH" pitchFamily="34" charset="-122"/>
+                          <a:cs typeface="Graphik TH" pitchFamily="34" charset="-120"/>
+                        </a:rPr>
+                        <a:t>13.7%</a:t>
+                      </a:r>
+                      <a:pPr algn="ctr" indent="0" marL="0">
+                        <a:buNone/>
+                      </a:pPr>
+                      <a:endParaRPr lang="en-US" sz="1200" dirty="0"/>
+                    </a:p>
+                    <a:p>
+                      <a:pPr algn="ctr" indent="0" marL="0">
+                        <a:buNone/>
+                      </a:pPr>
+                      <a:r>
+                        <a:rPr lang="en-US" sz="700" dirty="0">
+                          <a:solidFill>
+                            <a:srgbClr val="6B7A90"/>
+                          </a:solidFill>
+                          <a:latin typeface="Graphik TH" pitchFamily="34" charset="0"/>
+                          <a:ea typeface="Graphik TH" pitchFamily="34" charset="-122"/>
+                          <a:cs typeface="Graphik TH" pitchFamily="34" charset="-120"/>
+                        </a:rPr>
+                        <a:t>5,595</a:t>
+                      </a:r>
+                      <a:endParaRPr lang="en-US" sz="1200" dirty="0"/>
+                    </a:p>
+                  </a:txBody>
+                  <a:tcPr marL="36576" marR="36576" marT="9144" marB="9144" anchor="ctr">
+                    <a:lnL w="6350" cap="flat" cmpd="sng" algn="ctr">
+                      <a:solidFill>
+                        <a:srgbClr val="D8DFE9"/>
+                      </a:solidFill>
+                      <a:prstDash val="solid"/>
+                      <a:round/>
+                      <a:headEnd type="none" w="med" len="med"/>
+                      <a:tailEnd type="none" w="med" len="med"/>
+                    </a:lnL>
+                    <a:lnR w="6350" cap="flat" cmpd="sng" algn="ctr">
+                      <a:solidFill>
+                        <a:srgbClr val="D8DFE9"/>
+                      </a:solidFill>
+                      <a:prstDash val="solid"/>
+                      <a:round/>
+                      <a:headEnd type="none" w="med" len="med"/>
+                      <a:tailEnd type="none" w="med" len="med"/>
+                    </a:lnR>
+                    <a:lnT w="6350" cap="flat" cmpd="sng" algn="ctr">
+                      <a:solidFill>
+                        <a:srgbClr val="D8DFE9"/>
+                      </a:solidFill>
+                      <a:prstDash val="solid"/>
+                      <a:round/>
+                      <a:headEnd type="none" w="med" len="med"/>
+                      <a:tailEnd type="none" w="med" len="med"/>
+                    </a:lnT>
+                    <a:lnB w="6350" cap="flat" cmpd="sng" algn="ctr">
+                      <a:solidFill>
+                        <a:srgbClr val="D8DFE9"/>
+                      </a:solidFill>
+                      <a:prstDash val="solid"/>
+                      <a:round/>
+                      <a:headEnd type="none" w="med" len="med"/>
+                      <a:tailEnd type="none" w="med" len="med"/>
+                    </a:lnB>
+                    <a:solidFill>
+                      <a:srgbClr val="F0C1C1"/>
+                    </a:solidFill>
+                  </a:tcPr>
+                </a:tc>
+                <a:tc>
+                  <a:txBody>
+                    <a:bodyPr/>
+                    <a:lstStyle/>
+                    <a:p>
+                      <a:pPr algn="ctr" indent="0" marL="0">
+                        <a:buNone/>
+                      </a:pPr>
+                      <a:r>
+                        <a:rPr lang="en-US" sz="950" dirty="0">
+                          <a:solidFill>
+                            <a:srgbClr val="6B7A90"/>
+                          </a:solidFill>
+                          <a:latin typeface="Graphik TH" pitchFamily="34" charset="0"/>
+                          <a:ea typeface="Graphik TH" pitchFamily="34" charset="-122"/>
+                          <a:cs typeface="Graphik TH" pitchFamily="34" charset="-120"/>
+                        </a:rPr>
+                        <a:t>0.0%</a:t>
+                      </a:r>
+                      <a:pPr algn="ctr" indent="0" marL="0">
+                        <a:buNone/>
+                      </a:pPr>
+                      <a:endParaRPr lang="en-US" sz="1200" dirty="0"/>
+                    </a:p>
+                    <a:p>
+                      <a:pPr algn="ctr" indent="0" marL="0">
+                        <a:buNone/>
+                      </a:pPr>
+                      <a:r>
+                        <a:rPr lang="en-US" sz="700" dirty="0">
+                          <a:solidFill>
+                            <a:srgbClr val="6B7A90"/>
+                          </a:solidFill>
+                          <a:latin typeface="Graphik TH" pitchFamily="34" charset="0"/>
+                          <a:ea typeface="Graphik TH" pitchFamily="34" charset="-122"/>
+                          <a:cs typeface="Graphik TH" pitchFamily="34" charset="-120"/>
+                        </a:rPr>
+                        <a:t>2</a:t>
+                      </a:r>
+                      <a:endParaRPr lang="en-US" sz="1200" dirty="0"/>
+                    </a:p>
+                  </a:txBody>
+                  <a:tcPr marL="36576" marR="36576" marT="9144" marB="9144" anchor="ctr">
+                    <a:lnL w="6350" cap="flat" cmpd="sng" algn="ctr">
+                      <a:solidFill>
+                        <a:srgbClr val="D8DFE9"/>
+                      </a:solidFill>
+                      <a:prstDash val="solid"/>
+                      <a:round/>
+                      <a:headEnd type="none" w="med" len="med"/>
+                      <a:tailEnd type="none" w="med" len="med"/>
+                    </a:lnL>
+                    <a:lnR w="6350" cap="flat" cmpd="sng" algn="ctr">
+                      <a:solidFill>
+                        <a:srgbClr val="D8DFE9"/>
+                      </a:solidFill>
+                      <a:prstDash val="solid"/>
+                      <a:round/>
+                      <a:headEnd type="none" w="med" len="med"/>
+                      <a:tailEnd type="none" w="med" len="med"/>
+                    </a:lnR>
+                    <a:lnT w="6350" cap="flat" cmpd="sng" algn="ctr">
+                      <a:solidFill>
+                        <a:srgbClr val="D8DFE9"/>
+                      </a:solidFill>
+                      <a:prstDash val="solid"/>
+                      <a:round/>
+                      <a:headEnd type="none" w="med" len="med"/>
+                      <a:tailEnd type="none" w="med" len="med"/>
+                    </a:lnT>
+                    <a:lnB w="6350" cap="flat" cmpd="sng" algn="ctr">
+                      <a:solidFill>
+                        <a:srgbClr val="D8DFE9"/>
+                      </a:solidFill>
+                      <a:prstDash val="solid"/>
+                      <a:round/>
+                      <a:headEnd type="none" w="med" len="med"/>
+                      <a:tailEnd type="none" w="med" len="med"/>
+                    </a:lnB>
+                    <a:solidFill>
+                      <a:srgbClr val="FFFFFF"/>
+                    </a:solidFill>
+                  </a:tcPr>
+                </a:tc>
+                <a:tc>
+                  <a:txBody>
+                    <a:bodyPr/>
+                    <a:lstStyle/>
+                    <a:p>
+                      <a:pPr algn="ctr" indent="0" marL="0">
+                        <a:buNone/>
+                      </a:pPr>
+                      <a:r>
+                        <a:rPr lang="en-US" sz="950" b="1" dirty="0">
+                          <a:solidFill>
+                            <a:srgbClr val="FFFFFF"/>
+                          </a:solidFill>
+                          <a:latin typeface="Graphik TH" pitchFamily="34" charset="0"/>
+                          <a:ea typeface="Graphik TH" pitchFamily="34" charset="-122"/>
+                          <a:cs typeface="Graphik TH" pitchFamily="34" charset="-120"/>
+                        </a:rPr>
+                        <a:t>41.8%</a:t>
+                      </a:r>
+                      <a:pPr algn="ctr" indent="0" marL="0">
+                        <a:buNone/>
+                      </a:pPr>
+                      <a:endParaRPr lang="en-US" sz="1200" dirty="0"/>
+                    </a:p>
+                    <a:p>
+                      <a:pPr algn="ctr" indent="0" marL="0">
+                        <a:buNone/>
+                      </a:pPr>
+                      <a:r>
+                        <a:rPr lang="en-US" sz="700" dirty="0">
+                          <a:solidFill>
+                            <a:srgbClr val="F0D6D6"/>
+                          </a:solidFill>
+                          <a:latin typeface="Graphik TH" pitchFamily="34" charset="0"/>
+                          <a:ea typeface="Graphik TH" pitchFamily="34" charset="-122"/>
+                          <a:cs typeface="Graphik TH" pitchFamily="34" charset="-120"/>
+                        </a:rPr>
+                        <a:t>2,340</a:t>
+                      </a:r>
+                      <a:endParaRPr lang="en-US" sz="1200" dirty="0"/>
+                    </a:p>
+                  </a:txBody>
+                  <a:tcPr marL="36576" marR="36576" marT="9144" marB="9144" anchor="ctr">
+                    <a:lnL w="6350" cap="flat" cmpd="sng" algn="ctr">
+                      <a:solidFill>
+                        <a:srgbClr val="D8DFE9"/>
+                      </a:solidFill>
+                      <a:prstDash val="solid"/>
+                      <a:round/>
+                      <a:headEnd type="none" w="med" len="med"/>
+                      <a:tailEnd type="none" w="med" len="med"/>
+                    </a:lnL>
+                    <a:lnR w="6350" cap="flat" cmpd="sng" algn="ctr">
+                      <a:solidFill>
+                        <a:srgbClr val="D8DFE9"/>
+                      </a:solidFill>
+                      <a:prstDash val="solid"/>
+                      <a:round/>
+                      <a:headEnd type="none" w="med" len="med"/>
+                      <a:tailEnd type="none" w="med" len="med"/>
+                    </a:lnR>
+                    <a:lnT w="6350" cap="flat" cmpd="sng" algn="ctr">
+                      <a:solidFill>
+                        <a:srgbClr val="D8DFE9"/>
+                      </a:solidFill>
+                      <a:prstDash val="solid"/>
+                      <a:round/>
+                      <a:headEnd type="none" w="med" len="med"/>
+                      <a:tailEnd type="none" w="med" len="med"/>
+                    </a:lnT>
+                    <a:lnB w="6350" cap="flat" cmpd="sng" algn="ctr">
+                      <a:solidFill>
+                        <a:srgbClr val="D8DFE9"/>
+                      </a:solidFill>
+                      <a:prstDash val="solid"/>
+                      <a:round/>
+                      <a:headEnd type="none" w="med" len="med"/>
+                      <a:tailEnd type="none" w="med" len="med"/>
+                    </a:lnB>
+                    <a:solidFill>
+                      <a:srgbClr val="D04141"/>
+                    </a:solidFill>
+                  </a:tcPr>
+                </a:tc>
+                <a:tc>
+                  <a:txBody>
+                    <a:bodyPr/>
+                    <a:lstStyle/>
+                    <a:p>
+                      <a:pPr algn="ctr" indent="0" marL="0">
+                        <a:buNone/>
+                      </a:pPr>
+                      <a:r>
+                        <a:rPr lang="en-US" sz="950" b="1" dirty="0">
+                          <a:solidFill>
+                            <a:srgbClr val="16233D"/>
+                          </a:solidFill>
+                          <a:latin typeface="Graphik TH" pitchFamily="34" charset="0"/>
+                          <a:ea typeface="Graphik TH" pitchFamily="34" charset="-122"/>
+                          <a:cs typeface="Graphik TH" pitchFamily="34" charset="-120"/>
+                        </a:rPr>
+                        <a:t>14.2%</a:t>
+                      </a:r>
+                      <a:pPr algn="ctr" indent="0" marL="0">
+                        <a:buNone/>
+                      </a:pPr>
+                      <a:endParaRPr lang="en-US" sz="1200" dirty="0"/>
+                    </a:p>
+                    <a:p>
+                      <a:pPr algn="ctr" indent="0" marL="0">
+                        <a:buNone/>
+                      </a:pPr>
+                      <a:r>
+                        <a:rPr lang="en-US" sz="700" dirty="0">
+                          <a:solidFill>
+                            <a:srgbClr val="6B7A90"/>
+                          </a:solidFill>
+                          <a:latin typeface="Graphik TH" pitchFamily="34" charset="0"/>
+                          <a:ea typeface="Graphik TH" pitchFamily="34" charset="-122"/>
+                          <a:cs typeface="Graphik TH" pitchFamily="34" charset="-120"/>
+                        </a:rPr>
+                        <a:t>3,318</a:t>
+                      </a:r>
+                      <a:endParaRPr lang="en-US" sz="1200" dirty="0"/>
+                    </a:p>
+                  </a:txBody>
+                  <a:tcPr marL="36576" marR="36576" marT="9144" marB="9144" anchor="ctr">
+                    <a:lnL w="6350" cap="flat" cmpd="sng" algn="ctr">
+                      <a:solidFill>
+                        <a:srgbClr val="D8DFE9"/>
+                      </a:solidFill>
+                      <a:prstDash val="solid"/>
+                      <a:round/>
+                      <a:headEnd type="none" w="med" len="med"/>
+                      <a:tailEnd type="none" w="med" len="med"/>
+                    </a:lnL>
+                    <a:lnR w="6350" cap="flat" cmpd="sng" algn="ctr">
+                      <a:solidFill>
+                        <a:srgbClr val="D8DFE9"/>
+                      </a:solidFill>
+                      <a:prstDash val="solid"/>
+                      <a:round/>
+                      <a:headEnd type="none" w="med" len="med"/>
+                      <a:tailEnd type="none" w="med" len="med"/>
+                    </a:lnR>
+                    <a:lnT w="6350" cap="flat" cmpd="sng" algn="ctr">
+                      <a:solidFill>
+                        <a:srgbClr val="D8DFE9"/>
+                      </a:solidFill>
+                      <a:prstDash val="solid"/>
+                      <a:round/>
+                      <a:headEnd type="none" w="med" len="med"/>
+                      <a:tailEnd type="none" w="med" len="med"/>
+                    </a:lnT>
+                    <a:lnB w="6350" cap="flat" cmpd="sng" algn="ctr">
+                      <a:solidFill>
+                        <a:srgbClr val="D8DFE9"/>
+                      </a:solidFill>
+                      <a:prstDash val="solid"/>
+                      <a:round/>
+                      <a:headEnd type="none" w="med" len="med"/>
+                      <a:tailEnd type="none" w="med" len="med"/>
+                    </a:lnB>
+                    <a:solidFill>
+                      <a:srgbClr val="EFBFBF"/>
+                    </a:solidFill>
+                  </a:tcPr>
+                </a:tc>
+              </a:tr>
+              <a:tr h="274320">
+                <a:tc>
+                  <a:txBody>
+                    <a:bodyPr/>
+                    <a:lstStyle/>
+                    <a:p>
+                      <a:pPr algn="l" indent="0" marL="0">
+                        <a:buNone/>
+                      </a:pPr>
+                      <a:r>
+                        <a:rPr lang="en-US" sz="950" b="1" dirty="0">
+                          <a:solidFill>
+                            <a:srgbClr val="16233D"/>
+                          </a:solidFill>
+                          <a:latin typeface="Graphik TH" pitchFamily="34" charset="0"/>
+                          <a:ea typeface="Graphik TH" pitchFamily="34" charset="-122"/>
+                          <a:cs typeface="Graphik TH" pitchFamily="34" charset="-120"/>
+                        </a:rPr>
+                        <a:t>High</a:t>
+                      </a:r>
+                      <a:endParaRPr lang="en-US" sz="950" dirty="0">
+                        <a:latin typeface="Graphik TH" charset="0"/>
+                        <a:ea typeface="Graphik TH" charset="0"/>
+                        <a:cs typeface="Graphik TH" charset="0"/>
+                      </a:endParaRPr>
+                    </a:p>
+                  </a:txBody>
+                  <a:tcPr marL="36576" marR="36576" marT="9144" marB="9144" anchor="ctr">
+                    <a:lnL w="6350" cap="flat" cmpd="sng" algn="ctr">
+                      <a:solidFill>
+                        <a:srgbClr val="D8DFE9"/>
+                      </a:solidFill>
+                      <a:prstDash val="solid"/>
+                      <a:round/>
+                      <a:headEnd type="none" w="med" len="med"/>
+                      <a:tailEnd type="none" w="med" len="med"/>
+                    </a:lnL>
+                    <a:lnR w="6350" cap="flat" cmpd="sng" algn="ctr">
+                      <a:solidFill>
+                        <a:srgbClr val="D8DFE9"/>
+                      </a:solidFill>
+                      <a:prstDash val="solid"/>
+                      <a:round/>
+                      <a:headEnd type="none" w="med" len="med"/>
+                      <a:tailEnd type="none" w="med" len="med"/>
+                    </a:lnR>
+                    <a:lnT w="6350" cap="flat" cmpd="sng" algn="ctr">
+                      <a:solidFill>
+                        <a:srgbClr val="D8DFE9"/>
+                      </a:solidFill>
+                      <a:prstDash val="solid"/>
+                      <a:round/>
+                      <a:headEnd type="none" w="med" len="med"/>
+                      <a:tailEnd type="none" w="med" len="med"/>
+                    </a:lnT>
+                    <a:lnB w="6350" cap="flat" cmpd="sng" algn="ctr">
+                      <a:solidFill>
+                        <a:srgbClr val="D8DFE9"/>
+                      </a:solidFill>
+                      <a:prstDash val="solid"/>
+                      <a:round/>
+                      <a:headEnd type="none" w="med" len="med"/>
+                      <a:tailEnd type="none" w="med" len="med"/>
+                    </a:lnB>
+                    <a:solidFill>
+                      <a:srgbClr val="F1F4F9"/>
+                    </a:solidFill>
+                  </a:tcPr>
+                </a:tc>
+                <a:tc>
+                  <a:txBody>
+                    <a:bodyPr/>
+                    <a:lstStyle/>
+                    <a:p>
+                      <a:pPr algn="ctr" indent="0" marL="0">
+                        <a:buNone/>
+                      </a:pPr>
+                      <a:r>
+                        <a:rPr lang="en-US" sz="950" b="1" dirty="0">
+                          <a:solidFill>
+                            <a:srgbClr val="16233D"/>
+                          </a:solidFill>
+                          <a:latin typeface="Graphik TH" pitchFamily="34" charset="0"/>
+                          <a:ea typeface="Graphik TH" pitchFamily="34" charset="-122"/>
+                          <a:cs typeface="Graphik TH" pitchFamily="34" charset="-120"/>
+                        </a:rPr>
+                        <a:t>6.2%</a:t>
+                      </a:r>
+                      <a:pPr algn="ctr" indent="0" marL="0">
+                        <a:buNone/>
+                      </a:pPr>
+                      <a:endParaRPr lang="en-US" sz="1200" dirty="0"/>
+                    </a:p>
+                    <a:p>
+                      <a:pPr algn="ctr" indent="0" marL="0">
+                        <a:buNone/>
+                      </a:pPr>
+                      <a:r>
+                        <a:rPr lang="en-US" sz="700" dirty="0">
+                          <a:solidFill>
+                            <a:srgbClr val="6B7A90"/>
+                          </a:solidFill>
+                          <a:latin typeface="Graphik TH" pitchFamily="34" charset="0"/>
+                          <a:ea typeface="Graphik TH" pitchFamily="34" charset="-122"/>
+                          <a:cs typeface="Graphik TH" pitchFamily="34" charset="-120"/>
+                        </a:rPr>
+                        <a:t>829</a:t>
+                      </a:r>
+                      <a:endParaRPr lang="en-US" sz="1200" dirty="0"/>
+                    </a:p>
+                  </a:txBody>
+                  <a:tcPr marL="36576" marR="36576" marT="9144" marB="9144" anchor="ctr">
+                    <a:lnL w="6350" cap="flat" cmpd="sng" algn="ctr">
+                      <a:solidFill>
+                        <a:srgbClr val="D8DFE9"/>
+                      </a:solidFill>
+                      <a:prstDash val="solid"/>
+                      <a:round/>
+                      <a:headEnd type="none" w="med" len="med"/>
+                      <a:tailEnd type="none" w="med" len="med"/>
+                    </a:lnL>
+                    <a:lnR w="6350" cap="flat" cmpd="sng" algn="ctr">
+                      <a:solidFill>
+                        <a:srgbClr val="D8DFE9"/>
+                      </a:solidFill>
+                      <a:prstDash val="solid"/>
+                      <a:round/>
+                      <a:headEnd type="none" w="med" len="med"/>
+                      <a:tailEnd type="none" w="med" len="med"/>
+                    </a:lnR>
+                    <a:lnT w="6350" cap="flat" cmpd="sng" algn="ctr">
+                      <a:solidFill>
+                        <a:srgbClr val="D8DFE9"/>
+                      </a:solidFill>
+                      <a:prstDash val="solid"/>
+                      <a:round/>
+                      <a:headEnd type="none" w="med" len="med"/>
+                      <a:tailEnd type="none" w="med" len="med"/>
+                    </a:lnT>
+                    <a:lnB w="6350" cap="flat" cmpd="sng" algn="ctr">
+                      <a:solidFill>
+                        <a:srgbClr val="D8DFE9"/>
+                      </a:solidFill>
+                      <a:prstDash val="solid"/>
+                      <a:round/>
+                      <a:headEnd type="none" w="med" len="med"/>
+                      <a:tailEnd type="none" w="med" len="med"/>
+                    </a:lnB>
+                    <a:solidFill>
+                      <a:srgbClr val="F8E3E3"/>
+                    </a:solidFill>
+                  </a:tcPr>
+                </a:tc>
+                <a:tc>
+                  <a:txBody>
+                    <a:bodyPr/>
+                    <a:lstStyle/>
+                    <a:p>
+                      <a:pPr algn="ctr" indent="0" marL="0">
+                        <a:buNone/>
+                      </a:pPr>
+                      <a:r>
+                        <a:rPr lang="en-US" sz="950" b="1" dirty="0">
+                          <a:solidFill>
+                            <a:srgbClr val="16233D"/>
+                          </a:solidFill>
+                          <a:latin typeface="Graphik TH" pitchFamily="34" charset="0"/>
+                          <a:ea typeface="Graphik TH" pitchFamily="34" charset="-122"/>
+                          <a:cs typeface="Graphik TH" pitchFamily="34" charset="-120"/>
+                        </a:rPr>
+                        <a:t>6.8%</a:t>
+                      </a:r>
+                      <a:pPr algn="ctr" indent="0" marL="0">
+                        <a:buNone/>
+                      </a:pPr>
+                      <a:endParaRPr lang="en-US" sz="1200" dirty="0"/>
+                    </a:p>
+                    <a:p>
+                      <a:pPr algn="ctr" indent="0" marL="0">
+                        <a:buNone/>
+                      </a:pPr>
+                      <a:r>
+                        <a:rPr lang="en-US" sz="700" dirty="0">
+                          <a:solidFill>
+                            <a:srgbClr val="6B7A90"/>
+                          </a:solidFill>
+                          <a:latin typeface="Graphik TH" pitchFamily="34" charset="0"/>
+                          <a:ea typeface="Graphik TH" pitchFamily="34" charset="-122"/>
+                          <a:cs typeface="Graphik TH" pitchFamily="34" charset="-120"/>
+                        </a:rPr>
+                        <a:t>7,809</a:t>
+                      </a:r>
+                      <a:endParaRPr lang="en-US" sz="1200" dirty="0"/>
+                    </a:p>
+                  </a:txBody>
+                  <a:tcPr marL="36576" marR="36576" marT="9144" marB="9144" anchor="ctr">
+                    <a:lnL w="6350" cap="flat" cmpd="sng" algn="ctr">
+                      <a:solidFill>
+                        <a:srgbClr val="D8DFE9"/>
+                      </a:solidFill>
+                      <a:prstDash val="solid"/>
+                      <a:round/>
+                      <a:headEnd type="none" w="med" len="med"/>
+                      <a:tailEnd type="none" w="med" len="med"/>
+                    </a:lnL>
+                    <a:lnR w="6350" cap="flat" cmpd="sng" algn="ctr">
+                      <a:solidFill>
+                        <a:srgbClr val="D8DFE9"/>
+                      </a:solidFill>
+                      <a:prstDash val="solid"/>
+                      <a:round/>
+                      <a:headEnd type="none" w="med" len="med"/>
+                      <a:tailEnd type="none" w="med" len="med"/>
+                    </a:lnR>
+                    <a:lnT w="6350" cap="flat" cmpd="sng" algn="ctr">
+                      <a:solidFill>
+                        <a:srgbClr val="D8DFE9"/>
+                      </a:solidFill>
+                      <a:prstDash val="solid"/>
+                      <a:round/>
+                      <a:headEnd type="none" w="med" len="med"/>
+                      <a:tailEnd type="none" w="med" len="med"/>
+                    </a:lnT>
+                    <a:lnB w="6350" cap="flat" cmpd="sng" algn="ctr">
+                      <a:solidFill>
+                        <a:srgbClr val="D8DFE9"/>
+                      </a:solidFill>
+                      <a:prstDash val="solid"/>
+                      <a:round/>
+                      <a:headEnd type="none" w="med" len="med"/>
+                      <a:tailEnd type="none" w="med" len="med"/>
+                    </a:lnB>
+                    <a:solidFill>
+                      <a:srgbClr val="F7E0E0"/>
+                    </a:solidFill>
+                  </a:tcPr>
+                </a:tc>
+                <a:tc>
+                  <a:txBody>
+                    <a:bodyPr/>
+                    <a:lstStyle/>
+                    <a:p>
+                      <a:pPr algn="ctr" indent="0" marL="0">
+                        <a:buNone/>
+                      </a:pPr>
+                      <a:r>
+                        <a:rPr lang="en-US" sz="950" dirty="0">
+                          <a:solidFill>
+                            <a:srgbClr val="6B7A90"/>
+                          </a:solidFill>
+                          <a:latin typeface="Graphik TH" pitchFamily="34" charset="0"/>
+                          <a:ea typeface="Graphik TH" pitchFamily="34" charset="-122"/>
+                          <a:cs typeface="Graphik TH" pitchFamily="34" charset="-120"/>
+                        </a:rPr>
+                        <a:t>0.0%</a:t>
+                      </a:r>
+                      <a:pPr algn="ctr" indent="0" marL="0">
+                        <a:buNone/>
+                      </a:pPr>
+                      <a:endParaRPr lang="en-US" sz="1200" dirty="0"/>
+                    </a:p>
+                    <a:p>
+                      <a:pPr algn="ctr" indent="0" marL="0">
+                        <a:buNone/>
+                      </a:pPr>
+                      <a:r>
+                        <a:rPr lang="en-US" sz="700" dirty="0">
+                          <a:solidFill>
+                            <a:srgbClr val="6B7A90"/>
+                          </a:solidFill>
+                          <a:latin typeface="Graphik TH" pitchFamily="34" charset="0"/>
+                          <a:ea typeface="Graphik TH" pitchFamily="34" charset="-122"/>
+                          <a:cs typeface="Graphik TH" pitchFamily="34" charset="-120"/>
+                        </a:rPr>
+                        <a:t>2</a:t>
+                      </a:r>
+                      <a:endParaRPr lang="en-US" sz="1200" dirty="0"/>
+                    </a:p>
+                  </a:txBody>
+                  <a:tcPr marL="36576" marR="36576" marT="9144" marB="9144" anchor="ctr">
+                    <a:lnL w="6350" cap="flat" cmpd="sng" algn="ctr">
+                      <a:solidFill>
+                        <a:srgbClr val="D8DFE9"/>
+                      </a:solidFill>
+                      <a:prstDash val="solid"/>
+                      <a:round/>
+                      <a:headEnd type="none" w="med" len="med"/>
+                      <a:tailEnd type="none" w="med" len="med"/>
+                    </a:lnL>
+                    <a:lnR w="6350" cap="flat" cmpd="sng" algn="ctr">
+                      <a:solidFill>
+                        <a:srgbClr val="D8DFE9"/>
+                      </a:solidFill>
+                      <a:prstDash val="solid"/>
+                      <a:round/>
+                      <a:headEnd type="none" w="med" len="med"/>
+                      <a:tailEnd type="none" w="med" len="med"/>
+                    </a:lnR>
+                    <a:lnT w="6350" cap="flat" cmpd="sng" algn="ctr">
+                      <a:solidFill>
+                        <a:srgbClr val="D8DFE9"/>
+                      </a:solidFill>
+                      <a:prstDash val="solid"/>
+                      <a:round/>
+                      <a:headEnd type="none" w="med" len="med"/>
+                      <a:tailEnd type="none" w="med" len="med"/>
+                    </a:lnT>
+                    <a:lnB w="6350" cap="flat" cmpd="sng" algn="ctr">
+                      <a:solidFill>
+                        <a:srgbClr val="D8DFE9"/>
+                      </a:solidFill>
+                      <a:prstDash val="solid"/>
+                      <a:round/>
+                      <a:headEnd type="none" w="med" len="med"/>
+                      <a:tailEnd type="none" w="med" len="med"/>
+                    </a:lnB>
+                    <a:solidFill>
+                      <a:srgbClr val="FFFFFF"/>
+                    </a:solidFill>
+                  </a:tcPr>
+                </a:tc>
+                <a:tc>
+                  <a:txBody>
+                    <a:bodyPr/>
+                    <a:lstStyle/>
+                    <a:p>
+                      <a:pPr algn="ctr" indent="0" marL="0">
+                        <a:buNone/>
+                      </a:pPr>
+                      <a:r>
+                        <a:rPr lang="en-US" sz="950" b="1" dirty="0">
+                          <a:solidFill>
+                            <a:srgbClr val="FFFFFF"/>
+                          </a:solidFill>
+                          <a:latin typeface="Graphik TH" pitchFamily="34" charset="0"/>
+                          <a:ea typeface="Graphik TH" pitchFamily="34" charset="-122"/>
+                          <a:cs typeface="Graphik TH" pitchFamily="34" charset="-120"/>
+                        </a:rPr>
+                        <a:t>56.2%</a:t>
+                      </a:r>
+                      <a:pPr algn="ctr" indent="0" marL="0">
+                        <a:buNone/>
+                      </a:pPr>
+                      <a:endParaRPr lang="en-US" sz="1200" dirty="0"/>
+                    </a:p>
+                    <a:p>
+                      <a:pPr algn="ctr" indent="0" marL="0">
+                        <a:buNone/>
+                      </a:pPr>
+                      <a:r>
+                        <a:rPr lang="en-US" sz="700" dirty="0">
+                          <a:solidFill>
+                            <a:srgbClr val="F0D6D6"/>
+                          </a:solidFill>
+                          <a:latin typeface="Graphik TH" pitchFamily="34" charset="0"/>
+                          <a:ea typeface="Graphik TH" pitchFamily="34" charset="-122"/>
+                          <a:cs typeface="Graphik TH" pitchFamily="34" charset="-120"/>
+                        </a:rPr>
+                        <a:t>2,788</a:t>
+                      </a:r>
+                      <a:endParaRPr lang="en-US" sz="1200" dirty="0"/>
+                    </a:p>
+                  </a:txBody>
+                  <a:tcPr marL="36576" marR="36576" marT="9144" marB="9144" anchor="ctr">
+                    <a:lnL w="6350" cap="flat" cmpd="sng" algn="ctr">
+                      <a:solidFill>
+                        <a:srgbClr val="D8DFE9"/>
+                      </a:solidFill>
+                      <a:prstDash val="solid"/>
+                      <a:round/>
+                      <a:headEnd type="none" w="med" len="med"/>
+                      <a:tailEnd type="none" w="med" len="med"/>
+                    </a:lnL>
+                    <a:lnR w="6350" cap="flat" cmpd="sng" algn="ctr">
+                      <a:solidFill>
+                        <a:srgbClr val="D8DFE9"/>
+                      </a:solidFill>
+                      <a:prstDash val="solid"/>
+                      <a:round/>
+                      <a:headEnd type="none" w="med" len="med"/>
+                      <a:tailEnd type="none" w="med" len="med"/>
+                    </a:lnR>
+                    <a:lnT w="6350" cap="flat" cmpd="sng" algn="ctr">
+                      <a:solidFill>
+                        <a:srgbClr val="D8DFE9"/>
+                      </a:solidFill>
+                      <a:prstDash val="solid"/>
+                      <a:round/>
+                      <a:headEnd type="none" w="med" len="med"/>
+                      <a:tailEnd type="none" w="med" len="med"/>
+                    </a:lnT>
+                    <a:lnB w="6350" cap="flat" cmpd="sng" algn="ctr">
+                      <a:solidFill>
+                        <a:srgbClr val="D8DFE9"/>
+                      </a:solidFill>
+                      <a:prstDash val="solid"/>
+                      <a:round/>
+                      <a:headEnd type="none" w="med" len="med"/>
+                      <a:tailEnd type="none" w="med" len="med"/>
+                    </a:lnB>
+                    <a:solidFill>
+                      <a:srgbClr val="C00000"/>
+                    </a:solidFill>
+                  </a:tcPr>
+                </a:tc>
+                <a:tc>
+                  <a:txBody>
+                    <a:bodyPr/>
+                    <a:lstStyle/>
+                    <a:p>
+                      <a:pPr algn="ctr" indent="0" marL="0">
+                        <a:buNone/>
+                      </a:pPr>
+                      <a:r>
+                        <a:rPr lang="en-US" sz="950" b="1" dirty="0">
+                          <a:solidFill>
+                            <a:srgbClr val="16233D"/>
+                          </a:solidFill>
+                          <a:latin typeface="Graphik TH" pitchFamily="34" charset="0"/>
+                          <a:ea typeface="Graphik TH" pitchFamily="34" charset="-122"/>
+                          <a:cs typeface="Graphik TH" pitchFamily="34" charset="-120"/>
+                        </a:rPr>
+                        <a:t>12.6%</a:t>
+                      </a:r>
+                      <a:pPr algn="ctr" indent="0" marL="0">
+                        <a:buNone/>
+                      </a:pPr>
+                      <a:endParaRPr lang="en-US" sz="1200" dirty="0"/>
+                    </a:p>
+                    <a:p>
+                      <a:pPr algn="ctr" indent="0" marL="0">
+                        <a:buNone/>
+                      </a:pPr>
+                      <a:r>
+                        <a:rPr lang="en-US" sz="700" dirty="0">
+                          <a:solidFill>
+                            <a:srgbClr val="6B7A90"/>
+                          </a:solidFill>
+                          <a:latin typeface="Graphik TH" pitchFamily="34" charset="0"/>
+                          <a:ea typeface="Graphik TH" pitchFamily="34" charset="-122"/>
+                          <a:cs typeface="Graphik TH" pitchFamily="34" charset="-120"/>
+                        </a:rPr>
+                        <a:t>15,007</a:t>
+                      </a:r>
+                      <a:endParaRPr lang="en-US" sz="1200" dirty="0"/>
+                    </a:p>
+                  </a:txBody>
+                  <a:tcPr marL="36576" marR="36576" marT="9144" marB="9144" anchor="ctr">
+                    <a:lnL w="6350" cap="flat" cmpd="sng" algn="ctr">
+                      <a:solidFill>
+                        <a:srgbClr val="D8DFE9"/>
+                      </a:solidFill>
+                      <a:prstDash val="solid"/>
+                      <a:round/>
+                      <a:headEnd type="none" w="med" len="med"/>
+                      <a:tailEnd type="none" w="med" len="med"/>
+                    </a:lnL>
+                    <a:lnR w="6350" cap="flat" cmpd="sng" algn="ctr">
+                      <a:solidFill>
+                        <a:srgbClr val="D8DFE9"/>
+                      </a:solidFill>
+                      <a:prstDash val="solid"/>
+                      <a:round/>
+                      <a:headEnd type="none" w="med" len="med"/>
+                      <a:tailEnd type="none" w="med" len="med"/>
+                    </a:lnR>
+                    <a:lnT w="6350" cap="flat" cmpd="sng" algn="ctr">
+                      <a:solidFill>
+                        <a:srgbClr val="D8DFE9"/>
+                      </a:solidFill>
+                      <a:prstDash val="solid"/>
+                      <a:round/>
+                      <a:headEnd type="none" w="med" len="med"/>
+                      <a:tailEnd type="none" w="med" len="med"/>
+                    </a:lnT>
+                    <a:lnB w="6350" cap="flat" cmpd="sng" algn="ctr">
+                      <a:solidFill>
+                        <a:srgbClr val="D8DFE9"/>
+                      </a:solidFill>
+                      <a:prstDash val="solid"/>
+                      <a:round/>
+                      <a:headEnd type="none" w="med" len="med"/>
+                      <a:tailEnd type="none" w="med" len="med"/>
+                    </a:lnB>
+                    <a:solidFill>
+                      <a:srgbClr val="F1C6C6"/>
+                    </a:solidFill>
+                  </a:tcPr>
+                </a:tc>
+              </a:tr>
+              <a:tr h="274320">
+                <a:tc>
+                  <a:txBody>
+                    <a:bodyPr/>
+                    <a:lstStyle/>
+                    <a:p>
+                      <a:pPr algn="l" indent="0" marL="0">
+                        <a:buNone/>
+                      </a:pPr>
+                      <a:r>
+                        <a:rPr lang="en-US" sz="950" b="1" dirty="0">
+                          <a:solidFill>
+                            <a:srgbClr val="16233D"/>
+                          </a:solidFill>
+                          <a:latin typeface="Graphik TH" pitchFamily="34" charset="0"/>
+                          <a:ea typeface="Graphik TH" pitchFamily="34" charset="-122"/>
+                          <a:cs typeface="Graphik TH" pitchFamily="34" charset="-120"/>
+                        </a:rPr>
+                        <a:t>Medium</a:t>
+                      </a:r>
+                      <a:endParaRPr lang="en-US" sz="950" dirty="0">
+                        <a:latin typeface="Graphik TH" charset="0"/>
+                        <a:ea typeface="Graphik TH" charset="0"/>
+                        <a:cs typeface="Graphik TH" charset="0"/>
+                      </a:endParaRPr>
+                    </a:p>
+                  </a:txBody>
+                  <a:tcPr marL="36576" marR="36576" marT="9144" marB="9144" anchor="ctr">
+                    <a:lnL w="6350" cap="flat" cmpd="sng" algn="ctr">
+                      <a:solidFill>
+                        <a:srgbClr val="D8DFE9"/>
+                      </a:solidFill>
+                      <a:prstDash val="solid"/>
+                      <a:round/>
+                      <a:headEnd type="none" w="med" len="med"/>
+                      <a:tailEnd type="none" w="med" len="med"/>
+                    </a:lnL>
+                    <a:lnR w="6350" cap="flat" cmpd="sng" algn="ctr">
+                      <a:solidFill>
+                        <a:srgbClr val="D8DFE9"/>
+                      </a:solidFill>
+                      <a:prstDash val="solid"/>
+                      <a:round/>
+                      <a:headEnd type="none" w="med" len="med"/>
+                      <a:tailEnd type="none" w="med" len="med"/>
+                    </a:lnR>
+                    <a:lnT w="6350" cap="flat" cmpd="sng" algn="ctr">
+                      <a:solidFill>
+                        <a:srgbClr val="D8DFE9"/>
+                      </a:solidFill>
+                      <a:prstDash val="solid"/>
+                      <a:round/>
+                      <a:headEnd type="none" w="med" len="med"/>
+                      <a:tailEnd type="none" w="med" len="med"/>
+                    </a:lnT>
+                    <a:lnB w="6350" cap="flat" cmpd="sng" algn="ctr">
+                      <a:solidFill>
+                        <a:srgbClr val="D8DFE9"/>
+                      </a:solidFill>
+                      <a:prstDash val="solid"/>
+                      <a:round/>
+                      <a:headEnd type="none" w="med" len="med"/>
+                      <a:tailEnd type="none" w="med" len="med"/>
+                    </a:lnB>
+                    <a:solidFill>
+                      <a:srgbClr val="F1F4F9"/>
+                    </a:solidFill>
+                  </a:tcPr>
+                </a:tc>
+                <a:tc>
+                  <a:txBody>
+                    <a:bodyPr/>
+                    <a:lstStyle/>
+                    <a:p>
+                      <a:pPr algn="ctr" indent="0" marL="0">
+                        <a:buNone/>
+                      </a:pPr>
+                      <a:r>
+                        <a:rPr lang="en-US" sz="950" dirty="0">
+                          <a:solidFill>
+                            <a:srgbClr val="6B7A90"/>
+                          </a:solidFill>
+                          <a:latin typeface="Graphik TH" pitchFamily="34" charset="0"/>
+                          <a:ea typeface="Graphik TH" pitchFamily="34" charset="-122"/>
+                          <a:cs typeface="Graphik TH" pitchFamily="34" charset="-120"/>
+                        </a:rPr>
+                        <a:t>12.9%</a:t>
+                      </a:r>
+                      <a:pPr algn="ctr" indent="0" marL="0">
+                        <a:buNone/>
+                      </a:pPr>
+                      <a:endParaRPr lang="en-US" sz="1200" dirty="0"/>
+                    </a:p>
+                    <a:p>
+                      <a:pPr algn="ctr" indent="0" marL="0">
+                        <a:buNone/>
+                      </a:pPr>
+                      <a:r>
+                        <a:rPr lang="en-US" sz="700" dirty="0">
+                          <a:solidFill>
+                            <a:srgbClr val="6B7A90"/>
+                          </a:solidFill>
+                          <a:latin typeface="Graphik TH" pitchFamily="34" charset="0"/>
+                          <a:ea typeface="Graphik TH" pitchFamily="34" charset="-122"/>
+                          <a:cs typeface="Graphik TH" pitchFamily="34" charset="-120"/>
+                        </a:rPr>
+                        <a:t>31</a:t>
+                      </a:r>
+                      <a:endParaRPr lang="en-US" sz="1200" dirty="0"/>
+                    </a:p>
+                  </a:txBody>
+                  <a:tcPr marL="36576" marR="36576" marT="9144" marB="9144" anchor="ctr">
+                    <a:lnL w="6350" cap="flat" cmpd="sng" algn="ctr">
+                      <a:solidFill>
+                        <a:srgbClr val="D8DFE9"/>
+                      </a:solidFill>
+                      <a:prstDash val="solid"/>
+                      <a:round/>
+                      <a:headEnd type="none" w="med" len="med"/>
+                      <a:tailEnd type="none" w="med" len="med"/>
+                    </a:lnL>
+                    <a:lnR w="6350" cap="flat" cmpd="sng" algn="ctr">
+                      <a:solidFill>
+                        <a:srgbClr val="D8DFE9"/>
+                      </a:solidFill>
+                      <a:prstDash val="solid"/>
+                      <a:round/>
+                      <a:headEnd type="none" w="med" len="med"/>
+                      <a:tailEnd type="none" w="med" len="med"/>
+                    </a:lnR>
+                    <a:lnT w="6350" cap="flat" cmpd="sng" algn="ctr">
+                      <a:solidFill>
+                        <a:srgbClr val="D8DFE9"/>
+                      </a:solidFill>
+                      <a:prstDash val="solid"/>
+                      <a:round/>
+                      <a:headEnd type="none" w="med" len="med"/>
+                      <a:tailEnd type="none" w="med" len="med"/>
+                    </a:lnT>
+                    <a:lnB w="6350" cap="flat" cmpd="sng" algn="ctr">
+                      <a:solidFill>
+                        <a:srgbClr val="D8DFE9"/>
+                      </a:solidFill>
+                      <a:prstDash val="solid"/>
+                      <a:round/>
+                      <a:headEnd type="none" w="med" len="med"/>
+                      <a:tailEnd type="none" w="med" len="med"/>
+                    </a:lnB>
+                    <a:solidFill>
+                      <a:srgbClr val="FFFFFF"/>
+                    </a:solidFill>
+                  </a:tcPr>
+                </a:tc>
+                <a:tc>
+                  <a:txBody>
+                    <a:bodyPr/>
+                    <a:lstStyle/>
+                    <a:p>
+                      <a:pPr algn="ctr" indent="0" marL="0">
+                        <a:buNone/>
+                      </a:pPr>
+                      <a:r>
+                        <a:rPr lang="en-US" sz="950" b="1" dirty="0">
+                          <a:solidFill>
+                            <a:srgbClr val="16233D"/>
+                          </a:solidFill>
+                          <a:latin typeface="Graphik TH" pitchFamily="34" charset="0"/>
+                          <a:ea typeface="Graphik TH" pitchFamily="34" charset="-122"/>
+                          <a:cs typeface="Graphik TH" pitchFamily="34" charset="-120"/>
+                        </a:rPr>
+                        <a:t>3.7%</a:t>
+                      </a:r>
+                      <a:pPr algn="ctr" indent="0" marL="0">
+                        <a:buNone/>
+                      </a:pPr>
+                      <a:endParaRPr lang="en-US" sz="1200" dirty="0"/>
+                    </a:p>
+                    <a:p>
+                      <a:pPr algn="ctr" indent="0" marL="0">
+                        <a:buNone/>
+                      </a:pPr>
+                      <a:r>
+                        <a:rPr lang="en-US" sz="700" dirty="0">
+                          <a:solidFill>
+                            <a:srgbClr val="6B7A90"/>
+                          </a:solidFill>
+                          <a:latin typeface="Graphik TH" pitchFamily="34" charset="0"/>
+                          <a:ea typeface="Graphik TH" pitchFamily="34" charset="-122"/>
+                          <a:cs typeface="Graphik TH" pitchFamily="34" charset="-120"/>
+                        </a:rPr>
+                        <a:t>4,791</a:t>
+                      </a:r>
+                      <a:endParaRPr lang="en-US" sz="1200" dirty="0"/>
+                    </a:p>
+                  </a:txBody>
+                  <a:tcPr marL="36576" marR="36576" marT="9144" marB="9144" anchor="ctr">
+                    <a:lnL w="6350" cap="flat" cmpd="sng" algn="ctr">
+                      <a:solidFill>
+                        <a:srgbClr val="D8DFE9"/>
+                      </a:solidFill>
+                      <a:prstDash val="solid"/>
+                      <a:round/>
+                      <a:headEnd type="none" w="med" len="med"/>
+                      <a:tailEnd type="none" w="med" len="med"/>
+                    </a:lnL>
+                    <a:lnR w="6350" cap="flat" cmpd="sng" algn="ctr">
+                      <a:solidFill>
+                        <a:srgbClr val="D8DFE9"/>
+                      </a:solidFill>
+                      <a:prstDash val="solid"/>
+                      <a:round/>
+                      <a:headEnd type="none" w="med" len="med"/>
+                      <a:tailEnd type="none" w="med" len="med"/>
+                    </a:lnR>
+                    <a:lnT w="6350" cap="flat" cmpd="sng" algn="ctr">
+                      <a:solidFill>
+                        <a:srgbClr val="D8DFE9"/>
+                      </a:solidFill>
+                      <a:prstDash val="solid"/>
+                      <a:round/>
+                      <a:headEnd type="none" w="med" len="med"/>
+                      <a:tailEnd type="none" w="med" len="med"/>
+                    </a:lnT>
+                    <a:lnB w="6350" cap="flat" cmpd="sng" algn="ctr">
+                      <a:solidFill>
+                        <a:srgbClr val="D8DFE9"/>
+                      </a:solidFill>
+                      <a:prstDash val="solid"/>
+                      <a:round/>
+                      <a:headEnd type="none" w="med" len="med"/>
+                      <a:tailEnd type="none" w="med" len="med"/>
+                    </a:lnB>
+                    <a:solidFill>
+                      <a:srgbClr val="FBEEEE"/>
+                    </a:solidFill>
+                  </a:tcPr>
+                </a:tc>
+                <a:tc>
+                  <a:txBody>
+                    <a:bodyPr/>
+                    <a:lstStyle/>
+                    <a:p>
+                      <a:pPr algn="ctr" indent="0" marL="0">
+                        <a:buNone/>
+                      </a:pPr>
+                      <a:r>
+                        <a:rPr lang="en-US" sz="900" dirty="0">
+                          <a:solidFill>
+                            <a:srgbClr val="6B7A90"/>
+                          </a:solidFill>
+                          <a:latin typeface="Graphik TH" pitchFamily="34" charset="0"/>
+                          <a:ea typeface="Graphik TH" pitchFamily="34" charset="-122"/>
+                          <a:cs typeface="Graphik TH" pitchFamily="34" charset="-120"/>
+                        </a:rPr>
+                        <a:t>—</a:t>
+                      </a:r>
+                      <a:endParaRPr lang="en-US" sz="900" dirty="0">
+                        <a:latin typeface="Graphik TH" charset="0"/>
+                        <a:ea typeface="Graphik TH" charset="0"/>
+                        <a:cs typeface="Graphik TH" charset="0"/>
+                      </a:endParaRPr>
+                    </a:p>
+                  </a:txBody>
+                  <a:tcPr marL="36576" marR="36576" marT="9144" marB="9144" anchor="ctr">
+                    <a:lnL w="6350" cap="flat" cmpd="sng" algn="ctr">
+                      <a:solidFill>
+                        <a:srgbClr val="D8DFE9"/>
+                      </a:solidFill>
+                      <a:prstDash val="solid"/>
+                      <a:round/>
+                      <a:headEnd type="none" w="med" len="med"/>
+                      <a:tailEnd type="none" w="med" len="med"/>
+                    </a:lnL>
+                    <a:lnR w="6350" cap="flat" cmpd="sng" algn="ctr">
+                      <a:solidFill>
+                        <a:srgbClr val="D8DFE9"/>
+                      </a:solidFill>
+                      <a:prstDash val="solid"/>
+                      <a:round/>
+                      <a:headEnd type="none" w="med" len="med"/>
+                      <a:tailEnd type="none" w="med" len="med"/>
+                    </a:lnR>
+                    <a:lnT w="6350" cap="flat" cmpd="sng" algn="ctr">
+                      <a:solidFill>
+                        <a:srgbClr val="D8DFE9"/>
+                      </a:solidFill>
+                      <a:prstDash val="solid"/>
+                      <a:round/>
+                      <a:headEnd type="none" w="med" len="med"/>
+                      <a:tailEnd type="none" w="med" len="med"/>
+                    </a:lnT>
+                    <a:lnB w="6350" cap="flat" cmpd="sng" algn="ctr">
+                      <a:solidFill>
+                        <a:srgbClr val="D8DFE9"/>
+                      </a:solidFill>
+                      <a:prstDash val="solid"/>
+                      <a:round/>
+                      <a:headEnd type="none" w="med" len="med"/>
+                      <a:tailEnd type="none" w="med" len="med"/>
+                    </a:lnB>
+                    <a:solidFill>
+                      <a:srgbClr val="FFFFFF"/>
+                    </a:solidFill>
+                  </a:tcPr>
+                </a:tc>
+                <a:tc>
+                  <a:txBody>
+                    <a:bodyPr/>
+                    <a:lstStyle/>
+                    <a:p>
+                      <a:pPr algn="ctr" indent="0" marL="0">
+                        <a:buNone/>
+                      </a:pPr>
+                      <a:r>
+                        <a:rPr lang="en-US" sz="950" dirty="0">
+                          <a:solidFill>
+                            <a:srgbClr val="6B7A90"/>
+                          </a:solidFill>
+                          <a:latin typeface="Graphik TH" pitchFamily="34" charset="0"/>
+                          <a:ea typeface="Graphik TH" pitchFamily="34" charset="-122"/>
+                          <a:cs typeface="Graphik TH" pitchFamily="34" charset="-120"/>
+                        </a:rPr>
+                        <a:t>38.8%</a:t>
+                      </a:r>
+                      <a:pPr algn="ctr" indent="0" marL="0">
+                        <a:buNone/>
+                      </a:pPr>
+                      <a:endParaRPr lang="en-US" sz="1200" dirty="0"/>
+                    </a:p>
+                    <a:p>
+                      <a:pPr algn="ctr" indent="0" marL="0">
+                        <a:buNone/>
+                      </a:pPr>
+                      <a:r>
+                        <a:rPr lang="en-US" sz="700" dirty="0">
+                          <a:solidFill>
+                            <a:srgbClr val="6B7A90"/>
+                          </a:solidFill>
+                          <a:latin typeface="Graphik TH" pitchFamily="34" charset="0"/>
+                          <a:ea typeface="Graphik TH" pitchFamily="34" charset="-122"/>
+                          <a:cs typeface="Graphik TH" pitchFamily="34" charset="-120"/>
+                        </a:rPr>
+                        <a:t>49</a:t>
+                      </a:r>
+                      <a:endParaRPr lang="en-US" sz="1200" dirty="0"/>
+                    </a:p>
+                  </a:txBody>
+                  <a:tcPr marL="36576" marR="36576" marT="9144" marB="9144" anchor="ctr">
+                    <a:lnL w="6350" cap="flat" cmpd="sng" algn="ctr">
+                      <a:solidFill>
+                        <a:srgbClr val="D8DFE9"/>
+                      </a:solidFill>
+                      <a:prstDash val="solid"/>
+                      <a:round/>
+                      <a:headEnd type="none" w="med" len="med"/>
+                      <a:tailEnd type="none" w="med" len="med"/>
+                    </a:lnL>
+                    <a:lnR w="6350" cap="flat" cmpd="sng" algn="ctr">
+                      <a:solidFill>
+                        <a:srgbClr val="D8DFE9"/>
+                      </a:solidFill>
+                      <a:prstDash val="solid"/>
+                      <a:round/>
+                      <a:headEnd type="none" w="med" len="med"/>
+                      <a:tailEnd type="none" w="med" len="med"/>
+                    </a:lnR>
+                    <a:lnT w="6350" cap="flat" cmpd="sng" algn="ctr">
+                      <a:solidFill>
+                        <a:srgbClr val="D8DFE9"/>
+                      </a:solidFill>
+                      <a:prstDash val="solid"/>
+                      <a:round/>
+                      <a:headEnd type="none" w="med" len="med"/>
+                      <a:tailEnd type="none" w="med" len="med"/>
+                    </a:lnT>
+                    <a:lnB w="6350" cap="flat" cmpd="sng" algn="ctr">
+                      <a:solidFill>
+                        <a:srgbClr val="D8DFE9"/>
+                      </a:solidFill>
+                      <a:prstDash val="solid"/>
+                      <a:round/>
+                      <a:headEnd type="none" w="med" len="med"/>
+                      <a:tailEnd type="none" w="med" len="med"/>
+                    </a:lnB>
+                    <a:solidFill>
+                      <a:srgbClr val="FFFFFF"/>
+                    </a:solidFill>
+                  </a:tcPr>
+                </a:tc>
+                <a:tc>
+                  <a:txBody>
+                    <a:bodyPr/>
+                    <a:lstStyle/>
+                    <a:p>
+                      <a:pPr algn="ctr" indent="0" marL="0">
+                        <a:buNone/>
+                      </a:pPr>
+                      <a:r>
+                        <a:rPr lang="en-US" sz="950" b="1" dirty="0">
+                          <a:solidFill>
+                            <a:srgbClr val="16233D"/>
+                          </a:solidFill>
+                          <a:latin typeface="Graphik TH" pitchFamily="34" charset="0"/>
+                          <a:ea typeface="Graphik TH" pitchFamily="34" charset="-122"/>
+                          <a:cs typeface="Graphik TH" pitchFamily="34" charset="-120"/>
+                        </a:rPr>
+                        <a:t>9.7%</a:t>
+                      </a:r>
+                      <a:pPr algn="ctr" indent="0" marL="0">
+                        <a:buNone/>
+                      </a:pPr>
+                      <a:endParaRPr lang="en-US" sz="1200" dirty="0"/>
+                    </a:p>
+                    <a:p>
+                      <a:pPr algn="ctr" indent="0" marL="0">
+                        <a:buNone/>
+                      </a:pPr>
+                      <a:r>
+                        <a:rPr lang="en-US" sz="700" dirty="0">
+                          <a:solidFill>
+                            <a:srgbClr val="6B7A90"/>
+                          </a:solidFill>
+                          <a:latin typeface="Graphik TH" pitchFamily="34" charset="0"/>
+                          <a:ea typeface="Graphik TH" pitchFamily="34" charset="-122"/>
+                          <a:cs typeface="Graphik TH" pitchFamily="34" charset="-120"/>
+                        </a:rPr>
+                        <a:t>236</a:t>
+                      </a:r>
+                      <a:endParaRPr lang="en-US" sz="1200" dirty="0"/>
+                    </a:p>
+                  </a:txBody>
+                  <a:tcPr marL="36576" marR="36576" marT="9144" marB="9144" anchor="ctr">
+                    <a:lnL w="6350" cap="flat" cmpd="sng" algn="ctr">
+                      <a:solidFill>
+                        <a:srgbClr val="D8DFE9"/>
+                      </a:solidFill>
+                      <a:prstDash val="solid"/>
+                      <a:round/>
+                      <a:headEnd type="none" w="med" len="med"/>
+                      <a:tailEnd type="none" w="med" len="med"/>
+                    </a:lnL>
+                    <a:lnR w="6350" cap="flat" cmpd="sng" algn="ctr">
+                      <a:solidFill>
+                        <a:srgbClr val="D8DFE9"/>
+                      </a:solidFill>
+                      <a:prstDash val="solid"/>
+                      <a:round/>
+                      <a:headEnd type="none" w="med" len="med"/>
+                      <a:tailEnd type="none" w="med" len="med"/>
+                    </a:lnR>
+                    <a:lnT w="6350" cap="flat" cmpd="sng" algn="ctr">
+                      <a:solidFill>
+                        <a:srgbClr val="D8DFE9"/>
+                      </a:solidFill>
+                      <a:prstDash val="solid"/>
+                      <a:round/>
+                      <a:headEnd type="none" w="med" len="med"/>
+                      <a:tailEnd type="none" w="med" len="med"/>
+                    </a:lnT>
+                    <a:lnB w="6350" cap="flat" cmpd="sng" algn="ctr">
+                      <a:solidFill>
+                        <a:srgbClr val="D8DFE9"/>
+                      </a:solidFill>
+                      <a:prstDash val="solid"/>
+                      <a:round/>
+                      <a:headEnd type="none" w="med" len="med"/>
+                      <a:tailEnd type="none" w="med" len="med"/>
+                    </a:lnB>
+                    <a:solidFill>
+                      <a:srgbClr val="F4D3D3"/>
+                    </a:solidFill>
+                  </a:tcPr>
+                </a:tc>
+              </a:tr>
+              <a:tr h="274320">
+                <a:tc>
+                  <a:txBody>
+                    <a:bodyPr/>
+                    <a:lstStyle/>
+                    <a:p>
+                      <a:pPr algn="l" indent="0" marL="0">
+                        <a:buNone/>
+                      </a:pPr>
+                      <a:r>
+                        <a:rPr lang="en-US" sz="950" b="1" dirty="0">
+                          <a:solidFill>
+                            <a:srgbClr val="16233D"/>
+                          </a:solidFill>
+                          <a:latin typeface="Graphik TH" pitchFamily="34" charset="0"/>
+                          <a:ea typeface="Graphik TH" pitchFamily="34" charset="-122"/>
+                          <a:cs typeface="Graphik TH" pitchFamily="34" charset="-120"/>
+                        </a:rPr>
+                        <a:t>Low</a:t>
+                      </a:r>
+                      <a:endParaRPr lang="en-US" sz="950" dirty="0">
+                        <a:latin typeface="Graphik TH" charset="0"/>
+                        <a:ea typeface="Graphik TH" charset="0"/>
+                        <a:cs typeface="Graphik TH" charset="0"/>
+                      </a:endParaRPr>
+                    </a:p>
+                  </a:txBody>
+                  <a:tcPr marL="36576" marR="36576" marT="9144" marB="9144" anchor="ctr">
+                    <a:lnL w="6350" cap="flat" cmpd="sng" algn="ctr">
+                      <a:solidFill>
+                        <a:srgbClr val="D8DFE9"/>
+                      </a:solidFill>
+                      <a:prstDash val="solid"/>
+                      <a:round/>
+                      <a:headEnd type="none" w="med" len="med"/>
+                      <a:tailEnd type="none" w="med" len="med"/>
+                    </a:lnL>
+                    <a:lnR w="6350" cap="flat" cmpd="sng" algn="ctr">
+                      <a:solidFill>
+                        <a:srgbClr val="D8DFE9"/>
+                      </a:solidFill>
+                      <a:prstDash val="solid"/>
+                      <a:round/>
+                      <a:headEnd type="none" w="med" len="med"/>
+                      <a:tailEnd type="none" w="med" len="med"/>
+                    </a:lnR>
+                    <a:lnT w="6350" cap="flat" cmpd="sng" algn="ctr">
+                      <a:solidFill>
+                        <a:srgbClr val="D8DFE9"/>
+                      </a:solidFill>
+                      <a:prstDash val="solid"/>
+                      <a:round/>
+                      <a:headEnd type="none" w="med" len="med"/>
+                      <a:tailEnd type="none" w="med" len="med"/>
+                    </a:lnT>
+                    <a:lnB w="6350" cap="flat" cmpd="sng" algn="ctr">
+                      <a:solidFill>
+                        <a:srgbClr val="D8DFE9"/>
+                      </a:solidFill>
+                      <a:prstDash val="solid"/>
+                      <a:round/>
+                      <a:headEnd type="none" w="med" len="med"/>
+                      <a:tailEnd type="none" w="med" len="med"/>
+                    </a:lnB>
+                    <a:solidFill>
+                      <a:srgbClr val="F1F4F9"/>
+                    </a:solidFill>
+                  </a:tcPr>
+                </a:tc>
+                <a:tc>
+                  <a:txBody>
+                    <a:bodyPr/>
+                    <a:lstStyle/>
+                    <a:p>
+                      <a:pPr algn="ctr" indent="0" marL="0">
+                        <a:buNone/>
+                      </a:pPr>
+                      <a:r>
+                        <a:rPr lang="en-US" sz="950" dirty="0">
+                          <a:solidFill>
+                            <a:srgbClr val="6B7A90"/>
+                          </a:solidFill>
+                          <a:latin typeface="Graphik TH" pitchFamily="34" charset="0"/>
+                          <a:ea typeface="Graphik TH" pitchFamily="34" charset="-122"/>
+                          <a:cs typeface="Graphik TH" pitchFamily="34" charset="-120"/>
+                        </a:rPr>
+                        <a:t>0.0%</a:t>
+                      </a:r>
+                      <a:pPr algn="ctr" indent="0" marL="0">
+                        <a:buNone/>
+                      </a:pPr>
+                      <a:endParaRPr lang="en-US" sz="1200" dirty="0"/>
+                    </a:p>
+                    <a:p>
+                      <a:pPr algn="ctr" indent="0" marL="0">
+                        <a:buNone/>
+                      </a:pPr>
+                      <a:r>
+                        <a:rPr lang="en-US" sz="700" dirty="0">
+                          <a:solidFill>
+                            <a:srgbClr val="6B7A90"/>
+                          </a:solidFill>
+                          <a:latin typeface="Graphik TH" pitchFamily="34" charset="0"/>
+                          <a:ea typeface="Graphik TH" pitchFamily="34" charset="-122"/>
+                          <a:cs typeface="Graphik TH" pitchFamily="34" charset="-120"/>
+                        </a:rPr>
+                        <a:t>4</a:t>
+                      </a:r>
+                      <a:endParaRPr lang="en-US" sz="1200" dirty="0"/>
+                    </a:p>
+                  </a:txBody>
+                  <a:tcPr marL="36576" marR="36576" marT="9144" marB="9144" anchor="ctr">
+                    <a:lnL w="6350" cap="flat" cmpd="sng" algn="ctr">
+                      <a:solidFill>
+                        <a:srgbClr val="D8DFE9"/>
+                      </a:solidFill>
+                      <a:prstDash val="solid"/>
+                      <a:round/>
+                      <a:headEnd type="none" w="med" len="med"/>
+                      <a:tailEnd type="none" w="med" len="med"/>
+                    </a:lnL>
+                    <a:lnR w="6350" cap="flat" cmpd="sng" algn="ctr">
+                      <a:solidFill>
+                        <a:srgbClr val="D8DFE9"/>
+                      </a:solidFill>
+                      <a:prstDash val="solid"/>
+                      <a:round/>
+                      <a:headEnd type="none" w="med" len="med"/>
+                      <a:tailEnd type="none" w="med" len="med"/>
+                    </a:lnR>
+                    <a:lnT w="6350" cap="flat" cmpd="sng" algn="ctr">
+                      <a:solidFill>
+                        <a:srgbClr val="D8DFE9"/>
+                      </a:solidFill>
+                      <a:prstDash val="solid"/>
+                      <a:round/>
+                      <a:headEnd type="none" w="med" len="med"/>
+                      <a:tailEnd type="none" w="med" len="med"/>
+                    </a:lnT>
+                    <a:lnB w="6350" cap="flat" cmpd="sng" algn="ctr">
+                      <a:solidFill>
+                        <a:srgbClr val="D8DFE9"/>
+                      </a:solidFill>
+                      <a:prstDash val="solid"/>
+                      <a:round/>
+                      <a:headEnd type="none" w="med" len="med"/>
+                      <a:tailEnd type="none" w="med" len="med"/>
+                    </a:lnB>
+                    <a:solidFill>
+                      <a:srgbClr val="FFFFFF"/>
+                    </a:solidFill>
+                  </a:tcPr>
+                </a:tc>
+                <a:tc>
+                  <a:txBody>
+                    <a:bodyPr/>
+                    <a:lstStyle/>
+                    <a:p>
+                      <a:pPr algn="ctr" indent="0" marL="0">
+                        <a:buNone/>
+                      </a:pPr>
+                      <a:r>
+                        <a:rPr lang="en-US" sz="950" b="1" dirty="0">
+                          <a:solidFill>
+                            <a:srgbClr val="16233D"/>
+                          </a:solidFill>
+                          <a:latin typeface="Graphik TH" pitchFamily="34" charset="0"/>
+                          <a:ea typeface="Graphik TH" pitchFamily="34" charset="-122"/>
+                          <a:cs typeface="Graphik TH" pitchFamily="34" charset="-120"/>
+                        </a:rPr>
+                        <a:t>2.5%</a:t>
+                      </a:r>
+                      <a:pPr algn="ctr" indent="0" marL="0">
+                        <a:buNone/>
+                      </a:pPr>
+                      <a:endParaRPr lang="en-US" sz="1200" dirty="0"/>
+                    </a:p>
+                    <a:p>
+                      <a:pPr algn="ctr" indent="0" marL="0">
+                        <a:buNone/>
+                      </a:pPr>
+                      <a:r>
+                        <a:rPr lang="en-US" sz="700" dirty="0">
+                          <a:solidFill>
+                            <a:srgbClr val="6B7A90"/>
+                          </a:solidFill>
+                          <a:latin typeface="Graphik TH" pitchFamily="34" charset="0"/>
+                          <a:ea typeface="Graphik TH" pitchFamily="34" charset="-122"/>
+                          <a:cs typeface="Graphik TH" pitchFamily="34" charset="-120"/>
+                        </a:rPr>
+                        <a:t>2,073</a:t>
+                      </a:r>
+                      <a:endParaRPr lang="en-US" sz="1200" dirty="0"/>
+                    </a:p>
+                  </a:txBody>
+                  <a:tcPr marL="36576" marR="36576" marT="9144" marB="9144" anchor="ctr">
+                    <a:lnL w="6350" cap="flat" cmpd="sng" algn="ctr">
+                      <a:solidFill>
+                        <a:srgbClr val="D8DFE9"/>
+                      </a:solidFill>
+                      <a:prstDash val="solid"/>
+                      <a:round/>
+                      <a:headEnd type="none" w="med" len="med"/>
+                      <a:tailEnd type="none" w="med" len="med"/>
+                    </a:lnL>
+                    <a:lnR w="6350" cap="flat" cmpd="sng" algn="ctr">
+                      <a:solidFill>
+                        <a:srgbClr val="D8DFE9"/>
+                      </a:solidFill>
+                      <a:prstDash val="solid"/>
+                      <a:round/>
+                      <a:headEnd type="none" w="med" len="med"/>
+                      <a:tailEnd type="none" w="med" len="med"/>
+                    </a:lnR>
+                    <a:lnT w="6350" cap="flat" cmpd="sng" algn="ctr">
+                      <a:solidFill>
+                        <a:srgbClr val="D8DFE9"/>
+                      </a:solidFill>
+                      <a:prstDash val="solid"/>
+                      <a:round/>
+                      <a:headEnd type="none" w="med" len="med"/>
+                      <a:tailEnd type="none" w="med" len="med"/>
+                    </a:lnT>
+                    <a:lnB w="6350" cap="flat" cmpd="sng" algn="ctr">
+                      <a:solidFill>
+                        <a:srgbClr val="D8DFE9"/>
+                      </a:solidFill>
+                      <a:prstDash val="solid"/>
+                      <a:round/>
+                      <a:headEnd type="none" w="med" len="med"/>
+                      <a:tailEnd type="none" w="med" len="med"/>
+                    </a:lnB>
+                    <a:solidFill>
+                      <a:srgbClr val="FCF4F4"/>
+                    </a:solidFill>
+                  </a:tcPr>
+                </a:tc>
+                <a:tc>
+                  <a:txBody>
+                    <a:bodyPr/>
+                    <a:lstStyle/>
+                    <a:p>
+                      <a:pPr algn="ctr" indent="0" marL="0">
+                        <a:buNone/>
+                      </a:pPr>
+                      <a:r>
+                        <a:rPr lang="en-US" sz="900" dirty="0">
+                          <a:solidFill>
+                            <a:srgbClr val="6B7A90"/>
+                          </a:solidFill>
+                          <a:latin typeface="Graphik TH" pitchFamily="34" charset="0"/>
+                          <a:ea typeface="Graphik TH" pitchFamily="34" charset="-122"/>
+                          <a:cs typeface="Graphik TH" pitchFamily="34" charset="-120"/>
+                        </a:rPr>
+                        <a:t>—</a:t>
+                      </a:r>
+                      <a:endParaRPr lang="en-US" sz="900" dirty="0">
+                        <a:latin typeface="Graphik TH" charset="0"/>
+                        <a:ea typeface="Graphik TH" charset="0"/>
+                        <a:cs typeface="Graphik TH" charset="0"/>
+                      </a:endParaRPr>
+                    </a:p>
+                  </a:txBody>
+                  <a:tcPr marL="36576" marR="36576" marT="9144" marB="9144" anchor="ctr">
+                    <a:lnL w="6350" cap="flat" cmpd="sng" algn="ctr">
+                      <a:solidFill>
+                        <a:srgbClr val="D8DFE9"/>
+                      </a:solidFill>
+                      <a:prstDash val="solid"/>
+                      <a:round/>
+                      <a:headEnd type="none" w="med" len="med"/>
+                      <a:tailEnd type="none" w="med" len="med"/>
+                    </a:lnL>
+                    <a:lnR w="6350" cap="flat" cmpd="sng" algn="ctr">
+                      <a:solidFill>
+                        <a:srgbClr val="D8DFE9"/>
+                      </a:solidFill>
+                      <a:prstDash val="solid"/>
+                      <a:round/>
+                      <a:headEnd type="none" w="med" len="med"/>
+                      <a:tailEnd type="none" w="med" len="med"/>
+                    </a:lnR>
+                    <a:lnT w="6350" cap="flat" cmpd="sng" algn="ctr">
+                      <a:solidFill>
+                        <a:srgbClr val="D8DFE9"/>
+                      </a:solidFill>
+                      <a:prstDash val="solid"/>
+                      <a:round/>
+                      <a:headEnd type="none" w="med" len="med"/>
+                      <a:tailEnd type="none" w="med" len="med"/>
+                    </a:lnT>
+                    <a:lnB w="6350" cap="flat" cmpd="sng" algn="ctr">
+                      <a:solidFill>
+                        <a:srgbClr val="D8DFE9"/>
+                      </a:solidFill>
+                      <a:prstDash val="solid"/>
+                      <a:round/>
+                      <a:headEnd type="none" w="med" len="med"/>
+                      <a:tailEnd type="none" w="med" len="med"/>
+                    </a:lnB>
+                    <a:solidFill>
+                      <a:srgbClr val="FFFFFF"/>
+                    </a:solidFill>
+                  </a:tcPr>
+                </a:tc>
+                <a:tc>
+                  <a:txBody>
+                    <a:bodyPr/>
+                    <a:lstStyle/>
+                    <a:p>
+                      <a:pPr algn="ctr" indent="0" marL="0">
+                        <a:buNone/>
+                      </a:pPr>
+                      <a:r>
+                        <a:rPr lang="en-US" sz="950" dirty="0">
+                          <a:solidFill>
+                            <a:srgbClr val="6B7A90"/>
+                          </a:solidFill>
+                          <a:latin typeface="Graphik TH" pitchFamily="34" charset="0"/>
+                          <a:ea typeface="Graphik TH" pitchFamily="34" charset="-122"/>
+                          <a:cs typeface="Graphik TH" pitchFamily="34" charset="-120"/>
+                        </a:rPr>
+                        <a:t>0.0%</a:t>
+                      </a:r>
+                      <a:pPr algn="ctr" indent="0" marL="0">
+                        <a:buNone/>
+                      </a:pPr>
+                      <a:endParaRPr lang="en-US" sz="1200" dirty="0"/>
+                    </a:p>
+                    <a:p>
+                      <a:pPr algn="ctr" indent="0" marL="0">
+                        <a:buNone/>
+                      </a:pPr>
+                      <a:r>
+                        <a:rPr lang="en-US" sz="700" dirty="0">
+                          <a:solidFill>
+                            <a:srgbClr val="6B7A90"/>
+                          </a:solidFill>
+                          <a:latin typeface="Graphik TH" pitchFamily="34" charset="0"/>
+                          <a:ea typeface="Graphik TH" pitchFamily="34" charset="-122"/>
+                          <a:cs typeface="Graphik TH" pitchFamily="34" charset="-120"/>
+                        </a:rPr>
+                        <a:t>1</a:t>
+                      </a:r>
+                      <a:endParaRPr lang="en-US" sz="1200" dirty="0"/>
+                    </a:p>
+                  </a:txBody>
+                  <a:tcPr marL="36576" marR="36576" marT="9144" marB="9144" anchor="ctr">
+                    <a:lnL w="6350" cap="flat" cmpd="sng" algn="ctr">
+                      <a:solidFill>
+                        <a:srgbClr val="D8DFE9"/>
+                      </a:solidFill>
+                      <a:prstDash val="solid"/>
+                      <a:round/>
+                      <a:headEnd type="none" w="med" len="med"/>
+                      <a:tailEnd type="none" w="med" len="med"/>
+                    </a:lnL>
+                    <a:lnR w="6350" cap="flat" cmpd="sng" algn="ctr">
+                      <a:solidFill>
+                        <a:srgbClr val="D8DFE9"/>
+                      </a:solidFill>
+                      <a:prstDash val="solid"/>
+                      <a:round/>
+                      <a:headEnd type="none" w="med" len="med"/>
+                      <a:tailEnd type="none" w="med" len="med"/>
+                    </a:lnR>
+                    <a:lnT w="6350" cap="flat" cmpd="sng" algn="ctr">
+                      <a:solidFill>
+                        <a:srgbClr val="D8DFE9"/>
+                      </a:solidFill>
+                      <a:prstDash val="solid"/>
+                      <a:round/>
+                      <a:headEnd type="none" w="med" len="med"/>
+                      <a:tailEnd type="none" w="med" len="med"/>
+                    </a:lnT>
+                    <a:lnB w="6350" cap="flat" cmpd="sng" algn="ctr">
+                      <a:solidFill>
+                        <a:srgbClr val="D8DFE9"/>
+                      </a:solidFill>
+                      <a:prstDash val="solid"/>
+                      <a:round/>
+                      <a:headEnd type="none" w="med" len="med"/>
+                      <a:tailEnd type="none" w="med" len="med"/>
+                    </a:lnB>
+                    <a:solidFill>
+                      <a:srgbClr val="FFFFFF"/>
+                    </a:solidFill>
+                  </a:tcPr>
+                </a:tc>
+                <a:tc>
+                  <a:txBody>
+                    <a:bodyPr/>
+                    <a:lstStyle/>
+                    <a:p>
+                      <a:pPr algn="ctr" indent="0" marL="0">
+                        <a:buNone/>
+                      </a:pPr>
+                      <a:r>
+                        <a:rPr lang="en-US" sz="950" dirty="0">
+                          <a:solidFill>
+                            <a:srgbClr val="6B7A90"/>
+                          </a:solidFill>
+                          <a:latin typeface="Graphik TH" pitchFamily="34" charset="0"/>
+                          <a:ea typeface="Graphik TH" pitchFamily="34" charset="-122"/>
+                          <a:cs typeface="Graphik TH" pitchFamily="34" charset="-120"/>
+                        </a:rPr>
+                        <a:t>36.4%</a:t>
+                      </a:r>
+                      <a:pPr algn="ctr" indent="0" marL="0">
+                        <a:buNone/>
+                      </a:pPr>
+                      <a:endParaRPr lang="en-US" sz="1200" dirty="0"/>
+                    </a:p>
+                    <a:p>
+                      <a:pPr algn="ctr" indent="0" marL="0">
+                        <a:buNone/>
+                      </a:pPr>
+                      <a:r>
+                        <a:rPr lang="en-US" sz="700" dirty="0">
+                          <a:solidFill>
+                            <a:srgbClr val="6B7A90"/>
+                          </a:solidFill>
+                          <a:latin typeface="Graphik TH" pitchFamily="34" charset="0"/>
+                          <a:ea typeface="Graphik TH" pitchFamily="34" charset="-122"/>
+                          <a:cs typeface="Graphik TH" pitchFamily="34" charset="-120"/>
+                        </a:rPr>
+                        <a:t>11</a:t>
+                      </a:r>
+                      <a:endParaRPr lang="en-US" sz="1200" dirty="0"/>
+                    </a:p>
+                  </a:txBody>
+                  <a:tcPr marL="36576" marR="36576" marT="9144" marB="9144" anchor="ctr">
+                    <a:lnL w="6350" cap="flat" cmpd="sng" algn="ctr">
+                      <a:solidFill>
+                        <a:srgbClr val="D8DFE9"/>
+                      </a:solidFill>
+                      <a:prstDash val="solid"/>
+                      <a:round/>
+                      <a:headEnd type="none" w="med" len="med"/>
+                      <a:tailEnd type="none" w="med" len="med"/>
+                    </a:lnL>
+                    <a:lnR w="6350" cap="flat" cmpd="sng" algn="ctr">
+                      <a:solidFill>
+                        <a:srgbClr val="D8DFE9"/>
+                      </a:solidFill>
+                      <a:prstDash val="solid"/>
+                      <a:round/>
+                      <a:headEnd type="none" w="med" len="med"/>
+                      <a:tailEnd type="none" w="med" len="med"/>
+                    </a:lnR>
+                    <a:lnT w="6350" cap="flat" cmpd="sng" algn="ctr">
+                      <a:solidFill>
+                        <a:srgbClr val="D8DFE9"/>
+                      </a:solidFill>
+                      <a:prstDash val="solid"/>
+                      <a:round/>
+                      <a:headEnd type="none" w="med" len="med"/>
+                      <a:tailEnd type="none" w="med" len="med"/>
+                    </a:lnT>
+                    <a:lnB w="6350" cap="flat" cmpd="sng" algn="ctr">
+                      <a:solidFill>
+                        <a:srgbClr val="D8DFE9"/>
+                      </a:solidFill>
+                      <a:prstDash val="solid"/>
+                      <a:round/>
+                      <a:headEnd type="none" w="med" len="med"/>
+                      <a:tailEnd type="none" w="med" len="med"/>
+                    </a:lnB>
+                    <a:solidFill>
+                      <a:srgbClr val="FFFFFF"/>
+                    </a:solidFill>
+                  </a:tcPr>
+                </a:tc>
+              </a:tr>
+              <a:tr h="274320">
+                <a:tc>
+                  <a:txBody>
+                    <a:bodyPr/>
+                    <a:lstStyle/>
+                    <a:p>
+                      <a:pPr algn="l" indent="0" marL="0">
+                        <a:buNone/>
+                      </a:pPr>
+                      <a:r>
+                        <a:rPr lang="en-US" sz="950" b="1" dirty="0">
+                          <a:solidFill>
+                            <a:srgbClr val="16233D"/>
+                          </a:solidFill>
+                          <a:latin typeface="Graphik TH" pitchFamily="34" charset="0"/>
+                          <a:ea typeface="Graphik TH" pitchFamily="34" charset="-122"/>
+                          <a:cs typeface="Graphik TH" pitchFamily="34" charset="-120"/>
+                        </a:rPr>
+                        <a:t>Very Low</a:t>
+                      </a:r>
+                      <a:endParaRPr lang="en-US" sz="950" dirty="0">
+                        <a:latin typeface="Graphik TH" charset="0"/>
+                        <a:ea typeface="Graphik TH" charset="0"/>
+                        <a:cs typeface="Graphik TH" charset="0"/>
+                      </a:endParaRPr>
+                    </a:p>
+                  </a:txBody>
+                  <a:tcPr marL="36576" marR="36576" marT="9144" marB="9144" anchor="ctr">
+                    <a:lnL w="6350" cap="flat" cmpd="sng" algn="ctr">
+                      <a:solidFill>
+                        <a:srgbClr val="D8DFE9"/>
+                      </a:solidFill>
+                      <a:prstDash val="solid"/>
+                      <a:round/>
+                      <a:headEnd type="none" w="med" len="med"/>
+                      <a:tailEnd type="none" w="med" len="med"/>
+                    </a:lnL>
+                    <a:lnR w="6350" cap="flat" cmpd="sng" algn="ctr">
+                      <a:solidFill>
+                        <a:srgbClr val="D8DFE9"/>
+                      </a:solidFill>
+                      <a:prstDash val="solid"/>
+                      <a:round/>
+                      <a:headEnd type="none" w="med" len="med"/>
+                      <a:tailEnd type="none" w="med" len="med"/>
+                    </a:lnR>
+                    <a:lnT w="6350" cap="flat" cmpd="sng" algn="ctr">
+                      <a:solidFill>
+                        <a:srgbClr val="D8DFE9"/>
+                      </a:solidFill>
+                      <a:prstDash val="solid"/>
+                      <a:round/>
+                      <a:headEnd type="none" w="med" len="med"/>
+                      <a:tailEnd type="none" w="med" len="med"/>
+                    </a:lnT>
+                    <a:lnB w="6350" cap="flat" cmpd="sng" algn="ctr">
+                      <a:solidFill>
+                        <a:srgbClr val="D8DFE9"/>
+                      </a:solidFill>
+                      <a:prstDash val="solid"/>
+                      <a:round/>
+                      <a:headEnd type="none" w="med" len="med"/>
+                      <a:tailEnd type="none" w="med" len="med"/>
+                    </a:lnB>
+                    <a:solidFill>
+                      <a:srgbClr val="F1F4F9"/>
+                    </a:solidFill>
+                  </a:tcPr>
+                </a:tc>
+                <a:tc>
+                  <a:txBody>
+                    <a:bodyPr/>
+                    <a:lstStyle/>
+                    <a:p>
+                      <a:pPr algn="ctr" indent="0" marL="0">
+                        <a:buNone/>
+                      </a:pPr>
+                      <a:r>
+                        <a:rPr lang="en-US" sz="900" dirty="0">
+                          <a:solidFill>
+                            <a:srgbClr val="6B7A90"/>
+                          </a:solidFill>
+                          <a:latin typeface="Graphik TH" pitchFamily="34" charset="0"/>
+                          <a:ea typeface="Graphik TH" pitchFamily="34" charset="-122"/>
+                          <a:cs typeface="Graphik TH" pitchFamily="34" charset="-120"/>
+                        </a:rPr>
+                        <a:t>—</a:t>
+                      </a:r>
+                      <a:endParaRPr lang="en-US" sz="900" dirty="0">
+                        <a:latin typeface="Graphik TH" charset="0"/>
+                        <a:ea typeface="Graphik TH" charset="0"/>
+                        <a:cs typeface="Graphik TH" charset="0"/>
+                      </a:endParaRPr>
+                    </a:p>
+                  </a:txBody>
+                  <a:tcPr marL="36576" marR="36576" marT="9144" marB="9144" anchor="ctr">
+                    <a:lnL w="6350" cap="flat" cmpd="sng" algn="ctr">
+                      <a:solidFill>
+                        <a:srgbClr val="D8DFE9"/>
+                      </a:solidFill>
+                      <a:prstDash val="solid"/>
+                      <a:round/>
+                      <a:headEnd type="none" w="med" len="med"/>
+                      <a:tailEnd type="none" w="med" len="med"/>
+                    </a:lnL>
+                    <a:lnR w="6350" cap="flat" cmpd="sng" algn="ctr">
+                      <a:solidFill>
+                        <a:srgbClr val="D8DFE9"/>
+                      </a:solidFill>
+                      <a:prstDash val="solid"/>
+                      <a:round/>
+                      <a:headEnd type="none" w="med" len="med"/>
+                      <a:tailEnd type="none" w="med" len="med"/>
+                    </a:lnR>
+                    <a:lnT w="6350" cap="flat" cmpd="sng" algn="ctr">
+                      <a:solidFill>
+                        <a:srgbClr val="D8DFE9"/>
+                      </a:solidFill>
+                      <a:prstDash val="solid"/>
+                      <a:round/>
+                      <a:headEnd type="none" w="med" len="med"/>
+                      <a:tailEnd type="none" w="med" len="med"/>
+                    </a:lnT>
+                    <a:lnB w="6350" cap="flat" cmpd="sng" algn="ctr">
+                      <a:solidFill>
+                        <a:srgbClr val="D8DFE9"/>
+                      </a:solidFill>
+                      <a:prstDash val="solid"/>
+                      <a:round/>
+                      <a:headEnd type="none" w="med" len="med"/>
+                      <a:tailEnd type="none" w="med" len="med"/>
+                    </a:lnB>
+                    <a:solidFill>
+                      <a:srgbClr val="FFFFFF"/>
+                    </a:solidFill>
+                  </a:tcPr>
+                </a:tc>
+                <a:tc>
+                  <a:txBody>
+                    <a:bodyPr/>
+                    <a:lstStyle/>
+                    <a:p>
+                      <a:pPr algn="ctr" indent="0" marL="0">
+                        <a:buNone/>
+                      </a:pPr>
+                      <a:r>
+                        <a:rPr lang="en-US" sz="950" b="1" dirty="0">
+                          <a:solidFill>
+                            <a:srgbClr val="16233D"/>
+                          </a:solidFill>
+                          <a:latin typeface="Graphik TH" pitchFamily="34" charset="0"/>
+                          <a:ea typeface="Graphik TH" pitchFamily="34" charset="-122"/>
+                          <a:cs typeface="Graphik TH" pitchFamily="34" charset="-120"/>
+                        </a:rPr>
+                        <a:t>1.9%</a:t>
+                      </a:r>
+                      <a:pPr algn="ctr" indent="0" marL="0">
+                        <a:buNone/>
+                      </a:pPr>
+                      <a:endParaRPr lang="en-US" sz="1200" dirty="0"/>
+                    </a:p>
+                    <a:p>
+                      <a:pPr algn="ctr" indent="0" marL="0">
+                        <a:buNone/>
+                      </a:pPr>
+                      <a:r>
+                        <a:rPr lang="en-US" sz="700" dirty="0">
+                          <a:solidFill>
+                            <a:srgbClr val="6B7A90"/>
+                          </a:solidFill>
+                          <a:latin typeface="Graphik TH" pitchFamily="34" charset="0"/>
+                          <a:ea typeface="Graphik TH" pitchFamily="34" charset="-122"/>
+                          <a:cs typeface="Graphik TH" pitchFamily="34" charset="-120"/>
+                        </a:rPr>
+                        <a:t>1,408</a:t>
+                      </a:r>
+                      <a:endParaRPr lang="en-US" sz="1200" dirty="0"/>
+                    </a:p>
+                  </a:txBody>
+                  <a:tcPr marL="36576" marR="36576" marT="9144" marB="9144" anchor="ctr">
+                    <a:lnL w="6350" cap="flat" cmpd="sng" algn="ctr">
+                      <a:solidFill>
+                        <a:srgbClr val="D8DFE9"/>
+                      </a:solidFill>
+                      <a:prstDash val="solid"/>
+                      <a:round/>
+                      <a:headEnd type="none" w="med" len="med"/>
+                      <a:tailEnd type="none" w="med" len="med"/>
+                    </a:lnL>
+                    <a:lnR w="6350" cap="flat" cmpd="sng" algn="ctr">
+                      <a:solidFill>
+                        <a:srgbClr val="D8DFE9"/>
+                      </a:solidFill>
+                      <a:prstDash val="solid"/>
+                      <a:round/>
+                      <a:headEnd type="none" w="med" len="med"/>
+                      <a:tailEnd type="none" w="med" len="med"/>
+                    </a:lnR>
+                    <a:lnT w="6350" cap="flat" cmpd="sng" algn="ctr">
+                      <a:solidFill>
+                        <a:srgbClr val="D8DFE9"/>
+                      </a:solidFill>
+                      <a:prstDash val="solid"/>
+                      <a:round/>
+                      <a:headEnd type="none" w="med" len="med"/>
+                      <a:tailEnd type="none" w="med" len="med"/>
+                    </a:lnT>
+                    <a:lnB w="6350" cap="flat" cmpd="sng" algn="ctr">
+                      <a:solidFill>
+                        <a:srgbClr val="D8DFE9"/>
+                      </a:solidFill>
+                      <a:prstDash val="solid"/>
+                      <a:round/>
+                      <a:headEnd type="none" w="med" len="med"/>
+                      <a:tailEnd type="none" w="med" len="med"/>
+                    </a:lnB>
+                    <a:solidFill>
+                      <a:srgbClr val="FDF6F6"/>
+                    </a:solidFill>
+                  </a:tcPr>
+                </a:tc>
+                <a:tc>
+                  <a:txBody>
+                    <a:bodyPr/>
+                    <a:lstStyle/>
+                    <a:p>
+                      <a:pPr algn="ctr" indent="0" marL="0">
+                        <a:buNone/>
+                      </a:pPr>
+                      <a:r>
+                        <a:rPr lang="en-US" sz="900" dirty="0">
+                          <a:solidFill>
+                            <a:srgbClr val="6B7A90"/>
+                          </a:solidFill>
+                          <a:latin typeface="Graphik TH" pitchFamily="34" charset="0"/>
+                          <a:ea typeface="Graphik TH" pitchFamily="34" charset="-122"/>
+                          <a:cs typeface="Graphik TH" pitchFamily="34" charset="-120"/>
+                        </a:rPr>
+                        <a:t>—</a:t>
+                      </a:r>
+                      <a:endParaRPr lang="en-US" sz="900" dirty="0">
+                        <a:latin typeface="Graphik TH" charset="0"/>
+                        <a:ea typeface="Graphik TH" charset="0"/>
+                        <a:cs typeface="Graphik TH" charset="0"/>
+                      </a:endParaRPr>
+                    </a:p>
+                  </a:txBody>
+                  <a:tcPr marL="36576" marR="36576" marT="9144" marB="9144" anchor="ctr">
+                    <a:lnL w="6350" cap="flat" cmpd="sng" algn="ctr">
+                      <a:solidFill>
+                        <a:srgbClr val="D8DFE9"/>
+                      </a:solidFill>
+                      <a:prstDash val="solid"/>
+                      <a:round/>
+                      <a:headEnd type="none" w="med" len="med"/>
+                      <a:tailEnd type="none" w="med" len="med"/>
+                    </a:lnL>
+                    <a:lnR w="6350" cap="flat" cmpd="sng" algn="ctr">
+                      <a:solidFill>
+                        <a:srgbClr val="D8DFE9"/>
+                      </a:solidFill>
+                      <a:prstDash val="solid"/>
+                      <a:round/>
+                      <a:headEnd type="none" w="med" len="med"/>
+                      <a:tailEnd type="none" w="med" len="med"/>
+                    </a:lnR>
+                    <a:lnT w="6350" cap="flat" cmpd="sng" algn="ctr">
+                      <a:solidFill>
+                        <a:srgbClr val="D8DFE9"/>
+                      </a:solidFill>
+                      <a:prstDash val="solid"/>
+                      <a:round/>
+                      <a:headEnd type="none" w="med" len="med"/>
+                      <a:tailEnd type="none" w="med" len="med"/>
+                    </a:lnT>
+                    <a:lnB w="6350" cap="flat" cmpd="sng" algn="ctr">
+                      <a:solidFill>
+                        <a:srgbClr val="D8DFE9"/>
+                      </a:solidFill>
+                      <a:prstDash val="solid"/>
+                      <a:round/>
+                      <a:headEnd type="none" w="med" len="med"/>
+                      <a:tailEnd type="none" w="med" len="med"/>
+                    </a:lnB>
+                    <a:solidFill>
+                      <a:srgbClr val="FFFFFF"/>
+                    </a:solidFill>
+                  </a:tcPr>
+                </a:tc>
+                <a:tc>
+                  <a:txBody>
+                    <a:bodyPr/>
+                    <a:lstStyle/>
+                    <a:p>
+                      <a:pPr algn="ctr" indent="0" marL="0">
+                        <a:buNone/>
+                      </a:pPr>
+                      <a:r>
+                        <a:rPr lang="en-US" sz="900" dirty="0">
+                          <a:solidFill>
+                            <a:srgbClr val="6B7A90"/>
+                          </a:solidFill>
+                          <a:latin typeface="Graphik TH" pitchFamily="34" charset="0"/>
+                          <a:ea typeface="Graphik TH" pitchFamily="34" charset="-122"/>
+                          <a:cs typeface="Graphik TH" pitchFamily="34" charset="-120"/>
+                        </a:rPr>
+                        <a:t>—</a:t>
+                      </a:r>
+                      <a:endParaRPr lang="en-US" sz="900" dirty="0">
+                        <a:latin typeface="Graphik TH" charset="0"/>
+                        <a:ea typeface="Graphik TH" charset="0"/>
+                        <a:cs typeface="Graphik TH" charset="0"/>
+                      </a:endParaRPr>
+                    </a:p>
+                  </a:txBody>
+                  <a:tcPr marL="36576" marR="36576" marT="9144" marB="9144" anchor="ctr">
+                    <a:lnL w="6350" cap="flat" cmpd="sng" algn="ctr">
+                      <a:solidFill>
+                        <a:srgbClr val="D8DFE9"/>
+                      </a:solidFill>
+                      <a:prstDash val="solid"/>
+                      <a:round/>
+                      <a:headEnd type="none" w="med" len="med"/>
+                      <a:tailEnd type="none" w="med" len="med"/>
+                    </a:lnL>
+                    <a:lnR w="6350" cap="flat" cmpd="sng" algn="ctr">
+                      <a:solidFill>
+                        <a:srgbClr val="D8DFE9"/>
+                      </a:solidFill>
+                      <a:prstDash val="solid"/>
+                      <a:round/>
+                      <a:headEnd type="none" w="med" len="med"/>
+                      <a:tailEnd type="none" w="med" len="med"/>
+                    </a:lnR>
+                    <a:lnT w="6350" cap="flat" cmpd="sng" algn="ctr">
+                      <a:solidFill>
+                        <a:srgbClr val="D8DFE9"/>
+                      </a:solidFill>
+                      <a:prstDash val="solid"/>
+                      <a:round/>
+                      <a:headEnd type="none" w="med" len="med"/>
+                      <a:tailEnd type="none" w="med" len="med"/>
+                    </a:lnT>
+                    <a:lnB w="6350" cap="flat" cmpd="sng" algn="ctr">
+                      <a:solidFill>
+                        <a:srgbClr val="D8DFE9"/>
+                      </a:solidFill>
+                      <a:prstDash val="solid"/>
+                      <a:round/>
+                      <a:headEnd type="none" w="med" len="med"/>
+                      <a:tailEnd type="none" w="med" len="med"/>
+                    </a:lnB>
+                    <a:solidFill>
+                      <a:srgbClr val="FFFFFF"/>
+                    </a:solidFill>
+                  </a:tcPr>
+                </a:tc>
+                <a:tc>
+                  <a:txBody>
+                    <a:bodyPr/>
+                    <a:lstStyle/>
+                    <a:p>
+                      <a:pPr algn="ctr" indent="0" marL="0">
+                        <a:buNone/>
+                      </a:pPr>
+                      <a:r>
+                        <a:rPr lang="en-US" sz="900" dirty="0">
+                          <a:solidFill>
+                            <a:srgbClr val="6B7A90"/>
+                          </a:solidFill>
+                          <a:latin typeface="Graphik TH" pitchFamily="34" charset="0"/>
+                          <a:ea typeface="Graphik TH" pitchFamily="34" charset="-122"/>
+                          <a:cs typeface="Graphik TH" pitchFamily="34" charset="-120"/>
+                        </a:rPr>
+                        <a:t>—</a:t>
+                      </a:r>
+                      <a:endParaRPr lang="en-US" sz="900" dirty="0">
+                        <a:latin typeface="Graphik TH" charset="0"/>
+                        <a:ea typeface="Graphik TH" charset="0"/>
+                        <a:cs typeface="Graphik TH" charset="0"/>
+                      </a:endParaRPr>
+                    </a:p>
+                  </a:txBody>
+                  <a:tcPr marL="36576" marR="36576" marT="9144" marB="9144" anchor="ctr">
+                    <a:lnL w="6350" cap="flat" cmpd="sng" algn="ctr">
+                      <a:solidFill>
+                        <a:srgbClr val="D8DFE9"/>
+                      </a:solidFill>
+                      <a:prstDash val="solid"/>
+                      <a:round/>
+                      <a:headEnd type="none" w="med" len="med"/>
+                      <a:tailEnd type="none" w="med" len="med"/>
+                    </a:lnL>
+                    <a:lnR w="6350" cap="flat" cmpd="sng" algn="ctr">
+                      <a:solidFill>
+                        <a:srgbClr val="D8DFE9"/>
+                      </a:solidFill>
+                      <a:prstDash val="solid"/>
+                      <a:round/>
+                      <a:headEnd type="none" w="med" len="med"/>
+                      <a:tailEnd type="none" w="med" len="med"/>
+                    </a:lnR>
+                    <a:lnT w="6350" cap="flat" cmpd="sng" algn="ctr">
+                      <a:solidFill>
+                        <a:srgbClr val="D8DFE9"/>
+                      </a:solidFill>
+                      <a:prstDash val="solid"/>
+                      <a:round/>
+                      <a:headEnd type="none" w="med" len="med"/>
+                      <a:tailEnd type="none" w="med" len="med"/>
+                    </a:lnT>
+                    <a:lnB w="6350" cap="flat" cmpd="sng" algn="ctr">
+                      <a:solidFill>
+                        <a:srgbClr val="D8DFE9"/>
+                      </a:solidFill>
+                      <a:prstDash val="solid"/>
+                      <a:round/>
+                      <a:headEnd type="none" w="med" len="med"/>
+                      <a:tailEnd type="none" w="med" len="med"/>
+                    </a:lnB>
+                    <a:solidFill>
+                      <a:srgbClr val="FFFFFF"/>
+                    </a:solidFill>
+                  </a:tcPr>
+                </a:tc>
+              </a:tr>
+            </a:tbl>
+          </a:graphicData>
+        </a:graphic>
+      </p:graphicFrame>
+      <p:sp>
+        <p:nvSpPr>
+          <p:cNvPr id="26" name="Shape 23"/>
+          <p:cNvSpPr/>
+          <p:nvPr/>
+        </p:nvSpPr>
+        <p:spPr>
+          <a:xfrm>
+            <a:off x="7479792" y="2798064"/>
+            <a:ext cx="4325112" cy="2322576"/>
+          </a:xfrm>
+          <a:prstGeom prst="roundRect">
+            <a:avLst>
+              <a:gd name="adj" fmla="val 3543"/>
+            </a:avLst>
+          </a:prstGeom>
+          <a:solidFill>
+            <a:srgbClr val="F1F4F9"/>
+          </a:solidFill>
+          <a:ln/>
+        </p:spPr>
+      </p:sp>
+      <p:sp>
+        <p:nvSpPr>
+          <p:cNvPr id="27" name="Text 24"/>
+          <p:cNvSpPr/>
+          <p:nvPr/>
+        </p:nvSpPr>
+        <p:spPr>
+          <a:xfrm>
+            <a:off x="7735824" y="2944368"/>
+            <a:ext cx="3813048" cy="274320"/>
+          </a:xfrm>
+          <a:prstGeom prst="rect">
+            <a:avLst/>
+          </a:prstGeom>
+          <a:noFill/>
+          <a:ln/>
+        </p:spPr>
+        <p:txBody>
+          <a:bodyPr wrap="square" lIns="0" tIns="0" rIns="0" bIns="0" rtlCol="0" anchor="ctr"/>
+          <a:lstStyle/>
+          <a:p>
+            <a:pPr indent="0" marL="0">
+              <a:buNone/>
+            </a:pPr>
+            <a:r>
+              <a:rPr lang="en-US" sz="1400" b="1" dirty="0">
+                <a:solidFill>
+                  <a:srgbClr val="16233D"/>
+                </a:solidFill>
+                <a:latin typeface="Cambria" pitchFamily="34" charset="0"/>
+                <a:ea typeface="Cambria" pitchFamily="34" charset="-122"/>
+                <a:cs typeface="Cambria" pitchFamily="34" charset="-120"/>
+              </a:rPr>
+              <a:t>Move rate by stickiness</a:t>
+            </a:r>
+            <a:endParaRPr lang="en-US" sz="1400" dirty="0"/>
+          </a:p>
+        </p:txBody>
+      </p:sp>
+      <p:sp>
+        <p:nvSpPr>
+          <p:cNvPr id="28" name="Text 25"/>
+          <p:cNvSpPr/>
+          <p:nvPr/>
+        </p:nvSpPr>
+        <p:spPr>
+          <a:xfrm>
+            <a:off x="7735824" y="3218688"/>
+            <a:ext cx="3813048" cy="237744"/>
+          </a:xfrm>
+          <a:prstGeom prst="rect">
+            <a:avLst/>
+          </a:prstGeom>
+          <a:noFill/>
+          <a:ln/>
+        </p:spPr>
+        <p:txBody>
+          <a:bodyPr wrap="square" lIns="0" tIns="0" rIns="0" bIns="0" rtlCol="0" anchor="ctr"/>
+          <a:lstStyle/>
+          <a:p>
+            <a:pPr indent="0" marL="0">
+              <a:buNone/>
+            </a:pPr>
+            <a:r>
+              <a:rPr lang="en-US" sz="950" dirty="0">
+                <a:solidFill>
+                  <a:srgbClr val="6B7A90"/>
+                </a:solidFill>
+                <a:latin typeface="Graphik TH" pitchFamily="34" charset="0"/>
+                <a:ea typeface="Graphik TH" pitchFamily="34" charset="-122"/>
+                <a:cs typeface="Graphik TH" pitchFamily="34" charset="-120"/>
+              </a:rPr>
+              <a:t>The new dimension, on its own</a:t>
+            </a:r>
+            <a:endParaRPr lang="en-US" sz="950" dirty="0"/>
+          </a:p>
+        </p:txBody>
+      </p:sp>
+      <p:sp>
+        <p:nvSpPr>
+          <p:cNvPr id="29" name="Text 26"/>
+          <p:cNvSpPr/>
+          <p:nvPr/>
+        </p:nvSpPr>
+        <p:spPr>
+          <a:xfrm>
+            <a:off x="7735824" y="3438144"/>
+            <a:ext cx="1051560" cy="237744"/>
+          </a:xfrm>
+          <a:prstGeom prst="rect">
+            <a:avLst/>
+          </a:prstGeom>
+          <a:noFill/>
+          <a:ln/>
+        </p:spPr>
+        <p:txBody>
+          <a:bodyPr wrap="square" lIns="0" tIns="0" rIns="0" bIns="0" rtlCol="0" anchor="ctr"/>
+          <a:lstStyle/>
+          <a:p>
+            <a:pPr indent="0" marL="0">
+              <a:buNone/>
+            </a:pPr>
+            <a:r>
+              <a:rPr lang="en-US" sz="1000" b="1" dirty="0">
+                <a:solidFill>
+                  <a:srgbClr val="16233D"/>
+                </a:solidFill>
+                <a:latin typeface="Graphik TH" pitchFamily="34" charset="0"/>
+                <a:ea typeface="Graphik TH" pitchFamily="34" charset="-122"/>
+                <a:cs typeface="Graphik TH" pitchFamily="34" charset="-120"/>
+              </a:rPr>
+              <a:t>Very High</a:t>
+            </a:r>
+            <a:endParaRPr lang="en-US" sz="1000" dirty="0"/>
+          </a:p>
+        </p:txBody>
+      </p:sp>
+      <p:sp>
+        <p:nvSpPr>
+          <p:cNvPr id="30" name="Shape 27"/>
+          <p:cNvSpPr/>
+          <p:nvPr/>
+        </p:nvSpPr>
+        <p:spPr>
+          <a:xfrm>
+            <a:off x="8833104" y="3474720"/>
+            <a:ext cx="1417320" cy="164592"/>
+          </a:xfrm>
+          <a:prstGeom prst="roundRect">
+            <a:avLst>
+              <a:gd name="adj" fmla="val 16667"/>
+            </a:avLst>
+          </a:prstGeom>
+          <a:solidFill>
+            <a:srgbClr val="165A73"/>
+          </a:solidFill>
+          <a:ln/>
+        </p:spPr>
+      </p:sp>
+      <p:sp>
+        <p:nvSpPr>
+          <p:cNvPr id="31" name="Text 28"/>
+          <p:cNvSpPr/>
+          <p:nvPr/>
+        </p:nvSpPr>
+        <p:spPr>
+          <a:xfrm>
+            <a:off x="10296144" y="3438144"/>
+            <a:ext cx="658368" cy="237744"/>
+          </a:xfrm>
+          <a:prstGeom prst="rect">
+            <a:avLst/>
+          </a:prstGeom>
+          <a:noFill/>
+          <a:ln/>
+        </p:spPr>
+        <p:txBody>
+          <a:bodyPr wrap="square" lIns="0" tIns="0" rIns="0" bIns="0" rtlCol="0" anchor="ctr"/>
+          <a:lstStyle/>
+          <a:p>
+            <a:pPr algn="r" indent="0" marL="0">
+              <a:buNone/>
+            </a:pPr>
+            <a:r>
+              <a:rPr lang="en-US" sz="1000" b="1" dirty="0">
+                <a:solidFill>
+                  <a:srgbClr val="165A73"/>
+                </a:solidFill>
+                <a:latin typeface="Graphik TH" pitchFamily="34" charset="0"/>
+                <a:ea typeface="Graphik TH" pitchFamily="34" charset="-122"/>
+                <a:cs typeface="Graphik TH" pitchFamily="34" charset="-120"/>
+              </a:rPr>
+              <a:t>19.2%</a:t>
+            </a:r>
+            <a:endParaRPr lang="en-US" sz="1000" dirty="0"/>
+          </a:p>
+        </p:txBody>
+      </p:sp>
+      <p:sp>
+        <p:nvSpPr>
+          <p:cNvPr id="32" name="Text 29"/>
+          <p:cNvSpPr/>
+          <p:nvPr/>
+        </p:nvSpPr>
+        <p:spPr>
+          <a:xfrm>
+            <a:off x="10991088" y="3438144"/>
+            <a:ext cx="557784" cy="237744"/>
+          </a:xfrm>
+          <a:prstGeom prst="rect">
+            <a:avLst/>
+          </a:prstGeom>
+          <a:noFill/>
+          <a:ln/>
+        </p:spPr>
+        <p:txBody>
+          <a:bodyPr wrap="square" lIns="0" tIns="0" rIns="0" bIns="0" rtlCol="0" anchor="ctr"/>
+          <a:lstStyle/>
+          <a:p>
+            <a:pPr algn="r" indent="0" marL="0">
+              <a:buNone/>
+            </a:pPr>
+            <a:r>
+              <a:rPr lang="en-US" sz="850" dirty="0">
+                <a:solidFill>
+                  <a:srgbClr val="6B7A90"/>
+                </a:solidFill>
+                <a:latin typeface="Graphik TH" pitchFamily="34" charset="0"/>
+                <a:ea typeface="Graphik TH" pitchFamily="34" charset="-122"/>
+                <a:cs typeface="Graphik TH" pitchFamily="34" charset="-120"/>
+              </a:rPr>
+              <a:t>12,145</a:t>
+            </a:r>
+            <a:endParaRPr lang="en-US" sz="850" dirty="0"/>
+          </a:p>
+        </p:txBody>
+      </p:sp>
+      <p:sp>
+        <p:nvSpPr>
+          <p:cNvPr id="33" name="Text 30"/>
+          <p:cNvSpPr/>
+          <p:nvPr/>
+        </p:nvSpPr>
+        <p:spPr>
+          <a:xfrm>
+            <a:off x="7735824" y="3712464"/>
+            <a:ext cx="1051560" cy="237744"/>
+          </a:xfrm>
+          <a:prstGeom prst="rect">
+            <a:avLst/>
+          </a:prstGeom>
+          <a:noFill/>
+          <a:ln/>
+        </p:spPr>
+        <p:txBody>
+          <a:bodyPr wrap="square" lIns="0" tIns="0" rIns="0" bIns="0" rtlCol="0" anchor="ctr"/>
+          <a:lstStyle/>
+          <a:p>
+            <a:pPr indent="0" marL="0">
+              <a:buNone/>
+            </a:pPr>
+            <a:r>
+              <a:rPr lang="en-US" sz="1000" b="1" dirty="0">
+                <a:solidFill>
+                  <a:srgbClr val="16233D"/>
+                </a:solidFill>
+                <a:latin typeface="Graphik TH" pitchFamily="34" charset="0"/>
+                <a:ea typeface="Graphik TH" pitchFamily="34" charset="-122"/>
+                <a:cs typeface="Graphik TH" pitchFamily="34" charset="-120"/>
+              </a:rPr>
+              <a:t>High</a:t>
+            </a:r>
+            <a:endParaRPr lang="en-US" sz="1000" dirty="0"/>
+          </a:p>
+        </p:txBody>
+      </p:sp>
+      <p:sp>
+        <p:nvSpPr>
+          <p:cNvPr id="34" name="Shape 31"/>
+          <p:cNvSpPr/>
+          <p:nvPr/>
+        </p:nvSpPr>
+        <p:spPr>
+          <a:xfrm>
+            <a:off x="8833104" y="3749040"/>
+            <a:ext cx="1128412" cy="164592"/>
+          </a:xfrm>
+          <a:prstGeom prst="roundRect">
+            <a:avLst>
+              <a:gd name="adj" fmla="val 16667"/>
+            </a:avLst>
+          </a:prstGeom>
+          <a:solidFill>
+            <a:srgbClr val="1E8E86"/>
+          </a:solidFill>
+          <a:ln/>
+        </p:spPr>
+      </p:sp>
+      <p:sp>
+        <p:nvSpPr>
+          <p:cNvPr id="35" name="Text 32"/>
+          <p:cNvSpPr/>
+          <p:nvPr/>
+        </p:nvSpPr>
+        <p:spPr>
+          <a:xfrm>
+            <a:off x="10296144" y="3712464"/>
+            <a:ext cx="658368" cy="237744"/>
+          </a:xfrm>
+          <a:prstGeom prst="rect">
+            <a:avLst/>
+          </a:prstGeom>
+          <a:noFill/>
+          <a:ln/>
+        </p:spPr>
+        <p:txBody>
+          <a:bodyPr wrap="square" lIns="0" tIns="0" rIns="0" bIns="0" rtlCol="0" anchor="ctr"/>
+          <a:lstStyle/>
+          <a:p>
+            <a:pPr algn="r" indent="0" marL="0">
+              <a:buNone/>
+            </a:pPr>
+            <a:r>
+              <a:rPr lang="en-US" sz="1000" b="1" dirty="0">
+                <a:solidFill>
+                  <a:srgbClr val="1E8E86"/>
+                </a:solidFill>
+                <a:latin typeface="Graphik TH" pitchFamily="34" charset="0"/>
+                <a:ea typeface="Graphik TH" pitchFamily="34" charset="-122"/>
+                <a:cs typeface="Graphik TH" pitchFamily="34" charset="-120"/>
+              </a:rPr>
+              <a:t>15.3%</a:t>
+            </a:r>
+            <a:endParaRPr lang="en-US" sz="1000" dirty="0"/>
+          </a:p>
+        </p:txBody>
+      </p:sp>
+      <p:sp>
+        <p:nvSpPr>
+          <p:cNvPr id="36" name="Text 33"/>
+          <p:cNvSpPr/>
+          <p:nvPr/>
+        </p:nvSpPr>
+        <p:spPr>
+          <a:xfrm>
+            <a:off x="10991088" y="3712464"/>
+            <a:ext cx="557784" cy="237744"/>
+          </a:xfrm>
+          <a:prstGeom prst="rect">
+            <a:avLst/>
+          </a:prstGeom>
+          <a:noFill/>
+          <a:ln/>
+        </p:spPr>
+        <p:txBody>
+          <a:bodyPr wrap="square" lIns="0" tIns="0" rIns="0" bIns="0" rtlCol="0" anchor="ctr"/>
+          <a:lstStyle/>
+          <a:p>
+            <a:pPr algn="r" indent="0" marL="0">
+              <a:buNone/>
+            </a:pPr>
+            <a:r>
+              <a:rPr lang="en-US" sz="850" dirty="0">
+                <a:solidFill>
+                  <a:srgbClr val="6B7A90"/>
+                </a:solidFill>
+                <a:latin typeface="Graphik TH" pitchFamily="34" charset="0"/>
+                <a:ea typeface="Graphik TH" pitchFamily="34" charset="-122"/>
+                <a:cs typeface="Graphik TH" pitchFamily="34" charset="-120"/>
+              </a:rPr>
+              <a:t>26,435</a:t>
+            </a:r>
+            <a:endParaRPr lang="en-US" sz="850" dirty="0"/>
+          </a:p>
+        </p:txBody>
+      </p:sp>
+      <p:sp>
+        <p:nvSpPr>
+          <p:cNvPr id="37" name="Text 34"/>
+          <p:cNvSpPr/>
+          <p:nvPr/>
+        </p:nvSpPr>
+        <p:spPr>
+          <a:xfrm>
+            <a:off x="7735824" y="3986784"/>
+            <a:ext cx="1051560" cy="237744"/>
+          </a:xfrm>
+          <a:prstGeom prst="rect">
+            <a:avLst/>
+          </a:prstGeom>
+          <a:noFill/>
+          <a:ln/>
+        </p:spPr>
+        <p:txBody>
+          <a:bodyPr wrap="square" lIns="0" tIns="0" rIns="0" bIns="0" rtlCol="0" anchor="ctr"/>
+          <a:lstStyle/>
+          <a:p>
+            <a:pPr indent="0" marL="0">
+              <a:buNone/>
+            </a:pPr>
+            <a:r>
+              <a:rPr lang="en-US" sz="1000" b="1" dirty="0">
+                <a:solidFill>
+                  <a:srgbClr val="16233D"/>
+                </a:solidFill>
+                <a:latin typeface="Graphik TH" pitchFamily="34" charset="0"/>
+                <a:ea typeface="Graphik TH" pitchFamily="34" charset="-122"/>
+                <a:cs typeface="Graphik TH" pitchFamily="34" charset="-120"/>
+              </a:rPr>
+              <a:t>Medium</a:t>
+            </a:r>
+            <a:endParaRPr lang="en-US" sz="1000" dirty="0"/>
+          </a:p>
+        </p:txBody>
+      </p:sp>
+      <p:sp>
+        <p:nvSpPr>
+          <p:cNvPr id="38" name="Shape 35"/>
+          <p:cNvSpPr/>
+          <p:nvPr/>
+        </p:nvSpPr>
+        <p:spPr>
+          <a:xfrm>
+            <a:off x="8833104" y="4023360"/>
+            <a:ext cx="322727" cy="164592"/>
+          </a:xfrm>
+          <a:prstGeom prst="roundRect">
+            <a:avLst>
+              <a:gd name="adj" fmla="val 16667"/>
+            </a:avLst>
+          </a:prstGeom>
+          <a:solidFill>
+            <a:srgbClr val="3FB89F"/>
+          </a:solidFill>
+          <a:ln/>
+        </p:spPr>
+      </p:sp>
+      <p:sp>
+        <p:nvSpPr>
+          <p:cNvPr id="39" name="Text 36"/>
+          <p:cNvSpPr/>
+          <p:nvPr/>
+        </p:nvSpPr>
+        <p:spPr>
+          <a:xfrm>
+            <a:off x="10296144" y="3986784"/>
+            <a:ext cx="658368" cy="237744"/>
+          </a:xfrm>
+          <a:prstGeom prst="rect">
+            <a:avLst/>
+          </a:prstGeom>
+          <a:noFill/>
+          <a:ln/>
+        </p:spPr>
+        <p:txBody>
+          <a:bodyPr wrap="square" lIns="0" tIns="0" rIns="0" bIns="0" rtlCol="0" anchor="ctr"/>
+          <a:lstStyle/>
+          <a:p>
+            <a:pPr algn="r" indent="0" marL="0">
+              <a:buNone/>
+            </a:pPr>
+            <a:r>
+              <a:rPr lang="en-US" sz="1000" b="1" dirty="0">
+                <a:solidFill>
+                  <a:srgbClr val="3FB89F"/>
+                </a:solidFill>
+                <a:latin typeface="Graphik TH" pitchFamily="34" charset="0"/>
+                <a:ea typeface="Graphik TH" pitchFamily="34" charset="-122"/>
+                <a:cs typeface="Graphik TH" pitchFamily="34" charset="-120"/>
+              </a:rPr>
+              <a:t>4.4%</a:t>
+            </a:r>
+            <a:endParaRPr lang="en-US" sz="1000" dirty="0"/>
+          </a:p>
+        </p:txBody>
+      </p:sp>
+      <p:sp>
+        <p:nvSpPr>
+          <p:cNvPr id="40" name="Text 37"/>
+          <p:cNvSpPr/>
+          <p:nvPr/>
+        </p:nvSpPr>
+        <p:spPr>
+          <a:xfrm>
+            <a:off x="10991088" y="3986784"/>
+            <a:ext cx="557784" cy="237744"/>
+          </a:xfrm>
+          <a:prstGeom prst="rect">
+            <a:avLst/>
+          </a:prstGeom>
+          <a:noFill/>
+          <a:ln/>
+        </p:spPr>
+        <p:txBody>
+          <a:bodyPr wrap="square" lIns="0" tIns="0" rIns="0" bIns="0" rtlCol="0" anchor="ctr"/>
+          <a:lstStyle/>
+          <a:p>
+            <a:pPr algn="r" indent="0" marL="0">
+              <a:buNone/>
+            </a:pPr>
+            <a:r>
+              <a:rPr lang="en-US" sz="850" dirty="0">
+                <a:solidFill>
+                  <a:srgbClr val="6B7A90"/>
+                </a:solidFill>
+                <a:latin typeface="Graphik TH" pitchFamily="34" charset="0"/>
+                <a:ea typeface="Graphik TH" pitchFamily="34" charset="-122"/>
+                <a:cs typeface="Graphik TH" pitchFamily="34" charset="-120"/>
+              </a:rPr>
+              <a:t>5,107</a:t>
+            </a:r>
+            <a:endParaRPr lang="en-US" sz="850" dirty="0"/>
+          </a:p>
+        </p:txBody>
+      </p:sp>
+      <p:sp>
+        <p:nvSpPr>
+          <p:cNvPr id="41" name="Text 38"/>
+          <p:cNvSpPr/>
+          <p:nvPr/>
+        </p:nvSpPr>
+        <p:spPr>
+          <a:xfrm>
+            <a:off x="7735824" y="4261104"/>
+            <a:ext cx="1051560" cy="237744"/>
+          </a:xfrm>
+          <a:prstGeom prst="rect">
+            <a:avLst/>
+          </a:prstGeom>
+          <a:noFill/>
+          <a:ln/>
+        </p:spPr>
+        <p:txBody>
+          <a:bodyPr wrap="square" lIns="0" tIns="0" rIns="0" bIns="0" rtlCol="0" anchor="ctr"/>
+          <a:lstStyle/>
+          <a:p>
+            <a:pPr indent="0" marL="0">
+              <a:buNone/>
+            </a:pPr>
+            <a:r>
+              <a:rPr lang="en-US" sz="1000" b="1" dirty="0">
+                <a:solidFill>
+                  <a:srgbClr val="16233D"/>
+                </a:solidFill>
+                <a:latin typeface="Graphik TH" pitchFamily="34" charset="0"/>
+                <a:ea typeface="Graphik TH" pitchFamily="34" charset="-122"/>
+                <a:cs typeface="Graphik TH" pitchFamily="34" charset="-120"/>
+              </a:rPr>
+              <a:t>Low</a:t>
+            </a:r>
+            <a:endParaRPr lang="en-US" sz="1000" dirty="0"/>
+          </a:p>
+        </p:txBody>
+      </p:sp>
+      <p:sp>
+        <p:nvSpPr>
+          <p:cNvPr id="42" name="Shape 39"/>
+          <p:cNvSpPr/>
+          <p:nvPr/>
+        </p:nvSpPr>
+        <p:spPr>
+          <a:xfrm>
+            <a:off x="8833104" y="4297680"/>
+            <a:ext cx="198128" cy="164592"/>
+          </a:xfrm>
+          <a:prstGeom prst="roundRect">
+            <a:avLst>
+              <a:gd name="adj" fmla="val 16667"/>
+            </a:avLst>
+          </a:prstGeom>
+          <a:solidFill>
+            <a:srgbClr val="E9A03B"/>
+          </a:solidFill>
+          <a:ln/>
+        </p:spPr>
+      </p:sp>
+      <p:sp>
+        <p:nvSpPr>
+          <p:cNvPr id="43" name="Text 40"/>
+          <p:cNvSpPr/>
+          <p:nvPr/>
+        </p:nvSpPr>
+        <p:spPr>
+          <a:xfrm>
+            <a:off x="10296144" y="4261104"/>
+            <a:ext cx="658368" cy="237744"/>
+          </a:xfrm>
+          <a:prstGeom prst="rect">
+            <a:avLst/>
+          </a:prstGeom>
+          <a:noFill/>
+          <a:ln/>
+        </p:spPr>
+        <p:txBody>
+          <a:bodyPr wrap="square" lIns="0" tIns="0" rIns="0" bIns="0" rtlCol="0" anchor="ctr"/>
+          <a:lstStyle/>
+          <a:p>
+            <a:pPr algn="r" indent="0" marL="0">
+              <a:buNone/>
+            </a:pPr>
+            <a:r>
+              <a:rPr lang="en-US" sz="1000" b="1" dirty="0">
+                <a:solidFill>
+                  <a:srgbClr val="E9A03B"/>
+                </a:solidFill>
+                <a:latin typeface="Graphik TH" pitchFamily="34" charset="0"/>
+                <a:ea typeface="Graphik TH" pitchFamily="34" charset="-122"/>
+                <a:cs typeface="Graphik TH" pitchFamily="34" charset="-120"/>
+              </a:rPr>
+              <a:t>2.7%</a:t>
+            </a:r>
+            <a:endParaRPr lang="en-US" sz="1000" dirty="0"/>
+          </a:p>
+        </p:txBody>
+      </p:sp>
+      <p:sp>
+        <p:nvSpPr>
+          <p:cNvPr id="44" name="Text 41"/>
+          <p:cNvSpPr/>
+          <p:nvPr/>
+        </p:nvSpPr>
+        <p:spPr>
+          <a:xfrm>
+            <a:off x="10991088" y="4261104"/>
+            <a:ext cx="557784" cy="237744"/>
+          </a:xfrm>
+          <a:prstGeom prst="rect">
+            <a:avLst/>
+          </a:prstGeom>
+          <a:noFill/>
+          <a:ln/>
+        </p:spPr>
+        <p:txBody>
+          <a:bodyPr wrap="square" lIns="0" tIns="0" rIns="0" bIns="0" rtlCol="0" anchor="ctr"/>
+          <a:lstStyle/>
+          <a:p>
+            <a:pPr algn="r" indent="0" marL="0">
+              <a:buNone/>
+            </a:pPr>
+            <a:r>
+              <a:rPr lang="en-US" sz="850" dirty="0">
+                <a:solidFill>
+                  <a:srgbClr val="6B7A90"/>
+                </a:solidFill>
+                <a:latin typeface="Graphik TH" pitchFamily="34" charset="0"/>
+                <a:ea typeface="Graphik TH" pitchFamily="34" charset="-122"/>
+                <a:cs typeface="Graphik TH" pitchFamily="34" charset="-120"/>
+              </a:rPr>
+              <a:t>2,089</a:t>
+            </a:r>
+            <a:endParaRPr lang="en-US" sz="850" dirty="0"/>
+          </a:p>
+        </p:txBody>
+      </p:sp>
+      <p:sp>
+        <p:nvSpPr>
+          <p:cNvPr id="45" name="Text 42"/>
+          <p:cNvSpPr/>
+          <p:nvPr/>
+        </p:nvSpPr>
+        <p:spPr>
+          <a:xfrm>
+            <a:off x="7735824" y="4535424"/>
+            <a:ext cx="1051560" cy="237744"/>
+          </a:xfrm>
+          <a:prstGeom prst="rect">
+            <a:avLst/>
+          </a:prstGeom>
+          <a:noFill/>
+          <a:ln/>
+        </p:spPr>
+        <p:txBody>
+          <a:bodyPr wrap="square" lIns="0" tIns="0" rIns="0" bIns="0" rtlCol="0" anchor="ctr"/>
+          <a:lstStyle/>
+          <a:p>
+            <a:pPr indent="0" marL="0">
+              <a:buNone/>
+            </a:pPr>
+            <a:r>
+              <a:rPr lang="en-US" sz="1000" b="1" dirty="0">
+                <a:solidFill>
+                  <a:srgbClr val="16233D"/>
+                </a:solidFill>
+                <a:latin typeface="Graphik TH" pitchFamily="34" charset="0"/>
+                <a:ea typeface="Graphik TH" pitchFamily="34" charset="-122"/>
+                <a:cs typeface="Graphik TH" pitchFamily="34" charset="-120"/>
+              </a:rPr>
+              <a:t>Very Low</a:t>
+            </a:r>
+            <a:endParaRPr lang="en-US" sz="1000" dirty="0"/>
+          </a:p>
+        </p:txBody>
+      </p:sp>
+      <p:sp>
+        <p:nvSpPr>
+          <p:cNvPr id="46" name="Shape 43"/>
+          <p:cNvSpPr/>
+          <p:nvPr/>
+        </p:nvSpPr>
+        <p:spPr>
+          <a:xfrm>
+            <a:off x="8833104" y="4572000"/>
+            <a:ext cx="141728" cy="164592"/>
+          </a:xfrm>
+          <a:prstGeom prst="roundRect">
+            <a:avLst>
+              <a:gd name="adj" fmla="val 19355"/>
+            </a:avLst>
+          </a:prstGeom>
+          <a:solidFill>
+            <a:srgbClr val="8DA0B8"/>
+          </a:solidFill>
+          <a:ln/>
+        </p:spPr>
+      </p:sp>
+      <p:sp>
+        <p:nvSpPr>
+          <p:cNvPr id="47" name="Text 44"/>
+          <p:cNvSpPr/>
+          <p:nvPr/>
+        </p:nvSpPr>
+        <p:spPr>
+          <a:xfrm>
+            <a:off x="10296144" y="4535424"/>
+            <a:ext cx="658368" cy="237744"/>
+          </a:xfrm>
+          <a:prstGeom prst="rect">
+            <a:avLst/>
+          </a:prstGeom>
+          <a:noFill/>
+          <a:ln/>
+        </p:spPr>
+        <p:txBody>
+          <a:bodyPr wrap="square" lIns="0" tIns="0" rIns="0" bIns="0" rtlCol="0" anchor="ctr"/>
+          <a:lstStyle/>
+          <a:p>
+            <a:pPr algn="r" indent="0" marL="0">
+              <a:buNone/>
+            </a:pPr>
+            <a:r>
+              <a:rPr lang="en-US" sz="1000" b="1" dirty="0">
+                <a:solidFill>
+                  <a:srgbClr val="8DA0B8"/>
+                </a:solidFill>
+                <a:latin typeface="Graphik TH" pitchFamily="34" charset="0"/>
+                <a:ea typeface="Graphik TH" pitchFamily="34" charset="-122"/>
+                <a:cs typeface="Graphik TH" pitchFamily="34" charset="-120"/>
+              </a:rPr>
+              <a:t>1.9%</a:t>
+            </a:r>
+            <a:endParaRPr lang="en-US" sz="1000" dirty="0"/>
+          </a:p>
+        </p:txBody>
+      </p:sp>
+      <p:sp>
+        <p:nvSpPr>
+          <p:cNvPr id="48" name="Text 45"/>
+          <p:cNvSpPr/>
+          <p:nvPr/>
+        </p:nvSpPr>
+        <p:spPr>
+          <a:xfrm>
+            <a:off x="10991088" y="4535424"/>
+            <a:ext cx="557784" cy="237744"/>
+          </a:xfrm>
+          <a:prstGeom prst="rect">
+            <a:avLst/>
+          </a:prstGeom>
+          <a:noFill/>
+          <a:ln/>
+        </p:spPr>
+        <p:txBody>
+          <a:bodyPr wrap="square" lIns="0" tIns="0" rIns="0" bIns="0" rtlCol="0" anchor="ctr"/>
+          <a:lstStyle/>
+          <a:p>
+            <a:pPr algn="r" indent="0" marL="0">
+              <a:buNone/>
+            </a:pPr>
+            <a:r>
+              <a:rPr lang="en-US" sz="850" dirty="0">
+                <a:solidFill>
+                  <a:srgbClr val="6B7A90"/>
+                </a:solidFill>
+                <a:latin typeface="Graphik TH" pitchFamily="34" charset="0"/>
+                <a:ea typeface="Graphik TH" pitchFamily="34" charset="-122"/>
+                <a:cs typeface="Graphik TH" pitchFamily="34" charset="-120"/>
+              </a:rPr>
+              <a:t>1,408</a:t>
+            </a:r>
+            <a:endParaRPr lang="en-US" sz="850" dirty="0"/>
+          </a:p>
+        </p:txBody>
+      </p:sp>
+      <p:sp>
+        <p:nvSpPr>
+          <p:cNvPr id="49" name="Shape 46"/>
+          <p:cNvSpPr/>
+          <p:nvPr/>
+        </p:nvSpPr>
+        <p:spPr>
+          <a:xfrm>
+            <a:off x="7735824" y="4809744"/>
+            <a:ext cx="3813048" cy="274320"/>
+          </a:xfrm>
+          <a:prstGeom prst="roundRect">
+            <a:avLst>
+              <a:gd name="adj" fmla="val 30000"/>
+            </a:avLst>
+          </a:prstGeom>
+          <a:solidFill>
+            <a:srgbClr val="FBF0E6"/>
+          </a:solidFill>
+          <a:ln/>
+        </p:spPr>
+      </p:sp>
+      <p:sp>
+        <p:nvSpPr>
+          <p:cNvPr id="50" name="Text 47"/>
+          <p:cNvSpPr/>
+          <p:nvPr/>
+        </p:nvSpPr>
+        <p:spPr>
+          <a:xfrm>
+            <a:off x="7882128" y="4809744"/>
+            <a:ext cx="3520440" cy="274320"/>
+          </a:xfrm>
+          <a:prstGeom prst="rect">
+            <a:avLst/>
+          </a:prstGeom>
+          <a:noFill/>
+          <a:ln/>
+        </p:spPr>
+        <p:txBody>
+          <a:bodyPr wrap="square" lIns="0" tIns="0" rIns="0" bIns="0" rtlCol="0" anchor="ctr"/>
+          <a:lstStyle/>
+          <a:p>
+            <a:pPr indent="0" marL="0">
+              <a:buNone/>
+            </a:pPr>
+            <a:r>
+              <a:rPr lang="en-US" sz="950" dirty="0">
+                <a:solidFill>
+                  <a:srgbClr val="16233D"/>
+                </a:solidFill>
+                <a:latin typeface="Graphik TH" pitchFamily="34" charset="0"/>
+                <a:ea typeface="Graphik TH" pitchFamily="34" charset="-122"/>
+                <a:cs typeface="Graphik TH" pitchFamily="34" charset="-120"/>
+              </a:rPr>
+              <a:t>Stickiness &lt; 60: 18.2% of customers, 1.6% of pocket.</a:t>
+            </a:r>
+            <a:endParaRPr lang="en-US" sz="950" dirty="0"/>
+          </a:p>
+        </p:txBody>
+      </p:sp>
+      <p:sp>
+        <p:nvSpPr>
+          <p:cNvPr id="51" name="Shape 48"/>
+          <p:cNvSpPr/>
+          <p:nvPr/>
+        </p:nvSpPr>
+        <p:spPr>
+          <a:xfrm>
+            <a:off x="530352" y="5285232"/>
+            <a:ext cx="11274552" cy="786384"/>
+          </a:xfrm>
+          <a:prstGeom prst="roundRect">
+            <a:avLst>
+              <a:gd name="adj" fmla="val 10465"/>
+            </a:avLst>
+          </a:prstGeom>
+          <a:solidFill>
+            <a:srgbClr val="FBF0E6"/>
+          </a:solidFill>
+          <a:ln/>
+        </p:spPr>
+      </p:sp>
+      <p:sp>
+        <p:nvSpPr>
+          <p:cNvPr id="52" name="Text 49"/>
+          <p:cNvSpPr/>
+          <p:nvPr/>
+        </p:nvSpPr>
+        <p:spPr>
+          <a:xfrm>
+            <a:off x="804672" y="5285232"/>
+            <a:ext cx="10725912" cy="786384"/>
+          </a:xfrm>
+          <a:prstGeom prst="rect">
+            <a:avLst/>
+          </a:prstGeom>
+          <a:noFill/>
+          <a:ln/>
+        </p:spPr>
+        <p:txBody>
+          <a:bodyPr wrap="square" lIns="0" tIns="0" rIns="0" bIns="0" rtlCol="0" anchor="ctr"/>
+          <a:lstStyle/>
+          <a:p>
+            <a:pPr indent="0" marL="0">
+              <a:buNone/>
+            </a:pPr>
+            <a:r>
+              <a:rPr lang="en-US" sz="1100" b="1" dirty="0">
+                <a:solidFill>
+                  <a:srgbClr val="C00000"/>
+                </a:solidFill>
+                <a:latin typeface="Graphik TH" pitchFamily="34" charset="0"/>
+                <a:ea typeface="Graphik TH" pitchFamily="34" charset="-122"/>
+                <a:cs typeface="Graphik TH" pitchFamily="34" charset="-120"/>
+              </a:rPr>
+              <a:t>98.7% of the Save Max balance that walked came from customers scoring stickiness ≥ 60</a:t>
+            </a:r>
+            <a:pPr indent="0" marL="0">
+              <a:buNone/>
+            </a:pPr>
+            <a:r>
+              <a:rPr lang="en-US" sz="1100" dirty="0">
+                <a:solidFill>
+                  <a:srgbClr val="16233D"/>
+                </a:solidFill>
+                <a:latin typeface="Graphik TH" pitchFamily="34" charset="0"/>
+                <a:ea typeface="Graphik TH" pitchFamily="34" charset="-122"/>
+                <a:cs typeface="Graphik TH" pitchFamily="34" charset="-120"/>
+              </a:rPr>
+              <a:t>  —  the low-stickiness corner the decision view flags as fragile holds 297 customers and THB 5.9m. Low stickiness here means dormant, not disloyal.</a:t>
+            </a:r>
+            <a:endParaRPr lang="en-US" sz="1100" dirty="0"/>
+          </a:p>
+        </p:txBody>
+      </p:sp>
+    </p:spTree>
+  </p:cSld>
+  <p:clrMapOvr>
+    <a:masterClrMapping/>
+  </p:clrMapOvr>
+</p:sld>
+</file>
+
 <file path=ppt/slides/slide2.xml><?xml version="1.0" encoding="utf-8"?>
 <p:sld xmlns:a="http://schemas.openxmlformats.org/drawingml/2006/main" xmlns:r="http://schemas.openxmlformats.org/officeDocument/2006/relationships" xmlns:p="http://schemas.openxmlformats.org/presentationml/2006/main">
   <p:cSld name="Slide 2">

</xml_diff>

<commit_message>
Add balance-change matrix across the same two dimensions
Slide 13 repeats the stickiness x rate-sensitivity grid with the measure
changed from move rate to change in total deposit balance, shaded
diverging - teal for gained, red for lost.

The result inverts the previous slide. High rate sensitivity moved most
and gained THB 144.7m (+12.4%); Very High moved least and lost THB 36.0m
(-2.5%). Emptying the promotional pocket is a reallocation, and the
balance actually leaving sits with the segments the score calls least
rate-sensitive.

Percentages are suppressed where the prior balance is under THB 5m,
since the low-stickiness rows hold near-zero balances and produce
ratios such as +1549% that carry no meaning; those cells show headcount
instead. Cells under 50 customers stay unshaded as on slide 12.

Co-Authored-By: Claude Opus 5 <noreply@anthropic.com>
Claude-Session: https://claude.ai/code/session_01VKpfo226Go9vQJYa4eoC1d
</commit_message>
<xml_diff>
--- a/Deposit_Stickiness_Framework.pptx
+++ b/Deposit_Stickiness_Framework.pptx
@@ -17,9 +17,10 @@
     <p:sldId id="265" r:id="rId11"/>
     <p:sldId id="266" r:id="rId12"/>
     <p:sldId id="267" r:id="rId13"/>
+    <p:sldId id="268" r:id="rId14"/>
   </p:sldIdLst>
   <p:notesMasterIdLst>
-    <p:notesMasterId r:id="rId14"/>
+    <p:notesMasterId r:id="rId15"/>
   </p:notesMasterIdLst>
   <p:sldSz cx="12192000" cy="6858000"/>
   <p:notesSz cx="6858000" cy="12192000"/>
@@ -801,6 +802,94 @@
             <a:fld id="{F7021451-1387-4CA6-816F-3879F97B5CBC}" type="slidenum">
               <a:rPr lang="en-US"/>
               <a:t>12</a:t>
+            </a:fld>
+            <a:endParaRPr lang="en-US"/>
+          </a:p>
+        </p:txBody>
+      </p:sp>
+    </p:spTree>
+    <p:extLst>
+      <p:ext uri="{BB962C8B-B14F-4D97-AF65-F5344CB8AC3E}">
+        <p14:creationId xmlns:p14="http://schemas.microsoft.com/office/powerpoint/2010/main" val="1024086991"/>
+      </p:ext>
+    </p:extLst>
+  </p:cSld>
+  <p:clrMapOvr>
+    <a:masterClrMapping/>
+  </p:clrMapOvr>
+</p:notes>
+</file>
+
+<file path=ppt/notesSlides/notesSlide13.xml><?xml version="1.0" encoding="utf-8"?>
+<p:notes xmlns:a="http://schemas.openxmlformats.org/drawingml/2006/main" xmlns:r="http://schemas.openxmlformats.org/officeDocument/2006/relationships" xmlns:p="http://schemas.openxmlformats.org/presentationml/2006/main">
+  <p:cSld>
+    <p:spTree>
+      <p:nvGrpSpPr>
+        <p:cNvPr id="1" name=""/>
+        <p:cNvGrpSpPr/>
+        <p:nvPr/>
+      </p:nvGrpSpPr>
+      <p:grpSpPr>
+        <a:xfrm>
+          <a:off x="0" y="0"/>
+          <a:ext cx="0" cy="0"/>
+          <a:chOff x="0" y="0"/>
+          <a:chExt cx="0" cy="0"/>
+        </a:xfrm>
+      </p:grpSpPr>
+      <p:sp>
+        <p:nvSpPr>
+          <p:cNvPr id="2" name="Slide Image Placeholder 1"/>
+          <p:cNvSpPr>
+            <a:spLocks noGrp="1" noRot="1" noChangeAspect="1"/>
+          </p:cNvSpPr>
+          <p:nvPr>
+            <p:ph type="sldImg"/>
+          </p:nvPr>
+        </p:nvSpPr>
+        <p:spPr/>
+      </p:sp>
+      <p:sp>
+        <p:nvSpPr>
+          <p:cNvPr id="3" name="Notes Placeholder 2"/>
+          <p:cNvSpPr>
+            <a:spLocks noGrp="1"/>
+          </p:cNvSpPr>
+          <p:nvPr>
+            <p:ph type="body" idx="1"/>
+          </p:nvPr>
+        </p:nvSpPr>
+        <p:spPr/>
+        <p:txBody>
+          <a:bodyPr/>
+          <a:lstStyle/>
+          <a:p>
+            <a:r>
+              <a:rPr lang="en-US" dirty="0"/>
+              <a:t>Total deposit balance across the cohort rose +111.3m (+3.8%). By rate sensitivity: High +144.7m (+12.4%) against Very High −36.0m (−2.5%), and Very Low −11.0m (−6.9%). That is the reverse of the move-rate grid on the previous slide: the segments most likely to empty Save Max are the ones whose total balance grew, and the segments least likely to move are the ones losing money. The largest single cell is High stickiness with High sensitivity at +94.2m on 2,788 customers. Percentages are suppressed for the low-stickiness rows because their prior balances are near zero - Very Low stickiness held THB 0.03m in total, so a ratio there reads as +1549% and means nothing. Practical read: pocket-level runoff and bank-level runoff are different outcomes and need separate scores. Rate sensitivity predicts the first and is actively misleading on the second.</a:t>
+            </a:r>
+            <a:endParaRPr lang="en-US" dirty="0"/>
+          </a:p>
+        </p:txBody>
+      </p:sp>
+      <p:sp>
+        <p:nvSpPr>
+          <p:cNvPr id="4" name="Slide Number Placeholder 3"/>
+          <p:cNvSpPr>
+            <a:spLocks noGrp="1"/>
+          </p:cNvSpPr>
+          <p:nvPr>
+            <p:ph type="sldNum" sz="quarter" idx="10"/>
+          </p:nvPr>
+        </p:nvSpPr>
+        <p:spPr/>
+        <p:txBody>
+          <a:bodyPr/>
+          <a:lstStyle/>
+          <a:p>
+            <a:fld id="{F7021451-1387-4CA6-816F-3879F97B5CBC}" type="slidenum">
+              <a:rPr lang="en-US"/>
+              <a:t>13</a:t>
             </a:fld>
             <a:endParaRPr lang="en-US"/>
           </a:p>
@@ -13297,6 +13386,4404 @@
 </p:sld>
 </file>
 
+<file path=ppt/slides/slide13.xml><?xml version="1.0" encoding="utf-8"?>
+<p:sld xmlns:a="http://schemas.openxmlformats.org/drawingml/2006/main" xmlns:r="http://schemas.openxmlformats.org/officeDocument/2006/relationships" xmlns:p="http://schemas.openxmlformats.org/presentationml/2006/main">
+  <p:cSld name="Slide 13">
+    <p:bg>
+      <p:bgPr>
+        <a:solidFill>
+          <a:srgbClr val="FFFFFF"/>
+        </a:solidFill>
+      </p:bgPr>
+    </p:bg>
+    <p:spTree>
+      <p:nvGrpSpPr>
+        <p:cNvPr id="1" name=""/>
+        <p:cNvGrpSpPr/>
+        <p:nvPr/>
+      </p:nvGrpSpPr>
+      <p:grpSpPr>
+        <a:xfrm>
+          <a:off x="0" y="0"/>
+          <a:ext cx="0" cy="0"/>
+          <a:chOff x="0" y="0"/>
+          <a:chExt cx="0" cy="0"/>
+        </a:xfrm>
+      </p:grpSpPr>
+      <p:sp>
+        <p:nvSpPr>
+          <p:cNvPr id="2" name="Text 0"/>
+          <p:cNvSpPr/>
+          <p:nvPr/>
+        </p:nvSpPr>
+        <p:spPr>
+          <a:xfrm>
+            <a:off x="530352" y="283464"/>
+            <a:ext cx="11274552" cy="384048"/>
+          </a:xfrm>
+          <a:prstGeom prst="rect">
+            <a:avLst/>
+          </a:prstGeom>
+          <a:noFill/>
+          <a:ln/>
+        </p:spPr>
+        <p:txBody>
+          <a:bodyPr wrap="square" lIns="0" tIns="0" rIns="0" bIns="0" rtlCol="0" anchor="ctr"/>
+          <a:lstStyle/>
+          <a:p>
+            <a:pPr indent="0" marL="0">
+              <a:buNone/>
+            </a:pPr>
+            <a:r>
+              <a:rPr lang="en-US" sz="2200" b="1" dirty="0">
+                <a:solidFill>
+                  <a:srgbClr val="045D66"/>
+                </a:solidFill>
+                <a:latin typeface="Graphik TH" pitchFamily="34" charset="0"/>
+                <a:ea typeface="Graphik TH" pitchFamily="34" charset="-122"/>
+                <a:cs typeface="Graphik TH" pitchFamily="34" charset="-120"/>
+              </a:rPr>
+              <a:t>Balance change : deposit stickiness against rate sensitivity</a:t>
+            </a:r>
+            <a:endParaRPr lang="en-US" sz="2200" dirty="0"/>
+          </a:p>
+        </p:txBody>
+      </p:sp>
+      <p:sp>
+        <p:nvSpPr>
+          <p:cNvPr id="3" name="Text 1"/>
+          <p:cNvSpPr/>
+          <p:nvPr/>
+        </p:nvSpPr>
+        <p:spPr>
+          <a:xfrm>
+            <a:off x="530352" y="713232"/>
+            <a:ext cx="11274552" cy="237744"/>
+          </a:xfrm>
+          <a:prstGeom prst="rect">
+            <a:avLst/>
+          </a:prstGeom>
+          <a:noFill/>
+          <a:ln/>
+        </p:spPr>
+        <p:txBody>
+          <a:bodyPr wrap="square" lIns="0" tIns="0" rIns="0" bIns="0" rtlCol="0" anchor="ctr"/>
+          <a:lstStyle/>
+          <a:p>
+            <a:pPr indent="0" marL="0">
+              <a:buNone/>
+            </a:pPr>
+            <a:r>
+              <a:rPr lang="en-US" sz="1150" i="1" dirty="0">
+                <a:solidFill>
+                  <a:srgbClr val="6B6B6B"/>
+                </a:solidFill>
+                <a:latin typeface="Graphik TH" pitchFamily="34" charset="0"/>
+                <a:ea typeface="Graphik TH" pitchFamily="34" charset="-122"/>
+                <a:cs typeface="Graphik TH" pitchFamily="34" charset="-120"/>
+              </a:rPr>
+              <a:t>*Change in total deposit balance, prior to latest. Percentages suppressed below THB 5m prior balance; cells under 50 customers unshaded.</a:t>
+            </a:r>
+            <a:endParaRPr lang="en-US" sz="1150" dirty="0"/>
+          </a:p>
+        </p:txBody>
+      </p:sp>
+      <p:sp>
+        <p:nvSpPr>
+          <p:cNvPr id="4" name="Text 2"/>
+          <p:cNvSpPr/>
+          <p:nvPr/>
+        </p:nvSpPr>
+        <p:spPr>
+          <a:xfrm>
+            <a:off x="548640" y="996696"/>
+            <a:ext cx="11064240" cy="237744"/>
+          </a:xfrm>
+          <a:prstGeom prst="rect">
+            <a:avLst/>
+          </a:prstGeom>
+          <a:noFill/>
+          <a:ln/>
+        </p:spPr>
+        <p:txBody>
+          <a:bodyPr wrap="square" lIns="0" tIns="0" rIns="0" bIns="0" rtlCol="0" anchor="ctr"/>
+          <a:lstStyle/>
+          <a:p>
+            <a:pPr indent="0" marL="0">
+              <a:buNone/>
+            </a:pPr>
+            <a:r>
+              <a:rPr lang="en-US" sz="1300" b="1" dirty="0">
+                <a:solidFill>
+                  <a:srgbClr val="045D66"/>
+                </a:solidFill>
+                <a:latin typeface="Graphik TH" pitchFamily="34" charset="0"/>
+                <a:ea typeface="Graphik TH" pitchFamily="34" charset="-122"/>
+                <a:cs typeface="Graphik TH" pitchFamily="34" charset="-120"/>
+              </a:rPr>
+              <a:t>Cohort 47,184   ·   Total +111.3m (+3.8%)   ·   High sensitivity +144.7m (+12.4%)   ·   Very High −36.0m (−2.5%)</a:t>
+            </a:r>
+            <a:endParaRPr lang="en-US" sz="1300" dirty="0"/>
+          </a:p>
+        </p:txBody>
+      </p:sp>
+      <p:sp>
+        <p:nvSpPr>
+          <p:cNvPr id="5" name="Text 3"/>
+          <p:cNvSpPr/>
+          <p:nvPr/>
+        </p:nvSpPr>
+        <p:spPr>
+          <a:xfrm>
+            <a:off x="548640" y="1280160"/>
+            <a:ext cx="11064240" cy="274320"/>
+          </a:xfrm>
+          <a:prstGeom prst="rect">
+            <a:avLst/>
+          </a:prstGeom>
+          <a:noFill/>
+          <a:ln/>
+        </p:spPr>
+        <p:txBody>
+          <a:bodyPr wrap="square" lIns="0" tIns="0" rIns="0" bIns="0" rtlCol="0" anchor="ctr"/>
+          <a:lstStyle/>
+          <a:p>
+            <a:pPr indent="0" marL="0">
+              <a:buNone/>
+            </a:pPr>
+            <a:r>
+              <a:rPr lang="en-US" sz="1400" dirty="0">
+                <a:solidFill>
+                  <a:srgbClr val="16233D"/>
+                </a:solidFill>
+                <a:latin typeface="Graphik TH" pitchFamily="34" charset="0"/>
+                <a:ea typeface="Graphik TH" pitchFamily="34" charset="-122"/>
+                <a:cs typeface="Graphik TH" pitchFamily="34" charset="-120"/>
+              </a:rPr>
+              <a:t>Balance change runs opposite to move rate — the segment that emptied Save Max most is the one that grew.</a:t>
+            </a:r>
+            <a:endParaRPr lang="en-US" sz="1400" dirty="0"/>
+          </a:p>
+        </p:txBody>
+      </p:sp>
+      <p:sp>
+        <p:nvSpPr>
+          <p:cNvPr id="6" name="Shape 4"/>
+          <p:cNvSpPr/>
+          <p:nvPr/>
+        </p:nvSpPr>
+        <p:spPr>
+          <a:xfrm>
+            <a:off x="530352" y="1645920"/>
+            <a:ext cx="2647188" cy="987552"/>
+          </a:xfrm>
+          <a:prstGeom prst="roundRect">
+            <a:avLst>
+              <a:gd name="adj" fmla="val 8333"/>
+            </a:avLst>
+          </a:prstGeom>
+          <a:solidFill>
+            <a:srgbClr val="F1F4F9"/>
+          </a:solidFill>
+          <a:ln/>
+        </p:spPr>
+      </p:sp>
+      <p:sp>
+        <p:nvSpPr>
+          <p:cNvPr id="7" name="Text 5"/>
+          <p:cNvSpPr/>
+          <p:nvPr/>
+        </p:nvSpPr>
+        <p:spPr>
+          <a:xfrm>
+            <a:off x="749808" y="1719072"/>
+            <a:ext cx="2208276" cy="402336"/>
+          </a:xfrm>
+          <a:prstGeom prst="rect">
+            <a:avLst/>
+          </a:prstGeom>
+          <a:noFill/>
+          <a:ln/>
+        </p:spPr>
+        <p:txBody>
+          <a:bodyPr wrap="square" lIns="0" tIns="0" rIns="0" bIns="0" rtlCol="0" anchor="ctr"/>
+          <a:lstStyle/>
+          <a:p>
+            <a:pPr indent="0" marL="0">
+              <a:buNone/>
+            </a:pPr>
+            <a:r>
+              <a:rPr lang="en-US" sz="2400" b="1" dirty="0">
+                <a:solidFill>
+                  <a:srgbClr val="00A896"/>
+                </a:solidFill>
+                <a:latin typeface="Graphik TH" pitchFamily="34" charset="0"/>
+                <a:ea typeface="Graphik TH" pitchFamily="34" charset="-122"/>
+                <a:cs typeface="Graphik TH" pitchFamily="34" charset="-120"/>
+              </a:rPr>
+              <a:t>+111.3m</a:t>
+            </a:r>
+            <a:endParaRPr lang="en-US" sz="2400" dirty="0"/>
+          </a:p>
+        </p:txBody>
+      </p:sp>
+      <p:sp>
+        <p:nvSpPr>
+          <p:cNvPr id="8" name="Text 6"/>
+          <p:cNvSpPr/>
+          <p:nvPr/>
+        </p:nvSpPr>
+        <p:spPr>
+          <a:xfrm>
+            <a:off x="749808" y="2121408"/>
+            <a:ext cx="2208276" cy="237744"/>
+          </a:xfrm>
+          <a:prstGeom prst="rect">
+            <a:avLst/>
+          </a:prstGeom>
+          <a:noFill/>
+          <a:ln/>
+        </p:spPr>
+        <p:txBody>
+          <a:bodyPr wrap="square" lIns="0" tIns="0" rIns="0" bIns="0" rtlCol="0" anchor="t"/>
+          <a:lstStyle/>
+          <a:p>
+            <a:pPr indent="0" marL="0">
+              <a:buNone/>
+            </a:pPr>
+            <a:r>
+              <a:rPr lang="en-US" sz="1150" b="1" dirty="0">
+                <a:solidFill>
+                  <a:srgbClr val="16233D"/>
+                </a:solidFill>
+                <a:latin typeface="Graphik TH" pitchFamily="34" charset="0"/>
+                <a:ea typeface="Graphik TH" pitchFamily="34" charset="-122"/>
+                <a:cs typeface="Graphik TH" pitchFamily="34" charset="-120"/>
+              </a:rPr>
+              <a:t>total balance change</a:t>
+            </a:r>
+            <a:endParaRPr lang="en-US" sz="1150" dirty="0"/>
+          </a:p>
+        </p:txBody>
+      </p:sp>
+      <p:sp>
+        <p:nvSpPr>
+          <p:cNvPr id="9" name="Text 7"/>
+          <p:cNvSpPr/>
+          <p:nvPr/>
+        </p:nvSpPr>
+        <p:spPr>
+          <a:xfrm>
+            <a:off x="749808" y="2350008"/>
+            <a:ext cx="2208276" cy="237744"/>
+          </a:xfrm>
+          <a:prstGeom prst="rect">
+            <a:avLst/>
+          </a:prstGeom>
+          <a:noFill/>
+          <a:ln/>
+        </p:spPr>
+        <p:txBody>
+          <a:bodyPr wrap="square" lIns="0" tIns="0" rIns="0" bIns="0" rtlCol="0" anchor="t"/>
+          <a:lstStyle/>
+          <a:p>
+            <a:pPr indent="0" marL="0">
+              <a:buNone/>
+            </a:pPr>
+            <a:r>
+              <a:rPr lang="en-US" sz="950" dirty="0">
+                <a:solidFill>
+                  <a:srgbClr val="6B7A90"/>
+                </a:solidFill>
+                <a:latin typeface="Graphik TH" pitchFamily="34" charset="0"/>
+                <a:ea typeface="Graphik TH" pitchFamily="34" charset="-122"/>
+                <a:cs typeface="Graphik TH" pitchFamily="34" charset="-120"/>
+              </a:rPr>
+              <a:t>+3.8% across the cohort</a:t>
+            </a:r>
+            <a:endParaRPr lang="en-US" sz="950" dirty="0"/>
+          </a:p>
+        </p:txBody>
+      </p:sp>
+      <p:sp>
+        <p:nvSpPr>
+          <p:cNvPr id="10" name="Shape 8"/>
+          <p:cNvSpPr/>
+          <p:nvPr/>
+        </p:nvSpPr>
+        <p:spPr>
+          <a:xfrm>
+            <a:off x="3406140" y="1645920"/>
+            <a:ext cx="2647188" cy="987552"/>
+          </a:xfrm>
+          <a:prstGeom prst="roundRect">
+            <a:avLst>
+              <a:gd name="adj" fmla="val 8333"/>
+            </a:avLst>
+          </a:prstGeom>
+          <a:solidFill>
+            <a:srgbClr val="F1F4F9"/>
+          </a:solidFill>
+          <a:ln/>
+        </p:spPr>
+      </p:sp>
+      <p:sp>
+        <p:nvSpPr>
+          <p:cNvPr id="11" name="Text 9"/>
+          <p:cNvSpPr/>
+          <p:nvPr/>
+        </p:nvSpPr>
+        <p:spPr>
+          <a:xfrm>
+            <a:off x="3625596" y="1719072"/>
+            <a:ext cx="2208276" cy="402336"/>
+          </a:xfrm>
+          <a:prstGeom prst="rect">
+            <a:avLst/>
+          </a:prstGeom>
+          <a:noFill/>
+          <a:ln/>
+        </p:spPr>
+        <p:txBody>
+          <a:bodyPr wrap="square" lIns="0" tIns="0" rIns="0" bIns="0" rtlCol="0" anchor="ctr"/>
+          <a:lstStyle/>
+          <a:p>
+            <a:pPr indent="0" marL="0">
+              <a:buNone/>
+            </a:pPr>
+            <a:r>
+              <a:rPr lang="en-US" sz="2400" b="1" dirty="0">
+                <a:solidFill>
+                  <a:srgbClr val="00A896"/>
+                </a:solidFill>
+                <a:latin typeface="Graphik TH" pitchFamily="34" charset="0"/>
+                <a:ea typeface="Graphik TH" pitchFamily="34" charset="-122"/>
+                <a:cs typeface="Graphik TH" pitchFamily="34" charset="-120"/>
+              </a:rPr>
+              <a:t>+144.7m</a:t>
+            </a:r>
+            <a:endParaRPr lang="en-US" sz="2400" dirty="0"/>
+          </a:p>
+        </p:txBody>
+      </p:sp>
+      <p:sp>
+        <p:nvSpPr>
+          <p:cNvPr id="12" name="Text 10"/>
+          <p:cNvSpPr/>
+          <p:nvPr/>
+        </p:nvSpPr>
+        <p:spPr>
+          <a:xfrm>
+            <a:off x="3625596" y="2121408"/>
+            <a:ext cx="2208276" cy="237744"/>
+          </a:xfrm>
+          <a:prstGeom prst="rect">
+            <a:avLst/>
+          </a:prstGeom>
+          <a:noFill/>
+          <a:ln/>
+        </p:spPr>
+        <p:txBody>
+          <a:bodyPr wrap="square" lIns="0" tIns="0" rIns="0" bIns="0" rtlCol="0" anchor="t"/>
+          <a:lstStyle/>
+          <a:p>
+            <a:pPr indent="0" marL="0">
+              <a:buNone/>
+            </a:pPr>
+            <a:r>
+              <a:rPr lang="en-US" sz="1150" b="1" dirty="0">
+                <a:solidFill>
+                  <a:srgbClr val="16233D"/>
+                </a:solidFill>
+                <a:latin typeface="Graphik TH" pitchFamily="34" charset="0"/>
+                <a:ea typeface="Graphik TH" pitchFamily="34" charset="-122"/>
+                <a:cs typeface="Graphik TH" pitchFamily="34" charset="-120"/>
+              </a:rPr>
+              <a:t>High rate sensitivity</a:t>
+            </a:r>
+            <a:endParaRPr lang="en-US" sz="1150" dirty="0"/>
+          </a:p>
+        </p:txBody>
+      </p:sp>
+      <p:sp>
+        <p:nvSpPr>
+          <p:cNvPr id="13" name="Text 11"/>
+          <p:cNvSpPr/>
+          <p:nvPr/>
+        </p:nvSpPr>
+        <p:spPr>
+          <a:xfrm>
+            <a:off x="3625596" y="2350008"/>
+            <a:ext cx="2208276" cy="237744"/>
+          </a:xfrm>
+          <a:prstGeom prst="rect">
+            <a:avLst/>
+          </a:prstGeom>
+          <a:noFill/>
+          <a:ln/>
+        </p:spPr>
+        <p:txBody>
+          <a:bodyPr wrap="square" lIns="0" tIns="0" rIns="0" bIns="0" rtlCol="0" anchor="t"/>
+          <a:lstStyle/>
+          <a:p>
+            <a:pPr indent="0" marL="0">
+              <a:buNone/>
+            </a:pPr>
+            <a:r>
+              <a:rPr lang="en-US" sz="950" dirty="0">
+                <a:solidFill>
+                  <a:srgbClr val="6B7A90"/>
+                </a:solidFill>
+                <a:latin typeface="Graphik TH" pitchFamily="34" charset="0"/>
+                <a:ea typeface="Graphik TH" pitchFamily="34" charset="-122"/>
+                <a:cs typeface="Graphik TH" pitchFamily="34" charset="-120"/>
+              </a:rPr>
+              <a:t>+12.4% · moved most</a:t>
+            </a:r>
+            <a:endParaRPr lang="en-US" sz="950" dirty="0"/>
+          </a:p>
+        </p:txBody>
+      </p:sp>
+      <p:sp>
+        <p:nvSpPr>
+          <p:cNvPr id="14" name="Shape 12"/>
+          <p:cNvSpPr/>
+          <p:nvPr/>
+        </p:nvSpPr>
+        <p:spPr>
+          <a:xfrm>
+            <a:off x="6281928" y="1645920"/>
+            <a:ext cx="2647188" cy="987552"/>
+          </a:xfrm>
+          <a:prstGeom prst="roundRect">
+            <a:avLst>
+              <a:gd name="adj" fmla="val 8333"/>
+            </a:avLst>
+          </a:prstGeom>
+          <a:solidFill>
+            <a:srgbClr val="F1F4F9"/>
+          </a:solidFill>
+          <a:ln/>
+        </p:spPr>
+      </p:sp>
+      <p:sp>
+        <p:nvSpPr>
+          <p:cNvPr id="15" name="Text 13"/>
+          <p:cNvSpPr/>
+          <p:nvPr/>
+        </p:nvSpPr>
+        <p:spPr>
+          <a:xfrm>
+            <a:off x="6501384" y="1719072"/>
+            <a:ext cx="2208276" cy="402336"/>
+          </a:xfrm>
+          <a:prstGeom prst="rect">
+            <a:avLst/>
+          </a:prstGeom>
+          <a:noFill/>
+          <a:ln/>
+        </p:spPr>
+        <p:txBody>
+          <a:bodyPr wrap="square" lIns="0" tIns="0" rIns="0" bIns="0" rtlCol="0" anchor="ctr"/>
+          <a:lstStyle/>
+          <a:p>
+            <a:pPr indent="0" marL="0">
+              <a:buNone/>
+            </a:pPr>
+            <a:r>
+              <a:rPr lang="en-US" sz="2400" b="1" dirty="0">
+                <a:solidFill>
+                  <a:srgbClr val="C00000"/>
+                </a:solidFill>
+                <a:latin typeface="Graphik TH" pitchFamily="34" charset="0"/>
+                <a:ea typeface="Graphik TH" pitchFamily="34" charset="-122"/>
+                <a:cs typeface="Graphik TH" pitchFamily="34" charset="-120"/>
+              </a:rPr>
+              <a:t>−36.0m</a:t>
+            </a:r>
+            <a:endParaRPr lang="en-US" sz="2400" dirty="0"/>
+          </a:p>
+        </p:txBody>
+      </p:sp>
+      <p:sp>
+        <p:nvSpPr>
+          <p:cNvPr id="16" name="Text 14"/>
+          <p:cNvSpPr/>
+          <p:nvPr/>
+        </p:nvSpPr>
+        <p:spPr>
+          <a:xfrm>
+            <a:off x="6501384" y="2121408"/>
+            <a:ext cx="2208276" cy="237744"/>
+          </a:xfrm>
+          <a:prstGeom prst="rect">
+            <a:avLst/>
+          </a:prstGeom>
+          <a:noFill/>
+          <a:ln/>
+        </p:spPr>
+        <p:txBody>
+          <a:bodyPr wrap="square" lIns="0" tIns="0" rIns="0" bIns="0" rtlCol="0" anchor="t"/>
+          <a:lstStyle/>
+          <a:p>
+            <a:pPr indent="0" marL="0">
+              <a:buNone/>
+            </a:pPr>
+            <a:r>
+              <a:rPr lang="en-US" sz="1150" b="1" dirty="0">
+                <a:solidFill>
+                  <a:srgbClr val="16233D"/>
+                </a:solidFill>
+                <a:latin typeface="Graphik TH" pitchFamily="34" charset="0"/>
+                <a:ea typeface="Graphik TH" pitchFamily="34" charset="-122"/>
+                <a:cs typeface="Graphik TH" pitchFamily="34" charset="-120"/>
+              </a:rPr>
+              <a:t>Very High rate sensitivity</a:t>
+            </a:r>
+            <a:endParaRPr lang="en-US" sz="1150" dirty="0"/>
+          </a:p>
+        </p:txBody>
+      </p:sp>
+      <p:sp>
+        <p:nvSpPr>
+          <p:cNvPr id="17" name="Text 15"/>
+          <p:cNvSpPr/>
+          <p:nvPr/>
+        </p:nvSpPr>
+        <p:spPr>
+          <a:xfrm>
+            <a:off x="6501384" y="2350008"/>
+            <a:ext cx="2208276" cy="237744"/>
+          </a:xfrm>
+          <a:prstGeom prst="rect">
+            <a:avLst/>
+          </a:prstGeom>
+          <a:noFill/>
+          <a:ln/>
+        </p:spPr>
+        <p:txBody>
+          <a:bodyPr wrap="square" lIns="0" tIns="0" rIns="0" bIns="0" rtlCol="0" anchor="t"/>
+          <a:lstStyle/>
+          <a:p>
+            <a:pPr indent="0" marL="0">
+              <a:buNone/>
+            </a:pPr>
+            <a:r>
+              <a:rPr lang="en-US" sz="950" dirty="0">
+                <a:solidFill>
+                  <a:srgbClr val="6B7A90"/>
+                </a:solidFill>
+                <a:latin typeface="Graphik TH" pitchFamily="34" charset="0"/>
+                <a:ea typeface="Graphik TH" pitchFamily="34" charset="-122"/>
+                <a:cs typeface="Graphik TH" pitchFamily="34" charset="-120"/>
+              </a:rPr>
+              <a:t>−2.5% · moved least</a:t>
+            </a:r>
+            <a:endParaRPr lang="en-US" sz="950" dirty="0"/>
+          </a:p>
+        </p:txBody>
+      </p:sp>
+      <p:sp>
+        <p:nvSpPr>
+          <p:cNvPr id="18" name="Shape 16"/>
+          <p:cNvSpPr/>
+          <p:nvPr/>
+        </p:nvSpPr>
+        <p:spPr>
+          <a:xfrm>
+            <a:off x="9157716" y="1645920"/>
+            <a:ext cx="2647188" cy="987552"/>
+          </a:xfrm>
+          <a:prstGeom prst="roundRect">
+            <a:avLst>
+              <a:gd name="adj" fmla="val 8333"/>
+            </a:avLst>
+          </a:prstGeom>
+          <a:solidFill>
+            <a:srgbClr val="F1F4F9"/>
+          </a:solidFill>
+          <a:ln/>
+        </p:spPr>
+      </p:sp>
+      <p:sp>
+        <p:nvSpPr>
+          <p:cNvPr id="19" name="Text 17"/>
+          <p:cNvSpPr/>
+          <p:nvPr/>
+        </p:nvSpPr>
+        <p:spPr>
+          <a:xfrm>
+            <a:off x="9377172" y="1719072"/>
+            <a:ext cx="2208276" cy="402336"/>
+          </a:xfrm>
+          <a:prstGeom prst="rect">
+            <a:avLst/>
+          </a:prstGeom>
+          <a:noFill/>
+          <a:ln/>
+        </p:spPr>
+        <p:txBody>
+          <a:bodyPr wrap="square" lIns="0" tIns="0" rIns="0" bIns="0" rtlCol="0" anchor="ctr"/>
+          <a:lstStyle/>
+          <a:p>
+            <a:pPr indent="0" marL="0">
+              <a:buNone/>
+            </a:pPr>
+            <a:r>
+              <a:rPr lang="en-US" sz="2400" b="1" dirty="0">
+                <a:solidFill>
+                  <a:srgbClr val="00A896"/>
+                </a:solidFill>
+                <a:latin typeface="Graphik TH" pitchFamily="34" charset="0"/>
+                <a:ea typeface="Graphik TH" pitchFamily="34" charset="-122"/>
+                <a:cs typeface="Graphik TH" pitchFamily="34" charset="-120"/>
+              </a:rPr>
+              <a:t>+94.2m</a:t>
+            </a:r>
+            <a:endParaRPr lang="en-US" sz="2400" dirty="0"/>
+          </a:p>
+        </p:txBody>
+      </p:sp>
+      <p:sp>
+        <p:nvSpPr>
+          <p:cNvPr id="20" name="Text 18"/>
+          <p:cNvSpPr/>
+          <p:nvPr/>
+        </p:nvSpPr>
+        <p:spPr>
+          <a:xfrm>
+            <a:off x="9377172" y="2121408"/>
+            <a:ext cx="2208276" cy="237744"/>
+          </a:xfrm>
+          <a:prstGeom prst="rect">
+            <a:avLst/>
+          </a:prstGeom>
+          <a:noFill/>
+          <a:ln/>
+        </p:spPr>
+        <p:txBody>
+          <a:bodyPr wrap="square" lIns="0" tIns="0" rIns="0" bIns="0" rtlCol="0" anchor="t"/>
+          <a:lstStyle/>
+          <a:p>
+            <a:pPr indent="0" marL="0">
+              <a:buNone/>
+            </a:pPr>
+            <a:r>
+              <a:rPr lang="en-US" sz="1150" b="1" dirty="0">
+                <a:solidFill>
+                  <a:srgbClr val="16233D"/>
+                </a:solidFill>
+                <a:latin typeface="Graphik TH" pitchFamily="34" charset="0"/>
+                <a:ea typeface="Graphik TH" pitchFamily="34" charset="-122"/>
+                <a:cs typeface="Graphik TH" pitchFamily="34" charset="-120"/>
+              </a:rPr>
+              <a:t>largest single cell</a:t>
+            </a:r>
+            <a:endParaRPr lang="en-US" sz="1150" dirty="0"/>
+          </a:p>
+        </p:txBody>
+      </p:sp>
+      <p:sp>
+        <p:nvSpPr>
+          <p:cNvPr id="21" name="Text 19"/>
+          <p:cNvSpPr/>
+          <p:nvPr/>
+        </p:nvSpPr>
+        <p:spPr>
+          <a:xfrm>
+            <a:off x="9377172" y="2350008"/>
+            <a:ext cx="2208276" cy="237744"/>
+          </a:xfrm>
+          <a:prstGeom prst="rect">
+            <a:avLst/>
+          </a:prstGeom>
+          <a:noFill/>
+          <a:ln/>
+        </p:spPr>
+        <p:txBody>
+          <a:bodyPr wrap="square" lIns="0" tIns="0" rIns="0" bIns="0" rtlCol="0" anchor="t"/>
+          <a:lstStyle/>
+          <a:p>
+            <a:pPr indent="0" marL="0">
+              <a:buNone/>
+            </a:pPr>
+            <a:r>
+              <a:rPr lang="en-US" sz="950" dirty="0">
+                <a:solidFill>
+                  <a:srgbClr val="6B7A90"/>
+                </a:solidFill>
+                <a:latin typeface="Graphik TH" pitchFamily="34" charset="0"/>
+                <a:ea typeface="Graphik TH" pitchFamily="34" charset="-122"/>
+                <a:cs typeface="Graphik TH" pitchFamily="34" charset="-120"/>
+              </a:rPr>
+              <a:t>High stickiness × High sensitivity</a:t>
+            </a:r>
+            <a:endParaRPr lang="en-US" sz="950" dirty="0"/>
+          </a:p>
+        </p:txBody>
+      </p:sp>
+      <p:sp>
+        <p:nvSpPr>
+          <p:cNvPr id="22" name="Shape 20"/>
+          <p:cNvSpPr/>
+          <p:nvPr/>
+        </p:nvSpPr>
+        <p:spPr>
+          <a:xfrm>
+            <a:off x="530352" y="2798064"/>
+            <a:ext cx="6720840" cy="2322576"/>
+          </a:xfrm>
+          <a:prstGeom prst="roundRect">
+            <a:avLst>
+              <a:gd name="adj" fmla="val 3543"/>
+            </a:avLst>
+          </a:prstGeom>
+          <a:solidFill>
+            <a:srgbClr val="F1F4F9"/>
+          </a:solidFill>
+          <a:ln/>
+        </p:spPr>
+      </p:sp>
+      <p:sp>
+        <p:nvSpPr>
+          <p:cNvPr id="23" name="Text 21"/>
+          <p:cNvSpPr/>
+          <p:nvPr/>
+        </p:nvSpPr>
+        <p:spPr>
+          <a:xfrm>
+            <a:off x="786384" y="2944368"/>
+            <a:ext cx="6208776" cy="274320"/>
+          </a:xfrm>
+          <a:prstGeom prst="rect">
+            <a:avLst/>
+          </a:prstGeom>
+          <a:noFill/>
+          <a:ln/>
+        </p:spPr>
+        <p:txBody>
+          <a:bodyPr wrap="square" lIns="0" tIns="0" rIns="0" bIns="0" rtlCol="0" anchor="ctr"/>
+          <a:lstStyle/>
+          <a:p>
+            <a:pPr indent="0" marL="0">
+              <a:buNone/>
+            </a:pPr>
+            <a:r>
+              <a:rPr lang="en-US" sz="1400" b="1" dirty="0">
+                <a:solidFill>
+                  <a:srgbClr val="16233D"/>
+                </a:solidFill>
+                <a:latin typeface="Cambria" pitchFamily="34" charset="0"/>
+                <a:ea typeface="Cambria" pitchFamily="34" charset="-122"/>
+                <a:cs typeface="Cambria" pitchFamily="34" charset="-120"/>
+              </a:rPr>
+              <a:t>Change in total deposit balance, THB m</a:t>
+            </a:r>
+            <a:endParaRPr lang="en-US" sz="1400" dirty="0"/>
+          </a:p>
+        </p:txBody>
+      </p:sp>
+      <p:sp>
+        <p:nvSpPr>
+          <p:cNvPr id="24" name="Text 22"/>
+          <p:cNvSpPr/>
+          <p:nvPr/>
+        </p:nvSpPr>
+        <p:spPr>
+          <a:xfrm>
+            <a:off x="786384" y="3218688"/>
+            <a:ext cx="6208776" cy="237744"/>
+          </a:xfrm>
+          <a:prstGeom prst="rect">
+            <a:avLst/>
+          </a:prstGeom>
+          <a:noFill/>
+          <a:ln/>
+        </p:spPr>
+        <p:txBody>
+          <a:bodyPr wrap="square" lIns="0" tIns="0" rIns="0" bIns="0" rtlCol="0" anchor="ctr"/>
+          <a:lstStyle/>
+          <a:p>
+            <a:pPr indent="0" marL="0">
+              <a:buNone/>
+            </a:pPr>
+            <a:r>
+              <a:rPr lang="en-US" sz="950" dirty="0">
+                <a:solidFill>
+                  <a:srgbClr val="6B7A90"/>
+                </a:solidFill>
+                <a:latin typeface="Graphik TH" pitchFamily="34" charset="0"/>
+                <a:ea typeface="Graphik TH" pitchFamily="34" charset="-122"/>
+                <a:cs typeface="Graphik TH" pitchFamily="34" charset="-120"/>
+              </a:rPr>
+              <a:t>Rows: deposit stickiness · columns: rate sensitivity · teal = gained, red = lost</a:t>
+            </a:r>
+            <a:endParaRPr lang="en-US" sz="950" dirty="0"/>
+          </a:p>
+        </p:txBody>
+      </p:sp>
+      <p:graphicFrame>
+        <p:nvGraphicFramePr>
+          <p:cNvPr id="14" name="Table 0"/>
+          <p:cNvGraphicFramePr>
+            <a:graphicFrameLocks noGrp="1"/>
+          </p:cNvGraphicFramePr>
+          <p:nvPr>
+            <p:extLst>
+              <p:ext uri="{D42A27DB-BD31-4B8C-83A1-F6EECF244321}">
+                <p14:modId xmlns:p14="http://schemas.microsoft.com/office/powerpoint/2010/main" val="1579011935"/>
+              </p:ext>
+            </p:extLst>
+          </p:nvPr>
+        </p:nvGraphicFramePr>
+        <p:xfrm>
+          <a:off x="749808" y="3474720"/>
+          <a:ext cx="6281928" cy="914400"/>
+        </p:xfrm>
+        <a:graphic>
+          <a:graphicData uri="http://schemas.openxmlformats.org/drawingml/2006/table">
+            <a:tbl>
+              <a:tblPr/>
+              <a:tblGrid>
+                <a:gridCol w="1161288"/>
+                <a:gridCol w="1024128"/>
+                <a:gridCol w="1024128"/>
+                <a:gridCol w="1024128"/>
+                <a:gridCol w="1024128"/>
+                <a:gridCol w="1024128"/>
+              </a:tblGrid>
+              <a:tr h="237744">
+                <a:tc>
+                  <a:txBody>
+                    <a:bodyPr/>
+                    <a:lstStyle/>
+                    <a:p>
+                      <a:pPr algn="l" indent="0" marL="0">
+                        <a:buNone/>
+                      </a:pPr>
+                      <a:r>
+                        <a:rPr lang="en-US" sz="900" b="1" dirty="0">
+                          <a:solidFill>
+                            <a:srgbClr val="FFFFFF"/>
+                          </a:solidFill>
+                          <a:latin typeface="Graphik TH" pitchFamily="34" charset="0"/>
+                          <a:ea typeface="Graphik TH" pitchFamily="34" charset="-122"/>
+                          <a:cs typeface="Graphik TH" pitchFamily="34" charset="-120"/>
+                        </a:rPr>
+                        <a:t>Stickiness</a:t>
+                      </a:r>
+                      <a:endParaRPr lang="en-US" sz="900" dirty="0">
+                        <a:latin typeface="Graphik TH" charset="0"/>
+                        <a:ea typeface="Graphik TH" charset="0"/>
+                        <a:cs typeface="Graphik TH" charset="0"/>
+                      </a:endParaRPr>
+                    </a:p>
+                  </a:txBody>
+                  <a:tcPr marL="36576" marR="36576" marT="9144" marB="9144" anchor="ctr">
+                    <a:lnL w="6350" cap="flat" cmpd="sng" algn="ctr">
+                      <a:solidFill>
+                        <a:srgbClr val="D8DFE9"/>
+                      </a:solidFill>
+                      <a:prstDash val="solid"/>
+                      <a:round/>
+                      <a:headEnd type="none" w="med" len="med"/>
+                      <a:tailEnd type="none" w="med" len="med"/>
+                    </a:lnL>
+                    <a:lnR w="6350" cap="flat" cmpd="sng" algn="ctr">
+                      <a:solidFill>
+                        <a:srgbClr val="D8DFE9"/>
+                      </a:solidFill>
+                      <a:prstDash val="solid"/>
+                      <a:round/>
+                      <a:headEnd type="none" w="med" len="med"/>
+                      <a:tailEnd type="none" w="med" len="med"/>
+                    </a:lnR>
+                    <a:lnT w="6350" cap="flat" cmpd="sng" algn="ctr">
+                      <a:solidFill>
+                        <a:srgbClr val="D8DFE9"/>
+                      </a:solidFill>
+                      <a:prstDash val="solid"/>
+                      <a:round/>
+                      <a:headEnd type="none" w="med" len="med"/>
+                      <a:tailEnd type="none" w="med" len="med"/>
+                    </a:lnT>
+                    <a:lnB w="6350" cap="flat" cmpd="sng" algn="ctr">
+                      <a:solidFill>
+                        <a:srgbClr val="D8DFE9"/>
+                      </a:solidFill>
+                      <a:prstDash val="solid"/>
+                      <a:round/>
+                      <a:headEnd type="none" w="med" len="med"/>
+                      <a:tailEnd type="none" w="med" len="med"/>
+                    </a:lnB>
+                    <a:solidFill>
+                      <a:srgbClr val="045D66"/>
+                    </a:solidFill>
+                  </a:tcPr>
+                </a:tc>
+                <a:tc>
+                  <a:txBody>
+                    <a:bodyPr/>
+                    <a:lstStyle/>
+                    <a:p>
+                      <a:pPr algn="ctr" indent="0" marL="0">
+                        <a:buNone/>
+                      </a:pPr>
+                      <a:r>
+                        <a:rPr lang="en-US" sz="900" b="1" dirty="0">
+                          <a:solidFill>
+                            <a:srgbClr val="FFFFFF"/>
+                          </a:solidFill>
+                          <a:latin typeface="Graphik TH" pitchFamily="34" charset="0"/>
+                          <a:ea typeface="Graphik TH" pitchFamily="34" charset="-122"/>
+                          <a:cs typeface="Graphik TH" pitchFamily="34" charset="-120"/>
+                        </a:rPr>
+                        <a:t>Very Low</a:t>
+                      </a:r>
+                      <a:endParaRPr lang="en-US" sz="900" dirty="0">
+                        <a:latin typeface="Graphik TH" charset="0"/>
+                        <a:ea typeface="Graphik TH" charset="0"/>
+                        <a:cs typeface="Graphik TH" charset="0"/>
+                      </a:endParaRPr>
+                    </a:p>
+                  </a:txBody>
+                  <a:tcPr marL="36576" marR="36576" marT="9144" marB="9144" anchor="ctr">
+                    <a:lnL w="6350" cap="flat" cmpd="sng" algn="ctr">
+                      <a:solidFill>
+                        <a:srgbClr val="D8DFE9"/>
+                      </a:solidFill>
+                      <a:prstDash val="solid"/>
+                      <a:round/>
+                      <a:headEnd type="none" w="med" len="med"/>
+                      <a:tailEnd type="none" w="med" len="med"/>
+                    </a:lnL>
+                    <a:lnR w="6350" cap="flat" cmpd="sng" algn="ctr">
+                      <a:solidFill>
+                        <a:srgbClr val="D8DFE9"/>
+                      </a:solidFill>
+                      <a:prstDash val="solid"/>
+                      <a:round/>
+                      <a:headEnd type="none" w="med" len="med"/>
+                      <a:tailEnd type="none" w="med" len="med"/>
+                    </a:lnR>
+                    <a:lnT w="6350" cap="flat" cmpd="sng" algn="ctr">
+                      <a:solidFill>
+                        <a:srgbClr val="D8DFE9"/>
+                      </a:solidFill>
+                      <a:prstDash val="solid"/>
+                      <a:round/>
+                      <a:headEnd type="none" w="med" len="med"/>
+                      <a:tailEnd type="none" w="med" len="med"/>
+                    </a:lnT>
+                    <a:lnB w="6350" cap="flat" cmpd="sng" algn="ctr">
+                      <a:solidFill>
+                        <a:srgbClr val="D8DFE9"/>
+                      </a:solidFill>
+                      <a:prstDash val="solid"/>
+                      <a:round/>
+                      <a:headEnd type="none" w="med" len="med"/>
+                      <a:tailEnd type="none" w="med" len="med"/>
+                    </a:lnB>
+                    <a:solidFill>
+                      <a:srgbClr val="045D66"/>
+                    </a:solidFill>
+                  </a:tcPr>
+                </a:tc>
+                <a:tc>
+                  <a:txBody>
+                    <a:bodyPr/>
+                    <a:lstStyle/>
+                    <a:p>
+                      <a:pPr algn="ctr" indent="0" marL="0">
+                        <a:buNone/>
+                      </a:pPr>
+                      <a:r>
+                        <a:rPr lang="en-US" sz="900" b="1" dirty="0">
+                          <a:solidFill>
+                            <a:srgbClr val="FFFFFF"/>
+                          </a:solidFill>
+                          <a:latin typeface="Graphik TH" pitchFamily="34" charset="0"/>
+                          <a:ea typeface="Graphik TH" pitchFamily="34" charset="-122"/>
+                          <a:cs typeface="Graphik TH" pitchFamily="34" charset="-120"/>
+                        </a:rPr>
+                        <a:t>Low</a:t>
+                      </a:r>
+                      <a:endParaRPr lang="en-US" sz="900" dirty="0">
+                        <a:latin typeface="Graphik TH" charset="0"/>
+                        <a:ea typeface="Graphik TH" charset="0"/>
+                        <a:cs typeface="Graphik TH" charset="0"/>
+                      </a:endParaRPr>
+                    </a:p>
+                  </a:txBody>
+                  <a:tcPr marL="36576" marR="36576" marT="9144" marB="9144" anchor="ctr">
+                    <a:lnL w="6350" cap="flat" cmpd="sng" algn="ctr">
+                      <a:solidFill>
+                        <a:srgbClr val="D8DFE9"/>
+                      </a:solidFill>
+                      <a:prstDash val="solid"/>
+                      <a:round/>
+                      <a:headEnd type="none" w="med" len="med"/>
+                      <a:tailEnd type="none" w="med" len="med"/>
+                    </a:lnL>
+                    <a:lnR w="6350" cap="flat" cmpd="sng" algn="ctr">
+                      <a:solidFill>
+                        <a:srgbClr val="D8DFE9"/>
+                      </a:solidFill>
+                      <a:prstDash val="solid"/>
+                      <a:round/>
+                      <a:headEnd type="none" w="med" len="med"/>
+                      <a:tailEnd type="none" w="med" len="med"/>
+                    </a:lnR>
+                    <a:lnT w="6350" cap="flat" cmpd="sng" algn="ctr">
+                      <a:solidFill>
+                        <a:srgbClr val="D8DFE9"/>
+                      </a:solidFill>
+                      <a:prstDash val="solid"/>
+                      <a:round/>
+                      <a:headEnd type="none" w="med" len="med"/>
+                      <a:tailEnd type="none" w="med" len="med"/>
+                    </a:lnT>
+                    <a:lnB w="6350" cap="flat" cmpd="sng" algn="ctr">
+                      <a:solidFill>
+                        <a:srgbClr val="D8DFE9"/>
+                      </a:solidFill>
+                      <a:prstDash val="solid"/>
+                      <a:round/>
+                      <a:headEnd type="none" w="med" len="med"/>
+                      <a:tailEnd type="none" w="med" len="med"/>
+                    </a:lnB>
+                    <a:solidFill>
+                      <a:srgbClr val="045D66"/>
+                    </a:solidFill>
+                  </a:tcPr>
+                </a:tc>
+                <a:tc>
+                  <a:txBody>
+                    <a:bodyPr/>
+                    <a:lstStyle/>
+                    <a:p>
+                      <a:pPr algn="ctr" indent="0" marL="0">
+                        <a:buNone/>
+                      </a:pPr>
+                      <a:r>
+                        <a:rPr lang="en-US" sz="900" b="1" dirty="0">
+                          <a:solidFill>
+                            <a:srgbClr val="FFFFFF"/>
+                          </a:solidFill>
+                          <a:latin typeface="Graphik TH" pitchFamily="34" charset="0"/>
+                          <a:ea typeface="Graphik TH" pitchFamily="34" charset="-122"/>
+                          <a:cs typeface="Graphik TH" pitchFamily="34" charset="-120"/>
+                        </a:rPr>
+                        <a:t>Medium</a:t>
+                      </a:r>
+                      <a:endParaRPr lang="en-US" sz="900" dirty="0">
+                        <a:latin typeface="Graphik TH" charset="0"/>
+                        <a:ea typeface="Graphik TH" charset="0"/>
+                        <a:cs typeface="Graphik TH" charset="0"/>
+                      </a:endParaRPr>
+                    </a:p>
+                  </a:txBody>
+                  <a:tcPr marL="36576" marR="36576" marT="9144" marB="9144" anchor="ctr">
+                    <a:lnL w="6350" cap="flat" cmpd="sng" algn="ctr">
+                      <a:solidFill>
+                        <a:srgbClr val="D8DFE9"/>
+                      </a:solidFill>
+                      <a:prstDash val="solid"/>
+                      <a:round/>
+                      <a:headEnd type="none" w="med" len="med"/>
+                      <a:tailEnd type="none" w="med" len="med"/>
+                    </a:lnL>
+                    <a:lnR w="6350" cap="flat" cmpd="sng" algn="ctr">
+                      <a:solidFill>
+                        <a:srgbClr val="D8DFE9"/>
+                      </a:solidFill>
+                      <a:prstDash val="solid"/>
+                      <a:round/>
+                      <a:headEnd type="none" w="med" len="med"/>
+                      <a:tailEnd type="none" w="med" len="med"/>
+                    </a:lnR>
+                    <a:lnT w="6350" cap="flat" cmpd="sng" algn="ctr">
+                      <a:solidFill>
+                        <a:srgbClr val="D8DFE9"/>
+                      </a:solidFill>
+                      <a:prstDash val="solid"/>
+                      <a:round/>
+                      <a:headEnd type="none" w="med" len="med"/>
+                      <a:tailEnd type="none" w="med" len="med"/>
+                    </a:lnT>
+                    <a:lnB w="6350" cap="flat" cmpd="sng" algn="ctr">
+                      <a:solidFill>
+                        <a:srgbClr val="D8DFE9"/>
+                      </a:solidFill>
+                      <a:prstDash val="solid"/>
+                      <a:round/>
+                      <a:headEnd type="none" w="med" len="med"/>
+                      <a:tailEnd type="none" w="med" len="med"/>
+                    </a:lnB>
+                    <a:solidFill>
+                      <a:srgbClr val="045D66"/>
+                    </a:solidFill>
+                  </a:tcPr>
+                </a:tc>
+                <a:tc>
+                  <a:txBody>
+                    <a:bodyPr/>
+                    <a:lstStyle/>
+                    <a:p>
+                      <a:pPr algn="ctr" indent="0" marL="0">
+                        <a:buNone/>
+                      </a:pPr>
+                      <a:r>
+                        <a:rPr lang="en-US" sz="900" b="1" dirty="0">
+                          <a:solidFill>
+                            <a:srgbClr val="FFFFFF"/>
+                          </a:solidFill>
+                          <a:latin typeface="Graphik TH" pitchFamily="34" charset="0"/>
+                          <a:ea typeface="Graphik TH" pitchFamily="34" charset="-122"/>
+                          <a:cs typeface="Graphik TH" pitchFamily="34" charset="-120"/>
+                        </a:rPr>
+                        <a:t>High</a:t>
+                      </a:r>
+                      <a:endParaRPr lang="en-US" sz="900" dirty="0">
+                        <a:latin typeface="Graphik TH" charset="0"/>
+                        <a:ea typeface="Graphik TH" charset="0"/>
+                        <a:cs typeface="Graphik TH" charset="0"/>
+                      </a:endParaRPr>
+                    </a:p>
+                  </a:txBody>
+                  <a:tcPr marL="36576" marR="36576" marT="9144" marB="9144" anchor="ctr">
+                    <a:lnL w="6350" cap="flat" cmpd="sng" algn="ctr">
+                      <a:solidFill>
+                        <a:srgbClr val="D8DFE9"/>
+                      </a:solidFill>
+                      <a:prstDash val="solid"/>
+                      <a:round/>
+                      <a:headEnd type="none" w="med" len="med"/>
+                      <a:tailEnd type="none" w="med" len="med"/>
+                    </a:lnL>
+                    <a:lnR w="6350" cap="flat" cmpd="sng" algn="ctr">
+                      <a:solidFill>
+                        <a:srgbClr val="D8DFE9"/>
+                      </a:solidFill>
+                      <a:prstDash val="solid"/>
+                      <a:round/>
+                      <a:headEnd type="none" w="med" len="med"/>
+                      <a:tailEnd type="none" w="med" len="med"/>
+                    </a:lnR>
+                    <a:lnT w="6350" cap="flat" cmpd="sng" algn="ctr">
+                      <a:solidFill>
+                        <a:srgbClr val="D8DFE9"/>
+                      </a:solidFill>
+                      <a:prstDash val="solid"/>
+                      <a:round/>
+                      <a:headEnd type="none" w="med" len="med"/>
+                      <a:tailEnd type="none" w="med" len="med"/>
+                    </a:lnT>
+                    <a:lnB w="6350" cap="flat" cmpd="sng" algn="ctr">
+                      <a:solidFill>
+                        <a:srgbClr val="D8DFE9"/>
+                      </a:solidFill>
+                      <a:prstDash val="solid"/>
+                      <a:round/>
+                      <a:headEnd type="none" w="med" len="med"/>
+                      <a:tailEnd type="none" w="med" len="med"/>
+                    </a:lnB>
+                    <a:solidFill>
+                      <a:srgbClr val="045D66"/>
+                    </a:solidFill>
+                  </a:tcPr>
+                </a:tc>
+                <a:tc>
+                  <a:txBody>
+                    <a:bodyPr/>
+                    <a:lstStyle/>
+                    <a:p>
+                      <a:pPr algn="ctr" indent="0" marL="0">
+                        <a:buNone/>
+                      </a:pPr>
+                      <a:r>
+                        <a:rPr lang="en-US" sz="900" b="1" dirty="0">
+                          <a:solidFill>
+                            <a:srgbClr val="FFFFFF"/>
+                          </a:solidFill>
+                          <a:latin typeface="Graphik TH" pitchFamily="34" charset="0"/>
+                          <a:ea typeface="Graphik TH" pitchFamily="34" charset="-122"/>
+                          <a:cs typeface="Graphik TH" pitchFamily="34" charset="-120"/>
+                        </a:rPr>
+                        <a:t>Very High</a:t>
+                      </a:r>
+                      <a:endParaRPr lang="en-US" sz="900" dirty="0">
+                        <a:latin typeface="Graphik TH" charset="0"/>
+                        <a:ea typeface="Graphik TH" charset="0"/>
+                        <a:cs typeface="Graphik TH" charset="0"/>
+                      </a:endParaRPr>
+                    </a:p>
+                  </a:txBody>
+                  <a:tcPr marL="36576" marR="36576" marT="9144" marB="9144" anchor="ctr">
+                    <a:lnL w="6350" cap="flat" cmpd="sng" algn="ctr">
+                      <a:solidFill>
+                        <a:srgbClr val="D8DFE9"/>
+                      </a:solidFill>
+                      <a:prstDash val="solid"/>
+                      <a:round/>
+                      <a:headEnd type="none" w="med" len="med"/>
+                      <a:tailEnd type="none" w="med" len="med"/>
+                    </a:lnL>
+                    <a:lnR w="6350" cap="flat" cmpd="sng" algn="ctr">
+                      <a:solidFill>
+                        <a:srgbClr val="D8DFE9"/>
+                      </a:solidFill>
+                      <a:prstDash val="solid"/>
+                      <a:round/>
+                      <a:headEnd type="none" w="med" len="med"/>
+                      <a:tailEnd type="none" w="med" len="med"/>
+                    </a:lnR>
+                    <a:lnT w="6350" cap="flat" cmpd="sng" algn="ctr">
+                      <a:solidFill>
+                        <a:srgbClr val="D8DFE9"/>
+                      </a:solidFill>
+                      <a:prstDash val="solid"/>
+                      <a:round/>
+                      <a:headEnd type="none" w="med" len="med"/>
+                      <a:tailEnd type="none" w="med" len="med"/>
+                    </a:lnT>
+                    <a:lnB w="6350" cap="flat" cmpd="sng" algn="ctr">
+                      <a:solidFill>
+                        <a:srgbClr val="D8DFE9"/>
+                      </a:solidFill>
+                      <a:prstDash val="solid"/>
+                      <a:round/>
+                      <a:headEnd type="none" w="med" len="med"/>
+                      <a:tailEnd type="none" w="med" len="med"/>
+                    </a:lnB>
+                    <a:solidFill>
+                      <a:srgbClr val="045D66"/>
+                    </a:solidFill>
+                  </a:tcPr>
+                </a:tc>
+              </a:tr>
+              <a:tr h="274320">
+                <a:tc>
+                  <a:txBody>
+                    <a:bodyPr/>
+                    <a:lstStyle/>
+                    <a:p>
+                      <a:pPr algn="l" indent="0" marL="0">
+                        <a:buNone/>
+                      </a:pPr>
+                      <a:r>
+                        <a:rPr lang="en-US" sz="950" b="1" dirty="0">
+                          <a:solidFill>
+                            <a:srgbClr val="16233D"/>
+                          </a:solidFill>
+                          <a:latin typeface="Graphik TH" pitchFamily="34" charset="0"/>
+                          <a:ea typeface="Graphik TH" pitchFamily="34" charset="-122"/>
+                          <a:cs typeface="Graphik TH" pitchFamily="34" charset="-120"/>
+                        </a:rPr>
+                        <a:t>Very High</a:t>
+                      </a:r>
+                      <a:endParaRPr lang="en-US" sz="950" dirty="0">
+                        <a:latin typeface="Graphik TH" charset="0"/>
+                        <a:ea typeface="Graphik TH" charset="0"/>
+                        <a:cs typeface="Graphik TH" charset="0"/>
+                      </a:endParaRPr>
+                    </a:p>
+                  </a:txBody>
+                  <a:tcPr marL="36576" marR="36576" marT="9144" marB="9144" anchor="ctr">
+                    <a:lnL w="6350" cap="flat" cmpd="sng" algn="ctr">
+                      <a:solidFill>
+                        <a:srgbClr val="D8DFE9"/>
+                      </a:solidFill>
+                      <a:prstDash val="solid"/>
+                      <a:round/>
+                      <a:headEnd type="none" w="med" len="med"/>
+                      <a:tailEnd type="none" w="med" len="med"/>
+                    </a:lnL>
+                    <a:lnR w="6350" cap="flat" cmpd="sng" algn="ctr">
+                      <a:solidFill>
+                        <a:srgbClr val="D8DFE9"/>
+                      </a:solidFill>
+                      <a:prstDash val="solid"/>
+                      <a:round/>
+                      <a:headEnd type="none" w="med" len="med"/>
+                      <a:tailEnd type="none" w="med" len="med"/>
+                    </a:lnR>
+                    <a:lnT w="6350" cap="flat" cmpd="sng" algn="ctr">
+                      <a:solidFill>
+                        <a:srgbClr val="D8DFE9"/>
+                      </a:solidFill>
+                      <a:prstDash val="solid"/>
+                      <a:round/>
+                      <a:headEnd type="none" w="med" len="med"/>
+                      <a:tailEnd type="none" w="med" len="med"/>
+                    </a:lnT>
+                    <a:lnB w="6350" cap="flat" cmpd="sng" algn="ctr">
+                      <a:solidFill>
+                        <a:srgbClr val="D8DFE9"/>
+                      </a:solidFill>
+                      <a:prstDash val="solid"/>
+                      <a:round/>
+                      <a:headEnd type="none" w="med" len="med"/>
+                      <a:tailEnd type="none" w="med" len="med"/>
+                    </a:lnB>
+                    <a:solidFill>
+                      <a:srgbClr val="F1F4F9"/>
+                    </a:solidFill>
+                  </a:tcPr>
+                </a:tc>
+                <a:tc>
+                  <a:txBody>
+                    <a:bodyPr/>
+                    <a:lstStyle/>
+                    <a:p>
+                      <a:pPr algn="ctr" indent="0" marL="0">
+                        <a:buNone/>
+                      </a:pPr>
+                      <a:r>
+                        <a:rPr lang="en-US" sz="950" b="1" dirty="0">
+                          <a:solidFill>
+                            <a:srgbClr val="16233D"/>
+                          </a:solidFill>
+                          <a:latin typeface="Graphik TH" pitchFamily="34" charset="0"/>
+                          <a:ea typeface="Graphik TH" pitchFamily="34" charset="-122"/>
+                          <a:cs typeface="Graphik TH" pitchFamily="34" charset="-120"/>
+                        </a:rPr>
+                        <a:t>−7.8</a:t>
+                      </a:r>
+                      <a:pPr algn="ctr" indent="0" marL="0">
+                        <a:buNone/>
+                      </a:pPr>
+                      <a:endParaRPr lang="en-US" sz="1200" dirty="0"/>
+                    </a:p>
+                    <a:p>
+                      <a:pPr algn="ctr" indent="0" marL="0">
+                        <a:buNone/>
+                      </a:pPr>
+                      <a:r>
+                        <a:rPr lang="en-US" sz="700" dirty="0">
+                          <a:solidFill>
+                            <a:srgbClr val="6B7A90"/>
+                          </a:solidFill>
+                          <a:latin typeface="Graphik TH" pitchFamily="34" charset="0"/>
+                          <a:ea typeface="Graphik TH" pitchFamily="34" charset="-122"/>
+                          <a:cs typeface="Graphik TH" pitchFamily="34" charset="-120"/>
+                        </a:rPr>
+                        <a:t>−9.1%</a:t>
+                      </a:r>
+                      <a:endParaRPr lang="en-US" sz="1200" dirty="0"/>
+                    </a:p>
+                  </a:txBody>
+                  <a:tcPr marL="36576" marR="36576" marT="9144" marB="9144" anchor="ctr">
+                    <a:lnL w="6350" cap="flat" cmpd="sng" algn="ctr">
+                      <a:solidFill>
+                        <a:srgbClr val="D8DFE9"/>
+                      </a:solidFill>
+                      <a:prstDash val="solid"/>
+                      <a:round/>
+                      <a:headEnd type="none" w="med" len="med"/>
+                      <a:tailEnd type="none" w="med" len="med"/>
+                    </a:lnL>
+                    <a:lnR w="6350" cap="flat" cmpd="sng" algn="ctr">
+                      <a:solidFill>
+                        <a:srgbClr val="D8DFE9"/>
+                      </a:solidFill>
+                      <a:prstDash val="solid"/>
+                      <a:round/>
+                      <a:headEnd type="none" w="med" len="med"/>
+                      <a:tailEnd type="none" w="med" len="med"/>
+                    </a:lnR>
+                    <a:lnT w="6350" cap="flat" cmpd="sng" algn="ctr">
+                      <a:solidFill>
+                        <a:srgbClr val="D8DFE9"/>
+                      </a:solidFill>
+                      <a:prstDash val="solid"/>
+                      <a:round/>
+                      <a:headEnd type="none" w="med" len="med"/>
+                      <a:tailEnd type="none" w="med" len="med"/>
+                    </a:lnT>
+                    <a:lnB w="6350" cap="flat" cmpd="sng" algn="ctr">
+                      <a:solidFill>
+                        <a:srgbClr val="D8DFE9"/>
+                      </a:solidFill>
+                      <a:prstDash val="solid"/>
+                      <a:round/>
+                      <a:headEnd type="none" w="med" len="med"/>
+                      <a:tailEnd type="none" w="med" len="med"/>
+                    </a:lnB>
+                    <a:solidFill>
+                      <a:srgbClr val="FAEAEA"/>
+                    </a:solidFill>
+                  </a:tcPr>
+                </a:tc>
+                <a:tc>
+                  <a:txBody>
+                    <a:bodyPr/>
+                    <a:lstStyle/>
+                    <a:p>
+                      <a:pPr algn="ctr" indent="0" marL="0">
+                        <a:buNone/>
+                      </a:pPr>
+                      <a:r>
+                        <a:rPr lang="en-US" sz="950" b="1" dirty="0">
+                          <a:solidFill>
+                            <a:srgbClr val="16233D"/>
+                          </a:solidFill>
+                          <a:latin typeface="Graphik TH" pitchFamily="34" charset="0"/>
+                          <a:ea typeface="Graphik TH" pitchFamily="34" charset="-122"/>
+                          <a:cs typeface="Graphik TH" pitchFamily="34" charset="-120"/>
+                        </a:rPr>
+                        <a:t>+4.3</a:t>
+                      </a:r>
+                      <a:pPr algn="ctr" indent="0" marL="0">
+                        <a:buNone/>
+                      </a:pPr>
+                      <a:endParaRPr lang="en-US" sz="1200" dirty="0"/>
+                    </a:p>
+                    <a:p>
+                      <a:pPr algn="ctr" indent="0" marL="0">
+                        <a:buNone/>
+                      </a:pPr>
+                      <a:r>
+                        <a:rPr lang="en-US" sz="700" dirty="0">
+                          <a:solidFill>
+                            <a:srgbClr val="6B7A90"/>
+                          </a:solidFill>
+                          <a:latin typeface="Graphik TH" pitchFamily="34" charset="0"/>
+                          <a:ea typeface="Graphik TH" pitchFamily="34" charset="-122"/>
+                          <a:cs typeface="Graphik TH" pitchFamily="34" charset="-120"/>
+                        </a:rPr>
+                        <a:t>+6.3%</a:t>
+                      </a:r>
+                      <a:endParaRPr lang="en-US" sz="1200" dirty="0"/>
+                    </a:p>
+                  </a:txBody>
+                  <a:tcPr marL="36576" marR="36576" marT="9144" marB="9144" anchor="ctr">
+                    <a:lnL w="6350" cap="flat" cmpd="sng" algn="ctr">
+                      <a:solidFill>
+                        <a:srgbClr val="D8DFE9"/>
+                      </a:solidFill>
+                      <a:prstDash val="solid"/>
+                      <a:round/>
+                      <a:headEnd type="none" w="med" len="med"/>
+                      <a:tailEnd type="none" w="med" len="med"/>
+                    </a:lnL>
+                    <a:lnR w="6350" cap="flat" cmpd="sng" algn="ctr">
+                      <a:solidFill>
+                        <a:srgbClr val="D8DFE9"/>
+                      </a:solidFill>
+                      <a:prstDash val="solid"/>
+                      <a:round/>
+                      <a:headEnd type="none" w="med" len="med"/>
+                      <a:tailEnd type="none" w="med" len="med"/>
+                    </a:lnR>
+                    <a:lnT w="6350" cap="flat" cmpd="sng" algn="ctr">
+                      <a:solidFill>
+                        <a:srgbClr val="D8DFE9"/>
+                      </a:solidFill>
+                      <a:prstDash val="solid"/>
+                      <a:round/>
+                      <a:headEnd type="none" w="med" len="med"/>
+                      <a:tailEnd type="none" w="med" len="med"/>
+                    </a:lnT>
+                    <a:lnB w="6350" cap="flat" cmpd="sng" algn="ctr">
+                      <a:solidFill>
+                        <a:srgbClr val="D8DFE9"/>
+                      </a:solidFill>
+                      <a:prstDash val="solid"/>
+                      <a:round/>
+                      <a:headEnd type="none" w="med" len="med"/>
+                      <a:tailEnd type="none" w="med" len="med"/>
+                    </a:lnB>
+                    <a:solidFill>
+                      <a:srgbClr val="F5FAFA"/>
+                    </a:solidFill>
+                  </a:tcPr>
+                </a:tc>
+                <a:tc>
+                  <a:txBody>
+                    <a:bodyPr/>
+                    <a:lstStyle/>
+                    <a:p>
+                      <a:pPr algn="ctr" indent="0" marL="0">
+                        <a:buNone/>
+                      </a:pPr>
+                      <a:r>
+                        <a:rPr lang="en-US" sz="950" dirty="0">
+                          <a:solidFill>
+                            <a:srgbClr val="6B7A90"/>
+                          </a:solidFill>
+                          <a:latin typeface="Graphik TH" pitchFamily="34" charset="0"/>
+                          <a:ea typeface="Graphik TH" pitchFamily="34" charset="-122"/>
+                          <a:cs typeface="Graphik TH" pitchFamily="34" charset="-120"/>
+                        </a:rPr>
+                        <a:t>+0.0</a:t>
+                      </a:r>
+                      <a:pPr algn="ctr" indent="0" marL="0">
+                        <a:buNone/>
+                      </a:pPr>
+                      <a:endParaRPr lang="en-US" sz="1200" dirty="0"/>
+                    </a:p>
+                    <a:p>
+                      <a:pPr algn="ctr" indent="0" marL="0">
+                        <a:buNone/>
+                      </a:pPr>
+                      <a:r>
+                        <a:rPr lang="en-US" sz="700" dirty="0">
+                          <a:solidFill>
+                            <a:srgbClr val="6B7A90"/>
+                          </a:solidFill>
+                          <a:latin typeface="Graphik TH" pitchFamily="34" charset="0"/>
+                          <a:ea typeface="Graphik TH" pitchFamily="34" charset="-122"/>
+                          <a:cs typeface="Graphik TH" pitchFamily="34" charset="-120"/>
+                        </a:rPr>
+                        <a:t>n 2</a:t>
+                      </a:r>
+                      <a:endParaRPr lang="en-US" sz="1200" dirty="0"/>
+                    </a:p>
+                  </a:txBody>
+                  <a:tcPr marL="36576" marR="36576" marT="9144" marB="9144" anchor="ctr">
+                    <a:lnL w="6350" cap="flat" cmpd="sng" algn="ctr">
+                      <a:solidFill>
+                        <a:srgbClr val="D8DFE9"/>
+                      </a:solidFill>
+                      <a:prstDash val="solid"/>
+                      <a:round/>
+                      <a:headEnd type="none" w="med" len="med"/>
+                      <a:tailEnd type="none" w="med" len="med"/>
+                    </a:lnL>
+                    <a:lnR w="6350" cap="flat" cmpd="sng" algn="ctr">
+                      <a:solidFill>
+                        <a:srgbClr val="D8DFE9"/>
+                      </a:solidFill>
+                      <a:prstDash val="solid"/>
+                      <a:round/>
+                      <a:headEnd type="none" w="med" len="med"/>
+                      <a:tailEnd type="none" w="med" len="med"/>
+                    </a:lnR>
+                    <a:lnT w="6350" cap="flat" cmpd="sng" algn="ctr">
+                      <a:solidFill>
+                        <a:srgbClr val="D8DFE9"/>
+                      </a:solidFill>
+                      <a:prstDash val="solid"/>
+                      <a:round/>
+                      <a:headEnd type="none" w="med" len="med"/>
+                      <a:tailEnd type="none" w="med" len="med"/>
+                    </a:lnT>
+                    <a:lnB w="6350" cap="flat" cmpd="sng" algn="ctr">
+                      <a:solidFill>
+                        <a:srgbClr val="D8DFE9"/>
+                      </a:solidFill>
+                      <a:prstDash val="solid"/>
+                      <a:round/>
+                      <a:headEnd type="none" w="med" len="med"/>
+                      <a:tailEnd type="none" w="med" len="med"/>
+                    </a:lnB>
+                    <a:solidFill>
+                      <a:srgbClr val="FFFFFF"/>
+                    </a:solidFill>
+                  </a:tcPr>
+                </a:tc>
+                <a:tc>
+                  <a:txBody>
+                    <a:bodyPr/>
+                    <a:lstStyle/>
+                    <a:p>
+                      <a:pPr algn="ctr" indent="0" marL="0">
+                        <a:buNone/>
+                      </a:pPr>
+                      <a:r>
+                        <a:rPr lang="en-US" sz="950" b="1" dirty="0">
+                          <a:solidFill>
+                            <a:srgbClr val="16233D"/>
+                          </a:solidFill>
+                          <a:latin typeface="Graphik TH" pitchFamily="34" charset="0"/>
+                          <a:ea typeface="Graphik TH" pitchFamily="34" charset="-122"/>
+                          <a:cs typeface="Graphik TH" pitchFamily="34" charset="-120"/>
+                        </a:rPr>
+                        <a:t>+48.6</a:t>
+                      </a:r>
+                      <a:pPr algn="ctr" indent="0" marL="0">
+                        <a:buNone/>
+                      </a:pPr>
+                      <a:endParaRPr lang="en-US" sz="1200" dirty="0"/>
+                    </a:p>
+                    <a:p>
+                      <a:pPr algn="ctr" indent="0" marL="0">
+                        <a:buNone/>
+                      </a:pPr>
+                      <a:r>
+                        <a:rPr lang="en-US" sz="700" dirty="0">
+                          <a:solidFill>
+                            <a:srgbClr val="6B7A90"/>
+                          </a:solidFill>
+                          <a:latin typeface="Graphik TH" pitchFamily="34" charset="0"/>
+                          <a:ea typeface="Graphik TH" pitchFamily="34" charset="-122"/>
+                          <a:cs typeface="Graphik TH" pitchFamily="34" charset="-120"/>
+                        </a:rPr>
+                        <a:t>+10.5%</a:t>
+                      </a:r>
+                      <a:endParaRPr lang="en-US" sz="1200" dirty="0"/>
+                    </a:p>
+                  </a:txBody>
+                  <a:tcPr marL="36576" marR="36576" marT="9144" marB="9144" anchor="ctr">
+                    <a:lnL w="6350" cap="flat" cmpd="sng" algn="ctr">
+                      <a:solidFill>
+                        <a:srgbClr val="D8DFE9"/>
+                      </a:solidFill>
+                      <a:prstDash val="solid"/>
+                      <a:round/>
+                      <a:headEnd type="none" w="med" len="med"/>
+                      <a:tailEnd type="none" w="med" len="med"/>
+                    </a:lnL>
+                    <a:lnR w="6350" cap="flat" cmpd="sng" algn="ctr">
+                      <a:solidFill>
+                        <a:srgbClr val="D8DFE9"/>
+                      </a:solidFill>
+                      <a:prstDash val="solid"/>
+                      <a:round/>
+                      <a:headEnd type="none" w="med" len="med"/>
+                      <a:tailEnd type="none" w="med" len="med"/>
+                    </a:lnR>
+                    <a:lnT w="6350" cap="flat" cmpd="sng" algn="ctr">
+                      <a:solidFill>
+                        <a:srgbClr val="D8DFE9"/>
+                      </a:solidFill>
+                      <a:prstDash val="solid"/>
+                      <a:round/>
+                      <a:headEnd type="none" w="med" len="med"/>
+                      <a:tailEnd type="none" w="med" len="med"/>
+                    </a:lnT>
+                    <a:lnB w="6350" cap="flat" cmpd="sng" algn="ctr">
+                      <a:solidFill>
+                        <a:srgbClr val="D8DFE9"/>
+                      </a:solidFill>
+                      <a:prstDash val="solid"/>
+                      <a:round/>
+                      <a:headEnd type="none" w="med" len="med"/>
+                      <a:tailEnd type="none" w="med" len="med"/>
+                    </a:lnB>
+                    <a:solidFill>
+                      <a:srgbClr val="8BC5C1"/>
+                    </a:solidFill>
+                  </a:tcPr>
+                </a:tc>
+                <a:tc>
+                  <a:txBody>
+                    <a:bodyPr/>
+                    <a:lstStyle/>
+                    <a:p>
+                      <a:pPr algn="ctr" indent="0" marL="0">
+                        <a:buNone/>
+                      </a:pPr>
+                      <a:r>
+                        <a:rPr lang="en-US" sz="950" b="1" dirty="0">
+                          <a:solidFill>
+                            <a:srgbClr val="16233D"/>
+                          </a:solidFill>
+                          <a:latin typeface="Graphik TH" pitchFamily="34" charset="0"/>
+                          <a:ea typeface="Graphik TH" pitchFamily="34" charset="-122"/>
+                          <a:cs typeface="Graphik TH" pitchFamily="34" charset="-120"/>
+                        </a:rPr>
+                        <a:t>−10.3</a:t>
+                      </a:r>
+                      <a:pPr algn="ctr" indent="0" marL="0">
+                        <a:buNone/>
+                      </a:pPr>
+                      <a:endParaRPr lang="en-US" sz="1200" dirty="0"/>
+                    </a:p>
+                    <a:p>
+                      <a:pPr algn="ctr" indent="0" marL="0">
+                        <a:buNone/>
+                      </a:pPr>
+                      <a:r>
+                        <a:rPr lang="en-US" sz="700" dirty="0">
+                          <a:solidFill>
+                            <a:srgbClr val="6B7A90"/>
+                          </a:solidFill>
+                          <a:latin typeface="Graphik TH" pitchFamily="34" charset="0"/>
+                          <a:ea typeface="Graphik TH" pitchFamily="34" charset="-122"/>
+                          <a:cs typeface="Graphik TH" pitchFamily="34" charset="-120"/>
+                        </a:rPr>
+                        <a:t>−2.2%</a:t>
+                      </a:r>
+                      <a:endParaRPr lang="en-US" sz="1200" dirty="0"/>
+                    </a:p>
+                  </a:txBody>
+                  <a:tcPr marL="36576" marR="36576" marT="9144" marB="9144" anchor="ctr">
+                    <a:lnL w="6350" cap="flat" cmpd="sng" algn="ctr">
+                      <a:solidFill>
+                        <a:srgbClr val="D8DFE9"/>
+                      </a:solidFill>
+                      <a:prstDash val="solid"/>
+                      <a:round/>
+                      <a:headEnd type="none" w="med" len="med"/>
+                      <a:tailEnd type="none" w="med" len="med"/>
+                    </a:lnL>
+                    <a:lnR w="6350" cap="flat" cmpd="sng" algn="ctr">
+                      <a:solidFill>
+                        <a:srgbClr val="D8DFE9"/>
+                      </a:solidFill>
+                      <a:prstDash val="solid"/>
+                      <a:round/>
+                      <a:headEnd type="none" w="med" len="med"/>
+                      <a:tailEnd type="none" w="med" len="med"/>
+                    </a:lnR>
+                    <a:lnT w="6350" cap="flat" cmpd="sng" algn="ctr">
+                      <a:solidFill>
+                        <a:srgbClr val="D8DFE9"/>
+                      </a:solidFill>
+                      <a:prstDash val="solid"/>
+                      <a:round/>
+                      <a:headEnd type="none" w="med" len="med"/>
+                      <a:tailEnd type="none" w="med" len="med"/>
+                    </a:lnT>
+                    <a:lnB w="6350" cap="flat" cmpd="sng" algn="ctr">
+                      <a:solidFill>
+                        <a:srgbClr val="D8DFE9"/>
+                      </a:solidFill>
+                      <a:prstDash val="solid"/>
+                      <a:round/>
+                      <a:headEnd type="none" w="med" len="med"/>
+                      <a:tailEnd type="none" w="med" len="med"/>
+                    </a:lnB>
+                    <a:solidFill>
+                      <a:srgbClr val="F8E3E3"/>
+                    </a:solidFill>
+                  </a:tcPr>
+                </a:tc>
+              </a:tr>
+              <a:tr h="274320">
+                <a:tc>
+                  <a:txBody>
+                    <a:bodyPr/>
+                    <a:lstStyle/>
+                    <a:p>
+                      <a:pPr algn="l" indent="0" marL="0">
+                        <a:buNone/>
+                      </a:pPr>
+                      <a:r>
+                        <a:rPr lang="en-US" sz="950" b="1" dirty="0">
+                          <a:solidFill>
+                            <a:srgbClr val="16233D"/>
+                          </a:solidFill>
+                          <a:latin typeface="Graphik TH" pitchFamily="34" charset="0"/>
+                          <a:ea typeface="Graphik TH" pitchFamily="34" charset="-122"/>
+                          <a:cs typeface="Graphik TH" pitchFamily="34" charset="-120"/>
+                        </a:rPr>
+                        <a:t>High</a:t>
+                      </a:r>
+                      <a:endParaRPr lang="en-US" sz="950" dirty="0">
+                        <a:latin typeface="Graphik TH" charset="0"/>
+                        <a:ea typeface="Graphik TH" charset="0"/>
+                        <a:cs typeface="Graphik TH" charset="0"/>
+                      </a:endParaRPr>
+                    </a:p>
+                  </a:txBody>
+                  <a:tcPr marL="36576" marR="36576" marT="9144" marB="9144" anchor="ctr">
+                    <a:lnL w="6350" cap="flat" cmpd="sng" algn="ctr">
+                      <a:solidFill>
+                        <a:srgbClr val="D8DFE9"/>
+                      </a:solidFill>
+                      <a:prstDash val="solid"/>
+                      <a:round/>
+                      <a:headEnd type="none" w="med" len="med"/>
+                      <a:tailEnd type="none" w="med" len="med"/>
+                    </a:lnL>
+                    <a:lnR w="6350" cap="flat" cmpd="sng" algn="ctr">
+                      <a:solidFill>
+                        <a:srgbClr val="D8DFE9"/>
+                      </a:solidFill>
+                      <a:prstDash val="solid"/>
+                      <a:round/>
+                      <a:headEnd type="none" w="med" len="med"/>
+                      <a:tailEnd type="none" w="med" len="med"/>
+                    </a:lnR>
+                    <a:lnT w="6350" cap="flat" cmpd="sng" algn="ctr">
+                      <a:solidFill>
+                        <a:srgbClr val="D8DFE9"/>
+                      </a:solidFill>
+                      <a:prstDash val="solid"/>
+                      <a:round/>
+                      <a:headEnd type="none" w="med" len="med"/>
+                      <a:tailEnd type="none" w="med" len="med"/>
+                    </a:lnT>
+                    <a:lnB w="6350" cap="flat" cmpd="sng" algn="ctr">
+                      <a:solidFill>
+                        <a:srgbClr val="D8DFE9"/>
+                      </a:solidFill>
+                      <a:prstDash val="solid"/>
+                      <a:round/>
+                      <a:headEnd type="none" w="med" len="med"/>
+                      <a:tailEnd type="none" w="med" len="med"/>
+                    </a:lnB>
+                    <a:solidFill>
+                      <a:srgbClr val="F1F4F9"/>
+                    </a:solidFill>
+                  </a:tcPr>
+                </a:tc>
+                <a:tc>
+                  <a:txBody>
+                    <a:bodyPr/>
+                    <a:lstStyle/>
+                    <a:p>
+                      <a:pPr algn="ctr" indent="0" marL="0">
+                        <a:buNone/>
+                      </a:pPr>
+                      <a:r>
+                        <a:rPr lang="en-US" sz="950" b="1" dirty="0">
+                          <a:solidFill>
+                            <a:srgbClr val="16233D"/>
+                          </a:solidFill>
+                          <a:latin typeface="Graphik TH" pitchFamily="34" charset="0"/>
+                          <a:ea typeface="Graphik TH" pitchFamily="34" charset="-122"/>
+                          <a:cs typeface="Graphik TH" pitchFamily="34" charset="-120"/>
+                        </a:rPr>
+                        <a:t>−2.3</a:t>
+                      </a:r>
+                      <a:pPr algn="ctr" indent="0" marL="0">
+                        <a:buNone/>
+                      </a:pPr>
+                      <a:endParaRPr lang="en-US" sz="1200" dirty="0"/>
+                    </a:p>
+                    <a:p>
+                      <a:pPr algn="ctr" indent="0" marL="0">
+                        <a:buNone/>
+                      </a:pPr>
+                      <a:r>
+                        <a:rPr lang="en-US" sz="700" dirty="0">
+                          <a:solidFill>
+                            <a:srgbClr val="6B7A90"/>
+                          </a:solidFill>
+                          <a:latin typeface="Graphik TH" pitchFamily="34" charset="0"/>
+                          <a:ea typeface="Graphik TH" pitchFamily="34" charset="-122"/>
+                          <a:cs typeface="Graphik TH" pitchFamily="34" charset="-120"/>
+                        </a:rPr>
+                        <a:t>−3.1%</a:t>
+                      </a:r>
+                      <a:endParaRPr lang="en-US" sz="1200" dirty="0"/>
+                    </a:p>
+                  </a:txBody>
+                  <a:tcPr marL="36576" marR="36576" marT="9144" marB="9144" anchor="ctr">
+                    <a:lnL w="6350" cap="flat" cmpd="sng" algn="ctr">
+                      <a:solidFill>
+                        <a:srgbClr val="D8DFE9"/>
+                      </a:solidFill>
+                      <a:prstDash val="solid"/>
+                      <a:round/>
+                      <a:headEnd type="none" w="med" len="med"/>
+                      <a:tailEnd type="none" w="med" len="med"/>
+                    </a:lnL>
+                    <a:lnR w="6350" cap="flat" cmpd="sng" algn="ctr">
+                      <a:solidFill>
+                        <a:srgbClr val="D8DFE9"/>
+                      </a:solidFill>
+                      <a:prstDash val="solid"/>
+                      <a:round/>
+                      <a:headEnd type="none" w="med" len="med"/>
+                      <a:tailEnd type="none" w="med" len="med"/>
+                    </a:lnR>
+                    <a:lnT w="6350" cap="flat" cmpd="sng" algn="ctr">
+                      <a:solidFill>
+                        <a:srgbClr val="D8DFE9"/>
+                      </a:solidFill>
+                      <a:prstDash val="solid"/>
+                      <a:round/>
+                      <a:headEnd type="none" w="med" len="med"/>
+                      <a:tailEnd type="none" w="med" len="med"/>
+                    </a:lnT>
+                    <a:lnB w="6350" cap="flat" cmpd="sng" algn="ctr">
+                      <a:solidFill>
+                        <a:srgbClr val="D8DFE9"/>
+                      </a:solidFill>
+                      <a:prstDash val="solid"/>
+                      <a:round/>
+                      <a:headEnd type="none" w="med" len="med"/>
+                      <a:tailEnd type="none" w="med" len="med"/>
+                    </a:lnB>
+                    <a:solidFill>
+                      <a:srgbClr val="FDF9F9"/>
+                    </a:solidFill>
+                  </a:tcPr>
+                </a:tc>
+                <a:tc>
+                  <a:txBody>
+                    <a:bodyPr/>
+                    <a:lstStyle/>
+                    <a:p>
+                      <a:pPr algn="ctr" indent="0" marL="0">
+                        <a:buNone/>
+                      </a:pPr>
+                      <a:r>
+                        <a:rPr lang="en-US" sz="950" b="1" dirty="0">
+                          <a:solidFill>
+                            <a:srgbClr val="16233D"/>
+                          </a:solidFill>
+                          <a:latin typeface="Graphik TH" pitchFamily="34" charset="0"/>
+                          <a:ea typeface="Graphik TH" pitchFamily="34" charset="-122"/>
+                          <a:cs typeface="Graphik TH" pitchFamily="34" charset="-120"/>
+                        </a:rPr>
+                        <a:t>+4.8</a:t>
+                      </a:r>
+                      <a:pPr algn="ctr" indent="0" marL="0">
+                        <a:buNone/>
+                      </a:pPr>
+                      <a:endParaRPr lang="en-US" sz="1200" dirty="0"/>
+                    </a:p>
+                    <a:p>
+                      <a:pPr algn="ctr" indent="0" marL="0">
+                        <a:buNone/>
+                      </a:pPr>
+                      <a:r>
+                        <a:rPr lang="en-US" sz="700" dirty="0">
+                          <a:solidFill>
+                            <a:srgbClr val="6B7A90"/>
+                          </a:solidFill>
+                          <a:latin typeface="Graphik TH" pitchFamily="34" charset="0"/>
+                          <a:ea typeface="Graphik TH" pitchFamily="34" charset="-122"/>
+                          <a:cs typeface="Graphik TH" pitchFamily="34" charset="-120"/>
+                        </a:rPr>
+                        <a:t>+8.5%</a:t>
+                      </a:r>
+                      <a:endParaRPr lang="en-US" sz="1200" dirty="0"/>
+                    </a:p>
+                  </a:txBody>
+                  <a:tcPr marL="36576" marR="36576" marT="9144" marB="9144" anchor="ctr">
+                    <a:lnL w="6350" cap="flat" cmpd="sng" algn="ctr">
+                      <a:solidFill>
+                        <a:srgbClr val="D8DFE9"/>
+                      </a:solidFill>
+                      <a:prstDash val="solid"/>
+                      <a:round/>
+                      <a:headEnd type="none" w="med" len="med"/>
+                      <a:tailEnd type="none" w="med" len="med"/>
+                    </a:lnL>
+                    <a:lnR w="6350" cap="flat" cmpd="sng" algn="ctr">
+                      <a:solidFill>
+                        <a:srgbClr val="D8DFE9"/>
+                      </a:solidFill>
+                      <a:prstDash val="solid"/>
+                      <a:round/>
+                      <a:headEnd type="none" w="med" len="med"/>
+                      <a:tailEnd type="none" w="med" len="med"/>
+                    </a:lnR>
+                    <a:lnT w="6350" cap="flat" cmpd="sng" algn="ctr">
+                      <a:solidFill>
+                        <a:srgbClr val="D8DFE9"/>
+                      </a:solidFill>
+                      <a:prstDash val="solid"/>
+                      <a:round/>
+                      <a:headEnd type="none" w="med" len="med"/>
+                      <a:tailEnd type="none" w="med" len="med"/>
+                    </a:lnT>
+                    <a:lnB w="6350" cap="flat" cmpd="sng" algn="ctr">
+                      <a:solidFill>
+                        <a:srgbClr val="D8DFE9"/>
+                      </a:solidFill>
+                      <a:prstDash val="solid"/>
+                      <a:round/>
+                      <a:headEnd type="none" w="med" len="med"/>
+                      <a:tailEnd type="none" w="med" len="med"/>
+                    </a:lnB>
+                    <a:solidFill>
+                      <a:srgbClr val="F4F9F9"/>
+                    </a:solidFill>
+                  </a:tcPr>
+                </a:tc>
+                <a:tc>
+                  <a:txBody>
+                    <a:bodyPr/>
+                    <a:lstStyle/>
+                    <a:p>
+                      <a:pPr algn="ctr" indent="0" marL="0">
+                        <a:buNone/>
+                      </a:pPr>
+                      <a:r>
+                        <a:rPr lang="en-US" sz="950" dirty="0">
+                          <a:solidFill>
+                            <a:srgbClr val="6B7A90"/>
+                          </a:solidFill>
+                          <a:latin typeface="Graphik TH" pitchFamily="34" charset="0"/>
+                          <a:ea typeface="Graphik TH" pitchFamily="34" charset="-122"/>
+                          <a:cs typeface="Graphik TH" pitchFamily="34" charset="-120"/>
+                        </a:rPr>
+                        <a:t>−1.2</a:t>
+                      </a:r>
+                      <a:pPr algn="ctr" indent="0" marL="0">
+                        <a:buNone/>
+                      </a:pPr>
+                      <a:endParaRPr lang="en-US" sz="1200" dirty="0"/>
+                    </a:p>
+                    <a:p>
+                      <a:pPr algn="ctr" indent="0" marL="0">
+                        <a:buNone/>
+                      </a:pPr>
+                      <a:r>
+                        <a:rPr lang="en-US" sz="700" dirty="0">
+                          <a:solidFill>
+                            <a:srgbClr val="6B7A90"/>
+                          </a:solidFill>
+                          <a:latin typeface="Graphik TH" pitchFamily="34" charset="0"/>
+                          <a:ea typeface="Graphik TH" pitchFamily="34" charset="-122"/>
+                          <a:cs typeface="Graphik TH" pitchFamily="34" charset="-120"/>
+                        </a:rPr>
+                        <a:t>n 2</a:t>
+                      </a:r>
+                      <a:endParaRPr lang="en-US" sz="1200" dirty="0"/>
+                    </a:p>
+                  </a:txBody>
+                  <a:tcPr marL="36576" marR="36576" marT="9144" marB="9144" anchor="ctr">
+                    <a:lnL w="6350" cap="flat" cmpd="sng" algn="ctr">
+                      <a:solidFill>
+                        <a:srgbClr val="D8DFE9"/>
+                      </a:solidFill>
+                      <a:prstDash val="solid"/>
+                      <a:round/>
+                      <a:headEnd type="none" w="med" len="med"/>
+                      <a:tailEnd type="none" w="med" len="med"/>
+                    </a:lnL>
+                    <a:lnR w="6350" cap="flat" cmpd="sng" algn="ctr">
+                      <a:solidFill>
+                        <a:srgbClr val="D8DFE9"/>
+                      </a:solidFill>
+                      <a:prstDash val="solid"/>
+                      <a:round/>
+                      <a:headEnd type="none" w="med" len="med"/>
+                      <a:tailEnd type="none" w="med" len="med"/>
+                    </a:lnR>
+                    <a:lnT w="6350" cap="flat" cmpd="sng" algn="ctr">
+                      <a:solidFill>
+                        <a:srgbClr val="D8DFE9"/>
+                      </a:solidFill>
+                      <a:prstDash val="solid"/>
+                      <a:round/>
+                      <a:headEnd type="none" w="med" len="med"/>
+                      <a:tailEnd type="none" w="med" len="med"/>
+                    </a:lnT>
+                    <a:lnB w="6350" cap="flat" cmpd="sng" algn="ctr">
+                      <a:solidFill>
+                        <a:srgbClr val="D8DFE9"/>
+                      </a:solidFill>
+                      <a:prstDash val="solid"/>
+                      <a:round/>
+                      <a:headEnd type="none" w="med" len="med"/>
+                      <a:tailEnd type="none" w="med" len="med"/>
+                    </a:lnB>
+                    <a:solidFill>
+                      <a:srgbClr val="FFFFFF"/>
+                    </a:solidFill>
+                  </a:tcPr>
+                </a:tc>
+                <a:tc>
+                  <a:txBody>
+                    <a:bodyPr/>
+                    <a:lstStyle/>
+                    <a:p>
+                      <a:pPr algn="ctr" indent="0" marL="0">
+                        <a:buNone/>
+                      </a:pPr>
+                      <a:r>
+                        <a:rPr lang="en-US" sz="950" b="1" dirty="0">
+                          <a:solidFill>
+                            <a:srgbClr val="FFFFFF"/>
+                          </a:solidFill>
+                          <a:latin typeface="Graphik TH" pitchFamily="34" charset="0"/>
+                          <a:ea typeface="Graphik TH" pitchFamily="34" charset="-122"/>
+                          <a:cs typeface="Graphik TH" pitchFamily="34" charset="-120"/>
+                        </a:rPr>
+                        <a:t>+94.2</a:t>
+                      </a:r>
+                      <a:pPr algn="ctr" indent="0" marL="0">
+                        <a:buNone/>
+                      </a:pPr>
+                      <a:endParaRPr lang="en-US" sz="1200" dirty="0"/>
+                    </a:p>
+                    <a:p>
+                      <a:pPr algn="ctr" indent="0" marL="0">
+                        <a:buNone/>
+                      </a:pPr>
+                      <a:r>
+                        <a:rPr lang="en-US" sz="700" dirty="0">
+                          <a:solidFill>
+                            <a:srgbClr val="E6EFEC"/>
+                          </a:solidFill>
+                          <a:latin typeface="Graphik TH" pitchFamily="34" charset="0"/>
+                          <a:ea typeface="Graphik TH" pitchFamily="34" charset="-122"/>
+                          <a:cs typeface="Graphik TH" pitchFamily="34" charset="-120"/>
+                        </a:rPr>
+                        <a:t>+13.6%</a:t>
+                      </a:r>
+                      <a:endParaRPr lang="en-US" sz="1200" dirty="0"/>
+                    </a:p>
+                  </a:txBody>
+                  <a:tcPr marL="36576" marR="36576" marT="9144" marB="9144" anchor="ctr">
+                    <a:lnL w="6350" cap="flat" cmpd="sng" algn="ctr">
+                      <a:solidFill>
+                        <a:srgbClr val="D8DFE9"/>
+                      </a:solidFill>
+                      <a:prstDash val="solid"/>
+                      <a:round/>
+                      <a:headEnd type="none" w="med" len="med"/>
+                      <a:tailEnd type="none" w="med" len="med"/>
+                    </a:lnL>
+                    <a:lnR w="6350" cap="flat" cmpd="sng" algn="ctr">
+                      <a:solidFill>
+                        <a:srgbClr val="D8DFE9"/>
+                      </a:solidFill>
+                      <a:prstDash val="solid"/>
+                      <a:round/>
+                      <a:headEnd type="none" w="med" len="med"/>
+                      <a:tailEnd type="none" w="med" len="med"/>
+                    </a:lnR>
+                    <a:lnT w="6350" cap="flat" cmpd="sng" algn="ctr">
+                      <a:solidFill>
+                        <a:srgbClr val="D8DFE9"/>
+                      </a:solidFill>
+                      <a:prstDash val="solid"/>
+                      <a:round/>
+                      <a:headEnd type="none" w="med" len="med"/>
+                      <a:tailEnd type="none" w="med" len="med"/>
+                    </a:lnT>
+                    <a:lnB w="6350" cap="flat" cmpd="sng" algn="ctr">
+                      <a:solidFill>
+                        <a:srgbClr val="D8DFE9"/>
+                      </a:solidFill>
+                      <a:prstDash val="solid"/>
+                      <a:round/>
+                      <a:headEnd type="none" w="med" len="med"/>
+                      <a:tailEnd type="none" w="med" len="med"/>
+                    </a:lnB>
+                    <a:solidFill>
+                      <a:srgbClr val="1E8E86"/>
+                    </a:solidFill>
+                  </a:tcPr>
+                </a:tc>
+                <a:tc>
+                  <a:txBody>
+                    <a:bodyPr/>
+                    <a:lstStyle/>
+                    <a:p>
+                      <a:pPr algn="ctr" indent="0" marL="0">
+                        <a:buNone/>
+                      </a:pPr>
+                      <a:r>
+                        <a:rPr lang="en-US" sz="950" b="1" dirty="0">
+                          <a:solidFill>
+                            <a:srgbClr val="16233D"/>
+                          </a:solidFill>
+                          <a:latin typeface="Graphik TH" pitchFamily="34" charset="0"/>
+                          <a:ea typeface="Graphik TH" pitchFamily="34" charset="-122"/>
+                          <a:cs typeface="Graphik TH" pitchFamily="34" charset="-120"/>
+                        </a:rPr>
+                        <a:t>−24.1</a:t>
+                      </a:r>
+                      <a:pPr algn="ctr" indent="0" marL="0">
+                        <a:buNone/>
+                      </a:pPr>
+                      <a:endParaRPr lang="en-US" sz="1200" dirty="0"/>
+                    </a:p>
+                    <a:p>
+                      <a:pPr algn="ctr" indent="0" marL="0">
+                        <a:buNone/>
+                      </a:pPr>
+                      <a:r>
+                        <a:rPr lang="en-US" sz="700" dirty="0">
+                          <a:solidFill>
+                            <a:srgbClr val="6B7A90"/>
+                          </a:solidFill>
+                          <a:latin typeface="Graphik TH" pitchFamily="34" charset="0"/>
+                          <a:ea typeface="Graphik TH" pitchFamily="34" charset="-122"/>
+                          <a:cs typeface="Graphik TH" pitchFamily="34" charset="-120"/>
+                        </a:rPr>
+                        <a:t>−2.5%</a:t>
+                      </a:r>
+                      <a:endParaRPr lang="en-US" sz="1200" dirty="0"/>
+                    </a:p>
+                  </a:txBody>
+                  <a:tcPr marL="36576" marR="36576" marT="9144" marB="9144" anchor="ctr">
+                    <a:lnL w="6350" cap="flat" cmpd="sng" algn="ctr">
+                      <a:solidFill>
+                        <a:srgbClr val="D8DFE9"/>
+                      </a:solidFill>
+                      <a:prstDash val="solid"/>
+                      <a:round/>
+                      <a:headEnd type="none" w="med" len="med"/>
+                      <a:tailEnd type="none" w="med" len="med"/>
+                    </a:lnL>
+                    <a:lnR w="6350" cap="flat" cmpd="sng" algn="ctr">
+                      <a:solidFill>
+                        <a:srgbClr val="D8DFE9"/>
+                      </a:solidFill>
+                      <a:prstDash val="solid"/>
+                      <a:round/>
+                      <a:headEnd type="none" w="med" len="med"/>
+                      <a:tailEnd type="none" w="med" len="med"/>
+                    </a:lnR>
+                    <a:lnT w="6350" cap="flat" cmpd="sng" algn="ctr">
+                      <a:solidFill>
+                        <a:srgbClr val="D8DFE9"/>
+                      </a:solidFill>
+                      <a:prstDash val="solid"/>
+                      <a:round/>
+                      <a:headEnd type="none" w="med" len="med"/>
+                      <a:tailEnd type="none" w="med" len="med"/>
+                    </a:lnT>
+                    <a:lnB w="6350" cap="flat" cmpd="sng" algn="ctr">
+                      <a:solidFill>
+                        <a:srgbClr val="D8DFE9"/>
+                      </a:solidFill>
+                      <a:prstDash val="solid"/>
+                      <a:round/>
+                      <a:headEnd type="none" w="med" len="med"/>
+                      <a:tailEnd type="none" w="med" len="med"/>
+                    </a:lnB>
+                    <a:solidFill>
+                      <a:srgbClr val="EFBEBE"/>
+                    </a:solidFill>
+                  </a:tcPr>
+                </a:tc>
+              </a:tr>
+              <a:tr h="274320">
+                <a:tc>
+                  <a:txBody>
+                    <a:bodyPr/>
+                    <a:lstStyle/>
+                    <a:p>
+                      <a:pPr algn="l" indent="0" marL="0">
+                        <a:buNone/>
+                      </a:pPr>
+                      <a:r>
+                        <a:rPr lang="en-US" sz="950" b="1" dirty="0">
+                          <a:solidFill>
+                            <a:srgbClr val="16233D"/>
+                          </a:solidFill>
+                          <a:latin typeface="Graphik TH" pitchFamily="34" charset="0"/>
+                          <a:ea typeface="Graphik TH" pitchFamily="34" charset="-122"/>
+                          <a:cs typeface="Graphik TH" pitchFamily="34" charset="-120"/>
+                        </a:rPr>
+                        <a:t>Medium</a:t>
+                      </a:r>
+                      <a:endParaRPr lang="en-US" sz="950" dirty="0">
+                        <a:latin typeface="Graphik TH" charset="0"/>
+                        <a:ea typeface="Graphik TH" charset="0"/>
+                        <a:cs typeface="Graphik TH" charset="0"/>
+                      </a:endParaRPr>
+                    </a:p>
+                  </a:txBody>
+                  <a:tcPr marL="36576" marR="36576" marT="9144" marB="9144" anchor="ctr">
+                    <a:lnL w="6350" cap="flat" cmpd="sng" algn="ctr">
+                      <a:solidFill>
+                        <a:srgbClr val="D8DFE9"/>
+                      </a:solidFill>
+                      <a:prstDash val="solid"/>
+                      <a:round/>
+                      <a:headEnd type="none" w="med" len="med"/>
+                      <a:tailEnd type="none" w="med" len="med"/>
+                    </a:lnL>
+                    <a:lnR w="6350" cap="flat" cmpd="sng" algn="ctr">
+                      <a:solidFill>
+                        <a:srgbClr val="D8DFE9"/>
+                      </a:solidFill>
+                      <a:prstDash val="solid"/>
+                      <a:round/>
+                      <a:headEnd type="none" w="med" len="med"/>
+                      <a:tailEnd type="none" w="med" len="med"/>
+                    </a:lnR>
+                    <a:lnT w="6350" cap="flat" cmpd="sng" algn="ctr">
+                      <a:solidFill>
+                        <a:srgbClr val="D8DFE9"/>
+                      </a:solidFill>
+                      <a:prstDash val="solid"/>
+                      <a:round/>
+                      <a:headEnd type="none" w="med" len="med"/>
+                      <a:tailEnd type="none" w="med" len="med"/>
+                    </a:lnT>
+                    <a:lnB w="6350" cap="flat" cmpd="sng" algn="ctr">
+                      <a:solidFill>
+                        <a:srgbClr val="D8DFE9"/>
+                      </a:solidFill>
+                      <a:prstDash val="solid"/>
+                      <a:round/>
+                      <a:headEnd type="none" w="med" len="med"/>
+                      <a:tailEnd type="none" w="med" len="med"/>
+                    </a:lnB>
+                    <a:solidFill>
+                      <a:srgbClr val="F1F4F9"/>
+                    </a:solidFill>
+                  </a:tcPr>
+                </a:tc>
+                <a:tc>
+                  <a:txBody>
+                    <a:bodyPr/>
+                    <a:lstStyle/>
+                    <a:p>
+                      <a:pPr algn="ctr" indent="0" marL="0">
+                        <a:buNone/>
+                      </a:pPr>
+                      <a:r>
+                        <a:rPr lang="en-US" sz="950" dirty="0">
+                          <a:solidFill>
+                            <a:srgbClr val="6B7A90"/>
+                          </a:solidFill>
+                          <a:latin typeface="Graphik TH" pitchFamily="34" charset="0"/>
+                          <a:ea typeface="Graphik TH" pitchFamily="34" charset="-122"/>
+                          <a:cs typeface="Graphik TH" pitchFamily="34" charset="-120"/>
+                        </a:rPr>
+                        <a:t>−0.9</a:t>
+                      </a:r>
+                      <a:pPr algn="ctr" indent="0" marL="0">
+                        <a:buNone/>
+                      </a:pPr>
+                      <a:endParaRPr lang="en-US" sz="1200" dirty="0"/>
+                    </a:p>
+                    <a:p>
+                      <a:pPr algn="ctr" indent="0" marL="0">
+                        <a:buNone/>
+                      </a:pPr>
+                      <a:r>
+                        <a:rPr lang="en-US" sz="700" dirty="0">
+                          <a:solidFill>
+                            <a:srgbClr val="6B7A90"/>
+                          </a:solidFill>
+                          <a:latin typeface="Graphik TH" pitchFamily="34" charset="0"/>
+                          <a:ea typeface="Graphik TH" pitchFamily="34" charset="-122"/>
+                          <a:cs typeface="Graphik TH" pitchFamily="34" charset="-120"/>
+                        </a:rPr>
+                        <a:t>n 31</a:t>
+                      </a:r>
+                      <a:endParaRPr lang="en-US" sz="1200" dirty="0"/>
+                    </a:p>
+                  </a:txBody>
+                  <a:tcPr marL="36576" marR="36576" marT="9144" marB="9144" anchor="ctr">
+                    <a:lnL w="6350" cap="flat" cmpd="sng" algn="ctr">
+                      <a:solidFill>
+                        <a:srgbClr val="D8DFE9"/>
+                      </a:solidFill>
+                      <a:prstDash val="solid"/>
+                      <a:round/>
+                      <a:headEnd type="none" w="med" len="med"/>
+                      <a:tailEnd type="none" w="med" len="med"/>
+                    </a:lnL>
+                    <a:lnR w="6350" cap="flat" cmpd="sng" algn="ctr">
+                      <a:solidFill>
+                        <a:srgbClr val="D8DFE9"/>
+                      </a:solidFill>
+                      <a:prstDash val="solid"/>
+                      <a:round/>
+                      <a:headEnd type="none" w="med" len="med"/>
+                      <a:tailEnd type="none" w="med" len="med"/>
+                    </a:lnR>
+                    <a:lnT w="6350" cap="flat" cmpd="sng" algn="ctr">
+                      <a:solidFill>
+                        <a:srgbClr val="D8DFE9"/>
+                      </a:solidFill>
+                      <a:prstDash val="solid"/>
+                      <a:round/>
+                      <a:headEnd type="none" w="med" len="med"/>
+                      <a:tailEnd type="none" w="med" len="med"/>
+                    </a:lnT>
+                    <a:lnB w="6350" cap="flat" cmpd="sng" algn="ctr">
+                      <a:solidFill>
+                        <a:srgbClr val="D8DFE9"/>
+                      </a:solidFill>
+                      <a:prstDash val="solid"/>
+                      <a:round/>
+                      <a:headEnd type="none" w="med" len="med"/>
+                      <a:tailEnd type="none" w="med" len="med"/>
+                    </a:lnB>
+                    <a:solidFill>
+                      <a:srgbClr val="FFFFFF"/>
+                    </a:solidFill>
+                  </a:tcPr>
+                </a:tc>
+                <a:tc>
+                  <a:txBody>
+                    <a:bodyPr/>
+                    <a:lstStyle/>
+                    <a:p>
+                      <a:pPr algn="ctr" indent="0" marL="0">
+                        <a:buNone/>
+                      </a:pPr>
+                      <a:r>
+                        <a:rPr lang="en-US" sz="950" b="1" dirty="0">
+                          <a:solidFill>
+                            <a:srgbClr val="16233D"/>
+                          </a:solidFill>
+                          <a:latin typeface="Graphik TH" pitchFamily="34" charset="0"/>
+                          <a:ea typeface="Graphik TH" pitchFamily="34" charset="-122"/>
+                          <a:cs typeface="Graphik TH" pitchFamily="34" charset="-120"/>
+                        </a:rPr>
+                        <a:t>+3.4</a:t>
+                      </a:r>
+                      <a:pPr algn="ctr" indent="0" marL="0">
+                        <a:buNone/>
+                      </a:pPr>
+                      <a:endParaRPr lang="en-US" sz="1200" dirty="0"/>
+                    </a:p>
+                    <a:p>
+                      <a:pPr algn="ctr" indent="0" marL="0">
+                        <a:buNone/>
+                      </a:pPr>
+                      <a:r>
+                        <a:rPr lang="en-US" sz="700" dirty="0">
+                          <a:solidFill>
+                            <a:srgbClr val="6B7A90"/>
+                          </a:solidFill>
+                          <a:latin typeface="Graphik TH" pitchFamily="34" charset="0"/>
+                          <a:ea typeface="Graphik TH" pitchFamily="34" charset="-122"/>
+                          <a:cs typeface="Graphik TH" pitchFamily="34" charset="-120"/>
+                        </a:rPr>
+                        <a:t>n 4,791</a:t>
+                      </a:r>
+                      <a:endParaRPr lang="en-US" sz="1200" dirty="0"/>
+                    </a:p>
+                  </a:txBody>
+                  <a:tcPr marL="36576" marR="36576" marT="9144" marB="9144" anchor="ctr">
+                    <a:lnL w="6350" cap="flat" cmpd="sng" algn="ctr">
+                      <a:solidFill>
+                        <a:srgbClr val="D8DFE9"/>
+                      </a:solidFill>
+                      <a:prstDash val="solid"/>
+                      <a:round/>
+                      <a:headEnd type="none" w="med" len="med"/>
+                      <a:tailEnd type="none" w="med" len="med"/>
+                    </a:lnL>
+                    <a:lnR w="6350" cap="flat" cmpd="sng" algn="ctr">
+                      <a:solidFill>
+                        <a:srgbClr val="D8DFE9"/>
+                      </a:solidFill>
+                      <a:prstDash val="solid"/>
+                      <a:round/>
+                      <a:headEnd type="none" w="med" len="med"/>
+                      <a:tailEnd type="none" w="med" len="med"/>
+                    </a:lnR>
+                    <a:lnT w="6350" cap="flat" cmpd="sng" algn="ctr">
+                      <a:solidFill>
+                        <a:srgbClr val="D8DFE9"/>
+                      </a:solidFill>
+                      <a:prstDash val="solid"/>
+                      <a:round/>
+                      <a:headEnd type="none" w="med" len="med"/>
+                      <a:tailEnd type="none" w="med" len="med"/>
+                    </a:lnT>
+                    <a:lnB w="6350" cap="flat" cmpd="sng" algn="ctr">
+                      <a:solidFill>
+                        <a:srgbClr val="D8DFE9"/>
+                      </a:solidFill>
+                      <a:prstDash val="solid"/>
+                      <a:round/>
+                      <a:headEnd type="none" w="med" len="med"/>
+                      <a:tailEnd type="none" w="med" len="med"/>
+                    </a:lnB>
+                    <a:solidFill>
+                      <a:srgbClr val="F7FBFB"/>
+                    </a:solidFill>
+                  </a:tcPr>
+                </a:tc>
+                <a:tc>
+                  <a:txBody>
+                    <a:bodyPr/>
+                    <a:lstStyle/>
+                    <a:p>
+                      <a:pPr algn="ctr" indent="0" marL="0">
+                        <a:buNone/>
+                      </a:pPr>
+                      <a:r>
+                        <a:rPr lang="en-US" sz="900" dirty="0">
+                          <a:solidFill>
+                            <a:srgbClr val="6B7A90"/>
+                          </a:solidFill>
+                          <a:latin typeface="Graphik TH" pitchFamily="34" charset="0"/>
+                          <a:ea typeface="Graphik TH" pitchFamily="34" charset="-122"/>
+                          <a:cs typeface="Graphik TH" pitchFamily="34" charset="-120"/>
+                        </a:rPr>
+                        <a:t>—</a:t>
+                      </a:r>
+                      <a:endParaRPr lang="en-US" sz="900" dirty="0">
+                        <a:latin typeface="Graphik TH" charset="0"/>
+                        <a:ea typeface="Graphik TH" charset="0"/>
+                        <a:cs typeface="Graphik TH" charset="0"/>
+                      </a:endParaRPr>
+                    </a:p>
+                  </a:txBody>
+                  <a:tcPr marL="36576" marR="36576" marT="9144" marB="9144" anchor="ctr">
+                    <a:lnL w="6350" cap="flat" cmpd="sng" algn="ctr">
+                      <a:solidFill>
+                        <a:srgbClr val="D8DFE9"/>
+                      </a:solidFill>
+                      <a:prstDash val="solid"/>
+                      <a:round/>
+                      <a:headEnd type="none" w="med" len="med"/>
+                      <a:tailEnd type="none" w="med" len="med"/>
+                    </a:lnL>
+                    <a:lnR w="6350" cap="flat" cmpd="sng" algn="ctr">
+                      <a:solidFill>
+                        <a:srgbClr val="D8DFE9"/>
+                      </a:solidFill>
+                      <a:prstDash val="solid"/>
+                      <a:round/>
+                      <a:headEnd type="none" w="med" len="med"/>
+                      <a:tailEnd type="none" w="med" len="med"/>
+                    </a:lnR>
+                    <a:lnT w="6350" cap="flat" cmpd="sng" algn="ctr">
+                      <a:solidFill>
+                        <a:srgbClr val="D8DFE9"/>
+                      </a:solidFill>
+                      <a:prstDash val="solid"/>
+                      <a:round/>
+                      <a:headEnd type="none" w="med" len="med"/>
+                      <a:tailEnd type="none" w="med" len="med"/>
+                    </a:lnT>
+                    <a:lnB w="6350" cap="flat" cmpd="sng" algn="ctr">
+                      <a:solidFill>
+                        <a:srgbClr val="D8DFE9"/>
+                      </a:solidFill>
+                      <a:prstDash val="solid"/>
+                      <a:round/>
+                      <a:headEnd type="none" w="med" len="med"/>
+                      <a:tailEnd type="none" w="med" len="med"/>
+                    </a:lnB>
+                    <a:solidFill>
+                      <a:srgbClr val="FFFFFF"/>
+                    </a:solidFill>
+                  </a:tcPr>
+                </a:tc>
+                <a:tc>
+                  <a:txBody>
+                    <a:bodyPr/>
+                    <a:lstStyle/>
+                    <a:p>
+                      <a:pPr algn="ctr" indent="0" marL="0">
+                        <a:buNone/>
+                      </a:pPr>
+                      <a:r>
+                        <a:rPr lang="en-US" sz="950" dirty="0">
+                          <a:solidFill>
+                            <a:srgbClr val="6B7A90"/>
+                          </a:solidFill>
+                          <a:latin typeface="Graphik TH" pitchFamily="34" charset="0"/>
+                          <a:ea typeface="Graphik TH" pitchFamily="34" charset="-122"/>
+                          <a:cs typeface="Graphik TH" pitchFamily="34" charset="-120"/>
+                        </a:rPr>
+                        <a:t>+1.9</a:t>
+                      </a:r>
+                      <a:pPr algn="ctr" indent="0" marL="0">
+                        <a:buNone/>
+                      </a:pPr>
+                      <a:endParaRPr lang="en-US" sz="1200" dirty="0"/>
+                    </a:p>
+                    <a:p>
+                      <a:pPr algn="ctr" indent="0" marL="0">
+                        <a:buNone/>
+                      </a:pPr>
+                      <a:r>
+                        <a:rPr lang="en-US" sz="700" dirty="0">
+                          <a:solidFill>
+                            <a:srgbClr val="6B7A90"/>
+                          </a:solidFill>
+                          <a:latin typeface="Graphik TH" pitchFamily="34" charset="0"/>
+                          <a:ea typeface="Graphik TH" pitchFamily="34" charset="-122"/>
+                          <a:cs typeface="Graphik TH" pitchFamily="34" charset="-120"/>
+                        </a:rPr>
+                        <a:t>+16.8%</a:t>
+                      </a:r>
+                      <a:endParaRPr lang="en-US" sz="1200" dirty="0"/>
+                    </a:p>
+                  </a:txBody>
+                  <a:tcPr marL="36576" marR="36576" marT="9144" marB="9144" anchor="ctr">
+                    <a:lnL w="6350" cap="flat" cmpd="sng" algn="ctr">
+                      <a:solidFill>
+                        <a:srgbClr val="D8DFE9"/>
+                      </a:solidFill>
+                      <a:prstDash val="solid"/>
+                      <a:round/>
+                      <a:headEnd type="none" w="med" len="med"/>
+                      <a:tailEnd type="none" w="med" len="med"/>
+                    </a:lnL>
+                    <a:lnR w="6350" cap="flat" cmpd="sng" algn="ctr">
+                      <a:solidFill>
+                        <a:srgbClr val="D8DFE9"/>
+                      </a:solidFill>
+                      <a:prstDash val="solid"/>
+                      <a:round/>
+                      <a:headEnd type="none" w="med" len="med"/>
+                      <a:tailEnd type="none" w="med" len="med"/>
+                    </a:lnR>
+                    <a:lnT w="6350" cap="flat" cmpd="sng" algn="ctr">
+                      <a:solidFill>
+                        <a:srgbClr val="D8DFE9"/>
+                      </a:solidFill>
+                      <a:prstDash val="solid"/>
+                      <a:round/>
+                      <a:headEnd type="none" w="med" len="med"/>
+                      <a:tailEnd type="none" w="med" len="med"/>
+                    </a:lnT>
+                    <a:lnB w="6350" cap="flat" cmpd="sng" algn="ctr">
+                      <a:solidFill>
+                        <a:srgbClr val="D8DFE9"/>
+                      </a:solidFill>
+                      <a:prstDash val="solid"/>
+                      <a:round/>
+                      <a:headEnd type="none" w="med" len="med"/>
+                      <a:tailEnd type="none" w="med" len="med"/>
+                    </a:lnB>
+                    <a:solidFill>
+                      <a:srgbClr val="FFFFFF"/>
+                    </a:solidFill>
+                  </a:tcPr>
+                </a:tc>
+                <a:tc>
+                  <a:txBody>
+                    <a:bodyPr/>
+                    <a:lstStyle/>
+                    <a:p>
+                      <a:pPr algn="ctr" indent="0" marL="0">
+                        <a:buNone/>
+                      </a:pPr>
+                      <a:r>
+                        <a:rPr lang="en-US" sz="950" b="1" dirty="0">
+                          <a:solidFill>
+                            <a:srgbClr val="16233D"/>
+                          </a:solidFill>
+                          <a:latin typeface="Graphik TH" pitchFamily="34" charset="0"/>
+                          <a:ea typeface="Graphik TH" pitchFamily="34" charset="-122"/>
+                          <a:cs typeface="Graphik TH" pitchFamily="34" charset="-120"/>
+                        </a:rPr>
+                        <a:t>−1.5</a:t>
+                      </a:r>
+                      <a:pPr algn="ctr" indent="0" marL="0">
+                        <a:buNone/>
+                      </a:pPr>
+                      <a:endParaRPr lang="en-US" sz="1200" dirty="0"/>
+                    </a:p>
+                    <a:p>
+                      <a:pPr algn="ctr" indent="0" marL="0">
+                        <a:buNone/>
+                      </a:pPr>
+                      <a:r>
+                        <a:rPr lang="en-US" sz="700" dirty="0">
+                          <a:solidFill>
+                            <a:srgbClr val="6B7A90"/>
+                          </a:solidFill>
+                          <a:latin typeface="Graphik TH" pitchFamily="34" charset="0"/>
+                          <a:ea typeface="Graphik TH" pitchFamily="34" charset="-122"/>
+                          <a:cs typeface="Graphik TH" pitchFamily="34" charset="-120"/>
+                        </a:rPr>
+                        <a:t>−9.9%</a:t>
+                      </a:r>
+                      <a:endParaRPr lang="en-US" sz="1200" dirty="0"/>
+                    </a:p>
+                  </a:txBody>
+                  <a:tcPr marL="36576" marR="36576" marT="9144" marB="9144" anchor="ctr">
+                    <a:lnL w="6350" cap="flat" cmpd="sng" algn="ctr">
+                      <a:solidFill>
+                        <a:srgbClr val="D8DFE9"/>
+                      </a:solidFill>
+                      <a:prstDash val="solid"/>
+                      <a:round/>
+                      <a:headEnd type="none" w="med" len="med"/>
+                      <a:tailEnd type="none" w="med" len="med"/>
+                    </a:lnL>
+                    <a:lnR w="6350" cap="flat" cmpd="sng" algn="ctr">
+                      <a:solidFill>
+                        <a:srgbClr val="D8DFE9"/>
+                      </a:solidFill>
+                      <a:prstDash val="solid"/>
+                      <a:round/>
+                      <a:headEnd type="none" w="med" len="med"/>
+                      <a:tailEnd type="none" w="med" len="med"/>
+                    </a:lnR>
+                    <a:lnT w="6350" cap="flat" cmpd="sng" algn="ctr">
+                      <a:solidFill>
+                        <a:srgbClr val="D8DFE9"/>
+                      </a:solidFill>
+                      <a:prstDash val="solid"/>
+                      <a:round/>
+                      <a:headEnd type="none" w="med" len="med"/>
+                      <a:tailEnd type="none" w="med" len="med"/>
+                    </a:lnT>
+                    <a:lnB w="6350" cap="flat" cmpd="sng" algn="ctr">
+                      <a:solidFill>
+                        <a:srgbClr val="D8DFE9"/>
+                      </a:solidFill>
+                      <a:prstDash val="solid"/>
+                      <a:round/>
+                      <a:headEnd type="none" w="med" len="med"/>
+                      <a:tailEnd type="none" w="med" len="med"/>
+                    </a:lnB>
+                    <a:solidFill>
+                      <a:srgbClr val="FEFBFB"/>
+                    </a:solidFill>
+                  </a:tcPr>
+                </a:tc>
+              </a:tr>
+              <a:tr h="274320">
+                <a:tc>
+                  <a:txBody>
+                    <a:bodyPr/>
+                    <a:lstStyle/>
+                    <a:p>
+                      <a:pPr algn="l" indent="0" marL="0">
+                        <a:buNone/>
+                      </a:pPr>
+                      <a:r>
+                        <a:rPr lang="en-US" sz="950" b="1" dirty="0">
+                          <a:solidFill>
+                            <a:srgbClr val="16233D"/>
+                          </a:solidFill>
+                          <a:latin typeface="Graphik TH" pitchFamily="34" charset="0"/>
+                          <a:ea typeface="Graphik TH" pitchFamily="34" charset="-122"/>
+                          <a:cs typeface="Graphik TH" pitchFamily="34" charset="-120"/>
+                        </a:rPr>
+                        <a:t>Low</a:t>
+                      </a:r>
+                      <a:endParaRPr lang="en-US" sz="950" dirty="0">
+                        <a:latin typeface="Graphik TH" charset="0"/>
+                        <a:ea typeface="Graphik TH" charset="0"/>
+                        <a:cs typeface="Graphik TH" charset="0"/>
+                      </a:endParaRPr>
+                    </a:p>
+                  </a:txBody>
+                  <a:tcPr marL="36576" marR="36576" marT="9144" marB="9144" anchor="ctr">
+                    <a:lnL w="6350" cap="flat" cmpd="sng" algn="ctr">
+                      <a:solidFill>
+                        <a:srgbClr val="D8DFE9"/>
+                      </a:solidFill>
+                      <a:prstDash val="solid"/>
+                      <a:round/>
+                      <a:headEnd type="none" w="med" len="med"/>
+                      <a:tailEnd type="none" w="med" len="med"/>
+                    </a:lnL>
+                    <a:lnR w="6350" cap="flat" cmpd="sng" algn="ctr">
+                      <a:solidFill>
+                        <a:srgbClr val="D8DFE9"/>
+                      </a:solidFill>
+                      <a:prstDash val="solid"/>
+                      <a:round/>
+                      <a:headEnd type="none" w="med" len="med"/>
+                      <a:tailEnd type="none" w="med" len="med"/>
+                    </a:lnR>
+                    <a:lnT w="6350" cap="flat" cmpd="sng" algn="ctr">
+                      <a:solidFill>
+                        <a:srgbClr val="D8DFE9"/>
+                      </a:solidFill>
+                      <a:prstDash val="solid"/>
+                      <a:round/>
+                      <a:headEnd type="none" w="med" len="med"/>
+                      <a:tailEnd type="none" w="med" len="med"/>
+                    </a:lnT>
+                    <a:lnB w="6350" cap="flat" cmpd="sng" algn="ctr">
+                      <a:solidFill>
+                        <a:srgbClr val="D8DFE9"/>
+                      </a:solidFill>
+                      <a:prstDash val="solid"/>
+                      <a:round/>
+                      <a:headEnd type="none" w="med" len="med"/>
+                      <a:tailEnd type="none" w="med" len="med"/>
+                    </a:lnB>
+                    <a:solidFill>
+                      <a:srgbClr val="F1F4F9"/>
+                    </a:solidFill>
+                  </a:tcPr>
+                </a:tc>
+                <a:tc>
+                  <a:txBody>
+                    <a:bodyPr/>
+                    <a:lstStyle/>
+                    <a:p>
+                      <a:pPr algn="ctr" indent="0" marL="0">
+                        <a:buNone/>
+                      </a:pPr>
+                      <a:r>
+                        <a:rPr lang="en-US" sz="950" dirty="0">
+                          <a:solidFill>
+                            <a:srgbClr val="6B7A90"/>
+                          </a:solidFill>
+                          <a:latin typeface="Graphik TH" pitchFamily="34" charset="0"/>
+                          <a:ea typeface="Graphik TH" pitchFamily="34" charset="-122"/>
+                          <a:cs typeface="Graphik TH" pitchFamily="34" charset="-120"/>
+                        </a:rPr>
+                        <a:t>−0.1</a:t>
+                      </a:r>
+                      <a:pPr algn="ctr" indent="0" marL="0">
+                        <a:buNone/>
+                      </a:pPr>
+                      <a:endParaRPr lang="en-US" sz="1200" dirty="0"/>
+                    </a:p>
+                    <a:p>
+                      <a:pPr algn="ctr" indent="0" marL="0">
+                        <a:buNone/>
+                      </a:pPr>
+                      <a:r>
+                        <a:rPr lang="en-US" sz="700" dirty="0">
+                          <a:solidFill>
+                            <a:srgbClr val="6B7A90"/>
+                          </a:solidFill>
+                          <a:latin typeface="Graphik TH" pitchFamily="34" charset="0"/>
+                          <a:ea typeface="Graphik TH" pitchFamily="34" charset="-122"/>
+                          <a:cs typeface="Graphik TH" pitchFamily="34" charset="-120"/>
+                        </a:rPr>
+                        <a:t>n 4</a:t>
+                      </a:r>
+                      <a:endParaRPr lang="en-US" sz="1200" dirty="0"/>
+                    </a:p>
+                  </a:txBody>
+                  <a:tcPr marL="36576" marR="36576" marT="9144" marB="9144" anchor="ctr">
+                    <a:lnL w="6350" cap="flat" cmpd="sng" algn="ctr">
+                      <a:solidFill>
+                        <a:srgbClr val="D8DFE9"/>
+                      </a:solidFill>
+                      <a:prstDash val="solid"/>
+                      <a:round/>
+                      <a:headEnd type="none" w="med" len="med"/>
+                      <a:tailEnd type="none" w="med" len="med"/>
+                    </a:lnL>
+                    <a:lnR w="6350" cap="flat" cmpd="sng" algn="ctr">
+                      <a:solidFill>
+                        <a:srgbClr val="D8DFE9"/>
+                      </a:solidFill>
+                      <a:prstDash val="solid"/>
+                      <a:round/>
+                      <a:headEnd type="none" w="med" len="med"/>
+                      <a:tailEnd type="none" w="med" len="med"/>
+                    </a:lnR>
+                    <a:lnT w="6350" cap="flat" cmpd="sng" algn="ctr">
+                      <a:solidFill>
+                        <a:srgbClr val="D8DFE9"/>
+                      </a:solidFill>
+                      <a:prstDash val="solid"/>
+                      <a:round/>
+                      <a:headEnd type="none" w="med" len="med"/>
+                      <a:tailEnd type="none" w="med" len="med"/>
+                    </a:lnT>
+                    <a:lnB w="6350" cap="flat" cmpd="sng" algn="ctr">
+                      <a:solidFill>
+                        <a:srgbClr val="D8DFE9"/>
+                      </a:solidFill>
+                      <a:prstDash val="solid"/>
+                      <a:round/>
+                      <a:headEnd type="none" w="med" len="med"/>
+                      <a:tailEnd type="none" w="med" len="med"/>
+                    </a:lnB>
+                    <a:solidFill>
+                      <a:srgbClr val="FFFFFF"/>
+                    </a:solidFill>
+                  </a:tcPr>
+                </a:tc>
+                <a:tc>
+                  <a:txBody>
+                    <a:bodyPr/>
+                    <a:lstStyle/>
+                    <a:p>
+                      <a:pPr algn="ctr" indent="0" marL="0">
+                        <a:buNone/>
+                      </a:pPr>
+                      <a:r>
+                        <a:rPr lang="en-US" sz="950" b="1" dirty="0">
+                          <a:solidFill>
+                            <a:srgbClr val="16233D"/>
+                          </a:solidFill>
+                          <a:latin typeface="Graphik TH" pitchFamily="34" charset="0"/>
+                          <a:ea typeface="Graphik TH" pitchFamily="34" charset="-122"/>
+                          <a:cs typeface="Graphik TH" pitchFamily="34" charset="-120"/>
+                        </a:rPr>
+                        <a:t>+1.8</a:t>
+                      </a:r>
+                      <a:pPr algn="ctr" indent="0" marL="0">
+                        <a:buNone/>
+                      </a:pPr>
+                      <a:endParaRPr lang="en-US" sz="1200" dirty="0"/>
+                    </a:p>
+                    <a:p>
+                      <a:pPr algn="ctr" indent="0" marL="0">
+                        <a:buNone/>
+                      </a:pPr>
+                      <a:r>
+                        <a:rPr lang="en-US" sz="700" dirty="0">
+                          <a:solidFill>
+                            <a:srgbClr val="6B7A90"/>
+                          </a:solidFill>
+                          <a:latin typeface="Graphik TH" pitchFamily="34" charset="0"/>
+                          <a:ea typeface="Graphik TH" pitchFamily="34" charset="-122"/>
+                          <a:cs typeface="Graphik TH" pitchFamily="34" charset="-120"/>
+                        </a:rPr>
+                        <a:t>n 2,073</a:t>
+                      </a:r>
+                      <a:endParaRPr lang="en-US" sz="1200" dirty="0"/>
+                    </a:p>
+                  </a:txBody>
+                  <a:tcPr marL="36576" marR="36576" marT="9144" marB="9144" anchor="ctr">
+                    <a:lnL w="6350" cap="flat" cmpd="sng" algn="ctr">
+                      <a:solidFill>
+                        <a:srgbClr val="D8DFE9"/>
+                      </a:solidFill>
+                      <a:prstDash val="solid"/>
+                      <a:round/>
+                      <a:headEnd type="none" w="med" len="med"/>
+                      <a:tailEnd type="none" w="med" len="med"/>
+                    </a:lnL>
+                    <a:lnR w="6350" cap="flat" cmpd="sng" algn="ctr">
+                      <a:solidFill>
+                        <a:srgbClr val="D8DFE9"/>
+                      </a:solidFill>
+                      <a:prstDash val="solid"/>
+                      <a:round/>
+                      <a:headEnd type="none" w="med" len="med"/>
+                      <a:tailEnd type="none" w="med" len="med"/>
+                    </a:lnR>
+                    <a:lnT w="6350" cap="flat" cmpd="sng" algn="ctr">
+                      <a:solidFill>
+                        <a:srgbClr val="D8DFE9"/>
+                      </a:solidFill>
+                      <a:prstDash val="solid"/>
+                      <a:round/>
+                      <a:headEnd type="none" w="med" len="med"/>
+                      <a:tailEnd type="none" w="med" len="med"/>
+                    </a:lnT>
+                    <a:lnB w="6350" cap="flat" cmpd="sng" algn="ctr">
+                      <a:solidFill>
+                        <a:srgbClr val="D8DFE9"/>
+                      </a:solidFill>
+                      <a:prstDash val="solid"/>
+                      <a:round/>
+                      <a:headEnd type="none" w="med" len="med"/>
+                      <a:tailEnd type="none" w="med" len="med"/>
+                    </a:lnB>
+                    <a:solidFill>
+                      <a:srgbClr val="FBFDFD"/>
+                    </a:solidFill>
+                  </a:tcPr>
+                </a:tc>
+                <a:tc>
+                  <a:txBody>
+                    <a:bodyPr/>
+                    <a:lstStyle/>
+                    <a:p>
+                      <a:pPr algn="ctr" indent="0" marL="0">
+                        <a:buNone/>
+                      </a:pPr>
+                      <a:r>
+                        <a:rPr lang="en-US" sz="900" dirty="0">
+                          <a:solidFill>
+                            <a:srgbClr val="6B7A90"/>
+                          </a:solidFill>
+                          <a:latin typeface="Graphik TH" pitchFamily="34" charset="0"/>
+                          <a:ea typeface="Graphik TH" pitchFamily="34" charset="-122"/>
+                          <a:cs typeface="Graphik TH" pitchFamily="34" charset="-120"/>
+                        </a:rPr>
+                        <a:t>—</a:t>
+                      </a:r>
+                      <a:endParaRPr lang="en-US" sz="900" dirty="0">
+                        <a:latin typeface="Graphik TH" charset="0"/>
+                        <a:ea typeface="Graphik TH" charset="0"/>
+                        <a:cs typeface="Graphik TH" charset="0"/>
+                      </a:endParaRPr>
+                    </a:p>
+                  </a:txBody>
+                  <a:tcPr marL="36576" marR="36576" marT="9144" marB="9144" anchor="ctr">
+                    <a:lnL w="6350" cap="flat" cmpd="sng" algn="ctr">
+                      <a:solidFill>
+                        <a:srgbClr val="D8DFE9"/>
+                      </a:solidFill>
+                      <a:prstDash val="solid"/>
+                      <a:round/>
+                      <a:headEnd type="none" w="med" len="med"/>
+                      <a:tailEnd type="none" w="med" len="med"/>
+                    </a:lnL>
+                    <a:lnR w="6350" cap="flat" cmpd="sng" algn="ctr">
+                      <a:solidFill>
+                        <a:srgbClr val="D8DFE9"/>
+                      </a:solidFill>
+                      <a:prstDash val="solid"/>
+                      <a:round/>
+                      <a:headEnd type="none" w="med" len="med"/>
+                      <a:tailEnd type="none" w="med" len="med"/>
+                    </a:lnR>
+                    <a:lnT w="6350" cap="flat" cmpd="sng" algn="ctr">
+                      <a:solidFill>
+                        <a:srgbClr val="D8DFE9"/>
+                      </a:solidFill>
+                      <a:prstDash val="solid"/>
+                      <a:round/>
+                      <a:headEnd type="none" w="med" len="med"/>
+                      <a:tailEnd type="none" w="med" len="med"/>
+                    </a:lnT>
+                    <a:lnB w="6350" cap="flat" cmpd="sng" algn="ctr">
+                      <a:solidFill>
+                        <a:srgbClr val="D8DFE9"/>
+                      </a:solidFill>
+                      <a:prstDash val="solid"/>
+                      <a:round/>
+                      <a:headEnd type="none" w="med" len="med"/>
+                      <a:tailEnd type="none" w="med" len="med"/>
+                    </a:lnB>
+                    <a:solidFill>
+                      <a:srgbClr val="FFFFFF"/>
+                    </a:solidFill>
+                  </a:tcPr>
+                </a:tc>
+                <a:tc>
+                  <a:txBody>
+                    <a:bodyPr/>
+                    <a:lstStyle/>
+                    <a:p>
+                      <a:pPr algn="ctr" indent="0" marL="0">
+                        <a:buNone/>
+                      </a:pPr>
+                      <a:r>
+                        <a:rPr lang="en-US" sz="950" dirty="0">
+                          <a:solidFill>
+                            <a:srgbClr val="6B7A90"/>
+                          </a:solidFill>
+                          <a:latin typeface="Graphik TH" pitchFamily="34" charset="0"/>
+                          <a:ea typeface="Graphik TH" pitchFamily="34" charset="-122"/>
+                          <a:cs typeface="Graphik TH" pitchFamily="34" charset="-120"/>
+                        </a:rPr>
+                        <a:t>−0.0</a:t>
+                      </a:r>
+                      <a:pPr algn="ctr" indent="0" marL="0">
+                        <a:buNone/>
+                      </a:pPr>
+                      <a:endParaRPr lang="en-US" sz="1200" dirty="0"/>
+                    </a:p>
+                    <a:p>
+                      <a:pPr algn="ctr" indent="0" marL="0">
+                        <a:buNone/>
+                      </a:pPr>
+                      <a:r>
+                        <a:rPr lang="en-US" sz="700" dirty="0">
+                          <a:solidFill>
+                            <a:srgbClr val="6B7A90"/>
+                          </a:solidFill>
+                          <a:latin typeface="Graphik TH" pitchFamily="34" charset="0"/>
+                          <a:ea typeface="Graphik TH" pitchFamily="34" charset="-122"/>
+                          <a:cs typeface="Graphik TH" pitchFamily="34" charset="-120"/>
+                        </a:rPr>
+                        <a:t>n 1</a:t>
+                      </a:r>
+                      <a:endParaRPr lang="en-US" sz="1200" dirty="0"/>
+                    </a:p>
+                  </a:txBody>
+                  <a:tcPr marL="36576" marR="36576" marT="9144" marB="9144" anchor="ctr">
+                    <a:lnL w="6350" cap="flat" cmpd="sng" algn="ctr">
+                      <a:solidFill>
+                        <a:srgbClr val="D8DFE9"/>
+                      </a:solidFill>
+                      <a:prstDash val="solid"/>
+                      <a:round/>
+                      <a:headEnd type="none" w="med" len="med"/>
+                      <a:tailEnd type="none" w="med" len="med"/>
+                    </a:lnL>
+                    <a:lnR w="6350" cap="flat" cmpd="sng" algn="ctr">
+                      <a:solidFill>
+                        <a:srgbClr val="D8DFE9"/>
+                      </a:solidFill>
+                      <a:prstDash val="solid"/>
+                      <a:round/>
+                      <a:headEnd type="none" w="med" len="med"/>
+                      <a:tailEnd type="none" w="med" len="med"/>
+                    </a:lnR>
+                    <a:lnT w="6350" cap="flat" cmpd="sng" algn="ctr">
+                      <a:solidFill>
+                        <a:srgbClr val="D8DFE9"/>
+                      </a:solidFill>
+                      <a:prstDash val="solid"/>
+                      <a:round/>
+                      <a:headEnd type="none" w="med" len="med"/>
+                      <a:tailEnd type="none" w="med" len="med"/>
+                    </a:lnT>
+                    <a:lnB w="6350" cap="flat" cmpd="sng" algn="ctr">
+                      <a:solidFill>
+                        <a:srgbClr val="D8DFE9"/>
+                      </a:solidFill>
+                      <a:prstDash val="solid"/>
+                      <a:round/>
+                      <a:headEnd type="none" w="med" len="med"/>
+                      <a:tailEnd type="none" w="med" len="med"/>
+                    </a:lnB>
+                    <a:solidFill>
+                      <a:srgbClr val="FFFFFF"/>
+                    </a:solidFill>
+                  </a:tcPr>
+                </a:tc>
+                <a:tc>
+                  <a:txBody>
+                    <a:bodyPr/>
+                    <a:lstStyle/>
+                    <a:p>
+                      <a:pPr algn="ctr" indent="0" marL="0">
+                        <a:buNone/>
+                      </a:pPr>
+                      <a:r>
+                        <a:rPr lang="en-US" sz="950" dirty="0">
+                          <a:solidFill>
+                            <a:srgbClr val="6B7A90"/>
+                          </a:solidFill>
+                          <a:latin typeface="Graphik TH" pitchFamily="34" charset="0"/>
+                          <a:ea typeface="Graphik TH" pitchFamily="34" charset="-122"/>
+                          <a:cs typeface="Graphik TH" pitchFamily="34" charset="-120"/>
+                        </a:rPr>
+                        <a:t>−0.1</a:t>
+                      </a:r>
+                      <a:pPr algn="ctr" indent="0" marL="0">
+                        <a:buNone/>
+                      </a:pPr>
+                      <a:endParaRPr lang="en-US" sz="1200" dirty="0"/>
+                    </a:p>
+                    <a:p>
+                      <a:pPr algn="ctr" indent="0" marL="0">
+                        <a:buNone/>
+                      </a:pPr>
+                      <a:r>
+                        <a:rPr lang="en-US" sz="700" dirty="0">
+                          <a:solidFill>
+                            <a:srgbClr val="6B7A90"/>
+                          </a:solidFill>
+                          <a:latin typeface="Graphik TH" pitchFamily="34" charset="0"/>
+                          <a:ea typeface="Graphik TH" pitchFamily="34" charset="-122"/>
+                          <a:cs typeface="Graphik TH" pitchFamily="34" charset="-120"/>
+                        </a:rPr>
+                        <a:t>n 11</a:t>
+                      </a:r>
+                      <a:endParaRPr lang="en-US" sz="1200" dirty="0"/>
+                    </a:p>
+                  </a:txBody>
+                  <a:tcPr marL="36576" marR="36576" marT="9144" marB="9144" anchor="ctr">
+                    <a:lnL w="6350" cap="flat" cmpd="sng" algn="ctr">
+                      <a:solidFill>
+                        <a:srgbClr val="D8DFE9"/>
+                      </a:solidFill>
+                      <a:prstDash val="solid"/>
+                      <a:round/>
+                      <a:headEnd type="none" w="med" len="med"/>
+                      <a:tailEnd type="none" w="med" len="med"/>
+                    </a:lnL>
+                    <a:lnR w="6350" cap="flat" cmpd="sng" algn="ctr">
+                      <a:solidFill>
+                        <a:srgbClr val="D8DFE9"/>
+                      </a:solidFill>
+                      <a:prstDash val="solid"/>
+                      <a:round/>
+                      <a:headEnd type="none" w="med" len="med"/>
+                      <a:tailEnd type="none" w="med" len="med"/>
+                    </a:lnR>
+                    <a:lnT w="6350" cap="flat" cmpd="sng" algn="ctr">
+                      <a:solidFill>
+                        <a:srgbClr val="D8DFE9"/>
+                      </a:solidFill>
+                      <a:prstDash val="solid"/>
+                      <a:round/>
+                      <a:headEnd type="none" w="med" len="med"/>
+                      <a:tailEnd type="none" w="med" len="med"/>
+                    </a:lnT>
+                    <a:lnB w="6350" cap="flat" cmpd="sng" algn="ctr">
+                      <a:solidFill>
+                        <a:srgbClr val="D8DFE9"/>
+                      </a:solidFill>
+                      <a:prstDash val="solid"/>
+                      <a:round/>
+                      <a:headEnd type="none" w="med" len="med"/>
+                      <a:tailEnd type="none" w="med" len="med"/>
+                    </a:lnB>
+                    <a:solidFill>
+                      <a:srgbClr val="FFFFFF"/>
+                    </a:solidFill>
+                  </a:tcPr>
+                </a:tc>
+              </a:tr>
+              <a:tr h="274320">
+                <a:tc>
+                  <a:txBody>
+                    <a:bodyPr/>
+                    <a:lstStyle/>
+                    <a:p>
+                      <a:pPr algn="l" indent="0" marL="0">
+                        <a:buNone/>
+                      </a:pPr>
+                      <a:r>
+                        <a:rPr lang="en-US" sz="950" b="1" dirty="0">
+                          <a:solidFill>
+                            <a:srgbClr val="16233D"/>
+                          </a:solidFill>
+                          <a:latin typeface="Graphik TH" pitchFamily="34" charset="0"/>
+                          <a:ea typeface="Graphik TH" pitchFamily="34" charset="-122"/>
+                          <a:cs typeface="Graphik TH" pitchFamily="34" charset="-120"/>
+                        </a:rPr>
+                        <a:t>Very Low</a:t>
+                      </a:r>
+                      <a:endParaRPr lang="en-US" sz="950" dirty="0">
+                        <a:latin typeface="Graphik TH" charset="0"/>
+                        <a:ea typeface="Graphik TH" charset="0"/>
+                        <a:cs typeface="Graphik TH" charset="0"/>
+                      </a:endParaRPr>
+                    </a:p>
+                  </a:txBody>
+                  <a:tcPr marL="36576" marR="36576" marT="9144" marB="9144" anchor="ctr">
+                    <a:lnL w="6350" cap="flat" cmpd="sng" algn="ctr">
+                      <a:solidFill>
+                        <a:srgbClr val="D8DFE9"/>
+                      </a:solidFill>
+                      <a:prstDash val="solid"/>
+                      <a:round/>
+                      <a:headEnd type="none" w="med" len="med"/>
+                      <a:tailEnd type="none" w="med" len="med"/>
+                    </a:lnL>
+                    <a:lnR w="6350" cap="flat" cmpd="sng" algn="ctr">
+                      <a:solidFill>
+                        <a:srgbClr val="D8DFE9"/>
+                      </a:solidFill>
+                      <a:prstDash val="solid"/>
+                      <a:round/>
+                      <a:headEnd type="none" w="med" len="med"/>
+                      <a:tailEnd type="none" w="med" len="med"/>
+                    </a:lnR>
+                    <a:lnT w="6350" cap="flat" cmpd="sng" algn="ctr">
+                      <a:solidFill>
+                        <a:srgbClr val="D8DFE9"/>
+                      </a:solidFill>
+                      <a:prstDash val="solid"/>
+                      <a:round/>
+                      <a:headEnd type="none" w="med" len="med"/>
+                      <a:tailEnd type="none" w="med" len="med"/>
+                    </a:lnT>
+                    <a:lnB w="6350" cap="flat" cmpd="sng" algn="ctr">
+                      <a:solidFill>
+                        <a:srgbClr val="D8DFE9"/>
+                      </a:solidFill>
+                      <a:prstDash val="solid"/>
+                      <a:round/>
+                      <a:headEnd type="none" w="med" len="med"/>
+                      <a:tailEnd type="none" w="med" len="med"/>
+                    </a:lnB>
+                    <a:solidFill>
+                      <a:srgbClr val="F1F4F9"/>
+                    </a:solidFill>
+                  </a:tcPr>
+                </a:tc>
+                <a:tc>
+                  <a:txBody>
+                    <a:bodyPr/>
+                    <a:lstStyle/>
+                    <a:p>
+                      <a:pPr algn="ctr" indent="0" marL="0">
+                        <a:buNone/>
+                      </a:pPr>
+                      <a:r>
+                        <a:rPr lang="en-US" sz="900" dirty="0">
+                          <a:solidFill>
+                            <a:srgbClr val="6B7A90"/>
+                          </a:solidFill>
+                          <a:latin typeface="Graphik TH" pitchFamily="34" charset="0"/>
+                          <a:ea typeface="Graphik TH" pitchFamily="34" charset="-122"/>
+                          <a:cs typeface="Graphik TH" pitchFamily="34" charset="-120"/>
+                        </a:rPr>
+                        <a:t>—</a:t>
+                      </a:r>
+                      <a:endParaRPr lang="en-US" sz="900" dirty="0">
+                        <a:latin typeface="Graphik TH" charset="0"/>
+                        <a:ea typeface="Graphik TH" charset="0"/>
+                        <a:cs typeface="Graphik TH" charset="0"/>
+                      </a:endParaRPr>
+                    </a:p>
+                  </a:txBody>
+                  <a:tcPr marL="36576" marR="36576" marT="9144" marB="9144" anchor="ctr">
+                    <a:lnL w="6350" cap="flat" cmpd="sng" algn="ctr">
+                      <a:solidFill>
+                        <a:srgbClr val="D8DFE9"/>
+                      </a:solidFill>
+                      <a:prstDash val="solid"/>
+                      <a:round/>
+                      <a:headEnd type="none" w="med" len="med"/>
+                      <a:tailEnd type="none" w="med" len="med"/>
+                    </a:lnL>
+                    <a:lnR w="6350" cap="flat" cmpd="sng" algn="ctr">
+                      <a:solidFill>
+                        <a:srgbClr val="D8DFE9"/>
+                      </a:solidFill>
+                      <a:prstDash val="solid"/>
+                      <a:round/>
+                      <a:headEnd type="none" w="med" len="med"/>
+                      <a:tailEnd type="none" w="med" len="med"/>
+                    </a:lnR>
+                    <a:lnT w="6350" cap="flat" cmpd="sng" algn="ctr">
+                      <a:solidFill>
+                        <a:srgbClr val="D8DFE9"/>
+                      </a:solidFill>
+                      <a:prstDash val="solid"/>
+                      <a:round/>
+                      <a:headEnd type="none" w="med" len="med"/>
+                      <a:tailEnd type="none" w="med" len="med"/>
+                    </a:lnT>
+                    <a:lnB w="6350" cap="flat" cmpd="sng" algn="ctr">
+                      <a:solidFill>
+                        <a:srgbClr val="D8DFE9"/>
+                      </a:solidFill>
+                      <a:prstDash val="solid"/>
+                      <a:round/>
+                      <a:headEnd type="none" w="med" len="med"/>
+                      <a:tailEnd type="none" w="med" len="med"/>
+                    </a:lnB>
+                    <a:solidFill>
+                      <a:srgbClr val="FFFFFF"/>
+                    </a:solidFill>
+                  </a:tcPr>
+                </a:tc>
+                <a:tc>
+                  <a:txBody>
+                    <a:bodyPr/>
+                    <a:lstStyle/>
+                    <a:p>
+                      <a:pPr algn="ctr" indent="0" marL="0">
+                        <a:buNone/>
+                      </a:pPr>
+                      <a:r>
+                        <a:rPr lang="en-US" sz="950" b="1" dirty="0">
+                          <a:solidFill>
+                            <a:srgbClr val="16233D"/>
+                          </a:solidFill>
+                          <a:latin typeface="Graphik TH" pitchFamily="34" charset="0"/>
+                          <a:ea typeface="Graphik TH" pitchFamily="34" charset="-122"/>
+                          <a:cs typeface="Graphik TH" pitchFamily="34" charset="-120"/>
+                        </a:rPr>
+                        <a:t>+0.5</a:t>
+                      </a:r>
+                      <a:pPr algn="ctr" indent="0" marL="0">
+                        <a:buNone/>
+                      </a:pPr>
+                      <a:endParaRPr lang="en-US" sz="1200" dirty="0"/>
+                    </a:p>
+                    <a:p>
+                      <a:pPr algn="ctr" indent="0" marL="0">
+                        <a:buNone/>
+                      </a:pPr>
+                      <a:r>
+                        <a:rPr lang="en-US" sz="700" dirty="0">
+                          <a:solidFill>
+                            <a:srgbClr val="6B7A90"/>
+                          </a:solidFill>
+                          <a:latin typeface="Graphik TH" pitchFamily="34" charset="0"/>
+                          <a:ea typeface="Graphik TH" pitchFamily="34" charset="-122"/>
+                          <a:cs typeface="Graphik TH" pitchFamily="34" charset="-120"/>
+                        </a:rPr>
+                        <a:t>n 1,408</a:t>
+                      </a:r>
+                      <a:endParaRPr lang="en-US" sz="1200" dirty="0"/>
+                    </a:p>
+                  </a:txBody>
+                  <a:tcPr marL="36576" marR="36576" marT="9144" marB="9144" anchor="ctr">
+                    <a:lnL w="6350" cap="flat" cmpd="sng" algn="ctr">
+                      <a:solidFill>
+                        <a:srgbClr val="D8DFE9"/>
+                      </a:solidFill>
+                      <a:prstDash val="solid"/>
+                      <a:round/>
+                      <a:headEnd type="none" w="med" len="med"/>
+                      <a:tailEnd type="none" w="med" len="med"/>
+                    </a:lnL>
+                    <a:lnR w="6350" cap="flat" cmpd="sng" algn="ctr">
+                      <a:solidFill>
+                        <a:srgbClr val="D8DFE9"/>
+                      </a:solidFill>
+                      <a:prstDash val="solid"/>
+                      <a:round/>
+                      <a:headEnd type="none" w="med" len="med"/>
+                      <a:tailEnd type="none" w="med" len="med"/>
+                    </a:lnR>
+                    <a:lnT w="6350" cap="flat" cmpd="sng" algn="ctr">
+                      <a:solidFill>
+                        <a:srgbClr val="D8DFE9"/>
+                      </a:solidFill>
+                      <a:prstDash val="solid"/>
+                      <a:round/>
+                      <a:headEnd type="none" w="med" len="med"/>
+                      <a:tailEnd type="none" w="med" len="med"/>
+                    </a:lnT>
+                    <a:lnB w="6350" cap="flat" cmpd="sng" algn="ctr">
+                      <a:solidFill>
+                        <a:srgbClr val="D8DFE9"/>
+                      </a:solidFill>
+                      <a:prstDash val="solid"/>
+                      <a:round/>
+                      <a:headEnd type="none" w="med" len="med"/>
+                      <a:tailEnd type="none" w="med" len="med"/>
+                    </a:lnB>
+                    <a:solidFill>
+                      <a:srgbClr val="FEFEFE"/>
+                    </a:solidFill>
+                  </a:tcPr>
+                </a:tc>
+                <a:tc>
+                  <a:txBody>
+                    <a:bodyPr/>
+                    <a:lstStyle/>
+                    <a:p>
+                      <a:pPr algn="ctr" indent="0" marL="0">
+                        <a:buNone/>
+                      </a:pPr>
+                      <a:r>
+                        <a:rPr lang="en-US" sz="900" dirty="0">
+                          <a:solidFill>
+                            <a:srgbClr val="6B7A90"/>
+                          </a:solidFill>
+                          <a:latin typeface="Graphik TH" pitchFamily="34" charset="0"/>
+                          <a:ea typeface="Graphik TH" pitchFamily="34" charset="-122"/>
+                          <a:cs typeface="Graphik TH" pitchFamily="34" charset="-120"/>
+                        </a:rPr>
+                        <a:t>—</a:t>
+                      </a:r>
+                      <a:endParaRPr lang="en-US" sz="900" dirty="0">
+                        <a:latin typeface="Graphik TH" charset="0"/>
+                        <a:ea typeface="Graphik TH" charset="0"/>
+                        <a:cs typeface="Graphik TH" charset="0"/>
+                      </a:endParaRPr>
+                    </a:p>
+                  </a:txBody>
+                  <a:tcPr marL="36576" marR="36576" marT="9144" marB="9144" anchor="ctr">
+                    <a:lnL w="6350" cap="flat" cmpd="sng" algn="ctr">
+                      <a:solidFill>
+                        <a:srgbClr val="D8DFE9"/>
+                      </a:solidFill>
+                      <a:prstDash val="solid"/>
+                      <a:round/>
+                      <a:headEnd type="none" w="med" len="med"/>
+                      <a:tailEnd type="none" w="med" len="med"/>
+                    </a:lnL>
+                    <a:lnR w="6350" cap="flat" cmpd="sng" algn="ctr">
+                      <a:solidFill>
+                        <a:srgbClr val="D8DFE9"/>
+                      </a:solidFill>
+                      <a:prstDash val="solid"/>
+                      <a:round/>
+                      <a:headEnd type="none" w="med" len="med"/>
+                      <a:tailEnd type="none" w="med" len="med"/>
+                    </a:lnR>
+                    <a:lnT w="6350" cap="flat" cmpd="sng" algn="ctr">
+                      <a:solidFill>
+                        <a:srgbClr val="D8DFE9"/>
+                      </a:solidFill>
+                      <a:prstDash val="solid"/>
+                      <a:round/>
+                      <a:headEnd type="none" w="med" len="med"/>
+                      <a:tailEnd type="none" w="med" len="med"/>
+                    </a:lnT>
+                    <a:lnB w="6350" cap="flat" cmpd="sng" algn="ctr">
+                      <a:solidFill>
+                        <a:srgbClr val="D8DFE9"/>
+                      </a:solidFill>
+                      <a:prstDash val="solid"/>
+                      <a:round/>
+                      <a:headEnd type="none" w="med" len="med"/>
+                      <a:tailEnd type="none" w="med" len="med"/>
+                    </a:lnB>
+                    <a:solidFill>
+                      <a:srgbClr val="FFFFFF"/>
+                    </a:solidFill>
+                  </a:tcPr>
+                </a:tc>
+                <a:tc>
+                  <a:txBody>
+                    <a:bodyPr/>
+                    <a:lstStyle/>
+                    <a:p>
+                      <a:pPr algn="ctr" indent="0" marL="0">
+                        <a:buNone/>
+                      </a:pPr>
+                      <a:r>
+                        <a:rPr lang="en-US" sz="900" dirty="0">
+                          <a:solidFill>
+                            <a:srgbClr val="6B7A90"/>
+                          </a:solidFill>
+                          <a:latin typeface="Graphik TH" pitchFamily="34" charset="0"/>
+                          <a:ea typeface="Graphik TH" pitchFamily="34" charset="-122"/>
+                          <a:cs typeface="Graphik TH" pitchFamily="34" charset="-120"/>
+                        </a:rPr>
+                        <a:t>—</a:t>
+                      </a:r>
+                      <a:endParaRPr lang="en-US" sz="900" dirty="0">
+                        <a:latin typeface="Graphik TH" charset="0"/>
+                        <a:ea typeface="Graphik TH" charset="0"/>
+                        <a:cs typeface="Graphik TH" charset="0"/>
+                      </a:endParaRPr>
+                    </a:p>
+                  </a:txBody>
+                  <a:tcPr marL="36576" marR="36576" marT="9144" marB="9144" anchor="ctr">
+                    <a:lnL w="6350" cap="flat" cmpd="sng" algn="ctr">
+                      <a:solidFill>
+                        <a:srgbClr val="D8DFE9"/>
+                      </a:solidFill>
+                      <a:prstDash val="solid"/>
+                      <a:round/>
+                      <a:headEnd type="none" w="med" len="med"/>
+                      <a:tailEnd type="none" w="med" len="med"/>
+                    </a:lnL>
+                    <a:lnR w="6350" cap="flat" cmpd="sng" algn="ctr">
+                      <a:solidFill>
+                        <a:srgbClr val="D8DFE9"/>
+                      </a:solidFill>
+                      <a:prstDash val="solid"/>
+                      <a:round/>
+                      <a:headEnd type="none" w="med" len="med"/>
+                      <a:tailEnd type="none" w="med" len="med"/>
+                    </a:lnR>
+                    <a:lnT w="6350" cap="flat" cmpd="sng" algn="ctr">
+                      <a:solidFill>
+                        <a:srgbClr val="D8DFE9"/>
+                      </a:solidFill>
+                      <a:prstDash val="solid"/>
+                      <a:round/>
+                      <a:headEnd type="none" w="med" len="med"/>
+                      <a:tailEnd type="none" w="med" len="med"/>
+                    </a:lnT>
+                    <a:lnB w="6350" cap="flat" cmpd="sng" algn="ctr">
+                      <a:solidFill>
+                        <a:srgbClr val="D8DFE9"/>
+                      </a:solidFill>
+                      <a:prstDash val="solid"/>
+                      <a:round/>
+                      <a:headEnd type="none" w="med" len="med"/>
+                      <a:tailEnd type="none" w="med" len="med"/>
+                    </a:lnB>
+                    <a:solidFill>
+                      <a:srgbClr val="FFFFFF"/>
+                    </a:solidFill>
+                  </a:tcPr>
+                </a:tc>
+                <a:tc>
+                  <a:txBody>
+                    <a:bodyPr/>
+                    <a:lstStyle/>
+                    <a:p>
+                      <a:pPr algn="ctr" indent="0" marL="0">
+                        <a:buNone/>
+                      </a:pPr>
+                      <a:r>
+                        <a:rPr lang="en-US" sz="900" dirty="0">
+                          <a:solidFill>
+                            <a:srgbClr val="6B7A90"/>
+                          </a:solidFill>
+                          <a:latin typeface="Graphik TH" pitchFamily="34" charset="0"/>
+                          <a:ea typeface="Graphik TH" pitchFamily="34" charset="-122"/>
+                          <a:cs typeface="Graphik TH" pitchFamily="34" charset="-120"/>
+                        </a:rPr>
+                        <a:t>—</a:t>
+                      </a:r>
+                      <a:endParaRPr lang="en-US" sz="900" dirty="0">
+                        <a:latin typeface="Graphik TH" charset="0"/>
+                        <a:ea typeface="Graphik TH" charset="0"/>
+                        <a:cs typeface="Graphik TH" charset="0"/>
+                      </a:endParaRPr>
+                    </a:p>
+                  </a:txBody>
+                  <a:tcPr marL="36576" marR="36576" marT="9144" marB="9144" anchor="ctr">
+                    <a:lnL w="6350" cap="flat" cmpd="sng" algn="ctr">
+                      <a:solidFill>
+                        <a:srgbClr val="D8DFE9"/>
+                      </a:solidFill>
+                      <a:prstDash val="solid"/>
+                      <a:round/>
+                      <a:headEnd type="none" w="med" len="med"/>
+                      <a:tailEnd type="none" w="med" len="med"/>
+                    </a:lnL>
+                    <a:lnR w="6350" cap="flat" cmpd="sng" algn="ctr">
+                      <a:solidFill>
+                        <a:srgbClr val="D8DFE9"/>
+                      </a:solidFill>
+                      <a:prstDash val="solid"/>
+                      <a:round/>
+                      <a:headEnd type="none" w="med" len="med"/>
+                      <a:tailEnd type="none" w="med" len="med"/>
+                    </a:lnR>
+                    <a:lnT w="6350" cap="flat" cmpd="sng" algn="ctr">
+                      <a:solidFill>
+                        <a:srgbClr val="D8DFE9"/>
+                      </a:solidFill>
+                      <a:prstDash val="solid"/>
+                      <a:round/>
+                      <a:headEnd type="none" w="med" len="med"/>
+                      <a:tailEnd type="none" w="med" len="med"/>
+                    </a:lnT>
+                    <a:lnB w="6350" cap="flat" cmpd="sng" algn="ctr">
+                      <a:solidFill>
+                        <a:srgbClr val="D8DFE9"/>
+                      </a:solidFill>
+                      <a:prstDash val="solid"/>
+                      <a:round/>
+                      <a:headEnd type="none" w="med" len="med"/>
+                      <a:tailEnd type="none" w="med" len="med"/>
+                    </a:lnB>
+                    <a:solidFill>
+                      <a:srgbClr val="FFFFFF"/>
+                    </a:solidFill>
+                  </a:tcPr>
+                </a:tc>
+              </a:tr>
+            </a:tbl>
+          </a:graphicData>
+        </a:graphic>
+      </p:graphicFrame>
+      <p:sp>
+        <p:nvSpPr>
+          <p:cNvPr id="26" name="Shape 23"/>
+          <p:cNvSpPr/>
+          <p:nvPr/>
+        </p:nvSpPr>
+        <p:spPr>
+          <a:xfrm>
+            <a:off x="7479792" y="2798064"/>
+            <a:ext cx="4325112" cy="2322576"/>
+          </a:xfrm>
+          <a:prstGeom prst="roundRect">
+            <a:avLst>
+              <a:gd name="adj" fmla="val 3543"/>
+            </a:avLst>
+          </a:prstGeom>
+          <a:solidFill>
+            <a:srgbClr val="F1F4F9"/>
+          </a:solidFill>
+          <a:ln/>
+        </p:spPr>
+      </p:sp>
+      <p:sp>
+        <p:nvSpPr>
+          <p:cNvPr id="27" name="Text 24"/>
+          <p:cNvSpPr/>
+          <p:nvPr/>
+        </p:nvSpPr>
+        <p:spPr>
+          <a:xfrm>
+            <a:off x="7735824" y="2944368"/>
+            <a:ext cx="3813048" cy="274320"/>
+          </a:xfrm>
+          <a:prstGeom prst="rect">
+            <a:avLst/>
+          </a:prstGeom>
+          <a:noFill/>
+          <a:ln/>
+        </p:spPr>
+        <p:txBody>
+          <a:bodyPr wrap="square" lIns="0" tIns="0" rIns="0" bIns="0" rtlCol="0" anchor="ctr"/>
+          <a:lstStyle/>
+          <a:p>
+            <a:pPr indent="0" marL="0">
+              <a:buNone/>
+            </a:pPr>
+            <a:r>
+              <a:rPr lang="en-US" sz="1400" b="1" dirty="0">
+                <a:solidFill>
+                  <a:srgbClr val="16233D"/>
+                </a:solidFill>
+                <a:latin typeface="Cambria" pitchFamily="34" charset="0"/>
+                <a:ea typeface="Cambria" pitchFamily="34" charset="-122"/>
+                <a:cs typeface="Cambria" pitchFamily="34" charset="-120"/>
+              </a:rPr>
+              <a:t>Balance change by rate sensitivity</a:t>
+            </a:r>
+            <a:endParaRPr lang="en-US" sz="1400" dirty="0"/>
+          </a:p>
+        </p:txBody>
+      </p:sp>
+      <p:sp>
+        <p:nvSpPr>
+          <p:cNvPr id="28" name="Text 25"/>
+          <p:cNvSpPr/>
+          <p:nvPr/>
+        </p:nvSpPr>
+        <p:spPr>
+          <a:xfrm>
+            <a:off x="7735824" y="3218688"/>
+            <a:ext cx="3813048" cy="237744"/>
+          </a:xfrm>
+          <a:prstGeom prst="rect">
+            <a:avLst/>
+          </a:prstGeom>
+          <a:noFill/>
+          <a:ln/>
+        </p:spPr>
+        <p:txBody>
+          <a:bodyPr wrap="square" lIns="0" tIns="0" rIns="0" bIns="0" rtlCol="0" anchor="ctr"/>
+          <a:lstStyle/>
+          <a:p>
+            <a:pPr indent="0" marL="0">
+              <a:buNone/>
+            </a:pPr>
+            <a:r>
+              <a:rPr lang="en-US" sz="950" dirty="0">
+                <a:solidFill>
+                  <a:srgbClr val="6B7A90"/>
+                </a:solidFill>
+                <a:latin typeface="Graphik TH" pitchFamily="34" charset="0"/>
+                <a:ea typeface="Graphik TH" pitchFamily="34" charset="-122"/>
+                <a:cs typeface="Graphik TH" pitchFamily="34" charset="-120"/>
+              </a:rPr>
+              <a:t>THB m · bars diverge from zero</a:t>
+            </a:r>
+            <a:endParaRPr lang="en-US" sz="950" dirty="0"/>
+          </a:p>
+        </p:txBody>
+      </p:sp>
+      <p:sp>
+        <p:nvSpPr>
+          <p:cNvPr id="29" name="Shape 26"/>
+          <p:cNvSpPr/>
+          <p:nvPr/>
+        </p:nvSpPr>
+        <p:spPr>
+          <a:xfrm>
+            <a:off x="9710928" y="3401568"/>
+            <a:ext cx="10973" cy="1371600"/>
+          </a:xfrm>
+          <a:prstGeom prst="rect">
+            <a:avLst/>
+          </a:prstGeom>
+          <a:solidFill>
+            <a:srgbClr val="6B7A90"/>
+          </a:solidFill>
+          <a:ln/>
+        </p:spPr>
+      </p:sp>
+      <p:sp>
+        <p:nvSpPr>
+          <p:cNvPr id="30" name="Text 27"/>
+          <p:cNvSpPr/>
+          <p:nvPr/>
+        </p:nvSpPr>
+        <p:spPr>
+          <a:xfrm>
+            <a:off x="7735824" y="3438144"/>
+            <a:ext cx="1005840" cy="237744"/>
+          </a:xfrm>
+          <a:prstGeom prst="rect">
+            <a:avLst/>
+          </a:prstGeom>
+          <a:noFill/>
+          <a:ln/>
+        </p:spPr>
+        <p:txBody>
+          <a:bodyPr wrap="square" lIns="0" tIns="0" rIns="0" bIns="0" rtlCol="0" anchor="ctr"/>
+          <a:lstStyle/>
+          <a:p>
+            <a:pPr indent="0" marL="0">
+              <a:buNone/>
+            </a:pPr>
+            <a:r>
+              <a:rPr lang="en-US" sz="1000" b="1" dirty="0">
+                <a:solidFill>
+                  <a:srgbClr val="16233D"/>
+                </a:solidFill>
+                <a:latin typeface="Graphik TH" pitchFamily="34" charset="0"/>
+                <a:ea typeface="Graphik TH" pitchFamily="34" charset="-122"/>
+                <a:cs typeface="Graphik TH" pitchFamily="34" charset="-120"/>
+              </a:rPr>
+              <a:t>Very High</a:t>
+            </a:r>
+            <a:endParaRPr lang="en-US" sz="1000" dirty="0"/>
+          </a:p>
+        </p:txBody>
+      </p:sp>
+      <p:sp>
+        <p:nvSpPr>
+          <p:cNvPr id="31" name="Shape 28"/>
+          <p:cNvSpPr/>
+          <p:nvPr/>
+        </p:nvSpPr>
+        <p:spPr>
+          <a:xfrm>
+            <a:off x="9483551" y="3474720"/>
+            <a:ext cx="227377" cy="164592"/>
+          </a:xfrm>
+          <a:prstGeom prst="roundRect">
+            <a:avLst>
+              <a:gd name="adj" fmla="val 16667"/>
+            </a:avLst>
+          </a:prstGeom>
+          <a:solidFill>
+            <a:srgbClr val="C00000"/>
+          </a:solidFill>
+          <a:ln/>
+        </p:spPr>
+      </p:sp>
+      <p:sp>
+        <p:nvSpPr>
+          <p:cNvPr id="32" name="Text 29"/>
+          <p:cNvSpPr/>
+          <p:nvPr/>
+        </p:nvSpPr>
+        <p:spPr>
+          <a:xfrm>
+            <a:off x="10698480" y="3438144"/>
+            <a:ext cx="850392" cy="237744"/>
+          </a:xfrm>
+          <a:prstGeom prst="rect">
+            <a:avLst/>
+          </a:prstGeom>
+          <a:noFill/>
+          <a:ln/>
+        </p:spPr>
+        <p:txBody>
+          <a:bodyPr wrap="square" lIns="0" tIns="0" rIns="0" bIns="0" rtlCol="0" anchor="ctr"/>
+          <a:lstStyle/>
+          <a:p>
+            <a:pPr algn="r" indent="0" marL="0">
+              <a:buNone/>
+            </a:pPr>
+            <a:r>
+              <a:rPr lang="en-US" sz="1000" b="1" dirty="0">
+                <a:solidFill>
+                  <a:srgbClr val="C00000"/>
+                </a:solidFill>
+                <a:latin typeface="Graphik TH" pitchFamily="34" charset="0"/>
+                <a:ea typeface="Graphik TH" pitchFamily="34" charset="-122"/>
+                <a:cs typeface="Graphik TH" pitchFamily="34" charset="-120"/>
+              </a:rPr>
+              <a:t>−36.0</a:t>
+            </a:r>
+            <a:endParaRPr lang="en-US" sz="1000" dirty="0"/>
+          </a:p>
+        </p:txBody>
+      </p:sp>
+      <p:sp>
+        <p:nvSpPr>
+          <p:cNvPr id="33" name="Text 30"/>
+          <p:cNvSpPr/>
+          <p:nvPr/>
+        </p:nvSpPr>
+        <p:spPr>
+          <a:xfrm>
+            <a:off x="7735824" y="3712464"/>
+            <a:ext cx="1005840" cy="237744"/>
+          </a:xfrm>
+          <a:prstGeom prst="rect">
+            <a:avLst/>
+          </a:prstGeom>
+          <a:noFill/>
+          <a:ln/>
+        </p:spPr>
+        <p:txBody>
+          <a:bodyPr wrap="square" lIns="0" tIns="0" rIns="0" bIns="0" rtlCol="0" anchor="ctr"/>
+          <a:lstStyle/>
+          <a:p>
+            <a:pPr indent="0" marL="0">
+              <a:buNone/>
+            </a:pPr>
+            <a:r>
+              <a:rPr lang="en-US" sz="1000" b="1" dirty="0">
+                <a:solidFill>
+                  <a:srgbClr val="16233D"/>
+                </a:solidFill>
+                <a:latin typeface="Graphik TH" pitchFamily="34" charset="0"/>
+                <a:ea typeface="Graphik TH" pitchFamily="34" charset="-122"/>
+                <a:cs typeface="Graphik TH" pitchFamily="34" charset="-120"/>
+              </a:rPr>
+              <a:t>High</a:t>
+            </a:r>
+            <a:endParaRPr lang="en-US" sz="1000" dirty="0"/>
+          </a:p>
+        </p:txBody>
+      </p:sp>
+      <p:sp>
+        <p:nvSpPr>
+          <p:cNvPr id="34" name="Shape 31"/>
+          <p:cNvSpPr/>
+          <p:nvPr/>
+        </p:nvSpPr>
+        <p:spPr>
+          <a:xfrm>
+            <a:off x="9710928" y="3749040"/>
+            <a:ext cx="914400" cy="164592"/>
+          </a:xfrm>
+          <a:prstGeom prst="roundRect">
+            <a:avLst>
+              <a:gd name="adj" fmla="val 16667"/>
+            </a:avLst>
+          </a:prstGeom>
+          <a:solidFill>
+            <a:srgbClr val="1E8E86"/>
+          </a:solidFill>
+          <a:ln/>
+        </p:spPr>
+      </p:sp>
+      <p:sp>
+        <p:nvSpPr>
+          <p:cNvPr id="35" name="Text 32"/>
+          <p:cNvSpPr/>
+          <p:nvPr/>
+        </p:nvSpPr>
+        <p:spPr>
+          <a:xfrm>
+            <a:off x="10698480" y="3712464"/>
+            <a:ext cx="850392" cy="237744"/>
+          </a:xfrm>
+          <a:prstGeom prst="rect">
+            <a:avLst/>
+          </a:prstGeom>
+          <a:noFill/>
+          <a:ln/>
+        </p:spPr>
+        <p:txBody>
+          <a:bodyPr wrap="square" lIns="0" tIns="0" rIns="0" bIns="0" rtlCol="0" anchor="ctr"/>
+          <a:lstStyle/>
+          <a:p>
+            <a:pPr algn="r" indent="0" marL="0">
+              <a:buNone/>
+            </a:pPr>
+            <a:r>
+              <a:rPr lang="en-US" sz="1000" b="1" dirty="0">
+                <a:solidFill>
+                  <a:srgbClr val="1E8E86"/>
+                </a:solidFill>
+                <a:latin typeface="Graphik TH" pitchFamily="34" charset="0"/>
+                <a:ea typeface="Graphik TH" pitchFamily="34" charset="-122"/>
+                <a:cs typeface="Graphik TH" pitchFamily="34" charset="-120"/>
+              </a:rPr>
+              <a:t>+144.7</a:t>
+            </a:r>
+            <a:endParaRPr lang="en-US" sz="1000" dirty="0"/>
+          </a:p>
+        </p:txBody>
+      </p:sp>
+      <p:sp>
+        <p:nvSpPr>
+          <p:cNvPr id="36" name="Text 33"/>
+          <p:cNvSpPr/>
+          <p:nvPr/>
+        </p:nvSpPr>
+        <p:spPr>
+          <a:xfrm>
+            <a:off x="7735824" y="3986784"/>
+            <a:ext cx="1005840" cy="237744"/>
+          </a:xfrm>
+          <a:prstGeom prst="rect">
+            <a:avLst/>
+          </a:prstGeom>
+          <a:noFill/>
+          <a:ln/>
+        </p:spPr>
+        <p:txBody>
+          <a:bodyPr wrap="square" lIns="0" tIns="0" rIns="0" bIns="0" rtlCol="0" anchor="ctr"/>
+          <a:lstStyle/>
+          <a:p>
+            <a:pPr indent="0" marL="0">
+              <a:buNone/>
+            </a:pPr>
+            <a:r>
+              <a:rPr lang="en-US" sz="1000" b="1" dirty="0">
+                <a:solidFill>
+                  <a:srgbClr val="16233D"/>
+                </a:solidFill>
+                <a:latin typeface="Graphik TH" pitchFamily="34" charset="0"/>
+                <a:ea typeface="Graphik TH" pitchFamily="34" charset="-122"/>
+                <a:cs typeface="Graphik TH" pitchFamily="34" charset="-120"/>
+              </a:rPr>
+              <a:t>Medium</a:t>
+            </a:r>
+            <a:endParaRPr lang="en-US" sz="1000" dirty="0"/>
+          </a:p>
+        </p:txBody>
+      </p:sp>
+      <p:sp>
+        <p:nvSpPr>
+          <p:cNvPr id="37" name="Shape 34"/>
+          <p:cNvSpPr/>
+          <p:nvPr/>
+        </p:nvSpPr>
+        <p:spPr>
+          <a:xfrm>
+            <a:off x="9683496" y="4023360"/>
+            <a:ext cx="27432" cy="164592"/>
+          </a:xfrm>
+          <a:prstGeom prst="roundRect">
+            <a:avLst>
+              <a:gd name="adj" fmla="val 100000"/>
+            </a:avLst>
+          </a:prstGeom>
+          <a:solidFill>
+            <a:srgbClr val="C00000"/>
+          </a:solidFill>
+          <a:ln/>
+        </p:spPr>
+      </p:sp>
+      <p:sp>
+        <p:nvSpPr>
+          <p:cNvPr id="38" name="Text 35"/>
+          <p:cNvSpPr/>
+          <p:nvPr/>
+        </p:nvSpPr>
+        <p:spPr>
+          <a:xfrm>
+            <a:off x="10698480" y="3986784"/>
+            <a:ext cx="850392" cy="237744"/>
+          </a:xfrm>
+          <a:prstGeom prst="rect">
+            <a:avLst/>
+          </a:prstGeom>
+          <a:noFill/>
+          <a:ln/>
+        </p:spPr>
+        <p:txBody>
+          <a:bodyPr wrap="square" lIns="0" tIns="0" rIns="0" bIns="0" rtlCol="0" anchor="ctr"/>
+          <a:lstStyle/>
+          <a:p>
+            <a:pPr algn="r" indent="0" marL="0">
+              <a:buNone/>
+            </a:pPr>
+            <a:r>
+              <a:rPr lang="en-US" sz="1000" b="1" dirty="0">
+                <a:solidFill>
+                  <a:srgbClr val="C00000"/>
+                </a:solidFill>
+                <a:latin typeface="Graphik TH" pitchFamily="34" charset="0"/>
+                <a:ea typeface="Graphik TH" pitchFamily="34" charset="-122"/>
+                <a:cs typeface="Graphik TH" pitchFamily="34" charset="-120"/>
+              </a:rPr>
+              <a:t>−1.2</a:t>
+            </a:r>
+            <a:endParaRPr lang="en-US" sz="1000" dirty="0"/>
+          </a:p>
+        </p:txBody>
+      </p:sp>
+      <p:sp>
+        <p:nvSpPr>
+          <p:cNvPr id="39" name="Text 36"/>
+          <p:cNvSpPr/>
+          <p:nvPr/>
+        </p:nvSpPr>
+        <p:spPr>
+          <a:xfrm>
+            <a:off x="7735824" y="4261104"/>
+            <a:ext cx="1005840" cy="237744"/>
+          </a:xfrm>
+          <a:prstGeom prst="rect">
+            <a:avLst/>
+          </a:prstGeom>
+          <a:noFill/>
+          <a:ln/>
+        </p:spPr>
+        <p:txBody>
+          <a:bodyPr wrap="square" lIns="0" tIns="0" rIns="0" bIns="0" rtlCol="0" anchor="ctr"/>
+          <a:lstStyle/>
+          <a:p>
+            <a:pPr indent="0" marL="0">
+              <a:buNone/>
+            </a:pPr>
+            <a:r>
+              <a:rPr lang="en-US" sz="1000" b="1" dirty="0">
+                <a:solidFill>
+                  <a:srgbClr val="16233D"/>
+                </a:solidFill>
+                <a:latin typeface="Graphik TH" pitchFamily="34" charset="0"/>
+                <a:ea typeface="Graphik TH" pitchFamily="34" charset="-122"/>
+                <a:cs typeface="Graphik TH" pitchFamily="34" charset="-120"/>
+              </a:rPr>
+              <a:t>Low</a:t>
+            </a:r>
+            <a:endParaRPr lang="en-US" sz="1000" dirty="0"/>
+          </a:p>
+        </p:txBody>
+      </p:sp>
+      <p:sp>
+        <p:nvSpPr>
+          <p:cNvPr id="40" name="Shape 37"/>
+          <p:cNvSpPr/>
+          <p:nvPr/>
+        </p:nvSpPr>
+        <p:spPr>
+          <a:xfrm>
+            <a:off x="9710928" y="4297680"/>
+            <a:ext cx="93251" cy="164592"/>
+          </a:xfrm>
+          <a:prstGeom prst="roundRect">
+            <a:avLst>
+              <a:gd name="adj" fmla="val 29417"/>
+            </a:avLst>
+          </a:prstGeom>
+          <a:solidFill>
+            <a:srgbClr val="1E8E86"/>
+          </a:solidFill>
+          <a:ln/>
+        </p:spPr>
+      </p:sp>
+      <p:sp>
+        <p:nvSpPr>
+          <p:cNvPr id="41" name="Text 38"/>
+          <p:cNvSpPr/>
+          <p:nvPr/>
+        </p:nvSpPr>
+        <p:spPr>
+          <a:xfrm>
+            <a:off x="10698480" y="4261104"/>
+            <a:ext cx="850392" cy="237744"/>
+          </a:xfrm>
+          <a:prstGeom prst="rect">
+            <a:avLst/>
+          </a:prstGeom>
+          <a:noFill/>
+          <a:ln/>
+        </p:spPr>
+        <p:txBody>
+          <a:bodyPr wrap="square" lIns="0" tIns="0" rIns="0" bIns="0" rtlCol="0" anchor="ctr"/>
+          <a:lstStyle/>
+          <a:p>
+            <a:pPr algn="r" indent="0" marL="0">
+              <a:buNone/>
+            </a:pPr>
+            <a:r>
+              <a:rPr lang="en-US" sz="1000" b="1" dirty="0">
+                <a:solidFill>
+                  <a:srgbClr val="1E8E86"/>
+                </a:solidFill>
+                <a:latin typeface="Graphik TH" pitchFamily="34" charset="0"/>
+                <a:ea typeface="Graphik TH" pitchFamily="34" charset="-122"/>
+                <a:cs typeface="Graphik TH" pitchFamily="34" charset="-120"/>
+              </a:rPr>
+              <a:t>+14.8</a:t>
+            </a:r>
+            <a:endParaRPr lang="en-US" sz="1000" dirty="0"/>
+          </a:p>
+        </p:txBody>
+      </p:sp>
+      <p:sp>
+        <p:nvSpPr>
+          <p:cNvPr id="42" name="Text 39"/>
+          <p:cNvSpPr/>
+          <p:nvPr/>
+        </p:nvSpPr>
+        <p:spPr>
+          <a:xfrm>
+            <a:off x="7735824" y="4535424"/>
+            <a:ext cx="1005840" cy="237744"/>
+          </a:xfrm>
+          <a:prstGeom prst="rect">
+            <a:avLst/>
+          </a:prstGeom>
+          <a:noFill/>
+          <a:ln/>
+        </p:spPr>
+        <p:txBody>
+          <a:bodyPr wrap="square" lIns="0" tIns="0" rIns="0" bIns="0" rtlCol="0" anchor="ctr"/>
+          <a:lstStyle/>
+          <a:p>
+            <a:pPr indent="0" marL="0">
+              <a:buNone/>
+            </a:pPr>
+            <a:r>
+              <a:rPr lang="en-US" sz="1000" b="1" dirty="0">
+                <a:solidFill>
+                  <a:srgbClr val="16233D"/>
+                </a:solidFill>
+                <a:latin typeface="Graphik TH" pitchFamily="34" charset="0"/>
+                <a:ea typeface="Graphik TH" pitchFamily="34" charset="-122"/>
+                <a:cs typeface="Graphik TH" pitchFamily="34" charset="-120"/>
+              </a:rPr>
+              <a:t>Very Low</a:t>
+            </a:r>
+            <a:endParaRPr lang="en-US" sz="1000" dirty="0"/>
+          </a:p>
+        </p:txBody>
+      </p:sp>
+      <p:sp>
+        <p:nvSpPr>
+          <p:cNvPr id="43" name="Shape 40"/>
+          <p:cNvSpPr/>
+          <p:nvPr/>
+        </p:nvSpPr>
+        <p:spPr>
+          <a:xfrm>
+            <a:off x="9641216" y="4572000"/>
+            <a:ext cx="69712" cy="164592"/>
+          </a:xfrm>
+          <a:prstGeom prst="roundRect">
+            <a:avLst>
+              <a:gd name="adj" fmla="val 39350"/>
+            </a:avLst>
+          </a:prstGeom>
+          <a:solidFill>
+            <a:srgbClr val="C00000"/>
+          </a:solidFill>
+          <a:ln/>
+        </p:spPr>
+      </p:sp>
+      <p:sp>
+        <p:nvSpPr>
+          <p:cNvPr id="44" name="Text 41"/>
+          <p:cNvSpPr/>
+          <p:nvPr/>
+        </p:nvSpPr>
+        <p:spPr>
+          <a:xfrm>
+            <a:off x="10698480" y="4535424"/>
+            <a:ext cx="850392" cy="237744"/>
+          </a:xfrm>
+          <a:prstGeom prst="rect">
+            <a:avLst/>
+          </a:prstGeom>
+          <a:noFill/>
+          <a:ln/>
+        </p:spPr>
+        <p:txBody>
+          <a:bodyPr wrap="square" lIns="0" tIns="0" rIns="0" bIns="0" rtlCol="0" anchor="ctr"/>
+          <a:lstStyle/>
+          <a:p>
+            <a:pPr algn="r" indent="0" marL="0">
+              <a:buNone/>
+            </a:pPr>
+            <a:r>
+              <a:rPr lang="en-US" sz="1000" b="1" dirty="0">
+                <a:solidFill>
+                  <a:srgbClr val="C00000"/>
+                </a:solidFill>
+                <a:latin typeface="Graphik TH" pitchFamily="34" charset="0"/>
+                <a:ea typeface="Graphik TH" pitchFamily="34" charset="-122"/>
+                <a:cs typeface="Graphik TH" pitchFamily="34" charset="-120"/>
+              </a:rPr>
+              <a:t>−11.0</a:t>
+            </a:r>
+            <a:endParaRPr lang="en-US" sz="1000" dirty="0"/>
+          </a:p>
+        </p:txBody>
+      </p:sp>
+      <p:sp>
+        <p:nvSpPr>
+          <p:cNvPr id="45" name="Shape 42"/>
+          <p:cNvSpPr/>
+          <p:nvPr/>
+        </p:nvSpPr>
+        <p:spPr>
+          <a:xfrm>
+            <a:off x="7735824" y="4846320"/>
+            <a:ext cx="3813048" cy="274320"/>
+          </a:xfrm>
+          <a:prstGeom prst="roundRect">
+            <a:avLst>
+              <a:gd name="adj" fmla="val 30000"/>
+            </a:avLst>
+          </a:prstGeom>
+          <a:solidFill>
+            <a:srgbClr val="FBF0E6"/>
+          </a:solidFill>
+          <a:ln/>
+        </p:spPr>
+      </p:sp>
+      <p:sp>
+        <p:nvSpPr>
+          <p:cNvPr id="46" name="Text 43"/>
+          <p:cNvSpPr/>
+          <p:nvPr/>
+        </p:nvSpPr>
+        <p:spPr>
+          <a:xfrm>
+            <a:off x="7882128" y="4846320"/>
+            <a:ext cx="3520440" cy="274320"/>
+          </a:xfrm>
+          <a:prstGeom prst="rect">
+            <a:avLst/>
+          </a:prstGeom>
+          <a:noFill/>
+          <a:ln/>
+        </p:spPr>
+        <p:txBody>
+          <a:bodyPr wrap="square" lIns="0" tIns="0" rIns="0" bIns="0" rtlCol="0" anchor="ctr"/>
+          <a:lstStyle/>
+          <a:p>
+            <a:pPr indent="0" marL="0">
+              <a:buNone/>
+            </a:pPr>
+            <a:r>
+              <a:rPr lang="en-US" sz="950" dirty="0">
+                <a:solidFill>
+                  <a:srgbClr val="16233D"/>
+                </a:solidFill>
+                <a:latin typeface="Graphik TH" pitchFamily="34" charset="0"/>
+                <a:ea typeface="Graphik TH" pitchFamily="34" charset="-122"/>
+                <a:cs typeface="Graphik TH" pitchFamily="34" charset="-120"/>
+              </a:rPr>
+              <a:t>High sensitivity gained; Very High lost.</a:t>
+            </a:r>
+            <a:endParaRPr lang="en-US" sz="950" dirty="0"/>
+          </a:p>
+        </p:txBody>
+      </p:sp>
+      <p:sp>
+        <p:nvSpPr>
+          <p:cNvPr id="47" name="Shape 44"/>
+          <p:cNvSpPr/>
+          <p:nvPr/>
+        </p:nvSpPr>
+        <p:spPr>
+          <a:xfrm>
+            <a:off x="530352" y="5285232"/>
+            <a:ext cx="11274552" cy="786384"/>
+          </a:xfrm>
+          <a:prstGeom prst="roundRect">
+            <a:avLst>
+              <a:gd name="adj" fmla="val 10465"/>
+            </a:avLst>
+          </a:prstGeom>
+          <a:solidFill>
+            <a:srgbClr val="E8F6F3"/>
+          </a:solidFill>
+          <a:ln/>
+        </p:spPr>
+      </p:sp>
+      <p:sp>
+        <p:nvSpPr>
+          <p:cNvPr id="48" name="Text 45"/>
+          <p:cNvSpPr/>
+          <p:nvPr/>
+        </p:nvSpPr>
+        <p:spPr>
+          <a:xfrm>
+            <a:off x="804672" y="5285232"/>
+            <a:ext cx="10725912" cy="786384"/>
+          </a:xfrm>
+          <a:prstGeom prst="rect">
+            <a:avLst/>
+          </a:prstGeom>
+          <a:noFill/>
+          <a:ln/>
+        </p:spPr>
+        <p:txBody>
+          <a:bodyPr wrap="square" lIns="0" tIns="0" rIns="0" bIns="0" rtlCol="0" anchor="ctr"/>
+          <a:lstStyle/>
+          <a:p>
+            <a:pPr indent="0" marL="0">
+              <a:buNone/>
+            </a:pPr>
+            <a:r>
+              <a:rPr lang="en-US" sz="1100" b="1" dirty="0">
+                <a:solidFill>
+                  <a:srgbClr val="045D66"/>
+                </a:solidFill>
+                <a:latin typeface="Graphik TH" pitchFamily="34" charset="0"/>
+                <a:ea typeface="Graphik TH" pitchFamily="34" charset="-122"/>
+                <a:cs typeface="Graphik TH" pitchFamily="34" charset="-120"/>
+              </a:rPr>
+              <a:t>High rate sensitivity moved most and gained +144.7m; Very High moved least and lost 36.0m</a:t>
+            </a:r>
+            <a:pPr indent="0" marL="0">
+              <a:buNone/>
+            </a:pPr>
+            <a:r>
+              <a:rPr lang="en-US" sz="1100" dirty="0">
+                <a:solidFill>
+                  <a:srgbClr val="16233D"/>
+                </a:solidFill>
+                <a:latin typeface="Graphik TH" pitchFamily="34" charset="0"/>
+                <a:ea typeface="Graphik TH" pitchFamily="34" charset="-122"/>
+                <a:cs typeface="Graphik TH" pitchFamily="34" charset="-120"/>
+              </a:rPr>
+              <a:t>  —  emptying the promotional pocket is a reallocation, not a withdrawal. The balance actually leaving sits with customers the score calls least rate-sensitive.</a:t>
+            </a:r>
+            <a:endParaRPr lang="en-US" sz="1100" dirty="0"/>
+          </a:p>
+        </p:txBody>
+      </p:sp>
+    </p:spTree>
+  </p:cSld>
+  <p:clrMapOvr>
+    <a:masterClrMapping/>
+  </p:clrMapOvr>
+</p:sld>
+</file>
+
 <file path=ppt/slides/slide2.xml><?xml version="1.0" encoding="utf-8"?>
 <p:sld xmlns:a="http://schemas.openxmlformats.org/drawingml/2006/main" xmlns:r="http://schemas.openxmlformats.org/officeDocument/2006/relationships" xmlns:p="http://schemas.openxmlformats.org/presentationml/2006/main">
   <p:cSld name="Slide 2">

</xml_diff>

<commit_message>
Add side-by-side slide showing the inversion is specific to rate sensitivity
Slide 14 puts both scores on both measures. Deposit stickiness ranks
move rate and balance change the same way - move rate runs 1.9% to 19.2%
and every tier gained. Rate sensitivity does not: High moves at 49.5%
and gained THB 144.7m while Very High moves at 12.9% and lost THB 36.0m.

The takeaway band states the caveat rather than hiding it - stickiness
alignment is partly a size effect, since its two top tiers hold 98.8% of
prior balance and contributed 95.5% of the gain, and in percentage terms
the ordering is flatter and mildly reversed.

Tiers under 50 customers are greyed, which suppresses the 4-customer
Medium band in both panels.

Co-Authored-By: Claude Opus 5 <noreply@anthropic.com>
Claude-Session: https://claude.ai/code/session_01VKpfo226Go9vQJYa4eoC1d
</commit_message>
<xml_diff>
--- a/Deposit_Stickiness_Framework.pptx
+++ b/Deposit_Stickiness_Framework.pptx
@@ -18,9 +18,10 @@
     <p:sldId id="266" r:id="rId12"/>
     <p:sldId id="267" r:id="rId13"/>
     <p:sldId id="268" r:id="rId14"/>
+    <p:sldId id="269" r:id="rId15"/>
   </p:sldIdLst>
   <p:notesMasterIdLst>
-    <p:notesMasterId r:id="rId15"/>
+    <p:notesMasterId r:id="rId16"/>
   </p:notesMasterIdLst>
   <p:sldSz cx="12192000" cy="6858000"/>
   <p:notesSz cx="6858000" cy="12192000"/>
@@ -890,6 +891,94 @@
             <a:fld id="{F7021451-1387-4CA6-816F-3879F97B5CBC}" type="slidenum">
               <a:rPr lang="en-US"/>
               <a:t>13</a:t>
+            </a:fld>
+            <a:endParaRPr lang="en-US"/>
+          </a:p>
+        </p:txBody>
+      </p:sp>
+    </p:spTree>
+    <p:extLst>
+      <p:ext uri="{BB962C8B-B14F-4D97-AF65-F5344CB8AC3E}">
+        <p14:creationId xmlns:p14="http://schemas.microsoft.com/office/powerpoint/2010/main" val="1024086991"/>
+      </p:ext>
+    </p:extLst>
+  </p:cSld>
+  <p:clrMapOvr>
+    <a:masterClrMapping/>
+  </p:clrMapOvr>
+</p:notes>
+</file>
+
+<file path=ppt/notesSlides/notesSlide14.xml><?xml version="1.0" encoding="utf-8"?>
+<p:notes xmlns:a="http://schemas.openxmlformats.org/drawingml/2006/main" xmlns:r="http://schemas.openxmlformats.org/officeDocument/2006/relationships" xmlns:p="http://schemas.openxmlformats.org/presentationml/2006/main">
+  <p:cSld>
+    <p:spTree>
+      <p:nvGrpSpPr>
+        <p:cNvPr id="1" name=""/>
+        <p:cNvGrpSpPr/>
+        <p:nvPr/>
+      </p:nvGrpSpPr>
+      <p:grpSpPr>
+        <a:xfrm>
+          <a:off x="0" y="0"/>
+          <a:ext cx="0" cy="0"/>
+          <a:chOff x="0" y="0"/>
+          <a:chExt cx="0" cy="0"/>
+        </a:xfrm>
+      </p:grpSpPr>
+      <p:sp>
+        <p:nvSpPr>
+          <p:cNvPr id="2" name="Slide Image Placeholder 1"/>
+          <p:cNvSpPr>
+            <a:spLocks noGrp="1" noRot="1" noChangeAspect="1"/>
+          </p:cNvSpPr>
+          <p:nvPr>
+            <p:ph type="sldImg"/>
+          </p:nvPr>
+        </p:nvSpPr>
+        <p:spPr/>
+      </p:sp>
+      <p:sp>
+        <p:nvSpPr>
+          <p:cNvPr id="3" name="Notes Placeholder 2"/>
+          <p:cNvSpPr>
+            <a:spLocks noGrp="1"/>
+          </p:cNvSpPr>
+          <p:nvPr>
+            <p:ph type="body" idx="1"/>
+          </p:nvPr>
+        </p:nvSpPr>
+        <p:spPr/>
+        <p:txBody>
+          <a:bodyPr/>
+          <a:lstStyle/>
+          <a:p>
+            <a:r>
+              <a:rPr lang="en-US" dirty="0"/>
+              <a:t>Deposit stickiness ranks the two measures consistently: move rate runs 1.9% to 19.2% from Very Low to Very High, and balance change is positive in every tier. The caveat is that this consistency is partly mechanical - the High and Very High tiers hold 98.8% of prior balance and contributed 95.5% of the cohort's gain, so the ranking largely restates where the money is. In percentage terms the picture is flatter and mildly reversed: Very High +3.2%, High +4.0%, Medium +8.8%, with the Low and Very Low tiers unusable because their prior balances are near zero. Rate sensitivity diverges for real: High moves at 49.5% and gained THB 144.7m, while Very High moves at 12.9% and lost THB 36.0m. Very Low also lost, THB 11.0m on a 9.6% move rate. Medium is 4 customers in both scores and is greyed out rather than read. Conclusion for the framework: stickiness can stay as an activity and eligibility filter, but rate-sensitivity cut-offs should be re-fitted on observed outcomes, and the two outcomes - emptying the pocket and losing balance - should be scored separately.</a:t>
+            </a:r>
+            <a:endParaRPr lang="en-US" dirty="0"/>
+          </a:p>
+        </p:txBody>
+      </p:sp>
+      <p:sp>
+        <p:nvSpPr>
+          <p:cNvPr id="4" name="Slide Number Placeholder 3"/>
+          <p:cNvSpPr>
+            <a:spLocks noGrp="1"/>
+          </p:cNvSpPr>
+          <p:nvPr>
+            <p:ph type="sldNum" sz="quarter" idx="10"/>
+          </p:nvPr>
+        </p:nvSpPr>
+        <p:spPr/>
+        <p:txBody>
+          <a:bodyPr/>
+          <a:lstStyle/>
+          <a:p>
+            <a:fld id="{F7021451-1387-4CA6-816F-3879F97B5CBC}" type="slidenum">
+              <a:rPr lang="en-US"/>
+              <a:t>14</a:t>
             </a:fld>
             <a:endParaRPr lang="en-US"/>
           </a:p>
@@ -17784,6 +17873,2831 @@
 </p:sld>
 </file>
 
+<file path=ppt/slides/slide14.xml><?xml version="1.0" encoding="utf-8"?>
+<p:sld xmlns:a="http://schemas.openxmlformats.org/drawingml/2006/main" xmlns:r="http://schemas.openxmlformats.org/officeDocument/2006/relationships" xmlns:p="http://schemas.openxmlformats.org/presentationml/2006/main">
+  <p:cSld name="Slide 14">
+    <p:bg>
+      <p:bgPr>
+        <a:solidFill>
+          <a:srgbClr val="FFFFFF"/>
+        </a:solidFill>
+      </p:bgPr>
+    </p:bg>
+    <p:spTree>
+      <p:nvGrpSpPr>
+        <p:cNvPr id="1" name=""/>
+        <p:cNvGrpSpPr/>
+        <p:nvPr/>
+      </p:nvGrpSpPr>
+      <p:grpSpPr>
+        <a:xfrm>
+          <a:off x="0" y="0"/>
+          <a:ext cx="0" cy="0"/>
+          <a:chOff x="0" y="0"/>
+          <a:chExt cx="0" cy="0"/>
+        </a:xfrm>
+      </p:grpSpPr>
+      <p:sp>
+        <p:nvSpPr>
+          <p:cNvPr id="2" name="Text 0"/>
+          <p:cNvSpPr/>
+          <p:nvPr/>
+        </p:nvSpPr>
+        <p:spPr>
+          <a:xfrm>
+            <a:off x="530352" y="283464"/>
+            <a:ext cx="11274552" cy="384048"/>
+          </a:xfrm>
+          <a:prstGeom prst="rect">
+            <a:avLst/>
+          </a:prstGeom>
+          <a:noFill/>
+          <a:ln/>
+        </p:spPr>
+        <p:txBody>
+          <a:bodyPr wrap="square" lIns="0" tIns="0" rIns="0" bIns="0" rtlCol="0" anchor="ctr"/>
+          <a:lstStyle/>
+          <a:p>
+            <a:pPr indent="0" marL="0">
+              <a:buNone/>
+            </a:pPr>
+            <a:r>
+              <a:rPr lang="en-US" sz="2200" b="1" dirty="0">
+                <a:solidFill>
+                  <a:srgbClr val="045D66"/>
+                </a:solidFill>
+                <a:latin typeface="Graphik TH" pitchFamily="34" charset="0"/>
+                <a:ea typeface="Graphik TH" pitchFamily="34" charset="-122"/>
+                <a:cs typeface="Graphik TH" pitchFamily="34" charset="-120"/>
+              </a:rPr>
+              <a:t>The inversion belongs to rate sensitivity, not stickiness</a:t>
+            </a:r>
+            <a:endParaRPr lang="en-US" sz="2200" dirty="0"/>
+          </a:p>
+        </p:txBody>
+      </p:sp>
+      <p:sp>
+        <p:nvSpPr>
+          <p:cNvPr id="3" name="Text 1"/>
+          <p:cNvSpPr/>
+          <p:nvPr/>
+        </p:nvSpPr>
+        <p:spPr>
+          <a:xfrm>
+            <a:off x="530352" y="713232"/>
+            <a:ext cx="11274552" cy="237744"/>
+          </a:xfrm>
+          <a:prstGeom prst="rect">
+            <a:avLst/>
+          </a:prstGeom>
+          <a:noFill/>
+          <a:ln/>
+        </p:spPr>
+        <p:txBody>
+          <a:bodyPr wrap="square" lIns="0" tIns="0" rIns="0" bIns="0" rtlCol="0" anchor="ctr"/>
+          <a:lstStyle/>
+          <a:p>
+            <a:pPr indent="0" marL="0">
+              <a:buNone/>
+            </a:pPr>
+            <a:r>
+              <a:rPr lang="en-US" sz="1150" i="1" dirty="0">
+                <a:solidFill>
+                  <a:srgbClr val="6B6B6B"/>
+                </a:solidFill>
+                <a:latin typeface="Graphik TH" pitchFamily="34" charset="0"/>
+                <a:ea typeface="Graphik TH" pitchFamily="34" charset="-122"/>
+                <a:cs typeface="Graphik TH" pitchFamily="34" charset="-120"/>
+              </a:rPr>
+              <a:t>*Move rate = share of tier that emptied Save Max. Percentages suppressed below THB 5m prior balance; tiers under 50 customers greyed.</a:t>
+            </a:r>
+            <a:endParaRPr lang="en-US" sz="1150" dirty="0"/>
+          </a:p>
+        </p:txBody>
+      </p:sp>
+      <p:sp>
+        <p:nvSpPr>
+          <p:cNvPr id="4" name="Text 2"/>
+          <p:cNvSpPr/>
+          <p:nvPr/>
+        </p:nvSpPr>
+        <p:spPr>
+          <a:xfrm>
+            <a:off x="548640" y="996696"/>
+            <a:ext cx="11064240" cy="237744"/>
+          </a:xfrm>
+          <a:prstGeom prst="rect">
+            <a:avLst/>
+          </a:prstGeom>
+          <a:noFill/>
+          <a:ln/>
+        </p:spPr>
+        <p:txBody>
+          <a:bodyPr wrap="square" lIns="0" tIns="0" rIns="0" bIns="0" rtlCol="0" anchor="ctr"/>
+          <a:lstStyle/>
+          <a:p>
+            <a:pPr indent="0" marL="0">
+              <a:buNone/>
+            </a:pPr>
+            <a:r>
+              <a:rPr lang="en-US" sz="1300" b="1" dirty="0">
+                <a:solidFill>
+                  <a:srgbClr val="045D66"/>
+                </a:solidFill>
+                <a:latin typeface="Graphik TH" pitchFamily="34" charset="0"/>
+                <a:ea typeface="Graphik TH" pitchFamily="34" charset="-122"/>
+                <a:cs typeface="Graphik TH" pitchFamily="34" charset="-120"/>
+              </a:rPr>
+              <a:t>Cohort 47,184   ·   Move rate 14.1%   ·   Balance +111.3m   ·   Stickiness ≥ 60 contributed +106.3m of it</a:t>
+            </a:r>
+            <a:endParaRPr lang="en-US" sz="1300" dirty="0"/>
+          </a:p>
+        </p:txBody>
+      </p:sp>
+      <p:sp>
+        <p:nvSpPr>
+          <p:cNvPr id="5" name="Text 3"/>
+          <p:cNvSpPr/>
+          <p:nvPr/>
+        </p:nvSpPr>
+        <p:spPr>
+          <a:xfrm>
+            <a:off x="548640" y="1280160"/>
+            <a:ext cx="11064240" cy="274320"/>
+          </a:xfrm>
+          <a:prstGeom prst="rect">
+            <a:avLst/>
+          </a:prstGeom>
+          <a:noFill/>
+          <a:ln/>
+        </p:spPr>
+        <p:txBody>
+          <a:bodyPr wrap="square" lIns="0" tIns="0" rIns="0" bIns="0" rtlCol="0" anchor="ctr"/>
+          <a:lstStyle/>
+          <a:p>
+            <a:pPr indent="0" marL="0">
+              <a:buNone/>
+            </a:pPr>
+            <a:r>
+              <a:rPr lang="en-US" sz="1400" dirty="0">
+                <a:solidFill>
+                  <a:srgbClr val="16233D"/>
+                </a:solidFill>
+                <a:latin typeface="Graphik TH" pitchFamily="34" charset="0"/>
+                <a:ea typeface="Graphik TH" pitchFamily="34" charset="-122"/>
+                <a:cs typeface="Graphik TH" pitchFamily="34" charset="-120"/>
+              </a:rPr>
+              <a:t>Stickiness ranks both measures the same way; rate sensitivity ranks them in opposite directions.</a:t>
+            </a:r>
+            <a:endParaRPr lang="en-US" sz="1400" dirty="0"/>
+          </a:p>
+        </p:txBody>
+      </p:sp>
+      <p:sp>
+        <p:nvSpPr>
+          <p:cNvPr id="6" name="Shape 4"/>
+          <p:cNvSpPr/>
+          <p:nvPr/>
+        </p:nvSpPr>
+        <p:spPr>
+          <a:xfrm>
+            <a:off x="530352" y="1645920"/>
+            <a:ext cx="2647188" cy="987552"/>
+          </a:xfrm>
+          <a:prstGeom prst="roundRect">
+            <a:avLst>
+              <a:gd name="adj" fmla="val 8333"/>
+            </a:avLst>
+          </a:prstGeom>
+          <a:solidFill>
+            <a:srgbClr val="F1F4F9"/>
+          </a:solidFill>
+          <a:ln/>
+        </p:spPr>
+      </p:sp>
+      <p:sp>
+        <p:nvSpPr>
+          <p:cNvPr id="7" name="Text 5"/>
+          <p:cNvSpPr/>
+          <p:nvPr/>
+        </p:nvSpPr>
+        <p:spPr>
+          <a:xfrm>
+            <a:off x="749808" y="1719072"/>
+            <a:ext cx="2208276" cy="402336"/>
+          </a:xfrm>
+          <a:prstGeom prst="rect">
+            <a:avLst/>
+          </a:prstGeom>
+          <a:noFill/>
+          <a:ln/>
+        </p:spPr>
+        <p:txBody>
+          <a:bodyPr wrap="square" lIns="0" tIns="0" rIns="0" bIns="0" rtlCol="0" anchor="ctr"/>
+          <a:lstStyle/>
+          <a:p>
+            <a:pPr indent="0" marL="0">
+              <a:buNone/>
+            </a:pPr>
+            <a:r>
+              <a:rPr lang="en-US" sz="2000" b="1" dirty="0">
+                <a:solidFill>
+                  <a:srgbClr val="00A896"/>
+                </a:solidFill>
+                <a:latin typeface="Graphik TH" pitchFamily="34" charset="0"/>
+                <a:ea typeface="Graphik TH" pitchFamily="34" charset="-122"/>
+                <a:cs typeface="Graphik TH" pitchFamily="34" charset="-120"/>
+              </a:rPr>
+              <a:t>1.9% → 19.2%</a:t>
+            </a:r>
+            <a:endParaRPr lang="en-US" sz="2000" dirty="0"/>
+          </a:p>
+        </p:txBody>
+      </p:sp>
+      <p:sp>
+        <p:nvSpPr>
+          <p:cNvPr id="8" name="Text 6"/>
+          <p:cNvSpPr/>
+          <p:nvPr/>
+        </p:nvSpPr>
+        <p:spPr>
+          <a:xfrm>
+            <a:off x="749808" y="2121408"/>
+            <a:ext cx="2208276" cy="237744"/>
+          </a:xfrm>
+          <a:prstGeom prst="rect">
+            <a:avLst/>
+          </a:prstGeom>
+          <a:noFill/>
+          <a:ln/>
+        </p:spPr>
+        <p:txBody>
+          <a:bodyPr wrap="square" lIns="0" tIns="0" rIns="0" bIns="0" rtlCol="0" anchor="t"/>
+          <a:lstStyle/>
+          <a:p>
+            <a:pPr indent="0" marL="0">
+              <a:buNone/>
+            </a:pPr>
+            <a:r>
+              <a:rPr lang="en-US" sz="1150" b="1" dirty="0">
+                <a:solidFill>
+                  <a:srgbClr val="16233D"/>
+                </a:solidFill>
+                <a:latin typeface="Graphik TH" pitchFamily="34" charset="0"/>
+                <a:ea typeface="Graphik TH" pitchFamily="34" charset="-122"/>
+                <a:cs typeface="Graphik TH" pitchFamily="34" charset="-120"/>
+              </a:rPr>
+              <a:t>move rate by stickiness</a:t>
+            </a:r>
+            <a:endParaRPr lang="en-US" sz="1150" dirty="0"/>
+          </a:p>
+        </p:txBody>
+      </p:sp>
+      <p:sp>
+        <p:nvSpPr>
+          <p:cNvPr id="9" name="Text 7"/>
+          <p:cNvSpPr/>
+          <p:nvPr/>
+        </p:nvSpPr>
+        <p:spPr>
+          <a:xfrm>
+            <a:off x="749808" y="2350008"/>
+            <a:ext cx="2208276" cy="237744"/>
+          </a:xfrm>
+          <a:prstGeom prst="rect">
+            <a:avLst/>
+          </a:prstGeom>
+          <a:noFill/>
+          <a:ln/>
+        </p:spPr>
+        <p:txBody>
+          <a:bodyPr wrap="square" lIns="0" tIns="0" rIns="0" bIns="0" rtlCol="0" anchor="t"/>
+          <a:lstStyle/>
+          <a:p>
+            <a:pPr indent="0" marL="0">
+              <a:buNone/>
+            </a:pPr>
+            <a:r>
+              <a:rPr lang="en-US" sz="950" dirty="0">
+                <a:solidFill>
+                  <a:srgbClr val="6B7A90"/>
+                </a:solidFill>
+                <a:latin typeface="Graphik TH" pitchFamily="34" charset="0"/>
+                <a:ea typeface="Graphik TH" pitchFamily="34" charset="-122"/>
+                <a:cs typeface="Graphik TH" pitchFamily="34" charset="-120"/>
+              </a:rPr>
+              <a:t>Very Low tier to Very High tier</a:t>
+            </a:r>
+            <a:endParaRPr lang="en-US" sz="950" dirty="0"/>
+          </a:p>
+        </p:txBody>
+      </p:sp>
+      <p:sp>
+        <p:nvSpPr>
+          <p:cNvPr id="10" name="Shape 8"/>
+          <p:cNvSpPr/>
+          <p:nvPr/>
+        </p:nvSpPr>
+        <p:spPr>
+          <a:xfrm>
+            <a:off x="3406140" y="1645920"/>
+            <a:ext cx="2647188" cy="987552"/>
+          </a:xfrm>
+          <a:prstGeom prst="roundRect">
+            <a:avLst>
+              <a:gd name="adj" fmla="val 8333"/>
+            </a:avLst>
+          </a:prstGeom>
+          <a:solidFill>
+            <a:srgbClr val="F1F4F9"/>
+          </a:solidFill>
+          <a:ln/>
+        </p:spPr>
+      </p:sp>
+      <p:sp>
+        <p:nvSpPr>
+          <p:cNvPr id="11" name="Text 9"/>
+          <p:cNvSpPr/>
+          <p:nvPr/>
+        </p:nvSpPr>
+        <p:spPr>
+          <a:xfrm>
+            <a:off x="3625596" y="1719072"/>
+            <a:ext cx="2208276" cy="402336"/>
+          </a:xfrm>
+          <a:prstGeom prst="rect">
+            <a:avLst/>
+          </a:prstGeom>
+          <a:noFill/>
+          <a:ln/>
+        </p:spPr>
+        <p:txBody>
+          <a:bodyPr wrap="square" lIns="0" tIns="0" rIns="0" bIns="0" rtlCol="0" anchor="ctr"/>
+          <a:lstStyle/>
+          <a:p>
+            <a:pPr indent="0" marL="0">
+              <a:buNone/>
+            </a:pPr>
+            <a:r>
+              <a:rPr lang="en-US" sz="2400" b="1" dirty="0">
+                <a:solidFill>
+                  <a:srgbClr val="00A896"/>
+                </a:solidFill>
+                <a:latin typeface="Graphik TH" pitchFamily="34" charset="0"/>
+                <a:ea typeface="Graphik TH" pitchFamily="34" charset="-122"/>
+                <a:cs typeface="Graphik TH" pitchFamily="34" charset="-120"/>
+              </a:rPr>
+              <a:t>+106.3m</a:t>
+            </a:r>
+            <a:endParaRPr lang="en-US" sz="2400" dirty="0"/>
+          </a:p>
+        </p:txBody>
+      </p:sp>
+      <p:sp>
+        <p:nvSpPr>
+          <p:cNvPr id="12" name="Text 10"/>
+          <p:cNvSpPr/>
+          <p:nvPr/>
+        </p:nvSpPr>
+        <p:spPr>
+          <a:xfrm>
+            <a:off x="3625596" y="2121408"/>
+            <a:ext cx="2208276" cy="237744"/>
+          </a:xfrm>
+          <a:prstGeom prst="rect">
+            <a:avLst/>
+          </a:prstGeom>
+          <a:noFill/>
+          <a:ln/>
+        </p:spPr>
+        <p:txBody>
+          <a:bodyPr wrap="square" lIns="0" tIns="0" rIns="0" bIns="0" rtlCol="0" anchor="t"/>
+          <a:lstStyle/>
+          <a:p>
+            <a:pPr indent="0" marL="0">
+              <a:buNone/>
+            </a:pPr>
+            <a:r>
+              <a:rPr lang="en-US" sz="1150" b="1" dirty="0">
+                <a:solidFill>
+                  <a:srgbClr val="16233D"/>
+                </a:solidFill>
+                <a:latin typeface="Graphik TH" pitchFamily="34" charset="0"/>
+                <a:ea typeface="Graphik TH" pitchFamily="34" charset="-122"/>
+                <a:cs typeface="Graphik TH" pitchFamily="34" charset="-120"/>
+              </a:rPr>
+              <a:t>gained by stickiness ≥ 60</a:t>
+            </a:r>
+            <a:endParaRPr lang="en-US" sz="1150" dirty="0"/>
+          </a:p>
+        </p:txBody>
+      </p:sp>
+      <p:sp>
+        <p:nvSpPr>
+          <p:cNvPr id="13" name="Text 11"/>
+          <p:cNvSpPr/>
+          <p:nvPr/>
+        </p:nvSpPr>
+        <p:spPr>
+          <a:xfrm>
+            <a:off x="3625596" y="2350008"/>
+            <a:ext cx="2208276" cy="237744"/>
+          </a:xfrm>
+          <a:prstGeom prst="rect">
+            <a:avLst/>
+          </a:prstGeom>
+          <a:noFill/>
+          <a:ln/>
+        </p:spPr>
+        <p:txBody>
+          <a:bodyPr wrap="square" lIns="0" tIns="0" rIns="0" bIns="0" rtlCol="0" anchor="t"/>
+          <a:lstStyle/>
+          <a:p>
+            <a:pPr indent="0" marL="0">
+              <a:buNone/>
+            </a:pPr>
+            <a:r>
+              <a:rPr lang="en-US" sz="950" dirty="0">
+                <a:solidFill>
+                  <a:srgbClr val="6B7A90"/>
+                </a:solidFill>
+                <a:latin typeface="Graphik TH" pitchFamily="34" charset="0"/>
+                <a:ea typeface="Graphik TH" pitchFamily="34" charset="-122"/>
+                <a:cs typeface="Graphik TH" pitchFamily="34" charset="-120"/>
+              </a:rPr>
+              <a:t>96% of the cohort's total gain</a:t>
+            </a:r>
+            <a:endParaRPr lang="en-US" sz="950" dirty="0"/>
+          </a:p>
+        </p:txBody>
+      </p:sp>
+      <p:sp>
+        <p:nvSpPr>
+          <p:cNvPr id="14" name="Shape 12"/>
+          <p:cNvSpPr/>
+          <p:nvPr/>
+        </p:nvSpPr>
+        <p:spPr>
+          <a:xfrm>
+            <a:off x="6281928" y="1645920"/>
+            <a:ext cx="2647188" cy="987552"/>
+          </a:xfrm>
+          <a:prstGeom prst="roundRect">
+            <a:avLst>
+              <a:gd name="adj" fmla="val 8333"/>
+            </a:avLst>
+          </a:prstGeom>
+          <a:solidFill>
+            <a:srgbClr val="F1F4F9"/>
+          </a:solidFill>
+          <a:ln/>
+        </p:spPr>
+      </p:sp>
+      <p:sp>
+        <p:nvSpPr>
+          <p:cNvPr id="15" name="Text 13"/>
+          <p:cNvSpPr/>
+          <p:nvPr/>
+        </p:nvSpPr>
+        <p:spPr>
+          <a:xfrm>
+            <a:off x="6501384" y="1719072"/>
+            <a:ext cx="2208276" cy="402336"/>
+          </a:xfrm>
+          <a:prstGeom prst="rect">
+            <a:avLst/>
+          </a:prstGeom>
+          <a:noFill/>
+          <a:ln/>
+        </p:spPr>
+        <p:txBody>
+          <a:bodyPr wrap="square" lIns="0" tIns="0" rIns="0" bIns="0" rtlCol="0" anchor="ctr"/>
+          <a:lstStyle/>
+          <a:p>
+            <a:pPr indent="0" marL="0">
+              <a:buNone/>
+            </a:pPr>
+            <a:r>
+              <a:rPr lang="en-US" sz="1800" b="1" dirty="0">
+                <a:solidFill>
+                  <a:srgbClr val="C00000"/>
+                </a:solidFill>
+                <a:latin typeface="Graphik TH" pitchFamily="34" charset="0"/>
+                <a:ea typeface="Graphik TH" pitchFamily="34" charset="-122"/>
+                <a:cs typeface="Graphik TH" pitchFamily="34" charset="-120"/>
+              </a:rPr>
+              <a:t>49.5% / 12.9%</a:t>
+            </a:r>
+            <a:endParaRPr lang="en-US" sz="1800" dirty="0"/>
+          </a:p>
+        </p:txBody>
+      </p:sp>
+      <p:sp>
+        <p:nvSpPr>
+          <p:cNvPr id="16" name="Text 14"/>
+          <p:cNvSpPr/>
+          <p:nvPr/>
+        </p:nvSpPr>
+        <p:spPr>
+          <a:xfrm>
+            <a:off x="6501384" y="2121408"/>
+            <a:ext cx="2208276" cy="237744"/>
+          </a:xfrm>
+          <a:prstGeom prst="rect">
+            <a:avLst/>
+          </a:prstGeom>
+          <a:noFill/>
+          <a:ln/>
+        </p:spPr>
+        <p:txBody>
+          <a:bodyPr wrap="square" lIns="0" tIns="0" rIns="0" bIns="0" rtlCol="0" anchor="t"/>
+          <a:lstStyle/>
+          <a:p>
+            <a:pPr indent="0" marL="0">
+              <a:buNone/>
+            </a:pPr>
+            <a:r>
+              <a:rPr lang="en-US" sz="1150" b="1" dirty="0">
+                <a:solidFill>
+                  <a:srgbClr val="16233D"/>
+                </a:solidFill>
+                <a:latin typeface="Graphik TH" pitchFamily="34" charset="0"/>
+                <a:ea typeface="Graphik TH" pitchFamily="34" charset="-122"/>
+                <a:cs typeface="Graphik TH" pitchFamily="34" charset="-120"/>
+              </a:rPr>
+              <a:t>move rate, High / V.High</a:t>
+            </a:r>
+            <a:endParaRPr lang="en-US" sz="1150" dirty="0"/>
+          </a:p>
+        </p:txBody>
+      </p:sp>
+      <p:sp>
+        <p:nvSpPr>
+          <p:cNvPr id="17" name="Text 15"/>
+          <p:cNvSpPr/>
+          <p:nvPr/>
+        </p:nvSpPr>
+        <p:spPr>
+          <a:xfrm>
+            <a:off x="6501384" y="2350008"/>
+            <a:ext cx="2208276" cy="237744"/>
+          </a:xfrm>
+          <a:prstGeom prst="rect">
+            <a:avLst/>
+          </a:prstGeom>
+          <a:noFill/>
+          <a:ln/>
+        </p:spPr>
+        <p:txBody>
+          <a:bodyPr wrap="square" lIns="0" tIns="0" rIns="0" bIns="0" rtlCol="0" anchor="t"/>
+          <a:lstStyle/>
+          <a:p>
+            <a:pPr indent="0" marL="0">
+              <a:buNone/>
+            </a:pPr>
+            <a:r>
+              <a:rPr lang="en-US" sz="950" dirty="0">
+                <a:solidFill>
+                  <a:srgbClr val="6B7A90"/>
+                </a:solidFill>
+                <a:latin typeface="Graphik TH" pitchFamily="34" charset="0"/>
+                <a:ea typeface="Graphik TH" pitchFamily="34" charset="-122"/>
+                <a:cs typeface="Graphik TH" pitchFamily="34" charset="-120"/>
+              </a:rPr>
+              <a:t>the score's top band moves least</a:t>
+            </a:r>
+            <a:endParaRPr lang="en-US" sz="950" dirty="0"/>
+          </a:p>
+        </p:txBody>
+      </p:sp>
+      <p:sp>
+        <p:nvSpPr>
+          <p:cNvPr id="18" name="Shape 16"/>
+          <p:cNvSpPr/>
+          <p:nvPr/>
+        </p:nvSpPr>
+        <p:spPr>
+          <a:xfrm>
+            <a:off x="9157716" y="1645920"/>
+            <a:ext cx="2647188" cy="987552"/>
+          </a:xfrm>
+          <a:prstGeom prst="roundRect">
+            <a:avLst>
+              <a:gd name="adj" fmla="val 8333"/>
+            </a:avLst>
+          </a:prstGeom>
+          <a:solidFill>
+            <a:srgbClr val="F1F4F9"/>
+          </a:solidFill>
+          <a:ln/>
+        </p:spPr>
+      </p:sp>
+      <p:sp>
+        <p:nvSpPr>
+          <p:cNvPr id="19" name="Text 17"/>
+          <p:cNvSpPr/>
+          <p:nvPr/>
+        </p:nvSpPr>
+        <p:spPr>
+          <a:xfrm>
+            <a:off x="9377172" y="1719072"/>
+            <a:ext cx="2208276" cy="402336"/>
+          </a:xfrm>
+          <a:prstGeom prst="rect">
+            <a:avLst/>
+          </a:prstGeom>
+          <a:noFill/>
+          <a:ln/>
+        </p:spPr>
+        <p:txBody>
+          <a:bodyPr wrap="square" lIns="0" tIns="0" rIns="0" bIns="0" rtlCol="0" anchor="ctr"/>
+          <a:lstStyle/>
+          <a:p>
+            <a:pPr indent="0" marL="0">
+              <a:buNone/>
+            </a:pPr>
+            <a:r>
+              <a:rPr lang="en-US" sz="1800" b="1" dirty="0">
+                <a:solidFill>
+                  <a:srgbClr val="C00000"/>
+                </a:solidFill>
+                <a:latin typeface="Graphik TH" pitchFamily="34" charset="0"/>
+                <a:ea typeface="Graphik TH" pitchFamily="34" charset="-122"/>
+                <a:cs typeface="Graphik TH" pitchFamily="34" charset="-120"/>
+              </a:rPr>
+              <a:t>+144.7 / −36.0</a:t>
+            </a:r>
+            <a:endParaRPr lang="en-US" sz="1800" dirty="0"/>
+          </a:p>
+        </p:txBody>
+      </p:sp>
+      <p:sp>
+        <p:nvSpPr>
+          <p:cNvPr id="20" name="Text 18"/>
+          <p:cNvSpPr/>
+          <p:nvPr/>
+        </p:nvSpPr>
+        <p:spPr>
+          <a:xfrm>
+            <a:off x="9377172" y="2121408"/>
+            <a:ext cx="2208276" cy="237744"/>
+          </a:xfrm>
+          <a:prstGeom prst="rect">
+            <a:avLst/>
+          </a:prstGeom>
+          <a:noFill/>
+          <a:ln/>
+        </p:spPr>
+        <p:txBody>
+          <a:bodyPr wrap="square" lIns="0" tIns="0" rIns="0" bIns="0" rtlCol="0" anchor="t"/>
+          <a:lstStyle/>
+          <a:p>
+            <a:pPr indent="0" marL="0">
+              <a:buNone/>
+            </a:pPr>
+            <a:r>
+              <a:rPr lang="en-US" sz="1150" b="1" dirty="0">
+                <a:solidFill>
+                  <a:srgbClr val="16233D"/>
+                </a:solidFill>
+                <a:latin typeface="Graphik TH" pitchFamily="34" charset="0"/>
+                <a:ea typeface="Graphik TH" pitchFamily="34" charset="-122"/>
+                <a:cs typeface="Graphik TH" pitchFamily="34" charset="-120"/>
+              </a:rPr>
+              <a:t>balance change, THB m</a:t>
+            </a:r>
+            <a:endParaRPr lang="en-US" sz="1150" dirty="0"/>
+          </a:p>
+        </p:txBody>
+      </p:sp>
+      <p:sp>
+        <p:nvSpPr>
+          <p:cNvPr id="21" name="Text 19"/>
+          <p:cNvSpPr/>
+          <p:nvPr/>
+        </p:nvSpPr>
+        <p:spPr>
+          <a:xfrm>
+            <a:off x="9377172" y="2350008"/>
+            <a:ext cx="2208276" cy="237744"/>
+          </a:xfrm>
+          <a:prstGeom prst="rect">
+            <a:avLst/>
+          </a:prstGeom>
+          <a:noFill/>
+          <a:ln/>
+        </p:spPr>
+        <p:txBody>
+          <a:bodyPr wrap="square" lIns="0" tIns="0" rIns="0" bIns="0" rtlCol="0" anchor="t"/>
+          <a:lstStyle/>
+          <a:p>
+            <a:pPr indent="0" marL="0">
+              <a:buNone/>
+            </a:pPr>
+            <a:r>
+              <a:rPr lang="en-US" sz="950" dirty="0">
+                <a:solidFill>
+                  <a:srgbClr val="6B7A90"/>
+                </a:solidFill>
+                <a:latin typeface="Graphik TH" pitchFamily="34" charset="0"/>
+                <a:ea typeface="Graphik TH" pitchFamily="34" charset="-122"/>
+                <a:cs typeface="Graphik TH" pitchFamily="34" charset="-120"/>
+              </a:rPr>
+              <a:t>same pair, opposite directions</a:t>
+            </a:r>
+            <a:endParaRPr lang="en-US" sz="950" dirty="0"/>
+          </a:p>
+        </p:txBody>
+      </p:sp>
+      <p:sp>
+        <p:nvSpPr>
+          <p:cNvPr id="22" name="Shape 20"/>
+          <p:cNvSpPr/>
+          <p:nvPr/>
+        </p:nvSpPr>
+        <p:spPr>
+          <a:xfrm>
+            <a:off x="530352" y="2798064"/>
+            <a:ext cx="5522976" cy="2322576"/>
+          </a:xfrm>
+          <a:prstGeom prst="roundRect">
+            <a:avLst>
+              <a:gd name="adj" fmla="val 3543"/>
+            </a:avLst>
+          </a:prstGeom>
+          <a:solidFill>
+            <a:srgbClr val="F1F4F9"/>
+          </a:solidFill>
+          <a:ln/>
+        </p:spPr>
+      </p:sp>
+      <p:sp>
+        <p:nvSpPr>
+          <p:cNvPr id="23" name="Text 21"/>
+          <p:cNvSpPr/>
+          <p:nvPr/>
+        </p:nvSpPr>
+        <p:spPr>
+          <a:xfrm>
+            <a:off x="786384" y="2944368"/>
+            <a:ext cx="5010912" cy="274320"/>
+          </a:xfrm>
+          <a:prstGeom prst="rect">
+            <a:avLst/>
+          </a:prstGeom>
+          <a:noFill/>
+          <a:ln/>
+        </p:spPr>
+        <p:txBody>
+          <a:bodyPr wrap="square" lIns="0" tIns="0" rIns="0" bIns="0" rtlCol="0" anchor="ctr"/>
+          <a:lstStyle/>
+          <a:p>
+            <a:pPr indent="0" marL="0">
+              <a:buNone/>
+            </a:pPr>
+            <a:r>
+              <a:rPr lang="en-US" sz="1400" b="1" dirty="0">
+                <a:solidFill>
+                  <a:srgbClr val="16233D"/>
+                </a:solidFill>
+                <a:latin typeface="Cambria" pitchFamily="34" charset="0"/>
+                <a:ea typeface="Cambria" pitchFamily="34" charset="-122"/>
+                <a:cs typeface="Cambria" pitchFamily="34" charset="-120"/>
+              </a:rPr>
+              <a:t>Deposit stickiness</a:t>
+            </a:r>
+            <a:endParaRPr lang="en-US" sz="1400" dirty="0"/>
+          </a:p>
+        </p:txBody>
+      </p:sp>
+      <p:sp>
+        <p:nvSpPr>
+          <p:cNvPr id="24" name="Text 22"/>
+          <p:cNvSpPr/>
+          <p:nvPr/>
+        </p:nvSpPr>
+        <p:spPr>
+          <a:xfrm>
+            <a:off x="786384" y="3218688"/>
+            <a:ext cx="5010912" cy="237744"/>
+          </a:xfrm>
+          <a:prstGeom prst="rect">
+            <a:avLst/>
+          </a:prstGeom>
+          <a:noFill/>
+          <a:ln/>
+        </p:spPr>
+        <p:txBody>
+          <a:bodyPr wrap="square" lIns="0" tIns="0" rIns="0" bIns="0" rtlCol="0" anchor="ctr"/>
+          <a:lstStyle/>
+          <a:p>
+            <a:pPr indent="0" marL="0">
+              <a:buNone/>
+            </a:pPr>
+            <a:r>
+              <a:rPr lang="en-US" sz="950" dirty="0">
+                <a:solidFill>
+                  <a:srgbClr val="6B7A90"/>
+                </a:solidFill>
+                <a:latin typeface="Graphik TH" pitchFamily="34" charset="0"/>
+                <a:ea typeface="Graphik TH" pitchFamily="34" charset="-122"/>
+                <a:cs typeface="Graphik TH" pitchFamily="34" charset="-120"/>
+              </a:rPr>
+              <a:t>Both measures rise together — no inversion</a:t>
+            </a:r>
+            <a:endParaRPr lang="en-US" sz="950" dirty="0"/>
+          </a:p>
+        </p:txBody>
+      </p:sp>
+      <p:sp>
+        <p:nvSpPr>
+          <p:cNvPr id="25" name="Text 23"/>
+          <p:cNvSpPr/>
+          <p:nvPr/>
+        </p:nvSpPr>
+        <p:spPr>
+          <a:xfrm>
+            <a:off x="1755648" y="3383280"/>
+            <a:ext cx="1481328" cy="182880"/>
+          </a:xfrm>
+          <a:prstGeom prst="rect">
+            <a:avLst/>
+          </a:prstGeom>
+          <a:noFill/>
+          <a:ln/>
+        </p:spPr>
+        <p:txBody>
+          <a:bodyPr wrap="square" lIns="0" tIns="0" rIns="0" bIns="0" rtlCol="0" anchor="ctr"/>
+          <a:lstStyle/>
+          <a:p>
+            <a:pPr indent="0" marL="0">
+              <a:buNone/>
+            </a:pPr>
+            <a:r>
+              <a:rPr lang="en-US" sz="850" b="1" dirty="0">
+                <a:solidFill>
+                  <a:srgbClr val="6B7A90"/>
+                </a:solidFill>
+                <a:latin typeface="Graphik TH" pitchFamily="34" charset="0"/>
+                <a:ea typeface="Graphik TH" pitchFamily="34" charset="-122"/>
+                <a:cs typeface="Graphik TH" pitchFamily="34" charset="-120"/>
+              </a:rPr>
+              <a:t>Move rate</a:t>
+            </a:r>
+            <a:endParaRPr lang="en-US" sz="850" dirty="0"/>
+          </a:p>
+        </p:txBody>
+      </p:sp>
+      <p:sp>
+        <p:nvSpPr>
+          <p:cNvPr id="26" name="Text 24"/>
+          <p:cNvSpPr/>
+          <p:nvPr/>
+        </p:nvSpPr>
+        <p:spPr>
+          <a:xfrm>
+            <a:off x="3547872" y="3383280"/>
+            <a:ext cx="2249424" cy="182880"/>
+          </a:xfrm>
+          <a:prstGeom prst="rect">
+            <a:avLst/>
+          </a:prstGeom>
+          <a:noFill/>
+          <a:ln/>
+        </p:spPr>
+        <p:txBody>
+          <a:bodyPr wrap="square" lIns="0" tIns="0" rIns="0" bIns="0" rtlCol="0" anchor="ctr"/>
+          <a:lstStyle/>
+          <a:p>
+            <a:pPr algn="ctr" indent="0" marL="0">
+              <a:buNone/>
+            </a:pPr>
+            <a:r>
+              <a:rPr lang="en-US" sz="850" b="1" dirty="0">
+                <a:solidFill>
+                  <a:srgbClr val="6B7A90"/>
+                </a:solidFill>
+                <a:latin typeface="Graphik TH" pitchFamily="34" charset="0"/>
+                <a:ea typeface="Graphik TH" pitchFamily="34" charset="-122"/>
+                <a:cs typeface="Graphik TH" pitchFamily="34" charset="-120"/>
+              </a:rPr>
+              <a:t>Balance change, THB m</a:t>
+            </a:r>
+            <a:endParaRPr lang="en-US" sz="850" dirty="0"/>
+          </a:p>
+        </p:txBody>
+      </p:sp>
+      <p:sp>
+        <p:nvSpPr>
+          <p:cNvPr id="27" name="Shape 25"/>
+          <p:cNvSpPr/>
+          <p:nvPr/>
+        </p:nvSpPr>
+        <p:spPr>
+          <a:xfrm>
+            <a:off x="4114800" y="3584448"/>
+            <a:ext cx="10973" cy="1444752"/>
+          </a:xfrm>
+          <a:prstGeom prst="rect">
+            <a:avLst/>
+          </a:prstGeom>
+          <a:solidFill>
+            <a:srgbClr val="6B7A90"/>
+          </a:solidFill>
+          <a:ln/>
+        </p:spPr>
+      </p:sp>
+      <p:sp>
+        <p:nvSpPr>
+          <p:cNvPr id="28" name="Text 26"/>
+          <p:cNvSpPr/>
+          <p:nvPr/>
+        </p:nvSpPr>
+        <p:spPr>
+          <a:xfrm>
+            <a:off x="786384" y="3621024"/>
+            <a:ext cx="914400" cy="256032"/>
+          </a:xfrm>
+          <a:prstGeom prst="rect">
+            <a:avLst/>
+          </a:prstGeom>
+          <a:noFill/>
+          <a:ln/>
+        </p:spPr>
+        <p:txBody>
+          <a:bodyPr wrap="square" lIns="0" tIns="0" rIns="0" bIns="0" rtlCol="0" anchor="ctr"/>
+          <a:lstStyle/>
+          <a:p>
+            <a:pPr indent="0" marL="0">
+              <a:buNone/>
+            </a:pPr>
+            <a:r>
+              <a:rPr lang="en-US" sz="950" b="1" dirty="0">
+                <a:solidFill>
+                  <a:srgbClr val="16233D"/>
+                </a:solidFill>
+                <a:latin typeface="Graphik TH" pitchFamily="34" charset="0"/>
+                <a:ea typeface="Graphik TH" pitchFamily="34" charset="-122"/>
+                <a:cs typeface="Graphik TH" pitchFamily="34" charset="-120"/>
+              </a:rPr>
+              <a:t>Very High</a:t>
+            </a:r>
+            <a:endParaRPr lang="en-US" sz="950" dirty="0"/>
+          </a:p>
+        </p:txBody>
+      </p:sp>
+      <p:sp>
+        <p:nvSpPr>
+          <p:cNvPr id="29" name="Shape 27"/>
+          <p:cNvSpPr/>
+          <p:nvPr/>
+        </p:nvSpPr>
+        <p:spPr>
+          <a:xfrm>
+            <a:off x="1755648" y="3666744"/>
+            <a:ext cx="1005840" cy="164592"/>
+          </a:xfrm>
+          <a:prstGeom prst="roundRect">
+            <a:avLst>
+              <a:gd name="adj" fmla="val 16667"/>
+            </a:avLst>
+          </a:prstGeom>
+          <a:solidFill>
+            <a:srgbClr val="165A73"/>
+          </a:solidFill>
+          <a:ln/>
+        </p:spPr>
+      </p:sp>
+      <p:sp>
+        <p:nvSpPr>
+          <p:cNvPr id="30" name="Text 28"/>
+          <p:cNvSpPr/>
+          <p:nvPr/>
+        </p:nvSpPr>
+        <p:spPr>
+          <a:xfrm>
+            <a:off x="2798064" y="3621024"/>
+            <a:ext cx="512064" cy="256032"/>
+          </a:xfrm>
+          <a:prstGeom prst="rect">
+            <a:avLst/>
+          </a:prstGeom>
+          <a:noFill/>
+          <a:ln/>
+        </p:spPr>
+        <p:txBody>
+          <a:bodyPr wrap="square" lIns="0" tIns="0" rIns="0" bIns="0" rtlCol="0" anchor="ctr"/>
+          <a:lstStyle/>
+          <a:p>
+            <a:pPr algn="r" indent="0" marL="0">
+              <a:buNone/>
+            </a:pPr>
+            <a:r>
+              <a:rPr lang="en-US" sz="950" b="1" dirty="0">
+                <a:solidFill>
+                  <a:srgbClr val="165A73"/>
+                </a:solidFill>
+                <a:latin typeface="Graphik TH" pitchFamily="34" charset="0"/>
+                <a:ea typeface="Graphik TH" pitchFamily="34" charset="-122"/>
+                <a:cs typeface="Graphik TH" pitchFamily="34" charset="-120"/>
+              </a:rPr>
+              <a:t>19.2%</a:t>
+            </a:r>
+            <a:endParaRPr lang="en-US" sz="950" dirty="0"/>
+          </a:p>
+        </p:txBody>
+      </p:sp>
+      <p:sp>
+        <p:nvSpPr>
+          <p:cNvPr id="31" name="Shape 29"/>
+          <p:cNvSpPr/>
+          <p:nvPr/>
+        </p:nvSpPr>
+        <p:spPr>
+          <a:xfrm>
+            <a:off x="4114800" y="3666744"/>
+            <a:ext cx="232102" cy="164592"/>
+          </a:xfrm>
+          <a:prstGeom prst="roundRect">
+            <a:avLst>
+              <a:gd name="adj" fmla="val 16667"/>
+            </a:avLst>
+          </a:prstGeom>
+          <a:solidFill>
+            <a:srgbClr val="1E8E86"/>
+          </a:solidFill>
+          <a:ln/>
+        </p:spPr>
+      </p:sp>
+      <p:sp>
+        <p:nvSpPr>
+          <p:cNvPr id="32" name="Text 30"/>
+          <p:cNvSpPr/>
+          <p:nvPr/>
+        </p:nvSpPr>
+        <p:spPr>
+          <a:xfrm>
+            <a:off x="4626864" y="3621024"/>
+            <a:ext cx="1170432" cy="256032"/>
+          </a:xfrm>
+          <a:prstGeom prst="rect">
+            <a:avLst/>
+          </a:prstGeom>
+          <a:noFill/>
+          <a:ln/>
+        </p:spPr>
+        <p:txBody>
+          <a:bodyPr wrap="square" lIns="0" tIns="0" rIns="0" bIns="0" rtlCol="0" anchor="ctr"/>
+          <a:lstStyle/>
+          <a:p>
+            <a:pPr algn="r" indent="0" marL="0">
+              <a:buNone/>
+            </a:pPr>
+            <a:r>
+              <a:rPr lang="en-US" sz="850" b="1" dirty="0">
+                <a:solidFill>
+                  <a:srgbClr val="1E8E86"/>
+                </a:solidFill>
+                <a:latin typeface="Graphik TH" pitchFamily="34" charset="0"/>
+                <a:ea typeface="Graphik TH" pitchFamily="34" charset="-122"/>
+                <a:cs typeface="Graphik TH" pitchFamily="34" charset="-120"/>
+              </a:rPr>
+              <a:t>+34.9 (+3.2%)</a:t>
+            </a:r>
+            <a:endParaRPr lang="en-US" sz="850" dirty="0"/>
+          </a:p>
+        </p:txBody>
+      </p:sp>
+      <p:sp>
+        <p:nvSpPr>
+          <p:cNvPr id="33" name="Text 31"/>
+          <p:cNvSpPr/>
+          <p:nvPr/>
+        </p:nvSpPr>
+        <p:spPr>
+          <a:xfrm>
+            <a:off x="786384" y="3913632"/>
+            <a:ext cx="914400" cy="256032"/>
+          </a:xfrm>
+          <a:prstGeom prst="rect">
+            <a:avLst/>
+          </a:prstGeom>
+          <a:noFill/>
+          <a:ln/>
+        </p:spPr>
+        <p:txBody>
+          <a:bodyPr wrap="square" lIns="0" tIns="0" rIns="0" bIns="0" rtlCol="0" anchor="ctr"/>
+          <a:lstStyle/>
+          <a:p>
+            <a:pPr indent="0" marL="0">
+              <a:buNone/>
+            </a:pPr>
+            <a:r>
+              <a:rPr lang="en-US" sz="950" b="1" dirty="0">
+                <a:solidFill>
+                  <a:srgbClr val="16233D"/>
+                </a:solidFill>
+                <a:latin typeface="Graphik TH" pitchFamily="34" charset="0"/>
+                <a:ea typeface="Graphik TH" pitchFamily="34" charset="-122"/>
+                <a:cs typeface="Graphik TH" pitchFamily="34" charset="-120"/>
+              </a:rPr>
+              <a:t>High</a:t>
+            </a:r>
+            <a:endParaRPr lang="en-US" sz="950" dirty="0"/>
+          </a:p>
+        </p:txBody>
+      </p:sp>
+      <p:sp>
+        <p:nvSpPr>
+          <p:cNvPr id="34" name="Shape 32"/>
+          <p:cNvSpPr/>
+          <p:nvPr/>
+        </p:nvSpPr>
+        <p:spPr>
+          <a:xfrm>
+            <a:off x="1755648" y="3959352"/>
+            <a:ext cx="800809" cy="164592"/>
+          </a:xfrm>
+          <a:prstGeom prst="roundRect">
+            <a:avLst>
+              <a:gd name="adj" fmla="val 16667"/>
+            </a:avLst>
+          </a:prstGeom>
+          <a:solidFill>
+            <a:srgbClr val="165A73"/>
+          </a:solidFill>
+          <a:ln/>
+        </p:spPr>
+      </p:sp>
+      <p:sp>
+        <p:nvSpPr>
+          <p:cNvPr id="35" name="Text 33"/>
+          <p:cNvSpPr/>
+          <p:nvPr/>
+        </p:nvSpPr>
+        <p:spPr>
+          <a:xfrm>
+            <a:off x="2798064" y="3913632"/>
+            <a:ext cx="512064" cy="256032"/>
+          </a:xfrm>
+          <a:prstGeom prst="rect">
+            <a:avLst/>
+          </a:prstGeom>
+          <a:noFill/>
+          <a:ln/>
+        </p:spPr>
+        <p:txBody>
+          <a:bodyPr wrap="square" lIns="0" tIns="0" rIns="0" bIns="0" rtlCol="0" anchor="ctr"/>
+          <a:lstStyle/>
+          <a:p>
+            <a:pPr algn="r" indent="0" marL="0">
+              <a:buNone/>
+            </a:pPr>
+            <a:r>
+              <a:rPr lang="en-US" sz="950" b="1" dirty="0">
+                <a:solidFill>
+                  <a:srgbClr val="165A73"/>
+                </a:solidFill>
+                <a:latin typeface="Graphik TH" pitchFamily="34" charset="0"/>
+                <a:ea typeface="Graphik TH" pitchFamily="34" charset="-122"/>
+                <a:cs typeface="Graphik TH" pitchFamily="34" charset="-120"/>
+              </a:rPr>
+              <a:t>15.3%</a:t>
+            </a:r>
+            <a:endParaRPr lang="en-US" sz="950" dirty="0"/>
+          </a:p>
+        </p:txBody>
+      </p:sp>
+      <p:sp>
+        <p:nvSpPr>
+          <p:cNvPr id="36" name="Shape 34"/>
+          <p:cNvSpPr/>
+          <p:nvPr/>
+        </p:nvSpPr>
+        <p:spPr>
+          <a:xfrm>
+            <a:off x="4114800" y="3959352"/>
+            <a:ext cx="475488" cy="164592"/>
+          </a:xfrm>
+          <a:prstGeom prst="roundRect">
+            <a:avLst>
+              <a:gd name="adj" fmla="val 16667"/>
+            </a:avLst>
+          </a:prstGeom>
+          <a:solidFill>
+            <a:srgbClr val="1E8E86"/>
+          </a:solidFill>
+          <a:ln/>
+        </p:spPr>
+      </p:sp>
+      <p:sp>
+        <p:nvSpPr>
+          <p:cNvPr id="37" name="Text 35"/>
+          <p:cNvSpPr/>
+          <p:nvPr/>
+        </p:nvSpPr>
+        <p:spPr>
+          <a:xfrm>
+            <a:off x="4626864" y="3913632"/>
+            <a:ext cx="1170432" cy="256032"/>
+          </a:xfrm>
+          <a:prstGeom prst="rect">
+            <a:avLst/>
+          </a:prstGeom>
+          <a:noFill/>
+          <a:ln/>
+        </p:spPr>
+        <p:txBody>
+          <a:bodyPr wrap="square" lIns="0" tIns="0" rIns="0" bIns="0" rtlCol="0" anchor="ctr"/>
+          <a:lstStyle/>
+          <a:p>
+            <a:pPr algn="r" indent="0" marL="0">
+              <a:buNone/>
+            </a:pPr>
+            <a:r>
+              <a:rPr lang="en-US" sz="850" b="1" dirty="0">
+                <a:solidFill>
+                  <a:srgbClr val="1E8E86"/>
+                </a:solidFill>
+                <a:latin typeface="Graphik TH" pitchFamily="34" charset="0"/>
+                <a:ea typeface="Graphik TH" pitchFamily="34" charset="-122"/>
+                <a:cs typeface="Graphik TH" pitchFamily="34" charset="-120"/>
+              </a:rPr>
+              <a:t>+71.4 (+4.0%)</a:t>
+            </a:r>
+            <a:endParaRPr lang="en-US" sz="850" dirty="0"/>
+          </a:p>
+        </p:txBody>
+      </p:sp>
+      <p:sp>
+        <p:nvSpPr>
+          <p:cNvPr id="38" name="Text 36"/>
+          <p:cNvSpPr/>
+          <p:nvPr/>
+        </p:nvSpPr>
+        <p:spPr>
+          <a:xfrm>
+            <a:off x="786384" y="4206240"/>
+            <a:ext cx="914400" cy="256032"/>
+          </a:xfrm>
+          <a:prstGeom prst="rect">
+            <a:avLst/>
+          </a:prstGeom>
+          <a:noFill/>
+          <a:ln/>
+        </p:spPr>
+        <p:txBody>
+          <a:bodyPr wrap="square" lIns="0" tIns="0" rIns="0" bIns="0" rtlCol="0" anchor="ctr"/>
+          <a:lstStyle/>
+          <a:p>
+            <a:pPr indent="0" marL="0">
+              <a:buNone/>
+            </a:pPr>
+            <a:r>
+              <a:rPr lang="en-US" sz="950" b="1" dirty="0">
+                <a:solidFill>
+                  <a:srgbClr val="16233D"/>
+                </a:solidFill>
+                <a:latin typeface="Graphik TH" pitchFamily="34" charset="0"/>
+                <a:ea typeface="Graphik TH" pitchFamily="34" charset="-122"/>
+                <a:cs typeface="Graphik TH" pitchFamily="34" charset="-120"/>
+              </a:rPr>
+              <a:t>Medium</a:t>
+            </a:r>
+            <a:endParaRPr lang="en-US" sz="950" dirty="0"/>
+          </a:p>
+        </p:txBody>
+      </p:sp>
+      <p:sp>
+        <p:nvSpPr>
+          <p:cNvPr id="39" name="Shape 37"/>
+          <p:cNvSpPr/>
+          <p:nvPr/>
+        </p:nvSpPr>
+        <p:spPr>
+          <a:xfrm>
+            <a:off x="1755648" y="4251960"/>
+            <a:ext cx="229032" cy="164592"/>
+          </a:xfrm>
+          <a:prstGeom prst="roundRect">
+            <a:avLst>
+              <a:gd name="adj" fmla="val 16667"/>
+            </a:avLst>
+          </a:prstGeom>
+          <a:solidFill>
+            <a:srgbClr val="165A73"/>
+          </a:solidFill>
+          <a:ln/>
+        </p:spPr>
+      </p:sp>
+      <p:sp>
+        <p:nvSpPr>
+          <p:cNvPr id="40" name="Text 38"/>
+          <p:cNvSpPr/>
+          <p:nvPr/>
+        </p:nvSpPr>
+        <p:spPr>
+          <a:xfrm>
+            <a:off x="2798064" y="4206240"/>
+            <a:ext cx="512064" cy="256032"/>
+          </a:xfrm>
+          <a:prstGeom prst="rect">
+            <a:avLst/>
+          </a:prstGeom>
+          <a:noFill/>
+          <a:ln/>
+        </p:spPr>
+        <p:txBody>
+          <a:bodyPr wrap="square" lIns="0" tIns="0" rIns="0" bIns="0" rtlCol="0" anchor="ctr"/>
+          <a:lstStyle/>
+          <a:p>
+            <a:pPr algn="r" indent="0" marL="0">
+              <a:buNone/>
+            </a:pPr>
+            <a:r>
+              <a:rPr lang="en-US" sz="950" b="1" dirty="0">
+                <a:solidFill>
+                  <a:srgbClr val="165A73"/>
+                </a:solidFill>
+                <a:latin typeface="Graphik TH" pitchFamily="34" charset="0"/>
+                <a:ea typeface="Graphik TH" pitchFamily="34" charset="-122"/>
+                <a:cs typeface="Graphik TH" pitchFamily="34" charset="-120"/>
+              </a:rPr>
+              <a:t>4.4%</a:t>
+            </a:r>
+            <a:endParaRPr lang="en-US" sz="950" dirty="0"/>
+          </a:p>
+        </p:txBody>
+      </p:sp>
+      <p:sp>
+        <p:nvSpPr>
+          <p:cNvPr id="41" name="Shape 39"/>
+          <p:cNvSpPr/>
+          <p:nvPr/>
+        </p:nvSpPr>
+        <p:spPr>
+          <a:xfrm>
+            <a:off x="4114800" y="4251960"/>
+            <a:ext cx="27432" cy="164592"/>
+          </a:xfrm>
+          <a:prstGeom prst="roundRect">
+            <a:avLst>
+              <a:gd name="adj" fmla="val 100000"/>
+            </a:avLst>
+          </a:prstGeom>
+          <a:solidFill>
+            <a:srgbClr val="1E8E86"/>
+          </a:solidFill>
+          <a:ln/>
+        </p:spPr>
+      </p:sp>
+      <p:sp>
+        <p:nvSpPr>
+          <p:cNvPr id="42" name="Text 40"/>
+          <p:cNvSpPr/>
+          <p:nvPr/>
+        </p:nvSpPr>
+        <p:spPr>
+          <a:xfrm>
+            <a:off x="4626864" y="4206240"/>
+            <a:ext cx="1170432" cy="256032"/>
+          </a:xfrm>
+          <a:prstGeom prst="rect">
+            <a:avLst/>
+          </a:prstGeom>
+          <a:noFill/>
+          <a:ln/>
+        </p:spPr>
+        <p:txBody>
+          <a:bodyPr wrap="square" lIns="0" tIns="0" rIns="0" bIns="0" rtlCol="0" anchor="ctr"/>
+          <a:lstStyle/>
+          <a:p>
+            <a:pPr algn="r" indent="0" marL="0">
+              <a:buNone/>
+            </a:pPr>
+            <a:r>
+              <a:rPr lang="en-US" sz="850" b="1" dirty="0">
+                <a:solidFill>
+                  <a:srgbClr val="1E8E86"/>
+                </a:solidFill>
+                <a:latin typeface="Graphik TH" pitchFamily="34" charset="0"/>
+                <a:ea typeface="Graphik TH" pitchFamily="34" charset="-122"/>
+                <a:cs typeface="Graphik TH" pitchFamily="34" charset="-120"/>
+              </a:rPr>
+              <a:t>+2.9 (+8.8%)</a:t>
+            </a:r>
+            <a:endParaRPr lang="en-US" sz="850" dirty="0"/>
+          </a:p>
+        </p:txBody>
+      </p:sp>
+      <p:sp>
+        <p:nvSpPr>
+          <p:cNvPr id="43" name="Text 41"/>
+          <p:cNvSpPr/>
+          <p:nvPr/>
+        </p:nvSpPr>
+        <p:spPr>
+          <a:xfrm>
+            <a:off x="786384" y="4498848"/>
+            <a:ext cx="914400" cy="256032"/>
+          </a:xfrm>
+          <a:prstGeom prst="rect">
+            <a:avLst/>
+          </a:prstGeom>
+          <a:noFill/>
+          <a:ln/>
+        </p:spPr>
+        <p:txBody>
+          <a:bodyPr wrap="square" lIns="0" tIns="0" rIns="0" bIns="0" rtlCol="0" anchor="ctr"/>
+          <a:lstStyle/>
+          <a:p>
+            <a:pPr indent="0" marL="0">
+              <a:buNone/>
+            </a:pPr>
+            <a:r>
+              <a:rPr lang="en-US" sz="950" b="1" dirty="0">
+                <a:solidFill>
+                  <a:srgbClr val="16233D"/>
+                </a:solidFill>
+                <a:latin typeface="Graphik TH" pitchFamily="34" charset="0"/>
+                <a:ea typeface="Graphik TH" pitchFamily="34" charset="-122"/>
+                <a:cs typeface="Graphik TH" pitchFamily="34" charset="-120"/>
+              </a:rPr>
+              <a:t>Low</a:t>
+            </a:r>
+            <a:endParaRPr lang="en-US" sz="950" dirty="0"/>
+          </a:p>
+        </p:txBody>
+      </p:sp>
+      <p:sp>
+        <p:nvSpPr>
+          <p:cNvPr id="44" name="Shape 42"/>
+          <p:cNvSpPr/>
+          <p:nvPr/>
+        </p:nvSpPr>
+        <p:spPr>
+          <a:xfrm>
+            <a:off x="1755648" y="4544568"/>
+            <a:ext cx="140607" cy="164592"/>
+          </a:xfrm>
+          <a:prstGeom prst="roundRect">
+            <a:avLst>
+              <a:gd name="adj" fmla="val 19510"/>
+            </a:avLst>
+          </a:prstGeom>
+          <a:solidFill>
+            <a:srgbClr val="165A73"/>
+          </a:solidFill>
+          <a:ln/>
+        </p:spPr>
+      </p:sp>
+      <p:sp>
+        <p:nvSpPr>
+          <p:cNvPr id="45" name="Text 43"/>
+          <p:cNvSpPr/>
+          <p:nvPr/>
+        </p:nvSpPr>
+        <p:spPr>
+          <a:xfrm>
+            <a:off x="2798064" y="4498848"/>
+            <a:ext cx="512064" cy="256032"/>
+          </a:xfrm>
+          <a:prstGeom prst="rect">
+            <a:avLst/>
+          </a:prstGeom>
+          <a:noFill/>
+          <a:ln/>
+        </p:spPr>
+        <p:txBody>
+          <a:bodyPr wrap="square" lIns="0" tIns="0" rIns="0" bIns="0" rtlCol="0" anchor="ctr"/>
+          <a:lstStyle/>
+          <a:p>
+            <a:pPr algn="r" indent="0" marL="0">
+              <a:buNone/>
+            </a:pPr>
+            <a:r>
+              <a:rPr lang="en-US" sz="950" b="1" dirty="0">
+                <a:solidFill>
+                  <a:srgbClr val="165A73"/>
+                </a:solidFill>
+                <a:latin typeface="Graphik TH" pitchFamily="34" charset="0"/>
+                <a:ea typeface="Graphik TH" pitchFamily="34" charset="-122"/>
+                <a:cs typeface="Graphik TH" pitchFamily="34" charset="-120"/>
+              </a:rPr>
+              <a:t>2.7%</a:t>
+            </a:r>
+            <a:endParaRPr lang="en-US" sz="950" dirty="0"/>
+          </a:p>
+        </p:txBody>
+      </p:sp>
+      <p:sp>
+        <p:nvSpPr>
+          <p:cNvPr id="46" name="Shape 44"/>
+          <p:cNvSpPr/>
+          <p:nvPr/>
+        </p:nvSpPr>
+        <p:spPr>
+          <a:xfrm>
+            <a:off x="4114800" y="4544568"/>
+            <a:ext cx="27432" cy="164592"/>
+          </a:xfrm>
+          <a:prstGeom prst="roundRect">
+            <a:avLst>
+              <a:gd name="adj" fmla="val 100000"/>
+            </a:avLst>
+          </a:prstGeom>
+          <a:solidFill>
+            <a:srgbClr val="1E8E86"/>
+          </a:solidFill>
+          <a:ln/>
+        </p:spPr>
+      </p:sp>
+      <p:sp>
+        <p:nvSpPr>
+          <p:cNvPr id="47" name="Text 45"/>
+          <p:cNvSpPr/>
+          <p:nvPr/>
+        </p:nvSpPr>
+        <p:spPr>
+          <a:xfrm>
+            <a:off x="4626864" y="4498848"/>
+            <a:ext cx="1170432" cy="256032"/>
+          </a:xfrm>
+          <a:prstGeom prst="rect">
+            <a:avLst/>
+          </a:prstGeom>
+          <a:noFill/>
+          <a:ln/>
+        </p:spPr>
+        <p:txBody>
+          <a:bodyPr wrap="square" lIns="0" tIns="0" rIns="0" bIns="0" rtlCol="0" anchor="ctr"/>
+          <a:lstStyle/>
+          <a:p>
+            <a:pPr algn="r" indent="0" marL="0">
+              <a:buNone/>
+            </a:pPr>
+            <a:r>
+              <a:rPr lang="en-US" sz="850" b="1" dirty="0">
+                <a:solidFill>
+                  <a:srgbClr val="1E8E86"/>
+                </a:solidFill>
+                <a:latin typeface="Graphik TH" pitchFamily="34" charset="0"/>
+                <a:ea typeface="Graphik TH" pitchFamily="34" charset="-122"/>
+                <a:cs typeface="Graphik TH" pitchFamily="34" charset="-120"/>
+              </a:rPr>
+              <a:t>+1.6</a:t>
+            </a:r>
+            <a:endParaRPr lang="en-US" sz="850" dirty="0"/>
+          </a:p>
+        </p:txBody>
+      </p:sp>
+      <p:sp>
+        <p:nvSpPr>
+          <p:cNvPr id="48" name="Text 46"/>
+          <p:cNvSpPr/>
+          <p:nvPr/>
+        </p:nvSpPr>
+        <p:spPr>
+          <a:xfrm>
+            <a:off x="786384" y="4791456"/>
+            <a:ext cx="914400" cy="256032"/>
+          </a:xfrm>
+          <a:prstGeom prst="rect">
+            <a:avLst/>
+          </a:prstGeom>
+          <a:noFill/>
+          <a:ln/>
+        </p:spPr>
+        <p:txBody>
+          <a:bodyPr wrap="square" lIns="0" tIns="0" rIns="0" bIns="0" rtlCol="0" anchor="ctr"/>
+          <a:lstStyle/>
+          <a:p>
+            <a:pPr indent="0" marL="0">
+              <a:buNone/>
+            </a:pPr>
+            <a:r>
+              <a:rPr lang="en-US" sz="950" b="1" dirty="0">
+                <a:solidFill>
+                  <a:srgbClr val="16233D"/>
+                </a:solidFill>
+                <a:latin typeface="Graphik TH" pitchFamily="34" charset="0"/>
+                <a:ea typeface="Graphik TH" pitchFamily="34" charset="-122"/>
+                <a:cs typeface="Graphik TH" pitchFamily="34" charset="-120"/>
+              </a:rPr>
+              <a:t>Very Low</a:t>
+            </a:r>
+            <a:endParaRPr lang="en-US" sz="950" dirty="0"/>
+          </a:p>
+        </p:txBody>
+      </p:sp>
+      <p:sp>
+        <p:nvSpPr>
+          <p:cNvPr id="49" name="Shape 47"/>
+          <p:cNvSpPr/>
+          <p:nvPr/>
+        </p:nvSpPr>
+        <p:spPr>
+          <a:xfrm>
+            <a:off x="1755648" y="4837176"/>
+            <a:ext cx="100581" cy="164592"/>
+          </a:xfrm>
+          <a:prstGeom prst="roundRect">
+            <a:avLst>
+              <a:gd name="adj" fmla="val 27274"/>
+            </a:avLst>
+          </a:prstGeom>
+          <a:solidFill>
+            <a:srgbClr val="165A73"/>
+          </a:solidFill>
+          <a:ln/>
+        </p:spPr>
+      </p:sp>
+      <p:sp>
+        <p:nvSpPr>
+          <p:cNvPr id="50" name="Text 48"/>
+          <p:cNvSpPr/>
+          <p:nvPr/>
+        </p:nvSpPr>
+        <p:spPr>
+          <a:xfrm>
+            <a:off x="2798064" y="4791456"/>
+            <a:ext cx="512064" cy="256032"/>
+          </a:xfrm>
+          <a:prstGeom prst="rect">
+            <a:avLst/>
+          </a:prstGeom>
+          <a:noFill/>
+          <a:ln/>
+        </p:spPr>
+        <p:txBody>
+          <a:bodyPr wrap="square" lIns="0" tIns="0" rIns="0" bIns="0" rtlCol="0" anchor="ctr"/>
+          <a:lstStyle/>
+          <a:p>
+            <a:pPr algn="r" indent="0" marL="0">
+              <a:buNone/>
+            </a:pPr>
+            <a:r>
+              <a:rPr lang="en-US" sz="950" b="1" dirty="0">
+                <a:solidFill>
+                  <a:srgbClr val="165A73"/>
+                </a:solidFill>
+                <a:latin typeface="Graphik TH" pitchFamily="34" charset="0"/>
+                <a:ea typeface="Graphik TH" pitchFamily="34" charset="-122"/>
+                <a:cs typeface="Graphik TH" pitchFamily="34" charset="-120"/>
+              </a:rPr>
+              <a:t>1.9%</a:t>
+            </a:r>
+            <a:endParaRPr lang="en-US" sz="950" dirty="0"/>
+          </a:p>
+        </p:txBody>
+      </p:sp>
+      <p:sp>
+        <p:nvSpPr>
+          <p:cNvPr id="51" name="Shape 49"/>
+          <p:cNvSpPr/>
+          <p:nvPr/>
+        </p:nvSpPr>
+        <p:spPr>
+          <a:xfrm>
+            <a:off x="4114800" y="4837176"/>
+            <a:ext cx="27432" cy="164592"/>
+          </a:xfrm>
+          <a:prstGeom prst="roundRect">
+            <a:avLst>
+              <a:gd name="adj" fmla="val 100000"/>
+            </a:avLst>
+          </a:prstGeom>
+          <a:solidFill>
+            <a:srgbClr val="1E8E86"/>
+          </a:solidFill>
+          <a:ln/>
+        </p:spPr>
+      </p:sp>
+      <p:sp>
+        <p:nvSpPr>
+          <p:cNvPr id="52" name="Text 50"/>
+          <p:cNvSpPr/>
+          <p:nvPr/>
+        </p:nvSpPr>
+        <p:spPr>
+          <a:xfrm>
+            <a:off x="4626864" y="4791456"/>
+            <a:ext cx="1170432" cy="256032"/>
+          </a:xfrm>
+          <a:prstGeom prst="rect">
+            <a:avLst/>
+          </a:prstGeom>
+          <a:noFill/>
+          <a:ln/>
+        </p:spPr>
+        <p:txBody>
+          <a:bodyPr wrap="square" lIns="0" tIns="0" rIns="0" bIns="0" rtlCol="0" anchor="ctr"/>
+          <a:lstStyle/>
+          <a:p>
+            <a:pPr algn="r" indent="0" marL="0">
+              <a:buNone/>
+            </a:pPr>
+            <a:r>
+              <a:rPr lang="en-US" sz="850" b="1" dirty="0">
+                <a:solidFill>
+                  <a:srgbClr val="1E8E86"/>
+                </a:solidFill>
+                <a:latin typeface="Graphik TH" pitchFamily="34" charset="0"/>
+                <a:ea typeface="Graphik TH" pitchFamily="34" charset="-122"/>
+                <a:cs typeface="Graphik TH" pitchFamily="34" charset="-120"/>
+              </a:rPr>
+              <a:t>+0.5</a:t>
+            </a:r>
+            <a:endParaRPr lang="en-US" sz="850" dirty="0"/>
+          </a:p>
+        </p:txBody>
+      </p:sp>
+      <p:sp>
+        <p:nvSpPr>
+          <p:cNvPr id="53" name="Shape 51"/>
+          <p:cNvSpPr/>
+          <p:nvPr/>
+        </p:nvSpPr>
+        <p:spPr>
+          <a:xfrm>
+            <a:off x="6281928" y="2798064"/>
+            <a:ext cx="5522976" cy="2322576"/>
+          </a:xfrm>
+          <a:prstGeom prst="roundRect">
+            <a:avLst>
+              <a:gd name="adj" fmla="val 3543"/>
+            </a:avLst>
+          </a:prstGeom>
+          <a:solidFill>
+            <a:srgbClr val="F1F4F9"/>
+          </a:solidFill>
+          <a:ln/>
+        </p:spPr>
+      </p:sp>
+      <p:sp>
+        <p:nvSpPr>
+          <p:cNvPr id="54" name="Text 52"/>
+          <p:cNvSpPr/>
+          <p:nvPr/>
+        </p:nvSpPr>
+        <p:spPr>
+          <a:xfrm>
+            <a:off x="6537960" y="2944368"/>
+            <a:ext cx="5010912" cy="274320"/>
+          </a:xfrm>
+          <a:prstGeom prst="rect">
+            <a:avLst/>
+          </a:prstGeom>
+          <a:noFill/>
+          <a:ln/>
+        </p:spPr>
+        <p:txBody>
+          <a:bodyPr wrap="square" lIns="0" tIns="0" rIns="0" bIns="0" rtlCol="0" anchor="ctr"/>
+          <a:lstStyle/>
+          <a:p>
+            <a:pPr indent="0" marL="0">
+              <a:buNone/>
+            </a:pPr>
+            <a:r>
+              <a:rPr lang="en-US" sz="1400" b="1" dirty="0">
+                <a:solidFill>
+                  <a:srgbClr val="16233D"/>
+                </a:solidFill>
+                <a:latin typeface="Cambria" pitchFamily="34" charset="0"/>
+                <a:ea typeface="Cambria" pitchFamily="34" charset="-122"/>
+                <a:cs typeface="Cambria" pitchFamily="34" charset="-120"/>
+              </a:rPr>
+              <a:t>Rate sensitivity</a:t>
+            </a:r>
+            <a:endParaRPr lang="en-US" sz="1400" dirty="0"/>
+          </a:p>
+        </p:txBody>
+      </p:sp>
+      <p:sp>
+        <p:nvSpPr>
+          <p:cNvPr id="55" name="Text 53"/>
+          <p:cNvSpPr/>
+          <p:nvPr/>
+        </p:nvSpPr>
+        <p:spPr>
+          <a:xfrm>
+            <a:off x="6537960" y="3218688"/>
+            <a:ext cx="5010912" cy="237744"/>
+          </a:xfrm>
+          <a:prstGeom prst="rect">
+            <a:avLst/>
+          </a:prstGeom>
+          <a:noFill/>
+          <a:ln/>
+        </p:spPr>
+        <p:txBody>
+          <a:bodyPr wrap="square" lIns="0" tIns="0" rIns="0" bIns="0" rtlCol="0" anchor="ctr"/>
+          <a:lstStyle/>
+          <a:p>
+            <a:pPr indent="0" marL="0">
+              <a:buNone/>
+            </a:pPr>
+            <a:r>
+              <a:rPr lang="en-US" sz="950" dirty="0">
+                <a:solidFill>
+                  <a:srgbClr val="6B7A90"/>
+                </a:solidFill>
+                <a:latin typeface="Graphik TH" pitchFamily="34" charset="0"/>
+                <a:ea typeface="Graphik TH" pitchFamily="34" charset="-122"/>
+                <a:cs typeface="Graphik TH" pitchFamily="34" charset="-120"/>
+              </a:rPr>
+              <a:t>The two measures point in opposite directions</a:t>
+            </a:r>
+            <a:endParaRPr lang="en-US" sz="950" dirty="0"/>
+          </a:p>
+        </p:txBody>
+      </p:sp>
+      <p:sp>
+        <p:nvSpPr>
+          <p:cNvPr id="56" name="Text 54"/>
+          <p:cNvSpPr/>
+          <p:nvPr/>
+        </p:nvSpPr>
+        <p:spPr>
+          <a:xfrm>
+            <a:off x="7507224" y="3383280"/>
+            <a:ext cx="1481328" cy="182880"/>
+          </a:xfrm>
+          <a:prstGeom prst="rect">
+            <a:avLst/>
+          </a:prstGeom>
+          <a:noFill/>
+          <a:ln/>
+        </p:spPr>
+        <p:txBody>
+          <a:bodyPr wrap="square" lIns="0" tIns="0" rIns="0" bIns="0" rtlCol="0" anchor="ctr"/>
+          <a:lstStyle/>
+          <a:p>
+            <a:pPr indent="0" marL="0">
+              <a:buNone/>
+            </a:pPr>
+            <a:r>
+              <a:rPr lang="en-US" sz="850" b="1" dirty="0">
+                <a:solidFill>
+                  <a:srgbClr val="6B7A90"/>
+                </a:solidFill>
+                <a:latin typeface="Graphik TH" pitchFamily="34" charset="0"/>
+                <a:ea typeface="Graphik TH" pitchFamily="34" charset="-122"/>
+                <a:cs typeface="Graphik TH" pitchFamily="34" charset="-120"/>
+              </a:rPr>
+              <a:t>Move rate</a:t>
+            </a:r>
+            <a:endParaRPr lang="en-US" sz="850" dirty="0"/>
+          </a:p>
+        </p:txBody>
+      </p:sp>
+      <p:sp>
+        <p:nvSpPr>
+          <p:cNvPr id="57" name="Text 55"/>
+          <p:cNvSpPr/>
+          <p:nvPr/>
+        </p:nvSpPr>
+        <p:spPr>
+          <a:xfrm>
+            <a:off x="9299448" y="3383280"/>
+            <a:ext cx="2249424" cy="182880"/>
+          </a:xfrm>
+          <a:prstGeom prst="rect">
+            <a:avLst/>
+          </a:prstGeom>
+          <a:noFill/>
+          <a:ln/>
+        </p:spPr>
+        <p:txBody>
+          <a:bodyPr wrap="square" lIns="0" tIns="0" rIns="0" bIns="0" rtlCol="0" anchor="ctr"/>
+          <a:lstStyle/>
+          <a:p>
+            <a:pPr algn="ctr" indent="0" marL="0">
+              <a:buNone/>
+            </a:pPr>
+            <a:r>
+              <a:rPr lang="en-US" sz="850" b="1" dirty="0">
+                <a:solidFill>
+                  <a:srgbClr val="6B7A90"/>
+                </a:solidFill>
+                <a:latin typeface="Graphik TH" pitchFamily="34" charset="0"/>
+                <a:ea typeface="Graphik TH" pitchFamily="34" charset="-122"/>
+                <a:cs typeface="Graphik TH" pitchFamily="34" charset="-120"/>
+              </a:rPr>
+              <a:t>Balance change, THB m</a:t>
+            </a:r>
+            <a:endParaRPr lang="en-US" sz="850" dirty="0"/>
+          </a:p>
+        </p:txBody>
+      </p:sp>
+      <p:sp>
+        <p:nvSpPr>
+          <p:cNvPr id="58" name="Shape 56"/>
+          <p:cNvSpPr/>
+          <p:nvPr/>
+        </p:nvSpPr>
+        <p:spPr>
+          <a:xfrm>
+            <a:off x="9866376" y="3584448"/>
+            <a:ext cx="10973" cy="1444752"/>
+          </a:xfrm>
+          <a:prstGeom prst="rect">
+            <a:avLst/>
+          </a:prstGeom>
+          <a:solidFill>
+            <a:srgbClr val="6B7A90"/>
+          </a:solidFill>
+          <a:ln/>
+        </p:spPr>
+      </p:sp>
+      <p:sp>
+        <p:nvSpPr>
+          <p:cNvPr id="59" name="Text 57"/>
+          <p:cNvSpPr/>
+          <p:nvPr/>
+        </p:nvSpPr>
+        <p:spPr>
+          <a:xfrm>
+            <a:off x="6537960" y="3621024"/>
+            <a:ext cx="914400" cy="256032"/>
+          </a:xfrm>
+          <a:prstGeom prst="rect">
+            <a:avLst/>
+          </a:prstGeom>
+          <a:noFill/>
+          <a:ln/>
+        </p:spPr>
+        <p:txBody>
+          <a:bodyPr wrap="square" lIns="0" tIns="0" rIns="0" bIns="0" rtlCol="0" anchor="ctr"/>
+          <a:lstStyle/>
+          <a:p>
+            <a:pPr indent="0" marL="0">
+              <a:buNone/>
+            </a:pPr>
+            <a:r>
+              <a:rPr lang="en-US" sz="950" b="1" dirty="0">
+                <a:solidFill>
+                  <a:srgbClr val="16233D"/>
+                </a:solidFill>
+                <a:latin typeface="Graphik TH" pitchFamily="34" charset="0"/>
+                <a:ea typeface="Graphik TH" pitchFamily="34" charset="-122"/>
+                <a:cs typeface="Graphik TH" pitchFamily="34" charset="-120"/>
+              </a:rPr>
+              <a:t>Very High</a:t>
+            </a:r>
+            <a:endParaRPr lang="en-US" sz="950" dirty="0"/>
+          </a:p>
+        </p:txBody>
+      </p:sp>
+      <p:sp>
+        <p:nvSpPr>
+          <p:cNvPr id="60" name="Shape 58"/>
+          <p:cNvSpPr/>
+          <p:nvPr/>
+        </p:nvSpPr>
+        <p:spPr>
+          <a:xfrm>
+            <a:off x="7507224" y="3666744"/>
+            <a:ext cx="261280" cy="164592"/>
+          </a:xfrm>
+          <a:prstGeom prst="roundRect">
+            <a:avLst>
+              <a:gd name="adj" fmla="val 16667"/>
+            </a:avLst>
+          </a:prstGeom>
+          <a:solidFill>
+            <a:srgbClr val="165A73"/>
+          </a:solidFill>
+          <a:ln/>
+        </p:spPr>
+      </p:sp>
+      <p:sp>
+        <p:nvSpPr>
+          <p:cNvPr id="61" name="Text 59"/>
+          <p:cNvSpPr/>
+          <p:nvPr/>
+        </p:nvSpPr>
+        <p:spPr>
+          <a:xfrm>
+            <a:off x="8549640" y="3621024"/>
+            <a:ext cx="512064" cy="256032"/>
+          </a:xfrm>
+          <a:prstGeom prst="rect">
+            <a:avLst/>
+          </a:prstGeom>
+          <a:noFill/>
+          <a:ln/>
+        </p:spPr>
+        <p:txBody>
+          <a:bodyPr wrap="square" lIns="0" tIns="0" rIns="0" bIns="0" rtlCol="0" anchor="ctr"/>
+          <a:lstStyle/>
+          <a:p>
+            <a:pPr algn="r" indent="0" marL="0">
+              <a:buNone/>
+            </a:pPr>
+            <a:r>
+              <a:rPr lang="en-US" sz="950" b="1" dirty="0">
+                <a:solidFill>
+                  <a:srgbClr val="165A73"/>
+                </a:solidFill>
+                <a:latin typeface="Graphik TH" pitchFamily="34" charset="0"/>
+                <a:ea typeface="Graphik TH" pitchFamily="34" charset="-122"/>
+                <a:cs typeface="Graphik TH" pitchFamily="34" charset="-120"/>
+              </a:rPr>
+              <a:t>12.9%</a:t>
+            </a:r>
+            <a:endParaRPr lang="en-US" sz="950" dirty="0"/>
+          </a:p>
+        </p:txBody>
+      </p:sp>
+      <p:sp>
+        <p:nvSpPr>
+          <p:cNvPr id="62" name="Shape 60"/>
+          <p:cNvSpPr/>
+          <p:nvPr/>
+        </p:nvSpPr>
+        <p:spPr>
+          <a:xfrm>
+            <a:off x="9748140" y="3666744"/>
+            <a:ext cx="118236" cy="164592"/>
+          </a:xfrm>
+          <a:prstGeom prst="roundRect">
+            <a:avLst>
+              <a:gd name="adj" fmla="val 23201"/>
+            </a:avLst>
+          </a:prstGeom>
+          <a:solidFill>
+            <a:srgbClr val="C00000"/>
+          </a:solidFill>
+          <a:ln/>
+        </p:spPr>
+      </p:sp>
+      <p:sp>
+        <p:nvSpPr>
+          <p:cNvPr id="63" name="Text 61"/>
+          <p:cNvSpPr/>
+          <p:nvPr/>
+        </p:nvSpPr>
+        <p:spPr>
+          <a:xfrm>
+            <a:off x="10378440" y="3621024"/>
+            <a:ext cx="1170432" cy="256032"/>
+          </a:xfrm>
+          <a:prstGeom prst="rect">
+            <a:avLst/>
+          </a:prstGeom>
+          <a:noFill/>
+          <a:ln/>
+        </p:spPr>
+        <p:txBody>
+          <a:bodyPr wrap="square" lIns="0" tIns="0" rIns="0" bIns="0" rtlCol="0" anchor="ctr"/>
+          <a:lstStyle/>
+          <a:p>
+            <a:pPr algn="r" indent="0" marL="0">
+              <a:buNone/>
+            </a:pPr>
+            <a:r>
+              <a:rPr lang="en-US" sz="850" b="1" dirty="0">
+                <a:solidFill>
+                  <a:srgbClr val="C00000"/>
+                </a:solidFill>
+                <a:latin typeface="Graphik TH" pitchFamily="34" charset="0"/>
+                <a:ea typeface="Graphik TH" pitchFamily="34" charset="-122"/>
+                <a:cs typeface="Graphik TH" pitchFamily="34" charset="-120"/>
+              </a:rPr>
+              <a:t>−36.0 (−2.5%)</a:t>
+            </a:r>
+            <a:endParaRPr lang="en-US" sz="850" dirty="0"/>
+          </a:p>
+        </p:txBody>
+      </p:sp>
+      <p:sp>
+        <p:nvSpPr>
+          <p:cNvPr id="64" name="Text 62"/>
+          <p:cNvSpPr/>
+          <p:nvPr/>
+        </p:nvSpPr>
+        <p:spPr>
+          <a:xfrm>
+            <a:off x="6537960" y="3913632"/>
+            <a:ext cx="914400" cy="256032"/>
+          </a:xfrm>
+          <a:prstGeom prst="rect">
+            <a:avLst/>
+          </a:prstGeom>
+          <a:noFill/>
+          <a:ln/>
+        </p:spPr>
+        <p:txBody>
+          <a:bodyPr wrap="square" lIns="0" tIns="0" rIns="0" bIns="0" rtlCol="0" anchor="ctr"/>
+          <a:lstStyle/>
+          <a:p>
+            <a:pPr indent="0" marL="0">
+              <a:buNone/>
+            </a:pPr>
+            <a:r>
+              <a:rPr lang="en-US" sz="950" b="1" dirty="0">
+                <a:solidFill>
+                  <a:srgbClr val="16233D"/>
+                </a:solidFill>
+                <a:latin typeface="Graphik TH" pitchFamily="34" charset="0"/>
+                <a:ea typeface="Graphik TH" pitchFamily="34" charset="-122"/>
+                <a:cs typeface="Graphik TH" pitchFamily="34" charset="-120"/>
+              </a:rPr>
+              <a:t>High</a:t>
+            </a:r>
+            <a:endParaRPr lang="en-US" sz="950" dirty="0"/>
+          </a:p>
+        </p:txBody>
+      </p:sp>
+      <p:sp>
+        <p:nvSpPr>
+          <p:cNvPr id="65" name="Shape 63"/>
+          <p:cNvSpPr/>
+          <p:nvPr/>
+        </p:nvSpPr>
+        <p:spPr>
+          <a:xfrm>
+            <a:off x="7507224" y="3959352"/>
+            <a:ext cx="1005840" cy="164592"/>
+          </a:xfrm>
+          <a:prstGeom prst="roundRect">
+            <a:avLst>
+              <a:gd name="adj" fmla="val 16667"/>
+            </a:avLst>
+          </a:prstGeom>
+          <a:solidFill>
+            <a:srgbClr val="165A73"/>
+          </a:solidFill>
+          <a:ln/>
+        </p:spPr>
+      </p:sp>
+      <p:sp>
+        <p:nvSpPr>
+          <p:cNvPr id="66" name="Text 64"/>
+          <p:cNvSpPr/>
+          <p:nvPr/>
+        </p:nvSpPr>
+        <p:spPr>
+          <a:xfrm>
+            <a:off x="8549640" y="3913632"/>
+            <a:ext cx="512064" cy="256032"/>
+          </a:xfrm>
+          <a:prstGeom prst="rect">
+            <a:avLst/>
+          </a:prstGeom>
+          <a:noFill/>
+          <a:ln/>
+        </p:spPr>
+        <p:txBody>
+          <a:bodyPr wrap="square" lIns="0" tIns="0" rIns="0" bIns="0" rtlCol="0" anchor="ctr"/>
+          <a:lstStyle/>
+          <a:p>
+            <a:pPr algn="r" indent="0" marL="0">
+              <a:buNone/>
+            </a:pPr>
+            <a:r>
+              <a:rPr lang="en-US" sz="950" b="1" dirty="0">
+                <a:solidFill>
+                  <a:srgbClr val="165A73"/>
+                </a:solidFill>
+                <a:latin typeface="Graphik TH" pitchFamily="34" charset="0"/>
+                <a:ea typeface="Graphik TH" pitchFamily="34" charset="-122"/>
+                <a:cs typeface="Graphik TH" pitchFamily="34" charset="-120"/>
+              </a:rPr>
+              <a:t>49.5%</a:t>
+            </a:r>
+            <a:endParaRPr lang="en-US" sz="950" dirty="0"/>
+          </a:p>
+        </p:txBody>
+      </p:sp>
+      <p:sp>
+        <p:nvSpPr>
+          <p:cNvPr id="67" name="Shape 65"/>
+          <p:cNvSpPr/>
+          <p:nvPr/>
+        </p:nvSpPr>
+        <p:spPr>
+          <a:xfrm>
+            <a:off x="9866376" y="3959352"/>
+            <a:ext cx="475488" cy="164592"/>
+          </a:xfrm>
+          <a:prstGeom prst="roundRect">
+            <a:avLst>
+              <a:gd name="adj" fmla="val 16667"/>
+            </a:avLst>
+          </a:prstGeom>
+          <a:solidFill>
+            <a:srgbClr val="1E8E86"/>
+          </a:solidFill>
+          <a:ln/>
+        </p:spPr>
+      </p:sp>
+      <p:sp>
+        <p:nvSpPr>
+          <p:cNvPr id="68" name="Text 66"/>
+          <p:cNvSpPr/>
+          <p:nvPr/>
+        </p:nvSpPr>
+        <p:spPr>
+          <a:xfrm>
+            <a:off x="10378440" y="3913632"/>
+            <a:ext cx="1170432" cy="256032"/>
+          </a:xfrm>
+          <a:prstGeom prst="rect">
+            <a:avLst/>
+          </a:prstGeom>
+          <a:noFill/>
+          <a:ln/>
+        </p:spPr>
+        <p:txBody>
+          <a:bodyPr wrap="square" lIns="0" tIns="0" rIns="0" bIns="0" rtlCol="0" anchor="ctr"/>
+          <a:lstStyle/>
+          <a:p>
+            <a:pPr algn="r" indent="0" marL="0">
+              <a:buNone/>
+            </a:pPr>
+            <a:r>
+              <a:rPr lang="en-US" sz="850" b="1" dirty="0">
+                <a:solidFill>
+                  <a:srgbClr val="1E8E86"/>
+                </a:solidFill>
+                <a:latin typeface="Graphik TH" pitchFamily="34" charset="0"/>
+                <a:ea typeface="Graphik TH" pitchFamily="34" charset="-122"/>
+                <a:cs typeface="Graphik TH" pitchFamily="34" charset="-120"/>
+              </a:rPr>
+              <a:t>+144.7 (+12.4%)</a:t>
+            </a:r>
+            <a:endParaRPr lang="en-US" sz="850" dirty="0"/>
+          </a:p>
+        </p:txBody>
+      </p:sp>
+      <p:sp>
+        <p:nvSpPr>
+          <p:cNvPr id="69" name="Text 67"/>
+          <p:cNvSpPr/>
+          <p:nvPr/>
+        </p:nvSpPr>
+        <p:spPr>
+          <a:xfrm>
+            <a:off x="6537960" y="4206240"/>
+            <a:ext cx="914400" cy="256032"/>
+          </a:xfrm>
+          <a:prstGeom prst="rect">
+            <a:avLst/>
+          </a:prstGeom>
+          <a:noFill/>
+          <a:ln/>
+        </p:spPr>
+        <p:txBody>
+          <a:bodyPr wrap="square" lIns="0" tIns="0" rIns="0" bIns="0" rtlCol="0" anchor="ctr"/>
+          <a:lstStyle/>
+          <a:p>
+            <a:pPr indent="0" marL="0">
+              <a:buNone/>
+            </a:pPr>
+            <a:r>
+              <a:rPr lang="en-US" sz="950" b="1" dirty="0">
+                <a:solidFill>
+                  <a:srgbClr val="6B7A90"/>
+                </a:solidFill>
+                <a:latin typeface="Graphik TH" pitchFamily="34" charset="0"/>
+                <a:ea typeface="Graphik TH" pitchFamily="34" charset="-122"/>
+                <a:cs typeface="Graphik TH" pitchFamily="34" charset="-120"/>
+              </a:rPr>
+              <a:t>Medium</a:t>
+            </a:r>
+            <a:endParaRPr lang="en-US" sz="950" dirty="0"/>
+          </a:p>
+        </p:txBody>
+      </p:sp>
+      <p:sp>
+        <p:nvSpPr>
+          <p:cNvPr id="70" name="Shape 68"/>
+          <p:cNvSpPr/>
+          <p:nvPr/>
+        </p:nvSpPr>
+        <p:spPr>
+          <a:xfrm>
+            <a:off x="7507224" y="4251960"/>
+            <a:ext cx="27432" cy="164592"/>
+          </a:xfrm>
+          <a:prstGeom prst="roundRect">
+            <a:avLst>
+              <a:gd name="adj" fmla="val 100000"/>
+            </a:avLst>
+          </a:prstGeom>
+          <a:solidFill>
+            <a:srgbClr val="D8DFE9"/>
+          </a:solidFill>
+          <a:ln/>
+        </p:spPr>
+      </p:sp>
+      <p:sp>
+        <p:nvSpPr>
+          <p:cNvPr id="71" name="Text 69"/>
+          <p:cNvSpPr/>
+          <p:nvPr/>
+        </p:nvSpPr>
+        <p:spPr>
+          <a:xfrm>
+            <a:off x="8549640" y="4206240"/>
+            <a:ext cx="512064" cy="256032"/>
+          </a:xfrm>
+          <a:prstGeom prst="rect">
+            <a:avLst/>
+          </a:prstGeom>
+          <a:noFill/>
+          <a:ln/>
+        </p:spPr>
+        <p:txBody>
+          <a:bodyPr wrap="square" lIns="0" tIns="0" rIns="0" bIns="0" rtlCol="0" anchor="ctr"/>
+          <a:lstStyle/>
+          <a:p>
+            <a:pPr algn="r" indent="0" marL="0">
+              <a:buNone/>
+            </a:pPr>
+            <a:r>
+              <a:rPr lang="en-US" sz="950" b="1" dirty="0">
+                <a:solidFill>
+                  <a:srgbClr val="6B7A90"/>
+                </a:solidFill>
+                <a:latin typeface="Graphik TH" pitchFamily="34" charset="0"/>
+                <a:ea typeface="Graphik TH" pitchFamily="34" charset="-122"/>
+                <a:cs typeface="Graphik TH" pitchFamily="34" charset="-120"/>
+              </a:rPr>
+              <a:t>0.0%</a:t>
+            </a:r>
+            <a:endParaRPr lang="en-US" sz="950" dirty="0"/>
+          </a:p>
+        </p:txBody>
+      </p:sp>
+      <p:sp>
+        <p:nvSpPr>
+          <p:cNvPr id="72" name="Shape 70"/>
+          <p:cNvSpPr/>
+          <p:nvPr/>
+        </p:nvSpPr>
+        <p:spPr>
+          <a:xfrm>
+            <a:off x="9838944" y="4251960"/>
+            <a:ext cx="27432" cy="164592"/>
+          </a:xfrm>
+          <a:prstGeom prst="roundRect">
+            <a:avLst>
+              <a:gd name="adj" fmla="val 100000"/>
+            </a:avLst>
+          </a:prstGeom>
+          <a:solidFill>
+            <a:srgbClr val="D8DFE9"/>
+          </a:solidFill>
+          <a:ln/>
+        </p:spPr>
+      </p:sp>
+      <p:sp>
+        <p:nvSpPr>
+          <p:cNvPr id="73" name="Text 71"/>
+          <p:cNvSpPr/>
+          <p:nvPr/>
+        </p:nvSpPr>
+        <p:spPr>
+          <a:xfrm>
+            <a:off x="10378440" y="4206240"/>
+            <a:ext cx="1170432" cy="256032"/>
+          </a:xfrm>
+          <a:prstGeom prst="rect">
+            <a:avLst/>
+          </a:prstGeom>
+          <a:noFill/>
+          <a:ln/>
+        </p:spPr>
+        <p:txBody>
+          <a:bodyPr wrap="square" lIns="0" tIns="0" rIns="0" bIns="0" rtlCol="0" anchor="ctr"/>
+          <a:lstStyle/>
+          <a:p>
+            <a:pPr algn="r" indent="0" marL="0">
+              <a:buNone/>
+            </a:pPr>
+            <a:r>
+              <a:rPr lang="en-US" sz="850" b="1" dirty="0">
+                <a:solidFill>
+                  <a:srgbClr val="6B7A90"/>
+                </a:solidFill>
+                <a:latin typeface="Graphik TH" pitchFamily="34" charset="0"/>
+                <a:ea typeface="Graphik TH" pitchFamily="34" charset="-122"/>
+                <a:cs typeface="Graphik TH" pitchFamily="34" charset="-120"/>
+              </a:rPr>
+              <a:t>−1.2 (−19.0%)</a:t>
+            </a:r>
+            <a:endParaRPr lang="en-US" sz="850" dirty="0"/>
+          </a:p>
+        </p:txBody>
+      </p:sp>
+      <p:sp>
+        <p:nvSpPr>
+          <p:cNvPr id="74" name="Text 72"/>
+          <p:cNvSpPr/>
+          <p:nvPr/>
+        </p:nvSpPr>
+        <p:spPr>
+          <a:xfrm>
+            <a:off x="6537960" y="4498848"/>
+            <a:ext cx="914400" cy="256032"/>
+          </a:xfrm>
+          <a:prstGeom prst="rect">
+            <a:avLst/>
+          </a:prstGeom>
+          <a:noFill/>
+          <a:ln/>
+        </p:spPr>
+        <p:txBody>
+          <a:bodyPr wrap="square" lIns="0" tIns="0" rIns="0" bIns="0" rtlCol="0" anchor="ctr"/>
+          <a:lstStyle/>
+          <a:p>
+            <a:pPr indent="0" marL="0">
+              <a:buNone/>
+            </a:pPr>
+            <a:r>
+              <a:rPr lang="en-US" sz="950" b="1" dirty="0">
+                <a:solidFill>
+                  <a:srgbClr val="16233D"/>
+                </a:solidFill>
+                <a:latin typeface="Graphik TH" pitchFamily="34" charset="0"/>
+                <a:ea typeface="Graphik TH" pitchFamily="34" charset="-122"/>
+                <a:cs typeface="Graphik TH" pitchFamily="34" charset="-120"/>
+              </a:rPr>
+              <a:t>Low</a:t>
+            </a:r>
+            <a:endParaRPr lang="en-US" sz="950" dirty="0"/>
+          </a:p>
+        </p:txBody>
+      </p:sp>
+      <p:sp>
+        <p:nvSpPr>
+          <p:cNvPr id="75" name="Shape 73"/>
+          <p:cNvSpPr/>
+          <p:nvPr/>
+        </p:nvSpPr>
+        <p:spPr>
+          <a:xfrm>
+            <a:off x="7507224" y="4544568"/>
+            <a:ext cx="145648" cy="164592"/>
+          </a:xfrm>
+          <a:prstGeom prst="roundRect">
+            <a:avLst>
+              <a:gd name="adj" fmla="val 18834"/>
+            </a:avLst>
+          </a:prstGeom>
+          <a:solidFill>
+            <a:srgbClr val="165A73"/>
+          </a:solidFill>
+          <a:ln/>
+        </p:spPr>
+      </p:sp>
+      <p:sp>
+        <p:nvSpPr>
+          <p:cNvPr id="76" name="Text 74"/>
+          <p:cNvSpPr/>
+          <p:nvPr/>
+        </p:nvSpPr>
+        <p:spPr>
+          <a:xfrm>
+            <a:off x="8549640" y="4498848"/>
+            <a:ext cx="512064" cy="256032"/>
+          </a:xfrm>
+          <a:prstGeom prst="rect">
+            <a:avLst/>
+          </a:prstGeom>
+          <a:noFill/>
+          <a:ln/>
+        </p:spPr>
+        <p:txBody>
+          <a:bodyPr wrap="square" lIns="0" tIns="0" rIns="0" bIns="0" rtlCol="0" anchor="ctr"/>
+          <a:lstStyle/>
+          <a:p>
+            <a:pPr algn="r" indent="0" marL="0">
+              <a:buNone/>
+            </a:pPr>
+            <a:r>
+              <a:rPr lang="en-US" sz="950" b="1" dirty="0">
+                <a:solidFill>
+                  <a:srgbClr val="165A73"/>
+                </a:solidFill>
+                <a:latin typeface="Graphik TH" pitchFamily="34" charset="0"/>
+                <a:ea typeface="Graphik TH" pitchFamily="34" charset="-122"/>
+                <a:cs typeface="Graphik TH" pitchFamily="34" charset="-120"/>
+              </a:rPr>
+              <a:t>7.2%</a:t>
+            </a:r>
+            <a:endParaRPr lang="en-US" sz="950" dirty="0"/>
+          </a:p>
+        </p:txBody>
+      </p:sp>
+      <p:sp>
+        <p:nvSpPr>
+          <p:cNvPr id="77" name="Shape 75"/>
+          <p:cNvSpPr/>
+          <p:nvPr/>
+        </p:nvSpPr>
+        <p:spPr>
+          <a:xfrm>
+            <a:off x="9866376" y="4544568"/>
+            <a:ext cx="48491" cy="164592"/>
+          </a:xfrm>
+          <a:prstGeom prst="roundRect">
+            <a:avLst>
+              <a:gd name="adj" fmla="val 56571"/>
+            </a:avLst>
+          </a:prstGeom>
+          <a:solidFill>
+            <a:srgbClr val="1E8E86"/>
+          </a:solidFill>
+          <a:ln/>
+        </p:spPr>
+      </p:sp>
+      <p:sp>
+        <p:nvSpPr>
+          <p:cNvPr id="78" name="Text 76"/>
+          <p:cNvSpPr/>
+          <p:nvPr/>
+        </p:nvSpPr>
+        <p:spPr>
+          <a:xfrm>
+            <a:off x="10378440" y="4498848"/>
+            <a:ext cx="1170432" cy="256032"/>
+          </a:xfrm>
+          <a:prstGeom prst="rect">
+            <a:avLst/>
+          </a:prstGeom>
+          <a:noFill/>
+          <a:ln/>
+        </p:spPr>
+        <p:txBody>
+          <a:bodyPr wrap="square" lIns="0" tIns="0" rIns="0" bIns="0" rtlCol="0" anchor="ctr"/>
+          <a:lstStyle/>
+          <a:p>
+            <a:pPr algn="r" indent="0" marL="0">
+              <a:buNone/>
+            </a:pPr>
+            <a:r>
+              <a:rPr lang="en-US" sz="850" b="1" dirty="0">
+                <a:solidFill>
+                  <a:srgbClr val="1E8E86"/>
+                </a:solidFill>
+                <a:latin typeface="Graphik TH" pitchFamily="34" charset="0"/>
+                <a:ea typeface="Graphik TH" pitchFamily="34" charset="-122"/>
+                <a:cs typeface="Graphik TH" pitchFamily="34" charset="-120"/>
+              </a:rPr>
+              <a:t>+14.8 (+11.4%)</a:t>
+            </a:r>
+            <a:endParaRPr lang="en-US" sz="850" dirty="0"/>
+          </a:p>
+        </p:txBody>
+      </p:sp>
+      <p:sp>
+        <p:nvSpPr>
+          <p:cNvPr id="79" name="Text 77"/>
+          <p:cNvSpPr/>
+          <p:nvPr/>
+        </p:nvSpPr>
+        <p:spPr>
+          <a:xfrm>
+            <a:off x="6537960" y="4791456"/>
+            <a:ext cx="914400" cy="256032"/>
+          </a:xfrm>
+          <a:prstGeom prst="rect">
+            <a:avLst/>
+          </a:prstGeom>
+          <a:noFill/>
+          <a:ln/>
+        </p:spPr>
+        <p:txBody>
+          <a:bodyPr wrap="square" lIns="0" tIns="0" rIns="0" bIns="0" rtlCol="0" anchor="ctr"/>
+          <a:lstStyle/>
+          <a:p>
+            <a:pPr indent="0" marL="0">
+              <a:buNone/>
+            </a:pPr>
+            <a:r>
+              <a:rPr lang="en-US" sz="950" b="1" dirty="0">
+                <a:solidFill>
+                  <a:srgbClr val="16233D"/>
+                </a:solidFill>
+                <a:latin typeface="Graphik TH" pitchFamily="34" charset="0"/>
+                <a:ea typeface="Graphik TH" pitchFamily="34" charset="-122"/>
+                <a:cs typeface="Graphik TH" pitchFamily="34" charset="-120"/>
+              </a:rPr>
+              <a:t>Very Low</a:t>
+            </a:r>
+            <a:endParaRPr lang="en-US" sz="950" dirty="0"/>
+          </a:p>
+        </p:txBody>
+      </p:sp>
+      <p:sp>
+        <p:nvSpPr>
+          <p:cNvPr id="80" name="Shape 78"/>
+          <p:cNvSpPr/>
+          <p:nvPr/>
+        </p:nvSpPr>
+        <p:spPr>
+          <a:xfrm>
+            <a:off x="7507224" y="4837176"/>
+            <a:ext cx="195870" cy="164592"/>
+          </a:xfrm>
+          <a:prstGeom prst="roundRect">
+            <a:avLst>
+              <a:gd name="adj" fmla="val 16667"/>
+            </a:avLst>
+          </a:prstGeom>
+          <a:solidFill>
+            <a:srgbClr val="165A73"/>
+          </a:solidFill>
+          <a:ln/>
+        </p:spPr>
+      </p:sp>
+      <p:sp>
+        <p:nvSpPr>
+          <p:cNvPr id="81" name="Text 79"/>
+          <p:cNvSpPr/>
+          <p:nvPr/>
+        </p:nvSpPr>
+        <p:spPr>
+          <a:xfrm>
+            <a:off x="8549640" y="4791456"/>
+            <a:ext cx="512064" cy="256032"/>
+          </a:xfrm>
+          <a:prstGeom prst="rect">
+            <a:avLst/>
+          </a:prstGeom>
+          <a:noFill/>
+          <a:ln/>
+        </p:spPr>
+        <p:txBody>
+          <a:bodyPr wrap="square" lIns="0" tIns="0" rIns="0" bIns="0" rtlCol="0" anchor="ctr"/>
+          <a:lstStyle/>
+          <a:p>
+            <a:pPr algn="r" indent="0" marL="0">
+              <a:buNone/>
+            </a:pPr>
+            <a:r>
+              <a:rPr lang="en-US" sz="950" b="1" dirty="0">
+                <a:solidFill>
+                  <a:srgbClr val="165A73"/>
+                </a:solidFill>
+                <a:latin typeface="Graphik TH" pitchFamily="34" charset="0"/>
+                <a:ea typeface="Graphik TH" pitchFamily="34" charset="-122"/>
+                <a:cs typeface="Graphik TH" pitchFamily="34" charset="-120"/>
+              </a:rPr>
+              <a:t>9.6%</a:t>
+            </a:r>
+            <a:endParaRPr lang="en-US" sz="950" dirty="0"/>
+          </a:p>
+        </p:txBody>
+      </p:sp>
+      <p:sp>
+        <p:nvSpPr>
+          <p:cNvPr id="82" name="Shape 80"/>
+          <p:cNvSpPr/>
+          <p:nvPr/>
+        </p:nvSpPr>
+        <p:spPr>
+          <a:xfrm>
+            <a:off x="9830126" y="4837176"/>
+            <a:ext cx="36250" cy="164592"/>
+          </a:xfrm>
+          <a:prstGeom prst="roundRect">
+            <a:avLst>
+              <a:gd name="adj" fmla="val 75674"/>
+            </a:avLst>
+          </a:prstGeom>
+          <a:solidFill>
+            <a:srgbClr val="C00000"/>
+          </a:solidFill>
+          <a:ln/>
+        </p:spPr>
+      </p:sp>
+      <p:sp>
+        <p:nvSpPr>
+          <p:cNvPr id="83" name="Text 81"/>
+          <p:cNvSpPr/>
+          <p:nvPr/>
+        </p:nvSpPr>
+        <p:spPr>
+          <a:xfrm>
+            <a:off x="10378440" y="4791456"/>
+            <a:ext cx="1170432" cy="256032"/>
+          </a:xfrm>
+          <a:prstGeom prst="rect">
+            <a:avLst/>
+          </a:prstGeom>
+          <a:noFill/>
+          <a:ln/>
+        </p:spPr>
+        <p:txBody>
+          <a:bodyPr wrap="square" lIns="0" tIns="0" rIns="0" bIns="0" rtlCol="0" anchor="ctr"/>
+          <a:lstStyle/>
+          <a:p>
+            <a:pPr algn="r" indent="0" marL="0">
+              <a:buNone/>
+            </a:pPr>
+            <a:r>
+              <a:rPr lang="en-US" sz="850" b="1" dirty="0">
+                <a:solidFill>
+                  <a:srgbClr val="C00000"/>
+                </a:solidFill>
+                <a:latin typeface="Graphik TH" pitchFamily="34" charset="0"/>
+                <a:ea typeface="Graphik TH" pitchFamily="34" charset="-122"/>
+                <a:cs typeface="Graphik TH" pitchFamily="34" charset="-120"/>
+              </a:rPr>
+              <a:t>−11.0 (−6.9%)</a:t>
+            </a:r>
+            <a:endParaRPr lang="en-US" sz="850" dirty="0"/>
+          </a:p>
+        </p:txBody>
+      </p:sp>
+      <p:sp>
+        <p:nvSpPr>
+          <p:cNvPr id="84" name="Shape 82"/>
+          <p:cNvSpPr/>
+          <p:nvPr/>
+        </p:nvSpPr>
+        <p:spPr>
+          <a:xfrm>
+            <a:off x="530352" y="5285232"/>
+            <a:ext cx="11274552" cy="786384"/>
+          </a:xfrm>
+          <a:prstGeom prst="roundRect">
+            <a:avLst>
+              <a:gd name="adj" fmla="val 10465"/>
+            </a:avLst>
+          </a:prstGeom>
+          <a:solidFill>
+            <a:srgbClr val="FBF0E6"/>
+          </a:solidFill>
+          <a:ln/>
+        </p:spPr>
+      </p:sp>
+      <p:sp>
+        <p:nvSpPr>
+          <p:cNvPr id="85" name="Text 83"/>
+          <p:cNvSpPr/>
+          <p:nvPr/>
+        </p:nvSpPr>
+        <p:spPr>
+          <a:xfrm>
+            <a:off x="804672" y="5285232"/>
+            <a:ext cx="10725912" cy="786384"/>
+          </a:xfrm>
+          <a:prstGeom prst="rect">
+            <a:avLst/>
+          </a:prstGeom>
+          <a:noFill/>
+          <a:ln/>
+        </p:spPr>
+        <p:txBody>
+          <a:bodyPr wrap="square" lIns="0" tIns="0" rIns="0" bIns="0" rtlCol="0" anchor="ctr"/>
+          <a:lstStyle/>
+          <a:p>
+            <a:pPr indent="0" marL="0">
+              <a:buNone/>
+            </a:pPr>
+            <a:r>
+              <a:rPr lang="en-US" sz="1100" b="1" dirty="0">
+                <a:solidFill>
+                  <a:srgbClr val="C00000"/>
+                </a:solidFill>
+                <a:latin typeface="Graphik TH" pitchFamily="34" charset="0"/>
+                <a:ea typeface="Graphik TH" pitchFamily="34" charset="-122"/>
+                <a:cs typeface="Graphik TH" pitchFamily="34" charset="-120"/>
+              </a:rPr>
+              <a:t>Only rate sensitivity needs re-fitting</a:t>
+            </a:r>
+            <a:pPr indent="0" marL="0">
+              <a:buNone/>
+            </a:pPr>
+            <a:r>
+              <a:rPr lang="en-US" sz="1100" dirty="0">
+                <a:solidFill>
+                  <a:srgbClr val="16233D"/>
+                </a:solidFill>
+                <a:latin typeface="Graphik TH" pitchFamily="34" charset="0"/>
+                <a:ea typeface="Graphik TH" pitchFamily="34" charset="-122"/>
+                <a:cs typeface="Graphik TH" pitchFamily="34" charset="-120"/>
+              </a:rPr>
+              <a:t>  —  stickiness is directionally consistent, though its alignment is partly a size effect: the two top tiers hold 98.8% of the balance. Rate sensitivity genuinely diverges — High gained +144.7m while Very High lost 36.0m.</a:t>
+            </a:r>
+            <a:endParaRPr lang="en-US" sz="1100" dirty="0"/>
+          </a:p>
+        </p:txBody>
+      </p:sp>
+    </p:spTree>
+  </p:cSld>
+  <p:clrMapOvr>
+    <a:masterClrMapping/>
+  </p:clrMapOvr>
+</p:sld>
+</file>
+
 <file path=ppt/slides/slide2.xml><?xml version="1.0" encoding="utf-8"?>
 <p:sld xmlns:a="http://schemas.openxmlformats.org/drawingml/2006/main" xmlns:r="http://schemas.openxmlformats.org/officeDocument/2006/relationships" xmlns:p="http://schemas.openxmlformats.org/presentationml/2006/main">
   <p:cSld name="Slide 2">

</xml_diff>

<commit_message>
Add whole-base balance-change slide and share one builder with slide 13
Slide 13 is refactored into balanceByStickiness(), called twice: once
for the Save Max cohort and once for the whole funded deposit base, so
the two slides cannot drift apart.

The new extract reconciles exactly to the funded base already in the
deck - 320,109 customers and THB 5.478bn prior balance, with per-tier
average balances matching slide 8. Whole base gains THB 211.1m (+3.9%).

The contrast is the point: on the Save Max cohort stickiness >= 60
contributes 95.5% of the gain, but across the whole base only 79.2%,
with the three lower tiers supplying a fifth of the growth on prior
balances of THB 211m, 11.3m and 5.35m.

NULL values in the save_max columns of the new extract are parsed as
zero; those columns are not used by this slide.

Co-Authored-By: Claude Opus 5 <noreply@anthropic.com>
Claude-Session: https://claude.ai/code/session_01VKpfo226Go9vQJYa4eoC1d
</commit_message>
<xml_diff>
--- a/Deposit_Stickiness_Framework.pptx
+++ b/Deposit_Stickiness_Framework.pptx
@@ -19,9 +19,10 @@
     <p:sldId id="267" r:id="rId13"/>
     <p:sldId id="268" r:id="rId14"/>
     <p:sldId id="269" r:id="rId15"/>
+    <p:sldId id="270" r:id="rId16"/>
   </p:sldIdLst>
   <p:notesMasterIdLst>
-    <p:notesMasterId r:id="rId16"/>
+    <p:notesMasterId r:id="rId17"/>
   </p:notesMasterIdLst>
   <p:sldSz cx="12192000" cy="6858000"/>
   <p:notesSz cx="6858000" cy="12192000"/>
@@ -867,7 +868,7 @@
           <a:p>
             <a:r>
               <a:rPr lang="en-US" dirty="0"/>
-              <a:t>Total deposit balance rose from THB 2,901,915,577 to THB 3,013,181,725, +111.3m or +3.8%. Every stickiness tier gained. In absolute terms the gain is concentrated: High +71.4m and Very High +34.9m together are 95.5% of it, which follows from those two tiers holding 98.8% of prior balance. In percentage terms the ranking reverses: Very High +3.2%, High +4.0%, Medium +8.8%, Low +174.7%, Very Low +1549.2%. Those last two are computed on prior balances of THB 902,104 and THB 31,005 across 2,089 and 1,408 customers - average prior balances of THB 432 and THB 22 - so they represent dormant accounts receiving small deposits rather than material growth. Both readings are kept on the slide deliberately: the absolute column is the one to rank on, and the percentage column is a useful early indicator that previously unfunded accounts are becoming funded.</a:t>
+              <a:t>Cohort of 47,184. Total deposit balance rose from THB 2,901,915,577 to THB 3,013,181,725, +111.3m or +3.8%. Every stickiness tier gained. In absolute terms the gain concentrates in the top two tiers: High +71.4m and Very High +34.9m, together 95.5% of it, which follows from those tiers holding 98.8% of prior balance. In percentage terms the ranking reverses cleanly: Very High +3.2%, High +4.0%, Medium +8.8%, Low +174.7%, Very Low +1549.2%. Average prior balance per customer runs from THB 90,152 in the Very High tier to THB 22 in the Very Low tier, so the low tiers' percentages reflect dormant accounts receiving small deposits rather than material growth. Both readings are kept deliberately: rank on the absolute column, and read the percentage column as an early indicator that previously unfunded accounts are becoming funded.</a:t>
             </a:r>
             <a:endParaRPr lang="en-US" dirty="0"/>
           </a:p>
@@ -955,7 +956,7 @@
           <a:p>
             <a:r>
               <a:rPr lang="en-US" dirty="0"/>
-              <a:t>Deposit stickiness ranks the two measures consistently: move rate runs 1.9% to 19.2% from Very Low to Very High, and balance change is positive in every tier. The caveat is that this consistency is partly mechanical - the High and Very High tiers hold 98.8% of prior balance and contributed 95.5% of the cohort's gain, so the ranking largely restates where the money is. In percentage terms the picture is flatter and mildly reversed: Very High +3.2%, High +4.0%, Medium +8.8%, with the Low and Very Low tiers unusable because their prior balances are near zero. Rate sensitivity diverges for real: High moves at 49.5% and gained THB 144.7m, while Very High moves at 12.9% and lost THB 36.0m. Very Low also lost, THB 11.0m on a 9.6% move rate. Medium is 4 customers in both scores and is greyed out rather than read. Conclusion for the framework: stickiness can stay as an activity and eligibility filter, but rate-sensitivity cut-offs should be re-fitted on observed outcomes, and the two outcomes - emptying the pocket and losing balance - should be scored separately.</a:t>
+              <a:t>Base of 320,109. Total deposit balance rose from THB 5,477,500,352 to THB 5,688,588,400, +211.1m or +3.9%. Every stickiness tier gained. In absolute terms the gain concentrates in the top two tiers: High +99.5m and Very High +67.6m, together 79.2% of it, which follows from those tiers holding 95.8% of prior balance. In percentage terms the ranking reverses cleanly: Very High +2.5%, High +3.8%, Medium +11.8%, Low +100.6%, Very Low +143.6%. Average prior balance per customer runs from THB 49,529 in the Very High tier to THB 143 in the Very Low tier, so the low tiers' percentages reflect dormant accounts receiving small deposits rather than material growth. Both readings are kept deliberately: rank on the absolute column, and read the percentage column as an early indicator that previously unfunded accounts are becoming funded.</a:t>
             </a:r>
             <a:endParaRPr lang="en-US" dirty="0"/>
           </a:p>
@@ -979,6 +980,94 @@
             <a:fld id="{F7021451-1387-4CA6-816F-3879F97B5CBC}" type="slidenum">
               <a:rPr lang="en-US"/>
               <a:t>14</a:t>
+            </a:fld>
+            <a:endParaRPr lang="en-US"/>
+          </a:p>
+        </p:txBody>
+      </p:sp>
+    </p:spTree>
+    <p:extLst>
+      <p:ext uri="{BB962C8B-B14F-4D97-AF65-F5344CB8AC3E}">
+        <p14:creationId xmlns:p14="http://schemas.microsoft.com/office/powerpoint/2010/main" val="1024086991"/>
+      </p:ext>
+    </p:extLst>
+  </p:cSld>
+  <p:clrMapOvr>
+    <a:masterClrMapping/>
+  </p:clrMapOvr>
+</p:notes>
+</file>
+
+<file path=ppt/notesSlides/notesSlide15.xml><?xml version="1.0" encoding="utf-8"?>
+<p:notes xmlns:a="http://schemas.openxmlformats.org/drawingml/2006/main" xmlns:r="http://schemas.openxmlformats.org/officeDocument/2006/relationships" xmlns:p="http://schemas.openxmlformats.org/presentationml/2006/main">
+  <p:cSld>
+    <p:spTree>
+      <p:nvGrpSpPr>
+        <p:cNvPr id="1" name=""/>
+        <p:cNvGrpSpPr/>
+        <p:nvPr/>
+      </p:nvGrpSpPr>
+      <p:grpSpPr>
+        <a:xfrm>
+          <a:off x="0" y="0"/>
+          <a:ext cx="0" cy="0"/>
+          <a:chOff x="0" y="0"/>
+          <a:chExt cx="0" cy="0"/>
+        </a:xfrm>
+      </p:grpSpPr>
+      <p:sp>
+        <p:nvSpPr>
+          <p:cNvPr id="2" name="Slide Image Placeholder 1"/>
+          <p:cNvSpPr>
+            <a:spLocks noGrp="1" noRot="1" noChangeAspect="1"/>
+          </p:cNvSpPr>
+          <p:nvPr>
+            <p:ph type="sldImg"/>
+          </p:nvPr>
+        </p:nvSpPr>
+        <p:spPr/>
+      </p:sp>
+      <p:sp>
+        <p:nvSpPr>
+          <p:cNvPr id="3" name="Notes Placeholder 2"/>
+          <p:cNvSpPr>
+            <a:spLocks noGrp="1"/>
+          </p:cNvSpPr>
+          <p:nvPr>
+            <p:ph type="body" idx="1"/>
+          </p:nvPr>
+        </p:nvSpPr>
+        <p:spPr/>
+        <p:txBody>
+          <a:bodyPr/>
+          <a:lstStyle/>
+          <a:p>
+            <a:r>
+              <a:rPr lang="en-US" dirty="0"/>
+              <a:t>Deposit stickiness ranks the two measures consistently: move rate runs 1.9% to 19.2% from Very Low to Very High, and balance change is positive in every tier. The caveat is that this consistency is partly mechanical - the High and Very High tiers hold 98.8% of prior balance and contributed 95.5% of the cohort's gain, so the ranking largely restates where the money is. In percentage terms the picture is flatter and mildly reversed: Very High +3.2%, High +4.0%, Medium +8.8%, with the Low and Very Low tiers unusable because their prior balances are near zero. Rate sensitivity diverges for real: High moves at 49.5% and gained THB 144.7m, while Very High moves at 12.9% and lost THB 36.0m. Very Low also lost, THB 11.0m on a 9.6% move rate. Medium is 4 customers in both scores and is greyed out rather than read. Conclusion for the framework: stickiness can stay as an activity and eligibility filter, but rate-sensitivity cut-offs should be re-fitted on observed outcomes, and the two outcomes - emptying the pocket and losing balance - should be scored separately.</a:t>
+            </a:r>
+            <a:endParaRPr lang="en-US" dirty="0"/>
+          </a:p>
+        </p:txBody>
+      </p:sp>
+      <p:sp>
+        <p:nvSpPr>
+          <p:cNvPr id="4" name="Slide Number Placeholder 3"/>
+          <p:cNvSpPr>
+            <a:spLocks noGrp="1"/>
+          </p:cNvSpPr>
+          <p:nvPr>
+            <p:ph type="sldNum" sz="quarter" idx="10"/>
+          </p:nvPr>
+        </p:nvSpPr>
+        <p:spPr/>
+        <p:txBody>
+          <a:bodyPr/>
+          <a:lstStyle/>
+          <a:p>
+            <a:fld id="{F7021451-1387-4CA6-816F-3879F97B5CBC}" type="slidenum">
+              <a:rPr lang="en-US"/>
+              <a:t>15</a:t>
             </a:fld>
             <a:endParaRPr lang="en-US"/>
           </a:p>
@@ -13532,7 +13621,7 @@
                 <a:ea typeface="Graphik TH" pitchFamily="34" charset="-122"/>
                 <a:cs typeface="Graphik TH" pitchFamily="34" charset="-120"/>
               </a:rPr>
-              <a:t>Balance change by deposit stickiness</a:t>
+              <a:t>Balance change by deposit stickiness — Save Max holders</a:t>
             </a:r>
             <a:endParaRPr lang="en-US" sz="2200" dirty="0"/>
           </a:p>
@@ -13571,7 +13660,7 @@
                 <a:ea typeface="Graphik TH" pitchFamily="34" charset="-122"/>
                 <a:cs typeface="Graphik TH" pitchFamily="34" charset="-120"/>
               </a:rPr>
-              <a:t>*Change in total deposit balance, prior to latest. Percentage change is shown for every tier — read it against the prior-balance column.</a:t>
+              <a:t>*Save Max holders with balance &gt; 0. Percentage change is shown for every tier — read it against the prior-balance column.</a:t>
             </a:r>
             <a:endParaRPr lang="en-US" sz="1150" dirty="0"/>
           </a:p>
@@ -13610,7 +13699,7 @@
                 <a:ea typeface="Graphik TH" pitchFamily="34" charset="-122"/>
                 <a:cs typeface="Graphik TH" pitchFamily="34" charset="-120"/>
               </a:rPr>
-              <a:t>Cohort 47,184   ·   Prior THB 2901.9m → latest THB 3013.2m   ·   Change +111.3m (+3.8%)</a:t>
+              <a:t>Cohort 47,184   ·   Prior THB 2.90bn → latest THB 3.01bn   ·   Change +111.3m (+3.8%)</a:t>
             </a:r>
             <a:endParaRPr lang="en-US" sz="1300" dirty="0"/>
           </a:p>
@@ -13788,7 +13877,7 @@
                 <a:ea typeface="Graphik TH" pitchFamily="34" charset="-122"/>
                 <a:cs typeface="Graphik TH" pitchFamily="34" charset="-120"/>
               </a:rPr>
-              <a:t>+3.8% across the cohort</a:t>
+              <a:t>+3.8% across the base</a:t>
             </a:r>
             <a:endParaRPr lang="en-US" sz="950" dirty="0"/>
           </a:p>
@@ -18157,6 +18246,4685 @@
 <file path=ppt/slides/slide14.xml><?xml version="1.0" encoding="utf-8"?>
 <p:sld xmlns:a="http://schemas.openxmlformats.org/drawingml/2006/main" xmlns:r="http://schemas.openxmlformats.org/officeDocument/2006/relationships" xmlns:p="http://schemas.openxmlformats.org/presentationml/2006/main">
   <p:cSld name="Slide 14">
+    <p:bg>
+      <p:bgPr>
+        <a:solidFill>
+          <a:srgbClr val="FFFFFF"/>
+        </a:solidFill>
+      </p:bgPr>
+    </p:bg>
+    <p:spTree>
+      <p:nvGrpSpPr>
+        <p:cNvPr id="1" name=""/>
+        <p:cNvGrpSpPr/>
+        <p:nvPr/>
+      </p:nvGrpSpPr>
+      <p:grpSpPr>
+        <a:xfrm>
+          <a:off x="0" y="0"/>
+          <a:ext cx="0" cy="0"/>
+          <a:chOff x="0" y="0"/>
+          <a:chExt cx="0" cy="0"/>
+        </a:xfrm>
+      </p:grpSpPr>
+      <p:sp>
+        <p:nvSpPr>
+          <p:cNvPr id="2" name="Text 0"/>
+          <p:cNvSpPr/>
+          <p:nvPr/>
+        </p:nvSpPr>
+        <p:spPr>
+          <a:xfrm>
+            <a:off x="530352" y="283464"/>
+            <a:ext cx="11274552" cy="384048"/>
+          </a:xfrm>
+          <a:prstGeom prst="rect">
+            <a:avLst/>
+          </a:prstGeom>
+          <a:noFill/>
+          <a:ln/>
+        </p:spPr>
+        <p:txBody>
+          <a:bodyPr wrap="square" lIns="0" tIns="0" rIns="0" bIns="0" rtlCol="0" anchor="ctr"/>
+          <a:lstStyle/>
+          <a:p>
+            <a:pPr indent="0" marL="0">
+              <a:buNone/>
+            </a:pPr>
+            <a:r>
+              <a:rPr lang="en-US" sz="2200" b="1" dirty="0">
+                <a:solidFill>
+                  <a:srgbClr val="045D66"/>
+                </a:solidFill>
+                <a:latin typeface="Graphik TH" pitchFamily="34" charset="0"/>
+                <a:ea typeface="Graphik TH" pitchFamily="34" charset="-122"/>
+                <a:cs typeface="Graphik TH" pitchFamily="34" charset="-120"/>
+              </a:rPr>
+              <a:t>Balance change by deposit stickiness — whole deposit base</a:t>
+            </a:r>
+            <a:endParaRPr lang="en-US" sz="2200" dirty="0"/>
+          </a:p>
+        </p:txBody>
+      </p:sp>
+      <p:sp>
+        <p:nvSpPr>
+          <p:cNvPr id="3" name="Text 1"/>
+          <p:cNvSpPr/>
+          <p:nvPr/>
+        </p:nvSpPr>
+        <p:spPr>
+          <a:xfrm>
+            <a:off x="530352" y="713232"/>
+            <a:ext cx="11274552" cy="237744"/>
+          </a:xfrm>
+          <a:prstGeom prst="rect">
+            <a:avLst/>
+          </a:prstGeom>
+          <a:noFill/>
+          <a:ln/>
+        </p:spPr>
+        <p:txBody>
+          <a:bodyPr wrap="square" lIns="0" tIns="0" rIns="0" bIns="0" rtlCol="0" anchor="ctr"/>
+          <a:lstStyle/>
+          <a:p>
+            <a:pPr indent="0" marL="0">
+              <a:buNone/>
+            </a:pPr>
+            <a:r>
+              <a:rPr lang="en-US" sz="1150" i="1" dirty="0">
+                <a:solidFill>
+                  <a:srgbClr val="6B6B6B"/>
+                </a:solidFill>
+                <a:latin typeface="Graphik TH" pitchFamily="34" charset="0"/>
+                <a:ea typeface="Graphik TH" pitchFamily="34" charset="-122"/>
+                <a:cs typeface="Graphik TH" pitchFamily="34" charset="-120"/>
+              </a:rPr>
+              <a:t>*Whole funded deposit base (balance &gt; 0), all customers. Percentage change is shown for every tier — read it against the prior-balance column.</a:t>
+            </a:r>
+            <a:endParaRPr lang="en-US" sz="1150" dirty="0"/>
+          </a:p>
+        </p:txBody>
+      </p:sp>
+      <p:sp>
+        <p:nvSpPr>
+          <p:cNvPr id="4" name="Text 2"/>
+          <p:cNvSpPr/>
+          <p:nvPr/>
+        </p:nvSpPr>
+        <p:spPr>
+          <a:xfrm>
+            <a:off x="548640" y="996696"/>
+            <a:ext cx="11064240" cy="237744"/>
+          </a:xfrm>
+          <a:prstGeom prst="rect">
+            <a:avLst/>
+          </a:prstGeom>
+          <a:noFill/>
+          <a:ln/>
+        </p:spPr>
+        <p:txBody>
+          <a:bodyPr wrap="square" lIns="0" tIns="0" rIns="0" bIns="0" rtlCol="0" anchor="ctr"/>
+          <a:lstStyle/>
+          <a:p>
+            <a:pPr indent="0" marL="0">
+              <a:buNone/>
+            </a:pPr>
+            <a:r>
+              <a:rPr lang="en-US" sz="1300" b="1" dirty="0">
+                <a:solidFill>
+                  <a:srgbClr val="045D66"/>
+                </a:solidFill>
+                <a:latin typeface="Graphik TH" pitchFamily="34" charset="0"/>
+                <a:ea typeface="Graphik TH" pitchFamily="34" charset="-122"/>
+                <a:cs typeface="Graphik TH" pitchFamily="34" charset="-120"/>
+              </a:rPr>
+              <a:t>Base 320,109   ·   Prior THB 5.48bn → latest THB 5.69bn   ·   Change +211.1m (+3.9%)</a:t>
+            </a:r>
+            <a:endParaRPr lang="en-US" sz="1300" dirty="0"/>
+          </a:p>
+        </p:txBody>
+      </p:sp>
+      <p:sp>
+        <p:nvSpPr>
+          <p:cNvPr id="5" name="Text 3"/>
+          <p:cNvSpPr/>
+          <p:nvPr/>
+        </p:nvSpPr>
+        <p:spPr>
+          <a:xfrm>
+            <a:off x="548640" y="1280160"/>
+            <a:ext cx="11064240" cy="274320"/>
+          </a:xfrm>
+          <a:prstGeom prst="rect">
+            <a:avLst/>
+          </a:prstGeom>
+          <a:noFill/>
+          <a:ln/>
+        </p:spPr>
+        <p:txBody>
+          <a:bodyPr wrap="square" lIns="0" tIns="0" rIns="0" bIns="0" rtlCol="0" anchor="ctr"/>
+          <a:lstStyle/>
+          <a:p>
+            <a:pPr indent="0" marL="0">
+              <a:buNone/>
+            </a:pPr>
+            <a:r>
+              <a:rPr lang="en-US" sz="1400" dirty="0">
+                <a:solidFill>
+                  <a:srgbClr val="16233D"/>
+                </a:solidFill>
+                <a:latin typeface="Graphik TH" pitchFamily="34" charset="0"/>
+                <a:ea typeface="Graphik TH" pitchFamily="34" charset="-122"/>
+                <a:cs typeface="Graphik TH" pitchFamily="34" charset="-120"/>
+              </a:rPr>
+              <a:t>The same shape at seven times the size — but a fifth of the growth now comes from the three lower tiers.</a:t>
+            </a:r>
+            <a:endParaRPr lang="en-US" sz="1400" dirty="0"/>
+          </a:p>
+        </p:txBody>
+      </p:sp>
+      <p:sp>
+        <p:nvSpPr>
+          <p:cNvPr id="6" name="Shape 4"/>
+          <p:cNvSpPr/>
+          <p:nvPr/>
+        </p:nvSpPr>
+        <p:spPr>
+          <a:xfrm>
+            <a:off x="530352" y="1645920"/>
+            <a:ext cx="2647188" cy="987552"/>
+          </a:xfrm>
+          <a:prstGeom prst="roundRect">
+            <a:avLst>
+              <a:gd name="adj" fmla="val 8333"/>
+            </a:avLst>
+          </a:prstGeom>
+          <a:solidFill>
+            <a:srgbClr val="F1F4F9"/>
+          </a:solidFill>
+          <a:ln/>
+        </p:spPr>
+      </p:sp>
+      <p:sp>
+        <p:nvSpPr>
+          <p:cNvPr id="7" name="Text 5"/>
+          <p:cNvSpPr/>
+          <p:nvPr/>
+        </p:nvSpPr>
+        <p:spPr>
+          <a:xfrm>
+            <a:off x="749808" y="1719072"/>
+            <a:ext cx="2208276" cy="402336"/>
+          </a:xfrm>
+          <a:prstGeom prst="rect">
+            <a:avLst/>
+          </a:prstGeom>
+          <a:noFill/>
+          <a:ln/>
+        </p:spPr>
+        <p:txBody>
+          <a:bodyPr wrap="square" lIns="0" tIns="0" rIns="0" bIns="0" rtlCol="0" anchor="ctr"/>
+          <a:lstStyle/>
+          <a:p>
+            <a:pPr indent="0" marL="0">
+              <a:buNone/>
+            </a:pPr>
+            <a:r>
+              <a:rPr lang="en-US" sz="2400" b="1" dirty="0">
+                <a:solidFill>
+                  <a:srgbClr val="00A896"/>
+                </a:solidFill>
+                <a:latin typeface="Graphik TH" pitchFamily="34" charset="0"/>
+                <a:ea typeface="Graphik TH" pitchFamily="34" charset="-122"/>
+                <a:cs typeface="Graphik TH" pitchFamily="34" charset="-120"/>
+              </a:rPr>
+              <a:t>+211.1m</a:t>
+            </a:r>
+            <a:endParaRPr lang="en-US" sz="2400" dirty="0"/>
+          </a:p>
+        </p:txBody>
+      </p:sp>
+      <p:sp>
+        <p:nvSpPr>
+          <p:cNvPr id="8" name="Text 6"/>
+          <p:cNvSpPr/>
+          <p:nvPr/>
+        </p:nvSpPr>
+        <p:spPr>
+          <a:xfrm>
+            <a:off x="749808" y="2121408"/>
+            <a:ext cx="2208276" cy="237744"/>
+          </a:xfrm>
+          <a:prstGeom prst="rect">
+            <a:avLst/>
+          </a:prstGeom>
+          <a:noFill/>
+          <a:ln/>
+        </p:spPr>
+        <p:txBody>
+          <a:bodyPr wrap="square" lIns="0" tIns="0" rIns="0" bIns="0" rtlCol="0" anchor="t"/>
+          <a:lstStyle/>
+          <a:p>
+            <a:pPr indent="0" marL="0">
+              <a:buNone/>
+            </a:pPr>
+            <a:r>
+              <a:rPr lang="en-US" sz="1150" b="1" dirty="0">
+                <a:solidFill>
+                  <a:srgbClr val="16233D"/>
+                </a:solidFill>
+                <a:latin typeface="Graphik TH" pitchFamily="34" charset="0"/>
+                <a:ea typeface="Graphik TH" pitchFamily="34" charset="-122"/>
+                <a:cs typeface="Graphik TH" pitchFamily="34" charset="-120"/>
+              </a:rPr>
+              <a:t>total balance change</a:t>
+            </a:r>
+            <a:endParaRPr lang="en-US" sz="1150" dirty="0"/>
+          </a:p>
+        </p:txBody>
+      </p:sp>
+      <p:sp>
+        <p:nvSpPr>
+          <p:cNvPr id="9" name="Text 7"/>
+          <p:cNvSpPr/>
+          <p:nvPr/>
+        </p:nvSpPr>
+        <p:spPr>
+          <a:xfrm>
+            <a:off x="749808" y="2350008"/>
+            <a:ext cx="2208276" cy="237744"/>
+          </a:xfrm>
+          <a:prstGeom prst="rect">
+            <a:avLst/>
+          </a:prstGeom>
+          <a:noFill/>
+          <a:ln/>
+        </p:spPr>
+        <p:txBody>
+          <a:bodyPr wrap="square" lIns="0" tIns="0" rIns="0" bIns="0" rtlCol="0" anchor="t"/>
+          <a:lstStyle/>
+          <a:p>
+            <a:pPr indent="0" marL="0">
+              <a:buNone/>
+            </a:pPr>
+            <a:r>
+              <a:rPr lang="en-US" sz="950" dirty="0">
+                <a:solidFill>
+                  <a:srgbClr val="6B7A90"/>
+                </a:solidFill>
+                <a:latin typeface="Graphik TH" pitchFamily="34" charset="0"/>
+                <a:ea typeface="Graphik TH" pitchFamily="34" charset="-122"/>
+                <a:cs typeface="Graphik TH" pitchFamily="34" charset="-120"/>
+              </a:rPr>
+              <a:t>+3.9% across the base</a:t>
+            </a:r>
+            <a:endParaRPr lang="en-US" sz="950" dirty="0"/>
+          </a:p>
+        </p:txBody>
+      </p:sp>
+      <p:sp>
+        <p:nvSpPr>
+          <p:cNvPr id="10" name="Shape 8"/>
+          <p:cNvSpPr/>
+          <p:nvPr/>
+        </p:nvSpPr>
+        <p:spPr>
+          <a:xfrm>
+            <a:off x="3406140" y="1645920"/>
+            <a:ext cx="2647188" cy="987552"/>
+          </a:xfrm>
+          <a:prstGeom prst="roundRect">
+            <a:avLst>
+              <a:gd name="adj" fmla="val 8333"/>
+            </a:avLst>
+          </a:prstGeom>
+          <a:solidFill>
+            <a:srgbClr val="F1F4F9"/>
+          </a:solidFill>
+          <a:ln/>
+        </p:spPr>
+      </p:sp>
+      <p:sp>
+        <p:nvSpPr>
+          <p:cNvPr id="11" name="Text 9"/>
+          <p:cNvSpPr/>
+          <p:nvPr/>
+        </p:nvSpPr>
+        <p:spPr>
+          <a:xfrm>
+            <a:off x="3625596" y="1719072"/>
+            <a:ext cx="2208276" cy="402336"/>
+          </a:xfrm>
+          <a:prstGeom prst="rect">
+            <a:avLst/>
+          </a:prstGeom>
+          <a:noFill/>
+          <a:ln/>
+        </p:spPr>
+        <p:txBody>
+          <a:bodyPr wrap="square" lIns="0" tIns="0" rIns="0" bIns="0" rtlCol="0" anchor="ctr"/>
+          <a:lstStyle/>
+          <a:p>
+            <a:pPr indent="0" marL="0">
+              <a:buNone/>
+            </a:pPr>
+            <a:r>
+              <a:rPr lang="en-US" sz="2400" b="1" dirty="0">
+                <a:solidFill>
+                  <a:srgbClr val="00A896"/>
+                </a:solidFill>
+                <a:latin typeface="Graphik TH" pitchFamily="34" charset="0"/>
+                <a:ea typeface="Graphik TH" pitchFamily="34" charset="-122"/>
+                <a:cs typeface="Graphik TH" pitchFamily="34" charset="-120"/>
+              </a:rPr>
+              <a:t>+99.5m</a:t>
+            </a:r>
+            <a:endParaRPr lang="en-US" sz="2400" dirty="0"/>
+          </a:p>
+        </p:txBody>
+      </p:sp>
+      <p:sp>
+        <p:nvSpPr>
+          <p:cNvPr id="12" name="Text 10"/>
+          <p:cNvSpPr/>
+          <p:nvPr/>
+        </p:nvSpPr>
+        <p:spPr>
+          <a:xfrm>
+            <a:off x="3625596" y="2121408"/>
+            <a:ext cx="2208276" cy="237744"/>
+          </a:xfrm>
+          <a:prstGeom prst="rect">
+            <a:avLst/>
+          </a:prstGeom>
+          <a:noFill/>
+          <a:ln/>
+        </p:spPr>
+        <p:txBody>
+          <a:bodyPr wrap="square" lIns="0" tIns="0" rIns="0" bIns="0" rtlCol="0" anchor="t"/>
+          <a:lstStyle/>
+          <a:p>
+            <a:pPr indent="0" marL="0">
+              <a:buNone/>
+            </a:pPr>
+            <a:r>
+              <a:rPr lang="en-US" sz="1150" b="1" dirty="0">
+                <a:solidFill>
+                  <a:srgbClr val="16233D"/>
+                </a:solidFill>
+                <a:latin typeface="Graphik TH" pitchFamily="34" charset="0"/>
+                <a:ea typeface="Graphik TH" pitchFamily="34" charset="-122"/>
+                <a:cs typeface="Graphik TH" pitchFamily="34" charset="-120"/>
+              </a:rPr>
+              <a:t>High stickiness tier</a:t>
+            </a:r>
+            <a:endParaRPr lang="en-US" sz="1150" dirty="0"/>
+          </a:p>
+        </p:txBody>
+      </p:sp>
+      <p:sp>
+        <p:nvSpPr>
+          <p:cNvPr id="13" name="Text 11"/>
+          <p:cNvSpPr/>
+          <p:nvPr/>
+        </p:nvSpPr>
+        <p:spPr>
+          <a:xfrm>
+            <a:off x="3625596" y="2350008"/>
+            <a:ext cx="2208276" cy="237744"/>
+          </a:xfrm>
+          <a:prstGeom prst="rect">
+            <a:avLst/>
+          </a:prstGeom>
+          <a:noFill/>
+          <a:ln/>
+        </p:spPr>
+        <p:txBody>
+          <a:bodyPr wrap="square" lIns="0" tIns="0" rIns="0" bIns="0" rtlCol="0" anchor="t"/>
+          <a:lstStyle/>
+          <a:p>
+            <a:pPr indent="0" marL="0">
+              <a:buNone/>
+            </a:pPr>
+            <a:r>
+              <a:rPr lang="en-US" sz="950" dirty="0">
+                <a:solidFill>
+                  <a:srgbClr val="6B7A90"/>
+                </a:solidFill>
+                <a:latin typeface="Graphik TH" pitchFamily="34" charset="0"/>
+                <a:ea typeface="Graphik TH" pitchFamily="34" charset="-122"/>
+                <a:cs typeface="Graphik TH" pitchFamily="34" charset="-120"/>
+              </a:rPr>
+              <a:t>+3.8% · largest contributor</a:t>
+            </a:r>
+            <a:endParaRPr lang="en-US" sz="950" dirty="0"/>
+          </a:p>
+        </p:txBody>
+      </p:sp>
+      <p:sp>
+        <p:nvSpPr>
+          <p:cNvPr id="14" name="Shape 12"/>
+          <p:cNvSpPr/>
+          <p:nvPr/>
+        </p:nvSpPr>
+        <p:spPr>
+          <a:xfrm>
+            <a:off x="6281928" y="1645920"/>
+            <a:ext cx="2647188" cy="987552"/>
+          </a:xfrm>
+          <a:prstGeom prst="roundRect">
+            <a:avLst>
+              <a:gd name="adj" fmla="val 8333"/>
+            </a:avLst>
+          </a:prstGeom>
+          <a:solidFill>
+            <a:srgbClr val="F1F4F9"/>
+          </a:solidFill>
+          <a:ln/>
+        </p:spPr>
+      </p:sp>
+      <p:sp>
+        <p:nvSpPr>
+          <p:cNvPr id="15" name="Text 13"/>
+          <p:cNvSpPr/>
+          <p:nvPr/>
+        </p:nvSpPr>
+        <p:spPr>
+          <a:xfrm>
+            <a:off x="6501384" y="1719072"/>
+            <a:ext cx="2208276" cy="402336"/>
+          </a:xfrm>
+          <a:prstGeom prst="rect">
+            <a:avLst/>
+          </a:prstGeom>
+          <a:noFill/>
+          <a:ln/>
+        </p:spPr>
+        <p:txBody>
+          <a:bodyPr wrap="square" lIns="0" tIns="0" rIns="0" bIns="0" rtlCol="0" anchor="ctr"/>
+          <a:lstStyle/>
+          <a:p>
+            <a:pPr indent="0" marL="0">
+              <a:buNone/>
+            </a:pPr>
+            <a:r>
+              <a:rPr lang="en-US" sz="2000" b="1" dirty="0">
+                <a:solidFill>
+                  <a:srgbClr val="E9A03B"/>
+                </a:solidFill>
+                <a:latin typeface="Graphik TH" pitchFamily="34" charset="0"/>
+                <a:ea typeface="Graphik TH" pitchFamily="34" charset="-122"/>
+                <a:cs typeface="Graphik TH" pitchFamily="34" charset="-120"/>
+              </a:rPr>
+              <a:t>+143.6%</a:t>
+            </a:r>
+            <a:endParaRPr lang="en-US" sz="2000" dirty="0"/>
+          </a:p>
+        </p:txBody>
+      </p:sp>
+      <p:sp>
+        <p:nvSpPr>
+          <p:cNvPr id="16" name="Text 14"/>
+          <p:cNvSpPr/>
+          <p:nvPr/>
+        </p:nvSpPr>
+        <p:spPr>
+          <a:xfrm>
+            <a:off x="6501384" y="2121408"/>
+            <a:ext cx="2208276" cy="237744"/>
+          </a:xfrm>
+          <a:prstGeom prst="rect">
+            <a:avLst/>
+          </a:prstGeom>
+          <a:noFill/>
+          <a:ln/>
+        </p:spPr>
+        <p:txBody>
+          <a:bodyPr wrap="square" lIns="0" tIns="0" rIns="0" bIns="0" rtlCol="0" anchor="t"/>
+          <a:lstStyle/>
+          <a:p>
+            <a:pPr indent="0" marL="0">
+              <a:buNone/>
+            </a:pPr>
+            <a:r>
+              <a:rPr lang="en-US" sz="1150" b="1" dirty="0">
+                <a:solidFill>
+                  <a:srgbClr val="16233D"/>
+                </a:solidFill>
+                <a:latin typeface="Graphik TH" pitchFamily="34" charset="0"/>
+                <a:ea typeface="Graphik TH" pitchFamily="34" charset="-122"/>
+                <a:cs typeface="Graphik TH" pitchFamily="34" charset="-120"/>
+              </a:rPr>
+              <a:t>Very Low stickiness</a:t>
+            </a:r>
+            <a:endParaRPr lang="en-US" sz="1150" dirty="0"/>
+          </a:p>
+        </p:txBody>
+      </p:sp>
+      <p:sp>
+        <p:nvSpPr>
+          <p:cNvPr id="17" name="Text 15"/>
+          <p:cNvSpPr/>
+          <p:nvPr/>
+        </p:nvSpPr>
+        <p:spPr>
+          <a:xfrm>
+            <a:off x="6501384" y="2350008"/>
+            <a:ext cx="2208276" cy="237744"/>
+          </a:xfrm>
+          <a:prstGeom prst="rect">
+            <a:avLst/>
+          </a:prstGeom>
+          <a:noFill/>
+          <a:ln/>
+        </p:spPr>
+        <p:txBody>
+          <a:bodyPr wrap="square" lIns="0" tIns="0" rIns="0" bIns="0" rtlCol="0" anchor="t"/>
+          <a:lstStyle/>
+          <a:p>
+            <a:pPr indent="0" marL="0">
+              <a:buNone/>
+            </a:pPr>
+            <a:r>
+              <a:rPr lang="en-US" sz="950" dirty="0">
+                <a:solidFill>
+                  <a:srgbClr val="6B7A90"/>
+                </a:solidFill>
+                <a:latin typeface="Graphik TH" pitchFamily="34" charset="0"/>
+                <a:ea typeface="Graphik TH" pitchFamily="34" charset="-122"/>
+                <a:cs typeface="Graphik TH" pitchFamily="34" charset="-120"/>
+              </a:rPr>
+              <a:t>on a THB 5.35m prior balance</a:t>
+            </a:r>
+            <a:endParaRPr lang="en-US" sz="950" dirty="0"/>
+          </a:p>
+        </p:txBody>
+      </p:sp>
+      <p:sp>
+        <p:nvSpPr>
+          <p:cNvPr id="18" name="Shape 16"/>
+          <p:cNvSpPr/>
+          <p:nvPr/>
+        </p:nvSpPr>
+        <p:spPr>
+          <a:xfrm>
+            <a:off x="9157716" y="1645920"/>
+            <a:ext cx="2647188" cy="987552"/>
+          </a:xfrm>
+          <a:prstGeom prst="roundRect">
+            <a:avLst>
+              <a:gd name="adj" fmla="val 8333"/>
+            </a:avLst>
+          </a:prstGeom>
+          <a:solidFill>
+            <a:srgbClr val="F1F4F9"/>
+          </a:solidFill>
+          <a:ln/>
+        </p:spPr>
+      </p:sp>
+      <p:sp>
+        <p:nvSpPr>
+          <p:cNvPr id="19" name="Text 17"/>
+          <p:cNvSpPr/>
+          <p:nvPr/>
+        </p:nvSpPr>
+        <p:spPr>
+          <a:xfrm>
+            <a:off x="9377172" y="1719072"/>
+            <a:ext cx="2208276" cy="402336"/>
+          </a:xfrm>
+          <a:prstGeom prst="rect">
+            <a:avLst/>
+          </a:prstGeom>
+          <a:noFill/>
+          <a:ln/>
+        </p:spPr>
+        <p:txBody>
+          <a:bodyPr wrap="square" lIns="0" tIns="0" rIns="0" bIns="0" rtlCol="0" anchor="ctr"/>
+          <a:lstStyle/>
+          <a:p>
+            <a:pPr indent="0" marL="0">
+              <a:buNone/>
+            </a:pPr>
+            <a:r>
+              <a:rPr lang="en-US" sz="2400" b="1" dirty="0">
+                <a:solidFill>
+                  <a:srgbClr val="00A896"/>
+                </a:solidFill>
+                <a:latin typeface="Graphik TH" pitchFamily="34" charset="0"/>
+                <a:ea typeface="Graphik TH" pitchFamily="34" charset="-122"/>
+                <a:cs typeface="Graphik TH" pitchFamily="34" charset="-120"/>
+              </a:rPr>
+              <a:t>79.2%</a:t>
+            </a:r>
+            <a:endParaRPr lang="en-US" sz="2400" dirty="0"/>
+          </a:p>
+        </p:txBody>
+      </p:sp>
+      <p:sp>
+        <p:nvSpPr>
+          <p:cNvPr id="20" name="Text 18"/>
+          <p:cNvSpPr/>
+          <p:nvPr/>
+        </p:nvSpPr>
+        <p:spPr>
+          <a:xfrm>
+            <a:off x="9377172" y="2121408"/>
+            <a:ext cx="2208276" cy="237744"/>
+          </a:xfrm>
+          <a:prstGeom prst="rect">
+            <a:avLst/>
+          </a:prstGeom>
+          <a:noFill/>
+          <a:ln/>
+        </p:spPr>
+        <p:txBody>
+          <a:bodyPr wrap="square" lIns="0" tIns="0" rIns="0" bIns="0" rtlCol="0" anchor="t"/>
+          <a:lstStyle/>
+          <a:p>
+            <a:pPr indent="0" marL="0">
+              <a:buNone/>
+            </a:pPr>
+            <a:r>
+              <a:rPr lang="en-US" sz="1150" b="1" dirty="0">
+                <a:solidFill>
+                  <a:srgbClr val="16233D"/>
+                </a:solidFill>
+                <a:latin typeface="Graphik TH" pitchFamily="34" charset="0"/>
+                <a:ea typeface="Graphik TH" pitchFamily="34" charset="-122"/>
+                <a:cs typeface="Graphik TH" pitchFamily="34" charset="-120"/>
+              </a:rPr>
+              <a:t>of the gain</a:t>
+            </a:r>
+            <a:endParaRPr lang="en-US" sz="1150" dirty="0"/>
+          </a:p>
+        </p:txBody>
+      </p:sp>
+      <p:sp>
+        <p:nvSpPr>
+          <p:cNvPr id="21" name="Text 19"/>
+          <p:cNvSpPr/>
+          <p:nvPr/>
+        </p:nvSpPr>
+        <p:spPr>
+          <a:xfrm>
+            <a:off x="9377172" y="2350008"/>
+            <a:ext cx="2208276" cy="237744"/>
+          </a:xfrm>
+          <a:prstGeom prst="rect">
+            <a:avLst/>
+          </a:prstGeom>
+          <a:noFill/>
+          <a:ln/>
+        </p:spPr>
+        <p:txBody>
+          <a:bodyPr wrap="square" lIns="0" tIns="0" rIns="0" bIns="0" rtlCol="0" anchor="t"/>
+          <a:lstStyle/>
+          <a:p>
+            <a:pPr indent="0" marL="0">
+              <a:buNone/>
+            </a:pPr>
+            <a:r>
+              <a:rPr lang="en-US" sz="950" dirty="0">
+                <a:solidFill>
+                  <a:srgbClr val="6B7A90"/>
+                </a:solidFill>
+                <a:latin typeface="Graphik TH" pitchFamily="34" charset="0"/>
+                <a:ea typeface="Graphik TH" pitchFamily="34" charset="-122"/>
+                <a:cs typeface="Graphik TH" pitchFamily="34" charset="-120"/>
+              </a:rPr>
+              <a:t>came from stickiness ≥ 60</a:t>
+            </a:r>
+            <a:endParaRPr lang="en-US" sz="950" dirty="0"/>
+          </a:p>
+        </p:txBody>
+      </p:sp>
+      <p:sp>
+        <p:nvSpPr>
+          <p:cNvPr id="22" name="Shape 20"/>
+          <p:cNvSpPr/>
+          <p:nvPr/>
+        </p:nvSpPr>
+        <p:spPr>
+          <a:xfrm>
+            <a:off x="530352" y="2798064"/>
+            <a:ext cx="6720840" cy="2322576"/>
+          </a:xfrm>
+          <a:prstGeom prst="roundRect">
+            <a:avLst>
+              <a:gd name="adj" fmla="val 3543"/>
+            </a:avLst>
+          </a:prstGeom>
+          <a:solidFill>
+            <a:srgbClr val="F1F4F9"/>
+          </a:solidFill>
+          <a:ln/>
+        </p:spPr>
+      </p:sp>
+      <p:sp>
+        <p:nvSpPr>
+          <p:cNvPr id="23" name="Text 21"/>
+          <p:cNvSpPr/>
+          <p:nvPr/>
+        </p:nvSpPr>
+        <p:spPr>
+          <a:xfrm>
+            <a:off x="786384" y="2944368"/>
+            <a:ext cx="6208776" cy="274320"/>
+          </a:xfrm>
+          <a:prstGeom prst="rect">
+            <a:avLst/>
+          </a:prstGeom>
+          <a:noFill/>
+          <a:ln/>
+        </p:spPr>
+        <p:txBody>
+          <a:bodyPr wrap="square" lIns="0" tIns="0" rIns="0" bIns="0" rtlCol="0" anchor="ctr"/>
+          <a:lstStyle/>
+          <a:p>
+            <a:pPr indent="0" marL="0">
+              <a:buNone/>
+            </a:pPr>
+            <a:r>
+              <a:rPr lang="en-US" sz="1400" b="1" dirty="0">
+                <a:solidFill>
+                  <a:srgbClr val="16233D"/>
+                </a:solidFill>
+                <a:latin typeface="Cambria" pitchFamily="34" charset="0"/>
+                <a:ea typeface="Cambria" pitchFamily="34" charset="-122"/>
+                <a:cs typeface="Cambria" pitchFamily="34" charset="-120"/>
+              </a:rPr>
+              <a:t>Total deposit balance by stickiness tier</a:t>
+            </a:r>
+            <a:endParaRPr lang="en-US" sz="1400" dirty="0"/>
+          </a:p>
+        </p:txBody>
+      </p:sp>
+      <p:sp>
+        <p:nvSpPr>
+          <p:cNvPr id="24" name="Text 22"/>
+          <p:cNvSpPr/>
+          <p:nvPr/>
+        </p:nvSpPr>
+        <p:spPr>
+          <a:xfrm>
+            <a:off x="786384" y="3218688"/>
+            <a:ext cx="6208776" cy="237744"/>
+          </a:xfrm>
+          <a:prstGeom prst="rect">
+            <a:avLst/>
+          </a:prstGeom>
+          <a:noFill/>
+          <a:ln/>
+        </p:spPr>
+        <p:txBody>
+          <a:bodyPr wrap="square" lIns="0" tIns="0" rIns="0" bIns="0" rtlCol="0" anchor="ctr"/>
+          <a:lstStyle/>
+          <a:p>
+            <a:pPr indent="0" marL="0">
+              <a:buNone/>
+            </a:pPr>
+            <a:r>
+              <a:rPr lang="en-US" sz="950" dirty="0">
+                <a:solidFill>
+                  <a:srgbClr val="6B7A90"/>
+                </a:solidFill>
+                <a:latin typeface="Graphik TH" pitchFamily="34" charset="0"/>
+                <a:ea typeface="Graphik TH" pitchFamily="34" charset="-122"/>
+                <a:cs typeface="Graphik TH" pitchFamily="34" charset="-120"/>
+              </a:rPr>
+              <a:t>THB m · absolute change and percentage change for every tier</a:t>
+            </a:r>
+            <a:endParaRPr lang="en-US" sz="950" dirty="0"/>
+          </a:p>
+        </p:txBody>
+      </p:sp>
+      <p:graphicFrame>
+        <p:nvGraphicFramePr>
+          <p:cNvPr id="15" name="Table 0"/>
+          <p:cNvGraphicFramePr>
+            <a:graphicFrameLocks noGrp="1"/>
+          </p:cNvGraphicFramePr>
+          <p:nvPr>
+            <p:extLst>
+              <p:ext uri="{D42A27DB-BD31-4B8C-83A1-F6EECF244321}">
+                <p14:modId xmlns:p14="http://schemas.microsoft.com/office/powerpoint/2010/main" val="1579011935"/>
+              </p:ext>
+            </p:extLst>
+          </p:nvPr>
+        </p:nvGraphicFramePr>
+        <p:xfrm>
+          <a:off x="749808" y="3474720"/>
+          <a:ext cx="6281928" cy="914400"/>
+        </p:xfrm>
+        <a:graphic>
+          <a:graphicData uri="http://schemas.openxmlformats.org/drawingml/2006/table">
+            <a:tbl>
+              <a:tblPr/>
+              <a:tblGrid>
+                <a:gridCol w="1115568"/>
+                <a:gridCol w="969264"/>
+                <a:gridCol w="1024128"/>
+                <a:gridCol w="1024128"/>
+                <a:gridCol w="1024128"/>
+                <a:gridCol w="1124712"/>
+              </a:tblGrid>
+              <a:tr h="228600">
+                <a:tc>
+                  <a:txBody>
+                    <a:bodyPr/>
+                    <a:lstStyle/>
+                    <a:p>
+                      <a:pPr algn="l" indent="0" marL="0">
+                        <a:buNone/>
+                      </a:pPr>
+                      <a:r>
+                        <a:rPr lang="en-US" sz="850" b="1" dirty="0">
+                          <a:solidFill>
+                            <a:srgbClr val="FFFFFF"/>
+                          </a:solidFill>
+                          <a:latin typeface="Graphik TH" pitchFamily="34" charset="0"/>
+                          <a:ea typeface="Graphik TH" pitchFamily="34" charset="-122"/>
+                          <a:cs typeface="Graphik TH" pitchFamily="34" charset="-120"/>
+                        </a:rPr>
+                        <a:t>Stickiness</a:t>
+                      </a:r>
+                      <a:endParaRPr lang="en-US" sz="850" dirty="0">
+                        <a:latin typeface="Graphik TH" charset="0"/>
+                        <a:ea typeface="Graphik TH" charset="0"/>
+                        <a:cs typeface="Graphik TH" charset="0"/>
+                      </a:endParaRPr>
+                    </a:p>
+                  </a:txBody>
+                  <a:tcPr marL="54864" marR="54864" marT="9144" marB="9144" anchor="ctr">
+                    <a:lnL w="6350" cap="flat" cmpd="sng" algn="ctr">
+                      <a:solidFill>
+                        <a:srgbClr val="D8DFE9"/>
+                      </a:solidFill>
+                      <a:prstDash val="solid"/>
+                      <a:round/>
+                      <a:headEnd type="none" w="med" len="med"/>
+                      <a:tailEnd type="none" w="med" len="med"/>
+                    </a:lnL>
+                    <a:lnR w="6350" cap="flat" cmpd="sng" algn="ctr">
+                      <a:solidFill>
+                        <a:srgbClr val="D8DFE9"/>
+                      </a:solidFill>
+                      <a:prstDash val="solid"/>
+                      <a:round/>
+                      <a:headEnd type="none" w="med" len="med"/>
+                      <a:tailEnd type="none" w="med" len="med"/>
+                    </a:lnR>
+                    <a:lnT w="6350" cap="flat" cmpd="sng" algn="ctr">
+                      <a:solidFill>
+                        <a:srgbClr val="D8DFE9"/>
+                      </a:solidFill>
+                      <a:prstDash val="solid"/>
+                      <a:round/>
+                      <a:headEnd type="none" w="med" len="med"/>
+                      <a:tailEnd type="none" w="med" len="med"/>
+                    </a:lnT>
+                    <a:lnB w="6350" cap="flat" cmpd="sng" algn="ctr">
+                      <a:solidFill>
+                        <a:srgbClr val="D8DFE9"/>
+                      </a:solidFill>
+                      <a:prstDash val="solid"/>
+                      <a:round/>
+                      <a:headEnd type="none" w="med" len="med"/>
+                      <a:tailEnd type="none" w="med" len="med"/>
+                    </a:lnB>
+                    <a:solidFill>
+                      <a:srgbClr val="045D66"/>
+                    </a:solidFill>
+                  </a:tcPr>
+                </a:tc>
+                <a:tc>
+                  <a:txBody>
+                    <a:bodyPr/>
+                    <a:lstStyle/>
+                    <a:p>
+                      <a:pPr algn="r" indent="0" marL="0">
+                        <a:buNone/>
+                      </a:pPr>
+                      <a:r>
+                        <a:rPr lang="en-US" sz="850" b="1" dirty="0">
+                          <a:solidFill>
+                            <a:srgbClr val="FFFFFF"/>
+                          </a:solidFill>
+                          <a:latin typeface="Graphik TH" pitchFamily="34" charset="0"/>
+                          <a:ea typeface="Graphik TH" pitchFamily="34" charset="-122"/>
+                          <a:cs typeface="Graphik TH" pitchFamily="34" charset="-120"/>
+                        </a:rPr>
+                        <a:t>Customers</a:t>
+                      </a:r>
+                      <a:endParaRPr lang="en-US" sz="850" dirty="0">
+                        <a:latin typeface="Graphik TH" charset="0"/>
+                        <a:ea typeface="Graphik TH" charset="0"/>
+                        <a:cs typeface="Graphik TH" charset="0"/>
+                      </a:endParaRPr>
+                    </a:p>
+                  </a:txBody>
+                  <a:tcPr marL="54864" marR="54864" marT="9144" marB="9144" anchor="ctr">
+                    <a:lnL w="6350" cap="flat" cmpd="sng" algn="ctr">
+                      <a:solidFill>
+                        <a:srgbClr val="D8DFE9"/>
+                      </a:solidFill>
+                      <a:prstDash val="solid"/>
+                      <a:round/>
+                      <a:headEnd type="none" w="med" len="med"/>
+                      <a:tailEnd type="none" w="med" len="med"/>
+                    </a:lnL>
+                    <a:lnR w="6350" cap="flat" cmpd="sng" algn="ctr">
+                      <a:solidFill>
+                        <a:srgbClr val="D8DFE9"/>
+                      </a:solidFill>
+                      <a:prstDash val="solid"/>
+                      <a:round/>
+                      <a:headEnd type="none" w="med" len="med"/>
+                      <a:tailEnd type="none" w="med" len="med"/>
+                    </a:lnR>
+                    <a:lnT w="6350" cap="flat" cmpd="sng" algn="ctr">
+                      <a:solidFill>
+                        <a:srgbClr val="D8DFE9"/>
+                      </a:solidFill>
+                      <a:prstDash val="solid"/>
+                      <a:round/>
+                      <a:headEnd type="none" w="med" len="med"/>
+                      <a:tailEnd type="none" w="med" len="med"/>
+                    </a:lnT>
+                    <a:lnB w="6350" cap="flat" cmpd="sng" algn="ctr">
+                      <a:solidFill>
+                        <a:srgbClr val="D8DFE9"/>
+                      </a:solidFill>
+                      <a:prstDash val="solid"/>
+                      <a:round/>
+                      <a:headEnd type="none" w="med" len="med"/>
+                      <a:tailEnd type="none" w="med" len="med"/>
+                    </a:lnB>
+                    <a:solidFill>
+                      <a:srgbClr val="045D66"/>
+                    </a:solidFill>
+                  </a:tcPr>
+                </a:tc>
+                <a:tc>
+                  <a:txBody>
+                    <a:bodyPr/>
+                    <a:lstStyle/>
+                    <a:p>
+                      <a:pPr algn="r" indent="0" marL="0">
+                        <a:buNone/>
+                      </a:pPr>
+                      <a:r>
+                        <a:rPr lang="en-US" sz="850" b="1" dirty="0">
+                          <a:solidFill>
+                            <a:srgbClr val="FFFFFF"/>
+                          </a:solidFill>
+                          <a:latin typeface="Graphik TH" pitchFamily="34" charset="0"/>
+                          <a:ea typeface="Graphik TH" pitchFamily="34" charset="-122"/>
+                          <a:cs typeface="Graphik TH" pitchFamily="34" charset="-120"/>
+                        </a:rPr>
+                        <a:t>Prior</a:t>
+                      </a:r>
+                      <a:endParaRPr lang="en-US" sz="850" dirty="0">
+                        <a:latin typeface="Graphik TH" charset="0"/>
+                        <a:ea typeface="Graphik TH" charset="0"/>
+                        <a:cs typeface="Graphik TH" charset="0"/>
+                      </a:endParaRPr>
+                    </a:p>
+                  </a:txBody>
+                  <a:tcPr marL="54864" marR="54864" marT="9144" marB="9144" anchor="ctr">
+                    <a:lnL w="6350" cap="flat" cmpd="sng" algn="ctr">
+                      <a:solidFill>
+                        <a:srgbClr val="D8DFE9"/>
+                      </a:solidFill>
+                      <a:prstDash val="solid"/>
+                      <a:round/>
+                      <a:headEnd type="none" w="med" len="med"/>
+                      <a:tailEnd type="none" w="med" len="med"/>
+                    </a:lnL>
+                    <a:lnR w="6350" cap="flat" cmpd="sng" algn="ctr">
+                      <a:solidFill>
+                        <a:srgbClr val="D8DFE9"/>
+                      </a:solidFill>
+                      <a:prstDash val="solid"/>
+                      <a:round/>
+                      <a:headEnd type="none" w="med" len="med"/>
+                      <a:tailEnd type="none" w="med" len="med"/>
+                    </a:lnR>
+                    <a:lnT w="6350" cap="flat" cmpd="sng" algn="ctr">
+                      <a:solidFill>
+                        <a:srgbClr val="D8DFE9"/>
+                      </a:solidFill>
+                      <a:prstDash val="solid"/>
+                      <a:round/>
+                      <a:headEnd type="none" w="med" len="med"/>
+                      <a:tailEnd type="none" w="med" len="med"/>
+                    </a:lnT>
+                    <a:lnB w="6350" cap="flat" cmpd="sng" algn="ctr">
+                      <a:solidFill>
+                        <a:srgbClr val="D8DFE9"/>
+                      </a:solidFill>
+                      <a:prstDash val="solid"/>
+                      <a:round/>
+                      <a:headEnd type="none" w="med" len="med"/>
+                      <a:tailEnd type="none" w="med" len="med"/>
+                    </a:lnB>
+                    <a:solidFill>
+                      <a:srgbClr val="045D66"/>
+                    </a:solidFill>
+                  </a:tcPr>
+                </a:tc>
+                <a:tc>
+                  <a:txBody>
+                    <a:bodyPr/>
+                    <a:lstStyle/>
+                    <a:p>
+                      <a:pPr algn="r" indent="0" marL="0">
+                        <a:buNone/>
+                      </a:pPr>
+                      <a:r>
+                        <a:rPr lang="en-US" sz="850" b="1" dirty="0">
+                          <a:solidFill>
+                            <a:srgbClr val="FFFFFF"/>
+                          </a:solidFill>
+                          <a:latin typeface="Graphik TH" pitchFamily="34" charset="0"/>
+                          <a:ea typeface="Graphik TH" pitchFamily="34" charset="-122"/>
+                          <a:cs typeface="Graphik TH" pitchFamily="34" charset="-120"/>
+                        </a:rPr>
+                        <a:t>Latest</a:t>
+                      </a:r>
+                      <a:endParaRPr lang="en-US" sz="850" dirty="0">
+                        <a:latin typeface="Graphik TH" charset="0"/>
+                        <a:ea typeface="Graphik TH" charset="0"/>
+                        <a:cs typeface="Graphik TH" charset="0"/>
+                      </a:endParaRPr>
+                    </a:p>
+                  </a:txBody>
+                  <a:tcPr marL="54864" marR="54864" marT="9144" marB="9144" anchor="ctr">
+                    <a:lnL w="6350" cap="flat" cmpd="sng" algn="ctr">
+                      <a:solidFill>
+                        <a:srgbClr val="D8DFE9"/>
+                      </a:solidFill>
+                      <a:prstDash val="solid"/>
+                      <a:round/>
+                      <a:headEnd type="none" w="med" len="med"/>
+                      <a:tailEnd type="none" w="med" len="med"/>
+                    </a:lnL>
+                    <a:lnR w="6350" cap="flat" cmpd="sng" algn="ctr">
+                      <a:solidFill>
+                        <a:srgbClr val="D8DFE9"/>
+                      </a:solidFill>
+                      <a:prstDash val="solid"/>
+                      <a:round/>
+                      <a:headEnd type="none" w="med" len="med"/>
+                      <a:tailEnd type="none" w="med" len="med"/>
+                    </a:lnR>
+                    <a:lnT w="6350" cap="flat" cmpd="sng" algn="ctr">
+                      <a:solidFill>
+                        <a:srgbClr val="D8DFE9"/>
+                      </a:solidFill>
+                      <a:prstDash val="solid"/>
+                      <a:round/>
+                      <a:headEnd type="none" w="med" len="med"/>
+                      <a:tailEnd type="none" w="med" len="med"/>
+                    </a:lnT>
+                    <a:lnB w="6350" cap="flat" cmpd="sng" algn="ctr">
+                      <a:solidFill>
+                        <a:srgbClr val="D8DFE9"/>
+                      </a:solidFill>
+                      <a:prstDash val="solid"/>
+                      <a:round/>
+                      <a:headEnd type="none" w="med" len="med"/>
+                      <a:tailEnd type="none" w="med" len="med"/>
+                    </a:lnB>
+                    <a:solidFill>
+                      <a:srgbClr val="045D66"/>
+                    </a:solidFill>
+                  </a:tcPr>
+                </a:tc>
+                <a:tc>
+                  <a:txBody>
+                    <a:bodyPr/>
+                    <a:lstStyle/>
+                    <a:p>
+                      <a:pPr algn="r" indent="0" marL="0">
+                        <a:buNone/>
+                      </a:pPr>
+                      <a:r>
+                        <a:rPr lang="en-US" sz="850" b="1" dirty="0">
+                          <a:solidFill>
+                            <a:srgbClr val="FFFFFF"/>
+                          </a:solidFill>
+                          <a:latin typeface="Graphik TH" pitchFamily="34" charset="0"/>
+                          <a:ea typeface="Graphik TH" pitchFamily="34" charset="-122"/>
+                          <a:cs typeface="Graphik TH" pitchFamily="34" charset="-120"/>
+                        </a:rPr>
+                        <a:t>Change</a:t>
+                      </a:r>
+                      <a:endParaRPr lang="en-US" sz="850" dirty="0">
+                        <a:latin typeface="Graphik TH" charset="0"/>
+                        <a:ea typeface="Graphik TH" charset="0"/>
+                        <a:cs typeface="Graphik TH" charset="0"/>
+                      </a:endParaRPr>
+                    </a:p>
+                  </a:txBody>
+                  <a:tcPr marL="54864" marR="54864" marT="9144" marB="9144" anchor="ctr">
+                    <a:lnL w="6350" cap="flat" cmpd="sng" algn="ctr">
+                      <a:solidFill>
+                        <a:srgbClr val="D8DFE9"/>
+                      </a:solidFill>
+                      <a:prstDash val="solid"/>
+                      <a:round/>
+                      <a:headEnd type="none" w="med" len="med"/>
+                      <a:tailEnd type="none" w="med" len="med"/>
+                    </a:lnL>
+                    <a:lnR w="6350" cap="flat" cmpd="sng" algn="ctr">
+                      <a:solidFill>
+                        <a:srgbClr val="D8DFE9"/>
+                      </a:solidFill>
+                      <a:prstDash val="solid"/>
+                      <a:round/>
+                      <a:headEnd type="none" w="med" len="med"/>
+                      <a:tailEnd type="none" w="med" len="med"/>
+                    </a:lnR>
+                    <a:lnT w="6350" cap="flat" cmpd="sng" algn="ctr">
+                      <a:solidFill>
+                        <a:srgbClr val="D8DFE9"/>
+                      </a:solidFill>
+                      <a:prstDash val="solid"/>
+                      <a:round/>
+                      <a:headEnd type="none" w="med" len="med"/>
+                      <a:tailEnd type="none" w="med" len="med"/>
+                    </a:lnT>
+                    <a:lnB w="6350" cap="flat" cmpd="sng" algn="ctr">
+                      <a:solidFill>
+                        <a:srgbClr val="D8DFE9"/>
+                      </a:solidFill>
+                      <a:prstDash val="solid"/>
+                      <a:round/>
+                      <a:headEnd type="none" w="med" len="med"/>
+                      <a:tailEnd type="none" w="med" len="med"/>
+                    </a:lnB>
+                    <a:solidFill>
+                      <a:srgbClr val="045D66"/>
+                    </a:solidFill>
+                  </a:tcPr>
+                </a:tc>
+                <a:tc>
+                  <a:txBody>
+                    <a:bodyPr/>
+                    <a:lstStyle/>
+                    <a:p>
+                      <a:pPr algn="r" indent="0" marL="0">
+                        <a:buNone/>
+                      </a:pPr>
+                      <a:r>
+                        <a:rPr lang="en-US" sz="850" b="1" dirty="0">
+                          <a:solidFill>
+                            <a:srgbClr val="FFFFFF"/>
+                          </a:solidFill>
+                          <a:latin typeface="Graphik TH" pitchFamily="34" charset="0"/>
+                          <a:ea typeface="Graphik TH" pitchFamily="34" charset="-122"/>
+                          <a:cs typeface="Graphik TH" pitchFamily="34" charset="-120"/>
+                        </a:rPr>
+                        <a:t>Change %</a:t>
+                      </a:r>
+                      <a:endParaRPr lang="en-US" sz="850" dirty="0">
+                        <a:latin typeface="Graphik TH" charset="0"/>
+                        <a:ea typeface="Graphik TH" charset="0"/>
+                        <a:cs typeface="Graphik TH" charset="0"/>
+                      </a:endParaRPr>
+                    </a:p>
+                  </a:txBody>
+                  <a:tcPr marL="54864" marR="54864" marT="9144" marB="9144" anchor="ctr">
+                    <a:lnL w="6350" cap="flat" cmpd="sng" algn="ctr">
+                      <a:solidFill>
+                        <a:srgbClr val="D8DFE9"/>
+                      </a:solidFill>
+                      <a:prstDash val="solid"/>
+                      <a:round/>
+                      <a:headEnd type="none" w="med" len="med"/>
+                      <a:tailEnd type="none" w="med" len="med"/>
+                    </a:lnL>
+                    <a:lnR w="6350" cap="flat" cmpd="sng" algn="ctr">
+                      <a:solidFill>
+                        <a:srgbClr val="D8DFE9"/>
+                      </a:solidFill>
+                      <a:prstDash val="solid"/>
+                      <a:round/>
+                      <a:headEnd type="none" w="med" len="med"/>
+                      <a:tailEnd type="none" w="med" len="med"/>
+                    </a:lnR>
+                    <a:lnT w="6350" cap="flat" cmpd="sng" algn="ctr">
+                      <a:solidFill>
+                        <a:srgbClr val="D8DFE9"/>
+                      </a:solidFill>
+                      <a:prstDash val="solid"/>
+                      <a:round/>
+                      <a:headEnd type="none" w="med" len="med"/>
+                      <a:tailEnd type="none" w="med" len="med"/>
+                    </a:lnT>
+                    <a:lnB w="6350" cap="flat" cmpd="sng" algn="ctr">
+                      <a:solidFill>
+                        <a:srgbClr val="D8DFE9"/>
+                      </a:solidFill>
+                      <a:prstDash val="solid"/>
+                      <a:round/>
+                      <a:headEnd type="none" w="med" len="med"/>
+                      <a:tailEnd type="none" w="med" len="med"/>
+                    </a:lnB>
+                    <a:solidFill>
+                      <a:srgbClr val="045D66"/>
+                    </a:solidFill>
+                  </a:tcPr>
+                </a:tc>
+              </a:tr>
+              <a:tr h="228600">
+                <a:tc>
+                  <a:txBody>
+                    <a:bodyPr/>
+                    <a:lstStyle/>
+                    <a:p>
+                      <a:pPr algn="l" indent="0" marL="0">
+                        <a:buNone/>
+                      </a:pPr>
+                      <a:r>
+                        <a:rPr lang="en-US" sz="900" b="1" dirty="0">
+                          <a:solidFill>
+                            <a:srgbClr val="16233D"/>
+                          </a:solidFill>
+                          <a:latin typeface="Graphik TH" pitchFamily="34" charset="0"/>
+                          <a:ea typeface="Graphik TH" pitchFamily="34" charset="-122"/>
+                          <a:cs typeface="Graphik TH" pitchFamily="34" charset="-120"/>
+                        </a:rPr>
+                        <a:t>Very High</a:t>
+                      </a:r>
+                      <a:endParaRPr lang="en-US" sz="900" dirty="0">
+                        <a:latin typeface="Graphik TH" charset="0"/>
+                        <a:ea typeface="Graphik TH" charset="0"/>
+                        <a:cs typeface="Graphik TH" charset="0"/>
+                      </a:endParaRPr>
+                    </a:p>
+                  </a:txBody>
+                  <a:tcPr marL="54864" marR="54864" marT="9144" marB="9144" anchor="ctr">
+                    <a:lnL w="6350" cap="flat" cmpd="sng" algn="ctr">
+                      <a:solidFill>
+                        <a:srgbClr val="D8DFE9"/>
+                      </a:solidFill>
+                      <a:prstDash val="solid"/>
+                      <a:round/>
+                      <a:headEnd type="none" w="med" len="med"/>
+                      <a:tailEnd type="none" w="med" len="med"/>
+                    </a:lnL>
+                    <a:lnR w="6350" cap="flat" cmpd="sng" algn="ctr">
+                      <a:solidFill>
+                        <a:srgbClr val="D8DFE9"/>
+                      </a:solidFill>
+                      <a:prstDash val="solid"/>
+                      <a:round/>
+                      <a:headEnd type="none" w="med" len="med"/>
+                      <a:tailEnd type="none" w="med" len="med"/>
+                    </a:lnR>
+                    <a:lnT w="6350" cap="flat" cmpd="sng" algn="ctr">
+                      <a:solidFill>
+                        <a:srgbClr val="D8DFE9"/>
+                      </a:solidFill>
+                      <a:prstDash val="solid"/>
+                      <a:round/>
+                      <a:headEnd type="none" w="med" len="med"/>
+                      <a:tailEnd type="none" w="med" len="med"/>
+                    </a:lnT>
+                    <a:lnB w="6350" cap="flat" cmpd="sng" algn="ctr">
+                      <a:solidFill>
+                        <a:srgbClr val="D8DFE9"/>
+                      </a:solidFill>
+                      <a:prstDash val="solid"/>
+                      <a:round/>
+                      <a:headEnd type="none" w="med" len="med"/>
+                      <a:tailEnd type="none" w="med" len="med"/>
+                    </a:lnB>
+                    <a:solidFill>
+                      <a:srgbClr val="F1F4F9"/>
+                    </a:solidFill>
+                  </a:tcPr>
+                </a:tc>
+                <a:tc>
+                  <a:txBody>
+                    <a:bodyPr/>
+                    <a:lstStyle/>
+                    <a:p>
+                      <a:pPr algn="r" indent="0" marL="0">
+                        <a:buNone/>
+                      </a:pPr>
+                      <a:r>
+                        <a:rPr lang="en-US" sz="900" dirty="0">
+                          <a:solidFill>
+                            <a:srgbClr val="16233D"/>
+                          </a:solidFill>
+                          <a:latin typeface="Graphik TH" pitchFamily="34" charset="0"/>
+                          <a:ea typeface="Graphik TH" pitchFamily="34" charset="-122"/>
+                          <a:cs typeface="Graphik TH" pitchFamily="34" charset="-120"/>
+                        </a:rPr>
+                        <a:t>53,783</a:t>
+                      </a:r>
+                      <a:endParaRPr lang="en-US" sz="900" dirty="0">
+                        <a:latin typeface="Graphik TH" charset="0"/>
+                        <a:ea typeface="Graphik TH" charset="0"/>
+                        <a:cs typeface="Graphik TH" charset="0"/>
+                      </a:endParaRPr>
+                    </a:p>
+                  </a:txBody>
+                  <a:tcPr marL="54864" marR="54864" marT="9144" marB="9144" anchor="ctr">
+                    <a:lnL w="6350" cap="flat" cmpd="sng" algn="ctr">
+                      <a:solidFill>
+                        <a:srgbClr val="D8DFE9"/>
+                      </a:solidFill>
+                      <a:prstDash val="solid"/>
+                      <a:round/>
+                      <a:headEnd type="none" w="med" len="med"/>
+                      <a:tailEnd type="none" w="med" len="med"/>
+                    </a:lnL>
+                    <a:lnR w="6350" cap="flat" cmpd="sng" algn="ctr">
+                      <a:solidFill>
+                        <a:srgbClr val="D8DFE9"/>
+                      </a:solidFill>
+                      <a:prstDash val="solid"/>
+                      <a:round/>
+                      <a:headEnd type="none" w="med" len="med"/>
+                      <a:tailEnd type="none" w="med" len="med"/>
+                    </a:lnR>
+                    <a:lnT w="6350" cap="flat" cmpd="sng" algn="ctr">
+                      <a:solidFill>
+                        <a:srgbClr val="D8DFE9"/>
+                      </a:solidFill>
+                      <a:prstDash val="solid"/>
+                      <a:round/>
+                      <a:headEnd type="none" w="med" len="med"/>
+                      <a:tailEnd type="none" w="med" len="med"/>
+                    </a:lnT>
+                    <a:lnB w="6350" cap="flat" cmpd="sng" algn="ctr">
+                      <a:solidFill>
+                        <a:srgbClr val="D8DFE9"/>
+                      </a:solidFill>
+                      <a:prstDash val="solid"/>
+                      <a:round/>
+                      <a:headEnd type="none" w="med" len="med"/>
+                      <a:tailEnd type="none" w="med" len="med"/>
+                    </a:lnB>
+                    <a:solidFill>
+                      <a:srgbClr val="FFFFFF"/>
+                    </a:solidFill>
+                  </a:tcPr>
+                </a:tc>
+                <a:tc>
+                  <a:txBody>
+                    <a:bodyPr/>
+                    <a:lstStyle/>
+                    <a:p>
+                      <a:pPr algn="r" indent="0" marL="0">
+                        <a:buNone/>
+                      </a:pPr>
+                      <a:r>
+                        <a:rPr lang="en-US" sz="900" dirty="0">
+                          <a:solidFill>
+                            <a:srgbClr val="16233D"/>
+                          </a:solidFill>
+                          <a:latin typeface="Graphik TH" pitchFamily="34" charset="0"/>
+                          <a:ea typeface="Graphik TH" pitchFamily="34" charset="-122"/>
+                          <a:cs typeface="Graphik TH" pitchFamily="34" charset="-120"/>
+                        </a:rPr>
+                        <a:t>2663.8</a:t>
+                      </a:r>
+                      <a:endParaRPr lang="en-US" sz="900" dirty="0">
+                        <a:latin typeface="Graphik TH" charset="0"/>
+                        <a:ea typeface="Graphik TH" charset="0"/>
+                        <a:cs typeface="Graphik TH" charset="0"/>
+                      </a:endParaRPr>
+                    </a:p>
+                  </a:txBody>
+                  <a:tcPr marL="54864" marR="54864" marT="9144" marB="9144" anchor="ctr">
+                    <a:lnL w="6350" cap="flat" cmpd="sng" algn="ctr">
+                      <a:solidFill>
+                        <a:srgbClr val="D8DFE9"/>
+                      </a:solidFill>
+                      <a:prstDash val="solid"/>
+                      <a:round/>
+                      <a:headEnd type="none" w="med" len="med"/>
+                      <a:tailEnd type="none" w="med" len="med"/>
+                    </a:lnL>
+                    <a:lnR w="6350" cap="flat" cmpd="sng" algn="ctr">
+                      <a:solidFill>
+                        <a:srgbClr val="D8DFE9"/>
+                      </a:solidFill>
+                      <a:prstDash val="solid"/>
+                      <a:round/>
+                      <a:headEnd type="none" w="med" len="med"/>
+                      <a:tailEnd type="none" w="med" len="med"/>
+                    </a:lnR>
+                    <a:lnT w="6350" cap="flat" cmpd="sng" algn="ctr">
+                      <a:solidFill>
+                        <a:srgbClr val="D8DFE9"/>
+                      </a:solidFill>
+                      <a:prstDash val="solid"/>
+                      <a:round/>
+                      <a:headEnd type="none" w="med" len="med"/>
+                      <a:tailEnd type="none" w="med" len="med"/>
+                    </a:lnT>
+                    <a:lnB w="6350" cap="flat" cmpd="sng" algn="ctr">
+                      <a:solidFill>
+                        <a:srgbClr val="D8DFE9"/>
+                      </a:solidFill>
+                      <a:prstDash val="solid"/>
+                      <a:round/>
+                      <a:headEnd type="none" w="med" len="med"/>
+                      <a:tailEnd type="none" w="med" len="med"/>
+                    </a:lnB>
+                    <a:solidFill>
+                      <a:srgbClr val="FFFFFF"/>
+                    </a:solidFill>
+                  </a:tcPr>
+                </a:tc>
+                <a:tc>
+                  <a:txBody>
+                    <a:bodyPr/>
+                    <a:lstStyle/>
+                    <a:p>
+                      <a:pPr algn="r" indent="0" marL="0">
+                        <a:buNone/>
+                      </a:pPr>
+                      <a:r>
+                        <a:rPr lang="en-US" sz="900" dirty="0">
+                          <a:solidFill>
+                            <a:srgbClr val="16233D"/>
+                          </a:solidFill>
+                          <a:latin typeface="Graphik TH" pitchFamily="34" charset="0"/>
+                          <a:ea typeface="Graphik TH" pitchFamily="34" charset="-122"/>
+                          <a:cs typeface="Graphik TH" pitchFamily="34" charset="-120"/>
+                        </a:rPr>
+                        <a:t>2731.5</a:t>
+                      </a:r>
+                      <a:endParaRPr lang="en-US" sz="900" dirty="0">
+                        <a:latin typeface="Graphik TH" charset="0"/>
+                        <a:ea typeface="Graphik TH" charset="0"/>
+                        <a:cs typeface="Graphik TH" charset="0"/>
+                      </a:endParaRPr>
+                    </a:p>
+                  </a:txBody>
+                  <a:tcPr marL="54864" marR="54864" marT="9144" marB="9144" anchor="ctr">
+                    <a:lnL w="6350" cap="flat" cmpd="sng" algn="ctr">
+                      <a:solidFill>
+                        <a:srgbClr val="D8DFE9"/>
+                      </a:solidFill>
+                      <a:prstDash val="solid"/>
+                      <a:round/>
+                      <a:headEnd type="none" w="med" len="med"/>
+                      <a:tailEnd type="none" w="med" len="med"/>
+                    </a:lnL>
+                    <a:lnR w="6350" cap="flat" cmpd="sng" algn="ctr">
+                      <a:solidFill>
+                        <a:srgbClr val="D8DFE9"/>
+                      </a:solidFill>
+                      <a:prstDash val="solid"/>
+                      <a:round/>
+                      <a:headEnd type="none" w="med" len="med"/>
+                      <a:tailEnd type="none" w="med" len="med"/>
+                    </a:lnR>
+                    <a:lnT w="6350" cap="flat" cmpd="sng" algn="ctr">
+                      <a:solidFill>
+                        <a:srgbClr val="D8DFE9"/>
+                      </a:solidFill>
+                      <a:prstDash val="solid"/>
+                      <a:round/>
+                      <a:headEnd type="none" w="med" len="med"/>
+                      <a:tailEnd type="none" w="med" len="med"/>
+                    </a:lnT>
+                    <a:lnB w="6350" cap="flat" cmpd="sng" algn="ctr">
+                      <a:solidFill>
+                        <a:srgbClr val="D8DFE9"/>
+                      </a:solidFill>
+                      <a:prstDash val="solid"/>
+                      <a:round/>
+                      <a:headEnd type="none" w="med" len="med"/>
+                      <a:tailEnd type="none" w="med" len="med"/>
+                    </a:lnB>
+                    <a:solidFill>
+                      <a:srgbClr val="FFFFFF"/>
+                    </a:solidFill>
+                  </a:tcPr>
+                </a:tc>
+                <a:tc>
+                  <a:txBody>
+                    <a:bodyPr/>
+                    <a:lstStyle/>
+                    <a:p>
+                      <a:pPr algn="r" indent="0" marL="0">
+                        <a:buNone/>
+                      </a:pPr>
+                      <a:r>
+                        <a:rPr lang="en-US" sz="900" b="1" dirty="0">
+                          <a:solidFill>
+                            <a:srgbClr val="1E8E86"/>
+                          </a:solidFill>
+                          <a:latin typeface="Graphik TH" pitchFamily="34" charset="0"/>
+                          <a:ea typeface="Graphik TH" pitchFamily="34" charset="-122"/>
+                          <a:cs typeface="Graphik TH" pitchFamily="34" charset="-120"/>
+                        </a:rPr>
+                        <a:t>+67.6</a:t>
+                      </a:r>
+                      <a:endParaRPr lang="en-US" sz="900" dirty="0">
+                        <a:latin typeface="Graphik TH" charset="0"/>
+                        <a:ea typeface="Graphik TH" charset="0"/>
+                        <a:cs typeface="Graphik TH" charset="0"/>
+                      </a:endParaRPr>
+                    </a:p>
+                  </a:txBody>
+                  <a:tcPr marL="54864" marR="54864" marT="9144" marB="9144" anchor="ctr">
+                    <a:lnL w="6350" cap="flat" cmpd="sng" algn="ctr">
+                      <a:solidFill>
+                        <a:srgbClr val="D8DFE9"/>
+                      </a:solidFill>
+                      <a:prstDash val="solid"/>
+                      <a:round/>
+                      <a:headEnd type="none" w="med" len="med"/>
+                      <a:tailEnd type="none" w="med" len="med"/>
+                    </a:lnL>
+                    <a:lnR w="6350" cap="flat" cmpd="sng" algn="ctr">
+                      <a:solidFill>
+                        <a:srgbClr val="D8DFE9"/>
+                      </a:solidFill>
+                      <a:prstDash val="solid"/>
+                      <a:round/>
+                      <a:headEnd type="none" w="med" len="med"/>
+                      <a:tailEnd type="none" w="med" len="med"/>
+                    </a:lnR>
+                    <a:lnT w="6350" cap="flat" cmpd="sng" algn="ctr">
+                      <a:solidFill>
+                        <a:srgbClr val="D8DFE9"/>
+                      </a:solidFill>
+                      <a:prstDash val="solid"/>
+                      <a:round/>
+                      <a:headEnd type="none" w="med" len="med"/>
+                      <a:tailEnd type="none" w="med" len="med"/>
+                    </a:lnT>
+                    <a:lnB w="6350" cap="flat" cmpd="sng" algn="ctr">
+                      <a:solidFill>
+                        <a:srgbClr val="D8DFE9"/>
+                      </a:solidFill>
+                      <a:prstDash val="solid"/>
+                      <a:round/>
+                      <a:headEnd type="none" w="med" len="med"/>
+                      <a:tailEnd type="none" w="med" len="med"/>
+                    </a:lnB>
+                    <a:solidFill>
+                      <a:srgbClr val="FFFFFF"/>
+                    </a:solidFill>
+                  </a:tcPr>
+                </a:tc>
+                <a:tc>
+                  <a:txBody>
+                    <a:bodyPr/>
+                    <a:lstStyle/>
+                    <a:p>
+                      <a:pPr algn="r" indent="0" marL="0">
+                        <a:buNone/>
+                      </a:pPr>
+                      <a:r>
+                        <a:rPr lang="en-US" sz="900" b="1" dirty="0">
+                          <a:solidFill>
+                            <a:srgbClr val="1E8E86"/>
+                          </a:solidFill>
+                          <a:latin typeface="Graphik TH" pitchFamily="34" charset="0"/>
+                          <a:ea typeface="Graphik TH" pitchFamily="34" charset="-122"/>
+                          <a:cs typeface="Graphik TH" pitchFamily="34" charset="-120"/>
+                        </a:rPr>
+                        <a:t>+2.5%</a:t>
+                      </a:r>
+                      <a:endParaRPr lang="en-US" sz="900" dirty="0">
+                        <a:latin typeface="Graphik TH" charset="0"/>
+                        <a:ea typeface="Graphik TH" charset="0"/>
+                        <a:cs typeface="Graphik TH" charset="0"/>
+                      </a:endParaRPr>
+                    </a:p>
+                  </a:txBody>
+                  <a:tcPr marL="54864" marR="54864" marT="9144" marB="9144" anchor="ctr">
+                    <a:lnL w="6350" cap="flat" cmpd="sng" algn="ctr">
+                      <a:solidFill>
+                        <a:srgbClr val="D8DFE9"/>
+                      </a:solidFill>
+                      <a:prstDash val="solid"/>
+                      <a:round/>
+                      <a:headEnd type="none" w="med" len="med"/>
+                      <a:tailEnd type="none" w="med" len="med"/>
+                    </a:lnL>
+                    <a:lnR w="6350" cap="flat" cmpd="sng" algn="ctr">
+                      <a:solidFill>
+                        <a:srgbClr val="D8DFE9"/>
+                      </a:solidFill>
+                      <a:prstDash val="solid"/>
+                      <a:round/>
+                      <a:headEnd type="none" w="med" len="med"/>
+                      <a:tailEnd type="none" w="med" len="med"/>
+                    </a:lnR>
+                    <a:lnT w="6350" cap="flat" cmpd="sng" algn="ctr">
+                      <a:solidFill>
+                        <a:srgbClr val="D8DFE9"/>
+                      </a:solidFill>
+                      <a:prstDash val="solid"/>
+                      <a:round/>
+                      <a:headEnd type="none" w="med" len="med"/>
+                      <a:tailEnd type="none" w="med" len="med"/>
+                    </a:lnT>
+                    <a:lnB w="6350" cap="flat" cmpd="sng" algn="ctr">
+                      <a:solidFill>
+                        <a:srgbClr val="D8DFE9"/>
+                      </a:solidFill>
+                      <a:prstDash val="solid"/>
+                      <a:round/>
+                      <a:headEnd type="none" w="med" len="med"/>
+                      <a:tailEnd type="none" w="med" len="med"/>
+                    </a:lnB>
+                    <a:solidFill>
+                      <a:srgbClr val="FFFFFF"/>
+                    </a:solidFill>
+                  </a:tcPr>
+                </a:tc>
+              </a:tr>
+              <a:tr h="228600">
+                <a:tc>
+                  <a:txBody>
+                    <a:bodyPr/>
+                    <a:lstStyle/>
+                    <a:p>
+                      <a:pPr algn="l" indent="0" marL="0">
+                        <a:buNone/>
+                      </a:pPr>
+                      <a:r>
+                        <a:rPr lang="en-US" sz="900" b="1" dirty="0">
+                          <a:solidFill>
+                            <a:srgbClr val="16233D"/>
+                          </a:solidFill>
+                          <a:latin typeface="Graphik TH" pitchFamily="34" charset="0"/>
+                          <a:ea typeface="Graphik TH" pitchFamily="34" charset="-122"/>
+                          <a:cs typeface="Graphik TH" pitchFamily="34" charset="-120"/>
+                        </a:rPr>
+                        <a:t>High</a:t>
+                      </a:r>
+                      <a:endParaRPr lang="en-US" sz="900" dirty="0">
+                        <a:latin typeface="Graphik TH" charset="0"/>
+                        <a:ea typeface="Graphik TH" charset="0"/>
+                        <a:cs typeface="Graphik TH" charset="0"/>
+                      </a:endParaRPr>
+                    </a:p>
+                  </a:txBody>
+                  <a:tcPr marL="54864" marR="54864" marT="9144" marB="9144" anchor="ctr">
+                    <a:lnL w="6350" cap="flat" cmpd="sng" algn="ctr">
+                      <a:solidFill>
+                        <a:srgbClr val="D8DFE9"/>
+                      </a:solidFill>
+                      <a:prstDash val="solid"/>
+                      <a:round/>
+                      <a:headEnd type="none" w="med" len="med"/>
+                      <a:tailEnd type="none" w="med" len="med"/>
+                    </a:lnL>
+                    <a:lnR w="6350" cap="flat" cmpd="sng" algn="ctr">
+                      <a:solidFill>
+                        <a:srgbClr val="D8DFE9"/>
+                      </a:solidFill>
+                      <a:prstDash val="solid"/>
+                      <a:round/>
+                      <a:headEnd type="none" w="med" len="med"/>
+                      <a:tailEnd type="none" w="med" len="med"/>
+                    </a:lnR>
+                    <a:lnT w="6350" cap="flat" cmpd="sng" algn="ctr">
+                      <a:solidFill>
+                        <a:srgbClr val="D8DFE9"/>
+                      </a:solidFill>
+                      <a:prstDash val="solid"/>
+                      <a:round/>
+                      <a:headEnd type="none" w="med" len="med"/>
+                      <a:tailEnd type="none" w="med" len="med"/>
+                    </a:lnT>
+                    <a:lnB w="6350" cap="flat" cmpd="sng" algn="ctr">
+                      <a:solidFill>
+                        <a:srgbClr val="D8DFE9"/>
+                      </a:solidFill>
+                      <a:prstDash val="solid"/>
+                      <a:round/>
+                      <a:headEnd type="none" w="med" len="med"/>
+                      <a:tailEnd type="none" w="med" len="med"/>
+                    </a:lnB>
+                    <a:solidFill>
+                      <a:srgbClr val="F1F4F9"/>
+                    </a:solidFill>
+                  </a:tcPr>
+                </a:tc>
+                <a:tc>
+                  <a:txBody>
+                    <a:bodyPr/>
+                    <a:lstStyle/>
+                    <a:p>
+                      <a:pPr algn="r" indent="0" marL="0">
+                        <a:buNone/>
+                      </a:pPr>
+                      <a:r>
+                        <a:rPr lang="en-US" sz="900" dirty="0">
+                          <a:solidFill>
+                            <a:srgbClr val="16233D"/>
+                          </a:solidFill>
+                          <a:latin typeface="Graphik TH" pitchFamily="34" charset="0"/>
+                          <a:ea typeface="Graphik TH" pitchFamily="34" charset="-122"/>
+                          <a:cs typeface="Graphik TH" pitchFamily="34" charset="-120"/>
+                        </a:rPr>
+                        <a:t>102,005</a:t>
+                      </a:r>
+                      <a:endParaRPr lang="en-US" sz="900" dirty="0">
+                        <a:latin typeface="Graphik TH" charset="0"/>
+                        <a:ea typeface="Graphik TH" charset="0"/>
+                        <a:cs typeface="Graphik TH" charset="0"/>
+                      </a:endParaRPr>
+                    </a:p>
+                  </a:txBody>
+                  <a:tcPr marL="54864" marR="54864" marT="9144" marB="9144" anchor="ctr">
+                    <a:lnL w="6350" cap="flat" cmpd="sng" algn="ctr">
+                      <a:solidFill>
+                        <a:srgbClr val="D8DFE9"/>
+                      </a:solidFill>
+                      <a:prstDash val="solid"/>
+                      <a:round/>
+                      <a:headEnd type="none" w="med" len="med"/>
+                      <a:tailEnd type="none" w="med" len="med"/>
+                    </a:lnL>
+                    <a:lnR w="6350" cap="flat" cmpd="sng" algn="ctr">
+                      <a:solidFill>
+                        <a:srgbClr val="D8DFE9"/>
+                      </a:solidFill>
+                      <a:prstDash val="solid"/>
+                      <a:round/>
+                      <a:headEnd type="none" w="med" len="med"/>
+                      <a:tailEnd type="none" w="med" len="med"/>
+                    </a:lnR>
+                    <a:lnT w="6350" cap="flat" cmpd="sng" algn="ctr">
+                      <a:solidFill>
+                        <a:srgbClr val="D8DFE9"/>
+                      </a:solidFill>
+                      <a:prstDash val="solid"/>
+                      <a:round/>
+                      <a:headEnd type="none" w="med" len="med"/>
+                      <a:tailEnd type="none" w="med" len="med"/>
+                    </a:lnT>
+                    <a:lnB w="6350" cap="flat" cmpd="sng" algn="ctr">
+                      <a:solidFill>
+                        <a:srgbClr val="D8DFE9"/>
+                      </a:solidFill>
+                      <a:prstDash val="solid"/>
+                      <a:round/>
+                      <a:headEnd type="none" w="med" len="med"/>
+                      <a:tailEnd type="none" w="med" len="med"/>
+                    </a:lnB>
+                    <a:solidFill>
+                      <a:srgbClr val="FFFFFF"/>
+                    </a:solidFill>
+                  </a:tcPr>
+                </a:tc>
+                <a:tc>
+                  <a:txBody>
+                    <a:bodyPr/>
+                    <a:lstStyle/>
+                    <a:p>
+                      <a:pPr algn="r" indent="0" marL="0">
+                        <a:buNone/>
+                      </a:pPr>
+                      <a:r>
+                        <a:rPr lang="en-US" sz="900" dirty="0">
+                          <a:solidFill>
+                            <a:srgbClr val="16233D"/>
+                          </a:solidFill>
+                          <a:latin typeface="Graphik TH" pitchFamily="34" charset="0"/>
+                          <a:ea typeface="Graphik TH" pitchFamily="34" charset="-122"/>
+                          <a:cs typeface="Graphik TH" pitchFamily="34" charset="-120"/>
+                        </a:rPr>
+                        <a:t>2585.6</a:t>
+                      </a:r>
+                      <a:endParaRPr lang="en-US" sz="900" dirty="0">
+                        <a:latin typeface="Graphik TH" charset="0"/>
+                        <a:ea typeface="Graphik TH" charset="0"/>
+                        <a:cs typeface="Graphik TH" charset="0"/>
+                      </a:endParaRPr>
+                    </a:p>
+                  </a:txBody>
+                  <a:tcPr marL="54864" marR="54864" marT="9144" marB="9144" anchor="ctr">
+                    <a:lnL w="6350" cap="flat" cmpd="sng" algn="ctr">
+                      <a:solidFill>
+                        <a:srgbClr val="D8DFE9"/>
+                      </a:solidFill>
+                      <a:prstDash val="solid"/>
+                      <a:round/>
+                      <a:headEnd type="none" w="med" len="med"/>
+                      <a:tailEnd type="none" w="med" len="med"/>
+                    </a:lnL>
+                    <a:lnR w="6350" cap="flat" cmpd="sng" algn="ctr">
+                      <a:solidFill>
+                        <a:srgbClr val="D8DFE9"/>
+                      </a:solidFill>
+                      <a:prstDash val="solid"/>
+                      <a:round/>
+                      <a:headEnd type="none" w="med" len="med"/>
+                      <a:tailEnd type="none" w="med" len="med"/>
+                    </a:lnR>
+                    <a:lnT w="6350" cap="flat" cmpd="sng" algn="ctr">
+                      <a:solidFill>
+                        <a:srgbClr val="D8DFE9"/>
+                      </a:solidFill>
+                      <a:prstDash val="solid"/>
+                      <a:round/>
+                      <a:headEnd type="none" w="med" len="med"/>
+                      <a:tailEnd type="none" w="med" len="med"/>
+                    </a:lnT>
+                    <a:lnB w="6350" cap="flat" cmpd="sng" algn="ctr">
+                      <a:solidFill>
+                        <a:srgbClr val="D8DFE9"/>
+                      </a:solidFill>
+                      <a:prstDash val="solid"/>
+                      <a:round/>
+                      <a:headEnd type="none" w="med" len="med"/>
+                      <a:tailEnd type="none" w="med" len="med"/>
+                    </a:lnB>
+                    <a:solidFill>
+                      <a:srgbClr val="FFFFFF"/>
+                    </a:solidFill>
+                  </a:tcPr>
+                </a:tc>
+                <a:tc>
+                  <a:txBody>
+                    <a:bodyPr/>
+                    <a:lstStyle/>
+                    <a:p>
+                      <a:pPr algn="r" indent="0" marL="0">
+                        <a:buNone/>
+                      </a:pPr>
+                      <a:r>
+                        <a:rPr lang="en-US" sz="900" dirty="0">
+                          <a:solidFill>
+                            <a:srgbClr val="16233D"/>
+                          </a:solidFill>
+                          <a:latin typeface="Graphik TH" pitchFamily="34" charset="0"/>
+                          <a:ea typeface="Graphik TH" pitchFamily="34" charset="-122"/>
+                          <a:cs typeface="Graphik TH" pitchFamily="34" charset="-120"/>
+                        </a:rPr>
+                        <a:t>2685.1</a:t>
+                      </a:r>
+                      <a:endParaRPr lang="en-US" sz="900" dirty="0">
+                        <a:latin typeface="Graphik TH" charset="0"/>
+                        <a:ea typeface="Graphik TH" charset="0"/>
+                        <a:cs typeface="Graphik TH" charset="0"/>
+                      </a:endParaRPr>
+                    </a:p>
+                  </a:txBody>
+                  <a:tcPr marL="54864" marR="54864" marT="9144" marB="9144" anchor="ctr">
+                    <a:lnL w="6350" cap="flat" cmpd="sng" algn="ctr">
+                      <a:solidFill>
+                        <a:srgbClr val="D8DFE9"/>
+                      </a:solidFill>
+                      <a:prstDash val="solid"/>
+                      <a:round/>
+                      <a:headEnd type="none" w="med" len="med"/>
+                      <a:tailEnd type="none" w="med" len="med"/>
+                    </a:lnL>
+                    <a:lnR w="6350" cap="flat" cmpd="sng" algn="ctr">
+                      <a:solidFill>
+                        <a:srgbClr val="D8DFE9"/>
+                      </a:solidFill>
+                      <a:prstDash val="solid"/>
+                      <a:round/>
+                      <a:headEnd type="none" w="med" len="med"/>
+                      <a:tailEnd type="none" w="med" len="med"/>
+                    </a:lnR>
+                    <a:lnT w="6350" cap="flat" cmpd="sng" algn="ctr">
+                      <a:solidFill>
+                        <a:srgbClr val="D8DFE9"/>
+                      </a:solidFill>
+                      <a:prstDash val="solid"/>
+                      <a:round/>
+                      <a:headEnd type="none" w="med" len="med"/>
+                      <a:tailEnd type="none" w="med" len="med"/>
+                    </a:lnT>
+                    <a:lnB w="6350" cap="flat" cmpd="sng" algn="ctr">
+                      <a:solidFill>
+                        <a:srgbClr val="D8DFE9"/>
+                      </a:solidFill>
+                      <a:prstDash val="solid"/>
+                      <a:round/>
+                      <a:headEnd type="none" w="med" len="med"/>
+                      <a:tailEnd type="none" w="med" len="med"/>
+                    </a:lnB>
+                    <a:solidFill>
+                      <a:srgbClr val="FFFFFF"/>
+                    </a:solidFill>
+                  </a:tcPr>
+                </a:tc>
+                <a:tc>
+                  <a:txBody>
+                    <a:bodyPr/>
+                    <a:lstStyle/>
+                    <a:p>
+                      <a:pPr algn="r" indent="0" marL="0">
+                        <a:buNone/>
+                      </a:pPr>
+                      <a:r>
+                        <a:rPr lang="en-US" sz="900" b="1" dirty="0">
+                          <a:solidFill>
+                            <a:srgbClr val="1E8E86"/>
+                          </a:solidFill>
+                          <a:latin typeface="Graphik TH" pitchFamily="34" charset="0"/>
+                          <a:ea typeface="Graphik TH" pitchFamily="34" charset="-122"/>
+                          <a:cs typeface="Graphik TH" pitchFamily="34" charset="-120"/>
+                        </a:rPr>
+                        <a:t>+99.5</a:t>
+                      </a:r>
+                      <a:endParaRPr lang="en-US" sz="900" dirty="0">
+                        <a:latin typeface="Graphik TH" charset="0"/>
+                        <a:ea typeface="Graphik TH" charset="0"/>
+                        <a:cs typeface="Graphik TH" charset="0"/>
+                      </a:endParaRPr>
+                    </a:p>
+                  </a:txBody>
+                  <a:tcPr marL="54864" marR="54864" marT="9144" marB="9144" anchor="ctr">
+                    <a:lnL w="6350" cap="flat" cmpd="sng" algn="ctr">
+                      <a:solidFill>
+                        <a:srgbClr val="D8DFE9"/>
+                      </a:solidFill>
+                      <a:prstDash val="solid"/>
+                      <a:round/>
+                      <a:headEnd type="none" w="med" len="med"/>
+                      <a:tailEnd type="none" w="med" len="med"/>
+                    </a:lnL>
+                    <a:lnR w="6350" cap="flat" cmpd="sng" algn="ctr">
+                      <a:solidFill>
+                        <a:srgbClr val="D8DFE9"/>
+                      </a:solidFill>
+                      <a:prstDash val="solid"/>
+                      <a:round/>
+                      <a:headEnd type="none" w="med" len="med"/>
+                      <a:tailEnd type="none" w="med" len="med"/>
+                    </a:lnR>
+                    <a:lnT w="6350" cap="flat" cmpd="sng" algn="ctr">
+                      <a:solidFill>
+                        <a:srgbClr val="D8DFE9"/>
+                      </a:solidFill>
+                      <a:prstDash val="solid"/>
+                      <a:round/>
+                      <a:headEnd type="none" w="med" len="med"/>
+                      <a:tailEnd type="none" w="med" len="med"/>
+                    </a:lnT>
+                    <a:lnB w="6350" cap="flat" cmpd="sng" algn="ctr">
+                      <a:solidFill>
+                        <a:srgbClr val="D8DFE9"/>
+                      </a:solidFill>
+                      <a:prstDash val="solid"/>
+                      <a:round/>
+                      <a:headEnd type="none" w="med" len="med"/>
+                      <a:tailEnd type="none" w="med" len="med"/>
+                    </a:lnB>
+                    <a:solidFill>
+                      <a:srgbClr val="FFFFFF"/>
+                    </a:solidFill>
+                  </a:tcPr>
+                </a:tc>
+                <a:tc>
+                  <a:txBody>
+                    <a:bodyPr/>
+                    <a:lstStyle/>
+                    <a:p>
+                      <a:pPr algn="r" indent="0" marL="0">
+                        <a:buNone/>
+                      </a:pPr>
+                      <a:r>
+                        <a:rPr lang="en-US" sz="900" b="1" dirty="0">
+                          <a:solidFill>
+                            <a:srgbClr val="1E8E86"/>
+                          </a:solidFill>
+                          <a:latin typeface="Graphik TH" pitchFamily="34" charset="0"/>
+                          <a:ea typeface="Graphik TH" pitchFamily="34" charset="-122"/>
+                          <a:cs typeface="Graphik TH" pitchFamily="34" charset="-120"/>
+                        </a:rPr>
+                        <a:t>+3.8%</a:t>
+                      </a:r>
+                      <a:endParaRPr lang="en-US" sz="900" dirty="0">
+                        <a:latin typeface="Graphik TH" charset="0"/>
+                        <a:ea typeface="Graphik TH" charset="0"/>
+                        <a:cs typeface="Graphik TH" charset="0"/>
+                      </a:endParaRPr>
+                    </a:p>
+                  </a:txBody>
+                  <a:tcPr marL="54864" marR="54864" marT="9144" marB="9144" anchor="ctr">
+                    <a:lnL w="6350" cap="flat" cmpd="sng" algn="ctr">
+                      <a:solidFill>
+                        <a:srgbClr val="D8DFE9"/>
+                      </a:solidFill>
+                      <a:prstDash val="solid"/>
+                      <a:round/>
+                      <a:headEnd type="none" w="med" len="med"/>
+                      <a:tailEnd type="none" w="med" len="med"/>
+                    </a:lnL>
+                    <a:lnR w="6350" cap="flat" cmpd="sng" algn="ctr">
+                      <a:solidFill>
+                        <a:srgbClr val="D8DFE9"/>
+                      </a:solidFill>
+                      <a:prstDash val="solid"/>
+                      <a:round/>
+                      <a:headEnd type="none" w="med" len="med"/>
+                      <a:tailEnd type="none" w="med" len="med"/>
+                    </a:lnR>
+                    <a:lnT w="6350" cap="flat" cmpd="sng" algn="ctr">
+                      <a:solidFill>
+                        <a:srgbClr val="D8DFE9"/>
+                      </a:solidFill>
+                      <a:prstDash val="solid"/>
+                      <a:round/>
+                      <a:headEnd type="none" w="med" len="med"/>
+                      <a:tailEnd type="none" w="med" len="med"/>
+                    </a:lnT>
+                    <a:lnB w="6350" cap="flat" cmpd="sng" algn="ctr">
+                      <a:solidFill>
+                        <a:srgbClr val="D8DFE9"/>
+                      </a:solidFill>
+                      <a:prstDash val="solid"/>
+                      <a:round/>
+                      <a:headEnd type="none" w="med" len="med"/>
+                      <a:tailEnd type="none" w="med" len="med"/>
+                    </a:lnB>
+                    <a:solidFill>
+                      <a:srgbClr val="FFFFFF"/>
+                    </a:solidFill>
+                  </a:tcPr>
+                </a:tc>
+              </a:tr>
+              <a:tr h="228600">
+                <a:tc>
+                  <a:txBody>
+                    <a:bodyPr/>
+                    <a:lstStyle/>
+                    <a:p>
+                      <a:pPr algn="l" indent="0" marL="0">
+                        <a:buNone/>
+                      </a:pPr>
+                      <a:r>
+                        <a:rPr lang="en-US" sz="900" b="1" dirty="0">
+                          <a:solidFill>
+                            <a:srgbClr val="16233D"/>
+                          </a:solidFill>
+                          <a:latin typeface="Graphik TH" pitchFamily="34" charset="0"/>
+                          <a:ea typeface="Graphik TH" pitchFamily="34" charset="-122"/>
+                          <a:cs typeface="Graphik TH" pitchFamily="34" charset="-120"/>
+                        </a:rPr>
+                        <a:t>Medium</a:t>
+                      </a:r>
+                      <a:endParaRPr lang="en-US" sz="900" dirty="0">
+                        <a:latin typeface="Graphik TH" charset="0"/>
+                        <a:ea typeface="Graphik TH" charset="0"/>
+                        <a:cs typeface="Graphik TH" charset="0"/>
+                      </a:endParaRPr>
+                    </a:p>
+                  </a:txBody>
+                  <a:tcPr marL="54864" marR="54864" marT="9144" marB="9144" anchor="ctr">
+                    <a:lnL w="6350" cap="flat" cmpd="sng" algn="ctr">
+                      <a:solidFill>
+                        <a:srgbClr val="D8DFE9"/>
+                      </a:solidFill>
+                      <a:prstDash val="solid"/>
+                      <a:round/>
+                      <a:headEnd type="none" w="med" len="med"/>
+                      <a:tailEnd type="none" w="med" len="med"/>
+                    </a:lnL>
+                    <a:lnR w="6350" cap="flat" cmpd="sng" algn="ctr">
+                      <a:solidFill>
+                        <a:srgbClr val="D8DFE9"/>
+                      </a:solidFill>
+                      <a:prstDash val="solid"/>
+                      <a:round/>
+                      <a:headEnd type="none" w="med" len="med"/>
+                      <a:tailEnd type="none" w="med" len="med"/>
+                    </a:lnR>
+                    <a:lnT w="6350" cap="flat" cmpd="sng" algn="ctr">
+                      <a:solidFill>
+                        <a:srgbClr val="D8DFE9"/>
+                      </a:solidFill>
+                      <a:prstDash val="solid"/>
+                      <a:round/>
+                      <a:headEnd type="none" w="med" len="med"/>
+                      <a:tailEnd type="none" w="med" len="med"/>
+                    </a:lnT>
+                    <a:lnB w="6350" cap="flat" cmpd="sng" algn="ctr">
+                      <a:solidFill>
+                        <a:srgbClr val="D8DFE9"/>
+                      </a:solidFill>
+                      <a:prstDash val="solid"/>
+                      <a:round/>
+                      <a:headEnd type="none" w="med" len="med"/>
+                      <a:tailEnd type="none" w="med" len="med"/>
+                    </a:lnB>
+                    <a:solidFill>
+                      <a:srgbClr val="F1F4F9"/>
+                    </a:solidFill>
+                  </a:tcPr>
+                </a:tc>
+                <a:tc>
+                  <a:txBody>
+                    <a:bodyPr/>
+                    <a:lstStyle/>
+                    <a:p>
+                      <a:pPr algn="r" indent="0" marL="0">
+                        <a:buNone/>
+                      </a:pPr>
+                      <a:r>
+                        <a:rPr lang="en-US" sz="900" dirty="0">
+                          <a:solidFill>
+                            <a:srgbClr val="16233D"/>
+                          </a:solidFill>
+                          <a:latin typeface="Graphik TH" pitchFamily="34" charset="0"/>
+                          <a:ea typeface="Graphik TH" pitchFamily="34" charset="-122"/>
+                          <a:cs typeface="Graphik TH" pitchFamily="34" charset="-120"/>
+                        </a:rPr>
+                        <a:t>96,426</a:t>
+                      </a:r>
+                      <a:endParaRPr lang="en-US" sz="900" dirty="0">
+                        <a:latin typeface="Graphik TH" charset="0"/>
+                        <a:ea typeface="Graphik TH" charset="0"/>
+                        <a:cs typeface="Graphik TH" charset="0"/>
+                      </a:endParaRPr>
+                    </a:p>
+                  </a:txBody>
+                  <a:tcPr marL="54864" marR="54864" marT="9144" marB="9144" anchor="ctr">
+                    <a:lnL w="6350" cap="flat" cmpd="sng" algn="ctr">
+                      <a:solidFill>
+                        <a:srgbClr val="D8DFE9"/>
+                      </a:solidFill>
+                      <a:prstDash val="solid"/>
+                      <a:round/>
+                      <a:headEnd type="none" w="med" len="med"/>
+                      <a:tailEnd type="none" w="med" len="med"/>
+                    </a:lnL>
+                    <a:lnR w="6350" cap="flat" cmpd="sng" algn="ctr">
+                      <a:solidFill>
+                        <a:srgbClr val="D8DFE9"/>
+                      </a:solidFill>
+                      <a:prstDash val="solid"/>
+                      <a:round/>
+                      <a:headEnd type="none" w="med" len="med"/>
+                      <a:tailEnd type="none" w="med" len="med"/>
+                    </a:lnR>
+                    <a:lnT w="6350" cap="flat" cmpd="sng" algn="ctr">
+                      <a:solidFill>
+                        <a:srgbClr val="D8DFE9"/>
+                      </a:solidFill>
+                      <a:prstDash val="solid"/>
+                      <a:round/>
+                      <a:headEnd type="none" w="med" len="med"/>
+                      <a:tailEnd type="none" w="med" len="med"/>
+                    </a:lnT>
+                    <a:lnB w="6350" cap="flat" cmpd="sng" algn="ctr">
+                      <a:solidFill>
+                        <a:srgbClr val="D8DFE9"/>
+                      </a:solidFill>
+                      <a:prstDash val="solid"/>
+                      <a:round/>
+                      <a:headEnd type="none" w="med" len="med"/>
+                      <a:tailEnd type="none" w="med" len="med"/>
+                    </a:lnB>
+                    <a:solidFill>
+                      <a:srgbClr val="FFFFFF"/>
+                    </a:solidFill>
+                  </a:tcPr>
+                </a:tc>
+                <a:tc>
+                  <a:txBody>
+                    <a:bodyPr/>
+                    <a:lstStyle/>
+                    <a:p>
+                      <a:pPr algn="r" indent="0" marL="0">
+                        <a:buNone/>
+                      </a:pPr>
+                      <a:r>
+                        <a:rPr lang="en-US" sz="900" dirty="0">
+                          <a:solidFill>
+                            <a:srgbClr val="16233D"/>
+                          </a:solidFill>
+                          <a:latin typeface="Graphik TH" pitchFamily="34" charset="0"/>
+                          <a:ea typeface="Graphik TH" pitchFamily="34" charset="-122"/>
+                          <a:cs typeface="Graphik TH" pitchFamily="34" charset="-120"/>
+                        </a:rPr>
+                        <a:t>211.4</a:t>
+                      </a:r>
+                      <a:endParaRPr lang="en-US" sz="900" dirty="0">
+                        <a:latin typeface="Graphik TH" charset="0"/>
+                        <a:ea typeface="Graphik TH" charset="0"/>
+                        <a:cs typeface="Graphik TH" charset="0"/>
+                      </a:endParaRPr>
+                    </a:p>
+                  </a:txBody>
+                  <a:tcPr marL="54864" marR="54864" marT="9144" marB="9144" anchor="ctr">
+                    <a:lnL w="6350" cap="flat" cmpd="sng" algn="ctr">
+                      <a:solidFill>
+                        <a:srgbClr val="D8DFE9"/>
+                      </a:solidFill>
+                      <a:prstDash val="solid"/>
+                      <a:round/>
+                      <a:headEnd type="none" w="med" len="med"/>
+                      <a:tailEnd type="none" w="med" len="med"/>
+                    </a:lnL>
+                    <a:lnR w="6350" cap="flat" cmpd="sng" algn="ctr">
+                      <a:solidFill>
+                        <a:srgbClr val="D8DFE9"/>
+                      </a:solidFill>
+                      <a:prstDash val="solid"/>
+                      <a:round/>
+                      <a:headEnd type="none" w="med" len="med"/>
+                      <a:tailEnd type="none" w="med" len="med"/>
+                    </a:lnR>
+                    <a:lnT w="6350" cap="flat" cmpd="sng" algn="ctr">
+                      <a:solidFill>
+                        <a:srgbClr val="D8DFE9"/>
+                      </a:solidFill>
+                      <a:prstDash val="solid"/>
+                      <a:round/>
+                      <a:headEnd type="none" w="med" len="med"/>
+                      <a:tailEnd type="none" w="med" len="med"/>
+                    </a:lnT>
+                    <a:lnB w="6350" cap="flat" cmpd="sng" algn="ctr">
+                      <a:solidFill>
+                        <a:srgbClr val="D8DFE9"/>
+                      </a:solidFill>
+                      <a:prstDash val="solid"/>
+                      <a:round/>
+                      <a:headEnd type="none" w="med" len="med"/>
+                      <a:tailEnd type="none" w="med" len="med"/>
+                    </a:lnB>
+                    <a:solidFill>
+                      <a:srgbClr val="FFFFFF"/>
+                    </a:solidFill>
+                  </a:tcPr>
+                </a:tc>
+                <a:tc>
+                  <a:txBody>
+                    <a:bodyPr/>
+                    <a:lstStyle/>
+                    <a:p>
+                      <a:pPr algn="r" indent="0" marL="0">
+                        <a:buNone/>
+                      </a:pPr>
+                      <a:r>
+                        <a:rPr lang="en-US" sz="900" dirty="0">
+                          <a:solidFill>
+                            <a:srgbClr val="16233D"/>
+                          </a:solidFill>
+                          <a:latin typeface="Graphik TH" pitchFamily="34" charset="0"/>
+                          <a:ea typeface="Graphik TH" pitchFamily="34" charset="-122"/>
+                          <a:cs typeface="Graphik TH" pitchFamily="34" charset="-120"/>
+                        </a:rPr>
+                        <a:t>236.3</a:t>
+                      </a:r>
+                      <a:endParaRPr lang="en-US" sz="900" dirty="0">
+                        <a:latin typeface="Graphik TH" charset="0"/>
+                        <a:ea typeface="Graphik TH" charset="0"/>
+                        <a:cs typeface="Graphik TH" charset="0"/>
+                      </a:endParaRPr>
+                    </a:p>
+                  </a:txBody>
+                  <a:tcPr marL="54864" marR="54864" marT="9144" marB="9144" anchor="ctr">
+                    <a:lnL w="6350" cap="flat" cmpd="sng" algn="ctr">
+                      <a:solidFill>
+                        <a:srgbClr val="D8DFE9"/>
+                      </a:solidFill>
+                      <a:prstDash val="solid"/>
+                      <a:round/>
+                      <a:headEnd type="none" w="med" len="med"/>
+                      <a:tailEnd type="none" w="med" len="med"/>
+                    </a:lnL>
+                    <a:lnR w="6350" cap="flat" cmpd="sng" algn="ctr">
+                      <a:solidFill>
+                        <a:srgbClr val="D8DFE9"/>
+                      </a:solidFill>
+                      <a:prstDash val="solid"/>
+                      <a:round/>
+                      <a:headEnd type="none" w="med" len="med"/>
+                      <a:tailEnd type="none" w="med" len="med"/>
+                    </a:lnR>
+                    <a:lnT w="6350" cap="flat" cmpd="sng" algn="ctr">
+                      <a:solidFill>
+                        <a:srgbClr val="D8DFE9"/>
+                      </a:solidFill>
+                      <a:prstDash val="solid"/>
+                      <a:round/>
+                      <a:headEnd type="none" w="med" len="med"/>
+                      <a:tailEnd type="none" w="med" len="med"/>
+                    </a:lnT>
+                    <a:lnB w="6350" cap="flat" cmpd="sng" algn="ctr">
+                      <a:solidFill>
+                        <a:srgbClr val="D8DFE9"/>
+                      </a:solidFill>
+                      <a:prstDash val="solid"/>
+                      <a:round/>
+                      <a:headEnd type="none" w="med" len="med"/>
+                      <a:tailEnd type="none" w="med" len="med"/>
+                    </a:lnB>
+                    <a:solidFill>
+                      <a:srgbClr val="FFFFFF"/>
+                    </a:solidFill>
+                  </a:tcPr>
+                </a:tc>
+                <a:tc>
+                  <a:txBody>
+                    <a:bodyPr/>
+                    <a:lstStyle/>
+                    <a:p>
+                      <a:pPr algn="r" indent="0" marL="0">
+                        <a:buNone/>
+                      </a:pPr>
+                      <a:r>
+                        <a:rPr lang="en-US" sz="900" b="1" dirty="0">
+                          <a:solidFill>
+                            <a:srgbClr val="1E8E86"/>
+                          </a:solidFill>
+                          <a:latin typeface="Graphik TH" pitchFamily="34" charset="0"/>
+                          <a:ea typeface="Graphik TH" pitchFamily="34" charset="-122"/>
+                          <a:cs typeface="Graphik TH" pitchFamily="34" charset="-120"/>
+                        </a:rPr>
+                        <a:t>+24.9</a:t>
+                      </a:r>
+                      <a:endParaRPr lang="en-US" sz="900" dirty="0">
+                        <a:latin typeface="Graphik TH" charset="0"/>
+                        <a:ea typeface="Graphik TH" charset="0"/>
+                        <a:cs typeface="Graphik TH" charset="0"/>
+                      </a:endParaRPr>
+                    </a:p>
+                  </a:txBody>
+                  <a:tcPr marL="54864" marR="54864" marT="9144" marB="9144" anchor="ctr">
+                    <a:lnL w="6350" cap="flat" cmpd="sng" algn="ctr">
+                      <a:solidFill>
+                        <a:srgbClr val="D8DFE9"/>
+                      </a:solidFill>
+                      <a:prstDash val="solid"/>
+                      <a:round/>
+                      <a:headEnd type="none" w="med" len="med"/>
+                      <a:tailEnd type="none" w="med" len="med"/>
+                    </a:lnL>
+                    <a:lnR w="6350" cap="flat" cmpd="sng" algn="ctr">
+                      <a:solidFill>
+                        <a:srgbClr val="D8DFE9"/>
+                      </a:solidFill>
+                      <a:prstDash val="solid"/>
+                      <a:round/>
+                      <a:headEnd type="none" w="med" len="med"/>
+                      <a:tailEnd type="none" w="med" len="med"/>
+                    </a:lnR>
+                    <a:lnT w="6350" cap="flat" cmpd="sng" algn="ctr">
+                      <a:solidFill>
+                        <a:srgbClr val="D8DFE9"/>
+                      </a:solidFill>
+                      <a:prstDash val="solid"/>
+                      <a:round/>
+                      <a:headEnd type="none" w="med" len="med"/>
+                      <a:tailEnd type="none" w="med" len="med"/>
+                    </a:lnT>
+                    <a:lnB w="6350" cap="flat" cmpd="sng" algn="ctr">
+                      <a:solidFill>
+                        <a:srgbClr val="D8DFE9"/>
+                      </a:solidFill>
+                      <a:prstDash val="solid"/>
+                      <a:round/>
+                      <a:headEnd type="none" w="med" len="med"/>
+                      <a:tailEnd type="none" w="med" len="med"/>
+                    </a:lnB>
+                    <a:solidFill>
+                      <a:srgbClr val="FFFFFF"/>
+                    </a:solidFill>
+                  </a:tcPr>
+                </a:tc>
+                <a:tc>
+                  <a:txBody>
+                    <a:bodyPr/>
+                    <a:lstStyle/>
+                    <a:p>
+                      <a:pPr algn="r" indent="0" marL="0">
+                        <a:buNone/>
+                      </a:pPr>
+                      <a:r>
+                        <a:rPr lang="en-US" sz="900" b="1" dirty="0">
+                          <a:solidFill>
+                            <a:srgbClr val="1E8E86"/>
+                          </a:solidFill>
+                          <a:latin typeface="Graphik TH" pitchFamily="34" charset="0"/>
+                          <a:ea typeface="Graphik TH" pitchFamily="34" charset="-122"/>
+                          <a:cs typeface="Graphik TH" pitchFamily="34" charset="-120"/>
+                        </a:rPr>
+                        <a:t>+11.8%</a:t>
+                      </a:r>
+                      <a:endParaRPr lang="en-US" sz="900" dirty="0">
+                        <a:latin typeface="Graphik TH" charset="0"/>
+                        <a:ea typeface="Graphik TH" charset="0"/>
+                        <a:cs typeface="Graphik TH" charset="0"/>
+                      </a:endParaRPr>
+                    </a:p>
+                  </a:txBody>
+                  <a:tcPr marL="54864" marR="54864" marT="9144" marB="9144" anchor="ctr">
+                    <a:lnL w="6350" cap="flat" cmpd="sng" algn="ctr">
+                      <a:solidFill>
+                        <a:srgbClr val="D8DFE9"/>
+                      </a:solidFill>
+                      <a:prstDash val="solid"/>
+                      <a:round/>
+                      <a:headEnd type="none" w="med" len="med"/>
+                      <a:tailEnd type="none" w="med" len="med"/>
+                    </a:lnL>
+                    <a:lnR w="6350" cap="flat" cmpd="sng" algn="ctr">
+                      <a:solidFill>
+                        <a:srgbClr val="D8DFE9"/>
+                      </a:solidFill>
+                      <a:prstDash val="solid"/>
+                      <a:round/>
+                      <a:headEnd type="none" w="med" len="med"/>
+                      <a:tailEnd type="none" w="med" len="med"/>
+                    </a:lnR>
+                    <a:lnT w="6350" cap="flat" cmpd="sng" algn="ctr">
+                      <a:solidFill>
+                        <a:srgbClr val="D8DFE9"/>
+                      </a:solidFill>
+                      <a:prstDash val="solid"/>
+                      <a:round/>
+                      <a:headEnd type="none" w="med" len="med"/>
+                      <a:tailEnd type="none" w="med" len="med"/>
+                    </a:lnT>
+                    <a:lnB w="6350" cap="flat" cmpd="sng" algn="ctr">
+                      <a:solidFill>
+                        <a:srgbClr val="D8DFE9"/>
+                      </a:solidFill>
+                      <a:prstDash val="solid"/>
+                      <a:round/>
+                      <a:headEnd type="none" w="med" len="med"/>
+                      <a:tailEnd type="none" w="med" len="med"/>
+                    </a:lnB>
+                    <a:solidFill>
+                      <a:srgbClr val="FFFFFF"/>
+                    </a:solidFill>
+                  </a:tcPr>
+                </a:tc>
+              </a:tr>
+              <a:tr h="228600">
+                <a:tc>
+                  <a:txBody>
+                    <a:bodyPr/>
+                    <a:lstStyle/>
+                    <a:p>
+                      <a:pPr algn="l" indent="0" marL="0">
+                        <a:buNone/>
+                      </a:pPr>
+                      <a:r>
+                        <a:rPr lang="en-US" sz="900" b="1" dirty="0">
+                          <a:solidFill>
+                            <a:srgbClr val="16233D"/>
+                          </a:solidFill>
+                          <a:latin typeface="Graphik TH" pitchFamily="34" charset="0"/>
+                          <a:ea typeface="Graphik TH" pitchFamily="34" charset="-122"/>
+                          <a:cs typeface="Graphik TH" pitchFamily="34" charset="-120"/>
+                        </a:rPr>
+                        <a:t>Low</a:t>
+                      </a:r>
+                      <a:endParaRPr lang="en-US" sz="900" dirty="0">
+                        <a:latin typeface="Graphik TH" charset="0"/>
+                        <a:ea typeface="Graphik TH" charset="0"/>
+                        <a:cs typeface="Graphik TH" charset="0"/>
+                      </a:endParaRPr>
+                    </a:p>
+                  </a:txBody>
+                  <a:tcPr marL="54864" marR="54864" marT="9144" marB="9144" anchor="ctr">
+                    <a:lnL w="6350" cap="flat" cmpd="sng" algn="ctr">
+                      <a:solidFill>
+                        <a:srgbClr val="D8DFE9"/>
+                      </a:solidFill>
+                      <a:prstDash val="solid"/>
+                      <a:round/>
+                      <a:headEnd type="none" w="med" len="med"/>
+                      <a:tailEnd type="none" w="med" len="med"/>
+                    </a:lnL>
+                    <a:lnR w="6350" cap="flat" cmpd="sng" algn="ctr">
+                      <a:solidFill>
+                        <a:srgbClr val="D8DFE9"/>
+                      </a:solidFill>
+                      <a:prstDash val="solid"/>
+                      <a:round/>
+                      <a:headEnd type="none" w="med" len="med"/>
+                      <a:tailEnd type="none" w="med" len="med"/>
+                    </a:lnR>
+                    <a:lnT w="6350" cap="flat" cmpd="sng" algn="ctr">
+                      <a:solidFill>
+                        <a:srgbClr val="D8DFE9"/>
+                      </a:solidFill>
+                      <a:prstDash val="solid"/>
+                      <a:round/>
+                      <a:headEnd type="none" w="med" len="med"/>
+                      <a:tailEnd type="none" w="med" len="med"/>
+                    </a:lnT>
+                    <a:lnB w="6350" cap="flat" cmpd="sng" algn="ctr">
+                      <a:solidFill>
+                        <a:srgbClr val="D8DFE9"/>
+                      </a:solidFill>
+                      <a:prstDash val="solid"/>
+                      <a:round/>
+                      <a:headEnd type="none" w="med" len="med"/>
+                      <a:tailEnd type="none" w="med" len="med"/>
+                    </a:lnB>
+                    <a:solidFill>
+                      <a:srgbClr val="F1F4F9"/>
+                    </a:solidFill>
+                  </a:tcPr>
+                </a:tc>
+                <a:tc>
+                  <a:txBody>
+                    <a:bodyPr/>
+                    <a:lstStyle/>
+                    <a:p>
+                      <a:pPr algn="r" indent="0" marL="0">
+                        <a:buNone/>
+                      </a:pPr>
+                      <a:r>
+                        <a:rPr lang="en-US" sz="900" dirty="0">
+                          <a:solidFill>
+                            <a:srgbClr val="16233D"/>
+                          </a:solidFill>
+                          <a:latin typeface="Graphik TH" pitchFamily="34" charset="0"/>
+                          <a:ea typeface="Graphik TH" pitchFamily="34" charset="-122"/>
+                          <a:cs typeface="Graphik TH" pitchFamily="34" charset="-120"/>
+                        </a:rPr>
+                        <a:t>30,592</a:t>
+                      </a:r>
+                      <a:endParaRPr lang="en-US" sz="900" dirty="0">
+                        <a:latin typeface="Graphik TH" charset="0"/>
+                        <a:ea typeface="Graphik TH" charset="0"/>
+                        <a:cs typeface="Graphik TH" charset="0"/>
+                      </a:endParaRPr>
+                    </a:p>
+                  </a:txBody>
+                  <a:tcPr marL="54864" marR="54864" marT="9144" marB="9144" anchor="ctr">
+                    <a:lnL w="6350" cap="flat" cmpd="sng" algn="ctr">
+                      <a:solidFill>
+                        <a:srgbClr val="D8DFE9"/>
+                      </a:solidFill>
+                      <a:prstDash val="solid"/>
+                      <a:round/>
+                      <a:headEnd type="none" w="med" len="med"/>
+                      <a:tailEnd type="none" w="med" len="med"/>
+                    </a:lnL>
+                    <a:lnR w="6350" cap="flat" cmpd="sng" algn="ctr">
+                      <a:solidFill>
+                        <a:srgbClr val="D8DFE9"/>
+                      </a:solidFill>
+                      <a:prstDash val="solid"/>
+                      <a:round/>
+                      <a:headEnd type="none" w="med" len="med"/>
+                      <a:tailEnd type="none" w="med" len="med"/>
+                    </a:lnR>
+                    <a:lnT w="6350" cap="flat" cmpd="sng" algn="ctr">
+                      <a:solidFill>
+                        <a:srgbClr val="D8DFE9"/>
+                      </a:solidFill>
+                      <a:prstDash val="solid"/>
+                      <a:round/>
+                      <a:headEnd type="none" w="med" len="med"/>
+                      <a:tailEnd type="none" w="med" len="med"/>
+                    </a:lnT>
+                    <a:lnB w="6350" cap="flat" cmpd="sng" algn="ctr">
+                      <a:solidFill>
+                        <a:srgbClr val="D8DFE9"/>
+                      </a:solidFill>
+                      <a:prstDash val="solid"/>
+                      <a:round/>
+                      <a:headEnd type="none" w="med" len="med"/>
+                      <a:tailEnd type="none" w="med" len="med"/>
+                    </a:lnB>
+                    <a:solidFill>
+                      <a:srgbClr val="FFFFFF"/>
+                    </a:solidFill>
+                  </a:tcPr>
+                </a:tc>
+                <a:tc>
+                  <a:txBody>
+                    <a:bodyPr/>
+                    <a:lstStyle/>
+                    <a:p>
+                      <a:pPr algn="r" indent="0" marL="0">
+                        <a:buNone/>
+                      </a:pPr>
+                      <a:r>
+                        <a:rPr lang="en-US" sz="900" dirty="0">
+                          <a:solidFill>
+                            <a:srgbClr val="16233D"/>
+                          </a:solidFill>
+                          <a:latin typeface="Graphik TH" pitchFamily="34" charset="0"/>
+                          <a:ea typeface="Graphik TH" pitchFamily="34" charset="-122"/>
+                          <a:cs typeface="Graphik TH" pitchFamily="34" charset="-120"/>
+                        </a:rPr>
+                        <a:t>11.3</a:t>
+                      </a:r>
+                      <a:endParaRPr lang="en-US" sz="900" dirty="0">
+                        <a:latin typeface="Graphik TH" charset="0"/>
+                        <a:ea typeface="Graphik TH" charset="0"/>
+                        <a:cs typeface="Graphik TH" charset="0"/>
+                      </a:endParaRPr>
+                    </a:p>
+                  </a:txBody>
+                  <a:tcPr marL="54864" marR="54864" marT="9144" marB="9144" anchor="ctr">
+                    <a:lnL w="6350" cap="flat" cmpd="sng" algn="ctr">
+                      <a:solidFill>
+                        <a:srgbClr val="D8DFE9"/>
+                      </a:solidFill>
+                      <a:prstDash val="solid"/>
+                      <a:round/>
+                      <a:headEnd type="none" w="med" len="med"/>
+                      <a:tailEnd type="none" w="med" len="med"/>
+                    </a:lnL>
+                    <a:lnR w="6350" cap="flat" cmpd="sng" algn="ctr">
+                      <a:solidFill>
+                        <a:srgbClr val="D8DFE9"/>
+                      </a:solidFill>
+                      <a:prstDash val="solid"/>
+                      <a:round/>
+                      <a:headEnd type="none" w="med" len="med"/>
+                      <a:tailEnd type="none" w="med" len="med"/>
+                    </a:lnR>
+                    <a:lnT w="6350" cap="flat" cmpd="sng" algn="ctr">
+                      <a:solidFill>
+                        <a:srgbClr val="D8DFE9"/>
+                      </a:solidFill>
+                      <a:prstDash val="solid"/>
+                      <a:round/>
+                      <a:headEnd type="none" w="med" len="med"/>
+                      <a:tailEnd type="none" w="med" len="med"/>
+                    </a:lnT>
+                    <a:lnB w="6350" cap="flat" cmpd="sng" algn="ctr">
+                      <a:solidFill>
+                        <a:srgbClr val="D8DFE9"/>
+                      </a:solidFill>
+                      <a:prstDash val="solid"/>
+                      <a:round/>
+                      <a:headEnd type="none" w="med" len="med"/>
+                      <a:tailEnd type="none" w="med" len="med"/>
+                    </a:lnB>
+                    <a:solidFill>
+                      <a:srgbClr val="FFFFFF"/>
+                    </a:solidFill>
+                  </a:tcPr>
+                </a:tc>
+                <a:tc>
+                  <a:txBody>
+                    <a:bodyPr/>
+                    <a:lstStyle/>
+                    <a:p>
+                      <a:pPr algn="r" indent="0" marL="0">
+                        <a:buNone/>
+                      </a:pPr>
+                      <a:r>
+                        <a:rPr lang="en-US" sz="900" dirty="0">
+                          <a:solidFill>
+                            <a:srgbClr val="16233D"/>
+                          </a:solidFill>
+                          <a:latin typeface="Graphik TH" pitchFamily="34" charset="0"/>
+                          <a:ea typeface="Graphik TH" pitchFamily="34" charset="-122"/>
+                          <a:cs typeface="Graphik TH" pitchFamily="34" charset="-120"/>
+                        </a:rPr>
+                        <a:t>22.7</a:t>
+                      </a:r>
+                      <a:endParaRPr lang="en-US" sz="900" dirty="0">
+                        <a:latin typeface="Graphik TH" charset="0"/>
+                        <a:ea typeface="Graphik TH" charset="0"/>
+                        <a:cs typeface="Graphik TH" charset="0"/>
+                      </a:endParaRPr>
+                    </a:p>
+                  </a:txBody>
+                  <a:tcPr marL="54864" marR="54864" marT="9144" marB="9144" anchor="ctr">
+                    <a:lnL w="6350" cap="flat" cmpd="sng" algn="ctr">
+                      <a:solidFill>
+                        <a:srgbClr val="D8DFE9"/>
+                      </a:solidFill>
+                      <a:prstDash val="solid"/>
+                      <a:round/>
+                      <a:headEnd type="none" w="med" len="med"/>
+                      <a:tailEnd type="none" w="med" len="med"/>
+                    </a:lnL>
+                    <a:lnR w="6350" cap="flat" cmpd="sng" algn="ctr">
+                      <a:solidFill>
+                        <a:srgbClr val="D8DFE9"/>
+                      </a:solidFill>
+                      <a:prstDash val="solid"/>
+                      <a:round/>
+                      <a:headEnd type="none" w="med" len="med"/>
+                      <a:tailEnd type="none" w="med" len="med"/>
+                    </a:lnR>
+                    <a:lnT w="6350" cap="flat" cmpd="sng" algn="ctr">
+                      <a:solidFill>
+                        <a:srgbClr val="D8DFE9"/>
+                      </a:solidFill>
+                      <a:prstDash val="solid"/>
+                      <a:round/>
+                      <a:headEnd type="none" w="med" len="med"/>
+                      <a:tailEnd type="none" w="med" len="med"/>
+                    </a:lnT>
+                    <a:lnB w="6350" cap="flat" cmpd="sng" algn="ctr">
+                      <a:solidFill>
+                        <a:srgbClr val="D8DFE9"/>
+                      </a:solidFill>
+                      <a:prstDash val="solid"/>
+                      <a:round/>
+                      <a:headEnd type="none" w="med" len="med"/>
+                      <a:tailEnd type="none" w="med" len="med"/>
+                    </a:lnB>
+                    <a:solidFill>
+                      <a:srgbClr val="FFFFFF"/>
+                    </a:solidFill>
+                  </a:tcPr>
+                </a:tc>
+                <a:tc>
+                  <a:txBody>
+                    <a:bodyPr/>
+                    <a:lstStyle/>
+                    <a:p>
+                      <a:pPr algn="r" indent="0" marL="0">
+                        <a:buNone/>
+                      </a:pPr>
+                      <a:r>
+                        <a:rPr lang="en-US" sz="900" b="1" dirty="0">
+                          <a:solidFill>
+                            <a:srgbClr val="1E8E86"/>
+                          </a:solidFill>
+                          <a:latin typeface="Graphik TH" pitchFamily="34" charset="0"/>
+                          <a:ea typeface="Graphik TH" pitchFamily="34" charset="-122"/>
+                          <a:cs typeface="Graphik TH" pitchFamily="34" charset="-120"/>
+                        </a:rPr>
+                        <a:t>+11.4</a:t>
+                      </a:r>
+                      <a:endParaRPr lang="en-US" sz="900" dirty="0">
+                        <a:latin typeface="Graphik TH" charset="0"/>
+                        <a:ea typeface="Graphik TH" charset="0"/>
+                        <a:cs typeface="Graphik TH" charset="0"/>
+                      </a:endParaRPr>
+                    </a:p>
+                  </a:txBody>
+                  <a:tcPr marL="54864" marR="54864" marT="9144" marB="9144" anchor="ctr">
+                    <a:lnL w="6350" cap="flat" cmpd="sng" algn="ctr">
+                      <a:solidFill>
+                        <a:srgbClr val="D8DFE9"/>
+                      </a:solidFill>
+                      <a:prstDash val="solid"/>
+                      <a:round/>
+                      <a:headEnd type="none" w="med" len="med"/>
+                      <a:tailEnd type="none" w="med" len="med"/>
+                    </a:lnL>
+                    <a:lnR w="6350" cap="flat" cmpd="sng" algn="ctr">
+                      <a:solidFill>
+                        <a:srgbClr val="D8DFE9"/>
+                      </a:solidFill>
+                      <a:prstDash val="solid"/>
+                      <a:round/>
+                      <a:headEnd type="none" w="med" len="med"/>
+                      <a:tailEnd type="none" w="med" len="med"/>
+                    </a:lnR>
+                    <a:lnT w="6350" cap="flat" cmpd="sng" algn="ctr">
+                      <a:solidFill>
+                        <a:srgbClr val="D8DFE9"/>
+                      </a:solidFill>
+                      <a:prstDash val="solid"/>
+                      <a:round/>
+                      <a:headEnd type="none" w="med" len="med"/>
+                      <a:tailEnd type="none" w="med" len="med"/>
+                    </a:lnT>
+                    <a:lnB w="6350" cap="flat" cmpd="sng" algn="ctr">
+                      <a:solidFill>
+                        <a:srgbClr val="D8DFE9"/>
+                      </a:solidFill>
+                      <a:prstDash val="solid"/>
+                      <a:round/>
+                      <a:headEnd type="none" w="med" len="med"/>
+                      <a:tailEnd type="none" w="med" len="med"/>
+                    </a:lnB>
+                    <a:solidFill>
+                      <a:srgbClr val="FFFFFF"/>
+                    </a:solidFill>
+                  </a:tcPr>
+                </a:tc>
+                <a:tc>
+                  <a:txBody>
+                    <a:bodyPr/>
+                    <a:lstStyle/>
+                    <a:p>
+                      <a:pPr algn="r" indent="0" marL="0">
+                        <a:buNone/>
+                      </a:pPr>
+                      <a:r>
+                        <a:rPr lang="en-US" sz="900" b="1" dirty="0">
+                          <a:solidFill>
+                            <a:srgbClr val="1E8E86"/>
+                          </a:solidFill>
+                          <a:latin typeface="Graphik TH" pitchFamily="34" charset="0"/>
+                          <a:ea typeface="Graphik TH" pitchFamily="34" charset="-122"/>
+                          <a:cs typeface="Graphik TH" pitchFamily="34" charset="-120"/>
+                        </a:rPr>
+                        <a:t>+100.6%</a:t>
+                      </a:r>
+                      <a:endParaRPr lang="en-US" sz="900" dirty="0">
+                        <a:latin typeface="Graphik TH" charset="0"/>
+                        <a:ea typeface="Graphik TH" charset="0"/>
+                        <a:cs typeface="Graphik TH" charset="0"/>
+                      </a:endParaRPr>
+                    </a:p>
+                  </a:txBody>
+                  <a:tcPr marL="54864" marR="54864" marT="9144" marB="9144" anchor="ctr">
+                    <a:lnL w="6350" cap="flat" cmpd="sng" algn="ctr">
+                      <a:solidFill>
+                        <a:srgbClr val="D8DFE9"/>
+                      </a:solidFill>
+                      <a:prstDash val="solid"/>
+                      <a:round/>
+                      <a:headEnd type="none" w="med" len="med"/>
+                      <a:tailEnd type="none" w="med" len="med"/>
+                    </a:lnL>
+                    <a:lnR w="6350" cap="flat" cmpd="sng" algn="ctr">
+                      <a:solidFill>
+                        <a:srgbClr val="D8DFE9"/>
+                      </a:solidFill>
+                      <a:prstDash val="solid"/>
+                      <a:round/>
+                      <a:headEnd type="none" w="med" len="med"/>
+                      <a:tailEnd type="none" w="med" len="med"/>
+                    </a:lnR>
+                    <a:lnT w="6350" cap="flat" cmpd="sng" algn="ctr">
+                      <a:solidFill>
+                        <a:srgbClr val="D8DFE9"/>
+                      </a:solidFill>
+                      <a:prstDash val="solid"/>
+                      <a:round/>
+                      <a:headEnd type="none" w="med" len="med"/>
+                      <a:tailEnd type="none" w="med" len="med"/>
+                    </a:lnT>
+                    <a:lnB w="6350" cap="flat" cmpd="sng" algn="ctr">
+                      <a:solidFill>
+                        <a:srgbClr val="D8DFE9"/>
+                      </a:solidFill>
+                      <a:prstDash val="solid"/>
+                      <a:round/>
+                      <a:headEnd type="none" w="med" len="med"/>
+                      <a:tailEnd type="none" w="med" len="med"/>
+                    </a:lnB>
+                    <a:solidFill>
+                      <a:srgbClr val="FFFFFF"/>
+                    </a:solidFill>
+                  </a:tcPr>
+                </a:tc>
+              </a:tr>
+              <a:tr h="228600">
+                <a:tc>
+                  <a:txBody>
+                    <a:bodyPr/>
+                    <a:lstStyle/>
+                    <a:p>
+                      <a:pPr algn="l" indent="0" marL="0">
+                        <a:buNone/>
+                      </a:pPr>
+                      <a:r>
+                        <a:rPr lang="en-US" sz="900" b="1" dirty="0">
+                          <a:solidFill>
+                            <a:srgbClr val="16233D"/>
+                          </a:solidFill>
+                          <a:latin typeface="Graphik TH" pitchFamily="34" charset="0"/>
+                          <a:ea typeface="Graphik TH" pitchFamily="34" charset="-122"/>
+                          <a:cs typeface="Graphik TH" pitchFamily="34" charset="-120"/>
+                        </a:rPr>
+                        <a:t>Very Low</a:t>
+                      </a:r>
+                      <a:endParaRPr lang="en-US" sz="900" dirty="0">
+                        <a:latin typeface="Graphik TH" charset="0"/>
+                        <a:ea typeface="Graphik TH" charset="0"/>
+                        <a:cs typeface="Graphik TH" charset="0"/>
+                      </a:endParaRPr>
+                    </a:p>
+                  </a:txBody>
+                  <a:tcPr marL="54864" marR="54864" marT="9144" marB="9144" anchor="ctr">
+                    <a:lnL w="6350" cap="flat" cmpd="sng" algn="ctr">
+                      <a:solidFill>
+                        <a:srgbClr val="D8DFE9"/>
+                      </a:solidFill>
+                      <a:prstDash val="solid"/>
+                      <a:round/>
+                      <a:headEnd type="none" w="med" len="med"/>
+                      <a:tailEnd type="none" w="med" len="med"/>
+                    </a:lnL>
+                    <a:lnR w="6350" cap="flat" cmpd="sng" algn="ctr">
+                      <a:solidFill>
+                        <a:srgbClr val="D8DFE9"/>
+                      </a:solidFill>
+                      <a:prstDash val="solid"/>
+                      <a:round/>
+                      <a:headEnd type="none" w="med" len="med"/>
+                      <a:tailEnd type="none" w="med" len="med"/>
+                    </a:lnR>
+                    <a:lnT w="6350" cap="flat" cmpd="sng" algn="ctr">
+                      <a:solidFill>
+                        <a:srgbClr val="D8DFE9"/>
+                      </a:solidFill>
+                      <a:prstDash val="solid"/>
+                      <a:round/>
+                      <a:headEnd type="none" w="med" len="med"/>
+                      <a:tailEnd type="none" w="med" len="med"/>
+                    </a:lnT>
+                    <a:lnB w="6350" cap="flat" cmpd="sng" algn="ctr">
+                      <a:solidFill>
+                        <a:srgbClr val="D8DFE9"/>
+                      </a:solidFill>
+                      <a:prstDash val="solid"/>
+                      <a:round/>
+                      <a:headEnd type="none" w="med" len="med"/>
+                      <a:tailEnd type="none" w="med" len="med"/>
+                    </a:lnB>
+                    <a:solidFill>
+                      <a:srgbClr val="F1F4F9"/>
+                    </a:solidFill>
+                  </a:tcPr>
+                </a:tc>
+                <a:tc>
+                  <a:txBody>
+                    <a:bodyPr/>
+                    <a:lstStyle/>
+                    <a:p>
+                      <a:pPr algn="r" indent="0" marL="0">
+                        <a:buNone/>
+                      </a:pPr>
+                      <a:r>
+                        <a:rPr lang="en-US" sz="900" dirty="0">
+                          <a:solidFill>
+                            <a:srgbClr val="16233D"/>
+                          </a:solidFill>
+                          <a:latin typeface="Graphik TH" pitchFamily="34" charset="0"/>
+                          <a:ea typeface="Graphik TH" pitchFamily="34" charset="-122"/>
+                          <a:cs typeface="Graphik TH" pitchFamily="34" charset="-120"/>
+                        </a:rPr>
+                        <a:t>37,303</a:t>
+                      </a:r>
+                      <a:endParaRPr lang="en-US" sz="900" dirty="0">
+                        <a:latin typeface="Graphik TH" charset="0"/>
+                        <a:ea typeface="Graphik TH" charset="0"/>
+                        <a:cs typeface="Graphik TH" charset="0"/>
+                      </a:endParaRPr>
+                    </a:p>
+                  </a:txBody>
+                  <a:tcPr marL="54864" marR="54864" marT="9144" marB="9144" anchor="ctr">
+                    <a:lnL w="6350" cap="flat" cmpd="sng" algn="ctr">
+                      <a:solidFill>
+                        <a:srgbClr val="D8DFE9"/>
+                      </a:solidFill>
+                      <a:prstDash val="solid"/>
+                      <a:round/>
+                      <a:headEnd type="none" w="med" len="med"/>
+                      <a:tailEnd type="none" w="med" len="med"/>
+                    </a:lnL>
+                    <a:lnR w="6350" cap="flat" cmpd="sng" algn="ctr">
+                      <a:solidFill>
+                        <a:srgbClr val="D8DFE9"/>
+                      </a:solidFill>
+                      <a:prstDash val="solid"/>
+                      <a:round/>
+                      <a:headEnd type="none" w="med" len="med"/>
+                      <a:tailEnd type="none" w="med" len="med"/>
+                    </a:lnR>
+                    <a:lnT w="6350" cap="flat" cmpd="sng" algn="ctr">
+                      <a:solidFill>
+                        <a:srgbClr val="D8DFE9"/>
+                      </a:solidFill>
+                      <a:prstDash val="solid"/>
+                      <a:round/>
+                      <a:headEnd type="none" w="med" len="med"/>
+                      <a:tailEnd type="none" w="med" len="med"/>
+                    </a:lnT>
+                    <a:lnB w="6350" cap="flat" cmpd="sng" algn="ctr">
+                      <a:solidFill>
+                        <a:srgbClr val="D8DFE9"/>
+                      </a:solidFill>
+                      <a:prstDash val="solid"/>
+                      <a:round/>
+                      <a:headEnd type="none" w="med" len="med"/>
+                      <a:tailEnd type="none" w="med" len="med"/>
+                    </a:lnB>
+                    <a:solidFill>
+                      <a:srgbClr val="FFFFFF"/>
+                    </a:solidFill>
+                  </a:tcPr>
+                </a:tc>
+                <a:tc>
+                  <a:txBody>
+                    <a:bodyPr/>
+                    <a:lstStyle/>
+                    <a:p>
+                      <a:pPr algn="r" indent="0" marL="0">
+                        <a:buNone/>
+                      </a:pPr>
+                      <a:r>
+                        <a:rPr lang="en-US" sz="900" dirty="0">
+                          <a:solidFill>
+                            <a:srgbClr val="16233D"/>
+                          </a:solidFill>
+                          <a:latin typeface="Graphik TH" pitchFamily="34" charset="0"/>
+                          <a:ea typeface="Graphik TH" pitchFamily="34" charset="-122"/>
+                          <a:cs typeface="Graphik TH" pitchFamily="34" charset="-120"/>
+                        </a:rPr>
+                        <a:t>5.35</a:t>
+                      </a:r>
+                      <a:endParaRPr lang="en-US" sz="900" dirty="0">
+                        <a:latin typeface="Graphik TH" charset="0"/>
+                        <a:ea typeface="Graphik TH" charset="0"/>
+                        <a:cs typeface="Graphik TH" charset="0"/>
+                      </a:endParaRPr>
+                    </a:p>
+                  </a:txBody>
+                  <a:tcPr marL="54864" marR="54864" marT="9144" marB="9144" anchor="ctr">
+                    <a:lnL w="6350" cap="flat" cmpd="sng" algn="ctr">
+                      <a:solidFill>
+                        <a:srgbClr val="D8DFE9"/>
+                      </a:solidFill>
+                      <a:prstDash val="solid"/>
+                      <a:round/>
+                      <a:headEnd type="none" w="med" len="med"/>
+                      <a:tailEnd type="none" w="med" len="med"/>
+                    </a:lnL>
+                    <a:lnR w="6350" cap="flat" cmpd="sng" algn="ctr">
+                      <a:solidFill>
+                        <a:srgbClr val="D8DFE9"/>
+                      </a:solidFill>
+                      <a:prstDash val="solid"/>
+                      <a:round/>
+                      <a:headEnd type="none" w="med" len="med"/>
+                      <a:tailEnd type="none" w="med" len="med"/>
+                    </a:lnR>
+                    <a:lnT w="6350" cap="flat" cmpd="sng" algn="ctr">
+                      <a:solidFill>
+                        <a:srgbClr val="D8DFE9"/>
+                      </a:solidFill>
+                      <a:prstDash val="solid"/>
+                      <a:round/>
+                      <a:headEnd type="none" w="med" len="med"/>
+                      <a:tailEnd type="none" w="med" len="med"/>
+                    </a:lnT>
+                    <a:lnB w="6350" cap="flat" cmpd="sng" algn="ctr">
+                      <a:solidFill>
+                        <a:srgbClr val="D8DFE9"/>
+                      </a:solidFill>
+                      <a:prstDash val="solid"/>
+                      <a:round/>
+                      <a:headEnd type="none" w="med" len="med"/>
+                      <a:tailEnd type="none" w="med" len="med"/>
+                    </a:lnB>
+                    <a:solidFill>
+                      <a:srgbClr val="FFFFFF"/>
+                    </a:solidFill>
+                  </a:tcPr>
+                </a:tc>
+                <a:tc>
+                  <a:txBody>
+                    <a:bodyPr/>
+                    <a:lstStyle/>
+                    <a:p>
+                      <a:pPr algn="r" indent="0" marL="0">
+                        <a:buNone/>
+                      </a:pPr>
+                      <a:r>
+                        <a:rPr lang="en-US" sz="900" dirty="0">
+                          <a:solidFill>
+                            <a:srgbClr val="16233D"/>
+                          </a:solidFill>
+                          <a:latin typeface="Graphik TH" pitchFamily="34" charset="0"/>
+                          <a:ea typeface="Graphik TH" pitchFamily="34" charset="-122"/>
+                          <a:cs typeface="Graphik TH" pitchFamily="34" charset="-120"/>
+                        </a:rPr>
+                        <a:t>13.0</a:t>
+                      </a:r>
+                      <a:endParaRPr lang="en-US" sz="900" dirty="0">
+                        <a:latin typeface="Graphik TH" charset="0"/>
+                        <a:ea typeface="Graphik TH" charset="0"/>
+                        <a:cs typeface="Graphik TH" charset="0"/>
+                      </a:endParaRPr>
+                    </a:p>
+                  </a:txBody>
+                  <a:tcPr marL="54864" marR="54864" marT="9144" marB="9144" anchor="ctr">
+                    <a:lnL w="6350" cap="flat" cmpd="sng" algn="ctr">
+                      <a:solidFill>
+                        <a:srgbClr val="D8DFE9"/>
+                      </a:solidFill>
+                      <a:prstDash val="solid"/>
+                      <a:round/>
+                      <a:headEnd type="none" w="med" len="med"/>
+                      <a:tailEnd type="none" w="med" len="med"/>
+                    </a:lnL>
+                    <a:lnR w="6350" cap="flat" cmpd="sng" algn="ctr">
+                      <a:solidFill>
+                        <a:srgbClr val="D8DFE9"/>
+                      </a:solidFill>
+                      <a:prstDash val="solid"/>
+                      <a:round/>
+                      <a:headEnd type="none" w="med" len="med"/>
+                      <a:tailEnd type="none" w="med" len="med"/>
+                    </a:lnR>
+                    <a:lnT w="6350" cap="flat" cmpd="sng" algn="ctr">
+                      <a:solidFill>
+                        <a:srgbClr val="D8DFE9"/>
+                      </a:solidFill>
+                      <a:prstDash val="solid"/>
+                      <a:round/>
+                      <a:headEnd type="none" w="med" len="med"/>
+                      <a:tailEnd type="none" w="med" len="med"/>
+                    </a:lnT>
+                    <a:lnB w="6350" cap="flat" cmpd="sng" algn="ctr">
+                      <a:solidFill>
+                        <a:srgbClr val="D8DFE9"/>
+                      </a:solidFill>
+                      <a:prstDash val="solid"/>
+                      <a:round/>
+                      <a:headEnd type="none" w="med" len="med"/>
+                      <a:tailEnd type="none" w="med" len="med"/>
+                    </a:lnB>
+                    <a:solidFill>
+                      <a:srgbClr val="FFFFFF"/>
+                    </a:solidFill>
+                  </a:tcPr>
+                </a:tc>
+                <a:tc>
+                  <a:txBody>
+                    <a:bodyPr/>
+                    <a:lstStyle/>
+                    <a:p>
+                      <a:pPr algn="r" indent="0" marL="0">
+                        <a:buNone/>
+                      </a:pPr>
+                      <a:r>
+                        <a:rPr lang="en-US" sz="900" b="1" dirty="0">
+                          <a:solidFill>
+                            <a:srgbClr val="1E8E86"/>
+                          </a:solidFill>
+                          <a:latin typeface="Graphik TH" pitchFamily="34" charset="0"/>
+                          <a:ea typeface="Graphik TH" pitchFamily="34" charset="-122"/>
+                          <a:cs typeface="Graphik TH" pitchFamily="34" charset="-120"/>
+                        </a:rPr>
+                        <a:t>+7.7</a:t>
+                      </a:r>
+                      <a:endParaRPr lang="en-US" sz="900" dirty="0">
+                        <a:latin typeface="Graphik TH" charset="0"/>
+                        <a:ea typeface="Graphik TH" charset="0"/>
+                        <a:cs typeface="Graphik TH" charset="0"/>
+                      </a:endParaRPr>
+                    </a:p>
+                  </a:txBody>
+                  <a:tcPr marL="54864" marR="54864" marT="9144" marB="9144" anchor="ctr">
+                    <a:lnL w="6350" cap="flat" cmpd="sng" algn="ctr">
+                      <a:solidFill>
+                        <a:srgbClr val="D8DFE9"/>
+                      </a:solidFill>
+                      <a:prstDash val="solid"/>
+                      <a:round/>
+                      <a:headEnd type="none" w="med" len="med"/>
+                      <a:tailEnd type="none" w="med" len="med"/>
+                    </a:lnL>
+                    <a:lnR w="6350" cap="flat" cmpd="sng" algn="ctr">
+                      <a:solidFill>
+                        <a:srgbClr val="D8DFE9"/>
+                      </a:solidFill>
+                      <a:prstDash val="solid"/>
+                      <a:round/>
+                      <a:headEnd type="none" w="med" len="med"/>
+                      <a:tailEnd type="none" w="med" len="med"/>
+                    </a:lnR>
+                    <a:lnT w="6350" cap="flat" cmpd="sng" algn="ctr">
+                      <a:solidFill>
+                        <a:srgbClr val="D8DFE9"/>
+                      </a:solidFill>
+                      <a:prstDash val="solid"/>
+                      <a:round/>
+                      <a:headEnd type="none" w="med" len="med"/>
+                      <a:tailEnd type="none" w="med" len="med"/>
+                    </a:lnT>
+                    <a:lnB w="6350" cap="flat" cmpd="sng" algn="ctr">
+                      <a:solidFill>
+                        <a:srgbClr val="D8DFE9"/>
+                      </a:solidFill>
+                      <a:prstDash val="solid"/>
+                      <a:round/>
+                      <a:headEnd type="none" w="med" len="med"/>
+                      <a:tailEnd type="none" w="med" len="med"/>
+                    </a:lnB>
+                    <a:solidFill>
+                      <a:srgbClr val="FFFFFF"/>
+                    </a:solidFill>
+                  </a:tcPr>
+                </a:tc>
+                <a:tc>
+                  <a:txBody>
+                    <a:bodyPr/>
+                    <a:lstStyle/>
+                    <a:p>
+                      <a:pPr algn="r" indent="0" marL="0">
+                        <a:buNone/>
+                      </a:pPr>
+                      <a:r>
+                        <a:rPr lang="en-US" sz="900" b="1" dirty="0">
+                          <a:solidFill>
+                            <a:srgbClr val="1E8E86"/>
+                          </a:solidFill>
+                          <a:latin typeface="Graphik TH" pitchFamily="34" charset="0"/>
+                          <a:ea typeface="Graphik TH" pitchFamily="34" charset="-122"/>
+                          <a:cs typeface="Graphik TH" pitchFamily="34" charset="-120"/>
+                        </a:rPr>
+                        <a:t>+143.6%</a:t>
+                      </a:r>
+                      <a:endParaRPr lang="en-US" sz="900" dirty="0">
+                        <a:latin typeface="Graphik TH" charset="0"/>
+                        <a:ea typeface="Graphik TH" charset="0"/>
+                        <a:cs typeface="Graphik TH" charset="0"/>
+                      </a:endParaRPr>
+                    </a:p>
+                  </a:txBody>
+                  <a:tcPr marL="54864" marR="54864" marT="9144" marB="9144" anchor="ctr">
+                    <a:lnL w="6350" cap="flat" cmpd="sng" algn="ctr">
+                      <a:solidFill>
+                        <a:srgbClr val="D8DFE9"/>
+                      </a:solidFill>
+                      <a:prstDash val="solid"/>
+                      <a:round/>
+                      <a:headEnd type="none" w="med" len="med"/>
+                      <a:tailEnd type="none" w="med" len="med"/>
+                    </a:lnL>
+                    <a:lnR w="6350" cap="flat" cmpd="sng" algn="ctr">
+                      <a:solidFill>
+                        <a:srgbClr val="D8DFE9"/>
+                      </a:solidFill>
+                      <a:prstDash val="solid"/>
+                      <a:round/>
+                      <a:headEnd type="none" w="med" len="med"/>
+                      <a:tailEnd type="none" w="med" len="med"/>
+                    </a:lnR>
+                    <a:lnT w="6350" cap="flat" cmpd="sng" algn="ctr">
+                      <a:solidFill>
+                        <a:srgbClr val="D8DFE9"/>
+                      </a:solidFill>
+                      <a:prstDash val="solid"/>
+                      <a:round/>
+                      <a:headEnd type="none" w="med" len="med"/>
+                      <a:tailEnd type="none" w="med" len="med"/>
+                    </a:lnT>
+                    <a:lnB w="6350" cap="flat" cmpd="sng" algn="ctr">
+                      <a:solidFill>
+                        <a:srgbClr val="D8DFE9"/>
+                      </a:solidFill>
+                      <a:prstDash val="solid"/>
+                      <a:round/>
+                      <a:headEnd type="none" w="med" len="med"/>
+                      <a:tailEnd type="none" w="med" len="med"/>
+                    </a:lnB>
+                    <a:solidFill>
+                      <a:srgbClr val="FFFFFF"/>
+                    </a:solidFill>
+                  </a:tcPr>
+                </a:tc>
+              </a:tr>
+              <a:tr h="228600">
+                <a:tc>
+                  <a:txBody>
+                    <a:bodyPr/>
+                    <a:lstStyle/>
+                    <a:p>
+                      <a:pPr algn="l" indent="0" marL="0">
+                        <a:buNone/>
+                      </a:pPr>
+                      <a:r>
+                        <a:rPr lang="en-US" sz="900" b="1" dirty="0">
+                          <a:solidFill>
+                            <a:srgbClr val="16233D"/>
+                          </a:solidFill>
+                          <a:latin typeface="Graphik TH" pitchFamily="34" charset="0"/>
+                          <a:ea typeface="Graphik TH" pitchFamily="34" charset="-122"/>
+                          <a:cs typeface="Graphik TH" pitchFamily="34" charset="-120"/>
+                        </a:rPr>
+                        <a:t>All tiers</a:t>
+                      </a:r>
+                      <a:endParaRPr lang="en-US" sz="900" dirty="0">
+                        <a:latin typeface="Graphik TH" charset="0"/>
+                        <a:ea typeface="Graphik TH" charset="0"/>
+                        <a:cs typeface="Graphik TH" charset="0"/>
+                      </a:endParaRPr>
+                    </a:p>
+                  </a:txBody>
+                  <a:tcPr marL="54864" marR="54864" marT="9144" marB="9144" anchor="ctr">
+                    <a:lnL w="6350" cap="flat" cmpd="sng" algn="ctr">
+                      <a:solidFill>
+                        <a:srgbClr val="D8DFE9"/>
+                      </a:solidFill>
+                      <a:prstDash val="solid"/>
+                      <a:round/>
+                      <a:headEnd type="none" w="med" len="med"/>
+                      <a:tailEnd type="none" w="med" len="med"/>
+                    </a:lnL>
+                    <a:lnR w="6350" cap="flat" cmpd="sng" algn="ctr">
+                      <a:solidFill>
+                        <a:srgbClr val="D8DFE9"/>
+                      </a:solidFill>
+                      <a:prstDash val="solid"/>
+                      <a:round/>
+                      <a:headEnd type="none" w="med" len="med"/>
+                      <a:tailEnd type="none" w="med" len="med"/>
+                    </a:lnR>
+                    <a:lnT w="6350" cap="flat" cmpd="sng" algn="ctr">
+                      <a:solidFill>
+                        <a:srgbClr val="D8DFE9"/>
+                      </a:solidFill>
+                      <a:prstDash val="solid"/>
+                      <a:round/>
+                      <a:headEnd type="none" w="med" len="med"/>
+                      <a:tailEnd type="none" w="med" len="med"/>
+                    </a:lnT>
+                    <a:lnB w="6350" cap="flat" cmpd="sng" algn="ctr">
+                      <a:solidFill>
+                        <a:srgbClr val="D8DFE9"/>
+                      </a:solidFill>
+                      <a:prstDash val="solid"/>
+                      <a:round/>
+                      <a:headEnd type="none" w="med" len="med"/>
+                      <a:tailEnd type="none" w="med" len="med"/>
+                    </a:lnB>
+                    <a:solidFill>
+                      <a:srgbClr val="F1F4F9"/>
+                    </a:solidFill>
+                  </a:tcPr>
+                </a:tc>
+                <a:tc>
+                  <a:txBody>
+                    <a:bodyPr/>
+                    <a:lstStyle/>
+                    <a:p>
+                      <a:pPr algn="r" indent="0" marL="0">
+                        <a:buNone/>
+                      </a:pPr>
+                      <a:r>
+                        <a:rPr lang="en-US" sz="900" b="1" dirty="0">
+                          <a:solidFill>
+                            <a:srgbClr val="16233D"/>
+                          </a:solidFill>
+                          <a:latin typeface="Graphik TH" pitchFamily="34" charset="0"/>
+                          <a:ea typeface="Graphik TH" pitchFamily="34" charset="-122"/>
+                          <a:cs typeface="Graphik TH" pitchFamily="34" charset="-120"/>
+                        </a:rPr>
+                        <a:t>320,109</a:t>
+                      </a:r>
+                      <a:endParaRPr lang="en-US" sz="900" dirty="0">
+                        <a:latin typeface="Graphik TH" charset="0"/>
+                        <a:ea typeface="Graphik TH" charset="0"/>
+                        <a:cs typeface="Graphik TH" charset="0"/>
+                      </a:endParaRPr>
+                    </a:p>
+                  </a:txBody>
+                  <a:tcPr marL="54864" marR="54864" marT="9144" marB="9144" anchor="ctr">
+                    <a:lnL w="6350" cap="flat" cmpd="sng" algn="ctr">
+                      <a:solidFill>
+                        <a:srgbClr val="D8DFE9"/>
+                      </a:solidFill>
+                      <a:prstDash val="solid"/>
+                      <a:round/>
+                      <a:headEnd type="none" w="med" len="med"/>
+                      <a:tailEnd type="none" w="med" len="med"/>
+                    </a:lnL>
+                    <a:lnR w="6350" cap="flat" cmpd="sng" algn="ctr">
+                      <a:solidFill>
+                        <a:srgbClr val="D8DFE9"/>
+                      </a:solidFill>
+                      <a:prstDash val="solid"/>
+                      <a:round/>
+                      <a:headEnd type="none" w="med" len="med"/>
+                      <a:tailEnd type="none" w="med" len="med"/>
+                    </a:lnR>
+                    <a:lnT w="6350" cap="flat" cmpd="sng" algn="ctr">
+                      <a:solidFill>
+                        <a:srgbClr val="D8DFE9"/>
+                      </a:solidFill>
+                      <a:prstDash val="solid"/>
+                      <a:round/>
+                      <a:headEnd type="none" w="med" len="med"/>
+                      <a:tailEnd type="none" w="med" len="med"/>
+                    </a:lnT>
+                    <a:lnB w="6350" cap="flat" cmpd="sng" algn="ctr">
+                      <a:solidFill>
+                        <a:srgbClr val="D8DFE9"/>
+                      </a:solidFill>
+                      <a:prstDash val="solid"/>
+                      <a:round/>
+                      <a:headEnd type="none" w="med" len="med"/>
+                      <a:tailEnd type="none" w="med" len="med"/>
+                    </a:lnB>
+                    <a:solidFill>
+                      <a:srgbClr val="F1F4F9"/>
+                    </a:solidFill>
+                  </a:tcPr>
+                </a:tc>
+                <a:tc>
+                  <a:txBody>
+                    <a:bodyPr/>
+                    <a:lstStyle/>
+                    <a:p>
+                      <a:pPr algn="r" indent="0" marL="0">
+                        <a:buNone/>
+                      </a:pPr>
+                      <a:r>
+                        <a:rPr lang="en-US" sz="900" b="1" dirty="0">
+                          <a:solidFill>
+                            <a:srgbClr val="16233D"/>
+                          </a:solidFill>
+                          <a:latin typeface="Graphik TH" pitchFamily="34" charset="0"/>
+                          <a:ea typeface="Graphik TH" pitchFamily="34" charset="-122"/>
+                          <a:cs typeface="Graphik TH" pitchFamily="34" charset="-120"/>
+                        </a:rPr>
+                        <a:t>5477.5</a:t>
+                      </a:r>
+                      <a:endParaRPr lang="en-US" sz="900" dirty="0">
+                        <a:latin typeface="Graphik TH" charset="0"/>
+                        <a:ea typeface="Graphik TH" charset="0"/>
+                        <a:cs typeface="Graphik TH" charset="0"/>
+                      </a:endParaRPr>
+                    </a:p>
+                  </a:txBody>
+                  <a:tcPr marL="54864" marR="54864" marT="9144" marB="9144" anchor="ctr">
+                    <a:lnL w="6350" cap="flat" cmpd="sng" algn="ctr">
+                      <a:solidFill>
+                        <a:srgbClr val="D8DFE9"/>
+                      </a:solidFill>
+                      <a:prstDash val="solid"/>
+                      <a:round/>
+                      <a:headEnd type="none" w="med" len="med"/>
+                      <a:tailEnd type="none" w="med" len="med"/>
+                    </a:lnL>
+                    <a:lnR w="6350" cap="flat" cmpd="sng" algn="ctr">
+                      <a:solidFill>
+                        <a:srgbClr val="D8DFE9"/>
+                      </a:solidFill>
+                      <a:prstDash val="solid"/>
+                      <a:round/>
+                      <a:headEnd type="none" w="med" len="med"/>
+                      <a:tailEnd type="none" w="med" len="med"/>
+                    </a:lnR>
+                    <a:lnT w="6350" cap="flat" cmpd="sng" algn="ctr">
+                      <a:solidFill>
+                        <a:srgbClr val="D8DFE9"/>
+                      </a:solidFill>
+                      <a:prstDash val="solid"/>
+                      <a:round/>
+                      <a:headEnd type="none" w="med" len="med"/>
+                      <a:tailEnd type="none" w="med" len="med"/>
+                    </a:lnT>
+                    <a:lnB w="6350" cap="flat" cmpd="sng" algn="ctr">
+                      <a:solidFill>
+                        <a:srgbClr val="D8DFE9"/>
+                      </a:solidFill>
+                      <a:prstDash val="solid"/>
+                      <a:round/>
+                      <a:headEnd type="none" w="med" len="med"/>
+                      <a:tailEnd type="none" w="med" len="med"/>
+                    </a:lnB>
+                    <a:solidFill>
+                      <a:srgbClr val="F1F4F9"/>
+                    </a:solidFill>
+                  </a:tcPr>
+                </a:tc>
+                <a:tc>
+                  <a:txBody>
+                    <a:bodyPr/>
+                    <a:lstStyle/>
+                    <a:p>
+                      <a:pPr algn="r" indent="0" marL="0">
+                        <a:buNone/>
+                      </a:pPr>
+                      <a:r>
+                        <a:rPr lang="en-US" sz="900" b="1" dirty="0">
+                          <a:solidFill>
+                            <a:srgbClr val="16233D"/>
+                          </a:solidFill>
+                          <a:latin typeface="Graphik TH" pitchFamily="34" charset="0"/>
+                          <a:ea typeface="Graphik TH" pitchFamily="34" charset="-122"/>
+                          <a:cs typeface="Graphik TH" pitchFamily="34" charset="-120"/>
+                        </a:rPr>
+                        <a:t>5688.6</a:t>
+                      </a:r>
+                      <a:endParaRPr lang="en-US" sz="900" dirty="0">
+                        <a:latin typeface="Graphik TH" charset="0"/>
+                        <a:ea typeface="Graphik TH" charset="0"/>
+                        <a:cs typeface="Graphik TH" charset="0"/>
+                      </a:endParaRPr>
+                    </a:p>
+                  </a:txBody>
+                  <a:tcPr marL="54864" marR="54864" marT="9144" marB="9144" anchor="ctr">
+                    <a:lnL w="6350" cap="flat" cmpd="sng" algn="ctr">
+                      <a:solidFill>
+                        <a:srgbClr val="D8DFE9"/>
+                      </a:solidFill>
+                      <a:prstDash val="solid"/>
+                      <a:round/>
+                      <a:headEnd type="none" w="med" len="med"/>
+                      <a:tailEnd type="none" w="med" len="med"/>
+                    </a:lnL>
+                    <a:lnR w="6350" cap="flat" cmpd="sng" algn="ctr">
+                      <a:solidFill>
+                        <a:srgbClr val="D8DFE9"/>
+                      </a:solidFill>
+                      <a:prstDash val="solid"/>
+                      <a:round/>
+                      <a:headEnd type="none" w="med" len="med"/>
+                      <a:tailEnd type="none" w="med" len="med"/>
+                    </a:lnR>
+                    <a:lnT w="6350" cap="flat" cmpd="sng" algn="ctr">
+                      <a:solidFill>
+                        <a:srgbClr val="D8DFE9"/>
+                      </a:solidFill>
+                      <a:prstDash val="solid"/>
+                      <a:round/>
+                      <a:headEnd type="none" w="med" len="med"/>
+                      <a:tailEnd type="none" w="med" len="med"/>
+                    </a:lnT>
+                    <a:lnB w="6350" cap="flat" cmpd="sng" algn="ctr">
+                      <a:solidFill>
+                        <a:srgbClr val="D8DFE9"/>
+                      </a:solidFill>
+                      <a:prstDash val="solid"/>
+                      <a:round/>
+                      <a:headEnd type="none" w="med" len="med"/>
+                      <a:tailEnd type="none" w="med" len="med"/>
+                    </a:lnB>
+                    <a:solidFill>
+                      <a:srgbClr val="F1F4F9"/>
+                    </a:solidFill>
+                  </a:tcPr>
+                </a:tc>
+                <a:tc>
+                  <a:txBody>
+                    <a:bodyPr/>
+                    <a:lstStyle/>
+                    <a:p>
+                      <a:pPr algn="r" indent="0" marL="0">
+                        <a:buNone/>
+                      </a:pPr>
+                      <a:r>
+                        <a:rPr lang="en-US" sz="900" b="1" dirty="0">
+                          <a:solidFill>
+                            <a:srgbClr val="1E8E86"/>
+                          </a:solidFill>
+                          <a:latin typeface="Graphik TH" pitchFamily="34" charset="0"/>
+                          <a:ea typeface="Graphik TH" pitchFamily="34" charset="-122"/>
+                          <a:cs typeface="Graphik TH" pitchFamily="34" charset="-120"/>
+                        </a:rPr>
+                        <a:t>+211.1</a:t>
+                      </a:r>
+                      <a:endParaRPr lang="en-US" sz="900" dirty="0">
+                        <a:latin typeface="Graphik TH" charset="0"/>
+                        <a:ea typeface="Graphik TH" charset="0"/>
+                        <a:cs typeface="Graphik TH" charset="0"/>
+                      </a:endParaRPr>
+                    </a:p>
+                  </a:txBody>
+                  <a:tcPr marL="54864" marR="54864" marT="9144" marB="9144" anchor="ctr">
+                    <a:lnL w="6350" cap="flat" cmpd="sng" algn="ctr">
+                      <a:solidFill>
+                        <a:srgbClr val="D8DFE9"/>
+                      </a:solidFill>
+                      <a:prstDash val="solid"/>
+                      <a:round/>
+                      <a:headEnd type="none" w="med" len="med"/>
+                      <a:tailEnd type="none" w="med" len="med"/>
+                    </a:lnL>
+                    <a:lnR w="6350" cap="flat" cmpd="sng" algn="ctr">
+                      <a:solidFill>
+                        <a:srgbClr val="D8DFE9"/>
+                      </a:solidFill>
+                      <a:prstDash val="solid"/>
+                      <a:round/>
+                      <a:headEnd type="none" w="med" len="med"/>
+                      <a:tailEnd type="none" w="med" len="med"/>
+                    </a:lnR>
+                    <a:lnT w="6350" cap="flat" cmpd="sng" algn="ctr">
+                      <a:solidFill>
+                        <a:srgbClr val="D8DFE9"/>
+                      </a:solidFill>
+                      <a:prstDash val="solid"/>
+                      <a:round/>
+                      <a:headEnd type="none" w="med" len="med"/>
+                      <a:tailEnd type="none" w="med" len="med"/>
+                    </a:lnT>
+                    <a:lnB w="6350" cap="flat" cmpd="sng" algn="ctr">
+                      <a:solidFill>
+                        <a:srgbClr val="D8DFE9"/>
+                      </a:solidFill>
+                      <a:prstDash val="solid"/>
+                      <a:round/>
+                      <a:headEnd type="none" w="med" len="med"/>
+                      <a:tailEnd type="none" w="med" len="med"/>
+                    </a:lnB>
+                    <a:solidFill>
+                      <a:srgbClr val="F1F4F9"/>
+                    </a:solidFill>
+                  </a:tcPr>
+                </a:tc>
+                <a:tc>
+                  <a:txBody>
+                    <a:bodyPr/>
+                    <a:lstStyle/>
+                    <a:p>
+                      <a:pPr algn="r" indent="0" marL="0">
+                        <a:buNone/>
+                      </a:pPr>
+                      <a:r>
+                        <a:rPr lang="en-US" sz="900" b="1" dirty="0">
+                          <a:solidFill>
+                            <a:srgbClr val="1E8E86"/>
+                          </a:solidFill>
+                          <a:latin typeface="Graphik TH" pitchFamily="34" charset="0"/>
+                          <a:ea typeface="Graphik TH" pitchFamily="34" charset="-122"/>
+                          <a:cs typeface="Graphik TH" pitchFamily="34" charset="-120"/>
+                        </a:rPr>
+                        <a:t>+3.9%</a:t>
+                      </a:r>
+                      <a:endParaRPr lang="en-US" sz="900" dirty="0">
+                        <a:latin typeface="Graphik TH" charset="0"/>
+                        <a:ea typeface="Graphik TH" charset="0"/>
+                        <a:cs typeface="Graphik TH" charset="0"/>
+                      </a:endParaRPr>
+                    </a:p>
+                  </a:txBody>
+                  <a:tcPr marL="54864" marR="54864" marT="9144" marB="9144" anchor="ctr">
+                    <a:lnL w="6350" cap="flat" cmpd="sng" algn="ctr">
+                      <a:solidFill>
+                        <a:srgbClr val="D8DFE9"/>
+                      </a:solidFill>
+                      <a:prstDash val="solid"/>
+                      <a:round/>
+                      <a:headEnd type="none" w="med" len="med"/>
+                      <a:tailEnd type="none" w="med" len="med"/>
+                    </a:lnL>
+                    <a:lnR w="6350" cap="flat" cmpd="sng" algn="ctr">
+                      <a:solidFill>
+                        <a:srgbClr val="D8DFE9"/>
+                      </a:solidFill>
+                      <a:prstDash val="solid"/>
+                      <a:round/>
+                      <a:headEnd type="none" w="med" len="med"/>
+                      <a:tailEnd type="none" w="med" len="med"/>
+                    </a:lnR>
+                    <a:lnT w="6350" cap="flat" cmpd="sng" algn="ctr">
+                      <a:solidFill>
+                        <a:srgbClr val="D8DFE9"/>
+                      </a:solidFill>
+                      <a:prstDash val="solid"/>
+                      <a:round/>
+                      <a:headEnd type="none" w="med" len="med"/>
+                      <a:tailEnd type="none" w="med" len="med"/>
+                    </a:lnT>
+                    <a:lnB w="6350" cap="flat" cmpd="sng" algn="ctr">
+                      <a:solidFill>
+                        <a:srgbClr val="D8DFE9"/>
+                      </a:solidFill>
+                      <a:prstDash val="solid"/>
+                      <a:round/>
+                      <a:headEnd type="none" w="med" len="med"/>
+                      <a:tailEnd type="none" w="med" len="med"/>
+                    </a:lnB>
+                    <a:solidFill>
+                      <a:srgbClr val="F1F4F9"/>
+                    </a:solidFill>
+                  </a:tcPr>
+                </a:tc>
+              </a:tr>
+            </a:tbl>
+          </a:graphicData>
+        </a:graphic>
+      </p:graphicFrame>
+      <p:sp>
+        <p:nvSpPr>
+          <p:cNvPr id="26" name="Shape 23"/>
+          <p:cNvSpPr/>
+          <p:nvPr/>
+        </p:nvSpPr>
+        <p:spPr>
+          <a:xfrm>
+            <a:off x="7479792" y="2798064"/>
+            <a:ext cx="4325112" cy="2322576"/>
+          </a:xfrm>
+          <a:prstGeom prst="roundRect">
+            <a:avLst>
+              <a:gd name="adj" fmla="val 3543"/>
+            </a:avLst>
+          </a:prstGeom>
+          <a:solidFill>
+            <a:srgbClr val="F1F4F9"/>
+          </a:solidFill>
+          <a:ln/>
+        </p:spPr>
+      </p:sp>
+      <p:sp>
+        <p:nvSpPr>
+          <p:cNvPr id="27" name="Text 24"/>
+          <p:cNvSpPr/>
+          <p:nvPr/>
+        </p:nvSpPr>
+        <p:spPr>
+          <a:xfrm>
+            <a:off x="7735824" y="2944368"/>
+            <a:ext cx="3813048" cy="274320"/>
+          </a:xfrm>
+          <a:prstGeom prst="rect">
+            <a:avLst/>
+          </a:prstGeom>
+          <a:noFill/>
+          <a:ln/>
+        </p:spPr>
+        <p:txBody>
+          <a:bodyPr wrap="square" lIns="0" tIns="0" rIns="0" bIns="0" rtlCol="0" anchor="ctr"/>
+          <a:lstStyle/>
+          <a:p>
+            <a:pPr indent="0" marL="0">
+              <a:buNone/>
+            </a:pPr>
+            <a:r>
+              <a:rPr lang="en-US" sz="1400" b="1" dirty="0">
+                <a:solidFill>
+                  <a:srgbClr val="16233D"/>
+                </a:solidFill>
+                <a:latin typeface="Cambria" pitchFamily="34" charset="0"/>
+                <a:ea typeface="Cambria" pitchFamily="34" charset="-122"/>
+                <a:cs typeface="Cambria" pitchFamily="34" charset="-120"/>
+              </a:rPr>
+              <a:t>Share of the total gain</a:t>
+            </a:r>
+            <a:endParaRPr lang="en-US" sz="1400" dirty="0"/>
+          </a:p>
+        </p:txBody>
+      </p:sp>
+      <p:sp>
+        <p:nvSpPr>
+          <p:cNvPr id="28" name="Text 25"/>
+          <p:cNvSpPr/>
+          <p:nvPr/>
+        </p:nvSpPr>
+        <p:spPr>
+          <a:xfrm>
+            <a:off x="7735824" y="3218688"/>
+            <a:ext cx="3813048" cy="237744"/>
+          </a:xfrm>
+          <a:prstGeom prst="rect">
+            <a:avLst/>
+          </a:prstGeom>
+          <a:noFill/>
+          <a:ln/>
+        </p:spPr>
+        <p:txBody>
+          <a:bodyPr wrap="square" lIns="0" tIns="0" rIns="0" bIns="0" rtlCol="0" anchor="ctr"/>
+          <a:lstStyle/>
+          <a:p>
+            <a:pPr indent="0" marL="0">
+              <a:buNone/>
+            </a:pPr>
+            <a:r>
+              <a:rPr lang="en-US" sz="950" dirty="0">
+                <a:solidFill>
+                  <a:srgbClr val="6B7A90"/>
+                </a:solidFill>
+                <a:latin typeface="Graphik TH" pitchFamily="34" charset="0"/>
+                <a:ea typeface="Graphik TH" pitchFamily="34" charset="-122"/>
+                <a:cs typeface="Graphik TH" pitchFamily="34" charset="-120"/>
+              </a:rPr>
+              <a:t>Each tier's contribution to +211.1m</a:t>
+            </a:r>
+            <a:endParaRPr lang="en-US" sz="950" dirty="0"/>
+          </a:p>
+        </p:txBody>
+      </p:sp>
+      <p:sp>
+        <p:nvSpPr>
+          <p:cNvPr id="29" name="Text 26"/>
+          <p:cNvSpPr/>
+          <p:nvPr/>
+        </p:nvSpPr>
+        <p:spPr>
+          <a:xfrm>
+            <a:off x="7735824" y="3438144"/>
+            <a:ext cx="1051560" cy="237744"/>
+          </a:xfrm>
+          <a:prstGeom prst="rect">
+            <a:avLst/>
+          </a:prstGeom>
+          <a:noFill/>
+          <a:ln/>
+        </p:spPr>
+        <p:txBody>
+          <a:bodyPr wrap="square" lIns="0" tIns="0" rIns="0" bIns="0" rtlCol="0" anchor="ctr"/>
+          <a:lstStyle/>
+          <a:p>
+            <a:pPr indent="0" marL="0">
+              <a:buNone/>
+            </a:pPr>
+            <a:r>
+              <a:rPr lang="en-US" sz="1000" b="1" dirty="0">
+                <a:solidFill>
+                  <a:srgbClr val="16233D"/>
+                </a:solidFill>
+                <a:latin typeface="Graphik TH" pitchFamily="34" charset="0"/>
+                <a:ea typeface="Graphik TH" pitchFamily="34" charset="-122"/>
+                <a:cs typeface="Graphik TH" pitchFamily="34" charset="-120"/>
+              </a:rPr>
+              <a:t>Very High</a:t>
+            </a:r>
+            <a:endParaRPr lang="en-US" sz="1000" dirty="0"/>
+          </a:p>
+        </p:txBody>
+      </p:sp>
+      <p:sp>
+        <p:nvSpPr>
+          <p:cNvPr id="30" name="Shape 27"/>
+          <p:cNvSpPr/>
+          <p:nvPr/>
+        </p:nvSpPr>
+        <p:spPr>
+          <a:xfrm>
+            <a:off x="8833104" y="3474720"/>
+            <a:ext cx="963748" cy="164592"/>
+          </a:xfrm>
+          <a:prstGeom prst="roundRect">
+            <a:avLst>
+              <a:gd name="adj" fmla="val 16667"/>
+            </a:avLst>
+          </a:prstGeom>
+          <a:solidFill>
+            <a:srgbClr val="165A73"/>
+          </a:solidFill>
+          <a:ln/>
+        </p:spPr>
+      </p:sp>
+      <p:sp>
+        <p:nvSpPr>
+          <p:cNvPr id="31" name="Text 28"/>
+          <p:cNvSpPr/>
+          <p:nvPr/>
+        </p:nvSpPr>
+        <p:spPr>
+          <a:xfrm>
+            <a:off x="10296144" y="3438144"/>
+            <a:ext cx="658368" cy="237744"/>
+          </a:xfrm>
+          <a:prstGeom prst="rect">
+            <a:avLst/>
+          </a:prstGeom>
+          <a:noFill/>
+          <a:ln/>
+        </p:spPr>
+        <p:txBody>
+          <a:bodyPr wrap="square" lIns="0" tIns="0" rIns="0" bIns="0" rtlCol="0" anchor="ctr"/>
+          <a:lstStyle/>
+          <a:p>
+            <a:pPr algn="r" indent="0" marL="0">
+              <a:buNone/>
+            </a:pPr>
+            <a:r>
+              <a:rPr lang="en-US" sz="1000" b="1" dirty="0">
+                <a:solidFill>
+                  <a:srgbClr val="165A73"/>
+                </a:solidFill>
+                <a:latin typeface="Graphik TH" pitchFamily="34" charset="0"/>
+                <a:ea typeface="Graphik TH" pitchFamily="34" charset="-122"/>
+                <a:cs typeface="Graphik TH" pitchFamily="34" charset="-120"/>
+              </a:rPr>
+              <a:t>32.0%</a:t>
+            </a:r>
+            <a:endParaRPr lang="en-US" sz="1000" dirty="0"/>
+          </a:p>
+        </p:txBody>
+      </p:sp>
+      <p:sp>
+        <p:nvSpPr>
+          <p:cNvPr id="32" name="Text 29"/>
+          <p:cNvSpPr/>
+          <p:nvPr/>
+        </p:nvSpPr>
+        <p:spPr>
+          <a:xfrm>
+            <a:off x="10972800" y="3438144"/>
+            <a:ext cx="576072" cy="237744"/>
+          </a:xfrm>
+          <a:prstGeom prst="rect">
+            <a:avLst/>
+          </a:prstGeom>
+          <a:noFill/>
+          <a:ln/>
+        </p:spPr>
+        <p:txBody>
+          <a:bodyPr wrap="square" lIns="0" tIns="0" rIns="0" bIns="0" rtlCol="0" anchor="ctr"/>
+          <a:lstStyle/>
+          <a:p>
+            <a:pPr algn="r" indent="0" marL="0">
+              <a:buNone/>
+            </a:pPr>
+            <a:r>
+              <a:rPr lang="en-US" sz="850" dirty="0">
+                <a:solidFill>
+                  <a:srgbClr val="6B7A90"/>
+                </a:solidFill>
+                <a:latin typeface="Graphik TH" pitchFamily="34" charset="0"/>
+                <a:ea typeface="Graphik TH" pitchFamily="34" charset="-122"/>
+                <a:cs typeface="Graphik TH" pitchFamily="34" charset="-120"/>
+              </a:rPr>
+              <a:t>+67.6</a:t>
+            </a:r>
+            <a:endParaRPr lang="en-US" sz="850" dirty="0"/>
+          </a:p>
+        </p:txBody>
+      </p:sp>
+      <p:sp>
+        <p:nvSpPr>
+          <p:cNvPr id="33" name="Text 30"/>
+          <p:cNvSpPr/>
+          <p:nvPr/>
+        </p:nvSpPr>
+        <p:spPr>
+          <a:xfrm>
+            <a:off x="7735824" y="3712464"/>
+            <a:ext cx="1051560" cy="237744"/>
+          </a:xfrm>
+          <a:prstGeom prst="rect">
+            <a:avLst/>
+          </a:prstGeom>
+          <a:noFill/>
+          <a:ln/>
+        </p:spPr>
+        <p:txBody>
+          <a:bodyPr wrap="square" lIns="0" tIns="0" rIns="0" bIns="0" rtlCol="0" anchor="ctr"/>
+          <a:lstStyle/>
+          <a:p>
+            <a:pPr indent="0" marL="0">
+              <a:buNone/>
+            </a:pPr>
+            <a:r>
+              <a:rPr lang="en-US" sz="1000" b="1" dirty="0">
+                <a:solidFill>
+                  <a:srgbClr val="16233D"/>
+                </a:solidFill>
+                <a:latin typeface="Graphik TH" pitchFamily="34" charset="0"/>
+                <a:ea typeface="Graphik TH" pitchFamily="34" charset="-122"/>
+                <a:cs typeface="Graphik TH" pitchFamily="34" charset="-120"/>
+              </a:rPr>
+              <a:t>High</a:t>
+            </a:r>
+            <a:endParaRPr lang="en-US" sz="1000" dirty="0"/>
+          </a:p>
+        </p:txBody>
+      </p:sp>
+      <p:sp>
+        <p:nvSpPr>
+          <p:cNvPr id="34" name="Shape 31"/>
+          <p:cNvSpPr/>
+          <p:nvPr/>
+        </p:nvSpPr>
+        <p:spPr>
+          <a:xfrm>
+            <a:off x="8833104" y="3749040"/>
+            <a:ext cx="1417320" cy="164592"/>
+          </a:xfrm>
+          <a:prstGeom prst="roundRect">
+            <a:avLst>
+              <a:gd name="adj" fmla="val 16667"/>
+            </a:avLst>
+          </a:prstGeom>
+          <a:solidFill>
+            <a:srgbClr val="1E8E86"/>
+          </a:solidFill>
+          <a:ln/>
+        </p:spPr>
+      </p:sp>
+      <p:sp>
+        <p:nvSpPr>
+          <p:cNvPr id="35" name="Text 32"/>
+          <p:cNvSpPr/>
+          <p:nvPr/>
+        </p:nvSpPr>
+        <p:spPr>
+          <a:xfrm>
+            <a:off x="10296144" y="3712464"/>
+            <a:ext cx="658368" cy="237744"/>
+          </a:xfrm>
+          <a:prstGeom prst="rect">
+            <a:avLst/>
+          </a:prstGeom>
+          <a:noFill/>
+          <a:ln/>
+        </p:spPr>
+        <p:txBody>
+          <a:bodyPr wrap="square" lIns="0" tIns="0" rIns="0" bIns="0" rtlCol="0" anchor="ctr"/>
+          <a:lstStyle/>
+          <a:p>
+            <a:pPr algn="r" indent="0" marL="0">
+              <a:buNone/>
+            </a:pPr>
+            <a:r>
+              <a:rPr lang="en-US" sz="1000" b="1" dirty="0">
+                <a:solidFill>
+                  <a:srgbClr val="1E8E86"/>
+                </a:solidFill>
+                <a:latin typeface="Graphik TH" pitchFamily="34" charset="0"/>
+                <a:ea typeface="Graphik TH" pitchFamily="34" charset="-122"/>
+                <a:cs typeface="Graphik TH" pitchFamily="34" charset="-120"/>
+              </a:rPr>
+              <a:t>47.1%</a:t>
+            </a:r>
+            <a:endParaRPr lang="en-US" sz="1000" dirty="0"/>
+          </a:p>
+        </p:txBody>
+      </p:sp>
+      <p:sp>
+        <p:nvSpPr>
+          <p:cNvPr id="36" name="Text 33"/>
+          <p:cNvSpPr/>
+          <p:nvPr/>
+        </p:nvSpPr>
+        <p:spPr>
+          <a:xfrm>
+            <a:off x="10972800" y="3712464"/>
+            <a:ext cx="576072" cy="237744"/>
+          </a:xfrm>
+          <a:prstGeom prst="rect">
+            <a:avLst/>
+          </a:prstGeom>
+          <a:noFill/>
+          <a:ln/>
+        </p:spPr>
+        <p:txBody>
+          <a:bodyPr wrap="square" lIns="0" tIns="0" rIns="0" bIns="0" rtlCol="0" anchor="ctr"/>
+          <a:lstStyle/>
+          <a:p>
+            <a:pPr algn="r" indent="0" marL="0">
+              <a:buNone/>
+            </a:pPr>
+            <a:r>
+              <a:rPr lang="en-US" sz="850" dirty="0">
+                <a:solidFill>
+                  <a:srgbClr val="6B7A90"/>
+                </a:solidFill>
+                <a:latin typeface="Graphik TH" pitchFamily="34" charset="0"/>
+                <a:ea typeface="Graphik TH" pitchFamily="34" charset="-122"/>
+                <a:cs typeface="Graphik TH" pitchFamily="34" charset="-120"/>
+              </a:rPr>
+              <a:t>+99.5</a:t>
+            </a:r>
+            <a:endParaRPr lang="en-US" sz="850" dirty="0"/>
+          </a:p>
+        </p:txBody>
+      </p:sp>
+      <p:sp>
+        <p:nvSpPr>
+          <p:cNvPr id="37" name="Text 34"/>
+          <p:cNvSpPr/>
+          <p:nvPr/>
+        </p:nvSpPr>
+        <p:spPr>
+          <a:xfrm>
+            <a:off x="7735824" y="3986784"/>
+            <a:ext cx="1051560" cy="237744"/>
+          </a:xfrm>
+          <a:prstGeom prst="rect">
+            <a:avLst/>
+          </a:prstGeom>
+          <a:noFill/>
+          <a:ln/>
+        </p:spPr>
+        <p:txBody>
+          <a:bodyPr wrap="square" lIns="0" tIns="0" rIns="0" bIns="0" rtlCol="0" anchor="ctr"/>
+          <a:lstStyle/>
+          <a:p>
+            <a:pPr indent="0" marL="0">
+              <a:buNone/>
+            </a:pPr>
+            <a:r>
+              <a:rPr lang="en-US" sz="1000" b="1" dirty="0">
+                <a:solidFill>
+                  <a:srgbClr val="16233D"/>
+                </a:solidFill>
+                <a:latin typeface="Graphik TH" pitchFamily="34" charset="0"/>
+                <a:ea typeface="Graphik TH" pitchFamily="34" charset="-122"/>
+                <a:cs typeface="Graphik TH" pitchFamily="34" charset="-120"/>
+              </a:rPr>
+              <a:t>Medium</a:t>
+            </a:r>
+            <a:endParaRPr lang="en-US" sz="1000" dirty="0"/>
+          </a:p>
+        </p:txBody>
+      </p:sp>
+      <p:sp>
+        <p:nvSpPr>
+          <p:cNvPr id="38" name="Shape 35"/>
+          <p:cNvSpPr/>
+          <p:nvPr/>
+        </p:nvSpPr>
+        <p:spPr>
+          <a:xfrm>
+            <a:off x="8833104" y="4023360"/>
+            <a:ext cx="355231" cy="164592"/>
+          </a:xfrm>
+          <a:prstGeom prst="roundRect">
+            <a:avLst>
+              <a:gd name="adj" fmla="val 16667"/>
+            </a:avLst>
+          </a:prstGeom>
+          <a:solidFill>
+            <a:srgbClr val="3FB89F"/>
+          </a:solidFill>
+          <a:ln/>
+        </p:spPr>
+      </p:sp>
+      <p:sp>
+        <p:nvSpPr>
+          <p:cNvPr id="39" name="Text 36"/>
+          <p:cNvSpPr/>
+          <p:nvPr/>
+        </p:nvSpPr>
+        <p:spPr>
+          <a:xfrm>
+            <a:off x="10296144" y="3986784"/>
+            <a:ext cx="658368" cy="237744"/>
+          </a:xfrm>
+          <a:prstGeom prst="rect">
+            <a:avLst/>
+          </a:prstGeom>
+          <a:noFill/>
+          <a:ln/>
+        </p:spPr>
+        <p:txBody>
+          <a:bodyPr wrap="square" lIns="0" tIns="0" rIns="0" bIns="0" rtlCol="0" anchor="ctr"/>
+          <a:lstStyle/>
+          <a:p>
+            <a:pPr algn="r" indent="0" marL="0">
+              <a:buNone/>
+            </a:pPr>
+            <a:r>
+              <a:rPr lang="en-US" sz="1000" b="1" dirty="0">
+                <a:solidFill>
+                  <a:srgbClr val="3FB89F"/>
+                </a:solidFill>
+                <a:latin typeface="Graphik TH" pitchFamily="34" charset="0"/>
+                <a:ea typeface="Graphik TH" pitchFamily="34" charset="-122"/>
+                <a:cs typeface="Graphik TH" pitchFamily="34" charset="-120"/>
+              </a:rPr>
+              <a:t>11.8%</a:t>
+            </a:r>
+            <a:endParaRPr lang="en-US" sz="1000" dirty="0"/>
+          </a:p>
+        </p:txBody>
+      </p:sp>
+      <p:sp>
+        <p:nvSpPr>
+          <p:cNvPr id="40" name="Text 37"/>
+          <p:cNvSpPr/>
+          <p:nvPr/>
+        </p:nvSpPr>
+        <p:spPr>
+          <a:xfrm>
+            <a:off x="10972800" y="3986784"/>
+            <a:ext cx="576072" cy="237744"/>
+          </a:xfrm>
+          <a:prstGeom prst="rect">
+            <a:avLst/>
+          </a:prstGeom>
+          <a:noFill/>
+          <a:ln/>
+        </p:spPr>
+        <p:txBody>
+          <a:bodyPr wrap="square" lIns="0" tIns="0" rIns="0" bIns="0" rtlCol="0" anchor="ctr"/>
+          <a:lstStyle/>
+          <a:p>
+            <a:pPr algn="r" indent="0" marL="0">
+              <a:buNone/>
+            </a:pPr>
+            <a:r>
+              <a:rPr lang="en-US" sz="850" dirty="0">
+                <a:solidFill>
+                  <a:srgbClr val="6B7A90"/>
+                </a:solidFill>
+                <a:latin typeface="Graphik TH" pitchFamily="34" charset="0"/>
+                <a:ea typeface="Graphik TH" pitchFamily="34" charset="-122"/>
+                <a:cs typeface="Graphik TH" pitchFamily="34" charset="-120"/>
+              </a:rPr>
+              <a:t>+24.9</a:t>
+            </a:r>
+            <a:endParaRPr lang="en-US" sz="850" dirty="0"/>
+          </a:p>
+        </p:txBody>
+      </p:sp>
+      <p:sp>
+        <p:nvSpPr>
+          <p:cNvPr id="41" name="Text 38"/>
+          <p:cNvSpPr/>
+          <p:nvPr/>
+        </p:nvSpPr>
+        <p:spPr>
+          <a:xfrm>
+            <a:off x="7735824" y="4261104"/>
+            <a:ext cx="1051560" cy="237744"/>
+          </a:xfrm>
+          <a:prstGeom prst="rect">
+            <a:avLst/>
+          </a:prstGeom>
+          <a:noFill/>
+          <a:ln/>
+        </p:spPr>
+        <p:txBody>
+          <a:bodyPr wrap="square" lIns="0" tIns="0" rIns="0" bIns="0" rtlCol="0" anchor="ctr"/>
+          <a:lstStyle/>
+          <a:p>
+            <a:pPr indent="0" marL="0">
+              <a:buNone/>
+            </a:pPr>
+            <a:r>
+              <a:rPr lang="en-US" sz="1000" b="1" dirty="0">
+                <a:solidFill>
+                  <a:srgbClr val="16233D"/>
+                </a:solidFill>
+                <a:latin typeface="Graphik TH" pitchFamily="34" charset="0"/>
+                <a:ea typeface="Graphik TH" pitchFamily="34" charset="-122"/>
+                <a:cs typeface="Graphik TH" pitchFamily="34" charset="-120"/>
+              </a:rPr>
+              <a:t>Low</a:t>
+            </a:r>
+            <a:endParaRPr lang="en-US" sz="1000" dirty="0"/>
+          </a:p>
+        </p:txBody>
+      </p:sp>
+      <p:sp>
+        <p:nvSpPr>
+          <p:cNvPr id="42" name="Shape 39"/>
+          <p:cNvSpPr/>
+          <p:nvPr/>
+        </p:nvSpPr>
+        <p:spPr>
+          <a:xfrm>
+            <a:off x="8833104" y="4297680"/>
+            <a:ext cx="162359" cy="164592"/>
+          </a:xfrm>
+          <a:prstGeom prst="roundRect">
+            <a:avLst>
+              <a:gd name="adj" fmla="val 16896"/>
+            </a:avLst>
+          </a:prstGeom>
+          <a:solidFill>
+            <a:srgbClr val="E9A03B"/>
+          </a:solidFill>
+          <a:ln/>
+        </p:spPr>
+      </p:sp>
+      <p:sp>
+        <p:nvSpPr>
+          <p:cNvPr id="43" name="Text 40"/>
+          <p:cNvSpPr/>
+          <p:nvPr/>
+        </p:nvSpPr>
+        <p:spPr>
+          <a:xfrm>
+            <a:off x="10296144" y="4261104"/>
+            <a:ext cx="658368" cy="237744"/>
+          </a:xfrm>
+          <a:prstGeom prst="rect">
+            <a:avLst/>
+          </a:prstGeom>
+          <a:noFill/>
+          <a:ln/>
+        </p:spPr>
+        <p:txBody>
+          <a:bodyPr wrap="square" lIns="0" tIns="0" rIns="0" bIns="0" rtlCol="0" anchor="ctr"/>
+          <a:lstStyle/>
+          <a:p>
+            <a:pPr algn="r" indent="0" marL="0">
+              <a:buNone/>
+            </a:pPr>
+            <a:r>
+              <a:rPr lang="en-US" sz="1000" b="1" dirty="0">
+                <a:solidFill>
+                  <a:srgbClr val="E9A03B"/>
+                </a:solidFill>
+                <a:latin typeface="Graphik TH" pitchFamily="34" charset="0"/>
+                <a:ea typeface="Graphik TH" pitchFamily="34" charset="-122"/>
+                <a:cs typeface="Graphik TH" pitchFamily="34" charset="-120"/>
+              </a:rPr>
+              <a:t>5.4%</a:t>
+            </a:r>
+            <a:endParaRPr lang="en-US" sz="1000" dirty="0"/>
+          </a:p>
+        </p:txBody>
+      </p:sp>
+      <p:sp>
+        <p:nvSpPr>
+          <p:cNvPr id="44" name="Text 41"/>
+          <p:cNvSpPr/>
+          <p:nvPr/>
+        </p:nvSpPr>
+        <p:spPr>
+          <a:xfrm>
+            <a:off x="10972800" y="4261104"/>
+            <a:ext cx="576072" cy="237744"/>
+          </a:xfrm>
+          <a:prstGeom prst="rect">
+            <a:avLst/>
+          </a:prstGeom>
+          <a:noFill/>
+          <a:ln/>
+        </p:spPr>
+        <p:txBody>
+          <a:bodyPr wrap="square" lIns="0" tIns="0" rIns="0" bIns="0" rtlCol="0" anchor="ctr"/>
+          <a:lstStyle/>
+          <a:p>
+            <a:pPr algn="r" indent="0" marL="0">
+              <a:buNone/>
+            </a:pPr>
+            <a:r>
+              <a:rPr lang="en-US" sz="850" dirty="0">
+                <a:solidFill>
+                  <a:srgbClr val="6B7A90"/>
+                </a:solidFill>
+                <a:latin typeface="Graphik TH" pitchFamily="34" charset="0"/>
+                <a:ea typeface="Graphik TH" pitchFamily="34" charset="-122"/>
+                <a:cs typeface="Graphik TH" pitchFamily="34" charset="-120"/>
+              </a:rPr>
+              <a:t>+11.4</a:t>
+            </a:r>
+            <a:endParaRPr lang="en-US" sz="850" dirty="0"/>
+          </a:p>
+        </p:txBody>
+      </p:sp>
+      <p:sp>
+        <p:nvSpPr>
+          <p:cNvPr id="45" name="Text 42"/>
+          <p:cNvSpPr/>
+          <p:nvPr/>
+        </p:nvSpPr>
+        <p:spPr>
+          <a:xfrm>
+            <a:off x="7735824" y="4535424"/>
+            <a:ext cx="1051560" cy="237744"/>
+          </a:xfrm>
+          <a:prstGeom prst="rect">
+            <a:avLst/>
+          </a:prstGeom>
+          <a:noFill/>
+          <a:ln/>
+        </p:spPr>
+        <p:txBody>
+          <a:bodyPr wrap="square" lIns="0" tIns="0" rIns="0" bIns="0" rtlCol="0" anchor="ctr"/>
+          <a:lstStyle/>
+          <a:p>
+            <a:pPr indent="0" marL="0">
+              <a:buNone/>
+            </a:pPr>
+            <a:r>
+              <a:rPr lang="en-US" sz="1000" b="1" dirty="0">
+                <a:solidFill>
+                  <a:srgbClr val="16233D"/>
+                </a:solidFill>
+                <a:latin typeface="Graphik TH" pitchFamily="34" charset="0"/>
+                <a:ea typeface="Graphik TH" pitchFamily="34" charset="-122"/>
+                <a:cs typeface="Graphik TH" pitchFamily="34" charset="-120"/>
+              </a:rPr>
+              <a:t>Very Low</a:t>
+            </a:r>
+            <a:endParaRPr lang="en-US" sz="1000" dirty="0"/>
+          </a:p>
+        </p:txBody>
+      </p:sp>
+      <p:sp>
+        <p:nvSpPr>
+          <p:cNvPr id="46" name="Shape 43"/>
+          <p:cNvSpPr/>
+          <p:nvPr/>
+        </p:nvSpPr>
+        <p:spPr>
+          <a:xfrm>
+            <a:off x="8833104" y="4572000"/>
+            <a:ext cx="109383" cy="164592"/>
+          </a:xfrm>
+          <a:prstGeom prst="roundRect">
+            <a:avLst>
+              <a:gd name="adj" fmla="val 25079"/>
+            </a:avLst>
+          </a:prstGeom>
+          <a:solidFill>
+            <a:srgbClr val="8DA0B8"/>
+          </a:solidFill>
+          <a:ln/>
+        </p:spPr>
+      </p:sp>
+      <p:sp>
+        <p:nvSpPr>
+          <p:cNvPr id="47" name="Text 44"/>
+          <p:cNvSpPr/>
+          <p:nvPr/>
+        </p:nvSpPr>
+        <p:spPr>
+          <a:xfrm>
+            <a:off x="10296144" y="4535424"/>
+            <a:ext cx="658368" cy="237744"/>
+          </a:xfrm>
+          <a:prstGeom prst="rect">
+            <a:avLst/>
+          </a:prstGeom>
+          <a:noFill/>
+          <a:ln/>
+        </p:spPr>
+        <p:txBody>
+          <a:bodyPr wrap="square" lIns="0" tIns="0" rIns="0" bIns="0" rtlCol="0" anchor="ctr"/>
+          <a:lstStyle/>
+          <a:p>
+            <a:pPr algn="r" indent="0" marL="0">
+              <a:buNone/>
+            </a:pPr>
+            <a:r>
+              <a:rPr lang="en-US" sz="1000" b="1" dirty="0">
+                <a:solidFill>
+                  <a:srgbClr val="8DA0B8"/>
+                </a:solidFill>
+                <a:latin typeface="Graphik TH" pitchFamily="34" charset="0"/>
+                <a:ea typeface="Graphik TH" pitchFamily="34" charset="-122"/>
+                <a:cs typeface="Graphik TH" pitchFamily="34" charset="-120"/>
+              </a:rPr>
+              <a:t>3.6%</a:t>
+            </a:r>
+            <a:endParaRPr lang="en-US" sz="1000" dirty="0"/>
+          </a:p>
+        </p:txBody>
+      </p:sp>
+      <p:sp>
+        <p:nvSpPr>
+          <p:cNvPr id="48" name="Text 45"/>
+          <p:cNvSpPr/>
+          <p:nvPr/>
+        </p:nvSpPr>
+        <p:spPr>
+          <a:xfrm>
+            <a:off x="10972800" y="4535424"/>
+            <a:ext cx="576072" cy="237744"/>
+          </a:xfrm>
+          <a:prstGeom prst="rect">
+            <a:avLst/>
+          </a:prstGeom>
+          <a:noFill/>
+          <a:ln/>
+        </p:spPr>
+        <p:txBody>
+          <a:bodyPr wrap="square" lIns="0" tIns="0" rIns="0" bIns="0" rtlCol="0" anchor="ctr"/>
+          <a:lstStyle/>
+          <a:p>
+            <a:pPr algn="r" indent="0" marL="0">
+              <a:buNone/>
+            </a:pPr>
+            <a:r>
+              <a:rPr lang="en-US" sz="850" dirty="0">
+                <a:solidFill>
+                  <a:srgbClr val="6B7A90"/>
+                </a:solidFill>
+                <a:latin typeface="Graphik TH" pitchFamily="34" charset="0"/>
+                <a:ea typeface="Graphik TH" pitchFamily="34" charset="-122"/>
+                <a:cs typeface="Graphik TH" pitchFamily="34" charset="-120"/>
+              </a:rPr>
+              <a:t>+7.7</a:t>
+            </a:r>
+            <a:endParaRPr lang="en-US" sz="850" dirty="0"/>
+          </a:p>
+        </p:txBody>
+      </p:sp>
+      <p:sp>
+        <p:nvSpPr>
+          <p:cNvPr id="49" name="Shape 46"/>
+          <p:cNvSpPr/>
+          <p:nvPr/>
+        </p:nvSpPr>
+        <p:spPr>
+          <a:xfrm>
+            <a:off x="7735824" y="4846320"/>
+            <a:ext cx="3813048" cy="274320"/>
+          </a:xfrm>
+          <a:prstGeom prst="roundRect">
+            <a:avLst>
+              <a:gd name="adj" fmla="val 30000"/>
+            </a:avLst>
+          </a:prstGeom>
+          <a:solidFill>
+            <a:srgbClr val="FBF0E6"/>
+          </a:solidFill>
+          <a:ln/>
+        </p:spPr>
+      </p:sp>
+      <p:sp>
+        <p:nvSpPr>
+          <p:cNvPr id="50" name="Text 47"/>
+          <p:cNvSpPr/>
+          <p:nvPr/>
+        </p:nvSpPr>
+        <p:spPr>
+          <a:xfrm>
+            <a:off x="7882128" y="4846320"/>
+            <a:ext cx="3520440" cy="274320"/>
+          </a:xfrm>
+          <a:prstGeom prst="rect">
+            <a:avLst/>
+          </a:prstGeom>
+          <a:noFill/>
+          <a:ln/>
+        </p:spPr>
+        <p:txBody>
+          <a:bodyPr wrap="square" lIns="0" tIns="0" rIns="0" bIns="0" rtlCol="0" anchor="ctr"/>
+          <a:lstStyle/>
+          <a:p>
+            <a:pPr indent="0" marL="0">
+              <a:buNone/>
+            </a:pPr>
+            <a:r>
+              <a:rPr lang="en-US" sz="950" dirty="0">
+                <a:solidFill>
+                  <a:srgbClr val="16233D"/>
+                </a:solidFill>
+                <a:latin typeface="Graphik TH" pitchFamily="34" charset="0"/>
+                <a:ea typeface="Graphik TH" pitchFamily="34" charset="-122"/>
+                <a:cs typeface="Graphik TH" pitchFamily="34" charset="-120"/>
+              </a:rPr>
+              <a:t>Stickiness ≥ 60 holds 95.8% of the prior balance.</a:t>
+            </a:r>
+            <a:endParaRPr lang="en-US" sz="950" dirty="0"/>
+          </a:p>
+        </p:txBody>
+      </p:sp>
+      <p:sp>
+        <p:nvSpPr>
+          <p:cNvPr id="51" name="Shape 48"/>
+          <p:cNvSpPr/>
+          <p:nvPr/>
+        </p:nvSpPr>
+        <p:spPr>
+          <a:xfrm>
+            <a:off x="530352" y="5285232"/>
+            <a:ext cx="11274552" cy="786384"/>
+          </a:xfrm>
+          <a:prstGeom prst="roundRect">
+            <a:avLst>
+              <a:gd name="adj" fmla="val 10465"/>
+            </a:avLst>
+          </a:prstGeom>
+          <a:solidFill>
+            <a:srgbClr val="E8F6F3"/>
+          </a:solidFill>
+          <a:ln/>
+        </p:spPr>
+      </p:sp>
+      <p:sp>
+        <p:nvSpPr>
+          <p:cNvPr id="52" name="Text 49"/>
+          <p:cNvSpPr/>
+          <p:nvPr/>
+        </p:nvSpPr>
+        <p:spPr>
+          <a:xfrm>
+            <a:off x="804672" y="5285232"/>
+            <a:ext cx="10725912" cy="786384"/>
+          </a:xfrm>
+          <a:prstGeom prst="rect">
+            <a:avLst/>
+          </a:prstGeom>
+          <a:noFill/>
+          <a:ln/>
+        </p:spPr>
+        <p:txBody>
+          <a:bodyPr wrap="square" lIns="0" tIns="0" rIns="0" bIns="0" rtlCol="0" anchor="ctr"/>
+          <a:lstStyle/>
+          <a:p>
+            <a:pPr indent="0" marL="0">
+              <a:buNone/>
+            </a:pPr>
+            <a:r>
+              <a:rPr lang="en-US" sz="1100" b="1" dirty="0">
+                <a:solidFill>
+                  <a:srgbClr val="045D66"/>
+                </a:solidFill>
+                <a:latin typeface="Graphik TH" pitchFamily="34" charset="0"/>
+                <a:ea typeface="Graphik TH" pitchFamily="34" charset="-122"/>
+                <a:cs typeface="Graphik TH" pitchFamily="34" charset="-120"/>
+              </a:rPr>
+              <a:t>Stickiness ≥ 60 contributed +167.1m of the +211.1m gain</a:t>
+            </a:r>
+            <a:pPr indent="0" marL="0">
+              <a:buNone/>
+            </a:pPr>
+            <a:r>
+              <a:rPr lang="en-US" sz="1100" dirty="0">
+                <a:solidFill>
+                  <a:srgbClr val="16233D"/>
+                </a:solidFill>
+                <a:latin typeface="Graphik TH" pitchFamily="34" charset="0"/>
+                <a:ea typeface="Graphik TH" pitchFamily="34" charset="-122"/>
+                <a:cs typeface="Graphik TH" pitchFamily="34" charset="-120"/>
+              </a:rPr>
+              <a:t>  —  the Low and Very Low tiers post +100.6% and +143.6%, but on prior balances of THB 11.3m and THB 5.35m. Rank the tiers on absolute change; read the percentages as a signal that dormant accounts are being funded again.</a:t>
+            </a:r>
+            <a:endParaRPr lang="en-US" sz="1100" dirty="0"/>
+          </a:p>
+        </p:txBody>
+      </p:sp>
+    </p:spTree>
+  </p:cSld>
+  <p:clrMapOvr>
+    <a:masterClrMapping/>
+  </p:clrMapOvr>
+</p:sld>
+</file>
+
+<file path=ppt/slides/slide15.xml><?xml version="1.0" encoding="utf-8"?>
+<p:sld xmlns:a="http://schemas.openxmlformats.org/drawingml/2006/main" xmlns:r="http://schemas.openxmlformats.org/officeDocument/2006/relationships" xmlns:p="http://schemas.openxmlformats.org/presentationml/2006/main">
+  <p:cSld name="Slide 15">
     <p:bg>
       <p:bgPr>
         <a:solidFill>

</xml_diff>